<commit_message>
docs(presentation): patterns slide before As 1, ladder relabelled vs 4,12, footers renumbered
</commit_message>
<xml_diff>
--- a/docs/presentations/20260826_update_v2.pptx
+++ b/docs/presentations/20260826_update_v2.pptx
@@ -4,23 +4,28 @@
   <p:sldMasterIdLst>
     <p:sldMasterId id="2147483648" r:id="rId1"/>
   </p:sldMasterIdLst>
+  <p:notesMasterIdLst>
+    <p:notesMasterId r:id="rId17"/>
+  </p:notesMasterIdLst>
   <p:sldIdLst>
-    <p:sldId id="256" r:id="rId7"/>
-    <p:sldId id="257" r:id="rId8"/>
-    <p:sldId id="258" r:id="rId10"/>
-    <p:sldId id="259" r:id="rId11"/>
-    <p:sldId id="260" r:id="rId12"/>
-    <p:sldId id="261" r:id="rId13"/>
-    <p:sldId id="262" r:id="rId14"/>
-    <p:sldId id="263" r:id="rId15"/>
-    <p:sldId id="264" r:id="rId16"/>
-    <p:sldId id="265" r:id="rId17"/>
-    <p:sldId id="266" r:id="rId18"/>
-    <p:sldId id="267" r:id="rId19"/>
-    <p:sldId id="268" r:id="rId20"/>
-    <p:sldId id="269" r:id="rId21"/>
+    <p:sldId id="256" r:id="rId2"/>
+    <p:sldId id="257" r:id="rId3"/>
+    <p:sldId id="258" r:id="rId4"/>
+    <p:sldId id="270" r:id="rId5"/>
+    <p:sldId id="259" r:id="rId6"/>
+    <p:sldId id="271" r:id="rId22"/>
+    <p:sldId id="260" r:id="rId7"/>
+    <p:sldId id="261" r:id="rId8"/>
+    <p:sldId id="262" r:id="rId9"/>
+    <p:sldId id="263" r:id="rId10"/>
+    <p:sldId id="264" r:id="rId11"/>
+    <p:sldId id="265" r:id="rId12"/>
+    <p:sldId id="266" r:id="rId13"/>
+    <p:sldId id="267" r:id="rId14"/>
+    <p:sldId id="268" r:id="rId15"/>
+    <p:sldId id="269" r:id="rId16"/>
   </p:sldIdLst>
-  <p:sldSz cx="12191695" cy="6858000" type="screen4x3"/>
+  <p:sldSz cx="12192000" cy="6858000"/>
   <p:notesSz cx="6858000" cy="9144000"/>
   <p:defaultTextStyle>
     <a:defPPr>
@@ -117,11 +122,27 @@
       </a:defRPr>
     </a:lvl9pPr>
   </p:defaultTextStyle>
+  <p:extLst>
+    <p:ext uri="{EFAFB233-063F-42B5-8137-9DF3F51BA10A}">
+      <p15:sldGuideLst xmlns:p15="http://schemas.microsoft.com/office/powerpoint/2012/main">
+        <p15:guide id="1" orient="horz" pos="2160">
+          <p15:clr>
+            <a:srgbClr val="A4A3A4"/>
+          </p15:clr>
+        </p15:guide>
+        <p15:guide id="2" pos="2880">
+          <p15:clr>
+            <a:srgbClr val="A4A3A4"/>
+          </p15:clr>
+        </p15:guide>
+      </p15:sldGuideLst>
+    </p:ext>
+  </p:extLst>
 </p:presentation>
 </file>
 
 <file path=ppt/notesMasters/notesMaster1.xml><?xml version="1.0" encoding="utf-8"?>
-<p:notesMaster xmlns:a="http://schemas.openxmlformats.org/drawingml/2006/main" xmlns:p="http://schemas.openxmlformats.org/presentationml/2006/main" xmlns:r="http://schemas.openxmlformats.org/officeDocument/2006/relationships">
+<p:notesMaster xmlns:a="http://schemas.openxmlformats.org/drawingml/2006/main" xmlns:r="http://schemas.openxmlformats.org/officeDocument/2006/relationships" xmlns:p="http://schemas.openxmlformats.org/presentationml/2006/main">
   <p:cSld>
     <p:bg>
       <p:bgRef idx="1001">
@@ -155,7 +176,7 @@
         <p:spPr>
           <a:xfrm>
             <a:off x="0" y="0"/>
-            <a:ext cx="2971800" cy="457200"/>
+            <a:ext cx="2971800" cy="458788"/>
           </a:xfrm>
           <a:prstGeom prst="rect">
             <a:avLst/>
@@ -186,7 +207,7 @@
         <p:spPr>
           <a:xfrm>
             <a:off x="3884613" y="0"/>
-            <a:ext cx="2971800" cy="457200"/>
+            <a:ext cx="2971800" cy="458788"/>
           </a:xfrm>
           <a:prstGeom prst="rect">
             <a:avLst/>
@@ -200,9 +221,9 @@
             </a:lvl1pPr>
           </a:lstStyle>
           <a:p>
-            <a:fld id="{0F89C1C7-3DCD-1040-A9CF-14679D8B5DDD}" type="datetimeFigureOut">
+            <a:fld id="{215FDD8D-4CBC-4347-B89D-F063BFE20A1D}" type="datetimeFigureOut">
               <a:rPr lang="en-US" smtClean="0"/>
-              <a:t>10/17/16</a:t>
+              <a:t>8/26/26</a:t>
             </a:fld>
             <a:endParaRPr lang="en-US"/>
           </a:p>
@@ -220,8 +241,8 @@
         </p:nvSpPr>
         <p:spPr>
           <a:xfrm>
-            <a:off x="1143000" y="685800"/>
-            <a:ext cx="4572000" cy="3429000"/>
+            <a:off x="685800" y="1143000"/>
+            <a:ext cx="5486400" cy="3086100"/>
           </a:xfrm>
           <a:prstGeom prst="rect">
             <a:avLst/>
@@ -253,8 +274,8 @@
         </p:nvSpPr>
         <p:spPr>
           <a:xfrm>
-            <a:off x="685800" y="4343400"/>
-            <a:ext cx="5486400" cy="4114800"/>
+            <a:off x="685800" y="4400550"/>
+            <a:ext cx="5486400" cy="3600450"/>
           </a:xfrm>
           <a:prstGeom prst="rect">
             <a:avLst/>
@@ -266,38 +287,37 @@
           <a:p>
             <a:pPr lvl="0"/>
             <a:r>
-              <a:rPr lang="en-US" smtClean="0"/>
+              <a:rPr lang="en-US"/>
               <a:t>Click to edit Master text styles</a:t>
             </a:r>
           </a:p>
           <a:p>
             <a:pPr lvl="1"/>
             <a:r>
-              <a:rPr lang="en-US" smtClean="0"/>
+              <a:rPr lang="en-US"/>
               <a:t>Second level</a:t>
             </a:r>
           </a:p>
           <a:p>
             <a:pPr lvl="2"/>
             <a:r>
-              <a:rPr lang="en-US" smtClean="0"/>
+              <a:rPr lang="en-US"/>
               <a:t>Third level</a:t>
             </a:r>
           </a:p>
           <a:p>
             <a:pPr lvl="3"/>
             <a:r>
-              <a:rPr lang="en-US" smtClean="0"/>
+              <a:rPr lang="en-US"/>
               <a:t>Fourth level</a:t>
             </a:r>
           </a:p>
           <a:p>
             <a:pPr lvl="4"/>
             <a:r>
-              <a:rPr lang="en-US" smtClean="0"/>
+              <a:rPr lang="en-US"/>
               <a:t>Fifth level</a:t>
             </a:r>
-            <a:endParaRPr lang="en-US"/>
           </a:p>
         </p:txBody>
       </p:sp>
@@ -314,7 +334,7 @@
         <p:spPr>
           <a:xfrm>
             <a:off x="0" y="8685213"/>
-            <a:ext cx="2971800" cy="457200"/>
+            <a:ext cx="2971800" cy="458787"/>
           </a:xfrm>
           <a:prstGeom prst="rect">
             <a:avLst/>
@@ -345,7 +365,7 @@
         <p:spPr>
           <a:xfrm>
             <a:off x="3884613" y="8685213"/>
-            <a:ext cx="2971800" cy="457200"/>
+            <a:ext cx="2971800" cy="458787"/>
           </a:xfrm>
           <a:prstGeom prst="rect">
             <a:avLst/>
@@ -359,7 +379,7 @@
             </a:lvl1pPr>
           </a:lstStyle>
           <a:p>
-            <a:fld id="{BB5E49A5-4136-284D-997B-48E1D791AD67}" type="slidenum">
+            <a:fld id="{3CABB5FF-E68F-F848-8B49-42D48E9715A7}" type="slidenum">
               <a:rPr lang="en-US" smtClean="0"/>
               <a:t>‹#›</a:t>
             </a:fld>
@@ -370,13 +390,13 @@
     </p:spTree>
     <p:extLst>
       <p:ext uri="{BB962C8B-B14F-4D97-AF65-F5344CB8AC3E}">
-        <p14:creationId xmlns:p14="http://schemas.microsoft.com/office/powerpoint/2010/main" val="2623252185"/>
+        <p14:creationId xmlns:p14="http://schemas.microsoft.com/office/powerpoint/2010/main" val="2657570411"/>
       </p:ext>
     </p:extLst>
   </p:cSld>
   <p:clrMap bg1="lt1" tx1="dk1" bg2="lt2" tx2="dk2" accent1="accent1" accent2="accent2" accent3="accent3" accent4="accent4" accent5="accent5" accent6="accent6" hlink="hlink" folHlink="folHlink"/>
   <p:notesStyle>
-    <a:lvl1pPr marL="0" algn="l" defTabSz="457200" rtl="0" eaLnBrk="1" latinLnBrk="0" hangingPunct="1">
+    <a:lvl1pPr marL="0" algn="l" defTabSz="914400" rtl="0" eaLnBrk="1" latinLnBrk="0" hangingPunct="1">
       <a:defRPr sz="1200" kern="1200">
         <a:solidFill>
           <a:schemeClr val="tx1"/>
@@ -386,7 +406,7 @@
         <a:cs typeface="+mn-cs"/>
       </a:defRPr>
     </a:lvl1pPr>
-    <a:lvl2pPr marL="457200" algn="l" defTabSz="457200" rtl="0" eaLnBrk="1" latinLnBrk="0" hangingPunct="1">
+    <a:lvl2pPr marL="457200" algn="l" defTabSz="914400" rtl="0" eaLnBrk="1" latinLnBrk="0" hangingPunct="1">
       <a:defRPr sz="1200" kern="1200">
         <a:solidFill>
           <a:schemeClr val="tx1"/>
@@ -396,7 +416,7 @@
         <a:cs typeface="+mn-cs"/>
       </a:defRPr>
     </a:lvl2pPr>
-    <a:lvl3pPr marL="914400" algn="l" defTabSz="457200" rtl="0" eaLnBrk="1" latinLnBrk="0" hangingPunct="1">
+    <a:lvl3pPr marL="914400" algn="l" defTabSz="914400" rtl="0" eaLnBrk="1" latinLnBrk="0" hangingPunct="1">
       <a:defRPr sz="1200" kern="1200">
         <a:solidFill>
           <a:schemeClr val="tx1"/>
@@ -406,7 +426,7 @@
         <a:cs typeface="+mn-cs"/>
       </a:defRPr>
     </a:lvl3pPr>
-    <a:lvl4pPr marL="1371600" algn="l" defTabSz="457200" rtl="0" eaLnBrk="1" latinLnBrk="0" hangingPunct="1">
+    <a:lvl4pPr marL="1371600" algn="l" defTabSz="914400" rtl="0" eaLnBrk="1" latinLnBrk="0" hangingPunct="1">
       <a:defRPr sz="1200" kern="1200">
         <a:solidFill>
           <a:schemeClr val="tx1"/>
@@ -416,7 +436,7 @@
         <a:cs typeface="+mn-cs"/>
       </a:defRPr>
     </a:lvl4pPr>
-    <a:lvl5pPr marL="1828800" algn="l" defTabSz="457200" rtl="0" eaLnBrk="1" latinLnBrk="0" hangingPunct="1">
+    <a:lvl5pPr marL="1828800" algn="l" defTabSz="914400" rtl="0" eaLnBrk="1" latinLnBrk="0" hangingPunct="1">
       <a:defRPr sz="1200" kern="1200">
         <a:solidFill>
           <a:schemeClr val="tx1"/>
@@ -426,7 +446,7 @@
         <a:cs typeface="+mn-cs"/>
       </a:defRPr>
     </a:lvl5pPr>
-    <a:lvl6pPr marL="2286000" algn="l" defTabSz="457200" rtl="0" eaLnBrk="1" latinLnBrk="0" hangingPunct="1">
+    <a:lvl6pPr marL="2286000" algn="l" defTabSz="914400" rtl="0" eaLnBrk="1" latinLnBrk="0" hangingPunct="1">
       <a:defRPr sz="1200" kern="1200">
         <a:solidFill>
           <a:schemeClr val="tx1"/>
@@ -436,7 +456,7 @@
         <a:cs typeface="+mn-cs"/>
       </a:defRPr>
     </a:lvl6pPr>
-    <a:lvl7pPr marL="2743200" algn="l" defTabSz="457200" rtl="0" eaLnBrk="1" latinLnBrk="0" hangingPunct="1">
+    <a:lvl7pPr marL="2743200" algn="l" defTabSz="914400" rtl="0" eaLnBrk="1" latinLnBrk="0" hangingPunct="1">
       <a:defRPr sz="1200" kern="1200">
         <a:solidFill>
           <a:schemeClr val="tx1"/>
@@ -446,7 +466,7 @@
         <a:cs typeface="+mn-cs"/>
       </a:defRPr>
     </a:lvl7pPr>
-    <a:lvl8pPr marL="3200400" algn="l" defTabSz="457200" rtl="0" eaLnBrk="1" latinLnBrk="0" hangingPunct="1">
+    <a:lvl8pPr marL="3200400" algn="l" defTabSz="914400" rtl="0" eaLnBrk="1" latinLnBrk="0" hangingPunct="1">
       <a:defRPr sz="1200" kern="1200">
         <a:solidFill>
           <a:schemeClr val="tx1"/>
@@ -456,7 +476,7 @@
         <a:cs typeface="+mn-cs"/>
       </a:defRPr>
     </a:lvl8pPr>
-    <a:lvl9pPr marL="3657600" algn="l" defTabSz="457200" rtl="0" eaLnBrk="1" latinLnBrk="0" hangingPunct="1">
+    <a:lvl9pPr marL="3657600" algn="l" defTabSz="914400" rtl="0" eaLnBrk="1" latinLnBrk="0" hangingPunct="1">
       <a:defRPr sz="1200" kern="1200">
         <a:solidFill>
           <a:schemeClr val="tx1"/>
@@ -471,7 +491,7 @@
 </file>
 
 <file path=ppt/notesSlides/notesSlide1.xml><?xml version="1.0" encoding="utf-8"?>
-<p:notes xmlns:a="http://schemas.openxmlformats.org/drawingml/2006/main" xmlns:p="http://schemas.openxmlformats.org/presentationml/2006/main" xmlns:r="http://schemas.openxmlformats.org/officeDocument/2006/relationships">
+<p:notes xmlns:a="http://schemas.openxmlformats.org/drawingml/2006/main" xmlns:r="http://schemas.openxmlformats.org/officeDocument/2006/relationships" xmlns:p="http://schemas.openxmlformats.org/presentationml/2006/main">
   <p:cSld>
     <p:spTree>
       <p:nvGrpSpPr>
@@ -491,7 +511,7 @@
         <p:nvSpPr>
           <p:cNvPr id="2" name="Slide Image Placeholder 1"/>
           <p:cNvSpPr>
-            <a:spLocks noGrp="1"/>
+            <a:spLocks noGrp="1" noRot="1" noChangeAspect="1"/>
           </p:cNvSpPr>
           <p:nvPr>
             <p:ph type="sldImg" idx="2"/>
@@ -506,7 +526,7 @@
             <a:spLocks noGrp="1"/>
           </p:cNvSpPr>
           <p:nvPr>
-            <p:ph type="body" idx="3" sz="quarter"/>
+            <p:ph type="body" sz="quarter" idx="3"/>
           </p:nvPr>
         </p:nvSpPr>
         <p:spPr/>
@@ -527,7 +547,7 @@
             <a:spLocks noGrp="1"/>
           </p:cNvSpPr>
           <p:nvPr>
-            <p:ph type="sldNum" idx="5" sz="quarter"/>
+            <p:ph type="sldNum" sz="quarter" idx="5"/>
           </p:nvPr>
         </p:nvSpPr>
         <p:spPr/>
@@ -541,7 +561,7 @@
 </file>
 
 <file path=ppt/notesSlides/notesSlide2.xml><?xml version="1.0" encoding="utf-8"?>
-<p:notes xmlns:a="http://schemas.openxmlformats.org/drawingml/2006/main" xmlns:p="http://schemas.openxmlformats.org/presentationml/2006/main" xmlns:r="http://schemas.openxmlformats.org/officeDocument/2006/relationships">
+<p:notes xmlns:a="http://schemas.openxmlformats.org/drawingml/2006/main" xmlns:r="http://schemas.openxmlformats.org/officeDocument/2006/relationships" xmlns:p="http://schemas.openxmlformats.org/presentationml/2006/main">
   <p:cSld>
     <p:spTree>
       <p:nvGrpSpPr>
@@ -561,7 +581,7 @@
         <p:nvSpPr>
           <p:cNvPr id="2" name="Slide Image Placeholder 1"/>
           <p:cNvSpPr>
-            <a:spLocks noGrp="1"/>
+            <a:spLocks noGrp="1" noRot="1" noChangeAspect="1"/>
           </p:cNvSpPr>
           <p:nvPr>
             <p:ph type="sldImg" idx="2"/>
@@ -576,7 +596,7 @@
             <a:spLocks noGrp="1"/>
           </p:cNvSpPr>
           <p:nvPr>
-            <p:ph type="body" idx="3" sz="quarter"/>
+            <p:ph type="body" sz="quarter" idx="3"/>
           </p:nvPr>
         </p:nvSpPr>
         <p:spPr/>
@@ -597,7 +617,7 @@
             <a:spLocks noGrp="1"/>
           </p:cNvSpPr>
           <p:nvPr>
-            <p:ph type="sldNum" idx="5" sz="quarter"/>
+            <p:ph type="sldNum" sz="quarter" idx="5"/>
           </p:nvPr>
         </p:nvSpPr>
         <p:spPr/>
@@ -648,10 +668,9 @@
           <a:lstStyle/>
           <a:p>
             <a:r>
-              <a:rPr lang="en-US" smtClean="0"/>
+              <a:rPr lang="en-US"/>
               <a:t>Click to edit Master title style</a:t>
             </a:r>
-            <a:endParaRPr lang="en-US"/>
           </a:p>
         </p:txBody>
       </p:sp>
@@ -767,10 +786,9 @@
           </a:lstStyle>
           <a:p>
             <a:r>
-              <a:rPr lang="en-US" smtClean="0"/>
+              <a:rPr lang="en-US"/>
               <a:t>Click to edit Master subtitle style</a:t>
             </a:r>
-            <a:endParaRPr lang="en-US"/>
           </a:p>
         </p:txBody>
       </p:sp>
@@ -791,7 +809,7 @@
           <a:p>
             <a:fld id="{5BCAD085-E8A6-8845-BD4E-CB4CCA059FC4}" type="datetimeFigureOut">
               <a:rPr lang="en-US" smtClean="0"/>
-              <a:t>1/27/13</a:t>
+              <a:t>8/26/26</a:t>
             </a:fld>
             <a:endParaRPr lang="en-US"/>
           </a:p>
@@ -885,10 +903,9 @@
           <a:lstStyle/>
           <a:p>
             <a:r>
-              <a:rPr lang="en-US" smtClean="0"/>
+              <a:rPr lang="en-US"/>
               <a:t>Click to edit Master title style</a:t>
             </a:r>
-            <a:endParaRPr lang="en-US"/>
           </a:p>
         </p:txBody>
       </p:sp>
@@ -909,38 +926,37 @@
           <a:p>
             <a:pPr lvl="0"/>
             <a:r>
-              <a:rPr lang="en-US" smtClean="0"/>
+              <a:rPr lang="en-US"/>
               <a:t>Click to edit Master text styles</a:t>
             </a:r>
           </a:p>
           <a:p>
             <a:pPr lvl="1"/>
             <a:r>
-              <a:rPr lang="en-US" smtClean="0"/>
+              <a:rPr lang="en-US"/>
               <a:t>Second level</a:t>
             </a:r>
           </a:p>
           <a:p>
             <a:pPr lvl="2"/>
             <a:r>
-              <a:rPr lang="en-US" smtClean="0"/>
+              <a:rPr lang="en-US"/>
               <a:t>Third level</a:t>
             </a:r>
           </a:p>
           <a:p>
             <a:pPr lvl="3"/>
             <a:r>
-              <a:rPr lang="en-US" smtClean="0"/>
+              <a:rPr lang="en-US"/>
               <a:t>Fourth level</a:t>
             </a:r>
           </a:p>
           <a:p>
             <a:pPr lvl="4"/>
             <a:r>
-              <a:rPr lang="en-US" smtClean="0"/>
+              <a:rPr lang="en-US"/>
               <a:t>Fifth level</a:t>
             </a:r>
-            <a:endParaRPr lang="en-US"/>
           </a:p>
         </p:txBody>
       </p:sp>
@@ -961,7 +977,7 @@
           <a:p>
             <a:fld id="{5BCAD085-E8A6-8845-BD4E-CB4CCA059FC4}" type="datetimeFigureOut">
               <a:rPr lang="en-US" smtClean="0"/>
-              <a:t>1/27/13</a:t>
+              <a:t>8/26/26</a:t>
             </a:fld>
             <a:endParaRPr lang="en-US"/>
           </a:p>
@@ -1060,10 +1076,9 @@
           <a:lstStyle/>
           <a:p>
             <a:r>
-              <a:rPr lang="en-US" smtClean="0"/>
+              <a:rPr lang="en-US"/>
               <a:t>Click to edit Master title style</a:t>
             </a:r>
-            <a:endParaRPr lang="en-US"/>
           </a:p>
         </p:txBody>
       </p:sp>
@@ -1089,38 +1104,37 @@
           <a:p>
             <a:pPr lvl="0"/>
             <a:r>
-              <a:rPr lang="en-US" smtClean="0"/>
+              <a:rPr lang="en-US"/>
               <a:t>Click to edit Master text styles</a:t>
             </a:r>
           </a:p>
           <a:p>
             <a:pPr lvl="1"/>
             <a:r>
-              <a:rPr lang="en-US" smtClean="0"/>
+              <a:rPr lang="en-US"/>
               <a:t>Second level</a:t>
             </a:r>
           </a:p>
           <a:p>
             <a:pPr lvl="2"/>
             <a:r>
-              <a:rPr lang="en-US" smtClean="0"/>
+              <a:rPr lang="en-US"/>
               <a:t>Third level</a:t>
             </a:r>
           </a:p>
           <a:p>
             <a:pPr lvl="3"/>
             <a:r>
-              <a:rPr lang="en-US" smtClean="0"/>
+              <a:rPr lang="en-US"/>
               <a:t>Fourth level</a:t>
             </a:r>
           </a:p>
           <a:p>
             <a:pPr lvl="4"/>
             <a:r>
-              <a:rPr lang="en-US" smtClean="0"/>
+              <a:rPr lang="en-US"/>
               <a:t>Fifth level</a:t>
             </a:r>
-            <a:endParaRPr lang="en-US"/>
           </a:p>
         </p:txBody>
       </p:sp>
@@ -1141,7 +1155,7 @@
           <a:p>
             <a:fld id="{5BCAD085-E8A6-8845-BD4E-CB4CCA059FC4}" type="datetimeFigureOut">
               <a:rPr lang="en-US" smtClean="0"/>
-              <a:t>1/27/13</a:t>
+              <a:t>8/26/26</a:t>
             </a:fld>
             <a:endParaRPr lang="en-US"/>
           </a:p>
@@ -1235,10 +1249,9 @@
           <a:lstStyle/>
           <a:p>
             <a:r>
-              <a:rPr lang="en-US" smtClean="0"/>
+              <a:rPr lang="en-US"/>
               <a:t>Click to edit Master title style</a:t>
             </a:r>
-            <a:endParaRPr lang="en-US"/>
           </a:p>
         </p:txBody>
       </p:sp>
@@ -1259,38 +1272,37 @@
           <a:p>
             <a:pPr lvl="0"/>
             <a:r>
-              <a:rPr lang="en-US" smtClean="0"/>
+              <a:rPr lang="en-US"/>
               <a:t>Click to edit Master text styles</a:t>
             </a:r>
           </a:p>
           <a:p>
             <a:pPr lvl="1"/>
             <a:r>
-              <a:rPr lang="en-US" smtClean="0"/>
+              <a:rPr lang="en-US"/>
               <a:t>Second level</a:t>
             </a:r>
           </a:p>
           <a:p>
             <a:pPr lvl="2"/>
             <a:r>
-              <a:rPr lang="en-US" smtClean="0"/>
+              <a:rPr lang="en-US"/>
               <a:t>Third level</a:t>
             </a:r>
           </a:p>
           <a:p>
             <a:pPr lvl="3"/>
             <a:r>
-              <a:rPr lang="en-US" smtClean="0"/>
+              <a:rPr lang="en-US"/>
               <a:t>Fourth level</a:t>
             </a:r>
           </a:p>
           <a:p>
             <a:pPr lvl="4"/>
             <a:r>
-              <a:rPr lang="en-US" smtClean="0"/>
+              <a:rPr lang="en-US"/>
               <a:t>Fifth level</a:t>
             </a:r>
-            <a:endParaRPr lang="en-US"/>
           </a:p>
         </p:txBody>
       </p:sp>
@@ -1311,7 +1323,7 @@
           <a:p>
             <a:fld id="{5BCAD085-E8A6-8845-BD4E-CB4CCA059FC4}" type="datetimeFigureOut">
               <a:rPr lang="en-US" smtClean="0"/>
-              <a:t>1/27/13</a:t>
+              <a:t>8/26/26</a:t>
             </a:fld>
             <a:endParaRPr lang="en-US"/>
           </a:p>
@@ -1414,10 +1426,9 @@
           </a:lstStyle>
           <a:p>
             <a:r>
-              <a:rPr lang="en-US" smtClean="0"/>
+              <a:rPr lang="en-US"/>
               <a:t>Click to edit Master title style</a:t>
             </a:r>
-            <a:endParaRPr lang="en-US"/>
           </a:p>
         </p:txBody>
       </p:sp>
@@ -1534,7 +1545,7 @@
           <a:p>
             <a:pPr lvl="0"/>
             <a:r>
-              <a:rPr lang="en-US" smtClean="0"/>
+              <a:rPr lang="en-US"/>
               <a:t>Click to edit Master text styles</a:t>
             </a:r>
           </a:p>
@@ -1557,7 +1568,7 @@
           <a:p>
             <a:fld id="{5BCAD085-E8A6-8845-BD4E-CB4CCA059FC4}" type="datetimeFigureOut">
               <a:rPr lang="en-US" smtClean="0"/>
-              <a:t>1/27/13</a:t>
+              <a:t>8/26/26</a:t>
             </a:fld>
             <a:endParaRPr lang="en-US"/>
           </a:p>
@@ -1651,10 +1662,9 @@
           <a:lstStyle/>
           <a:p>
             <a:r>
-              <a:rPr lang="en-US" smtClean="0"/>
+              <a:rPr lang="en-US"/>
               <a:t>Click to edit Master title style</a:t>
             </a:r>
-            <a:endParaRPr lang="en-US"/>
           </a:p>
         </p:txBody>
       </p:sp>
@@ -1708,38 +1718,37 @@
           <a:p>
             <a:pPr lvl="0"/>
             <a:r>
-              <a:rPr lang="en-US" smtClean="0"/>
+              <a:rPr lang="en-US"/>
               <a:t>Click to edit Master text styles</a:t>
             </a:r>
           </a:p>
           <a:p>
             <a:pPr lvl="1"/>
             <a:r>
-              <a:rPr lang="en-US" smtClean="0"/>
+              <a:rPr lang="en-US"/>
               <a:t>Second level</a:t>
             </a:r>
           </a:p>
           <a:p>
             <a:pPr lvl="2"/>
             <a:r>
-              <a:rPr lang="en-US" smtClean="0"/>
+              <a:rPr lang="en-US"/>
               <a:t>Third level</a:t>
             </a:r>
           </a:p>
           <a:p>
             <a:pPr lvl="3"/>
             <a:r>
-              <a:rPr lang="en-US" smtClean="0"/>
+              <a:rPr lang="en-US"/>
               <a:t>Fourth level</a:t>
             </a:r>
           </a:p>
           <a:p>
             <a:pPr lvl="4"/>
             <a:r>
-              <a:rPr lang="en-US" smtClean="0"/>
+              <a:rPr lang="en-US"/>
               <a:t>Fifth level</a:t>
             </a:r>
-            <a:endParaRPr lang="en-US"/>
           </a:p>
         </p:txBody>
       </p:sp>
@@ -1793,38 +1802,37 @@
           <a:p>
             <a:pPr lvl="0"/>
             <a:r>
-              <a:rPr lang="en-US" smtClean="0"/>
+              <a:rPr lang="en-US"/>
               <a:t>Click to edit Master text styles</a:t>
             </a:r>
           </a:p>
           <a:p>
             <a:pPr lvl="1"/>
             <a:r>
-              <a:rPr lang="en-US" smtClean="0"/>
+              <a:rPr lang="en-US"/>
               <a:t>Second level</a:t>
             </a:r>
           </a:p>
           <a:p>
             <a:pPr lvl="2"/>
             <a:r>
-              <a:rPr lang="en-US" smtClean="0"/>
+              <a:rPr lang="en-US"/>
               <a:t>Third level</a:t>
             </a:r>
           </a:p>
           <a:p>
             <a:pPr lvl="3"/>
             <a:r>
-              <a:rPr lang="en-US" smtClean="0"/>
+              <a:rPr lang="en-US"/>
               <a:t>Fourth level</a:t>
             </a:r>
           </a:p>
           <a:p>
             <a:pPr lvl="4"/>
             <a:r>
-              <a:rPr lang="en-US" smtClean="0"/>
+              <a:rPr lang="en-US"/>
               <a:t>Fifth level</a:t>
             </a:r>
-            <a:endParaRPr lang="en-US"/>
           </a:p>
         </p:txBody>
       </p:sp>
@@ -1845,7 +1853,7 @@
           <a:p>
             <a:fld id="{5BCAD085-E8A6-8845-BD4E-CB4CCA059FC4}" type="datetimeFigureOut">
               <a:rPr lang="en-US" smtClean="0"/>
-              <a:t>1/27/13</a:t>
+              <a:t>8/26/26</a:t>
             </a:fld>
             <a:endParaRPr lang="en-US"/>
           </a:p>
@@ -1943,10 +1951,9 @@
           </a:lstStyle>
           <a:p>
             <a:r>
-              <a:rPr lang="en-US" smtClean="0"/>
+              <a:rPr lang="en-US"/>
               <a:t>Click to edit Master title style</a:t>
             </a:r>
-            <a:endParaRPr lang="en-US"/>
           </a:p>
         </p:txBody>
       </p:sp>
@@ -2009,7 +2016,7 @@
           <a:p>
             <a:pPr lvl="0"/>
             <a:r>
-              <a:rPr lang="en-US" smtClean="0"/>
+              <a:rPr lang="en-US"/>
               <a:t>Click to edit Master text styles</a:t>
             </a:r>
           </a:p>
@@ -2065,38 +2072,37 @@
           <a:p>
             <a:pPr lvl="0"/>
             <a:r>
-              <a:rPr lang="en-US" smtClean="0"/>
+              <a:rPr lang="en-US"/>
               <a:t>Click to edit Master text styles</a:t>
             </a:r>
           </a:p>
           <a:p>
             <a:pPr lvl="1"/>
             <a:r>
-              <a:rPr lang="en-US" smtClean="0"/>
+              <a:rPr lang="en-US"/>
               <a:t>Second level</a:t>
             </a:r>
           </a:p>
           <a:p>
             <a:pPr lvl="2"/>
             <a:r>
-              <a:rPr lang="en-US" smtClean="0"/>
+              <a:rPr lang="en-US"/>
               <a:t>Third level</a:t>
             </a:r>
           </a:p>
           <a:p>
             <a:pPr lvl="3"/>
             <a:r>
-              <a:rPr lang="en-US" smtClean="0"/>
+              <a:rPr lang="en-US"/>
               <a:t>Fourth level</a:t>
             </a:r>
           </a:p>
           <a:p>
             <a:pPr lvl="4"/>
             <a:r>
-              <a:rPr lang="en-US" smtClean="0"/>
+              <a:rPr lang="en-US"/>
               <a:t>Fifth level</a:t>
             </a:r>
-            <a:endParaRPr lang="en-US"/>
           </a:p>
         </p:txBody>
       </p:sp>
@@ -2159,7 +2165,7 @@
           <a:p>
             <a:pPr lvl="0"/>
             <a:r>
-              <a:rPr lang="en-US" smtClean="0"/>
+              <a:rPr lang="en-US"/>
               <a:t>Click to edit Master text styles</a:t>
             </a:r>
           </a:p>
@@ -2215,38 +2221,37 @@
           <a:p>
             <a:pPr lvl="0"/>
             <a:r>
-              <a:rPr lang="en-US" smtClean="0"/>
+              <a:rPr lang="en-US"/>
               <a:t>Click to edit Master text styles</a:t>
             </a:r>
           </a:p>
           <a:p>
             <a:pPr lvl="1"/>
             <a:r>
-              <a:rPr lang="en-US" smtClean="0"/>
+              <a:rPr lang="en-US"/>
               <a:t>Second level</a:t>
             </a:r>
           </a:p>
           <a:p>
             <a:pPr lvl="2"/>
             <a:r>
-              <a:rPr lang="en-US" smtClean="0"/>
+              <a:rPr lang="en-US"/>
               <a:t>Third level</a:t>
             </a:r>
           </a:p>
           <a:p>
             <a:pPr lvl="3"/>
             <a:r>
-              <a:rPr lang="en-US" smtClean="0"/>
+              <a:rPr lang="en-US"/>
               <a:t>Fourth level</a:t>
             </a:r>
           </a:p>
           <a:p>
             <a:pPr lvl="4"/>
             <a:r>
-              <a:rPr lang="en-US" smtClean="0"/>
+              <a:rPr lang="en-US"/>
               <a:t>Fifth level</a:t>
             </a:r>
-            <a:endParaRPr lang="en-US"/>
           </a:p>
         </p:txBody>
       </p:sp>
@@ -2267,7 +2272,7 @@
           <a:p>
             <a:fld id="{5BCAD085-E8A6-8845-BD4E-CB4CCA059FC4}" type="datetimeFigureOut">
               <a:rPr lang="en-US" smtClean="0"/>
-              <a:t>1/27/13</a:t>
+              <a:t>8/26/26</a:t>
             </a:fld>
             <a:endParaRPr lang="en-US"/>
           </a:p>
@@ -2361,10 +2366,9 @@
           <a:lstStyle/>
           <a:p>
             <a:r>
-              <a:rPr lang="en-US" smtClean="0"/>
+              <a:rPr lang="en-US"/>
               <a:t>Click to edit Master title style</a:t>
             </a:r>
-            <a:endParaRPr lang="en-US"/>
           </a:p>
         </p:txBody>
       </p:sp>
@@ -2385,7 +2389,7 @@
           <a:p>
             <a:fld id="{5BCAD085-E8A6-8845-BD4E-CB4CCA059FC4}" type="datetimeFigureOut">
               <a:rPr lang="en-US" smtClean="0"/>
-              <a:t>1/27/13</a:t>
+              <a:t>8/26/26</a:t>
             </a:fld>
             <a:endParaRPr lang="en-US"/>
           </a:p>
@@ -2480,7 +2484,7 @@
           <a:p>
             <a:fld id="{5BCAD085-E8A6-8845-BD4E-CB4CCA059FC4}" type="datetimeFigureOut">
               <a:rPr lang="en-US" smtClean="0"/>
-              <a:t>1/27/13</a:t>
+              <a:t>8/26/26</a:t>
             </a:fld>
             <a:endParaRPr lang="en-US"/>
           </a:p>
@@ -2583,10 +2587,9 @@
           </a:lstStyle>
           <a:p>
             <a:r>
-              <a:rPr lang="en-US" smtClean="0"/>
+              <a:rPr lang="en-US"/>
               <a:t>Click to edit Master title style</a:t>
             </a:r>
-            <a:endParaRPr lang="en-US"/>
           </a:p>
         </p:txBody>
       </p:sp>
@@ -2640,38 +2643,37 @@
           <a:p>
             <a:pPr lvl="0"/>
             <a:r>
-              <a:rPr lang="en-US" smtClean="0"/>
+              <a:rPr lang="en-US"/>
               <a:t>Click to edit Master text styles</a:t>
             </a:r>
           </a:p>
           <a:p>
             <a:pPr lvl="1"/>
             <a:r>
-              <a:rPr lang="en-US" smtClean="0"/>
+              <a:rPr lang="en-US"/>
               <a:t>Second level</a:t>
             </a:r>
           </a:p>
           <a:p>
             <a:pPr lvl="2"/>
             <a:r>
-              <a:rPr lang="en-US" smtClean="0"/>
+              <a:rPr lang="en-US"/>
               <a:t>Third level</a:t>
             </a:r>
           </a:p>
           <a:p>
             <a:pPr lvl="3"/>
             <a:r>
-              <a:rPr lang="en-US" smtClean="0"/>
+              <a:rPr lang="en-US"/>
               <a:t>Fourth level</a:t>
             </a:r>
           </a:p>
           <a:p>
             <a:pPr lvl="4"/>
             <a:r>
-              <a:rPr lang="en-US" smtClean="0"/>
+              <a:rPr lang="en-US"/>
               <a:t>Fifth level</a:t>
             </a:r>
-            <a:endParaRPr lang="en-US"/>
           </a:p>
         </p:txBody>
       </p:sp>
@@ -2734,7 +2736,7 @@
           <a:p>
             <a:pPr lvl="0"/>
             <a:r>
-              <a:rPr lang="en-US" smtClean="0"/>
+              <a:rPr lang="en-US"/>
               <a:t>Click to edit Master text styles</a:t>
             </a:r>
           </a:p>
@@ -2757,7 +2759,7 @@
           <a:p>
             <a:fld id="{5BCAD085-E8A6-8845-BD4E-CB4CCA059FC4}" type="datetimeFigureOut">
               <a:rPr lang="en-US" smtClean="0"/>
-              <a:t>1/27/13</a:t>
+              <a:t>8/26/26</a:t>
             </a:fld>
             <a:endParaRPr lang="en-US"/>
           </a:p>
@@ -2860,10 +2862,9 @@
           </a:lstStyle>
           <a:p>
             <a:r>
-              <a:rPr lang="en-US" smtClean="0"/>
+              <a:rPr lang="en-US"/>
               <a:t>Click to edit Master title style</a:t>
             </a:r>
-            <a:endParaRPr lang="en-US"/>
           </a:p>
         </p:txBody>
       </p:sp>
@@ -2987,7 +2988,7 @@
           <a:p>
             <a:pPr lvl="0"/>
             <a:r>
-              <a:rPr lang="en-US" smtClean="0"/>
+              <a:rPr lang="en-US"/>
               <a:t>Click to edit Master text styles</a:t>
             </a:r>
           </a:p>
@@ -3010,7 +3011,7 @@
           <a:p>
             <a:fld id="{5BCAD085-E8A6-8845-BD4E-CB4CCA059FC4}" type="datetimeFigureOut">
               <a:rPr lang="en-US" smtClean="0"/>
-              <a:t>1/27/13</a:t>
+              <a:t>8/26/26</a:t>
             </a:fld>
             <a:endParaRPr lang="en-US"/>
           </a:p>
@@ -3119,10 +3120,9 @@
           <a:lstStyle/>
           <a:p>
             <a:r>
-              <a:rPr lang="en-US" smtClean="0"/>
+              <a:rPr lang="en-US"/>
               <a:t>Click to edit Master title style</a:t>
             </a:r>
-            <a:endParaRPr lang="en-US"/>
           </a:p>
         </p:txBody>
       </p:sp>
@@ -3153,38 +3153,37 @@
           <a:p>
             <a:pPr lvl="0"/>
             <a:r>
-              <a:rPr lang="en-US" smtClean="0"/>
+              <a:rPr lang="en-US"/>
               <a:t>Click to edit Master text styles</a:t>
             </a:r>
           </a:p>
           <a:p>
             <a:pPr lvl="1"/>
             <a:r>
-              <a:rPr lang="en-US" smtClean="0"/>
+              <a:rPr lang="en-US"/>
               <a:t>Second level</a:t>
             </a:r>
           </a:p>
           <a:p>
             <a:pPr lvl="2"/>
             <a:r>
-              <a:rPr lang="en-US" smtClean="0"/>
+              <a:rPr lang="en-US"/>
               <a:t>Third level</a:t>
             </a:r>
           </a:p>
           <a:p>
             <a:pPr lvl="3"/>
             <a:r>
-              <a:rPr lang="en-US" smtClean="0"/>
+              <a:rPr lang="en-US"/>
               <a:t>Fourth level</a:t>
             </a:r>
           </a:p>
           <a:p>
             <a:pPr lvl="4"/>
             <a:r>
-              <a:rPr lang="en-US" smtClean="0"/>
+              <a:rPr lang="en-US"/>
               <a:t>Fifth level</a:t>
             </a:r>
-            <a:endParaRPr lang="en-US"/>
           </a:p>
         </p:txBody>
       </p:sp>
@@ -3223,7 +3222,7 @@
           <a:p>
             <a:fld id="{5BCAD085-E8A6-8845-BD4E-CB4CCA059FC4}" type="datetimeFigureOut">
               <a:rPr lang="en-US" smtClean="0"/>
-              <a:t>1/27/13</a:t>
+              <a:t>8/26/26</a:t>
             </a:fld>
             <a:endParaRPr lang="en-US"/>
           </a:p>
@@ -3582,7 +3581,7 @@
 </file>
 
 <file path=ppt/slides/slide1.xml><?xml version="1.0" encoding="utf-8"?>
-<p:sld xmlns:a="http://schemas.openxmlformats.org/drawingml/2006/main" xmlns:p="http://schemas.openxmlformats.org/presentationml/2006/main" xmlns:r="http://schemas.openxmlformats.org/officeDocument/2006/relationships">
+<p:sld xmlns:a="http://schemas.openxmlformats.org/drawingml/2006/main" xmlns:r="http://schemas.openxmlformats.org/officeDocument/2006/relationships" xmlns:p="http://schemas.openxmlformats.org/presentationml/2006/main">
   <p:cSld>
     <p:spTree>
       <p:nvGrpSpPr>
@@ -3590,7 +3589,14 @@
         <p:cNvGrpSpPr/>
         <p:nvPr/>
       </p:nvGrpSpPr>
-      <p:grpSpPr/>
+      <p:grpSpPr>
+        <a:xfrm>
+          <a:off x="0" y="0"/>
+          <a:ext cx="0" cy="0"/>
+          <a:chOff x="0" y="0"/>
+          <a:chExt cx="0" cy="0"/>
+        </a:xfrm>
+      </p:grpSpPr>
       <p:sp>
         <p:nvSpPr>
           <p:cNvPr id="2" name="Rectangle 1"/>
@@ -3631,6 +3637,7 @@
           <a:lstStyle/>
           <a:p>
             <a:pPr algn="ctr"/>
+            <a:endParaRPr/>
           </a:p>
         </p:txBody>
       </p:sp>
@@ -3708,7 +3715,7 @@
 </file>
 
 <file path=ppt/slides/slide10.xml><?xml version="1.0" encoding="utf-8"?>
-<p:sld xmlns:a="http://schemas.openxmlformats.org/drawingml/2006/main" xmlns:p="http://schemas.openxmlformats.org/presentationml/2006/main" xmlns:r="http://schemas.openxmlformats.org/officeDocument/2006/relationships">
+<p:sld xmlns:a="http://schemas.openxmlformats.org/drawingml/2006/main" xmlns:r="http://schemas.openxmlformats.org/officeDocument/2006/relationships" xmlns:p="http://schemas.openxmlformats.org/presentationml/2006/main">
   <p:cSld>
     <p:spTree>
       <p:nvGrpSpPr>
@@ -3716,7 +3723,14 @@
         <p:cNvGrpSpPr/>
         <p:nvPr/>
       </p:nvGrpSpPr>
-      <p:grpSpPr/>
+      <p:grpSpPr>
+        <a:xfrm>
+          <a:off x="0" y="0"/>
+          <a:ext cx="0" cy="0"/>
+          <a:chOff x="0" y="0"/>
+          <a:chExt cx="0" cy="0"/>
+        </a:xfrm>
+      </p:grpSpPr>
       <p:sp>
         <p:nvSpPr>
           <p:cNvPr id="2" name="TextBox 1"/>
@@ -3747,7 +3761,7 @@
               </a:defRPr>
             </a:pPr>
             <a:r>
-              <a:t>Alles bij elkaar</a:t>
+              <a:t>As 3 · Hoe fijn kan het?</a:t>
             </a:r>
           </a:p>
         </p:txBody>
@@ -3782,7 +3796,7 @@
               </a:defRPr>
             </a:pPr>
             <a:r>
-              <a:t>Stap voor stap, op één vaste testset — waar zit de winst?</a:t>
+              <a:t>Zelfde vlak, R = 1 … 100 · en de fout op de vaste testset per R</a:t>
             </a:r>
           </a:p>
         </p:txBody>
@@ -3817,14 +3831,14 @@
               </a:defRPr>
             </a:pPr>
             <a:r>
-              <a:t>Oevererosietool · update 26-08-2026 · 10</a:t>
+              <a:t>Oevererosietool · update 26-08-2026 · 11</a:t>
             </a:r>
           </a:p>
         </p:txBody>
       </p:sp>
       <p:pic>
         <p:nvPicPr>
-          <p:cNvPr id="5" name="Picture 4" descr="matrix.png"/>
+          <p:cNvPr id="5" name="Picture 4" descr="maas3_r_8930_8940.png"/>
           <p:cNvPicPr>
             <a:picLocks noChangeAspect="1"/>
           </p:cNvPicPr>
@@ -3839,23 +3853,47 @@
         <p:spPr>
           <a:xfrm>
             <a:off x="548640" y="1371600"/>
-            <a:ext cx="11064240" cy="4425696"/>
+            <a:ext cx="5760720" cy="3280921"/>
           </a:xfrm>
           <a:prstGeom prst="rect">
             <a:avLst/>
           </a:prstGeom>
         </p:spPr>
       </p:pic>
-      <p:sp>
-        <p:nvSpPr>
-          <p:cNvPr id="6" name="TextBox 5"/>
+      <p:pic>
+        <p:nvPicPr>
+          <p:cNvPr id="6" name="Picture 5" descr="resolution_sweep.png"/>
+          <p:cNvPicPr>
+            <a:picLocks noChangeAspect="1"/>
+          </p:cNvPicPr>
+          <p:nvPr/>
+        </p:nvPicPr>
+        <p:blipFill>
+          <a:blip r:embed="rId3"/>
+          <a:stretch>
+            <a:fillRect/>
+          </a:stretch>
+        </p:blipFill>
+        <p:spPr>
+          <a:xfrm>
+            <a:off x="6400800" y="1371600"/>
+            <a:ext cx="5577840" cy="2330016"/>
+          </a:xfrm>
+          <a:prstGeom prst="rect">
+            <a:avLst/>
+          </a:prstGeom>
+        </p:spPr>
+      </p:pic>
+      <p:sp>
+        <p:nvSpPr>
+          <p:cNvPr id="7" name="TextBox 6"/>
           <p:cNvSpPr txBox="1"/>
           <p:nvPr/>
         </p:nvSpPr>
         <p:spPr>
           <a:xfrm>
-            <a:off x="548640" y="5303520"/>
-            <a:ext cx="11064240" cy="1097280"/>
+            <a:off x="548640" y="4754880"/>
+            <a:ext cx="11430000" cy="1645920"/>
           </a:xfrm>
           <a:prstGeom prst="rect">
             <a:avLst/>
@@ -3870,31 +3908,61 @@
           <a:p>
             <a:pPr>
               <a:spcAft>
-                <a:spcPts val="400"/>
+                <a:spcPts val="300"/>
               </a:spcAft>
-              <a:defRPr sz="1400" b="0">
+              <a:defRPr sz="1200" b="0">
                 <a:solidFill>
                   <a:srgbClr val="1F3A3D"/>
                 </a:solidFill>
               </a:defRPr>
             </a:pPr>
             <a:r>
-              <a:t>• Opschonen: −1,72 m/jr (−43 %) · historie-features: −0,14 · structurenlaag: ±0 (dekking/juistheid) · resolutie: andere eenheid, −0,25 per segment</a:t>
+              <a:t>• De segment-representatie (bruin) volgt de gemeten oever vanaf R ≈ 5–10; bij R = 50–100 raken segmenten leeg (rood)</a:t>
             </a:r>
           </a:p>
           <a:p>
             <a:pPr>
               <a:spcAft>
-                <a:spcPts val="400"/>
+                <a:spcPts val="300"/>
               </a:spcAft>
-              <a:defRPr sz="1400" b="1">
+              <a:defRPr sz="1200" b="0">
                 <a:solidFill>
                   <a:srgbClr val="1F3A3D"/>
                 </a:solidFill>
               </a:defRPr>
             </a:pPr>
             <a:r>
-              <a:t>Het model was nooit de bottleneck — de labels waren het. En de regels raken op: wat overblijft, kan alleen een mens zien.</a:t>
+              <a:t>• Fout per segment daalt van 2,25 (R = 1) naar 1,88 (R = 5) en 1,61 (R = 20) — kleiner wordt nauwkeuriger, niet ruiziger</a:t>
+            </a:r>
+          </a:p>
+          <a:p>
+            <a:pPr>
+              <a:spcAft>
+                <a:spcPts val="300"/>
+              </a:spcAft>
+              <a:defRPr sz="1200" b="0">
+                <a:solidFill>
+                  <a:srgbClr val="1F3A3D"/>
+                </a:solidFill>
+              </a:defRPr>
+            </a:pPr>
+            <a:r>
+              <a:t>• Terug-samengevoegd per vlak blijft de fout ≈ 2,1–2,2: het vlak-getal zelf heeft een vloer (0,5–1,1 m/jr representatiefout)</a:t>
+            </a:r>
+          </a:p>
+          <a:p>
+            <a:pPr>
+              <a:spcAft>
+                <a:spcPts val="300"/>
+              </a:spcAft>
+              <a:defRPr sz="1200" b="0">
+                <a:solidFill>
+                  <a:srgbClr val="1F3A3D"/>
+                </a:solidFill>
+              </a:defRPr>
+            </a:pPr>
+            <a:r>
+              <a:t>• Grens ligt bij de lijnbemonstering (60 punten per lijn), niet bij het model · praktisch: R = 5–10 (≈ 10–20 m)</a:t>
             </a:r>
           </a:p>
         </p:txBody>
@@ -3908,7 +3976,7 @@
 </file>
 
 <file path=ppt/slides/slide11.xml><?xml version="1.0" encoding="utf-8"?>
-<p:sld xmlns:a="http://schemas.openxmlformats.org/drawingml/2006/main" xmlns:p="http://schemas.openxmlformats.org/presentationml/2006/main" xmlns:r="http://schemas.openxmlformats.org/officeDocument/2006/relationships">
+<p:sld xmlns:a="http://schemas.openxmlformats.org/drawingml/2006/main" xmlns:r="http://schemas.openxmlformats.org/officeDocument/2006/relationships" xmlns:p="http://schemas.openxmlformats.org/presentationml/2006/main">
   <p:cSld>
     <p:spTree>
       <p:nvGrpSpPr>
@@ -3916,7 +3984,14 @@
         <p:cNvGrpSpPr/>
         <p:nvPr/>
       </p:nvGrpSpPr>
-      <p:grpSpPr/>
+      <p:grpSpPr>
+        <a:xfrm>
+          <a:off x="0" y="0"/>
+          <a:ext cx="0" cy="0"/>
+          <a:chOff x="0" y="0"/>
+          <a:chExt cx="0" cy="0"/>
+        </a:xfrm>
+      </p:grpSpPr>
       <p:sp>
         <p:nvSpPr>
           <p:cNvPr id="2" name="TextBox 1"/>
@@ -3947,7 +4022,7 @@
               </a:defRPr>
             </a:pPr>
             <a:r>
-              <a:t>Scorebord — eerlijk gemeten</a:t>
+              <a:t>Alles bij elkaar</a:t>
             </a:r>
           </a:p>
         </p:txBody>
@@ -3982,7 +4057,7 @@
               </a:defRPr>
             </a:pPr>
             <a:r>
-              <a:t>Alleen binnen een rij vergelijken: elke rij is een andere meetlat</a:t>
+              <a:t>Stap voor stap, op één vaste testset — waar zit de winst?</a:t>
             </a:r>
           </a:p>
         </p:txBody>
@@ -4017,7 +4092,214 @@
               </a:defRPr>
             </a:pPr>
             <a:r>
-              <a:t>Oevererosietool · update 26-08-2026 · 11</a:t>
+              <a:t>Oevererosietool · update 26-08-2026 · 12</a:t>
+            </a:r>
+          </a:p>
+        </p:txBody>
+      </p:sp>
+      <p:pic>
+        <p:nvPicPr>
+          <p:cNvPr id="5" name="Picture 4" descr="matrix.png"/>
+          <p:cNvPicPr>
+            <a:picLocks noChangeAspect="1"/>
+          </p:cNvPicPr>
+          <p:nvPr/>
+        </p:nvPicPr>
+        <p:blipFill>
+          <a:blip r:embed="rId3"/>
+          <a:stretch>
+            <a:fillRect/>
+          </a:stretch>
+        </p:blipFill>
+        <p:spPr>
+          <a:xfrm>
+            <a:off x="548640" y="1371600"/>
+            <a:ext cx="11064240" cy="4425696"/>
+          </a:xfrm>
+          <a:prstGeom prst="rect">
+            <a:avLst/>
+          </a:prstGeom>
+        </p:spPr>
+      </p:pic>
+      <p:sp>
+        <p:nvSpPr>
+          <p:cNvPr id="6" name="TextBox 5"/>
+          <p:cNvSpPr txBox="1"/>
+          <p:nvPr/>
+        </p:nvSpPr>
+        <p:spPr>
+          <a:xfrm>
+            <a:off x="548640" y="5303520"/>
+            <a:ext cx="11064240" cy="1097280"/>
+          </a:xfrm>
+          <a:prstGeom prst="rect">
+            <a:avLst/>
+          </a:prstGeom>
+          <a:noFill/>
+        </p:spPr>
+        <p:txBody>
+          <a:bodyPr wrap="square">
+            <a:spAutoFit/>
+          </a:bodyPr>
+          <a:lstStyle/>
+          <a:p>
+            <a:pPr>
+              <a:spcAft>
+                <a:spcPts val="400"/>
+              </a:spcAft>
+              <a:defRPr sz="1400" b="0">
+                <a:solidFill>
+                  <a:srgbClr val="1F3A3D"/>
+                </a:solidFill>
+              </a:defRPr>
+            </a:pPr>
+            <a:r>
+              <a:t>• Opschonen: −1,72 m/jr (−43 %) · historie-features: −0,14 · structurenlaag: ±0 (dekking/juistheid) · resolutie: andere eenheid, −0,25 per segment</a:t>
+            </a:r>
+          </a:p>
+          <a:p>
+            <a:pPr>
+              <a:spcAft>
+                <a:spcPts val="400"/>
+              </a:spcAft>
+              <a:defRPr sz="1400" b="1">
+                <a:solidFill>
+                  <a:srgbClr val="1F3A3D"/>
+                </a:solidFill>
+              </a:defRPr>
+            </a:pPr>
+            <a:r>
+              <a:t>Het model was nooit de bottleneck — de labels waren het. En de regels raken op: wat overblijft, kan alleen een mens zien.</a:t>
+            </a:r>
+          </a:p>
+        </p:txBody>
+      </p:sp>
+    </p:spTree>
+  </p:cSld>
+  <p:clrMapOvr>
+    <a:masterClrMapping/>
+  </p:clrMapOvr>
+</p:sld>
+</file>
+
+<file path=ppt/slides/slide12.xml><?xml version="1.0" encoding="utf-8"?>
+<p:sld xmlns:a="http://schemas.openxmlformats.org/drawingml/2006/main" xmlns:r="http://schemas.openxmlformats.org/officeDocument/2006/relationships" xmlns:p="http://schemas.openxmlformats.org/presentationml/2006/main">
+  <p:cSld>
+    <p:spTree>
+      <p:nvGrpSpPr>
+        <p:cNvPr id="1" name=""/>
+        <p:cNvGrpSpPr/>
+        <p:nvPr/>
+      </p:nvGrpSpPr>
+      <p:grpSpPr>
+        <a:xfrm>
+          <a:off x="0" y="0"/>
+          <a:ext cx="0" cy="0"/>
+          <a:chOff x="0" y="0"/>
+          <a:chExt cx="0" cy="0"/>
+        </a:xfrm>
+      </p:grpSpPr>
+      <p:sp>
+        <p:nvSpPr>
+          <p:cNvPr id="2" name="TextBox 1"/>
+          <p:cNvSpPr txBox="1"/>
+          <p:nvPr/>
+        </p:nvSpPr>
+        <p:spPr>
+          <a:xfrm>
+            <a:off x="548640" y="320040"/>
+            <a:ext cx="10972800" cy="731520"/>
+          </a:xfrm>
+          <a:prstGeom prst="rect">
+            <a:avLst/>
+          </a:prstGeom>
+          <a:noFill/>
+        </p:spPr>
+        <p:txBody>
+          <a:bodyPr wrap="none">
+            <a:spAutoFit/>
+          </a:bodyPr>
+          <a:lstStyle/>
+          <a:p>
+            <a:pPr>
+              <a:defRPr sz="3000" b="1">
+                <a:solidFill>
+                  <a:srgbClr val="2BB5A6"/>
+                </a:solidFill>
+              </a:defRPr>
+            </a:pPr>
+            <a:r>
+              <a:t>Scorebord — eerlijk gemeten</a:t>
+            </a:r>
+          </a:p>
+        </p:txBody>
+      </p:sp>
+      <p:sp>
+        <p:nvSpPr>
+          <p:cNvPr id="3" name="TextBox 2"/>
+          <p:cNvSpPr txBox="1"/>
+          <p:nvPr/>
+        </p:nvSpPr>
+        <p:spPr>
+          <a:xfrm>
+            <a:off x="548640" y="960120"/>
+            <a:ext cx="10972800" cy="548640"/>
+          </a:xfrm>
+          <a:prstGeom prst="rect">
+            <a:avLst/>
+          </a:prstGeom>
+          <a:noFill/>
+        </p:spPr>
+        <p:txBody>
+          <a:bodyPr wrap="none">
+            <a:spAutoFit/>
+          </a:bodyPr>
+          <a:lstStyle/>
+          <a:p>
+            <a:pPr>
+              <a:defRPr sz="1700">
+                <a:solidFill>
+                  <a:srgbClr val="1F3A3D"/>
+                </a:solidFill>
+              </a:defRPr>
+            </a:pPr>
+            <a:r>
+              <a:t>Alleen binnen een rij vergelijken: elke rij is een andere meetlat</a:t>
+            </a:r>
+          </a:p>
+        </p:txBody>
+      </p:sp>
+      <p:sp>
+        <p:nvSpPr>
+          <p:cNvPr id="4" name="TextBox 3"/>
+          <p:cNvSpPr txBox="1"/>
+          <p:nvPr/>
+        </p:nvSpPr>
+        <p:spPr>
+          <a:xfrm>
+            <a:off x="548640" y="6400800"/>
+            <a:ext cx="10972800" cy="274320"/>
+          </a:xfrm>
+          <a:prstGeom prst="rect">
+            <a:avLst/>
+          </a:prstGeom>
+          <a:noFill/>
+        </p:spPr>
+        <p:txBody>
+          <a:bodyPr wrap="none">
+            <a:spAutoFit/>
+          </a:bodyPr>
+          <a:lstStyle/>
+          <a:p>
+            <a:pPr>
+              <a:defRPr sz="1000">
+                <a:solidFill>
+                  <a:srgbClr val="6B7778"/>
+                </a:solidFill>
+              </a:defRPr>
+            </a:pPr>
+            <a:r>
+              <a:t>Oevererosietool · update 26-08-2026 · 13</a:t>
             </a:r>
           </a:p>
         </p:txBody>
@@ -4032,7 +4314,7 @@
         </p:nvGraphicFramePr>
         <p:xfrm>
           <a:off x="548640" y="1645920"/>
-          <a:ext cx="11064240" cy="1828800"/>
+          <a:ext cx="11064240" cy="2042160"/>
         </p:xfrm>
         <a:graphic>
           <a:graphicData uri="http://schemas.openxmlformats.org/drawingml/2006/table">
@@ -4041,10 +4323,34 @@
                 <a:tableStyleId>{5C22544A-7EE6-4342-B048-85BDC9FD1C3A}</a:tableStyleId>
               </a:tblPr>
               <a:tblGrid>
-                <a:gridCol w="4846320"/>
-                <a:gridCol w="1463040"/>
-                <a:gridCol w="2194560"/>
-                <a:gridCol w="2560320"/>
+                <a:gridCol w="4846320">
+                  <a:extLst>
+                    <a:ext uri="{9D8B030D-6E8A-4147-A177-3AD203B41FA5}">
+                      <a16:colId xmlns:a16="http://schemas.microsoft.com/office/drawing/2014/main" val="20000"/>
+                    </a:ext>
+                  </a:extLst>
+                </a:gridCol>
+                <a:gridCol w="1463040">
+                  <a:extLst>
+                    <a:ext uri="{9D8B030D-6E8A-4147-A177-3AD203B41FA5}">
+                      <a16:colId xmlns:a16="http://schemas.microsoft.com/office/drawing/2014/main" val="20001"/>
+                    </a:ext>
+                  </a:extLst>
+                </a:gridCol>
+                <a:gridCol w="2194560">
+                  <a:extLst>
+                    <a:ext uri="{9D8B030D-6E8A-4147-A177-3AD203B41FA5}">
+                      <a16:colId xmlns:a16="http://schemas.microsoft.com/office/drawing/2014/main" val="20002"/>
+                    </a:ext>
+                  </a:extLst>
+                </a:gridCol>
+                <a:gridCol w="2560320">
+                  <a:extLst>
+                    <a:ext uri="{9D8B030D-6E8A-4147-A177-3AD203B41FA5}">
+                      <a16:colId xmlns:a16="http://schemas.microsoft.com/office/drawing/2014/main" val="20003"/>
+                    </a:ext>
+                  </a:extLst>
+                </a:gridCol>
               </a:tblGrid>
               <a:tr h="365760">
                 <a:tc>
@@ -4144,6 +4450,11 @@
                     </a:solidFill>
                   </a:tcPr>
                 </a:tc>
+                <a:extLst>
+                  <a:ext uri="{0D108BD9-81ED-4DB2-BD59-A6C34878D82A}">
+                    <a16:rowId xmlns:a16="http://schemas.microsoft.com/office/drawing/2014/main" val="10000"/>
+                  </a:ext>
+                </a:extLst>
               </a:tr>
               <a:tr h="365760">
                 <a:tc>
@@ -4238,6 +4549,11 @@
                     </a:solidFill>
                   </a:tcPr>
                 </a:tc>
+                <a:extLst>
+                  <a:ext uri="{0D108BD9-81ED-4DB2-BD59-A6C34878D82A}">
+                    <a16:rowId xmlns:a16="http://schemas.microsoft.com/office/drawing/2014/main" val="10001"/>
+                  </a:ext>
+                </a:extLst>
               </a:tr>
               <a:tr h="365760">
                 <a:tc>
@@ -4332,6 +4648,11 @@
                     </a:solidFill>
                   </a:tcPr>
                 </a:tc>
+                <a:extLst>
+                  <a:ext uri="{0D108BD9-81ED-4DB2-BD59-A6C34878D82A}">
+                    <a16:rowId xmlns:a16="http://schemas.microsoft.com/office/drawing/2014/main" val="10002"/>
+                  </a:ext>
+                </a:extLst>
               </a:tr>
               <a:tr h="365760">
                 <a:tc>
@@ -4426,6 +4747,11 @@
                     </a:solidFill>
                   </a:tcPr>
                 </a:tc>
+                <a:extLst>
+                  <a:ext uri="{0D108BD9-81ED-4DB2-BD59-A6C34878D82A}">
+                    <a16:rowId xmlns:a16="http://schemas.microsoft.com/office/drawing/2014/main" val="10003"/>
+                  </a:ext>
+                </a:extLst>
               </a:tr>
               <a:tr h="365760">
                 <a:tc>
@@ -4520,6 +4846,11 @@
                     </a:solidFill>
                   </a:tcPr>
                 </a:tc>
+                <a:extLst>
+                  <a:ext uri="{0D108BD9-81ED-4DB2-BD59-A6C34878D82A}">
+                    <a16:rowId xmlns:a16="http://schemas.microsoft.com/office/drawing/2014/main" val="10004"/>
+                  </a:ext>
+                </a:extLst>
               </a:tr>
             </a:tbl>
           </a:graphicData>
@@ -4616,8 +4947,8 @@
 </p:sld>
 </file>
 
-<file path=ppt/slides/slide12.xml><?xml version="1.0" encoding="utf-8"?>
-<p:sld xmlns:a="http://schemas.openxmlformats.org/drawingml/2006/main" xmlns:p="http://schemas.openxmlformats.org/presentationml/2006/main" xmlns:r="http://schemas.openxmlformats.org/officeDocument/2006/relationships">
+<file path=ppt/slides/slide13.xml><?xml version="1.0" encoding="utf-8"?>
+<p:sld xmlns:a="http://schemas.openxmlformats.org/drawingml/2006/main" xmlns:r="http://schemas.openxmlformats.org/officeDocument/2006/relationships" xmlns:p="http://schemas.openxmlformats.org/presentationml/2006/main">
   <p:cSld>
     <p:spTree>
       <p:nvGrpSpPr>
@@ -4625,7 +4956,14 @@
         <p:cNvGrpSpPr/>
         <p:nvPr/>
       </p:nvGrpSpPr>
-      <p:grpSpPr/>
+      <p:grpSpPr>
+        <a:xfrm>
+          <a:off x="0" y="0"/>
+          <a:ext cx="0" cy="0"/>
+          <a:chOff x="0" y="0"/>
+          <a:chExt cx="0" cy="0"/>
+        </a:xfrm>
+      </p:grpSpPr>
       <p:sp>
         <p:nvSpPr>
           <p:cNvPr id="2" name="TextBox 1"/>
@@ -4726,7 +5064,7 @@
               </a:defRPr>
             </a:pPr>
             <a:r>
-              <a:t>Oevererosietool · update 26-08-2026 · 12</a:t>
+              <a:t>Oevererosietool · update 26-08-2026 · 14</a:t>
             </a:r>
           </a:p>
         </p:txBody>
@@ -5099,8 +5437,8 @@
 </p:sld>
 </file>
 
-<file path=ppt/slides/slide13.xml><?xml version="1.0" encoding="utf-8"?>
-<p:sld xmlns:a="http://schemas.openxmlformats.org/drawingml/2006/main" xmlns:p="http://schemas.openxmlformats.org/presentationml/2006/main" xmlns:r="http://schemas.openxmlformats.org/officeDocument/2006/relationships">
+<file path=ppt/slides/slide14.xml><?xml version="1.0" encoding="utf-8"?>
+<p:sld xmlns:a="http://schemas.openxmlformats.org/drawingml/2006/main" xmlns:r="http://schemas.openxmlformats.org/officeDocument/2006/relationships" xmlns:p="http://schemas.openxmlformats.org/presentationml/2006/main">
   <p:cSld>
     <p:spTree>
       <p:nvGrpSpPr>
@@ -5108,7 +5446,14 @@
         <p:cNvGrpSpPr/>
         <p:nvPr/>
       </p:nvGrpSpPr>
-      <p:grpSpPr/>
+      <p:grpSpPr>
+        <a:xfrm>
+          <a:off x="0" y="0"/>
+          <a:ext cx="0" cy="0"/>
+          <a:chOff x="0" y="0"/>
+          <a:chExt cx="0" cy="0"/>
+        </a:xfrm>
+      </p:grpSpPr>
       <p:sp>
         <p:nvSpPr>
           <p:cNvPr id="2" name="TextBox 1"/>
@@ -5209,7 +5554,7 @@
               </a:defRPr>
             </a:pPr>
             <a:r>
-              <a:t>Oevererosietool · update 26-08-2026 · 13</a:t>
+              <a:t>Oevererosietool · update 26-08-2026 · 15</a:t>
             </a:r>
           </a:p>
         </p:txBody>
@@ -5344,7 +5689,245 @@
 </p:sld>
 </file>
 
-<file path=ppt/slides/slide14.xml><?xml version="1.0" encoding="utf-8"?>
+<file path=ppt/slides/slide15.xml><?xml version="1.0" encoding="utf-8"?>
+<p:sld xmlns:a="http://schemas.openxmlformats.org/drawingml/2006/main" xmlns:r="http://schemas.openxmlformats.org/officeDocument/2006/relationships" xmlns:p="http://schemas.openxmlformats.org/presentationml/2006/main">
+  <p:cSld>
+    <p:spTree>
+      <p:nvGrpSpPr>
+        <p:cNvPr id="1" name=""/>
+        <p:cNvGrpSpPr/>
+        <p:nvPr/>
+      </p:nvGrpSpPr>
+      <p:grpSpPr>
+        <a:xfrm>
+          <a:off x="0" y="0"/>
+          <a:ext cx="0" cy="0"/>
+          <a:chOff x="0" y="0"/>
+          <a:chExt cx="0" cy="0"/>
+        </a:xfrm>
+      </p:grpSpPr>
+      <p:sp>
+        <p:nvSpPr>
+          <p:cNvPr id="2" name="TextBox 1"/>
+          <p:cNvSpPr txBox="1"/>
+          <p:nvPr/>
+        </p:nvSpPr>
+        <p:spPr>
+          <a:xfrm>
+            <a:off x="548640" y="320040"/>
+            <a:ext cx="10972800" cy="731520"/>
+          </a:xfrm>
+          <a:prstGeom prst="rect">
+            <a:avLst/>
+          </a:prstGeom>
+          <a:noFill/>
+        </p:spPr>
+        <p:txBody>
+          <a:bodyPr wrap="none">
+            <a:spAutoFit/>
+          </a:bodyPr>
+          <a:lstStyle/>
+          <a:p>
+            <a:pPr>
+              <a:defRPr sz="3000" b="1">
+                <a:solidFill>
+                  <a:srgbClr val="2BB5A6"/>
+                </a:solidFill>
+              </a:defRPr>
+            </a:pPr>
+            <a:r>
+              <a:t>Samenvattend</a:t>
+            </a:r>
+          </a:p>
+        </p:txBody>
+      </p:sp>
+      <p:sp>
+        <p:nvSpPr>
+          <p:cNvPr id="3" name="TextBox 2"/>
+          <p:cNvSpPr txBox="1"/>
+          <p:nvPr/>
+        </p:nvSpPr>
+        <p:spPr>
+          <a:xfrm>
+            <a:off x="548640" y="6400800"/>
+            <a:ext cx="10972800" cy="274320"/>
+          </a:xfrm>
+          <a:prstGeom prst="rect">
+            <a:avLst/>
+          </a:prstGeom>
+          <a:noFill/>
+        </p:spPr>
+        <p:txBody>
+          <a:bodyPr wrap="none">
+            <a:spAutoFit/>
+          </a:bodyPr>
+          <a:lstStyle/>
+          <a:p>
+            <a:pPr>
+              <a:defRPr sz="1000">
+                <a:solidFill>
+                  <a:srgbClr val="6B7778"/>
+                </a:solidFill>
+              </a:defRPr>
+            </a:pPr>
+            <a:r>
+              <a:t>Oevererosietool · update 26-08-2026 · 16</a:t>
+            </a:r>
+          </a:p>
+        </p:txBody>
+      </p:sp>
+      <p:sp>
+        <p:nvSpPr>
+          <p:cNvPr id="4" name="TextBox 3"/>
+          <p:cNvSpPr txBox="1"/>
+          <p:nvPr/>
+        </p:nvSpPr>
+        <p:spPr>
+          <a:xfrm>
+            <a:off x="548640" y="1463040"/>
+            <a:ext cx="10972800" cy="4754880"/>
+          </a:xfrm>
+          <a:prstGeom prst="rect">
+            <a:avLst/>
+          </a:prstGeom>
+          <a:noFill/>
+        </p:spPr>
+        <p:txBody>
+          <a:bodyPr wrap="square">
+            <a:spAutoFit/>
+          </a:bodyPr>
+          <a:lstStyle/>
+          <a:p>
+            <a:pPr>
+              <a:spcAft>
+                <a:spcPts val="800"/>
+              </a:spcAft>
+              <a:defRPr sz="1800" b="1">
+                <a:solidFill>
+                  <a:srgbClr val="1F3A3D"/>
+                </a:solidFill>
+              </a:defRPr>
+            </a:pPr>
+            <a:r>
+              <a:t>Model: klaar en eerlijk gevalideerd</a:t>
+            </a:r>
+          </a:p>
+          <a:p>
+            <a:pPr>
+              <a:spcAft>
+                <a:spcPts val="800"/>
+              </a:spcAft>
+              <a:defRPr sz="1800" b="0">
+                <a:solidFill>
+                  <a:srgbClr val="1F3A3D"/>
+                </a:solidFill>
+              </a:defRPr>
+            </a:pPr>
+            <a:r>
+              <a:t>• Hybride bron, opschoonregels, historie-features, testset buiten de training</a:t>
+            </a:r>
+          </a:p>
+          <a:p>
+            <a:pPr>
+              <a:spcAft>
+                <a:spcPts val="800"/>
+              </a:spcAft>
+              <a:defRPr sz="1800" b="1">
+                <a:solidFill>
+                  <a:srgbClr val="1F3A3D"/>
+                </a:solidFill>
+              </a:defRPr>
+            </a:pPr>
+            <a:r>
+              <a:t>Van lijn naar oever</a:t>
+            </a:r>
+          </a:p>
+          <a:p>
+            <a:pPr>
+              <a:spcAft>
+                <a:spcPts val="800"/>
+              </a:spcAft>
+              <a:defRPr sz="1800" b="0">
+                <a:solidFill>
+                  <a:srgbClr val="1F3A3D"/>
+                </a:solidFill>
+              </a:defRPr>
+            </a:pPr>
+            <a:r>
+              <a:t>• Vijf segmenten per vlak; gemeten én voorspelde oever als lijn; positiefout ≈ 1 m</a:t>
+            </a:r>
+          </a:p>
+          <a:p>
+            <a:pPr>
+              <a:spcAft>
+                <a:spcPts val="800"/>
+              </a:spcAft>
+              <a:defRPr sz="1800" b="1">
+                <a:solidFill>
+                  <a:srgbClr val="1F3A3D"/>
+                </a:solidFill>
+              </a:defRPr>
+            </a:pPr>
+            <a:r>
+              <a:t>Bottleneck: gelabelde input, niet het algoritme</a:t>
+            </a:r>
+          </a:p>
+          <a:p>
+            <a:pPr>
+              <a:spcAft>
+                <a:spcPts val="800"/>
+              </a:spcAft>
+              <a:defRPr sz="1800" b="0">
+                <a:solidFill>
+                  <a:srgbClr val="1F3A3D"/>
+                </a:solidFill>
+              </a:defRPr>
+            </a:pPr>
+            <a:r>
+              <a:t>• Opschonen leverde 12× zoveel als modelleren; de regels raken op — wat overblijft vraagt een oordeel</a:t>
+            </a:r>
+          </a:p>
+          <a:p>
+            <a:pPr>
+              <a:spcAft>
+                <a:spcPts val="800"/>
+              </a:spcAft>
+              <a:defRPr sz="1800" b="1">
+                <a:solidFill>
+                  <a:srgbClr val="1F3A3D"/>
+                </a:solidFill>
+              </a:defRPr>
+            </a:pPr>
+            <a:r>
+              <a:t>Volgende stap</a:t>
+            </a:r>
+          </a:p>
+          <a:p>
+            <a:pPr>
+              <a:spcAft>
+                <a:spcPts val="800"/>
+              </a:spcAft>
+              <a:defRPr sz="1800" b="0">
+                <a:solidFill>
+                  <a:srgbClr val="1F3A3D"/>
+                </a:solidFill>
+              </a:defRPr>
+            </a:pPr>
+            <a:r>
+              <a:t>• Labelronde met SAM- en hoogtemodel-engineers · VVR-alarm op segmentniveau · daarna opnieuw meten</a:t>
+            </a:r>
+          </a:p>
+        </p:txBody>
+      </p:sp>
+    </p:spTree>
+  </p:cSld>
+  <p:clrMapOvr>
+    <a:masterClrMapping/>
+  </p:clrMapOvr>
+</p:sld>
+</file>
+
+<file path=ppt/slides/slide16.xml><?xml version="1.0" encoding="utf-8"?>
 <p:sld xmlns:a="http://schemas.openxmlformats.org/drawingml/2006/main" xmlns:p="http://schemas.openxmlformats.org/presentationml/2006/main" xmlns:r="http://schemas.openxmlformats.org/officeDocument/2006/relationships">
   <p:cSld>
     <p:spTree>
@@ -5371,20 +5954,20 @@
           <a:noFill/>
         </p:spPr>
         <p:txBody>
-          <a:bodyPr wrap="none">
+          <a:bodyPr wrap="square">
             <a:spAutoFit/>
           </a:bodyPr>
           <a:lstStyle/>
           <a:p>
             <a:pPr>
-              <a:defRPr sz="3000" b="1">
+              <a:defRPr sz="3000" b="1" i="0">
                 <a:solidFill>
                   <a:srgbClr val="2BB5A6"/>
                 </a:solidFill>
               </a:defRPr>
             </a:pPr>
             <a:r>
-              <a:t>Samenvattend</a:t>
+              <a:t>As 1 · Wat we in de SAM-lijnen tegenkomen</a:t>
             </a:r>
           </a:p>
         </p:txBody>
@@ -5397,43 +5980,8 @@
         </p:nvSpPr>
         <p:spPr>
           <a:xfrm>
-            <a:off x="548640" y="6400800"/>
-            <a:ext cx="10972800" cy="274320"/>
-          </a:xfrm>
-          <a:prstGeom prst="rect">
-            <a:avLst/>
-          </a:prstGeom>
-          <a:noFill/>
-        </p:spPr>
-        <p:txBody>
-          <a:bodyPr wrap="none">
-            <a:spAutoFit/>
-          </a:bodyPr>
-          <a:lstStyle/>
-          <a:p>
-            <a:pPr>
-              <a:defRPr sz="1000">
-                <a:solidFill>
-                  <a:srgbClr val="6B7778"/>
-                </a:solidFill>
-              </a:defRPr>
-            </a:pPr>
-            <a:r>
-              <a:t>Oevererosietool · update 26-08-2026 · 14</a:t>
-            </a:r>
-          </a:p>
-        </p:txBody>
-      </p:sp>
-      <p:sp>
-        <p:nvSpPr>
-          <p:cNvPr id="4" name="TextBox 3"/>
-          <p:cNvSpPr txBox="1"/>
-          <p:nvPr/>
-        </p:nvSpPr>
-        <p:spPr>
-          <a:xfrm>
-            <a:off x="548640" y="1463040"/>
-            <a:ext cx="10972800" cy="4754880"/>
+            <a:off x="548640" y="960120"/>
+            <a:ext cx="10972800" cy="548640"/>
           </a:xfrm>
           <a:prstGeom prst="rect">
             <a:avLst/>
@@ -5447,252 +5995,21 @@
           <a:lstStyle/>
           <a:p>
             <a:pPr>
-              <a:spcAft>
-                <a:spcPts val="800"/>
-              </a:spcAft>
-              <a:defRPr sz="1800" b="1">
+              <a:defRPr sz="1700" b="0" i="0">
                 <a:solidFill>
                   <a:srgbClr val="1F3A3D"/>
                 </a:solidFill>
               </a:defRPr>
             </a:pPr>
             <a:r>
-              <a:t>Model: klaar en eerlijk gevalideerd</a:t>
-            </a:r>
-          </a:p>
-          <a:p>
-            <a:pPr>
-              <a:spcAft>
-                <a:spcPts val="800"/>
-              </a:spcAft>
-              <a:defRPr sz="1800" b="0">
-                <a:solidFill>
-                  <a:srgbClr val="1F3A3D"/>
-                </a:solidFill>
-              </a:defRPr>
-            </a:pPr>
-            <a:r>
-              <a:t>• Hybride bron, opschoonregels, historie-features, testset buiten de training</a:t>
-            </a:r>
-          </a:p>
-          <a:p>
-            <a:pPr>
-              <a:spcAft>
-                <a:spcPts val="800"/>
-              </a:spcAft>
-              <a:defRPr sz="1800" b="1">
-                <a:solidFill>
-                  <a:srgbClr val="1F3A3D"/>
-                </a:solidFill>
-              </a:defRPr>
-            </a:pPr>
-            <a:r>
-              <a:t>Van lijn naar oever</a:t>
-            </a:r>
-          </a:p>
-          <a:p>
-            <a:pPr>
-              <a:spcAft>
-                <a:spcPts val="800"/>
-              </a:spcAft>
-              <a:defRPr sz="1800" b="0">
-                <a:solidFill>
-                  <a:srgbClr val="1F3A3D"/>
-                </a:solidFill>
-              </a:defRPr>
-            </a:pPr>
-            <a:r>
-              <a:t>• Vijf segmenten per vlak; gemeten én voorspelde oever als lijn; positiefout ≈ 1 m</a:t>
-            </a:r>
-          </a:p>
-          <a:p>
-            <a:pPr>
-              <a:spcAft>
-                <a:spcPts val="800"/>
-              </a:spcAft>
-              <a:defRPr sz="1800" b="1">
-                <a:solidFill>
-                  <a:srgbClr val="1F3A3D"/>
-                </a:solidFill>
-              </a:defRPr>
-            </a:pPr>
-            <a:r>
-              <a:t>Bottleneck: gelabelde input, niet het algoritme</a:t>
-            </a:r>
-          </a:p>
-          <a:p>
-            <a:pPr>
-              <a:spcAft>
-                <a:spcPts val="800"/>
-              </a:spcAft>
-              <a:defRPr sz="1800" b="0">
-                <a:solidFill>
-                  <a:srgbClr val="1F3A3D"/>
-                </a:solidFill>
-              </a:defRPr>
-            </a:pPr>
-            <a:r>
-              <a:t>• Opschonen leverde 12× zoveel als modelleren; de regels raken op — wat overblijft vraagt een oordeel</a:t>
-            </a:r>
-          </a:p>
-          <a:p>
-            <a:pPr>
-              <a:spcAft>
-                <a:spcPts val="800"/>
-              </a:spcAft>
-              <a:defRPr sz="1800" b="1">
-                <a:solidFill>
-                  <a:srgbClr val="1F3A3D"/>
-                </a:solidFill>
-              </a:defRPr>
-            </a:pPr>
-            <a:r>
-              <a:t>Volgende stap</a:t>
-            </a:r>
-          </a:p>
-          <a:p>
-            <a:pPr>
-              <a:spcAft>
-                <a:spcPts val="800"/>
-              </a:spcAft>
-              <a:defRPr sz="1800" b="0">
-                <a:solidFill>
-                  <a:srgbClr val="1F3A3D"/>
-                </a:solidFill>
-              </a:defRPr>
-            </a:pPr>
-            <a:r>
-              <a:t>• Labelronde met SAM- en hoogtemodel-engineers · VVR-alarm op segmentniveau · daarna opnieuw meten</a:t>
-            </a:r>
-          </a:p>
-        </p:txBody>
-      </p:sp>
-    </p:spTree>
-  </p:cSld>
-  <p:clrMapOvr>
-    <a:masterClrMapping/>
-  </p:clrMapOvr>
-</p:sld>
-</file>
-
-<file path=ppt/slides/slide2.xml><?xml version="1.0" encoding="utf-8"?>
-<p:sld xmlns:a="http://schemas.openxmlformats.org/drawingml/2006/main" xmlns:p="http://schemas.openxmlformats.org/presentationml/2006/main" xmlns:r="http://schemas.openxmlformats.org/officeDocument/2006/relationships">
-  <p:cSld>
-    <p:spTree>
-      <p:nvGrpSpPr>
-        <p:cNvPr id="1" name=""/>
-        <p:cNvGrpSpPr/>
-        <p:nvPr/>
-      </p:nvGrpSpPr>
-      <p:grpSpPr/>
-      <p:sp>
-        <p:nvSpPr>
-          <p:cNvPr id="2" name="TextBox 1"/>
-          <p:cNvSpPr txBox="1"/>
-          <p:nvPr/>
-        </p:nvSpPr>
-        <p:spPr>
-          <a:xfrm>
-            <a:off x="548640" y="320040"/>
-            <a:ext cx="10972800" cy="731520"/>
-          </a:xfrm>
-          <a:prstGeom prst="rect">
-            <a:avLst/>
-          </a:prstGeom>
-          <a:noFill/>
-        </p:spPr>
-        <p:txBody>
-          <a:bodyPr wrap="none">
-            <a:spAutoFit/>
-          </a:bodyPr>
-          <a:lstStyle/>
-          <a:p>
-            <a:pPr>
-              <a:defRPr sz="3000" b="1">
-                <a:solidFill>
-                  <a:srgbClr val="2BB5A6"/>
-                </a:solidFill>
-              </a:defRPr>
-            </a:pPr>
-            <a:r>
-              <a:t>Waar we in maart stonden</a:t>
-            </a:r>
-          </a:p>
-        </p:txBody>
-      </p:sp>
-      <p:sp>
-        <p:nvSpPr>
-          <p:cNvPr id="3" name="TextBox 2"/>
-          <p:cNvSpPr txBox="1"/>
-          <p:nvPr/>
-        </p:nvSpPr>
-        <p:spPr>
-          <a:xfrm>
-            <a:off x="548640" y="960120"/>
-            <a:ext cx="10972800" cy="548640"/>
-          </a:xfrm>
-          <a:prstGeom prst="rect">
-            <a:avLst/>
-          </a:prstGeom>
-          <a:noFill/>
-        </p:spPr>
-        <p:txBody>
-          <a:bodyPr wrap="none">
-            <a:spAutoFit/>
-          </a:bodyPr>
-          <a:lstStyle/>
-          <a:p>
-            <a:pPr>
-              <a:defRPr sz="1700">
-                <a:solidFill>
-                  <a:srgbClr val="1F3A3D"/>
-                </a:solidFill>
-              </a:defRPr>
-            </a:pPr>
-            <a:r>
-              <a:t>Eén afstand per scopevlak — en een oever is geen rechte lijn</a:t>
-            </a:r>
-          </a:p>
-        </p:txBody>
-      </p:sp>
-      <p:sp>
-        <p:nvSpPr>
-          <p:cNvPr id="4" name="TextBox 3"/>
-          <p:cNvSpPr txBox="1"/>
-          <p:nvPr/>
-        </p:nvSpPr>
-        <p:spPr>
-          <a:xfrm>
-            <a:off x="548640" y="6400800"/>
-            <a:ext cx="10972800" cy="274320"/>
-          </a:xfrm>
-          <a:prstGeom prst="rect">
-            <a:avLst/>
-          </a:prstGeom>
-          <a:noFill/>
-        </p:spPr>
-        <p:txBody>
-          <a:bodyPr wrap="none">
-            <a:spAutoFit/>
-          </a:bodyPr>
-          <a:lstStyle/>
-          <a:p>
-            <a:pPr>
-              <a:defRPr sz="1000">
-                <a:solidFill>
-                  <a:srgbClr val="6B7778"/>
-                </a:solidFill>
-              </a:defRPr>
-            </a:pPr>
-            <a:r>
-              <a:t>Oevererosietool · update 26-08-2026 · 2</a:t>
+              <a:t>Vijf terugkerende patronen — elk een 'oever' die geen oever is</a:t>
             </a:r>
           </a:p>
         </p:txBody>
       </p:sp>
       <p:pic>
         <p:nvPicPr>
-          <p:cNvPr id="5" name="Picture 4" descr="maas3_l_17410_17420.png"/>
+          <p:cNvPr id="4" name="Picture 3" descr="image.png"/>
           <p:cNvPicPr>
             <a:picLocks noChangeAspect="1"/>
           </p:cNvPicPr>
@@ -5706,17 +6023,217 @@
         </p:blipFill>
         <p:spPr>
           <a:xfrm>
-            <a:off x="457200" y="1463040"/>
-            <a:ext cx="4511761" cy="4206240"/>
+            <a:off x="274320" y="1554480"/>
+            <a:ext cx="11612880" cy="6530761"/>
           </a:xfrm>
           <a:prstGeom prst="rect">
             <a:avLst/>
           </a:prstGeom>
         </p:spPr>
       </p:pic>
+      <p:sp>
+        <p:nvSpPr>
+          <p:cNvPr id="5" name="TextBox 4"/>
+          <p:cNvSpPr txBox="1"/>
+          <p:nvPr/>
+        </p:nvSpPr>
+        <p:spPr>
+          <a:xfrm>
+            <a:off x="548640" y="5486400"/>
+            <a:ext cx="10972800" cy="822960"/>
+          </a:xfrm>
+          <a:prstGeom prst="rect">
+            <a:avLst/>
+          </a:prstGeom>
+          <a:noFill/>
+        </p:spPr>
+        <p:txBody>
+          <a:bodyPr wrap="square">
+            <a:spAutoFit/>
+          </a:bodyPr>
+          <a:lstStyle/>
+          <a:p>
+            <a:pPr>
+              <a:defRPr sz="1300" b="0" i="0">
+                <a:solidFill>
+                  <a:srgbClr val="1F3A3D"/>
+                </a:solidFill>
+              </a:defRPr>
+            </a:pPr>
+            <a:r>
+              <a:t>Daarnaast: nevengeulen en plassen (5,9 % van de metingen in 'normale' vlakken), fragmenten (&lt; 25 % van het vlak) en metingen die 15 m van de trend afwijken. Elk patroon = één opschoonregel; elke regel = een gok naar iets wat een mens zeker weet.</a:t>
+            </a:r>
+          </a:p>
+        </p:txBody>
+      </p:sp>
+      <p:sp>
+        <p:nvSpPr>
+          <p:cNvPr id="6" name="TextBox 5"/>
+          <p:cNvSpPr txBox="1"/>
+          <p:nvPr/>
+        </p:nvSpPr>
+        <p:spPr>
+          <a:xfrm>
+            <a:off x="548640" y="6400800"/>
+            <a:ext cx="10972800" cy="274320"/>
+          </a:xfrm>
+          <a:prstGeom prst="rect">
+            <a:avLst/>
+          </a:prstGeom>
+          <a:noFill/>
+        </p:spPr>
+        <p:txBody>
+          <a:bodyPr wrap="square">
+            <a:spAutoFit/>
+          </a:bodyPr>
+          <a:lstStyle/>
+          <a:p>
+            <a:pPr>
+              <a:defRPr sz="1000" b="0" i="0">
+                <a:solidFill>
+                  <a:srgbClr val="6B7778"/>
+                </a:solidFill>
+              </a:defRPr>
+            </a:pPr>
+            <a:r>
+              <a:t>Oevererosietool · update 26-08-2026 · 6</a:t>
+            </a:r>
+          </a:p>
+        </p:txBody>
+      </p:sp>
+    </p:spTree>
+  </p:cSld>
+  <p:clrMapOvr>
+    <a:masterClrMapping/>
+  </p:clrMapOvr>
+</p:sld>
+</file>
+
+<file path=ppt/slides/slide2.xml><?xml version="1.0" encoding="utf-8"?>
+<p:sld xmlns:a="http://schemas.openxmlformats.org/drawingml/2006/main" xmlns:r="http://schemas.openxmlformats.org/officeDocument/2006/relationships" xmlns:p="http://schemas.openxmlformats.org/presentationml/2006/main">
+  <p:cSld>
+    <p:spTree>
+      <p:nvGrpSpPr>
+        <p:cNvPr id="1" name=""/>
+        <p:cNvGrpSpPr/>
+        <p:nvPr/>
+      </p:nvGrpSpPr>
+      <p:grpSpPr>
+        <a:xfrm>
+          <a:off x="0" y="0"/>
+          <a:ext cx="0" cy="0"/>
+          <a:chOff x="0" y="0"/>
+          <a:chExt cx="0" cy="0"/>
+        </a:xfrm>
+      </p:grpSpPr>
+      <p:sp>
+        <p:nvSpPr>
+          <p:cNvPr id="2" name="TextBox 1"/>
+          <p:cNvSpPr txBox="1"/>
+          <p:nvPr/>
+        </p:nvSpPr>
+        <p:spPr>
+          <a:xfrm>
+            <a:off x="548640" y="320040"/>
+            <a:ext cx="10972800" cy="731520"/>
+          </a:xfrm>
+          <a:prstGeom prst="rect">
+            <a:avLst/>
+          </a:prstGeom>
+          <a:noFill/>
+        </p:spPr>
+        <p:txBody>
+          <a:bodyPr wrap="none">
+            <a:spAutoFit/>
+          </a:bodyPr>
+          <a:lstStyle/>
+          <a:p>
+            <a:pPr>
+              <a:defRPr sz="3000" b="1">
+                <a:solidFill>
+                  <a:srgbClr val="2BB5A6"/>
+                </a:solidFill>
+              </a:defRPr>
+            </a:pPr>
+            <a:r>
+              <a:t>Waar we in maart stonden</a:t>
+            </a:r>
+          </a:p>
+        </p:txBody>
+      </p:sp>
+      <p:sp>
+        <p:nvSpPr>
+          <p:cNvPr id="3" name="TextBox 2"/>
+          <p:cNvSpPr txBox="1"/>
+          <p:nvPr/>
+        </p:nvSpPr>
+        <p:spPr>
+          <a:xfrm>
+            <a:off x="548640" y="960120"/>
+            <a:ext cx="10972800" cy="548640"/>
+          </a:xfrm>
+          <a:prstGeom prst="rect">
+            <a:avLst/>
+          </a:prstGeom>
+          <a:noFill/>
+        </p:spPr>
+        <p:txBody>
+          <a:bodyPr wrap="none">
+            <a:spAutoFit/>
+          </a:bodyPr>
+          <a:lstStyle/>
+          <a:p>
+            <a:pPr>
+              <a:defRPr sz="1700">
+                <a:solidFill>
+                  <a:srgbClr val="1F3A3D"/>
+                </a:solidFill>
+              </a:defRPr>
+            </a:pPr>
+            <a:r>
+              <a:t>Eén afstand per scopevlak — en een oever is geen rechte lijn</a:t>
+            </a:r>
+          </a:p>
+        </p:txBody>
+      </p:sp>
+      <p:sp>
+        <p:nvSpPr>
+          <p:cNvPr id="4" name="TextBox 3"/>
+          <p:cNvSpPr txBox="1"/>
+          <p:nvPr/>
+        </p:nvSpPr>
+        <p:spPr>
+          <a:xfrm>
+            <a:off x="548640" y="6400800"/>
+            <a:ext cx="10972800" cy="274320"/>
+          </a:xfrm>
+          <a:prstGeom prst="rect">
+            <a:avLst/>
+          </a:prstGeom>
+          <a:noFill/>
+        </p:spPr>
+        <p:txBody>
+          <a:bodyPr wrap="none">
+            <a:spAutoFit/>
+          </a:bodyPr>
+          <a:lstStyle/>
+          <a:p>
+            <a:pPr>
+              <a:defRPr sz="1000">
+                <a:solidFill>
+                  <a:srgbClr val="6B7778"/>
+                </a:solidFill>
+              </a:defRPr>
+            </a:pPr>
+            <a:r>
+              <a:t>Oevererosietool · update 26-08-2026 · 2</a:t>
+            </a:r>
+          </a:p>
+        </p:txBody>
+      </p:sp>
       <p:pic>
         <p:nvPicPr>
-          <p:cNvPr id="6" name="Picture 5" descr="nederrijn_r_4470_4480.png"/>
+          <p:cNvPr id="5" name="Picture 4" descr="maas3_l_17410_17420.png"/>
           <p:cNvPicPr>
             <a:picLocks noChangeAspect="1"/>
           </p:cNvPicPr>
@@ -5730,7 +6247,31 @@
         </p:blipFill>
         <p:spPr>
           <a:xfrm>
-            <a:off x="4572000" y="1463040"/>
+            <a:off x="457200" y="1463040"/>
+            <a:ext cx="4511761" cy="4206240"/>
+          </a:xfrm>
+          <a:prstGeom prst="rect">
+            <a:avLst/>
+          </a:prstGeom>
+        </p:spPr>
+      </p:pic>
+      <p:pic>
+        <p:nvPicPr>
+          <p:cNvPr id="6" name="Picture 5" descr="nederrijn_r_4470_4480.png"/>
+          <p:cNvPicPr>
+            <a:picLocks noChangeAspect="1"/>
+          </p:cNvPicPr>
+          <p:nvPr/>
+        </p:nvPicPr>
+        <p:blipFill>
+          <a:blip r:embed="rId4"/>
+          <a:stretch>
+            <a:fillRect/>
+          </a:stretch>
+        </p:blipFill>
+        <p:spPr>
+          <a:xfrm>
+            <a:off x="6096000" y="1458030"/>
             <a:ext cx="4527056" cy="4206240"/>
           </a:xfrm>
           <a:prstGeom prst="rect">
@@ -5781,7 +6322,7 @@
         </p:nvSpPr>
         <p:spPr>
           <a:xfrm>
-            <a:off x="4572000" y="5669280"/>
+            <a:off x="6096000" y="5664270"/>
             <a:ext cx="4023360" cy="548640"/>
           </a:xfrm>
           <a:prstGeom prst="rect">
@@ -5803,105 +6344,80 @@
               </a:defRPr>
             </a:pPr>
             <a:r>
-              <a:t>SAM (nu): de oever kronkelt om een kribvak — één getal zegt hier nog minder</a:t>
-            </a:r>
-          </a:p>
-        </p:txBody>
-      </p:sp>
-      <p:sp>
-        <p:nvSpPr>
-          <p:cNvPr id="9" name="TextBox 8"/>
-          <p:cNvSpPr txBox="1"/>
-          <p:nvPr/>
-        </p:nvSpPr>
-        <p:spPr>
-          <a:xfrm>
-            <a:off x="8778240" y="1554480"/>
-            <a:ext cx="3200400" cy="4572000"/>
-          </a:xfrm>
-          <a:prstGeom prst="rect">
-            <a:avLst/>
-          </a:prstGeom>
-          <a:noFill/>
-        </p:spPr>
-        <p:txBody>
-          <a:bodyPr wrap="square">
-            <a:spAutoFit/>
-          </a:bodyPr>
-          <a:lstStyle/>
-          <a:p>
-            <a:pPr>
-              <a:spcAft>
-                <a:spcPts val="500"/>
-              </a:spcAft>
-              <a:defRPr sz="1300" b="0">
-                <a:solidFill>
-                  <a:srgbClr val="1F3A3D"/>
-                </a:solidFill>
-              </a:defRPr>
-            </a:pPr>
-            <a:r>
-              <a:t>• Maart: alleen hoogtemodel, 3–4 jaar tussen opnames</a:t>
-            </a:r>
-          </a:p>
-          <a:p>
-            <a:pPr>
-              <a:spcAft>
-                <a:spcPts val="500"/>
-              </a:spcAft>
-              <a:defRPr sz="1300" b="0">
-                <a:solidFill>
-                  <a:srgbClr val="1F3A3D"/>
-                </a:solidFill>
-              </a:defRPr>
-            </a:pPr>
-            <a:r>
-              <a:t>• Per vlak één afstand tot de hartlijn per opname (gestippeld)</a:t>
-            </a:r>
-          </a:p>
-          <a:p>
-            <a:pPr>
-              <a:spcAft>
-                <a:spcPts val="500"/>
-              </a:spcAft>
-              <a:defRPr sz="1300" b="0">
-                <a:solidFill>
-                  <a:srgbClr val="1F3A3D"/>
-                </a:solidFill>
-              </a:defRPr>
-            </a:pPr>
-            <a:r>
-              <a:t>• Fout 0,94 m/jr — maar 'neem het gemiddelde' deed het beter (0,78)</a:t>
-            </a:r>
-          </a:p>
-          <a:p>
-            <a:pPr>
-              <a:spcAft>
-                <a:spcPts val="500"/>
-              </a:spcAft>
-              <a:defRPr sz="1300" b="0">
-                <a:solidFill>
-                  <a:srgbClr val="1F3A3D"/>
-                </a:solidFill>
-              </a:defRPr>
-            </a:pPr>
-            <a:r>
-              <a:t>• Risicogevallen: 4,6 m/jr · 7.444 vlakken</a:t>
-            </a:r>
-          </a:p>
-          <a:p>
-            <a:pPr>
-              <a:spcAft>
-                <a:spcPts val="500"/>
-              </a:spcAft>
-              <a:defRPr sz="1300" b="0">
-                <a:solidFill>
-                  <a:srgbClr val="1F3A3D"/>
-                </a:solidFill>
-              </a:defRPr>
-            </a:pPr>
-            <a:r>
-              <a:t>• Met de SAM-lijnen wordt de oever écht een lijn — en het ene getal past nog slechter</a:t>
+              <a:rPr dirty="0"/>
+              <a:t>SAM (nu): de </a:t>
+            </a:r>
+            <a:r>
+              <a:rPr dirty="0" err="1"/>
+              <a:t>oever</a:t>
+            </a:r>
+            <a:r>
+              <a:rPr dirty="0"/>
+              <a:t> </a:t>
+            </a:r>
+            <a:r>
+              <a:rPr dirty="0" err="1"/>
+              <a:t>kronkelt</a:t>
+            </a:r>
+            <a:r>
+              <a:rPr dirty="0"/>
+              <a:t> om </a:t>
+            </a:r>
+            <a:r>
+              <a:rPr dirty="0" err="1"/>
+              <a:t>een</a:t>
+            </a:r>
+            <a:r>
+              <a:rPr dirty="0"/>
+              <a:t> </a:t>
+            </a:r>
+            <a:r>
+              <a:rPr dirty="0" err="1"/>
+              <a:t>kribvak</a:t>
+            </a:r>
+            <a:r>
+              <a:rPr dirty="0"/>
+              <a:t> — </a:t>
+            </a:r>
+            <a:r>
+              <a:rPr dirty="0" err="1"/>
+              <a:t>één</a:t>
+            </a:r>
+            <a:r>
+              <a:rPr dirty="0"/>
+              <a:t> </a:t>
+            </a:r>
+            <a:r>
+              <a:rPr dirty="0" err="1"/>
+              <a:t>getal</a:t>
+            </a:r>
+            <a:r>
+              <a:rPr dirty="0"/>
+              <a:t> </a:t>
+            </a:r>
+            <a:r>
+              <a:rPr dirty="0" err="1"/>
+              <a:t>zegt</a:t>
+            </a:r>
+            <a:r>
+              <a:rPr dirty="0"/>
+              <a:t> </a:t>
+            </a:r>
+            <a:r>
+              <a:rPr dirty="0" err="1"/>
+              <a:t>hier</a:t>
+            </a:r>
+            <a:r>
+              <a:rPr dirty="0"/>
+              <a:t> </a:t>
+            </a:r>
+            <a:r>
+              <a:rPr dirty="0" err="1"/>
+              <a:t>nog</a:t>
+            </a:r>
+            <a:r>
+              <a:rPr dirty="0"/>
+              <a:t> minder</a:t>
             </a:r>
           </a:p>
         </p:txBody>
@@ -5915,7 +6431,7 @@
 </file>
 
 <file path=ppt/slides/slide3.xml><?xml version="1.0" encoding="utf-8"?>
-<p:sld xmlns:a="http://schemas.openxmlformats.org/drawingml/2006/main" xmlns:p="http://schemas.openxmlformats.org/presentationml/2006/main" xmlns:r="http://schemas.openxmlformats.org/officeDocument/2006/relationships">
+<p:sld xmlns:a="http://schemas.openxmlformats.org/drawingml/2006/main" xmlns:r="http://schemas.openxmlformats.org/officeDocument/2006/relationships" xmlns:p="http://schemas.openxmlformats.org/presentationml/2006/main">
   <p:cSld>
     <p:spTree>
       <p:nvGrpSpPr>
@@ -5923,7 +6439,14 @@
         <p:cNvGrpSpPr/>
         <p:nvPr/>
       </p:nvGrpSpPr>
-      <p:grpSpPr/>
+      <p:grpSpPr>
+        <a:xfrm>
+          <a:off x="0" y="0"/>
+          <a:ext cx="0" cy="0"/>
+          <a:chOff x="0" y="0"/>
+          <a:chExt cx="0" cy="0"/>
+        </a:xfrm>
+      </p:grpSpPr>
       <p:sp>
         <p:nvSpPr>
           <p:cNvPr id="2" name="TextBox 1"/>
@@ -6045,580 +6568,14 @@
         </p:blipFill>
         <p:spPr>
           <a:xfrm>
-            <a:off x="548640" y="1463040"/>
-            <a:ext cx="6675120" cy="3753902"/>
+            <a:off x="1012102" y="1426122"/>
+            <a:ext cx="8845881" cy="4974678"/>
           </a:xfrm>
           <a:prstGeom prst="rect">
             <a:avLst/>
           </a:prstGeom>
         </p:spPr>
       </p:pic>
-      <p:graphicFrame>
-        <p:nvGraphicFramePr>
-          <p:cNvPr id="6" name="Table 5"/>
-          <p:cNvGraphicFramePr>
-            <a:graphicFrameLocks noGrp="1"/>
-          </p:cNvGraphicFramePr>
-          <p:nvPr/>
-        </p:nvGraphicFramePr>
-        <p:xfrm>
-          <a:off x="7406640" y="1554480"/>
-          <a:ext cx="4480560" cy="2560320"/>
-        </p:xfrm>
-        <a:graphic>
-          <a:graphicData uri="http://schemas.openxmlformats.org/drawingml/2006/table">
-            <a:tbl>
-              <a:tblPr firstRow="1" bandRow="1">
-                <a:tableStyleId>{5C22544A-7EE6-4342-B048-85BDC9FD1C3A}</a:tableStyleId>
-              </a:tblPr>
-              <a:tblGrid>
-                <a:gridCol w="2286000"/>
-                <a:gridCol w="1097280"/>
-                <a:gridCol w="1097280"/>
-              </a:tblGrid>
-              <a:tr h="365760">
-                <a:tc>
-                  <a:txBody>
-                    <a:bodyPr/>
-                    <a:lstStyle/>
-                    <a:p>
-                      <a:pPr>
-                        <a:defRPr sz="1100" b="1">
-                          <a:solidFill>
-                            <a:srgbClr val="1F3A3D"/>
-                          </a:solidFill>
-                        </a:defRPr>
-                      </a:pPr>
-                    </a:p>
-                  </a:txBody>
-                  <a:tcPr>
-                    <a:solidFill>
-                      <a:srgbClr val="E6F5F3"/>
-                    </a:solidFill>
-                  </a:tcPr>
-                </a:tc>
-                <a:tc>
-                  <a:txBody>
-                    <a:bodyPr/>
-                    <a:lstStyle/>
-                    <a:p>
-                      <a:pPr algn="ctr">
-                        <a:defRPr sz="1100" b="1">
-                          <a:solidFill>
-                            <a:srgbClr val="1F3A3D"/>
-                          </a:solidFill>
-                        </a:defRPr>
-                      </a:pPr>
-                      <a:r>
-                        <a:t>maart 2026</a:t>
-                      </a:r>
-                    </a:p>
-                    <a:p>
-                      <a:r>
-                        <a:t>alleen hoogtemodel</a:t>
-                      </a:r>
-                    </a:p>
-                  </a:txBody>
-                  <a:tcPr>
-                    <a:solidFill>
-                      <a:srgbClr val="E6F5F3"/>
-                    </a:solidFill>
-                  </a:tcPr>
-                </a:tc>
-                <a:tc>
-                  <a:txBody>
-                    <a:bodyPr/>
-                    <a:lstStyle/>
-                    <a:p>
-                      <a:pPr algn="ctr">
-                        <a:defRPr sz="1100" b="1">
-                          <a:solidFill>
-                            <a:srgbClr val="1F3A3D"/>
-                          </a:solidFill>
-                        </a:defRPr>
-                      </a:pPr>
-                      <a:r>
-                        <a:t>augustus 2026</a:t>
-                      </a:r>
-                    </a:p>
-                    <a:p>
-                      <a:r>
-                        <a:t>hybride</a:t>
-                      </a:r>
-                    </a:p>
-                  </a:txBody>
-                  <a:tcPr>
-                    <a:solidFill>
-                      <a:srgbClr val="E6F5F3"/>
-                    </a:solidFill>
-                  </a:tcPr>
-                </a:tc>
-              </a:tr>
-              <a:tr h="365760">
-                <a:tc>
-                  <a:txBody>
-                    <a:bodyPr/>
-                    <a:lstStyle/>
-                    <a:p>
-                      <a:pPr>
-                        <a:defRPr sz="1100" b="1">
-                          <a:solidFill>
-                            <a:srgbClr val="1F3A3D"/>
-                          </a:solidFill>
-                        </a:defRPr>
-                      </a:pPr>
-                      <a:r>
-                        <a:t>Baseline (naïef gemiddelde) — fout test</a:t>
-                      </a:r>
-                    </a:p>
-                  </a:txBody>
-                  <a:tcPr>
-                    <a:solidFill>
-                      <a:srgbClr val="FFFFFF"/>
-                    </a:solidFill>
-                  </a:tcPr>
-                </a:tc>
-                <a:tc>
-                  <a:txBody>
-                    <a:bodyPr/>
-                    <a:lstStyle/>
-                    <a:p>
-                      <a:pPr algn="ctr">
-                        <a:defRPr sz="1100" b="0">
-                          <a:solidFill>
-                            <a:srgbClr val="1F3A3D"/>
-                          </a:solidFill>
-                        </a:defRPr>
-                      </a:pPr>
-                      <a:r>
-                        <a:t>0,78</a:t>
-                      </a:r>
-                    </a:p>
-                  </a:txBody>
-                  <a:tcPr>
-                    <a:solidFill>
-                      <a:srgbClr val="FFFFFF"/>
-                    </a:solidFill>
-                  </a:tcPr>
-                </a:tc>
-                <a:tc>
-                  <a:txBody>
-                    <a:bodyPr/>
-                    <a:lstStyle/>
-                    <a:p>
-                      <a:pPr algn="ctr">
-                        <a:defRPr sz="1100" b="0">
-                          <a:solidFill>
-                            <a:srgbClr val="1F3A3D"/>
-                          </a:solidFill>
-                        </a:defRPr>
-                      </a:pPr>
-                      <a:r>
-                        <a:t>4,79</a:t>
-                      </a:r>
-                    </a:p>
-                  </a:txBody>
-                  <a:tcPr>
-                    <a:solidFill>
-                      <a:srgbClr val="FFFFFF"/>
-                    </a:solidFill>
-                  </a:tcPr>
-                </a:tc>
-              </a:tr>
-              <a:tr h="365760">
-                <a:tc>
-                  <a:txBody>
-                    <a:bodyPr/>
-                    <a:lstStyle/>
-                    <a:p>
-                      <a:pPr>
-                        <a:defRPr sz="1100" b="1">
-                          <a:solidFill>
-                            <a:srgbClr val="1F3A3D"/>
-                          </a:solidFill>
-                        </a:defRPr>
-                      </a:pPr>
-                      <a:r>
-                        <a:t>LightGBM — fout test</a:t>
-                      </a:r>
-                    </a:p>
-                  </a:txBody>
-                  <a:tcPr>
-                    <a:solidFill>
-                      <a:srgbClr val="FFFFFF"/>
-                    </a:solidFill>
-                  </a:tcPr>
-                </a:tc>
-                <a:tc>
-                  <a:txBody>
-                    <a:bodyPr/>
-                    <a:lstStyle/>
-                    <a:p>
-                      <a:pPr algn="ctr">
-                        <a:defRPr sz="1100" b="0">
-                          <a:solidFill>
-                            <a:srgbClr val="1F3A3D"/>
-                          </a:solidFill>
-                        </a:defRPr>
-                      </a:pPr>
-                      <a:r>
-                        <a:t>0,94</a:t>
-                      </a:r>
-                    </a:p>
-                  </a:txBody>
-                  <a:tcPr>
-                    <a:solidFill>
-                      <a:srgbClr val="FFFFFF"/>
-                    </a:solidFill>
-                  </a:tcPr>
-                </a:tc>
-                <a:tc>
-                  <a:txBody>
-                    <a:bodyPr/>
-                    <a:lstStyle/>
-                    <a:p>
-                      <a:pPr algn="ctr">
-                        <a:defRPr sz="1100" b="0">
-                          <a:solidFill>
-                            <a:srgbClr val="1F3A3D"/>
-                          </a:solidFill>
-                        </a:defRPr>
-                      </a:pPr>
-                      <a:r>
-                        <a:t>4,12</a:t>
-                      </a:r>
-                    </a:p>
-                  </a:txBody>
-                  <a:tcPr>
-                    <a:solidFill>
-                      <a:srgbClr val="FFFFFF"/>
-                    </a:solidFill>
-                  </a:tcPr>
-                </a:tc>
-              </a:tr>
-              <a:tr h="365760">
-                <a:tc>
-                  <a:txBody>
-                    <a:bodyPr/>
-                    <a:lstStyle/>
-                    <a:p>
-                      <a:pPr>
-                        <a:defRPr sz="1100" b="1">
-                          <a:solidFill>
-                            <a:srgbClr val="1F3A3D"/>
-                          </a:solidFill>
-                        </a:defRPr>
-                      </a:pPr>
-                      <a:r>
-                        <a:t>LightGBM t.o.v. baseline</a:t>
-                      </a:r>
-                    </a:p>
-                  </a:txBody>
-                  <a:tcPr>
-                    <a:solidFill>
-                      <a:srgbClr val="FFFFFF"/>
-                    </a:solidFill>
-                  </a:tcPr>
-                </a:tc>
-                <a:tc>
-                  <a:txBody>
-                    <a:bodyPr/>
-                    <a:lstStyle/>
-                    <a:p>
-                      <a:pPr algn="ctr">
-                        <a:defRPr sz="1100" b="0">
-                          <a:solidFill>
-                            <a:srgbClr val="1F3A3D"/>
-                          </a:solidFill>
-                        </a:defRPr>
-                      </a:pPr>
-                      <a:r>
-                        <a:t>20 % slechter</a:t>
-                      </a:r>
-                    </a:p>
-                  </a:txBody>
-                  <a:tcPr>
-                    <a:solidFill>
-                      <a:srgbClr val="FFFFFF"/>
-                    </a:solidFill>
-                  </a:tcPr>
-                </a:tc>
-                <a:tc>
-                  <a:txBody>
-                    <a:bodyPr/>
-                    <a:lstStyle/>
-                    <a:p>
-                      <a:pPr algn="ctr">
-                        <a:defRPr sz="1100" b="0">
-                          <a:solidFill>
-                            <a:srgbClr val="1F3A3D"/>
-                          </a:solidFill>
-                        </a:defRPr>
-                      </a:pPr>
-                      <a:r>
-                        <a:t>14 % beter</a:t>
-                      </a:r>
-                    </a:p>
-                  </a:txBody>
-                  <a:tcPr>
-                    <a:solidFill>
-                      <a:srgbClr val="FFFFFF"/>
-                    </a:solidFill>
-                  </a:tcPr>
-                </a:tc>
-              </a:tr>
-              <a:tr h="365760">
-                <a:tc>
-                  <a:txBody>
-                    <a:bodyPr/>
-                    <a:lstStyle/>
-                    <a:p>
-                      <a:pPr>
-                        <a:defRPr sz="1100" b="1">
-                          <a:solidFill>
-                            <a:srgbClr val="1F3A3D"/>
-                          </a:solidFill>
-                        </a:defRPr>
-                      </a:pPr>
-                      <a:r>
-                        <a:t>Spreiding doelvariabele (m/jr)</a:t>
-                      </a:r>
-                    </a:p>
-                  </a:txBody>
-                  <a:tcPr>
-                    <a:solidFill>
-                      <a:srgbClr val="FFFFFF"/>
-                    </a:solidFill>
-                  </a:tcPr>
-                </a:tc>
-                <a:tc>
-                  <a:txBody>
-                    <a:bodyPr/>
-                    <a:lstStyle/>
-                    <a:p>
-                      <a:pPr algn="ctr">
-                        <a:defRPr sz="1100" b="0">
-                          <a:solidFill>
-                            <a:srgbClr val="1F3A3D"/>
-                          </a:solidFill>
-                        </a:defRPr>
-                      </a:pPr>
-                      <a:r>
-                        <a:t>2,2</a:t>
-                      </a:r>
-                    </a:p>
-                  </a:txBody>
-                  <a:tcPr>
-                    <a:solidFill>
-                      <a:srgbClr val="FFFFFF"/>
-                    </a:solidFill>
-                  </a:tcPr>
-                </a:tc>
-                <a:tc>
-                  <a:txBody>
-                    <a:bodyPr/>
-                    <a:lstStyle/>
-                    <a:p>
-                      <a:pPr algn="ctr">
-                        <a:defRPr sz="1100" b="0">
-                          <a:solidFill>
-                            <a:srgbClr val="1F3A3D"/>
-                          </a:solidFill>
-                        </a:defRPr>
-                      </a:pPr>
-                      <a:r>
-                        <a:t>11,4</a:t>
-                      </a:r>
-                    </a:p>
-                  </a:txBody>
-                  <a:tcPr>
-                    <a:solidFill>
-                      <a:srgbClr val="FFFFFF"/>
-                    </a:solidFill>
-                  </a:tcPr>
-                </a:tc>
-              </a:tr>
-              <a:tr h="365760">
-                <a:tc>
-                  <a:txBody>
-                    <a:bodyPr/>
-                    <a:lstStyle/>
-                    <a:p>
-                      <a:pPr>
-                        <a:defRPr sz="1100" b="1">
-                          <a:solidFill>
-                            <a:srgbClr val="1F3A3D"/>
-                          </a:solidFill>
-                        </a:defRPr>
-                      </a:pPr>
-                      <a:r>
-                        <a:t>Tijd tussen t-punten</a:t>
-                      </a:r>
-                    </a:p>
-                  </a:txBody>
-                  <a:tcPr>
-                    <a:solidFill>
-                      <a:srgbClr val="FFFFFF"/>
-                    </a:solidFill>
-                  </a:tcPr>
-                </a:tc>
-                <a:tc>
-                  <a:txBody>
-                    <a:bodyPr/>
-                    <a:lstStyle/>
-                    <a:p>
-                      <a:pPr algn="ctr">
-                        <a:defRPr sz="1100" b="0">
-                          <a:solidFill>
-                            <a:srgbClr val="1F3A3D"/>
-                          </a:solidFill>
-                        </a:defRPr>
-                      </a:pPr>
-                      <a:r>
-                        <a:t>3–4 jaar</a:t>
-                      </a:r>
-                    </a:p>
-                  </a:txBody>
-                  <a:tcPr>
-                    <a:solidFill>
-                      <a:srgbClr val="FFFFFF"/>
-                    </a:solidFill>
-                  </a:tcPr>
-                </a:tc>
-                <a:tc>
-                  <a:txBody>
-                    <a:bodyPr/>
-                    <a:lstStyle/>
-                    <a:p>
-                      <a:pPr algn="ctr">
-                        <a:defRPr sz="1100" b="0">
-                          <a:solidFill>
-                            <a:srgbClr val="1F3A3D"/>
-                          </a:solidFill>
-                        </a:defRPr>
-                      </a:pPr>
-                      <a:r>
-                        <a:t>1 jaar</a:t>
-                      </a:r>
-                    </a:p>
-                  </a:txBody>
-                  <a:tcPr>
-                    <a:solidFill>
-                      <a:srgbClr val="FFFFFF"/>
-                    </a:solidFill>
-                  </a:tcPr>
-                </a:tc>
-              </a:tr>
-              <a:tr h="365760">
-                <a:tc>
-                  <a:txBody>
-                    <a:bodyPr/>
-                    <a:lstStyle/>
-                    <a:p>
-                      <a:pPr>
-                        <a:defRPr sz="1100" b="1">
-                          <a:solidFill>
-                            <a:srgbClr val="1F3A3D"/>
-                          </a:solidFill>
-                        </a:defRPr>
-                      </a:pPr>
-                      <a:r>
-                        <a:t>Regio's met voorspellingen</a:t>
-                      </a:r>
-                    </a:p>
-                  </a:txBody>
-                  <a:tcPr>
-                    <a:solidFill>
-                      <a:srgbClr val="FFFFFF"/>
-                    </a:solidFill>
-                  </a:tcPr>
-                </a:tc>
-                <a:tc>
-                  <a:txBody>
-                    <a:bodyPr/>
-                    <a:lstStyle/>
-                    <a:p>
-                      <a:pPr algn="ctr">
-                        <a:defRPr sz="1100" b="0">
-                          <a:solidFill>
-                            <a:srgbClr val="1F3A3D"/>
-                          </a:solidFill>
-                        </a:defRPr>
-                      </a:pPr>
-                      <a:r>
-                        <a:t>7.444</a:t>
-                      </a:r>
-                    </a:p>
-                  </a:txBody>
-                  <a:tcPr>
-                    <a:solidFill>
-                      <a:srgbClr val="FFFFFF"/>
-                    </a:solidFill>
-                  </a:tcPr>
-                </a:tc>
-                <a:tc>
-                  <a:txBody>
-                    <a:bodyPr/>
-                    <a:lstStyle/>
-                    <a:p>
-                      <a:pPr algn="ctr">
-                        <a:defRPr sz="1100" b="0">
-                          <a:solidFill>
-                            <a:srgbClr val="1F3A3D"/>
-                          </a:solidFill>
-                        </a:defRPr>
-                      </a:pPr>
-                      <a:r>
-                        <a:t>8.006</a:t>
-                      </a:r>
-                    </a:p>
-                  </a:txBody>
-                  <a:tcPr>
-                    <a:solidFill>
-                      <a:srgbClr val="FFFFFF"/>
-                    </a:solidFill>
-                  </a:tcPr>
-                </a:tc>
-              </a:tr>
-            </a:tbl>
-          </a:graphicData>
-        </a:graphic>
-      </p:graphicFrame>
-      <p:sp>
-        <p:nvSpPr>
-          <p:cNvPr id="7" name="TextBox 6"/>
-          <p:cNvSpPr txBox="1"/>
-          <p:nvPr/>
-        </p:nvSpPr>
-        <p:spPr>
-          <a:xfrm>
-            <a:off x="7406640" y="4572000"/>
-            <a:ext cx="4480560" cy="548640"/>
-          </a:xfrm>
-          <a:prstGeom prst="rect">
-            <a:avLst/>
-          </a:prstGeom>
-          <a:noFill/>
-        </p:spPr>
-        <p:txBody>
-          <a:bodyPr wrap="square">
-            <a:spAutoFit/>
-          </a:bodyPr>
-          <a:lstStyle/>
-          <a:p>
-            <a:pPr>
-              <a:defRPr sz="1200" i="0">
-                <a:solidFill>
-                  <a:srgbClr val="1F3A3D"/>
-                </a:solidFill>
-              </a:defRPr>
-            </a:pPr>
-            <a:r>
-              <a:t>Dezelfde meetruis, gedeeld door een 4× kleiner tijdsverschil: het doel wordt 4× ruiziger en élke fout groeit mee — ook die van de baseline. Relatief verslaat het model nu voor het eerst de baseline.</a:t>
-            </a:r>
-          </a:p>
-        </p:txBody>
-      </p:sp>
     </p:spTree>
   </p:cSld>
   <p:clrMapOvr>
@@ -6628,7 +6585,7 @@
 </file>
 
 <file path=ppt/slides/slide4.xml><?xml version="1.0" encoding="utf-8"?>
-<p:sld xmlns:a="http://schemas.openxmlformats.org/drawingml/2006/main" xmlns:p="http://schemas.openxmlformats.org/presentationml/2006/main" xmlns:r="http://schemas.openxmlformats.org/officeDocument/2006/relationships">
+<p:sld xmlns:a="http://schemas.openxmlformats.org/drawingml/2006/main" xmlns:r="http://schemas.openxmlformats.org/officeDocument/2006/relationships" xmlns:p="http://schemas.openxmlformats.org/presentationml/2006/main">
   <p:cSld>
     <p:spTree>
       <p:nvGrpSpPr>
@@ -6636,7 +6593,350 @@
         <p:cNvGrpSpPr/>
         <p:nvPr/>
       </p:nvGrpSpPr>
-      <p:grpSpPr/>
+      <p:grpSpPr>
+        <a:xfrm>
+          <a:off x="0" y="0"/>
+          <a:ext cx="0" cy="0"/>
+          <a:chOff x="0" y="0"/>
+          <a:chExt cx="0" cy="0"/>
+        </a:xfrm>
+      </p:grpSpPr>
+      <p:pic>
+        <p:nvPicPr>
+          <p:cNvPr id="5" name="Picture 4">
+            <a:extLst>
+              <a:ext uri="{FF2B5EF4-FFF2-40B4-BE49-F238E27FC236}">
+                <a16:creationId xmlns:a16="http://schemas.microsoft.com/office/drawing/2014/main" id="{0EC314E6-9497-9F41-719D-D84E6D9FC991}"/>
+              </a:ext>
+            </a:extLst>
+          </p:cNvPr>
+          <p:cNvPicPr>
+            <a:picLocks noChangeAspect="1"/>
+          </p:cNvPicPr>
+          <p:nvPr/>
+        </p:nvPicPr>
+        <p:blipFill>
+          <a:blip r:embed="rId2"/>
+          <a:stretch>
+            <a:fillRect/>
+          </a:stretch>
+        </p:blipFill>
+        <p:spPr>
+          <a:xfrm>
+            <a:off x="125259" y="1505425"/>
+            <a:ext cx="11297009" cy="3054047"/>
+          </a:xfrm>
+          <a:prstGeom prst="rect">
+            <a:avLst/>
+          </a:prstGeom>
+        </p:spPr>
+      </p:pic>
+      <p:sp>
+        <p:nvSpPr>
+          <p:cNvPr id="6" name="TextBox 5">
+            <a:extLst>
+              <a:ext uri="{FF2B5EF4-FFF2-40B4-BE49-F238E27FC236}">
+                <a16:creationId xmlns:a16="http://schemas.microsoft.com/office/drawing/2014/main" id="{F6B593F3-CFB5-118B-2255-4F90EC3B0783}"/>
+              </a:ext>
+            </a:extLst>
+          </p:cNvPr>
+          <p:cNvSpPr txBox="1"/>
+          <p:nvPr/>
+        </p:nvSpPr>
+        <p:spPr>
+          <a:xfrm>
+            <a:off x="548640" y="320040"/>
+            <a:ext cx="8044062" cy="553998"/>
+          </a:xfrm>
+          <a:prstGeom prst="rect">
+            <a:avLst/>
+          </a:prstGeom>
+          <a:noFill/>
+        </p:spPr>
+        <p:txBody>
+          <a:bodyPr wrap="none">
+            <a:spAutoFit/>
+          </a:bodyPr>
+          <a:lstStyle/>
+          <a:p>
+            <a:pPr>
+              <a:defRPr sz="3000" b="1">
+                <a:solidFill>
+                  <a:srgbClr val="2BB5A6"/>
+                </a:solidFill>
+              </a:defRPr>
+            </a:pPr>
+            <a:r>
+              <a:rPr lang="en-US" dirty="0" err="1"/>
+              <a:t>Afgelopen</a:t>
+            </a:r>
+            <a:r>
+              <a:rPr lang="en-US" dirty="0"/>
+              <a:t> week: </a:t>
+            </a:r>
+            <a:r>
+              <a:rPr lang="en-US" dirty="0" err="1"/>
+              <a:t>nieuwe</a:t>
+            </a:r>
+            <a:r>
+              <a:rPr lang="en-US" dirty="0"/>
+              <a:t> SAM data </a:t>
+            </a:r>
+            <a:r>
+              <a:rPr lang="en-US" dirty="0" err="1"/>
+              <a:t>meegenomen</a:t>
+            </a:r>
+            <a:endParaRPr dirty="0"/>
+          </a:p>
+        </p:txBody>
+      </p:sp>
+      <p:sp>
+        <p:nvSpPr>
+          <p:cNvPr id="7" name="TextBox 6">
+            <a:extLst>
+              <a:ext uri="{FF2B5EF4-FFF2-40B4-BE49-F238E27FC236}">
+                <a16:creationId xmlns:a16="http://schemas.microsoft.com/office/drawing/2014/main" id="{757D906F-AB61-355A-D295-4446B008C522}"/>
+              </a:ext>
+            </a:extLst>
+          </p:cNvPr>
+          <p:cNvSpPr txBox="1"/>
+          <p:nvPr/>
+        </p:nvSpPr>
+        <p:spPr>
+          <a:xfrm>
+            <a:off x="918158" y="4571996"/>
+            <a:ext cx="10042116" cy="461665"/>
+          </a:xfrm>
+          <a:prstGeom prst="rect">
+            <a:avLst/>
+          </a:prstGeom>
+          <a:noFill/>
+        </p:spPr>
+        <p:txBody>
+          <a:bodyPr wrap="square">
+            <a:spAutoFit/>
+          </a:bodyPr>
+          <a:lstStyle/>
+          <a:p>
+            <a:pPr>
+              <a:defRPr sz="1200" i="0">
+                <a:solidFill>
+                  <a:srgbClr val="1F3A3D"/>
+                </a:solidFill>
+              </a:defRPr>
+            </a:pPr>
+            <a:r>
+              <a:rPr dirty="0" err="1"/>
+              <a:t>Dezelfde</a:t>
+            </a:r>
+            <a:r>
+              <a:rPr dirty="0"/>
+              <a:t> </a:t>
+            </a:r>
+            <a:r>
+              <a:rPr dirty="0" err="1"/>
+              <a:t>meetruis</a:t>
+            </a:r>
+            <a:r>
+              <a:rPr dirty="0"/>
+              <a:t>, </a:t>
+            </a:r>
+            <a:r>
+              <a:rPr dirty="0" err="1"/>
+              <a:t>gedeeld</a:t>
+            </a:r>
+            <a:r>
+              <a:rPr dirty="0"/>
+              <a:t> door </a:t>
+            </a:r>
+            <a:r>
+              <a:rPr dirty="0" err="1"/>
+              <a:t>een</a:t>
+            </a:r>
+            <a:r>
+              <a:rPr dirty="0"/>
+              <a:t> 4× </a:t>
+            </a:r>
+            <a:r>
+              <a:rPr dirty="0" err="1"/>
+              <a:t>kleiner</a:t>
+            </a:r>
+            <a:r>
+              <a:rPr dirty="0"/>
+              <a:t> </a:t>
+            </a:r>
+            <a:r>
+              <a:rPr dirty="0" err="1"/>
+              <a:t>tijdsverschil</a:t>
+            </a:r>
+            <a:r>
+              <a:rPr dirty="0"/>
+              <a:t>: het </a:t>
+            </a:r>
+            <a:r>
+              <a:rPr dirty="0" err="1"/>
+              <a:t>doel</a:t>
+            </a:r>
+            <a:r>
+              <a:rPr dirty="0"/>
+              <a:t> </a:t>
+            </a:r>
+            <a:r>
+              <a:rPr dirty="0" err="1"/>
+              <a:t>wordt</a:t>
+            </a:r>
+            <a:r>
+              <a:rPr dirty="0"/>
+              <a:t> 4× </a:t>
+            </a:r>
+            <a:r>
+              <a:rPr dirty="0" err="1"/>
+              <a:t>ruiziger</a:t>
+            </a:r>
+            <a:r>
+              <a:rPr dirty="0"/>
+              <a:t> </a:t>
+            </a:r>
+            <a:r>
+              <a:rPr dirty="0" err="1"/>
+              <a:t>en</a:t>
+            </a:r>
+            <a:r>
+              <a:rPr dirty="0"/>
+              <a:t> </a:t>
+            </a:r>
+            <a:r>
+              <a:rPr dirty="0" err="1"/>
+              <a:t>élke</a:t>
+            </a:r>
+            <a:r>
+              <a:rPr dirty="0"/>
+              <a:t> </a:t>
+            </a:r>
+            <a:r>
+              <a:rPr dirty="0" err="1"/>
+              <a:t>fout</a:t>
+            </a:r>
+            <a:r>
+              <a:rPr dirty="0"/>
+              <a:t> </a:t>
+            </a:r>
+            <a:r>
+              <a:rPr dirty="0" err="1"/>
+              <a:t>groeit</a:t>
+            </a:r>
+            <a:r>
+              <a:rPr dirty="0"/>
+              <a:t> mee — </a:t>
+            </a:r>
+            <a:r>
+              <a:rPr dirty="0" err="1"/>
+              <a:t>ook</a:t>
+            </a:r>
+            <a:r>
+              <a:rPr dirty="0"/>
+              <a:t> die van de baseline. </a:t>
+            </a:r>
+            <a:r>
+              <a:rPr dirty="0" err="1"/>
+              <a:t>Relatief</a:t>
+            </a:r>
+            <a:r>
+              <a:rPr dirty="0"/>
+              <a:t> </a:t>
+            </a:r>
+            <a:r>
+              <a:rPr dirty="0" err="1"/>
+              <a:t>verslaat</a:t>
+            </a:r>
+            <a:r>
+              <a:rPr dirty="0"/>
+              <a:t> het model nu </a:t>
+            </a:r>
+            <a:r>
+              <a:rPr dirty="0" err="1"/>
+              <a:t>voor</a:t>
+            </a:r>
+            <a:r>
+              <a:rPr dirty="0"/>
+              <a:t> het </a:t>
+            </a:r>
+            <a:r>
+              <a:rPr dirty="0" err="1"/>
+              <a:t>eerst</a:t>
+            </a:r>
+            <a:r>
+              <a:rPr dirty="0"/>
+              <a:t> de baseline.</a:t>
+            </a:r>
+          </a:p>
+        </p:txBody>
+      </p:sp>
+      <p:sp>
+        <p:nvSpPr>
+          <p:cNvPr id="8" name="TextBox 7"/>
+          <p:cNvSpPr txBox="1"/>
+          <p:nvPr/>
+        </p:nvSpPr>
+        <p:spPr>
+          <a:xfrm>
+            <a:off x="548640" y="6400800"/>
+            <a:ext cx="10972800" cy="274320"/>
+          </a:xfrm>
+          <a:prstGeom prst="rect">
+            <a:avLst/>
+          </a:prstGeom>
+          <a:noFill/>
+        </p:spPr>
+        <p:txBody>
+          <a:bodyPr wrap="square">
+            <a:spAutoFit/>
+          </a:bodyPr>
+          <a:lstStyle/>
+          <a:p>
+            <a:pPr>
+              <a:defRPr sz="1000" b="0" i="0">
+                <a:solidFill>
+                  <a:srgbClr val="6B7778"/>
+                </a:solidFill>
+              </a:defRPr>
+            </a:pPr>
+            <a:r>
+              <a:t>Oevererosietool · update 26-08-2026 · 4</a:t>
+            </a:r>
+          </a:p>
+        </p:txBody>
+      </p:sp>
+    </p:spTree>
+    <p:extLst>
+      <p:ext uri="{BB962C8B-B14F-4D97-AF65-F5344CB8AC3E}">
+        <p14:creationId xmlns:p14="http://schemas.microsoft.com/office/powerpoint/2010/main" val="1728551451"/>
+      </p:ext>
+    </p:extLst>
+  </p:cSld>
+  <p:clrMapOvr>
+    <a:masterClrMapping/>
+  </p:clrMapOvr>
+</p:sld>
+</file>
+
+<file path=ppt/slides/slide5.xml><?xml version="1.0" encoding="utf-8"?>
+<p:sld xmlns:a="http://schemas.openxmlformats.org/drawingml/2006/main" xmlns:r="http://schemas.openxmlformats.org/officeDocument/2006/relationships" xmlns:p="http://schemas.openxmlformats.org/presentationml/2006/main">
+  <p:cSld>
+    <p:spTree>
+      <p:nvGrpSpPr>
+        <p:cNvPr id="1" name=""/>
+        <p:cNvGrpSpPr/>
+        <p:nvPr/>
+      </p:nvGrpSpPr>
+      <p:grpSpPr>
+        <a:xfrm>
+          <a:off x="0" y="0"/>
+          <a:ext cx="0" cy="0"/>
+          <a:chOff x="0" y="0"/>
+          <a:chExt cx="0" cy="0"/>
+        </a:xfrm>
+      </p:grpSpPr>
       <p:sp>
         <p:nvSpPr>
           <p:cNvPr id="2" name="TextBox 1"/>
@@ -6667,8 +6967,34 @@
               </a:defRPr>
             </a:pPr>
             <a:r>
-              <a:t>Drie assen om te verbeteren</a:t>
-            </a:r>
+              <a:rPr dirty="0" err="1"/>
+              <a:t>Drie</a:t>
+            </a:r>
+            <a:r>
+              <a:rPr dirty="0"/>
+              <a:t> </a:t>
+            </a:r>
+            <a:r>
+              <a:rPr dirty="0" err="1"/>
+              <a:t>assen</a:t>
+            </a:r>
+            <a:r>
+              <a:rPr dirty="0"/>
+              <a:t> om </a:t>
+            </a:r>
+            <a:r>
+              <a:rPr dirty="0" err="1"/>
+              <a:t>te</a:t>
+            </a:r>
+            <a:r>
+              <a:rPr dirty="0"/>
+              <a:t> </a:t>
+            </a:r>
+            <a:r>
+              <a:rPr dirty="0" err="1"/>
+              <a:t>verbeteren</a:t>
+            </a:r>
+            <a:endParaRPr dirty="0"/>
           </a:p>
         </p:txBody>
       </p:sp>
@@ -6737,7 +7063,7 @@
               </a:defRPr>
             </a:pPr>
             <a:r>
-              <a:t>Oevererosietool · update 26-08-2026 · 4</a:t>
+              <a:t>Oevererosietool · update 26-08-2026 · 5</a:t>
             </a:r>
           </a:p>
         </p:txBody>
@@ -7100,8 +7426,8 @@
 </p:sld>
 </file>
 
-<file path=ppt/slides/slide5.xml><?xml version="1.0" encoding="utf-8"?>
-<p:sld xmlns:a="http://schemas.openxmlformats.org/drawingml/2006/main" xmlns:p="http://schemas.openxmlformats.org/presentationml/2006/main" xmlns:r="http://schemas.openxmlformats.org/officeDocument/2006/relationships">
+<file path=ppt/slides/slide6.xml><?xml version="1.0" encoding="utf-8"?>
+<p:sld xmlns:a="http://schemas.openxmlformats.org/drawingml/2006/main" xmlns:r="http://schemas.openxmlformats.org/officeDocument/2006/relationships" xmlns:p="http://schemas.openxmlformats.org/presentationml/2006/main">
   <p:cSld>
     <p:spTree>
       <p:nvGrpSpPr>
@@ -7109,7 +7435,14 @@
         <p:cNvGrpSpPr/>
         <p:nvPr/>
       </p:nvGrpSpPr>
-      <p:grpSpPr/>
+      <p:grpSpPr>
+        <a:xfrm>
+          <a:off x="0" y="0"/>
+          <a:ext cx="0" cy="0"/>
+          <a:chOff x="0" y="0"/>
+          <a:chExt cx="0" cy="0"/>
+        </a:xfrm>
+      </p:grpSpPr>
       <p:sp>
         <p:nvSpPr>
           <p:cNvPr id="2" name="TextBox 1"/>
@@ -7140,7 +7473,7 @@
               </a:defRPr>
             </a:pPr>
             <a:r>
-              <a:t>As 1 · Opschonen: van 3,99 naar 2,27</a:t>
+              <a:t>As 1 · Opschonen: van 3,99 naar 2,27 op de vaste testset</a:t>
             </a:r>
           </a:p>
         </p:txBody>
@@ -7210,14 +7543,82 @@
               </a:defRPr>
             </a:pPr>
             <a:r>
-              <a:t>Oevererosietool · update 26-08-2026 · 5</a:t>
+              <a:t>Oevererosietool · update 26-08-2026 · 7</a:t>
+            </a:r>
+          </a:p>
+        </p:txBody>
+      </p:sp>
+      <p:sp>
+        <p:nvSpPr>
+          <p:cNvPr id="7" name="TextBox 6"/>
+          <p:cNvSpPr txBox="1"/>
+          <p:nvPr/>
+        </p:nvSpPr>
+        <p:spPr>
+          <a:xfrm>
+            <a:off x="548640" y="4572000"/>
+            <a:ext cx="6949440" cy="1737360"/>
+          </a:xfrm>
+          <a:prstGeom prst="rect">
+            <a:avLst/>
+          </a:prstGeom>
+          <a:noFill/>
+        </p:spPr>
+        <p:txBody>
+          <a:bodyPr wrap="square">
+            <a:spAutoFit/>
+          </a:bodyPr>
+          <a:lstStyle/>
+          <a:p>
+            <a:pPr>
+              <a:spcAft>
+                <a:spcPts val="400"/>
+              </a:spcAft>
+              <a:defRPr sz="1300" b="0">
+                <a:solidFill>
+                  <a:srgbClr val="1F3A3D"/>
+                </a:solidFill>
+              </a:defRPr>
+            </a:pPr>
+            <a:r>
+              <a:t>• Kronkelende lijnen, verkeerde oever, doolhoven, fragmenten, te weinig punten, uitschieters t.o.v. de trend</a:t>
+            </a:r>
+          </a:p>
+          <a:p>
+            <a:pPr>
+              <a:spcAft>
+                <a:spcPts val="400"/>
+              </a:spcAft>
+              <a:defRPr sz="1300" b="0">
+                <a:solidFill>
+                  <a:srgbClr val="1F3A3D"/>
+                </a:solidFill>
+              </a:defRPr>
+            </a:pPr>
+            <a:r>
+              <a:t>• Een uitschieter kost één meting, niet het hele vlak: +511 vlakken t.o.v. de oude |v| &gt; 50-filter</a:t>
+            </a:r>
+          </a:p>
+          <a:p>
+            <a:pPr>
+              <a:spcAft>
+                <a:spcPts val="400"/>
+              </a:spcAft>
+              <a:defRPr sz="1300" b="0">
+                <a:solidFill>
+                  <a:srgbClr val="1F3A3D"/>
+                </a:solidFill>
+              </a:defRPr>
+            </a:pPr>
+            <a:r>
+              <a:t>• Elke variant visueel gecontroleerd (50+ varianten, dekking blijft 0,94)</a:t>
             </a:r>
           </a:p>
         </p:txBody>
       </p:sp>
       <p:pic>
         <p:nvPicPr>
-          <p:cNvPr id="5" name="Picture 4" descr="cleaning_ladder.png"/>
+          <p:cNvPr id="8" name="Picture 7" descr="image.png"/>
           <p:cNvPicPr>
             <a:picLocks noChangeAspect="1"/>
           </p:cNvPicPr>
@@ -7232,47 +7633,23 @@
         <p:spPr>
           <a:xfrm>
             <a:off x="548640" y="1463040"/>
-            <a:ext cx="6949440" cy="2902971"/>
+            <a:ext cx="8686800" cy="3628713"/>
           </a:xfrm>
           <a:prstGeom prst="rect">
             <a:avLst/>
           </a:prstGeom>
         </p:spPr>
       </p:pic>
-      <p:pic>
-        <p:nvPicPr>
-          <p:cNvPr id="6" name="Picture 5" descr="aug-3.png"/>
-          <p:cNvPicPr>
-            <a:picLocks noChangeAspect="1"/>
-          </p:cNvPicPr>
-          <p:nvPr/>
-        </p:nvPicPr>
-        <p:blipFill>
-          <a:blip r:embed="rId3"/>
-          <a:stretch>
-            <a:fillRect/>
-          </a:stretch>
-        </p:blipFill>
-        <p:spPr>
-          <a:xfrm>
-            <a:off x="7589520" y="1463040"/>
-            <a:ext cx="4297680" cy="2416896"/>
-          </a:xfrm>
-          <a:prstGeom prst="rect">
-            <a:avLst/>
-          </a:prstGeom>
-        </p:spPr>
-      </p:pic>
-      <p:sp>
-        <p:nvSpPr>
-          <p:cNvPr id="7" name="TextBox 6"/>
+      <p:sp>
+        <p:nvSpPr>
+          <p:cNvPr id="9" name="TextBox 8"/>
           <p:cNvSpPr txBox="1"/>
           <p:nvPr/>
         </p:nvSpPr>
         <p:spPr>
           <a:xfrm>
-            <a:off x="548640" y="4572000"/>
-            <a:ext cx="6949440" cy="1737360"/>
+            <a:off x="9418320" y="1554480"/>
+            <a:ext cx="2560320" cy="3200400"/>
           </a:xfrm>
           <a:prstGeom prst="rect">
             <a:avLst/>
@@ -7286,82 +7663,14 @@
           <a:lstStyle/>
           <a:p>
             <a:pPr>
-              <a:spcAft>
-                <a:spcPts val="400"/>
-              </a:spcAft>
-              <a:defRPr sz="1300" b="0">
-                <a:solidFill>
-                  <a:srgbClr val="1F3A3D"/>
-                </a:solidFill>
-              </a:defRPr>
-            </a:pPr>
-            <a:r>
-              <a:t>• Kronkelende lijnen, verkeerde oever, doolhoven, fragmenten, te weinig punten, uitschieters t.o.v. de trend</a:t>
-            </a:r>
-          </a:p>
-          <a:p>
-            <a:pPr>
-              <a:spcAft>
-                <a:spcPts val="400"/>
-              </a:spcAft>
-              <a:defRPr sz="1300" b="0">
-                <a:solidFill>
-                  <a:srgbClr val="1F3A3D"/>
-                </a:solidFill>
-              </a:defRPr>
-            </a:pPr>
-            <a:r>
-              <a:t>• Een uitschieter kost één meting, niet het hele vlak: +511 vlakken t.o.v. de oude |v| &gt; 50-filter</a:t>
-            </a:r>
-          </a:p>
-          <a:p>
-            <a:pPr>
-              <a:spcAft>
-                <a:spcPts val="400"/>
-              </a:spcAft>
-              <a:defRPr sz="1300" b="0">
-                <a:solidFill>
-                  <a:srgbClr val="1F3A3D"/>
-                </a:solidFill>
-              </a:defRPr>
-            </a:pPr>
-            <a:r>
-              <a:t>• Elke variant visueel gecontroleerd (50+ varianten, dekking blijft 0,94)</a:t>
-            </a:r>
-          </a:p>
-        </p:txBody>
-      </p:sp>
-      <p:sp>
-        <p:nvSpPr>
-          <p:cNvPr id="8" name="TextBox 7"/>
-          <p:cNvSpPr txBox="1"/>
-          <p:nvPr/>
-        </p:nvSpPr>
-        <p:spPr>
-          <a:xfrm>
-            <a:off x="7589520" y="4023360"/>
-            <a:ext cx="4297680" cy="548640"/>
-          </a:xfrm>
-          <a:prstGeom prst="rect">
-            <a:avLst/>
-          </a:prstGeom>
-          <a:noFill/>
-        </p:spPr>
-        <p:txBody>
-          <a:bodyPr wrap="square">
-            <a:spAutoFit/>
-          </a:bodyPr>
-          <a:lstStyle/>
-          <a:p>
-            <a:pPr>
-              <a:defRPr sz="1100" i="1">
+              <a:defRPr sz="1100" b="0" i="1">
                 <a:solidFill>
                   <a:srgbClr val="6B7778"/>
                 </a:solidFill>
               </a:defRPr>
             </a:pPr>
             <a:r>
-              <a:t>Kribben · meeroeverig · bruggen · doolhoven · randen</a:t>
+              <a:t>Leeswijzer: 4,12 was de score van het 19 aug-model op zijn eigen willekeurige train/test-splitsing. Voor het experiment is één vaste testset van 1.174 vlakken bevroren zodat 50+ varianten vergelijkbaar zijn; datzelfde model scoort daarop 3,99. Alle stappen hierna zijn op deze set gemeten.</a:t>
             </a:r>
           </a:p>
         </p:txBody>
@@ -7374,8 +7683,8 @@
 </p:sld>
 </file>
 
-<file path=ppt/slides/slide6.xml><?xml version="1.0" encoding="utf-8"?>
-<p:sld xmlns:a="http://schemas.openxmlformats.org/drawingml/2006/main" xmlns:p="http://schemas.openxmlformats.org/presentationml/2006/main" xmlns:r="http://schemas.openxmlformats.org/officeDocument/2006/relationships">
+<file path=ppt/slides/slide7.xml><?xml version="1.0" encoding="utf-8"?>
+<p:sld xmlns:a="http://schemas.openxmlformats.org/drawingml/2006/main" xmlns:r="http://schemas.openxmlformats.org/officeDocument/2006/relationships" xmlns:p="http://schemas.openxmlformats.org/presentationml/2006/main">
   <p:cSld>
     <p:spTree>
       <p:nvGrpSpPr>
@@ -7383,7 +7692,14 @@
         <p:cNvGrpSpPr/>
         <p:nvPr/>
       </p:nvGrpSpPr>
-      <p:grpSpPr/>
+      <p:grpSpPr>
+        <a:xfrm>
+          <a:off x="0" y="0"/>
+          <a:ext cx="0" cy="0"/>
+          <a:chOff x="0" y="0"/>
+          <a:chExt cx="0" cy="0"/>
+        </a:xfrm>
+      </p:grpSpPr>
       <p:sp>
         <p:nvSpPr>
           <p:cNvPr id="2" name="TextBox 1"/>
@@ -7484,7 +7800,7 @@
               </a:defRPr>
             </a:pPr>
             <a:r>
-              <a:t>Oevererosietool · update 26-08-2026 · 6</a:t>
+              <a:t>Oevererosietool · update 26-08-2026 · 8</a:t>
             </a:r>
           </a:p>
         </p:txBody>
@@ -7648,8 +7964,8 @@
 </p:sld>
 </file>
 
-<file path=ppt/slides/slide7.xml><?xml version="1.0" encoding="utf-8"?>
-<p:sld xmlns:a="http://schemas.openxmlformats.org/drawingml/2006/main" xmlns:p="http://schemas.openxmlformats.org/presentationml/2006/main" xmlns:r="http://schemas.openxmlformats.org/officeDocument/2006/relationships">
+<file path=ppt/slides/slide8.xml><?xml version="1.0" encoding="utf-8"?>
+<p:sld xmlns:a="http://schemas.openxmlformats.org/drawingml/2006/main" xmlns:r="http://schemas.openxmlformats.org/officeDocument/2006/relationships" xmlns:p="http://schemas.openxmlformats.org/presentationml/2006/main">
   <p:cSld>
     <p:spTree>
       <p:nvGrpSpPr>
@@ -7657,7 +7973,14 @@
         <p:cNvGrpSpPr/>
         <p:nvPr/>
       </p:nvGrpSpPr>
-      <p:grpSpPr/>
+      <p:grpSpPr>
+        <a:xfrm>
+          <a:off x="0" y="0"/>
+          <a:ext cx="0" cy="0"/>
+          <a:chOff x="0" y="0"/>
+          <a:chExt cx="0" cy="0"/>
+        </a:xfrm>
+      </p:grpSpPr>
       <p:sp>
         <p:nvSpPr>
           <p:cNvPr id="2" name="TextBox 1"/>
@@ -7758,7 +8081,7 @@
               </a:defRPr>
             </a:pPr>
             <a:r>
-              <a:t>Oevererosietool · update 26-08-2026 · 7</a:t>
+              <a:t>Oevererosietool · update 26-08-2026 · 9</a:t>
             </a:r>
           </a:p>
         </p:txBody>
@@ -7923,8 +8246,8 @@
 </p:sld>
 </file>
 
-<file path=ppt/slides/slide8.xml><?xml version="1.0" encoding="utf-8"?>
-<p:sld xmlns:a="http://schemas.openxmlformats.org/drawingml/2006/main" xmlns:p="http://schemas.openxmlformats.org/presentationml/2006/main" xmlns:r="http://schemas.openxmlformats.org/officeDocument/2006/relationships">
+<file path=ppt/slides/slide9.xml><?xml version="1.0" encoding="utf-8"?>
+<p:sld xmlns:a="http://schemas.openxmlformats.org/drawingml/2006/main" xmlns:r="http://schemas.openxmlformats.org/officeDocument/2006/relationships" xmlns:p="http://schemas.openxmlformats.org/presentationml/2006/main">
   <p:cSld>
     <p:spTree>
       <p:nvGrpSpPr>
@@ -7932,7 +8255,14 @@
         <p:cNvGrpSpPr/>
         <p:nvPr/>
       </p:nvGrpSpPr>
-      <p:grpSpPr/>
+      <p:grpSpPr>
+        <a:xfrm>
+          <a:off x="0" y="0"/>
+          <a:ext cx="0" cy="0"/>
+          <a:chOff x="0" y="0"/>
+          <a:chExt cx="0" cy="0"/>
+        </a:xfrm>
+      </p:grpSpPr>
       <p:sp>
         <p:nvSpPr>
           <p:cNvPr id="2" name="TextBox 1"/>
@@ -8033,7 +8363,7 @@
               </a:defRPr>
             </a:pPr>
             <a:r>
-              <a:t>Oevererosietool · update 26-08-2026 · 8</a:t>
+              <a:t>Oevererosietool · update 26-08-2026 · 10</a:t>
             </a:r>
           </a:p>
         </p:txBody>
@@ -8216,260 +8546,6 @@
             </a:pPr>
             <a:r>
               <a:t>• VVR-jaar = één drempel per vlak (het verst gelegen punt van de signaleringslijn) tegen één scalar → per definitie laat</a:t>
-            </a:r>
-          </a:p>
-        </p:txBody>
-      </p:sp>
-    </p:spTree>
-  </p:cSld>
-  <p:clrMapOvr>
-    <a:masterClrMapping/>
-  </p:clrMapOvr>
-</p:sld>
-</file>
-
-<file path=ppt/slides/slide9.xml><?xml version="1.0" encoding="utf-8"?>
-<p:sld xmlns:a="http://schemas.openxmlformats.org/drawingml/2006/main" xmlns:p="http://schemas.openxmlformats.org/presentationml/2006/main" xmlns:r="http://schemas.openxmlformats.org/officeDocument/2006/relationships">
-  <p:cSld>
-    <p:spTree>
-      <p:nvGrpSpPr>
-        <p:cNvPr id="1" name=""/>
-        <p:cNvGrpSpPr/>
-        <p:nvPr/>
-      </p:nvGrpSpPr>
-      <p:grpSpPr/>
-      <p:sp>
-        <p:nvSpPr>
-          <p:cNvPr id="2" name="TextBox 1"/>
-          <p:cNvSpPr txBox="1"/>
-          <p:nvPr/>
-        </p:nvSpPr>
-        <p:spPr>
-          <a:xfrm>
-            <a:off x="548640" y="320040"/>
-            <a:ext cx="10972800" cy="731520"/>
-          </a:xfrm>
-          <a:prstGeom prst="rect">
-            <a:avLst/>
-          </a:prstGeom>
-          <a:noFill/>
-        </p:spPr>
-        <p:txBody>
-          <a:bodyPr wrap="none">
-            <a:spAutoFit/>
-          </a:bodyPr>
-          <a:lstStyle/>
-          <a:p>
-            <a:pPr>
-              <a:defRPr sz="3000" b="1">
-                <a:solidFill>
-                  <a:srgbClr val="2BB5A6"/>
-                </a:solidFill>
-              </a:defRPr>
-            </a:pPr>
-            <a:r>
-              <a:t>As 3 · Hoe fijn kan het?</a:t>
-            </a:r>
-          </a:p>
-        </p:txBody>
-      </p:sp>
-      <p:sp>
-        <p:nvSpPr>
-          <p:cNvPr id="3" name="TextBox 2"/>
-          <p:cNvSpPr txBox="1"/>
-          <p:nvPr/>
-        </p:nvSpPr>
-        <p:spPr>
-          <a:xfrm>
-            <a:off x="548640" y="960120"/>
-            <a:ext cx="10972800" cy="548640"/>
-          </a:xfrm>
-          <a:prstGeom prst="rect">
-            <a:avLst/>
-          </a:prstGeom>
-          <a:noFill/>
-        </p:spPr>
-        <p:txBody>
-          <a:bodyPr wrap="none">
-            <a:spAutoFit/>
-          </a:bodyPr>
-          <a:lstStyle/>
-          <a:p>
-            <a:pPr>
-              <a:defRPr sz="1700">
-                <a:solidFill>
-                  <a:srgbClr val="1F3A3D"/>
-                </a:solidFill>
-              </a:defRPr>
-            </a:pPr>
-            <a:r>
-              <a:t>Zelfde vlak, R = 1 … 100 · en de fout op de vaste testset per R</a:t>
-            </a:r>
-          </a:p>
-        </p:txBody>
-      </p:sp>
-      <p:sp>
-        <p:nvSpPr>
-          <p:cNvPr id="4" name="TextBox 3"/>
-          <p:cNvSpPr txBox="1"/>
-          <p:nvPr/>
-        </p:nvSpPr>
-        <p:spPr>
-          <a:xfrm>
-            <a:off x="548640" y="6400800"/>
-            <a:ext cx="10972800" cy="274320"/>
-          </a:xfrm>
-          <a:prstGeom prst="rect">
-            <a:avLst/>
-          </a:prstGeom>
-          <a:noFill/>
-        </p:spPr>
-        <p:txBody>
-          <a:bodyPr wrap="none">
-            <a:spAutoFit/>
-          </a:bodyPr>
-          <a:lstStyle/>
-          <a:p>
-            <a:pPr>
-              <a:defRPr sz="1000">
-                <a:solidFill>
-                  <a:srgbClr val="6B7778"/>
-                </a:solidFill>
-              </a:defRPr>
-            </a:pPr>
-            <a:r>
-              <a:t>Oevererosietool · update 26-08-2026 · 9</a:t>
-            </a:r>
-          </a:p>
-        </p:txBody>
-      </p:sp>
-      <p:pic>
-        <p:nvPicPr>
-          <p:cNvPr id="5" name="Picture 4" descr="maas3_r_8930_8940.png"/>
-          <p:cNvPicPr>
-            <a:picLocks noChangeAspect="1"/>
-          </p:cNvPicPr>
-          <p:nvPr/>
-        </p:nvPicPr>
-        <p:blipFill>
-          <a:blip r:embed="rId2"/>
-          <a:stretch>
-            <a:fillRect/>
-          </a:stretch>
-        </p:blipFill>
-        <p:spPr>
-          <a:xfrm>
-            <a:off x="548640" y="1371600"/>
-            <a:ext cx="5760720" cy="3280921"/>
-          </a:xfrm>
-          <a:prstGeom prst="rect">
-            <a:avLst/>
-          </a:prstGeom>
-        </p:spPr>
-      </p:pic>
-      <p:pic>
-        <p:nvPicPr>
-          <p:cNvPr id="6" name="Picture 5" descr="resolution_sweep.png"/>
-          <p:cNvPicPr>
-            <a:picLocks noChangeAspect="1"/>
-          </p:cNvPicPr>
-          <p:nvPr/>
-        </p:nvPicPr>
-        <p:blipFill>
-          <a:blip r:embed="rId3"/>
-          <a:stretch>
-            <a:fillRect/>
-          </a:stretch>
-        </p:blipFill>
-        <p:spPr>
-          <a:xfrm>
-            <a:off x="6400800" y="1371600"/>
-            <a:ext cx="5577840" cy="2330016"/>
-          </a:xfrm>
-          <a:prstGeom prst="rect">
-            <a:avLst/>
-          </a:prstGeom>
-        </p:spPr>
-      </p:pic>
-      <p:sp>
-        <p:nvSpPr>
-          <p:cNvPr id="7" name="TextBox 6"/>
-          <p:cNvSpPr txBox="1"/>
-          <p:nvPr/>
-        </p:nvSpPr>
-        <p:spPr>
-          <a:xfrm>
-            <a:off x="548640" y="4754880"/>
-            <a:ext cx="11430000" cy="1645920"/>
-          </a:xfrm>
-          <a:prstGeom prst="rect">
-            <a:avLst/>
-          </a:prstGeom>
-          <a:noFill/>
-        </p:spPr>
-        <p:txBody>
-          <a:bodyPr wrap="square">
-            <a:spAutoFit/>
-          </a:bodyPr>
-          <a:lstStyle/>
-          <a:p>
-            <a:pPr>
-              <a:spcAft>
-                <a:spcPts val="300"/>
-              </a:spcAft>
-              <a:defRPr sz="1200" b="0">
-                <a:solidFill>
-                  <a:srgbClr val="1F3A3D"/>
-                </a:solidFill>
-              </a:defRPr>
-            </a:pPr>
-            <a:r>
-              <a:t>• De segment-representatie (bruin) volgt de gemeten oever vanaf R ≈ 5–10; bij R = 50–100 raken segmenten leeg (rood)</a:t>
-            </a:r>
-          </a:p>
-          <a:p>
-            <a:pPr>
-              <a:spcAft>
-                <a:spcPts val="300"/>
-              </a:spcAft>
-              <a:defRPr sz="1200" b="0">
-                <a:solidFill>
-                  <a:srgbClr val="1F3A3D"/>
-                </a:solidFill>
-              </a:defRPr>
-            </a:pPr>
-            <a:r>
-              <a:t>• Fout per segment daalt van 2,25 (R = 1) naar 1,88 (R = 5) en 1,61 (R = 20) — kleiner wordt nauwkeuriger, niet ruiziger</a:t>
-            </a:r>
-          </a:p>
-          <a:p>
-            <a:pPr>
-              <a:spcAft>
-                <a:spcPts val="300"/>
-              </a:spcAft>
-              <a:defRPr sz="1200" b="0">
-                <a:solidFill>
-                  <a:srgbClr val="1F3A3D"/>
-                </a:solidFill>
-              </a:defRPr>
-            </a:pPr>
-            <a:r>
-              <a:t>• Terug-samengevoegd per vlak blijft de fout ≈ 2,1–2,2: het vlak-getal zelf heeft een vloer (0,5–1,1 m/jr representatiefout)</a:t>
-            </a:r>
-          </a:p>
-          <a:p>
-            <a:pPr>
-              <a:spcAft>
-                <a:spcPts val="300"/>
-              </a:spcAft>
-              <a:defRPr sz="1200" b="0">
-                <a:solidFill>
-                  <a:srgbClr val="1F3A3D"/>
-                </a:solidFill>
-              </a:defRPr>
-            </a:pPr>
-            <a:r>
-              <a:t>• Grens ligt bij de lijnbemonstering (60 punten per lijn), niet bij het model · praktisch: R = 5–10 (≈ 10–20 m)</a:t>
             </a:r>
           </a:p>
         </p:txBody>
@@ -8813,44 +8889,44 @@
         <a:sysClr val="window" lastClr="FFFFFF"/>
       </a:lt1>
       <a:dk2>
-        <a:srgbClr val="1F497D"/>
+        <a:srgbClr val="0E2841"/>
       </a:dk2>
       <a:lt2>
-        <a:srgbClr val="EEECE1"/>
+        <a:srgbClr val="E8E8E8"/>
       </a:lt2>
       <a:accent1>
-        <a:srgbClr val="4F81BD"/>
+        <a:srgbClr val="156082"/>
       </a:accent1>
       <a:accent2>
-        <a:srgbClr val="C0504D"/>
+        <a:srgbClr val="E97132"/>
       </a:accent2>
       <a:accent3>
-        <a:srgbClr val="9BBB59"/>
+        <a:srgbClr val="196B24"/>
       </a:accent3>
       <a:accent4>
-        <a:srgbClr val="8064A2"/>
+        <a:srgbClr val="0F9ED5"/>
       </a:accent4>
       <a:accent5>
-        <a:srgbClr val="4BACC6"/>
+        <a:srgbClr val="A02B93"/>
       </a:accent5>
       <a:accent6>
-        <a:srgbClr val="F79646"/>
+        <a:srgbClr val="4EA72E"/>
       </a:accent6>
       <a:hlink>
-        <a:srgbClr val="0000FF"/>
+        <a:srgbClr val="467886"/>
       </a:hlink>
       <a:folHlink>
-        <a:srgbClr val="800080"/>
+        <a:srgbClr val="96607D"/>
       </a:folHlink>
     </a:clrScheme>
     <a:fontScheme name="Office">
       <a:majorFont>
-        <a:latin typeface="Calibri"/>
+        <a:latin typeface="Aptos Display" panose="02110004020202020204"/>
         <a:ea typeface=""/>
         <a:cs typeface=""/>
-        <a:font script="Jpan" typeface="ＭＳ Ｐゴシック"/>
+        <a:font script="Jpan" typeface="游ゴシック Light"/>
         <a:font script="Hang" typeface="맑은 고딕"/>
-        <a:font script="Hans" typeface="宋体"/>
+        <a:font script="Hans" typeface="等线 Light"/>
         <a:font script="Hant" typeface="新細明體"/>
         <a:font script="Arab" typeface="Times New Roman"/>
         <a:font script="Hebr" typeface="Times New Roman"/>
@@ -8878,14 +8954,31 @@
         <a:font script="Viet" typeface="Times New Roman"/>
         <a:font script="Uigh" typeface="Microsoft Uighur"/>
         <a:font script="Geor" typeface="Sylfaen"/>
+        <a:font script="Armn" typeface="Arial"/>
+        <a:font script="Bugi" typeface="Leelawadee UI"/>
+        <a:font script="Bopo" typeface="Microsoft JhengHei"/>
+        <a:font script="Java" typeface="Javanese Text"/>
+        <a:font script="Lisu" typeface="Segoe UI"/>
+        <a:font script="Mymr" typeface="Myanmar Text"/>
+        <a:font script="Nkoo" typeface="Ebrima"/>
+        <a:font script="Olck" typeface="Nirmala UI"/>
+        <a:font script="Osma" typeface="Ebrima"/>
+        <a:font script="Phag" typeface="Phagspa"/>
+        <a:font script="Syrn" typeface="Estrangelo Edessa"/>
+        <a:font script="Syrj" typeface="Estrangelo Edessa"/>
+        <a:font script="Syre" typeface="Estrangelo Edessa"/>
+        <a:font script="Sora" typeface="Nirmala UI"/>
+        <a:font script="Tale" typeface="Microsoft Tai Le"/>
+        <a:font script="Talu" typeface="Microsoft New Tai Lue"/>
+        <a:font script="Tfng" typeface="Ebrima"/>
       </a:majorFont>
       <a:minorFont>
-        <a:latin typeface="Calibri"/>
+        <a:latin typeface="Aptos" panose="02110004020202020204"/>
         <a:ea typeface=""/>
         <a:cs typeface=""/>
-        <a:font script="Jpan" typeface="ＭＳ Ｐゴシック"/>
+        <a:font script="Jpan" typeface="游ゴシック"/>
         <a:font script="Hang" typeface="맑은 고딕"/>
-        <a:font script="Hans" typeface="宋体"/>
+        <a:font script="Hans" typeface="等线"/>
         <a:font script="Hant" typeface="新細明體"/>
         <a:font script="Arab" typeface="Arial"/>
         <a:font script="Hebr" typeface="Arial"/>
@@ -8913,6 +9006,23 @@
         <a:font script="Viet" typeface="Arial"/>
         <a:font script="Uigh" typeface="Microsoft Uighur"/>
         <a:font script="Geor" typeface="Sylfaen"/>
+        <a:font script="Armn" typeface="Arial"/>
+        <a:font script="Bugi" typeface="Leelawadee UI"/>
+        <a:font script="Bopo" typeface="Microsoft JhengHei"/>
+        <a:font script="Java" typeface="Javanese Text"/>
+        <a:font script="Lisu" typeface="Segoe UI"/>
+        <a:font script="Mymr" typeface="Myanmar Text"/>
+        <a:font script="Nkoo" typeface="Ebrima"/>
+        <a:font script="Olck" typeface="Nirmala UI"/>
+        <a:font script="Osma" typeface="Ebrima"/>
+        <a:font script="Phag" typeface="Phagspa"/>
+        <a:font script="Syrn" typeface="Estrangelo Edessa"/>
+        <a:font script="Syrj" typeface="Estrangelo Edessa"/>
+        <a:font script="Syre" typeface="Estrangelo Edessa"/>
+        <a:font script="Sora" typeface="Nirmala UI"/>
+        <a:font script="Tale" typeface="Microsoft Tai Le"/>
+        <a:font script="Talu" typeface="Microsoft New Tai Lue"/>
+        <a:font script="Tfng" typeface="Ebrima"/>
       </a:minorFont>
     </a:fontScheme>
     <a:fmtScheme name="Office">
@@ -8924,180 +9034,136 @@
           <a:gsLst>
             <a:gs pos="0">
               <a:schemeClr val="phClr">
-                <a:tint val="50000"/>
-                <a:satMod val="300000"/>
+                <a:lumMod val="110000"/>
+                <a:satMod val="105000"/>
+                <a:tint val="67000"/>
               </a:schemeClr>
             </a:gs>
-            <a:gs pos="35000">
+            <a:gs pos="50000">
               <a:schemeClr val="phClr">
-                <a:tint val="37000"/>
-                <a:satMod val="300000"/>
+                <a:lumMod val="105000"/>
+                <a:satMod val="103000"/>
+                <a:tint val="73000"/>
               </a:schemeClr>
             </a:gs>
             <a:gs pos="100000">
               <a:schemeClr val="phClr">
-                <a:tint val="15000"/>
-                <a:satMod val="350000"/>
+                <a:lumMod val="105000"/>
+                <a:satMod val="109000"/>
+                <a:tint val="81000"/>
               </a:schemeClr>
             </a:gs>
           </a:gsLst>
-          <a:lin ang="16200000" scaled="1"/>
+          <a:lin ang="5400000" scaled="0"/>
         </a:gradFill>
         <a:gradFill rotWithShape="1">
           <a:gsLst>
             <a:gs pos="0">
               <a:schemeClr val="phClr">
-                <a:tint val="100000"/>
+                <a:satMod val="103000"/>
+                <a:lumMod val="102000"/>
+                <a:tint val="94000"/>
+              </a:schemeClr>
+            </a:gs>
+            <a:gs pos="50000">
+              <a:schemeClr val="phClr">
+                <a:satMod val="110000"/>
+                <a:lumMod val="100000"/>
                 <a:shade val="100000"/>
-                <a:satMod val="130000"/>
               </a:schemeClr>
             </a:gs>
             <a:gs pos="100000">
               <a:schemeClr val="phClr">
-                <a:tint val="50000"/>
-                <a:shade val="100000"/>
-                <a:satMod val="350000"/>
+                <a:lumMod val="99000"/>
+                <a:satMod val="120000"/>
+                <a:shade val="78000"/>
               </a:schemeClr>
             </a:gs>
           </a:gsLst>
-          <a:lin ang="16200000" scaled="0"/>
+          <a:lin ang="5400000" scaled="0"/>
         </a:gradFill>
       </a:fillStyleLst>
       <a:lnStyleLst>
-        <a:ln w="9525" cap="flat" cmpd="sng" algn="ctr">
+        <a:ln w="12700" cap="flat" cmpd="sng" algn="ctr">
           <a:solidFill>
-            <a:schemeClr val="phClr">
-              <a:shade val="95000"/>
-              <a:satMod val="105000"/>
-            </a:schemeClr>
+            <a:schemeClr val="phClr"/>
           </a:solidFill>
           <a:prstDash val="solid"/>
+          <a:miter lim="800000"/>
+        </a:ln>
+        <a:ln w="19050" cap="flat" cmpd="sng" algn="ctr">
+          <a:solidFill>
+            <a:schemeClr val="phClr"/>
+          </a:solidFill>
+          <a:prstDash val="solid"/>
+          <a:miter lim="800000"/>
         </a:ln>
         <a:ln w="25400" cap="flat" cmpd="sng" algn="ctr">
           <a:solidFill>
             <a:schemeClr val="phClr"/>
           </a:solidFill>
           <a:prstDash val="solid"/>
-        </a:ln>
-        <a:ln w="38100" cap="flat" cmpd="sng" algn="ctr">
-          <a:solidFill>
-            <a:schemeClr val="phClr"/>
-          </a:solidFill>
-          <a:prstDash val="solid"/>
+          <a:miter lim="800000"/>
         </a:ln>
       </a:lnStyleLst>
       <a:effectStyleLst>
         <a:effectStyle>
+          <a:effectLst/>
+        </a:effectStyle>
+        <a:effectStyle>
+          <a:effectLst/>
+        </a:effectStyle>
+        <a:effectStyle>
           <a:effectLst>
-            <a:outerShdw blurRad="40000" dist="20000" dir="5400000" rotWithShape="0">
+            <a:outerShdw blurRad="57150" dist="19050" dir="5400000" algn="ctr" rotWithShape="0">
               <a:srgbClr val="000000">
-                <a:alpha val="38000"/>
+                <a:alpha val="63000"/>
               </a:srgbClr>
             </a:outerShdw>
           </a:effectLst>
-        </a:effectStyle>
-        <a:effectStyle>
-          <a:effectLst>
-            <a:outerShdw blurRad="40000" dist="23000" dir="5400000" rotWithShape="0">
-              <a:srgbClr val="000000">
-                <a:alpha val="35000"/>
-              </a:srgbClr>
-            </a:outerShdw>
-          </a:effectLst>
-        </a:effectStyle>
-        <a:effectStyle>
-          <a:effectLst>
-            <a:outerShdw blurRad="40000" dist="23000" dir="5400000" rotWithShape="0">
-              <a:srgbClr val="000000">
-                <a:alpha val="35000"/>
-              </a:srgbClr>
-            </a:outerShdw>
-          </a:effectLst>
-          <a:scene3d>
-            <a:camera prst="orthographicFront">
-              <a:rot lat="0" lon="0" rev="0"/>
-            </a:camera>
-            <a:lightRig rig="threePt" dir="t">
-              <a:rot lat="0" lon="0" rev="1200000"/>
-            </a:lightRig>
-          </a:scene3d>
-          <a:sp3d>
-            <a:bevelT w="63500" h="25400"/>
-          </a:sp3d>
         </a:effectStyle>
       </a:effectStyleLst>
       <a:bgFillStyleLst>
         <a:solidFill>
           <a:schemeClr val="phClr"/>
         </a:solidFill>
+        <a:solidFill>
+          <a:schemeClr val="phClr">
+            <a:tint val="95000"/>
+            <a:satMod val="170000"/>
+          </a:schemeClr>
+        </a:solidFill>
         <a:gradFill rotWithShape="1">
           <a:gsLst>
             <a:gs pos="0">
               <a:schemeClr val="phClr">
-                <a:tint val="40000"/>
-                <a:satMod val="350000"/>
+                <a:tint val="93000"/>
+                <a:satMod val="150000"/>
+                <a:shade val="98000"/>
+                <a:lumMod val="102000"/>
               </a:schemeClr>
             </a:gs>
-            <a:gs pos="40000">
+            <a:gs pos="50000">
               <a:schemeClr val="phClr">
-                <a:tint val="45000"/>
-                <a:shade val="99000"/>
-                <a:satMod val="350000"/>
+                <a:tint val="98000"/>
+                <a:satMod val="130000"/>
+                <a:shade val="90000"/>
+                <a:lumMod val="103000"/>
               </a:schemeClr>
             </a:gs>
             <a:gs pos="100000">
               <a:schemeClr val="phClr">
-                <a:shade val="20000"/>
-                <a:satMod val="255000"/>
+                <a:shade val="63000"/>
+                <a:satMod val="120000"/>
               </a:schemeClr>
             </a:gs>
           </a:gsLst>
-          <a:path path="circle">
-            <a:fillToRect l="50000" t="-80000" r="50000" b="180000"/>
-          </a:path>
-        </a:gradFill>
-        <a:gradFill rotWithShape="1">
-          <a:gsLst>
-            <a:gs pos="0">
-              <a:schemeClr val="phClr">
-                <a:tint val="80000"/>
-                <a:satMod val="300000"/>
-              </a:schemeClr>
-            </a:gs>
-            <a:gs pos="100000">
-              <a:schemeClr val="phClr">
-                <a:shade val="30000"/>
-                <a:satMod val="200000"/>
-              </a:schemeClr>
-            </a:gs>
-          </a:gsLst>
-          <a:path path="circle">
-            <a:fillToRect l="50000" t="50000" r="50000" b="50000"/>
-          </a:path>
+          <a:lin ang="5400000" scaled="0"/>
         </a:gradFill>
       </a:bgFillStyleLst>
     </a:fmtScheme>
   </a:themeElements>
   <a:objectDefaults>
-    <a:spDef>
-      <a:spPr/>
-      <a:bodyPr/>
-      <a:lstStyle/>
-      <a:style>
-        <a:lnRef idx="1">
-          <a:schemeClr val="accent1"/>
-        </a:lnRef>
-        <a:fillRef idx="3">
-          <a:schemeClr val="accent1"/>
-        </a:fillRef>
-        <a:effectRef idx="2">
-          <a:schemeClr val="accent1"/>
-        </a:effectRef>
-        <a:fontRef idx="minor">
-          <a:schemeClr val="lt1"/>
-        </a:fontRef>
-      </a:style>
-    </a:spDef>
     <a:lnDef>
       <a:spPr/>
       <a:bodyPr/>
@@ -9119,5 +9185,10 @@
     </a:lnDef>
   </a:objectDefaults>
   <a:extraClrSchemeLst/>
+  <a:extLst>
+    <a:ext uri="{05A4C25C-085E-4340-85A3-A5531E510DB2}">
+      <thm15:themeFamily xmlns:thm15="http://schemas.microsoft.com/office/thememl/2012/main" name="Office Theme" id="{2E142A2C-CD16-42D6-873A-C26D2A0506FA}" vid="{1BDDFF52-6CD6-40A5-AB3C-68EB2F1E4D0A}"/>
+    </a:ext>
+  </a:extLst>
 </a:theme>
 </file>
</xml_diff>

<commit_message>
docs(presentation): slide 4 = three-column table incl. tail row and frozen testset
</commit_message>
<xml_diff>
--- a/docs/presentations/20260826_update_v2.pptx
+++ b/docs/presentations/20260826_update_v2.pptx
@@ -5,7 +5,7 @@
     <p:sldMasterId id="2147483648" r:id="rId1"/>
   </p:sldMasterIdLst>
   <p:notesMasterIdLst>
-    <p:notesMasterId r:id="rId17"/>
+    <p:notesMasterId r:id="rId18"/>
   </p:notesMasterIdLst>
   <p:sldIdLst>
     <p:sldId id="256" r:id="rId2"/>
@@ -13,17 +13,17 @@
     <p:sldId id="258" r:id="rId4"/>
     <p:sldId id="270" r:id="rId5"/>
     <p:sldId id="259" r:id="rId6"/>
-    <p:sldId id="271" r:id="rId22"/>
-    <p:sldId id="260" r:id="rId7"/>
-    <p:sldId id="261" r:id="rId8"/>
-    <p:sldId id="262" r:id="rId9"/>
-    <p:sldId id="263" r:id="rId10"/>
-    <p:sldId id="264" r:id="rId11"/>
-    <p:sldId id="265" r:id="rId12"/>
-    <p:sldId id="266" r:id="rId13"/>
-    <p:sldId id="267" r:id="rId14"/>
-    <p:sldId id="268" r:id="rId15"/>
-    <p:sldId id="269" r:id="rId16"/>
+    <p:sldId id="271" r:id="rId7"/>
+    <p:sldId id="260" r:id="rId8"/>
+    <p:sldId id="261" r:id="rId9"/>
+    <p:sldId id="262" r:id="rId10"/>
+    <p:sldId id="263" r:id="rId11"/>
+    <p:sldId id="264" r:id="rId12"/>
+    <p:sldId id="265" r:id="rId13"/>
+    <p:sldId id="266" r:id="rId14"/>
+    <p:sldId id="267" r:id="rId15"/>
+    <p:sldId id="268" r:id="rId16"/>
+    <p:sldId id="269" r:id="rId17"/>
   </p:sldIdLst>
   <p:sldSz cx="12192000" cy="6858000"/>
   <p:notesSz cx="6858000" cy="9144000"/>
@@ -3761,7 +3761,7 @@
               </a:defRPr>
             </a:pPr>
             <a:r>
-              <a:t>As 3 · Hoe fijn kan het?</a:t>
+              <a:t>As 3 · Resolutie: van scalar naar oeverlijn</a:t>
             </a:r>
           </a:p>
         </p:txBody>
@@ -3796,7 +3796,7 @@
               </a:defRPr>
             </a:pPr>
             <a:r>
-              <a:t>Zelfde vlak, R = 1 … 100 · en de fout op de vaste testset per R</a:t>
+              <a:t>Eén afstand per vlak verbergt dat 20 m hard erodeert en 80 m stil ligt</a:t>
             </a:r>
           </a:p>
         </p:txBody>
@@ -3831,7 +3831,7 @@
               </a:defRPr>
             </a:pPr>
             <a:r>
-              <a:t>Oevererosietool · update 26-08-2026 · 11</a:t>
+              <a:t>Oevererosietool · update 26-08-2026 · 10</a:t>
             </a:r>
           </a:p>
         </p:txBody>
@@ -3852,48 +3852,24 @@
         </p:blipFill>
         <p:spPr>
           <a:xfrm>
-            <a:off x="548640" y="1371600"/>
-            <a:ext cx="5760720" cy="3280921"/>
+            <a:off x="548640" y="1463040"/>
+            <a:ext cx="6216996" cy="4846320"/>
           </a:xfrm>
           <a:prstGeom prst="rect">
             <a:avLst/>
           </a:prstGeom>
         </p:spPr>
       </p:pic>
-      <p:pic>
-        <p:nvPicPr>
-          <p:cNvPr id="6" name="Picture 5" descr="resolution_sweep.png"/>
-          <p:cNvPicPr>
-            <a:picLocks noChangeAspect="1"/>
-          </p:cNvPicPr>
-          <p:nvPr/>
-        </p:nvPicPr>
-        <p:blipFill>
-          <a:blip r:embed="rId3"/>
-          <a:stretch>
-            <a:fillRect/>
-          </a:stretch>
-        </p:blipFill>
-        <p:spPr>
-          <a:xfrm>
-            <a:off x="6400800" y="1371600"/>
-            <a:ext cx="5577840" cy="2330016"/>
-          </a:xfrm>
-          <a:prstGeom prst="rect">
-            <a:avLst/>
-          </a:prstGeom>
-        </p:spPr>
-      </p:pic>
-      <p:sp>
-        <p:nvSpPr>
-          <p:cNvPr id="7" name="TextBox 6"/>
+      <p:sp>
+        <p:nvSpPr>
+          <p:cNvPr id="6" name="TextBox 5"/>
           <p:cNvSpPr txBox="1"/>
           <p:nvPr/>
         </p:nvSpPr>
         <p:spPr>
           <a:xfrm>
-            <a:off x="548640" y="4754880"/>
-            <a:ext cx="11430000" cy="1645920"/>
+            <a:off x="6035040" y="1554480"/>
+            <a:ext cx="5943600" cy="4754880"/>
           </a:xfrm>
           <a:prstGeom prst="rect">
             <a:avLst/>
@@ -3908,61 +3884,136 @@
           <a:p>
             <a:pPr>
               <a:spcAft>
-                <a:spcPts val="300"/>
+                <a:spcPts val="400"/>
               </a:spcAft>
-              <a:defRPr sz="1200" b="0">
+              <a:defRPr sz="1300" b="1">
                 <a:solidFill>
                   <a:srgbClr val="1F3A3D"/>
                 </a:solidFill>
               </a:defRPr>
             </a:pPr>
             <a:r>
-              <a:t>• De segment-representatie (bruin) volgt de gemeten oever vanaf R ≈ 5–10; bij R = 50–100 raken segmenten leeg (rood)</a:t>
+              <a:t>Wat je ziet</a:t>
             </a:r>
           </a:p>
           <a:p>
             <a:pPr>
               <a:spcAft>
-                <a:spcPts val="300"/>
+                <a:spcPts val="400"/>
               </a:spcAft>
-              <a:defRPr sz="1200" b="0">
+              <a:defRPr sz="1300" b="0">
                 <a:solidFill>
                   <a:srgbClr val="1F3A3D"/>
                 </a:solidFill>
               </a:defRPr>
             </a:pPr>
             <a:r>
-              <a:t>• Fout per segment daalt van 2,25 (R = 1) naar 1,88 (R = 5) en 1,61 (R = 20) — kleiner wordt nauwkeuriger, niet ruiziger</a:t>
+              <a:t>• groen = gemeten oever per segment (2026) · bruin = voorspeld 2027 per segment</a:t>
             </a:r>
           </a:p>
           <a:p>
             <a:pPr>
               <a:spcAft>
-                <a:spcPts val="300"/>
+                <a:spcPts val="400"/>
               </a:spcAft>
-              <a:defRPr sz="1200" b="0">
+              <a:defRPr sz="1300" b="0">
                 <a:solidFill>
                   <a:srgbClr val="1F3A3D"/>
                 </a:solidFill>
               </a:defRPr>
             </a:pPr>
             <a:r>
-              <a:t>• Terug-samengevoegd per vlak blijft de fout ≈ 2,1–2,2: het vlak-getal zelf heeft een vloer (0,5–1,1 m/jr representatiefout)</a:t>
+              <a:t>• gestippeld = de oude voorspelling: één getal voor het hele vlak</a:t>
             </a:r>
           </a:p>
           <a:p>
             <a:pPr>
               <a:spcAft>
-                <a:spcPts val="300"/>
+                <a:spcPts val="400"/>
               </a:spcAft>
-              <a:defRPr sz="1200" b="0">
+              <a:defRPr sz="1300" b="0">
                 <a:solidFill>
                   <a:srgbClr val="1F3A3D"/>
                 </a:solidFill>
               </a:defRPr>
             </a:pPr>
             <a:r>
-              <a:t>• Grens ligt bij de lijnbemonstering (60 punten per lijn), niet bij het model · praktisch: R = 5–10 (≈ 10–20 m)</a:t>
+              <a:t>• paars = VVR / signaleringslijn</a:t>
+            </a:r>
+          </a:p>
+          <a:p>
+            <a:pPr>
+              <a:spcAft>
+                <a:spcPts val="400"/>
+              </a:spcAft>
+              <a:defRPr sz="1300" b="1">
+                <a:solidFill>
+                  <a:srgbClr val="1F3A3D"/>
+                </a:solidFill>
+              </a:defRPr>
+            </a:pPr>
+            <a:r>
+              <a:t>Dit vlak</a:t>
+            </a:r>
+          </a:p>
+          <a:p>
+            <a:pPr>
+              <a:spcAft>
+                <a:spcPts val="400"/>
+              </a:spcAft>
+              <a:defRPr sz="1300" b="0">
+                <a:solidFill>
+                  <a:srgbClr val="1F3A3D"/>
+                </a:solidFill>
+              </a:defRPr>
+            </a:pPr>
+            <a:r>
+              <a:t>• Eén getal zegt −9,7 m/jr; de vijf segmenten lopen van −17,1 tot +1,4</a:t>
+            </a:r>
+          </a:p>
+          <a:p>
+            <a:pPr>
+              <a:spcAft>
+                <a:spcPts val="400"/>
+              </a:spcAft>
+              <a:defRPr sz="1300" b="0">
+                <a:solidFill>
+                  <a:srgbClr val="1F3A3D"/>
+                </a:solidFill>
+              </a:defRPr>
+            </a:pPr>
+            <a:r>
+              <a:t>• Het bovenste segment nadert de VVR; de rest niet — het alarm hoort per segment te kijken</a:t>
+            </a:r>
+          </a:p>
+          <a:p>
+            <a:pPr>
+              <a:spcAft>
+                <a:spcPts val="400"/>
+              </a:spcAft>
+              <a:defRPr sz="1300" b="1">
+                <a:solidFill>
+                  <a:srgbClr val="1F3A3D"/>
+                </a:solidFill>
+              </a:defRPr>
+            </a:pPr>
+            <a:r>
+              <a:t>Vandaag</a:t>
+            </a:r>
+          </a:p>
+          <a:p>
+            <a:pPr>
+              <a:spcAft>
+                <a:spcPts val="400"/>
+              </a:spcAft>
+              <a:defRPr sz="1300" b="0">
+                <a:solidFill>
+                  <a:srgbClr val="1F3A3D"/>
+                </a:solidFill>
+              </a:defRPr>
+            </a:pPr>
+            <a:r>
+              <a:t>• VVR-jaar = één drempel per vlak (het verst gelegen punt van de signaleringslijn) tegen één scalar → per definitie laat</a:t>
             </a:r>
           </a:p>
         </p:txBody>
@@ -4022,6 +4073,267 @@
               </a:defRPr>
             </a:pPr>
             <a:r>
+              <a:t>As 3 · Hoe fijn kan het?</a:t>
+            </a:r>
+          </a:p>
+        </p:txBody>
+      </p:sp>
+      <p:sp>
+        <p:nvSpPr>
+          <p:cNvPr id="3" name="TextBox 2"/>
+          <p:cNvSpPr txBox="1"/>
+          <p:nvPr/>
+        </p:nvSpPr>
+        <p:spPr>
+          <a:xfrm>
+            <a:off x="548640" y="960120"/>
+            <a:ext cx="10972800" cy="548640"/>
+          </a:xfrm>
+          <a:prstGeom prst="rect">
+            <a:avLst/>
+          </a:prstGeom>
+          <a:noFill/>
+        </p:spPr>
+        <p:txBody>
+          <a:bodyPr wrap="none">
+            <a:spAutoFit/>
+          </a:bodyPr>
+          <a:lstStyle/>
+          <a:p>
+            <a:pPr>
+              <a:defRPr sz="1700">
+                <a:solidFill>
+                  <a:srgbClr val="1F3A3D"/>
+                </a:solidFill>
+              </a:defRPr>
+            </a:pPr>
+            <a:r>
+              <a:t>Zelfde vlak, R = 1 … 100 · en de fout op de vaste testset per R</a:t>
+            </a:r>
+          </a:p>
+        </p:txBody>
+      </p:sp>
+      <p:sp>
+        <p:nvSpPr>
+          <p:cNvPr id="4" name="TextBox 3"/>
+          <p:cNvSpPr txBox="1"/>
+          <p:nvPr/>
+        </p:nvSpPr>
+        <p:spPr>
+          <a:xfrm>
+            <a:off x="548640" y="6400800"/>
+            <a:ext cx="10972800" cy="274320"/>
+          </a:xfrm>
+          <a:prstGeom prst="rect">
+            <a:avLst/>
+          </a:prstGeom>
+          <a:noFill/>
+        </p:spPr>
+        <p:txBody>
+          <a:bodyPr wrap="none">
+            <a:spAutoFit/>
+          </a:bodyPr>
+          <a:lstStyle/>
+          <a:p>
+            <a:pPr>
+              <a:defRPr sz="1000">
+                <a:solidFill>
+                  <a:srgbClr val="6B7778"/>
+                </a:solidFill>
+              </a:defRPr>
+            </a:pPr>
+            <a:r>
+              <a:t>Oevererosietool · update 26-08-2026 · 11</a:t>
+            </a:r>
+          </a:p>
+        </p:txBody>
+      </p:sp>
+      <p:pic>
+        <p:nvPicPr>
+          <p:cNvPr id="5" name="Picture 4" descr="maas3_r_8930_8940.png"/>
+          <p:cNvPicPr>
+            <a:picLocks noChangeAspect="1"/>
+          </p:cNvPicPr>
+          <p:nvPr/>
+        </p:nvPicPr>
+        <p:blipFill>
+          <a:blip r:embed="rId2"/>
+          <a:stretch>
+            <a:fillRect/>
+          </a:stretch>
+        </p:blipFill>
+        <p:spPr>
+          <a:xfrm>
+            <a:off x="548640" y="1371600"/>
+            <a:ext cx="5760720" cy="3280921"/>
+          </a:xfrm>
+          <a:prstGeom prst="rect">
+            <a:avLst/>
+          </a:prstGeom>
+        </p:spPr>
+      </p:pic>
+      <p:pic>
+        <p:nvPicPr>
+          <p:cNvPr id="6" name="Picture 5" descr="resolution_sweep.png"/>
+          <p:cNvPicPr>
+            <a:picLocks noChangeAspect="1"/>
+          </p:cNvPicPr>
+          <p:nvPr/>
+        </p:nvPicPr>
+        <p:blipFill>
+          <a:blip r:embed="rId3"/>
+          <a:stretch>
+            <a:fillRect/>
+          </a:stretch>
+        </p:blipFill>
+        <p:spPr>
+          <a:xfrm>
+            <a:off x="6400800" y="1371600"/>
+            <a:ext cx="5577840" cy="2330016"/>
+          </a:xfrm>
+          <a:prstGeom prst="rect">
+            <a:avLst/>
+          </a:prstGeom>
+        </p:spPr>
+      </p:pic>
+      <p:sp>
+        <p:nvSpPr>
+          <p:cNvPr id="7" name="TextBox 6"/>
+          <p:cNvSpPr txBox="1"/>
+          <p:nvPr/>
+        </p:nvSpPr>
+        <p:spPr>
+          <a:xfrm>
+            <a:off x="548640" y="4754880"/>
+            <a:ext cx="11430000" cy="1645920"/>
+          </a:xfrm>
+          <a:prstGeom prst="rect">
+            <a:avLst/>
+          </a:prstGeom>
+          <a:noFill/>
+        </p:spPr>
+        <p:txBody>
+          <a:bodyPr wrap="square">
+            <a:spAutoFit/>
+          </a:bodyPr>
+          <a:lstStyle/>
+          <a:p>
+            <a:pPr>
+              <a:spcAft>
+                <a:spcPts val="300"/>
+              </a:spcAft>
+              <a:defRPr sz="1200" b="0">
+                <a:solidFill>
+                  <a:srgbClr val="1F3A3D"/>
+                </a:solidFill>
+              </a:defRPr>
+            </a:pPr>
+            <a:r>
+              <a:t>• De segment-representatie (bruin) volgt de gemeten oever vanaf R ≈ 5–10; bij R = 50–100 raken segmenten leeg (rood)</a:t>
+            </a:r>
+          </a:p>
+          <a:p>
+            <a:pPr>
+              <a:spcAft>
+                <a:spcPts val="300"/>
+              </a:spcAft>
+              <a:defRPr sz="1200" b="0">
+                <a:solidFill>
+                  <a:srgbClr val="1F3A3D"/>
+                </a:solidFill>
+              </a:defRPr>
+            </a:pPr>
+            <a:r>
+              <a:t>• Fout per segment daalt van 2,25 (R = 1) naar 1,88 (R = 5) en 1,61 (R = 20) — kleiner wordt nauwkeuriger, niet ruiziger</a:t>
+            </a:r>
+          </a:p>
+          <a:p>
+            <a:pPr>
+              <a:spcAft>
+                <a:spcPts val="300"/>
+              </a:spcAft>
+              <a:defRPr sz="1200" b="0">
+                <a:solidFill>
+                  <a:srgbClr val="1F3A3D"/>
+                </a:solidFill>
+              </a:defRPr>
+            </a:pPr>
+            <a:r>
+              <a:t>• Terug-samengevoegd per vlak blijft de fout ≈ 2,1–2,2: het vlak-getal zelf heeft een vloer (0,5–1,1 m/jr representatiefout)</a:t>
+            </a:r>
+          </a:p>
+          <a:p>
+            <a:pPr>
+              <a:spcAft>
+                <a:spcPts val="300"/>
+              </a:spcAft>
+              <a:defRPr sz="1200" b="0">
+                <a:solidFill>
+                  <a:srgbClr val="1F3A3D"/>
+                </a:solidFill>
+              </a:defRPr>
+            </a:pPr>
+            <a:r>
+              <a:t>• Grens ligt bij de lijnbemonstering (60 punten per lijn), niet bij het model · praktisch: R = 5–10 (≈ 10–20 m)</a:t>
+            </a:r>
+          </a:p>
+        </p:txBody>
+      </p:sp>
+    </p:spTree>
+  </p:cSld>
+  <p:clrMapOvr>
+    <a:masterClrMapping/>
+  </p:clrMapOvr>
+</p:sld>
+</file>
+
+<file path=ppt/slides/slide12.xml><?xml version="1.0" encoding="utf-8"?>
+<p:sld xmlns:a="http://schemas.openxmlformats.org/drawingml/2006/main" xmlns:r="http://schemas.openxmlformats.org/officeDocument/2006/relationships" xmlns:p="http://schemas.openxmlformats.org/presentationml/2006/main">
+  <p:cSld>
+    <p:spTree>
+      <p:nvGrpSpPr>
+        <p:cNvPr id="1" name=""/>
+        <p:cNvGrpSpPr/>
+        <p:nvPr/>
+      </p:nvGrpSpPr>
+      <p:grpSpPr>
+        <a:xfrm>
+          <a:off x="0" y="0"/>
+          <a:ext cx="0" cy="0"/>
+          <a:chOff x="0" y="0"/>
+          <a:chExt cx="0" cy="0"/>
+        </a:xfrm>
+      </p:grpSpPr>
+      <p:sp>
+        <p:nvSpPr>
+          <p:cNvPr id="2" name="TextBox 1"/>
+          <p:cNvSpPr txBox="1"/>
+          <p:nvPr/>
+        </p:nvSpPr>
+        <p:spPr>
+          <a:xfrm>
+            <a:off x="548640" y="320040"/>
+            <a:ext cx="10972800" cy="731520"/>
+          </a:xfrm>
+          <a:prstGeom prst="rect">
+            <a:avLst/>
+          </a:prstGeom>
+          <a:noFill/>
+        </p:spPr>
+        <p:txBody>
+          <a:bodyPr wrap="none">
+            <a:spAutoFit/>
+          </a:bodyPr>
+          <a:lstStyle/>
+          <a:p>
+            <a:pPr>
+              <a:defRPr sz="3000" b="1">
+                <a:solidFill>
+                  <a:srgbClr val="2BB5A6"/>
+                </a:solidFill>
+              </a:defRPr>
+            </a:pPr>
+            <a:r>
               <a:t>Alles bij elkaar</a:t>
             </a:r>
           </a:p>
@@ -4182,7 +4494,7 @@
 </p:sld>
 </file>
 
-<file path=ppt/slides/slide12.xml><?xml version="1.0" encoding="utf-8"?>
+<file path=ppt/slides/slide13.xml><?xml version="1.0" encoding="utf-8"?>
 <p:sld xmlns:a="http://schemas.openxmlformats.org/drawingml/2006/main" xmlns:r="http://schemas.openxmlformats.org/officeDocument/2006/relationships" xmlns:p="http://schemas.openxmlformats.org/presentationml/2006/main">
   <p:cSld>
     <p:spTree>
@@ -4947,496 +5259,6 @@
 </p:sld>
 </file>
 
-<file path=ppt/slides/slide13.xml><?xml version="1.0" encoding="utf-8"?>
-<p:sld xmlns:a="http://schemas.openxmlformats.org/drawingml/2006/main" xmlns:r="http://schemas.openxmlformats.org/officeDocument/2006/relationships" xmlns:p="http://schemas.openxmlformats.org/presentationml/2006/main">
-  <p:cSld>
-    <p:spTree>
-      <p:nvGrpSpPr>
-        <p:cNvPr id="1" name=""/>
-        <p:cNvGrpSpPr/>
-        <p:nvPr/>
-      </p:nvGrpSpPr>
-      <p:grpSpPr>
-        <a:xfrm>
-          <a:off x="0" y="0"/>
-          <a:ext cx="0" cy="0"/>
-          <a:chOff x="0" y="0"/>
-          <a:chExt cx="0" cy="0"/>
-        </a:xfrm>
-      </p:grpSpPr>
-      <p:sp>
-        <p:nvSpPr>
-          <p:cNvPr id="2" name="TextBox 1"/>
-          <p:cNvSpPr txBox="1"/>
-          <p:nvPr/>
-        </p:nvSpPr>
-        <p:spPr>
-          <a:xfrm>
-            <a:off x="548640" y="320040"/>
-            <a:ext cx="10972800" cy="731520"/>
-          </a:xfrm>
-          <a:prstGeom prst="rect">
-            <a:avLst/>
-          </a:prstGeom>
-          <a:noFill/>
-        </p:spPr>
-        <p:txBody>
-          <a:bodyPr wrap="none">
-            <a:spAutoFit/>
-          </a:bodyPr>
-          <a:lstStyle/>
-          <a:p>
-            <a:pPr>
-              <a:defRPr sz="3000" b="1">
-                <a:solidFill>
-                  <a:srgbClr val="2BB5A6"/>
-                </a:solidFill>
-              </a:defRPr>
-            </a:pPr>
-            <a:r>
-              <a:t>Wat we vragen</a:t>
-            </a:r>
-          </a:p>
-        </p:txBody>
-      </p:sp>
-      <p:sp>
-        <p:nvSpPr>
-          <p:cNvPr id="3" name="TextBox 2"/>
-          <p:cNvSpPr txBox="1"/>
-          <p:nvPr/>
-        </p:nvSpPr>
-        <p:spPr>
-          <a:xfrm>
-            <a:off x="548640" y="960120"/>
-            <a:ext cx="10972800" cy="548640"/>
-          </a:xfrm>
-          <a:prstGeom prst="rect">
-            <a:avLst/>
-          </a:prstGeom>
-          <a:noFill/>
-        </p:spPr>
-        <p:txBody>
-          <a:bodyPr wrap="none">
-            <a:spAutoFit/>
-          </a:bodyPr>
-          <a:lstStyle/>
-          <a:p>
-            <a:pPr>
-              <a:defRPr sz="1700">
-                <a:solidFill>
-                  <a:srgbClr val="1F3A3D"/>
-                </a:solidFill>
-              </a:defRPr>
-            </a:pPr>
-            <a:r>
-              <a:t>Labelen is trial-and-error — geen eenmalige levering</a:t>
-            </a:r>
-          </a:p>
-        </p:txBody>
-      </p:sp>
-      <p:sp>
-        <p:nvSpPr>
-          <p:cNvPr id="4" name="TextBox 3"/>
-          <p:cNvSpPr txBox="1"/>
-          <p:nvPr/>
-        </p:nvSpPr>
-        <p:spPr>
-          <a:xfrm>
-            <a:off x="548640" y="6400800"/>
-            <a:ext cx="10972800" cy="274320"/>
-          </a:xfrm>
-          <a:prstGeom prst="rect">
-            <a:avLst/>
-          </a:prstGeom>
-          <a:noFill/>
-        </p:spPr>
-        <p:txBody>
-          <a:bodyPr wrap="none">
-            <a:spAutoFit/>
-          </a:bodyPr>
-          <a:lstStyle/>
-          <a:p>
-            <a:pPr>
-              <a:defRPr sz="1000">
-                <a:solidFill>
-                  <a:srgbClr val="6B7778"/>
-                </a:solidFill>
-              </a:defRPr>
-            </a:pPr>
-            <a:r>
-              <a:t>Oevererosietool · update 26-08-2026 · 14</a:t>
-            </a:r>
-          </a:p>
-        </p:txBody>
-      </p:sp>
-      <p:sp>
-        <p:nvSpPr>
-          <p:cNvPr id="5" name="Rectangle 4"/>
-          <p:cNvSpPr/>
-          <p:nvPr/>
-        </p:nvSpPr>
-        <p:spPr>
-          <a:xfrm>
-            <a:off x="548640" y="1645920"/>
-            <a:ext cx="3566160" cy="548640"/>
-          </a:xfrm>
-          <a:prstGeom prst="rect">
-            <a:avLst/>
-          </a:prstGeom>
-          <a:solidFill>
-            <a:srgbClr val="2BB5A6"/>
-          </a:solidFill>
-          <a:ln>
-            <a:noFill/>
-          </a:ln>
-        </p:spPr>
-        <p:style>
-          <a:lnRef idx="1">
-            <a:schemeClr val="accent1"/>
-          </a:lnRef>
-          <a:fillRef idx="3">
-            <a:schemeClr val="accent1"/>
-          </a:fillRef>
-          <a:effectRef idx="2">
-            <a:schemeClr val="accent1"/>
-          </a:effectRef>
-          <a:fontRef idx="minor">
-            <a:schemeClr val="lt1"/>
-          </a:fontRef>
-        </p:style>
-        <p:txBody>
-          <a:bodyPr rtlCol="0" anchor="ctr"/>
-          <a:lstStyle/>
-          <a:p>
-            <a:pPr algn="ctr">
-              <a:defRPr sz="1800" b="1">
-                <a:solidFill>
-                  <a:srgbClr val="FFFFFF"/>
-                </a:solidFill>
-              </a:defRPr>
-            </a:pPr>
-            <a:r>
-              <a:t>Hoogtemodel-engineers</a:t>
-            </a:r>
-          </a:p>
-        </p:txBody>
-      </p:sp>
-      <p:sp>
-        <p:nvSpPr>
-          <p:cNvPr id="6" name="TextBox 5"/>
-          <p:cNvSpPr txBox="1"/>
-          <p:nvPr/>
-        </p:nvSpPr>
-        <p:spPr>
-          <a:xfrm>
-            <a:off x="548640" y="2377440"/>
-            <a:ext cx="3566160" cy="3474720"/>
-          </a:xfrm>
-          <a:prstGeom prst="rect">
-            <a:avLst/>
-          </a:prstGeom>
-          <a:noFill/>
-        </p:spPr>
-        <p:txBody>
-          <a:bodyPr wrap="square">
-            <a:spAutoFit/>
-          </a:bodyPr>
-          <a:lstStyle/>
-          <a:p>
-            <a:pPr>
-              <a:spcAft>
-                <a:spcPts val="600"/>
-              </a:spcAft>
-              <a:defRPr sz="1500" b="0">
-                <a:solidFill>
-                  <a:srgbClr val="1F3A3D"/>
-                </a:solidFill>
-              </a:defRPr>
-            </a:pPr>
-            <a:r>
-              <a:t>• De vijfdeling (scope_coverage) meeleveren</a:t>
-            </a:r>
-          </a:p>
-          <a:p>
-            <a:pPr>
-              <a:spcAft>
-                <a:spcPts val="600"/>
-              </a:spcAft>
-              <a:defRPr sz="1500" b="0">
-                <a:solidFill>
-                  <a:srgbClr val="1F3A3D"/>
-                </a:solidFill>
-              </a:defRPr>
-            </a:pPr>
-            <a:r>
-              <a:t>• Per lijn een vlag: 'dit is een constructie / verkeerde oever'</a:t>
-            </a:r>
-          </a:p>
-          <a:p>
-            <a:pPr>
-              <a:spcAft>
-                <a:spcPts val="600"/>
-              </a:spcAft>
-              <a:defRPr sz="1500" b="0">
-                <a:solidFill>
-                  <a:srgbClr val="1F3A3D"/>
-                </a:solidFill>
-              </a:defRPr>
-            </a:pPr>
-            <a:r>
-              <a:t>• Bekende randgevallen: meeroeverig, hoogwater</a:t>
-            </a:r>
-          </a:p>
-        </p:txBody>
-      </p:sp>
-      <p:sp>
-        <p:nvSpPr>
-          <p:cNvPr id="7" name="Rectangle 6"/>
-          <p:cNvSpPr/>
-          <p:nvPr/>
-        </p:nvSpPr>
-        <p:spPr>
-          <a:xfrm>
-            <a:off x="4389120" y="1645920"/>
-            <a:ext cx="3566160" cy="548640"/>
-          </a:xfrm>
-          <a:prstGeom prst="rect">
-            <a:avLst/>
-          </a:prstGeom>
-          <a:solidFill>
-            <a:srgbClr val="2BB5A6"/>
-          </a:solidFill>
-          <a:ln>
-            <a:noFill/>
-          </a:ln>
-        </p:spPr>
-        <p:style>
-          <a:lnRef idx="1">
-            <a:schemeClr val="accent1"/>
-          </a:lnRef>
-          <a:fillRef idx="3">
-            <a:schemeClr val="accent1"/>
-          </a:fillRef>
-          <a:effectRef idx="2">
-            <a:schemeClr val="accent1"/>
-          </a:effectRef>
-          <a:fontRef idx="minor">
-            <a:schemeClr val="lt1"/>
-          </a:fontRef>
-        </p:style>
-        <p:txBody>
-          <a:bodyPr rtlCol="0" anchor="ctr"/>
-          <a:lstStyle/>
-          <a:p>
-            <a:pPr algn="ctr">
-              <a:defRPr sz="1800" b="1">
-                <a:solidFill>
-                  <a:srgbClr val="FFFFFF"/>
-                </a:solidFill>
-              </a:defRPr>
-            </a:pPr>
-            <a:r>
-              <a:t>SAM-engineers</a:t>
-            </a:r>
-          </a:p>
-        </p:txBody>
-      </p:sp>
-      <p:sp>
-        <p:nvSpPr>
-          <p:cNvPr id="8" name="TextBox 7"/>
-          <p:cNvSpPr txBox="1"/>
-          <p:nvPr/>
-        </p:nvSpPr>
-        <p:spPr>
-          <a:xfrm>
-            <a:off x="4389120" y="2377440"/>
-            <a:ext cx="3566160" cy="3474720"/>
-          </a:xfrm>
-          <a:prstGeom prst="rect">
-            <a:avLst/>
-          </a:prstGeom>
-          <a:noFill/>
-        </p:spPr>
-        <p:txBody>
-          <a:bodyPr wrap="square">
-            <a:spAutoFit/>
-          </a:bodyPr>
-          <a:lstStyle/>
-          <a:p>
-            <a:pPr>
-              <a:spcAft>
-                <a:spcPts val="600"/>
-              </a:spcAft>
-              <a:defRPr sz="1500" b="0">
-                <a:solidFill>
-                  <a:srgbClr val="1F3A3D"/>
-                </a:solidFill>
-              </a:defRPr>
-            </a:pPr>
-            <a:r>
-              <a:t>• Kwaliteitsvlag per meting</a:t>
-            </a:r>
-          </a:p>
-          <a:p>
-            <a:pPr>
-              <a:spcAft>
-                <a:spcPts val="600"/>
-              </a:spcAft>
-              <a:defRPr sz="1500" b="0">
-                <a:solidFill>
-                  <a:srgbClr val="1F3A3D"/>
-                </a:solidFill>
-              </a:defRPr>
-            </a:pPr>
-            <a:r>
-              <a:t>• Vooral: méér jaren — elk jaar maakt het model vanzelf beter</a:t>
-            </a:r>
-          </a:p>
-          <a:p>
-            <a:pPr>
-              <a:spcAft>
-                <a:spcPts val="600"/>
-              </a:spcAft>
-              <a:defRPr sz="1500" b="0">
-                <a:solidFill>
-                  <a:srgbClr val="1F3A3D"/>
-                </a:solidFill>
-              </a:defRPr>
-            </a:pPr>
-            <a:r>
-              <a:t>• Waar mogelijk: één lijn per meetmoment</a:t>
-            </a:r>
-          </a:p>
-        </p:txBody>
-      </p:sp>
-      <p:sp>
-        <p:nvSpPr>
-          <p:cNvPr id="9" name="Rectangle 8"/>
-          <p:cNvSpPr/>
-          <p:nvPr/>
-        </p:nvSpPr>
-        <p:spPr>
-          <a:xfrm>
-            <a:off x="8229600" y="1645920"/>
-            <a:ext cx="3566160" cy="548640"/>
-          </a:xfrm>
-          <a:prstGeom prst="rect">
-            <a:avLst/>
-          </a:prstGeom>
-          <a:solidFill>
-            <a:srgbClr val="E07A3F"/>
-          </a:solidFill>
-          <a:ln>
-            <a:noFill/>
-          </a:ln>
-        </p:spPr>
-        <p:style>
-          <a:lnRef idx="1">
-            <a:schemeClr val="accent1"/>
-          </a:lnRef>
-          <a:fillRef idx="3">
-            <a:schemeClr val="accent1"/>
-          </a:fillRef>
-          <a:effectRef idx="2">
-            <a:schemeClr val="accent1"/>
-          </a:effectRef>
-          <a:fontRef idx="minor">
-            <a:schemeClr val="lt1"/>
-          </a:fontRef>
-        </p:style>
-        <p:txBody>
-          <a:bodyPr rtlCol="0" anchor="ctr"/>
-          <a:lstStyle/>
-          <a:p>
-            <a:pPr algn="ctr">
-              <a:defRPr sz="1800" b="1">
-                <a:solidFill>
-                  <a:srgbClr val="FFFFFF"/>
-                </a:solidFill>
-              </a:defRPr>
-            </a:pPr>
-            <a:r>
-              <a:t>Samen</a:t>
-            </a:r>
-          </a:p>
-        </p:txBody>
-      </p:sp>
-      <p:sp>
-        <p:nvSpPr>
-          <p:cNvPr id="10" name="TextBox 9"/>
-          <p:cNvSpPr txBox="1"/>
-          <p:nvPr/>
-        </p:nvSpPr>
-        <p:spPr>
-          <a:xfrm>
-            <a:off x="8229600" y="2377440"/>
-            <a:ext cx="3566160" cy="3474720"/>
-          </a:xfrm>
-          <a:prstGeom prst="rect">
-            <a:avLst/>
-          </a:prstGeom>
-          <a:noFill/>
-        </p:spPr>
-        <p:txBody>
-          <a:bodyPr wrap="square">
-            <a:spAutoFit/>
-          </a:bodyPr>
-          <a:lstStyle/>
-          <a:p>
-            <a:pPr>
-              <a:spcAft>
-                <a:spcPts val="600"/>
-              </a:spcAft>
-              <a:defRPr sz="1500" b="0">
-                <a:solidFill>
-                  <a:srgbClr val="1F3A3D"/>
-                </a:solidFill>
-              </a:defRPr>
-            </a:pPr>
-            <a:r>
-              <a:t>• Labelronde in QGIS: wij leveren de gesorteerde lijst twijfelgevallen, jullie het oordeel</a:t>
-            </a:r>
-          </a:p>
-          <a:p>
-            <a:pPr>
-              <a:spcAft>
-                <a:spcPts val="600"/>
-              </a:spcAft>
-              <a:defRPr sz="1500" b="0">
-                <a:solidFill>
-                  <a:srgbClr val="1F3A3D"/>
-                </a:solidFill>
-              </a:defRPr>
-            </a:pPr>
-            <a:r>
-              <a:t>• Eerste ronde: ~200 vlakken, twee uur</a:t>
-            </a:r>
-          </a:p>
-          <a:p>
-            <a:pPr>
-              <a:spcAft>
-                <a:spcPts val="600"/>
-              </a:spcAft>
-              <a:defRPr sz="1500" b="0">
-                <a:solidFill>
-                  <a:srgbClr val="1F3A3D"/>
-                </a:solidFill>
-              </a:defRPr>
-            </a:pPr>
-            <a:r>
-              <a:t>• Daarna meten we opnieuw</a:t>
-            </a:r>
-          </a:p>
-        </p:txBody>
-      </p:sp>
-    </p:spTree>
-  </p:cSld>
-  <p:clrMapOvr>
-    <a:masterClrMapping/>
-  </p:clrMapOvr>
-</p:sld>
-</file>
-
 <file path=ppt/slides/slide14.xml><?xml version="1.0" encoding="utf-8"?>
 <p:sld xmlns:a="http://schemas.openxmlformats.org/drawingml/2006/main" xmlns:r="http://schemas.openxmlformats.org/officeDocument/2006/relationships" xmlns:p="http://schemas.openxmlformats.org/presentationml/2006/main">
   <p:cSld>
@@ -5484,7 +5306,7 @@
               </a:defRPr>
             </a:pPr>
             <a:r>
-              <a:t>Wat dit oplevert voor asset management</a:t>
+              <a:t>Wat we vragen</a:t>
             </a:r>
           </a:p>
         </p:txBody>
@@ -5519,7 +5341,7 @@
               </a:defRPr>
             </a:pPr>
             <a:r>
-              <a:t>Van 'dit vlak gemiddeld' naar 'deze 20 meter'</a:t>
+              <a:t>Labelen is trial-and-error — geen eenmalige levering</a:t>
             </a:r>
           </a:p>
         </p:txBody>
@@ -5554,35 +5376,63 @@
               </a:defRPr>
             </a:pPr>
             <a:r>
-              <a:t>Oevererosietool · update 26-08-2026 · 15</a:t>
-            </a:r>
-          </a:p>
-        </p:txBody>
-      </p:sp>
-      <p:pic>
-        <p:nvPicPr>
-          <p:cNvPr id="5" name="Picture 4" descr="r5_rijn_1220.png"/>
-          <p:cNvPicPr>
-            <a:picLocks noChangeAspect="1"/>
-          </p:cNvPicPr>
+              <a:t>Oevererosietool · update 26-08-2026 · 14</a:t>
+            </a:r>
+          </a:p>
+        </p:txBody>
+      </p:sp>
+      <p:sp>
+        <p:nvSpPr>
+          <p:cNvPr id="5" name="Rectangle 4"/>
+          <p:cNvSpPr/>
           <p:nvPr/>
-        </p:nvPicPr>
-        <p:blipFill>
-          <a:blip r:embed="rId2"/>
-          <a:stretch>
-            <a:fillRect/>
-          </a:stretch>
-        </p:blipFill>
-        <p:spPr>
-          <a:xfrm>
-            <a:off x="548640" y="1554480"/>
-            <a:ext cx="3388524" cy="4480560"/>
+        </p:nvSpPr>
+        <p:spPr>
+          <a:xfrm>
+            <a:off x="548640" y="1645920"/>
+            <a:ext cx="3566160" cy="548640"/>
           </a:xfrm>
           <a:prstGeom prst="rect">
             <a:avLst/>
           </a:prstGeom>
-        </p:spPr>
-      </p:pic>
+          <a:solidFill>
+            <a:srgbClr val="2BB5A6"/>
+          </a:solidFill>
+          <a:ln>
+            <a:noFill/>
+          </a:ln>
+        </p:spPr>
+        <p:style>
+          <a:lnRef idx="1">
+            <a:schemeClr val="accent1"/>
+          </a:lnRef>
+          <a:fillRef idx="3">
+            <a:schemeClr val="accent1"/>
+          </a:fillRef>
+          <a:effectRef idx="2">
+            <a:schemeClr val="accent1"/>
+          </a:effectRef>
+          <a:fontRef idx="minor">
+            <a:schemeClr val="lt1"/>
+          </a:fontRef>
+        </p:style>
+        <p:txBody>
+          <a:bodyPr rtlCol="0" anchor="ctr"/>
+          <a:lstStyle/>
+          <a:p>
+            <a:pPr algn="ctr">
+              <a:defRPr sz="1800" b="1">
+                <a:solidFill>
+                  <a:srgbClr val="FFFFFF"/>
+                </a:solidFill>
+              </a:defRPr>
+            </a:pPr>
+            <a:r>
+              <a:t>Hoogtemodel-engineers</a:t>
+            </a:r>
+          </a:p>
+        </p:txBody>
+      </p:sp>
       <p:sp>
         <p:nvSpPr>
           <p:cNvPr id="6" name="TextBox 5"/>
@@ -5591,8 +5441,8 @@
         </p:nvSpPr>
         <p:spPr>
           <a:xfrm>
-            <a:off x="5120640" y="1737360"/>
-            <a:ext cx="6858000" cy="4114800"/>
+            <a:off x="548640" y="2377440"/>
+            <a:ext cx="3566160" cy="3474720"/>
           </a:xfrm>
           <a:prstGeom prst="rect">
             <a:avLst/>
@@ -5616,7 +5466,7 @@
               </a:defRPr>
             </a:pPr>
             <a:r>
-              <a:t>• Per segment een verwachte positie ≥ 2 jaar vooruit (48.000 segmenten, 10.000 vlakken)</a:t>
+              <a:t>• De vijfdeling (scope_coverage) meeleveren</a:t>
             </a:r>
           </a:p>
           <a:p>
@@ -5631,7 +5481,7 @@
               </a:defRPr>
             </a:pPr>
             <a:r>
-              <a:t>• Een vlak kleurt rood zodra énig segment de signaleringslijn nadert — met het segment erbij</a:t>
+              <a:t>• Per lijn een vlag: 'dit is een constructie / verkeerde oever'</a:t>
             </a:r>
           </a:p>
           <a:p>
@@ -5646,9 +5496,84 @@
               </a:defRPr>
             </a:pPr>
             <a:r>
-              <a:t>• Kribvakken en meerdelige vlakken worden daarmee vanzelf goed behandeld</a:t>
-            </a:r>
-          </a:p>
+              <a:t>• Bekende randgevallen: meeroeverig, hoogwater</a:t>
+            </a:r>
+          </a:p>
+        </p:txBody>
+      </p:sp>
+      <p:sp>
+        <p:nvSpPr>
+          <p:cNvPr id="7" name="Rectangle 6"/>
+          <p:cNvSpPr/>
+          <p:nvPr/>
+        </p:nvSpPr>
+        <p:spPr>
+          <a:xfrm>
+            <a:off x="4389120" y="1645920"/>
+            <a:ext cx="3566160" cy="548640"/>
+          </a:xfrm>
+          <a:prstGeom prst="rect">
+            <a:avLst/>
+          </a:prstGeom>
+          <a:solidFill>
+            <a:srgbClr val="2BB5A6"/>
+          </a:solidFill>
+          <a:ln>
+            <a:noFill/>
+          </a:ln>
+        </p:spPr>
+        <p:style>
+          <a:lnRef idx="1">
+            <a:schemeClr val="accent1"/>
+          </a:lnRef>
+          <a:fillRef idx="3">
+            <a:schemeClr val="accent1"/>
+          </a:fillRef>
+          <a:effectRef idx="2">
+            <a:schemeClr val="accent1"/>
+          </a:effectRef>
+          <a:fontRef idx="minor">
+            <a:schemeClr val="lt1"/>
+          </a:fontRef>
+        </p:style>
+        <p:txBody>
+          <a:bodyPr rtlCol="0" anchor="ctr"/>
+          <a:lstStyle/>
+          <a:p>
+            <a:pPr algn="ctr">
+              <a:defRPr sz="1800" b="1">
+                <a:solidFill>
+                  <a:srgbClr val="FFFFFF"/>
+                </a:solidFill>
+              </a:defRPr>
+            </a:pPr>
+            <a:r>
+              <a:t>SAM-engineers</a:t>
+            </a:r>
+          </a:p>
+        </p:txBody>
+      </p:sp>
+      <p:sp>
+        <p:nvSpPr>
+          <p:cNvPr id="8" name="TextBox 7"/>
+          <p:cNvSpPr txBox="1"/>
+          <p:nvPr/>
+        </p:nvSpPr>
+        <p:spPr>
+          <a:xfrm>
+            <a:off x="4389120" y="2377440"/>
+            <a:ext cx="3566160" cy="3474720"/>
+          </a:xfrm>
+          <a:prstGeom prst="rect">
+            <a:avLst/>
+          </a:prstGeom>
+          <a:noFill/>
+        </p:spPr>
+        <p:txBody>
+          <a:bodyPr wrap="square">
+            <a:spAutoFit/>
+          </a:bodyPr>
+          <a:lstStyle/>
           <a:p>
             <a:pPr>
               <a:spcAft>
@@ -5661,7 +5586,7 @@
               </a:defRPr>
             </a:pPr>
             <a:r>
-              <a:t>• Bestaande stoplicht-kaart en tijdslider blijven; dit komt er als laag bij</a:t>
+              <a:t>• Kwaliteitsvlag per meting</a:t>
             </a:r>
           </a:p>
           <a:p>
@@ -5669,14 +5594,149 @@
               <a:spcAft>
                 <a:spcPts val="600"/>
               </a:spcAft>
-              <a:defRPr sz="1500" b="1">
+              <a:defRPr sz="1500" b="0">
                 <a:solidFill>
                   <a:srgbClr val="1F3A3D"/>
                 </a:solidFill>
               </a:defRPr>
             </a:pPr>
             <a:r>
-              <a:t>Status: segmentvoorspellingen staan klaar; koppeling aan het VVR-alarm is de volgende stap</a:t>
+              <a:t>• Vooral: méér jaren — elk jaar maakt het model vanzelf beter</a:t>
+            </a:r>
+          </a:p>
+          <a:p>
+            <a:pPr>
+              <a:spcAft>
+                <a:spcPts val="600"/>
+              </a:spcAft>
+              <a:defRPr sz="1500" b="0">
+                <a:solidFill>
+                  <a:srgbClr val="1F3A3D"/>
+                </a:solidFill>
+              </a:defRPr>
+            </a:pPr>
+            <a:r>
+              <a:t>• Waar mogelijk: één lijn per meetmoment</a:t>
+            </a:r>
+          </a:p>
+        </p:txBody>
+      </p:sp>
+      <p:sp>
+        <p:nvSpPr>
+          <p:cNvPr id="9" name="Rectangle 8"/>
+          <p:cNvSpPr/>
+          <p:nvPr/>
+        </p:nvSpPr>
+        <p:spPr>
+          <a:xfrm>
+            <a:off x="8229600" y="1645920"/>
+            <a:ext cx="3566160" cy="548640"/>
+          </a:xfrm>
+          <a:prstGeom prst="rect">
+            <a:avLst/>
+          </a:prstGeom>
+          <a:solidFill>
+            <a:srgbClr val="E07A3F"/>
+          </a:solidFill>
+          <a:ln>
+            <a:noFill/>
+          </a:ln>
+        </p:spPr>
+        <p:style>
+          <a:lnRef idx="1">
+            <a:schemeClr val="accent1"/>
+          </a:lnRef>
+          <a:fillRef idx="3">
+            <a:schemeClr val="accent1"/>
+          </a:fillRef>
+          <a:effectRef idx="2">
+            <a:schemeClr val="accent1"/>
+          </a:effectRef>
+          <a:fontRef idx="minor">
+            <a:schemeClr val="lt1"/>
+          </a:fontRef>
+        </p:style>
+        <p:txBody>
+          <a:bodyPr rtlCol="0" anchor="ctr"/>
+          <a:lstStyle/>
+          <a:p>
+            <a:pPr algn="ctr">
+              <a:defRPr sz="1800" b="1">
+                <a:solidFill>
+                  <a:srgbClr val="FFFFFF"/>
+                </a:solidFill>
+              </a:defRPr>
+            </a:pPr>
+            <a:r>
+              <a:t>Samen</a:t>
+            </a:r>
+          </a:p>
+        </p:txBody>
+      </p:sp>
+      <p:sp>
+        <p:nvSpPr>
+          <p:cNvPr id="10" name="TextBox 9"/>
+          <p:cNvSpPr txBox="1"/>
+          <p:nvPr/>
+        </p:nvSpPr>
+        <p:spPr>
+          <a:xfrm>
+            <a:off x="8229600" y="2377440"/>
+            <a:ext cx="3566160" cy="3474720"/>
+          </a:xfrm>
+          <a:prstGeom prst="rect">
+            <a:avLst/>
+          </a:prstGeom>
+          <a:noFill/>
+        </p:spPr>
+        <p:txBody>
+          <a:bodyPr wrap="square">
+            <a:spAutoFit/>
+          </a:bodyPr>
+          <a:lstStyle/>
+          <a:p>
+            <a:pPr>
+              <a:spcAft>
+                <a:spcPts val="600"/>
+              </a:spcAft>
+              <a:defRPr sz="1500" b="0">
+                <a:solidFill>
+                  <a:srgbClr val="1F3A3D"/>
+                </a:solidFill>
+              </a:defRPr>
+            </a:pPr>
+            <a:r>
+              <a:t>• Labelronde in QGIS: wij leveren de gesorteerde lijst twijfelgevallen, jullie het oordeel</a:t>
+            </a:r>
+          </a:p>
+          <a:p>
+            <a:pPr>
+              <a:spcAft>
+                <a:spcPts val="600"/>
+              </a:spcAft>
+              <a:defRPr sz="1500" b="0">
+                <a:solidFill>
+                  <a:srgbClr val="1F3A3D"/>
+                </a:solidFill>
+              </a:defRPr>
+            </a:pPr>
+            <a:r>
+              <a:t>• Eerste ronde: ~200 vlakken, twee uur</a:t>
+            </a:r>
+          </a:p>
+          <a:p>
+            <a:pPr>
+              <a:spcAft>
+                <a:spcPts val="600"/>
+              </a:spcAft>
+              <a:defRPr sz="1500" b="0">
+                <a:solidFill>
+                  <a:srgbClr val="1F3A3D"/>
+                </a:solidFill>
+              </a:defRPr>
+            </a:pPr>
+            <a:r>
+              <a:t>• Daarna meten we opnieuw</a:t>
             </a:r>
           </a:p>
         </p:txBody>
@@ -5736,7 +5796,7 @@
               </a:defRPr>
             </a:pPr>
             <a:r>
-              <a:t>Samenvattend</a:t>
+              <a:t>Wat dit oplevert voor asset management</a:t>
             </a:r>
           </a:p>
         </p:txBody>
@@ -5749,8 +5809,8 @@
         </p:nvSpPr>
         <p:spPr>
           <a:xfrm>
-            <a:off x="548640" y="6400800"/>
-            <a:ext cx="10972800" cy="274320"/>
+            <a:off x="548640" y="960120"/>
+            <a:ext cx="10972800" cy="548640"/>
           </a:xfrm>
           <a:prstGeom prst="rect">
             <a:avLst/>
@@ -5764,14 +5824,14 @@
           <a:lstStyle/>
           <a:p>
             <a:pPr>
-              <a:defRPr sz="1000">
-                <a:solidFill>
-                  <a:srgbClr val="6B7778"/>
-                </a:solidFill>
-              </a:defRPr>
-            </a:pPr>
-            <a:r>
-              <a:t>Oevererosietool · update 26-08-2026 · 16</a:t>
+              <a:defRPr sz="1700">
+                <a:solidFill>
+                  <a:srgbClr val="1F3A3D"/>
+                </a:solidFill>
+              </a:defRPr>
+            </a:pPr>
+            <a:r>
+              <a:t>Van 'dit vlak gemiddeld' naar 'deze 20 meter'</a:t>
             </a:r>
           </a:p>
         </p:txBody>
@@ -5784,8 +5844,8 @@
         </p:nvSpPr>
         <p:spPr>
           <a:xfrm>
-            <a:off x="548640" y="1463040"/>
-            <a:ext cx="10972800" cy="4754880"/>
+            <a:off x="548640" y="6400800"/>
+            <a:ext cx="10972800" cy="274320"/>
           </a:xfrm>
           <a:prstGeom prst="rect">
             <a:avLst/>
@@ -5793,223 +5853,27 @@
           <a:noFill/>
         </p:spPr>
         <p:txBody>
-          <a:bodyPr wrap="square">
+          <a:bodyPr wrap="none">
             <a:spAutoFit/>
           </a:bodyPr>
           <a:lstStyle/>
           <a:p>
             <a:pPr>
-              <a:spcAft>
-                <a:spcPts val="800"/>
-              </a:spcAft>
-              <a:defRPr sz="1800" b="1">
-                <a:solidFill>
-                  <a:srgbClr val="1F3A3D"/>
-                </a:solidFill>
-              </a:defRPr>
-            </a:pPr>
-            <a:r>
-              <a:t>Model: klaar en eerlijk gevalideerd</a:t>
-            </a:r>
-          </a:p>
-          <a:p>
-            <a:pPr>
-              <a:spcAft>
-                <a:spcPts val="800"/>
-              </a:spcAft>
-              <a:defRPr sz="1800" b="0">
-                <a:solidFill>
-                  <a:srgbClr val="1F3A3D"/>
-                </a:solidFill>
-              </a:defRPr>
-            </a:pPr>
-            <a:r>
-              <a:t>• Hybride bron, opschoonregels, historie-features, testset buiten de training</a:t>
-            </a:r>
-          </a:p>
-          <a:p>
-            <a:pPr>
-              <a:spcAft>
-                <a:spcPts val="800"/>
-              </a:spcAft>
-              <a:defRPr sz="1800" b="1">
-                <a:solidFill>
-                  <a:srgbClr val="1F3A3D"/>
-                </a:solidFill>
-              </a:defRPr>
-            </a:pPr>
-            <a:r>
-              <a:t>Van lijn naar oever</a:t>
-            </a:r>
-          </a:p>
-          <a:p>
-            <a:pPr>
-              <a:spcAft>
-                <a:spcPts val="800"/>
-              </a:spcAft>
-              <a:defRPr sz="1800" b="0">
-                <a:solidFill>
-                  <a:srgbClr val="1F3A3D"/>
-                </a:solidFill>
-              </a:defRPr>
-            </a:pPr>
-            <a:r>
-              <a:t>• Vijf segmenten per vlak; gemeten én voorspelde oever als lijn; positiefout ≈ 1 m</a:t>
-            </a:r>
-          </a:p>
-          <a:p>
-            <a:pPr>
-              <a:spcAft>
-                <a:spcPts val="800"/>
-              </a:spcAft>
-              <a:defRPr sz="1800" b="1">
-                <a:solidFill>
-                  <a:srgbClr val="1F3A3D"/>
-                </a:solidFill>
-              </a:defRPr>
-            </a:pPr>
-            <a:r>
-              <a:t>Bottleneck: gelabelde input, niet het algoritme</a:t>
-            </a:r>
-          </a:p>
-          <a:p>
-            <a:pPr>
-              <a:spcAft>
-                <a:spcPts val="800"/>
-              </a:spcAft>
-              <a:defRPr sz="1800" b="0">
-                <a:solidFill>
-                  <a:srgbClr val="1F3A3D"/>
-                </a:solidFill>
-              </a:defRPr>
-            </a:pPr>
-            <a:r>
-              <a:t>• Opschonen leverde 12× zoveel als modelleren; de regels raken op — wat overblijft vraagt een oordeel</a:t>
-            </a:r>
-          </a:p>
-          <a:p>
-            <a:pPr>
-              <a:spcAft>
-                <a:spcPts val="800"/>
-              </a:spcAft>
-              <a:defRPr sz="1800" b="1">
-                <a:solidFill>
-                  <a:srgbClr val="1F3A3D"/>
-                </a:solidFill>
-              </a:defRPr>
-            </a:pPr>
-            <a:r>
-              <a:t>Volgende stap</a:t>
-            </a:r>
-          </a:p>
-          <a:p>
-            <a:pPr>
-              <a:spcAft>
-                <a:spcPts val="800"/>
-              </a:spcAft>
-              <a:defRPr sz="1800" b="0">
-                <a:solidFill>
-                  <a:srgbClr val="1F3A3D"/>
-                </a:solidFill>
-              </a:defRPr>
-            </a:pPr>
-            <a:r>
-              <a:t>• Labelronde met SAM- en hoogtemodel-engineers · VVR-alarm op segmentniveau · daarna opnieuw meten</a:t>
-            </a:r>
-          </a:p>
-        </p:txBody>
-      </p:sp>
-    </p:spTree>
-  </p:cSld>
-  <p:clrMapOvr>
-    <a:masterClrMapping/>
-  </p:clrMapOvr>
-</p:sld>
-</file>
-
-<file path=ppt/slides/slide16.xml><?xml version="1.0" encoding="utf-8"?>
-<p:sld xmlns:a="http://schemas.openxmlformats.org/drawingml/2006/main" xmlns:p="http://schemas.openxmlformats.org/presentationml/2006/main" xmlns:r="http://schemas.openxmlformats.org/officeDocument/2006/relationships">
-  <p:cSld>
-    <p:spTree>
-      <p:nvGrpSpPr>
-        <p:cNvPr id="1" name=""/>
-        <p:cNvGrpSpPr/>
-        <p:nvPr/>
-      </p:nvGrpSpPr>
-      <p:grpSpPr/>
-      <p:sp>
-        <p:nvSpPr>
-          <p:cNvPr id="2" name="TextBox 1"/>
-          <p:cNvSpPr txBox="1"/>
-          <p:nvPr/>
-        </p:nvSpPr>
-        <p:spPr>
-          <a:xfrm>
-            <a:off x="548640" y="320040"/>
-            <a:ext cx="10972800" cy="731520"/>
-          </a:xfrm>
-          <a:prstGeom prst="rect">
-            <a:avLst/>
-          </a:prstGeom>
-          <a:noFill/>
-        </p:spPr>
-        <p:txBody>
-          <a:bodyPr wrap="square">
-            <a:spAutoFit/>
-          </a:bodyPr>
-          <a:lstStyle/>
-          <a:p>
-            <a:pPr>
-              <a:defRPr sz="3000" b="1" i="0">
-                <a:solidFill>
-                  <a:srgbClr val="2BB5A6"/>
-                </a:solidFill>
-              </a:defRPr>
-            </a:pPr>
-            <a:r>
-              <a:t>As 1 · Wat we in de SAM-lijnen tegenkomen</a:t>
-            </a:r>
-          </a:p>
-        </p:txBody>
-      </p:sp>
-      <p:sp>
-        <p:nvSpPr>
-          <p:cNvPr id="3" name="TextBox 2"/>
-          <p:cNvSpPr txBox="1"/>
-          <p:nvPr/>
-        </p:nvSpPr>
-        <p:spPr>
-          <a:xfrm>
-            <a:off x="548640" y="960120"/>
-            <a:ext cx="10972800" cy="548640"/>
-          </a:xfrm>
-          <a:prstGeom prst="rect">
-            <a:avLst/>
-          </a:prstGeom>
-          <a:noFill/>
-        </p:spPr>
-        <p:txBody>
-          <a:bodyPr wrap="square">
-            <a:spAutoFit/>
-          </a:bodyPr>
-          <a:lstStyle/>
-          <a:p>
-            <a:pPr>
-              <a:defRPr sz="1700" b="0" i="0">
-                <a:solidFill>
-                  <a:srgbClr val="1F3A3D"/>
-                </a:solidFill>
-              </a:defRPr>
-            </a:pPr>
-            <a:r>
-              <a:t>Vijf terugkerende patronen — elk een 'oever' die geen oever is</a:t>
+              <a:defRPr sz="1000">
+                <a:solidFill>
+                  <a:srgbClr val="6B7778"/>
+                </a:solidFill>
+              </a:defRPr>
+            </a:pPr>
+            <a:r>
+              <a:t>Oevererosietool · update 26-08-2026 · 15</a:t>
             </a:r>
           </a:p>
         </p:txBody>
       </p:sp>
       <p:pic>
         <p:nvPicPr>
-          <p:cNvPr id="4" name="Picture 3" descr="image.png"/>
+          <p:cNvPr id="5" name="Picture 4" descr="r5_rijn_1220.png"/>
           <p:cNvPicPr>
             <a:picLocks noChangeAspect="1"/>
           </p:cNvPicPr>
@@ -6023,8 +5887,8 @@
         </p:blipFill>
         <p:spPr>
           <a:xfrm>
-            <a:off x="274320" y="1554480"/>
-            <a:ext cx="11612880" cy="6530761"/>
+            <a:off x="548640" y="1554480"/>
+            <a:ext cx="3388524" cy="4480560"/>
           </a:xfrm>
           <a:prstGeom prst="rect">
             <a:avLst/>
@@ -6033,14 +5897,14 @@
       </p:pic>
       <p:sp>
         <p:nvSpPr>
-          <p:cNvPr id="5" name="TextBox 4"/>
+          <p:cNvPr id="6" name="TextBox 5"/>
           <p:cNvSpPr txBox="1"/>
           <p:nvPr/>
         </p:nvSpPr>
         <p:spPr>
           <a:xfrm>
-            <a:off x="548640" y="5486400"/>
-            <a:ext cx="10972800" cy="822960"/>
+            <a:off x="5120640" y="1737360"/>
+            <a:ext cx="6858000" cy="4114800"/>
           </a:xfrm>
           <a:prstGeom prst="rect">
             <a:avLst/>
@@ -6054,28 +5918,116 @@
           <a:lstStyle/>
           <a:p>
             <a:pPr>
-              <a:defRPr sz="1300" b="0" i="0">
+              <a:spcAft>
+                <a:spcPts val="600"/>
+              </a:spcAft>
+              <a:defRPr sz="1500" b="0">
                 <a:solidFill>
                   <a:srgbClr val="1F3A3D"/>
                 </a:solidFill>
               </a:defRPr>
             </a:pPr>
             <a:r>
-              <a:t>Daarnaast: nevengeulen en plassen (5,9 % van de metingen in 'normale' vlakken), fragmenten (&lt; 25 % van het vlak) en metingen die 15 m van de trend afwijken. Elk patroon = één opschoonregel; elke regel = een gok naar iets wat een mens zeker weet.</a:t>
-            </a:r>
-          </a:p>
-        </p:txBody>
-      </p:sp>
-      <p:sp>
-        <p:nvSpPr>
-          <p:cNvPr id="6" name="TextBox 5"/>
+              <a:t>• Per segment een verwachte positie ≥ 2 jaar vooruit (48.000 segmenten, 10.000 vlakken)</a:t>
+            </a:r>
+          </a:p>
+          <a:p>
+            <a:pPr>
+              <a:spcAft>
+                <a:spcPts val="600"/>
+              </a:spcAft>
+              <a:defRPr sz="1500" b="0">
+                <a:solidFill>
+                  <a:srgbClr val="1F3A3D"/>
+                </a:solidFill>
+              </a:defRPr>
+            </a:pPr>
+            <a:r>
+              <a:t>• Een vlak kleurt rood zodra énig segment de signaleringslijn nadert — met het segment erbij</a:t>
+            </a:r>
+          </a:p>
+          <a:p>
+            <a:pPr>
+              <a:spcAft>
+                <a:spcPts val="600"/>
+              </a:spcAft>
+              <a:defRPr sz="1500" b="0">
+                <a:solidFill>
+                  <a:srgbClr val="1F3A3D"/>
+                </a:solidFill>
+              </a:defRPr>
+            </a:pPr>
+            <a:r>
+              <a:t>• Kribvakken en meerdelige vlakken worden daarmee vanzelf goed behandeld</a:t>
+            </a:r>
+          </a:p>
+          <a:p>
+            <a:pPr>
+              <a:spcAft>
+                <a:spcPts val="600"/>
+              </a:spcAft>
+              <a:defRPr sz="1500" b="0">
+                <a:solidFill>
+                  <a:srgbClr val="1F3A3D"/>
+                </a:solidFill>
+              </a:defRPr>
+            </a:pPr>
+            <a:r>
+              <a:t>• Bestaande stoplicht-kaart en tijdslider blijven; dit komt er als laag bij</a:t>
+            </a:r>
+          </a:p>
+          <a:p>
+            <a:pPr>
+              <a:spcAft>
+                <a:spcPts val="600"/>
+              </a:spcAft>
+              <a:defRPr sz="1500" b="1">
+                <a:solidFill>
+                  <a:srgbClr val="1F3A3D"/>
+                </a:solidFill>
+              </a:defRPr>
+            </a:pPr>
+            <a:r>
+              <a:t>Status: segmentvoorspellingen staan klaar; koppeling aan het VVR-alarm is de volgende stap</a:t>
+            </a:r>
+          </a:p>
+        </p:txBody>
+      </p:sp>
+    </p:spTree>
+  </p:cSld>
+  <p:clrMapOvr>
+    <a:masterClrMapping/>
+  </p:clrMapOvr>
+</p:sld>
+</file>
+
+<file path=ppt/slides/slide16.xml><?xml version="1.0" encoding="utf-8"?>
+<p:sld xmlns:a="http://schemas.openxmlformats.org/drawingml/2006/main" xmlns:r="http://schemas.openxmlformats.org/officeDocument/2006/relationships" xmlns:p="http://schemas.openxmlformats.org/presentationml/2006/main">
+  <p:cSld>
+    <p:spTree>
+      <p:nvGrpSpPr>
+        <p:cNvPr id="1" name=""/>
+        <p:cNvGrpSpPr/>
+        <p:nvPr/>
+      </p:nvGrpSpPr>
+      <p:grpSpPr>
+        <a:xfrm>
+          <a:off x="0" y="0"/>
+          <a:ext cx="0" cy="0"/>
+          <a:chOff x="0" y="0"/>
+          <a:chExt cx="0" cy="0"/>
+        </a:xfrm>
+      </p:grpSpPr>
+      <p:sp>
+        <p:nvSpPr>
+          <p:cNvPr id="2" name="TextBox 1"/>
           <p:cNvSpPr txBox="1"/>
           <p:nvPr/>
         </p:nvSpPr>
         <p:spPr>
           <a:xfrm>
-            <a:off x="548640" y="6400800"/>
-            <a:ext cx="10972800" cy="274320"/>
+            <a:off x="548640" y="320040"/>
+            <a:ext cx="10972800" cy="731520"/>
           </a:xfrm>
           <a:prstGeom prst="rect">
             <a:avLst/>
@@ -6083,20 +6035,198 @@
           <a:noFill/>
         </p:spPr>
         <p:txBody>
+          <a:bodyPr wrap="none">
+            <a:spAutoFit/>
+          </a:bodyPr>
+          <a:lstStyle/>
+          <a:p>
+            <a:pPr>
+              <a:defRPr sz="3000" b="1">
+                <a:solidFill>
+                  <a:srgbClr val="2BB5A6"/>
+                </a:solidFill>
+              </a:defRPr>
+            </a:pPr>
+            <a:r>
+              <a:t>Samenvattend</a:t>
+            </a:r>
+          </a:p>
+        </p:txBody>
+      </p:sp>
+      <p:sp>
+        <p:nvSpPr>
+          <p:cNvPr id="3" name="TextBox 2"/>
+          <p:cNvSpPr txBox="1"/>
+          <p:nvPr/>
+        </p:nvSpPr>
+        <p:spPr>
+          <a:xfrm>
+            <a:off x="548640" y="6400800"/>
+            <a:ext cx="10972800" cy="274320"/>
+          </a:xfrm>
+          <a:prstGeom prst="rect">
+            <a:avLst/>
+          </a:prstGeom>
+          <a:noFill/>
+        </p:spPr>
+        <p:txBody>
+          <a:bodyPr wrap="none">
+            <a:spAutoFit/>
+          </a:bodyPr>
+          <a:lstStyle/>
+          <a:p>
+            <a:pPr>
+              <a:defRPr sz="1000">
+                <a:solidFill>
+                  <a:srgbClr val="6B7778"/>
+                </a:solidFill>
+              </a:defRPr>
+            </a:pPr>
+            <a:r>
+              <a:t>Oevererosietool · update 26-08-2026 · 16</a:t>
+            </a:r>
+          </a:p>
+        </p:txBody>
+      </p:sp>
+      <p:sp>
+        <p:nvSpPr>
+          <p:cNvPr id="4" name="TextBox 3"/>
+          <p:cNvSpPr txBox="1"/>
+          <p:nvPr/>
+        </p:nvSpPr>
+        <p:spPr>
+          <a:xfrm>
+            <a:off x="548640" y="1463040"/>
+            <a:ext cx="10972800" cy="4754880"/>
+          </a:xfrm>
+          <a:prstGeom prst="rect">
+            <a:avLst/>
+          </a:prstGeom>
+          <a:noFill/>
+        </p:spPr>
+        <p:txBody>
           <a:bodyPr wrap="square">
             <a:spAutoFit/>
           </a:bodyPr>
           <a:lstStyle/>
           <a:p>
             <a:pPr>
-              <a:defRPr sz="1000" b="0" i="0">
-                <a:solidFill>
-                  <a:srgbClr val="6B7778"/>
-                </a:solidFill>
-              </a:defRPr>
-            </a:pPr>
-            <a:r>
-              <a:t>Oevererosietool · update 26-08-2026 · 6</a:t>
+              <a:spcAft>
+                <a:spcPts val="800"/>
+              </a:spcAft>
+              <a:defRPr sz="1800" b="1">
+                <a:solidFill>
+                  <a:srgbClr val="1F3A3D"/>
+                </a:solidFill>
+              </a:defRPr>
+            </a:pPr>
+            <a:r>
+              <a:t>Model: klaar en eerlijk gevalideerd</a:t>
+            </a:r>
+          </a:p>
+          <a:p>
+            <a:pPr>
+              <a:spcAft>
+                <a:spcPts val="800"/>
+              </a:spcAft>
+              <a:defRPr sz="1800" b="0">
+                <a:solidFill>
+                  <a:srgbClr val="1F3A3D"/>
+                </a:solidFill>
+              </a:defRPr>
+            </a:pPr>
+            <a:r>
+              <a:t>• Hybride bron, opschoonregels, historie-features, testset buiten de training</a:t>
+            </a:r>
+          </a:p>
+          <a:p>
+            <a:pPr>
+              <a:spcAft>
+                <a:spcPts val="800"/>
+              </a:spcAft>
+              <a:defRPr sz="1800" b="1">
+                <a:solidFill>
+                  <a:srgbClr val="1F3A3D"/>
+                </a:solidFill>
+              </a:defRPr>
+            </a:pPr>
+            <a:r>
+              <a:t>Van lijn naar oever</a:t>
+            </a:r>
+          </a:p>
+          <a:p>
+            <a:pPr>
+              <a:spcAft>
+                <a:spcPts val="800"/>
+              </a:spcAft>
+              <a:defRPr sz="1800" b="0">
+                <a:solidFill>
+                  <a:srgbClr val="1F3A3D"/>
+                </a:solidFill>
+              </a:defRPr>
+            </a:pPr>
+            <a:r>
+              <a:t>• Vijf segmenten per vlak; gemeten én voorspelde oever als lijn; positiefout ≈ 1 m</a:t>
+            </a:r>
+          </a:p>
+          <a:p>
+            <a:pPr>
+              <a:spcAft>
+                <a:spcPts val="800"/>
+              </a:spcAft>
+              <a:defRPr sz="1800" b="1">
+                <a:solidFill>
+                  <a:srgbClr val="1F3A3D"/>
+                </a:solidFill>
+              </a:defRPr>
+            </a:pPr>
+            <a:r>
+              <a:t>Bottleneck: gelabelde input, niet het algoritme</a:t>
+            </a:r>
+          </a:p>
+          <a:p>
+            <a:pPr>
+              <a:spcAft>
+                <a:spcPts val="800"/>
+              </a:spcAft>
+              <a:defRPr sz="1800" b="0">
+                <a:solidFill>
+                  <a:srgbClr val="1F3A3D"/>
+                </a:solidFill>
+              </a:defRPr>
+            </a:pPr>
+            <a:r>
+              <a:t>• Opschonen leverde 12× zoveel als modelleren; de regels raken op — wat overblijft vraagt een oordeel</a:t>
+            </a:r>
+          </a:p>
+          <a:p>
+            <a:pPr>
+              <a:spcAft>
+                <a:spcPts val="800"/>
+              </a:spcAft>
+              <a:defRPr sz="1800" b="1">
+                <a:solidFill>
+                  <a:srgbClr val="1F3A3D"/>
+                </a:solidFill>
+              </a:defRPr>
+            </a:pPr>
+            <a:r>
+              <a:t>Volgende stap</a:t>
+            </a:r>
+          </a:p>
+          <a:p>
+            <a:pPr>
+              <a:spcAft>
+                <a:spcPts val="800"/>
+              </a:spcAft>
+              <a:defRPr sz="1800" b="0">
+                <a:solidFill>
+                  <a:srgbClr val="1F3A3D"/>
+                </a:solidFill>
+              </a:defRPr>
+            </a:pPr>
+            <a:r>
+              <a:t>• Labelronde met SAM- en hoogtemodel-engineers · VVR-alarm op segmentniveau · daarna opnieuw meten</a:t>
             </a:r>
           </a:p>
         </p:txBody>
@@ -6601,36 +6731,6 @@
           <a:chExt cx="0" cy="0"/>
         </a:xfrm>
       </p:grpSpPr>
-      <p:pic>
-        <p:nvPicPr>
-          <p:cNvPr id="5" name="Picture 4">
-            <a:extLst>
-              <a:ext uri="{FF2B5EF4-FFF2-40B4-BE49-F238E27FC236}">
-                <a16:creationId xmlns:a16="http://schemas.microsoft.com/office/drawing/2014/main" id="{0EC314E6-9497-9F41-719D-D84E6D9FC991}"/>
-              </a:ext>
-            </a:extLst>
-          </p:cNvPr>
-          <p:cNvPicPr>
-            <a:picLocks noChangeAspect="1"/>
-          </p:cNvPicPr>
-          <p:nvPr/>
-        </p:nvPicPr>
-        <p:blipFill>
-          <a:blip r:embed="rId2"/>
-          <a:stretch>
-            <a:fillRect/>
-          </a:stretch>
-        </p:blipFill>
-        <p:spPr>
-          <a:xfrm>
-            <a:off x="125259" y="1505425"/>
-            <a:ext cx="11297009" cy="3054047"/>
-          </a:xfrm>
-          <a:prstGeom prst="rect">
-            <a:avLst/>
-          </a:prstGeom>
-        </p:spPr>
-      </p:pic>
       <p:sp>
         <p:nvSpPr>
           <p:cNvPr id="6" name="TextBox 5">
@@ -6704,8 +6804,8 @@
         </p:nvSpPr>
         <p:spPr>
           <a:xfrm>
-            <a:off x="918158" y="4571996"/>
-            <a:ext cx="10042116" cy="461665"/>
+            <a:off x="548640" y="5212080"/>
+            <a:ext cx="11064240" cy="1097280"/>
           </a:xfrm>
           <a:prstGeom prst="rect">
             <a:avLst/>
@@ -6907,6 +7007,892 @@
           </a:p>
         </p:txBody>
       </p:sp>
+      <p:graphicFrame>
+        <p:nvGraphicFramePr>
+          <p:cNvPr id="9" name="Table 8"/>
+          <p:cNvGraphicFramePr>
+            <a:graphicFrameLocks noGrp="1"/>
+          </p:cNvGraphicFramePr>
+          <p:nvPr/>
+        </p:nvGraphicFramePr>
+        <p:xfrm>
+          <a:off x="548640" y="1463040"/>
+          <a:ext cx="11064240" cy="3456432"/>
+        </p:xfrm>
+        <a:graphic>
+          <a:graphicData uri="http://schemas.openxmlformats.org/drawingml/2006/table">
+            <a:tbl>
+              <a:tblPr firstRow="1" bandRow="1">
+                <a:tableStyleId>{5C22544A-7EE6-4342-B048-85BDC9FD1C3A}</a:tableStyleId>
+              </a:tblPr>
+              <a:tblGrid>
+                <a:gridCol w="4206240"/>
+                <a:gridCol w="2103120"/>
+                <a:gridCol w="2377440"/>
+                <a:gridCol w="2377440"/>
+              </a:tblGrid>
+              <a:tr h="384048">
+                <a:tc>
+                  <a:txBody>
+                    <a:bodyPr/>
+                    <a:lstStyle/>
+                    <a:p>
+                      <a:pPr>
+                        <a:defRPr sz="1300" b="1">
+                          <a:solidFill>
+                            <a:srgbClr val="1F3A3D"/>
+                          </a:solidFill>
+                        </a:defRPr>
+                      </a:pPr>
+                    </a:p>
+                  </a:txBody>
+                  <a:tcPr>
+                    <a:solidFill>
+                      <a:srgbClr val="E6F5F3"/>
+                    </a:solidFill>
+                  </a:tcPr>
+                </a:tc>
+                <a:tc>
+                  <a:txBody>
+                    <a:bodyPr/>
+                    <a:lstStyle/>
+                    <a:p>
+                      <a:pPr algn="ctr">
+                        <a:defRPr sz="1300" b="1">
+                          <a:solidFill>
+                            <a:srgbClr val="1F3A3D"/>
+                          </a:solidFill>
+                        </a:defRPr>
+                      </a:pPr>
+                      <a:r>
+                        <a:t>maart 2026</a:t>
+                      </a:r>
+                    </a:p>
+                    <a:p>
+                      <a:r>
+                        <a:t>alleen hoogtemodel</a:t>
+                      </a:r>
+                    </a:p>
+                  </a:txBody>
+                  <a:tcPr>
+                    <a:solidFill>
+                      <a:srgbClr val="E6F5F3"/>
+                    </a:solidFill>
+                  </a:tcPr>
+                </a:tc>
+                <a:tc>
+                  <a:txBody>
+                    <a:bodyPr/>
+                    <a:lstStyle/>
+                    <a:p>
+                      <a:pPr algn="ctr">
+                        <a:defRPr sz="1300" b="1">
+                          <a:solidFill>
+                            <a:srgbClr val="1F3A3D"/>
+                          </a:solidFill>
+                        </a:defRPr>
+                      </a:pPr>
+                      <a:r>
+                        <a:t>19 augustus</a:t>
+                      </a:r>
+                    </a:p>
+                    <a:p>
+                      <a:r>
+                        <a:t>hybride (SAM + hoogtemodel)</a:t>
+                      </a:r>
+                    </a:p>
+                  </a:txBody>
+                  <a:tcPr>
+                    <a:solidFill>
+                      <a:srgbClr val="E6F5F3"/>
+                    </a:solidFill>
+                  </a:tcPr>
+                </a:tc>
+                <a:tc>
+                  <a:txBody>
+                    <a:bodyPr/>
+                    <a:lstStyle/>
+                    <a:p>
+                      <a:pPr algn="ctr">
+                        <a:defRPr sz="1300" b="1">
+                          <a:solidFill>
+                            <a:srgbClr val="1F3A3D"/>
+                          </a:solidFill>
+                        </a:defRPr>
+                      </a:pPr>
+                      <a:r>
+                        <a:t>nu: uitgangspunt</a:t>
+                      </a:r>
+                    </a:p>
+                    <a:p>
+                      <a:r>
+                        <a:t>zelfde model, vaste testset</a:t>
+                      </a:r>
+                    </a:p>
+                  </a:txBody>
+                  <a:tcPr>
+                    <a:solidFill>
+                      <a:srgbClr val="E6F5F3"/>
+                    </a:solidFill>
+                  </a:tcPr>
+                </a:tc>
+              </a:tr>
+              <a:tr h="384048">
+                <a:tc>
+                  <a:txBody>
+                    <a:bodyPr/>
+                    <a:lstStyle/>
+                    <a:p>
+                      <a:pPr>
+                        <a:defRPr sz="1300" b="1">
+                          <a:solidFill>
+                            <a:srgbClr val="1F3A3D"/>
+                          </a:solidFill>
+                        </a:defRPr>
+                      </a:pPr>
+                      <a:r>
+                        <a:t>Baseline (naïef gemiddelde) — fout test (m/jr)</a:t>
+                      </a:r>
+                    </a:p>
+                  </a:txBody>
+                  <a:tcPr>
+                    <a:solidFill>
+                      <a:srgbClr val="FFFFFF"/>
+                    </a:solidFill>
+                  </a:tcPr>
+                </a:tc>
+                <a:tc>
+                  <a:txBody>
+                    <a:bodyPr/>
+                    <a:lstStyle/>
+                    <a:p>
+                      <a:pPr algn="ctr">
+                        <a:defRPr sz="1300" b="0">
+                          <a:solidFill>
+                            <a:srgbClr val="1F3A3D"/>
+                          </a:solidFill>
+                        </a:defRPr>
+                      </a:pPr>
+                      <a:r>
+                        <a:t>0,78</a:t>
+                      </a:r>
+                    </a:p>
+                  </a:txBody>
+                  <a:tcPr>
+                    <a:solidFill>
+                      <a:srgbClr val="FFFFFF"/>
+                    </a:solidFill>
+                  </a:tcPr>
+                </a:tc>
+                <a:tc>
+                  <a:txBody>
+                    <a:bodyPr/>
+                    <a:lstStyle/>
+                    <a:p>
+                      <a:pPr algn="ctr">
+                        <a:defRPr sz="1300" b="0">
+                          <a:solidFill>
+                            <a:srgbClr val="1F3A3D"/>
+                          </a:solidFill>
+                        </a:defRPr>
+                      </a:pPr>
+                      <a:r>
+                        <a:t>4,79</a:t>
+                      </a:r>
+                    </a:p>
+                  </a:txBody>
+                  <a:tcPr>
+                    <a:solidFill>
+                      <a:srgbClr val="FFFFFF"/>
+                    </a:solidFill>
+                  </a:tcPr>
+                </a:tc>
+                <a:tc>
+                  <a:txBody>
+                    <a:bodyPr/>
+                    <a:lstStyle/>
+                    <a:p>
+                      <a:pPr algn="ctr">
+                        <a:defRPr sz="1300" b="1">
+                          <a:solidFill>
+                            <a:srgbClr val="1F3A3D"/>
+                          </a:solidFill>
+                        </a:defRPr>
+                      </a:pPr>
+                      <a:r>
+                        <a:t>4,68</a:t>
+                      </a:r>
+                    </a:p>
+                  </a:txBody>
+                  <a:tcPr>
+                    <a:solidFill>
+                      <a:srgbClr val="FFF1E6"/>
+                    </a:solidFill>
+                  </a:tcPr>
+                </a:tc>
+              </a:tr>
+              <a:tr h="384048">
+                <a:tc>
+                  <a:txBody>
+                    <a:bodyPr/>
+                    <a:lstStyle/>
+                    <a:p>
+                      <a:pPr>
+                        <a:defRPr sz="1300" b="1">
+                          <a:solidFill>
+                            <a:srgbClr val="1F3A3D"/>
+                          </a:solidFill>
+                        </a:defRPr>
+                      </a:pPr>
+                      <a:r>
+                        <a:t>LightGBM — fout test (m/jr)</a:t>
+                      </a:r>
+                    </a:p>
+                  </a:txBody>
+                  <a:tcPr>
+                    <a:solidFill>
+                      <a:srgbClr val="FFFFFF"/>
+                    </a:solidFill>
+                  </a:tcPr>
+                </a:tc>
+                <a:tc>
+                  <a:txBody>
+                    <a:bodyPr/>
+                    <a:lstStyle/>
+                    <a:p>
+                      <a:pPr algn="ctr">
+                        <a:defRPr sz="1300" b="0">
+                          <a:solidFill>
+                            <a:srgbClr val="1F3A3D"/>
+                          </a:solidFill>
+                        </a:defRPr>
+                      </a:pPr>
+                      <a:r>
+                        <a:t>0,94</a:t>
+                      </a:r>
+                    </a:p>
+                  </a:txBody>
+                  <a:tcPr>
+                    <a:solidFill>
+                      <a:srgbClr val="FFFFFF"/>
+                    </a:solidFill>
+                  </a:tcPr>
+                </a:tc>
+                <a:tc>
+                  <a:txBody>
+                    <a:bodyPr/>
+                    <a:lstStyle/>
+                    <a:p>
+                      <a:pPr algn="ctr">
+                        <a:defRPr sz="1300" b="0">
+                          <a:solidFill>
+                            <a:srgbClr val="1F3A3D"/>
+                          </a:solidFill>
+                        </a:defRPr>
+                      </a:pPr>
+                      <a:r>
+                        <a:t>4,12</a:t>
+                      </a:r>
+                    </a:p>
+                  </a:txBody>
+                  <a:tcPr>
+                    <a:solidFill>
+                      <a:srgbClr val="FFFFFF"/>
+                    </a:solidFill>
+                  </a:tcPr>
+                </a:tc>
+                <a:tc>
+                  <a:txBody>
+                    <a:bodyPr/>
+                    <a:lstStyle/>
+                    <a:p>
+                      <a:pPr algn="ctr">
+                        <a:defRPr sz="1300" b="1">
+                          <a:solidFill>
+                            <a:srgbClr val="1F3A3D"/>
+                          </a:solidFill>
+                        </a:defRPr>
+                      </a:pPr>
+                      <a:r>
+                        <a:t>3,99</a:t>
+                      </a:r>
+                    </a:p>
+                  </a:txBody>
+                  <a:tcPr>
+                    <a:solidFill>
+                      <a:srgbClr val="FFF1E6"/>
+                    </a:solidFill>
+                  </a:tcPr>
+                </a:tc>
+              </a:tr>
+              <a:tr h="384048">
+                <a:tc>
+                  <a:txBody>
+                    <a:bodyPr/>
+                    <a:lstStyle/>
+                    <a:p>
+                      <a:pPr>
+                        <a:defRPr sz="1300" b="1">
+                          <a:solidFill>
+                            <a:srgbClr val="1F3A3D"/>
+                          </a:solidFill>
+                        </a:defRPr>
+                      </a:pPr>
+                      <a:r>
+                        <a:t>LightGBM t.o.v. baseline</a:t>
+                      </a:r>
+                    </a:p>
+                  </a:txBody>
+                  <a:tcPr>
+                    <a:solidFill>
+                      <a:srgbClr val="FFFFFF"/>
+                    </a:solidFill>
+                  </a:tcPr>
+                </a:tc>
+                <a:tc>
+                  <a:txBody>
+                    <a:bodyPr/>
+                    <a:lstStyle/>
+                    <a:p>
+                      <a:pPr algn="ctr">
+                        <a:defRPr sz="1300" b="0">
+                          <a:solidFill>
+                            <a:srgbClr val="1F3A3D"/>
+                          </a:solidFill>
+                        </a:defRPr>
+                      </a:pPr>
+                      <a:r>
+                        <a:t>20 % slechter</a:t>
+                      </a:r>
+                    </a:p>
+                  </a:txBody>
+                  <a:tcPr>
+                    <a:solidFill>
+                      <a:srgbClr val="FFFFFF"/>
+                    </a:solidFill>
+                  </a:tcPr>
+                </a:tc>
+                <a:tc>
+                  <a:txBody>
+                    <a:bodyPr/>
+                    <a:lstStyle/>
+                    <a:p>
+                      <a:pPr algn="ctr">
+                        <a:defRPr sz="1300" b="0">
+                          <a:solidFill>
+                            <a:srgbClr val="1F3A3D"/>
+                          </a:solidFill>
+                        </a:defRPr>
+                      </a:pPr>
+                      <a:r>
+                        <a:t>14 % beter</a:t>
+                      </a:r>
+                    </a:p>
+                  </a:txBody>
+                  <a:tcPr>
+                    <a:solidFill>
+                      <a:srgbClr val="FFFFFF"/>
+                    </a:solidFill>
+                  </a:tcPr>
+                </a:tc>
+                <a:tc>
+                  <a:txBody>
+                    <a:bodyPr/>
+                    <a:lstStyle/>
+                    <a:p>
+                      <a:pPr algn="ctr">
+                        <a:defRPr sz="1300" b="1">
+                          <a:solidFill>
+                            <a:srgbClr val="1F3A3D"/>
+                          </a:solidFill>
+                        </a:defRPr>
+                      </a:pPr>
+                      <a:r>
+                        <a:t>15 % beter</a:t>
+                      </a:r>
+                    </a:p>
+                  </a:txBody>
+                  <a:tcPr>
+                    <a:solidFill>
+                      <a:srgbClr val="FFF1E6"/>
+                    </a:solidFill>
+                  </a:tcPr>
+                </a:tc>
+              </a:tr>
+              <a:tr h="384048">
+                <a:tc>
+                  <a:txBody>
+                    <a:bodyPr/>
+                    <a:lstStyle/>
+                    <a:p>
+                      <a:pPr>
+                        <a:defRPr sz="1300" b="1">
+                          <a:solidFill>
+                            <a:srgbClr val="1F3A3D"/>
+                          </a:solidFill>
+                        </a:defRPr>
+                      </a:pPr>
+                      <a:r>
+                        <a:t>LightGBM — fout risicogevallen &gt; 2 m/jr (m/jr)</a:t>
+                      </a:r>
+                    </a:p>
+                  </a:txBody>
+                  <a:tcPr>
+                    <a:solidFill>
+                      <a:srgbClr val="FFFFFF"/>
+                    </a:solidFill>
+                  </a:tcPr>
+                </a:tc>
+                <a:tc>
+                  <a:txBody>
+                    <a:bodyPr/>
+                    <a:lstStyle/>
+                    <a:p>
+                      <a:pPr algn="ctr">
+                        <a:defRPr sz="1300" b="0">
+                          <a:solidFill>
+                            <a:srgbClr val="1F3A3D"/>
+                          </a:solidFill>
+                        </a:defRPr>
+                      </a:pPr>
+                      <a:r>
+                        <a:t>4,61</a:t>
+                      </a:r>
+                    </a:p>
+                  </a:txBody>
+                  <a:tcPr>
+                    <a:solidFill>
+                      <a:srgbClr val="FFFFFF"/>
+                    </a:solidFill>
+                  </a:tcPr>
+                </a:tc>
+                <a:tc>
+                  <a:txBody>
+                    <a:bodyPr/>
+                    <a:lstStyle/>
+                    <a:p>
+                      <a:pPr algn="ctr">
+                        <a:defRPr sz="1300" b="0">
+                          <a:solidFill>
+                            <a:srgbClr val="1F3A3D"/>
+                          </a:solidFill>
+                        </a:defRPr>
+                      </a:pPr>
+                      <a:r>
+                        <a:t>9,13</a:t>
+                      </a:r>
+                    </a:p>
+                  </a:txBody>
+                  <a:tcPr>
+                    <a:solidFill>
+                      <a:srgbClr val="FFFFFF"/>
+                    </a:solidFill>
+                  </a:tcPr>
+                </a:tc>
+                <a:tc>
+                  <a:txBody>
+                    <a:bodyPr/>
+                    <a:lstStyle/>
+                    <a:p>
+                      <a:pPr algn="ctr">
+                        <a:defRPr sz="1300" b="1">
+                          <a:solidFill>
+                            <a:srgbClr val="1F3A3D"/>
+                          </a:solidFill>
+                        </a:defRPr>
+                      </a:pPr>
+                      <a:r>
+                        <a:t>8,30</a:t>
+                      </a:r>
+                    </a:p>
+                  </a:txBody>
+                  <a:tcPr>
+                    <a:solidFill>
+                      <a:srgbClr val="FFF1E6"/>
+                    </a:solidFill>
+                  </a:tcPr>
+                </a:tc>
+              </a:tr>
+              <a:tr h="384048">
+                <a:tc>
+                  <a:txBody>
+                    <a:bodyPr/>
+                    <a:lstStyle/>
+                    <a:p>
+                      <a:pPr>
+                        <a:defRPr sz="1300" b="1">
+                          <a:solidFill>
+                            <a:srgbClr val="1F3A3D"/>
+                          </a:solidFill>
+                        </a:defRPr>
+                      </a:pPr>
+                      <a:r>
+                        <a:t>Spreiding doelvariabele v_test (m/jr)</a:t>
+                      </a:r>
+                    </a:p>
+                  </a:txBody>
+                  <a:tcPr>
+                    <a:solidFill>
+                      <a:srgbClr val="FFFFFF"/>
+                    </a:solidFill>
+                  </a:tcPr>
+                </a:tc>
+                <a:tc>
+                  <a:txBody>
+                    <a:bodyPr/>
+                    <a:lstStyle/>
+                    <a:p>
+                      <a:pPr algn="ctr">
+                        <a:defRPr sz="1300" b="0">
+                          <a:solidFill>
+                            <a:srgbClr val="1F3A3D"/>
+                          </a:solidFill>
+                        </a:defRPr>
+                      </a:pPr>
+                      <a:r>
+                        <a:t>2,2</a:t>
+                      </a:r>
+                    </a:p>
+                  </a:txBody>
+                  <a:tcPr>
+                    <a:solidFill>
+                      <a:srgbClr val="FFFFFF"/>
+                    </a:solidFill>
+                  </a:tcPr>
+                </a:tc>
+                <a:tc>
+                  <a:txBody>
+                    <a:bodyPr/>
+                    <a:lstStyle/>
+                    <a:p>
+                      <a:pPr algn="ctr">
+                        <a:defRPr sz="1300" b="0">
+                          <a:solidFill>
+                            <a:srgbClr val="1F3A3D"/>
+                          </a:solidFill>
+                        </a:defRPr>
+                      </a:pPr>
+                      <a:r>
+                        <a:t>11,4</a:t>
+                      </a:r>
+                    </a:p>
+                  </a:txBody>
+                  <a:tcPr>
+                    <a:solidFill>
+                      <a:srgbClr val="FFFFFF"/>
+                    </a:solidFill>
+                  </a:tcPr>
+                </a:tc>
+                <a:tc>
+                  <a:txBody>
+                    <a:bodyPr/>
+                    <a:lstStyle/>
+                    <a:p>
+                      <a:pPr algn="ctr">
+                        <a:defRPr sz="1300" b="1">
+                          <a:solidFill>
+                            <a:srgbClr val="1F3A3D"/>
+                          </a:solidFill>
+                        </a:defRPr>
+                      </a:pPr>
+                      <a:r>
+                        <a:t>9,2</a:t>
+                      </a:r>
+                    </a:p>
+                  </a:txBody>
+                  <a:tcPr>
+                    <a:solidFill>
+                      <a:srgbClr val="FFF1E6"/>
+                    </a:solidFill>
+                  </a:tcPr>
+                </a:tc>
+              </a:tr>
+              <a:tr h="384048">
+                <a:tc>
+                  <a:txBody>
+                    <a:bodyPr/>
+                    <a:lstStyle/>
+                    <a:p>
+                      <a:pPr>
+                        <a:defRPr sz="1300" b="1">
+                          <a:solidFill>
+                            <a:srgbClr val="1F3A3D"/>
+                          </a:solidFill>
+                        </a:defRPr>
+                      </a:pPr>
+                      <a:r>
+                        <a:t>Tijd tussen t-punten</a:t>
+                      </a:r>
+                    </a:p>
+                  </a:txBody>
+                  <a:tcPr>
+                    <a:solidFill>
+                      <a:srgbClr val="FFFFFF"/>
+                    </a:solidFill>
+                  </a:tcPr>
+                </a:tc>
+                <a:tc>
+                  <a:txBody>
+                    <a:bodyPr/>
+                    <a:lstStyle/>
+                    <a:p>
+                      <a:pPr algn="ctr">
+                        <a:defRPr sz="1300" b="0">
+                          <a:solidFill>
+                            <a:srgbClr val="1F3A3D"/>
+                          </a:solidFill>
+                        </a:defRPr>
+                      </a:pPr>
+                      <a:r>
+                        <a:t>3–4 jaar</a:t>
+                      </a:r>
+                    </a:p>
+                  </a:txBody>
+                  <a:tcPr>
+                    <a:solidFill>
+                      <a:srgbClr val="FFFFFF"/>
+                    </a:solidFill>
+                  </a:tcPr>
+                </a:tc>
+                <a:tc>
+                  <a:txBody>
+                    <a:bodyPr/>
+                    <a:lstStyle/>
+                    <a:p>
+                      <a:pPr algn="ctr">
+                        <a:defRPr sz="1300" b="0">
+                          <a:solidFill>
+                            <a:srgbClr val="1F3A3D"/>
+                          </a:solidFill>
+                        </a:defRPr>
+                      </a:pPr>
+                      <a:r>
+                        <a:t>1 jaar</a:t>
+                      </a:r>
+                    </a:p>
+                  </a:txBody>
+                  <a:tcPr>
+                    <a:solidFill>
+                      <a:srgbClr val="FFFFFF"/>
+                    </a:solidFill>
+                  </a:tcPr>
+                </a:tc>
+                <a:tc>
+                  <a:txBody>
+                    <a:bodyPr/>
+                    <a:lstStyle/>
+                    <a:p>
+                      <a:pPr algn="ctr">
+                        <a:defRPr sz="1300" b="1">
+                          <a:solidFill>
+                            <a:srgbClr val="1F3A3D"/>
+                          </a:solidFill>
+                        </a:defRPr>
+                      </a:pPr>
+                      <a:r>
+                        <a:t>1 jaar</a:t>
+                      </a:r>
+                    </a:p>
+                  </a:txBody>
+                  <a:tcPr>
+                    <a:solidFill>
+                      <a:srgbClr val="FFF1E6"/>
+                    </a:solidFill>
+                  </a:tcPr>
+                </a:tc>
+              </a:tr>
+              <a:tr h="384048">
+                <a:tc>
+                  <a:txBody>
+                    <a:bodyPr/>
+                    <a:lstStyle/>
+                    <a:p>
+                      <a:pPr>
+                        <a:defRPr sz="1300" b="1">
+                          <a:solidFill>
+                            <a:srgbClr val="1F3A3D"/>
+                          </a:solidFill>
+                        </a:defRPr>
+                      </a:pPr>
+                      <a:r>
+                        <a:t>Testset</a:t>
+                      </a:r>
+                    </a:p>
+                  </a:txBody>
+                  <a:tcPr>
+                    <a:solidFill>
+                      <a:srgbClr val="FFFFFF"/>
+                    </a:solidFill>
+                  </a:tcPr>
+                </a:tc>
+                <a:tc>
+                  <a:txBody>
+                    <a:bodyPr/>
+                    <a:lstStyle/>
+                    <a:p>
+                      <a:pPr algn="ctr">
+                        <a:defRPr sz="1300" b="0">
+                          <a:solidFill>
+                            <a:srgbClr val="1F3A3D"/>
+                          </a:solidFill>
+                        </a:defRPr>
+                      </a:pPr>
+                      <a:r>
+                        <a:t>willekeurig 20 %</a:t>
+                      </a:r>
+                    </a:p>
+                  </a:txBody>
+                  <a:tcPr>
+                    <a:solidFill>
+                      <a:srgbClr val="FFFFFF"/>
+                    </a:solidFill>
+                  </a:tcPr>
+                </a:tc>
+                <a:tc>
+                  <a:txBody>
+                    <a:bodyPr/>
+                    <a:lstStyle/>
+                    <a:p>
+                      <a:pPr algn="ctr">
+                        <a:defRPr sz="1300" b="0">
+                          <a:solidFill>
+                            <a:srgbClr val="1F3A3D"/>
+                          </a:solidFill>
+                        </a:defRPr>
+                      </a:pPr>
+                      <a:r>
+                        <a:t>willekeurig 20 %</a:t>
+                      </a:r>
+                    </a:p>
+                  </a:txBody>
+                  <a:tcPr>
+                    <a:solidFill>
+                      <a:srgbClr val="FFFFFF"/>
+                    </a:solidFill>
+                  </a:tcPr>
+                </a:tc>
+                <a:tc>
+                  <a:txBody>
+                    <a:bodyPr/>
+                    <a:lstStyle/>
+                    <a:p>
+                      <a:pPr algn="ctr">
+                        <a:defRPr sz="1300" b="1">
+                          <a:solidFill>
+                            <a:srgbClr val="1F3A3D"/>
+                          </a:solidFill>
+                        </a:defRPr>
+                      </a:pPr>
+                      <a:r>
+                        <a:t>vast · 1.174 vlakken</a:t>
+                      </a:r>
+                    </a:p>
+                  </a:txBody>
+                  <a:tcPr>
+                    <a:solidFill>
+                      <a:srgbClr val="FFF1E6"/>
+                    </a:solidFill>
+                  </a:tcPr>
+                </a:tc>
+              </a:tr>
+              <a:tr h="384048">
+                <a:tc>
+                  <a:txBody>
+                    <a:bodyPr/>
+                    <a:lstStyle/>
+                    <a:p>
+                      <a:pPr>
+                        <a:defRPr sz="1300" b="1">
+                          <a:solidFill>
+                            <a:srgbClr val="1F3A3D"/>
+                          </a:solidFill>
+                        </a:defRPr>
+                      </a:pPr>
+                      <a:r>
+                        <a:t>Regio's met voorspellingen</a:t>
+                      </a:r>
+                    </a:p>
+                  </a:txBody>
+                  <a:tcPr>
+                    <a:solidFill>
+                      <a:srgbClr val="FFFFFF"/>
+                    </a:solidFill>
+                  </a:tcPr>
+                </a:tc>
+                <a:tc>
+                  <a:txBody>
+                    <a:bodyPr/>
+                    <a:lstStyle/>
+                    <a:p>
+                      <a:pPr algn="ctr">
+                        <a:defRPr sz="1300" b="0">
+                          <a:solidFill>
+                            <a:srgbClr val="1F3A3D"/>
+                          </a:solidFill>
+                        </a:defRPr>
+                      </a:pPr>
+                      <a:r>
+                        <a:t>7.444</a:t>
+                      </a:r>
+                    </a:p>
+                  </a:txBody>
+                  <a:tcPr>
+                    <a:solidFill>
+                      <a:srgbClr val="FFFFFF"/>
+                    </a:solidFill>
+                  </a:tcPr>
+                </a:tc>
+                <a:tc>
+                  <a:txBody>
+                    <a:bodyPr/>
+                    <a:lstStyle/>
+                    <a:p>
+                      <a:pPr algn="ctr">
+                        <a:defRPr sz="1300" b="0">
+                          <a:solidFill>
+                            <a:srgbClr val="1F3A3D"/>
+                          </a:solidFill>
+                        </a:defRPr>
+                      </a:pPr>
+                      <a:r>
+                        <a:t>8.006</a:t>
+                      </a:r>
+                    </a:p>
+                  </a:txBody>
+                  <a:tcPr>
+                    <a:solidFill>
+                      <a:srgbClr val="FFFFFF"/>
+                    </a:solidFill>
+                  </a:tcPr>
+                </a:tc>
+                <a:tc>
+                  <a:txBody>
+                    <a:bodyPr/>
+                    <a:lstStyle/>
+                    <a:p>
+                      <a:pPr algn="ctr">
+                        <a:defRPr sz="1300" b="1">
+                          <a:solidFill>
+                            <a:srgbClr val="1F3A3D"/>
+                          </a:solidFill>
+                        </a:defRPr>
+                      </a:pPr>
+                      <a:r>
+                        <a:t>10.437</a:t>
+                      </a:r>
+                    </a:p>
+                  </a:txBody>
+                  <a:tcPr>
+                    <a:solidFill>
+                      <a:srgbClr val="FFF1E6"/>
+                    </a:solidFill>
+                  </a:tcPr>
+                </a:tc>
+              </a:tr>
+            </a:tbl>
+          </a:graphicData>
+        </a:graphic>
+      </p:graphicFrame>
     </p:spTree>
     <p:extLst>
       <p:ext uri="{BB962C8B-B14F-4D97-AF65-F5344CB8AC3E}">
@@ -7460,20 +8446,20 @@
           <a:noFill/>
         </p:spPr>
         <p:txBody>
-          <a:bodyPr wrap="none">
+          <a:bodyPr wrap="square">
             <a:spAutoFit/>
           </a:bodyPr>
           <a:lstStyle/>
           <a:p>
             <a:pPr>
-              <a:defRPr sz="3000" b="1">
+              <a:defRPr sz="3000" b="1" i="0">
                 <a:solidFill>
                   <a:srgbClr val="2BB5A6"/>
                 </a:solidFill>
               </a:defRPr>
             </a:pPr>
             <a:r>
-              <a:t>As 1 · Opschonen: van 3,99 naar 2,27 op de vaste testset</a:t>
+              <a:t>As 1 · Wat we in de SAM-lijnen tegenkomen</a:t>
             </a:r>
           </a:p>
         </p:txBody>
@@ -7495,130 +8481,27 @@
           <a:noFill/>
         </p:spPr>
         <p:txBody>
-          <a:bodyPr wrap="none">
-            <a:spAutoFit/>
-          </a:bodyPr>
-          <a:lstStyle/>
-          <a:p>
-            <a:pPr>
-              <a:defRPr sz="1700">
-                <a:solidFill>
-                  <a:srgbClr val="1F3A3D"/>
-                </a:solidFill>
-              </a:defRPr>
-            </a:pPr>
-            <a:r>
-              <a:t>Zeven regels — herstellen in plaats van weggooien</a:t>
-            </a:r>
-          </a:p>
-        </p:txBody>
-      </p:sp>
-      <p:sp>
-        <p:nvSpPr>
-          <p:cNvPr id="4" name="TextBox 3"/>
-          <p:cNvSpPr txBox="1"/>
-          <p:nvPr/>
-        </p:nvSpPr>
-        <p:spPr>
-          <a:xfrm>
-            <a:off x="548640" y="6400800"/>
-            <a:ext cx="10972800" cy="274320"/>
-          </a:xfrm>
-          <a:prstGeom prst="rect">
-            <a:avLst/>
-          </a:prstGeom>
-          <a:noFill/>
-        </p:spPr>
-        <p:txBody>
-          <a:bodyPr wrap="none">
-            <a:spAutoFit/>
-          </a:bodyPr>
-          <a:lstStyle/>
-          <a:p>
-            <a:pPr>
-              <a:defRPr sz="1000">
-                <a:solidFill>
-                  <a:srgbClr val="6B7778"/>
-                </a:solidFill>
-              </a:defRPr>
-            </a:pPr>
-            <a:r>
-              <a:t>Oevererosietool · update 26-08-2026 · 7</a:t>
-            </a:r>
-          </a:p>
-        </p:txBody>
-      </p:sp>
-      <p:sp>
-        <p:nvSpPr>
-          <p:cNvPr id="7" name="TextBox 6"/>
-          <p:cNvSpPr txBox="1"/>
-          <p:nvPr/>
-        </p:nvSpPr>
-        <p:spPr>
-          <a:xfrm>
-            <a:off x="548640" y="4572000"/>
-            <a:ext cx="6949440" cy="1737360"/>
-          </a:xfrm>
-          <a:prstGeom prst="rect">
-            <a:avLst/>
-          </a:prstGeom>
-          <a:noFill/>
-        </p:spPr>
-        <p:txBody>
           <a:bodyPr wrap="square">
             <a:spAutoFit/>
           </a:bodyPr>
           <a:lstStyle/>
           <a:p>
             <a:pPr>
-              <a:spcAft>
-                <a:spcPts val="400"/>
-              </a:spcAft>
-              <a:defRPr sz="1300" b="0">
+              <a:defRPr sz="1700" b="0" i="0">
                 <a:solidFill>
                   <a:srgbClr val="1F3A3D"/>
                 </a:solidFill>
               </a:defRPr>
             </a:pPr>
             <a:r>
-              <a:t>• Kronkelende lijnen, verkeerde oever, doolhoven, fragmenten, te weinig punten, uitschieters t.o.v. de trend</a:t>
-            </a:r>
-          </a:p>
-          <a:p>
-            <a:pPr>
-              <a:spcAft>
-                <a:spcPts val="400"/>
-              </a:spcAft>
-              <a:defRPr sz="1300" b="0">
-                <a:solidFill>
-                  <a:srgbClr val="1F3A3D"/>
-                </a:solidFill>
-              </a:defRPr>
-            </a:pPr>
-            <a:r>
-              <a:t>• Een uitschieter kost één meting, niet het hele vlak: +511 vlakken t.o.v. de oude |v| &gt; 50-filter</a:t>
-            </a:r>
-          </a:p>
-          <a:p>
-            <a:pPr>
-              <a:spcAft>
-                <a:spcPts val="400"/>
-              </a:spcAft>
-              <a:defRPr sz="1300" b="0">
-                <a:solidFill>
-                  <a:srgbClr val="1F3A3D"/>
-                </a:solidFill>
-              </a:defRPr>
-            </a:pPr>
-            <a:r>
-              <a:t>• Elke variant visueel gecontroleerd (50+ varianten, dekking blijft 0,94)</a:t>
+              <a:t>Vijf terugkerende patronen — elk een 'oever' die geen oever is</a:t>
             </a:r>
           </a:p>
         </p:txBody>
       </p:sp>
       <p:pic>
         <p:nvPicPr>
-          <p:cNvPr id="8" name="Picture 7" descr="image.png"/>
+          <p:cNvPr id="4" name="Picture 3" descr="image.png"/>
           <p:cNvPicPr>
             <a:picLocks noChangeAspect="1"/>
           </p:cNvPicPr>
@@ -7626,14 +8509,15 @@
         </p:nvPicPr>
         <p:blipFill>
           <a:blip r:embed="rId2"/>
+          <a:srcRect t="20030"/>
           <a:stretch>
             <a:fillRect/>
           </a:stretch>
         </p:blipFill>
         <p:spPr>
           <a:xfrm>
-            <a:off x="548640" y="1463040"/>
-            <a:ext cx="8686800" cy="3628713"/>
+            <a:off x="289560" y="1993900"/>
+            <a:ext cx="11612880" cy="5222661"/>
           </a:xfrm>
           <a:prstGeom prst="rect">
             <a:avLst/>
@@ -7642,14 +8526,14 @@
       </p:pic>
       <p:sp>
         <p:nvSpPr>
-          <p:cNvPr id="9" name="TextBox 8"/>
+          <p:cNvPr id="5" name="TextBox 4"/>
           <p:cNvSpPr txBox="1"/>
           <p:nvPr/>
         </p:nvSpPr>
         <p:spPr>
           <a:xfrm>
-            <a:off x="9418320" y="1554480"/>
-            <a:ext cx="2560320" cy="3200400"/>
+            <a:off x="548640" y="5486400"/>
+            <a:ext cx="10972800" cy="822960"/>
           </a:xfrm>
           <a:prstGeom prst="rect">
             <a:avLst/>
@@ -7663,14 +8547,49 @@
           <a:lstStyle/>
           <a:p>
             <a:pPr>
-              <a:defRPr sz="1100" b="0" i="1">
+              <a:defRPr sz="1300" b="0" i="0">
+                <a:solidFill>
+                  <a:srgbClr val="1F3A3D"/>
+                </a:solidFill>
+              </a:defRPr>
+            </a:pPr>
+            <a:r>
+              <a:t>Daarnaast: nevengeulen en plassen (5,9 % van de metingen in 'normale' vlakken), fragmenten (&lt; 25 % van het vlak) en metingen die 15 m van de trend afwijken. Elk patroon = één opschoonregel; elke regel = een gok naar iets wat een mens zeker weet.</a:t>
+            </a:r>
+          </a:p>
+        </p:txBody>
+      </p:sp>
+      <p:sp>
+        <p:nvSpPr>
+          <p:cNvPr id="6" name="TextBox 5"/>
+          <p:cNvSpPr txBox="1"/>
+          <p:nvPr/>
+        </p:nvSpPr>
+        <p:spPr>
+          <a:xfrm>
+            <a:off x="548640" y="6400800"/>
+            <a:ext cx="10972800" cy="274320"/>
+          </a:xfrm>
+          <a:prstGeom prst="rect">
+            <a:avLst/>
+          </a:prstGeom>
+          <a:noFill/>
+        </p:spPr>
+        <p:txBody>
+          <a:bodyPr wrap="square">
+            <a:spAutoFit/>
+          </a:bodyPr>
+          <a:lstStyle/>
+          <a:p>
+            <a:pPr>
+              <a:defRPr sz="1000" b="0" i="0">
                 <a:solidFill>
                   <a:srgbClr val="6B7778"/>
                 </a:solidFill>
               </a:defRPr>
             </a:pPr>
             <a:r>
-              <a:t>Leeswijzer: 4,12 was de score van het 19 aug-model op zijn eigen willekeurige train/test-splitsing. Voor het experiment is één vaste testset van 1.174 vlakken bevroren zodat 50+ varianten vergelijkbaar zijn; datzelfde model scoort daarop 3,99. Alle stappen hierna zijn op deze set gemeten.</a:t>
+              <a:t>Oevererosietool · update 26-08-2026 · 6</a:t>
             </a:r>
           </a:p>
         </p:txBody>
@@ -7730,7 +8649,7 @@
               </a:defRPr>
             </a:pPr>
             <a:r>
-              <a:t>As 1 · Kribben en kunstwerken: nu een laag, geen gok meer</a:t>
+              <a:t>As 1 · Opschonen: van 3,99 naar 2,27 op de vaste testset</a:t>
             </a:r>
           </a:p>
         </p:txBody>
@@ -7765,7 +8684,7 @@
               </a:defRPr>
             </a:pPr>
             <a:r>
-              <a:t>Deze week geleverd: kribben landelijk (1.922 → 4.698) + 6.386 kunstwerken</a:t>
+              <a:t>Zeven regels — herstellen in plaats van weggooien</a:t>
             </a:r>
           </a:p>
         </p:txBody>
@@ -7800,14 +8719,82 @@
               </a:defRPr>
             </a:pPr>
             <a:r>
-              <a:t>Oevererosietool · update 26-08-2026 · 8</a:t>
+              <a:t>Oevererosietool · update 26-08-2026 · 7</a:t>
+            </a:r>
+          </a:p>
+        </p:txBody>
+      </p:sp>
+      <p:sp>
+        <p:nvSpPr>
+          <p:cNvPr id="7" name="TextBox 6"/>
+          <p:cNvSpPr txBox="1"/>
+          <p:nvPr/>
+        </p:nvSpPr>
+        <p:spPr>
+          <a:xfrm>
+            <a:off x="548640" y="4572000"/>
+            <a:ext cx="6949440" cy="1737360"/>
+          </a:xfrm>
+          <a:prstGeom prst="rect">
+            <a:avLst/>
+          </a:prstGeom>
+          <a:noFill/>
+        </p:spPr>
+        <p:txBody>
+          <a:bodyPr wrap="square">
+            <a:spAutoFit/>
+          </a:bodyPr>
+          <a:lstStyle/>
+          <a:p>
+            <a:pPr>
+              <a:spcAft>
+                <a:spcPts val="400"/>
+              </a:spcAft>
+              <a:defRPr sz="1300" b="0">
+                <a:solidFill>
+                  <a:srgbClr val="1F3A3D"/>
+                </a:solidFill>
+              </a:defRPr>
+            </a:pPr>
+            <a:r>
+              <a:t>• Kronkelende lijnen, verkeerde oever, doolhoven, fragmenten, te weinig punten, uitschieters t.o.v. de trend</a:t>
+            </a:r>
+          </a:p>
+          <a:p>
+            <a:pPr>
+              <a:spcAft>
+                <a:spcPts val="400"/>
+              </a:spcAft>
+              <a:defRPr sz="1300" b="0">
+                <a:solidFill>
+                  <a:srgbClr val="1F3A3D"/>
+                </a:solidFill>
+              </a:defRPr>
+            </a:pPr>
+            <a:r>
+              <a:t>• Een uitschieter kost één meting, niet het hele vlak: +511 vlakken t.o.v. de oude |v| &gt; 50-filter</a:t>
+            </a:r>
+          </a:p>
+          <a:p>
+            <a:pPr>
+              <a:spcAft>
+                <a:spcPts val="400"/>
+              </a:spcAft>
+              <a:defRPr sz="1300" b="0">
+                <a:solidFill>
+                  <a:srgbClr val="1F3A3D"/>
+                </a:solidFill>
+              </a:defRPr>
+            </a:pPr>
+            <a:r>
+              <a:t>• Elke variant visueel gecontroleerd (50+ varianten, dekking blijft 0,94)</a:t>
             </a:r>
           </a:p>
         </p:txBody>
       </p:sp>
       <p:pic>
         <p:nvPicPr>
-          <p:cNvPr id="5" name="Picture 4" descr="nederrijn_r_4780_4790.png"/>
+          <p:cNvPr id="8" name="Picture 7" descr="image.png"/>
           <p:cNvPicPr>
             <a:picLocks noChangeAspect="1"/>
           </p:cNvPicPr>
@@ -7822,47 +8809,23 @@
         <p:spPr>
           <a:xfrm>
             <a:off x="548640" y="1463040"/>
-            <a:ext cx="6766560" cy="3566490"/>
+            <a:ext cx="8686800" cy="3628713"/>
           </a:xfrm>
           <a:prstGeom prst="rect">
             <a:avLst/>
           </a:prstGeom>
         </p:spPr>
       </p:pic>
-      <p:pic>
-        <p:nvPicPr>
-          <p:cNvPr id="6" name="Picture 5" descr="structures_ablation.png"/>
-          <p:cNvPicPr>
-            <a:picLocks noChangeAspect="1"/>
-          </p:cNvPicPr>
-          <p:nvPr/>
-        </p:nvPicPr>
-        <p:blipFill>
-          <a:blip r:embed="rId3"/>
-          <a:stretch>
-            <a:fillRect/>
-          </a:stretch>
-        </p:blipFill>
-        <p:spPr>
-          <a:xfrm>
-            <a:off x="7406640" y="1463040"/>
-            <a:ext cx="4572000" cy="1909849"/>
-          </a:xfrm>
-          <a:prstGeom prst="rect">
-            <a:avLst/>
-          </a:prstGeom>
-        </p:spPr>
-      </p:pic>
-      <p:sp>
-        <p:nvSpPr>
-          <p:cNvPr id="7" name="TextBox 6"/>
+      <p:sp>
+        <p:nvSpPr>
+          <p:cNvPr id="9" name="TextBox 8"/>
           <p:cNvSpPr txBox="1"/>
           <p:nvPr/>
         </p:nvSpPr>
         <p:spPr>
           <a:xfrm>
-            <a:off x="7406640" y="4023360"/>
-            <a:ext cx="4572000" cy="2286000"/>
+            <a:off x="9418320" y="1554480"/>
+            <a:ext cx="2560320" cy="3200400"/>
           </a:xfrm>
           <a:prstGeom prst="rect">
             <a:avLst/>
@@ -7876,82 +8839,14 @@
           <a:lstStyle/>
           <a:p>
             <a:pPr>
-              <a:spcAft>
-                <a:spcPts val="400"/>
-              </a:spcAft>
-              <a:defRPr sz="1200" b="0">
-                <a:solidFill>
-                  <a:srgbClr val="1F3A3D"/>
-                </a:solidFill>
-              </a:defRPr>
-            </a:pPr>
-            <a:r>
-              <a:t>• Op de vaste testset is de laag metrisch neutraal: de opschoonregels vangen deze artefacten al</a:t>
-            </a:r>
-          </a:p>
-          <a:p>
-            <a:pPr>
-              <a:spcAft>
-                <a:spcPts val="400"/>
-              </a:spcAft>
-              <a:defRPr sz="1200" b="0">
-                <a:solidFill>
-                  <a:srgbClr val="1F3A3D"/>
-                </a:solidFill>
-              </a:defRPr>
-            </a:pPr>
-            <a:r>
-              <a:t>• Wél: 218 vlakken vallen af waarvan de 'oever' een constructie was — juistheid en dekking, geen foutwinst</a:t>
-            </a:r>
-          </a:p>
-          <a:p>
-            <a:pPr>
-              <a:spcAft>
-                <a:spcPts val="400"/>
-              </a:spcAft>
-              <a:defRPr sz="1200" b="0">
-                <a:solidFill>
-                  <a:srgbClr val="1F3A3D"/>
-                </a:solidFill>
-              </a:defRPr>
-            </a:pPr>
-            <a:r>
-              <a:t>• Les: wat een regel kan afleiden, hoeft niet gelabeld · wat een regel níet kan zien, wel</a:t>
-            </a:r>
-          </a:p>
-        </p:txBody>
-      </p:sp>
-      <p:sp>
-        <p:nvSpPr>
-          <p:cNvPr id="8" name="TextBox 7"/>
-          <p:cNvSpPr txBox="1"/>
-          <p:nvPr/>
-        </p:nvSpPr>
-        <p:spPr>
-          <a:xfrm>
-            <a:off x="548640" y="5760720"/>
-            <a:ext cx="6766560" cy="548640"/>
-          </a:xfrm>
-          <a:prstGeom prst="rect">
-            <a:avLst/>
-          </a:prstGeom>
-          <a:noFill/>
-        </p:spPr>
-        <p:txBody>
-          <a:bodyPr wrap="square">
-            <a:spAutoFit/>
-          </a:bodyPr>
-          <a:lstStyle/>
-          <a:p>
-            <a:pPr>
-              <a:defRPr sz="1100" i="1">
+              <a:defRPr sz="1100" b="0" i="1">
                 <a:solidFill>
                   <a:srgbClr val="6B7778"/>
                 </a:solidFill>
               </a:defRPr>
             </a:pPr>
             <a:r>
-              <a:t>links: zonder masker · rechts: met kribben + bruggen/kades/steigers (10 m) · grijs = constructie · paars = VVR</a:t>
+              <a:t>Leeswijzer: 4,12 was de score van het 19 aug-model op zijn eigen willekeurige train/test-splitsing. Voor het experiment is één vaste testset van 1.174 vlakken bevroren zodat 50+ varianten vergelijkbaar zijn; datzelfde model scoort daarop 3,99. Alle stappen hierna zijn op deze set gemeten.</a:t>
             </a:r>
           </a:p>
         </p:txBody>
@@ -8011,7 +8906,7 @@
               </a:defRPr>
             </a:pPr>
             <a:r>
-              <a:t>As 2 · Meerdere t-punten: van 2,27 naar 2,13</a:t>
+              <a:t>As 1 · Kribben en kunstwerken: nu een laag, geen gok meer</a:t>
             </a:r>
           </a:p>
         </p:txBody>
@@ -8046,7 +8941,7 @@
               </a:defRPr>
             </a:pPr>
             <a:r>
-              <a:t>Historie-features op resolutie 1 — en de horizon als meetlat voor het alarm</a:t>
+              <a:t>Deze week geleverd: kribben landelijk (1.922 → 4.698) + 6.386 kunstwerken</a:t>
             </a:r>
           </a:p>
         </p:txBody>
@@ -8081,14 +8976,14 @@
               </a:defRPr>
             </a:pPr>
             <a:r>
-              <a:t>Oevererosietool · update 26-08-2026 · 9</a:t>
+              <a:t>Oevererosietool · update 26-08-2026 · 8</a:t>
             </a:r>
           </a:p>
         </p:txBody>
       </p:sp>
       <p:pic>
         <p:nvPicPr>
-          <p:cNvPr id="5" name="Picture 4" descr="history.png"/>
+          <p:cNvPr id="5" name="Picture 4" descr="nederrijn_r_4780_4790.png"/>
           <p:cNvPicPr>
             <a:picLocks noChangeAspect="1"/>
           </p:cNvPicPr>
@@ -8103,23 +8998,47 @@
         <p:spPr>
           <a:xfrm>
             <a:off x="548640" y="1463040"/>
-            <a:ext cx="6766560" cy="2826577"/>
+            <a:ext cx="6766560" cy="3566490"/>
           </a:xfrm>
           <a:prstGeom prst="rect">
             <a:avLst/>
           </a:prstGeom>
         </p:spPr>
       </p:pic>
-      <p:sp>
-        <p:nvSpPr>
-          <p:cNvPr id="6" name="TextBox 5"/>
+      <p:pic>
+        <p:nvPicPr>
+          <p:cNvPr id="6" name="Picture 5" descr="structures_ablation.png"/>
+          <p:cNvPicPr>
+            <a:picLocks noChangeAspect="1"/>
+          </p:cNvPicPr>
+          <p:nvPr/>
+        </p:nvPicPr>
+        <p:blipFill>
+          <a:blip r:embed="rId3"/>
+          <a:stretch>
+            <a:fillRect/>
+          </a:stretch>
+        </p:blipFill>
+        <p:spPr>
+          <a:xfrm>
+            <a:off x="7406640" y="1463040"/>
+            <a:ext cx="4572000" cy="1909849"/>
+          </a:xfrm>
+          <a:prstGeom prst="rect">
+            <a:avLst/>
+          </a:prstGeom>
+        </p:spPr>
+      </p:pic>
+      <p:sp>
+        <p:nvSpPr>
+          <p:cNvPr id="7" name="TextBox 6"/>
           <p:cNvSpPr txBox="1"/>
           <p:nvPr/>
         </p:nvSpPr>
         <p:spPr>
           <a:xfrm>
-            <a:off x="7498079" y="1554480"/>
-            <a:ext cx="4480560" cy="4754880"/>
+            <a:off x="7406640" y="4023360"/>
+            <a:ext cx="4572000" cy="2286000"/>
           </a:xfrm>
           <a:prstGeom prst="rect">
             <a:avLst/>
@@ -8136,14 +9055,14 @@
               <a:spcAft>
                 <a:spcPts val="400"/>
               </a:spcAft>
-              <a:defRPr sz="1300" b="1">
+              <a:defRPr sz="1200" b="0">
                 <a:solidFill>
                   <a:srgbClr val="1F3A3D"/>
                 </a:solidFill>
               </a:defRPr>
             </a:pPr>
             <a:r>
-              <a:t>Features uit de hele meetreeks</a:t>
+              <a:t>• Op de vaste testset is de laag metrisch neutraal: de opschoonregels vangen deze artefacten al</a:t>
             </a:r>
           </a:p>
           <a:p>
@@ -8151,14 +9070,14 @@
               <a:spcAft>
                 <a:spcPts val="400"/>
               </a:spcAft>
-              <a:defRPr sz="1300" b="0">
+              <a:defRPr sz="1200" b="0">
                 <a:solidFill>
                   <a:srgbClr val="1F3A3D"/>
                 </a:solidFill>
               </a:defRPr>
             </a:pPr>
             <a:r>
-              <a:t>• Trend (Theil–Sen), spreiding om de trend, versnelling, terugkeer naar gemiddelde, recente helling</a:t>
+              <a:t>• Wél: 218 vlakken vallen af waarvan de 'oever' een constructie was — juistheid en dekking, geen foutwinst</a:t>
             </a:r>
           </a:p>
           <a:p>
@@ -8166,74 +9085,49 @@
               <a:spcAft>
                 <a:spcPts val="400"/>
               </a:spcAft>
-              <a:defRPr sz="1300" b="1">
+              <a:defRPr sz="1200" b="0">
                 <a:solidFill>
                   <a:srgbClr val="1F3A3D"/>
                 </a:solidFill>
               </a:defRPr>
             </a:pPr>
             <a:r>
-              <a:t>Wat níet werkte</a:t>
-            </a:r>
-          </a:p>
-          <a:p>
-            <a:pPr>
-              <a:spcAft>
-                <a:spcPts val="400"/>
-              </a:spcAft>
-              <a:defRPr sz="1300" b="0">
-                <a:solidFill>
-                  <a:srgbClr val="1F3A3D"/>
-                </a:solidFill>
-              </a:defRPr>
-            </a:pPr>
-            <a:r>
-              <a:t>• Trainen op losse jaar-op-jaar stappen (sub-jaar ruis), huber-loss (beter gemiddeld, slechter op de staart), debiet</a:t>
-            </a:r>
-          </a:p>
-          <a:p>
-            <a:pPr>
-              <a:spcAft>
-                <a:spcPts val="400"/>
-              </a:spcAft>
-              <a:defRPr sz="1300" b="1">
-                <a:solidFill>
-                  <a:srgbClr val="1F3A3D"/>
-                </a:solidFill>
-              </a:defRPr>
-            </a:pPr>
-            <a:r>
-              <a:t>Horizon ≥ 2 jaar — voor het alarm</a:t>
-            </a:r>
-          </a:p>
-          <a:p>
-            <a:pPr>
-              <a:spcAft>
-                <a:spcPts val="400"/>
-              </a:spcAft>
-              <a:defRPr sz="1300" b="0">
-                <a:solidFill>
-                  <a:srgbClr val="1F3A3D"/>
-                </a:solidFill>
-              </a:defRPr>
-            </a:pPr>
-            <a:r>
-              <a:t>• Hoogtemodel-paren zijn altijd 3–5 jaar uit elkaar; SAM-paren 1 jaar → ruis</a:t>
-            </a:r>
-          </a:p>
-          <a:p>
-            <a:pPr>
-              <a:spcAft>
-                <a:spcPts val="400"/>
-              </a:spcAft>
-              <a:defRPr sz="1300" b="0">
-                <a:solidFill>
-                  <a:srgbClr val="1F3A3D"/>
-                </a:solidFill>
-              </a:defRPr>
-            </a:pPr>
-            <a:r>
-              <a:t>• Zelfde doel (m/jr), zelfde fout, alleen paren ≥ 2 jaar: 1 vlak met 6 metingen = 10 leervoorbeelden</a:t>
+              <a:t>• Les: wat een regel kan afleiden, hoeft niet gelabeld · wat een regel níet kan zien, wel</a:t>
+            </a:r>
+          </a:p>
+        </p:txBody>
+      </p:sp>
+      <p:sp>
+        <p:nvSpPr>
+          <p:cNvPr id="8" name="TextBox 7"/>
+          <p:cNvSpPr txBox="1"/>
+          <p:nvPr/>
+        </p:nvSpPr>
+        <p:spPr>
+          <a:xfrm>
+            <a:off x="548640" y="5760720"/>
+            <a:ext cx="6766560" cy="548640"/>
+          </a:xfrm>
+          <a:prstGeom prst="rect">
+            <a:avLst/>
+          </a:prstGeom>
+          <a:noFill/>
+        </p:spPr>
+        <p:txBody>
+          <a:bodyPr wrap="square">
+            <a:spAutoFit/>
+          </a:bodyPr>
+          <a:lstStyle/>
+          <a:p>
+            <a:pPr>
+              <a:defRPr sz="1100" i="1">
+                <a:solidFill>
+                  <a:srgbClr val="6B7778"/>
+                </a:solidFill>
+              </a:defRPr>
+            </a:pPr>
+            <a:r>
+              <a:t>links: zonder masker · rechts: met kribben + bruggen/kades/steigers (10 m) · grijs = constructie · paars = VVR</a:t>
             </a:r>
           </a:p>
         </p:txBody>
@@ -8293,7 +9187,7 @@
               </a:defRPr>
             </a:pPr>
             <a:r>
-              <a:t>As 3 · Resolutie: van scalar naar oeverlijn</a:t>
+              <a:t>As 2 · Meerdere t-punten: van 2,27 naar 2,13</a:t>
             </a:r>
           </a:p>
         </p:txBody>
@@ -8328,7 +9222,7 @@
               </a:defRPr>
             </a:pPr>
             <a:r>
-              <a:t>Eén afstand per vlak verbergt dat 20 m hard erodeert en 80 m stil ligt</a:t>
+              <a:t>Historie-features op resolutie 1 — en de horizon als meetlat voor het alarm</a:t>
             </a:r>
           </a:p>
         </p:txBody>
@@ -8363,14 +9257,14 @@
               </a:defRPr>
             </a:pPr>
             <a:r>
-              <a:t>Oevererosietool · update 26-08-2026 · 10</a:t>
+              <a:t>Oevererosietool · update 26-08-2026 · 9</a:t>
             </a:r>
           </a:p>
         </p:txBody>
       </p:sp>
       <p:pic>
         <p:nvPicPr>
-          <p:cNvPr id="5" name="Picture 4" descr="maas3_r_8930_8940.png"/>
+          <p:cNvPr id="5" name="Picture 4" descr="history.png"/>
           <p:cNvPicPr>
             <a:picLocks noChangeAspect="1"/>
           </p:cNvPicPr>
@@ -8385,7 +9279,7 @@
         <p:spPr>
           <a:xfrm>
             <a:off x="548640" y="1463040"/>
-            <a:ext cx="6216996" cy="4846320"/>
+            <a:ext cx="6766560" cy="2826577"/>
           </a:xfrm>
           <a:prstGeom prst="rect">
             <a:avLst/>
@@ -8400,8 +9294,8 @@
         </p:nvSpPr>
         <p:spPr>
           <a:xfrm>
-            <a:off x="6035040" y="1554480"/>
-            <a:ext cx="5943600" cy="4754880"/>
+            <a:off x="7498079" y="1554480"/>
+            <a:ext cx="4480560" cy="4754880"/>
           </a:xfrm>
           <a:prstGeom prst="rect">
             <a:avLst/>
@@ -8425,7 +9319,7 @@
               </a:defRPr>
             </a:pPr>
             <a:r>
-              <a:t>Wat je ziet</a:t>
+              <a:t>Features uit de hele meetreeks</a:t>
             </a:r>
           </a:p>
           <a:p>
@@ -8440,7 +9334,22 @@
               </a:defRPr>
             </a:pPr>
             <a:r>
-              <a:t>• groen = gemeten oever per segment (2026) · bruin = voorspeld 2027 per segment</a:t>
+              <a:t>• Trend (Theil–Sen), spreiding om de trend, versnelling, terugkeer naar gemiddelde, recente helling</a:t>
+            </a:r>
+          </a:p>
+          <a:p>
+            <a:pPr>
+              <a:spcAft>
+                <a:spcPts val="400"/>
+              </a:spcAft>
+              <a:defRPr sz="1300" b="1">
+                <a:solidFill>
+                  <a:srgbClr val="1F3A3D"/>
+                </a:solidFill>
+              </a:defRPr>
+            </a:pPr>
+            <a:r>
+              <a:t>Wat níet werkte</a:t>
             </a:r>
           </a:p>
           <a:p>
@@ -8455,7 +9364,22 @@
               </a:defRPr>
             </a:pPr>
             <a:r>
-              <a:t>• gestippeld = de oude voorspelling: één getal voor het hele vlak</a:t>
+              <a:t>• Trainen op losse jaar-op-jaar stappen (sub-jaar ruis), huber-loss (beter gemiddeld, slechter op de staart), debiet</a:t>
+            </a:r>
+          </a:p>
+          <a:p>
+            <a:pPr>
+              <a:spcAft>
+                <a:spcPts val="400"/>
+              </a:spcAft>
+              <a:defRPr sz="1300" b="1">
+                <a:solidFill>
+                  <a:srgbClr val="1F3A3D"/>
+                </a:solidFill>
+              </a:defRPr>
+            </a:pPr>
+            <a:r>
+              <a:t>Horizon ≥ 2 jaar — voor het alarm</a:t>
             </a:r>
           </a:p>
           <a:p>
@@ -8470,22 +9394,7 @@
               </a:defRPr>
             </a:pPr>
             <a:r>
-              <a:t>• paars = VVR / signaleringslijn</a:t>
-            </a:r>
-          </a:p>
-          <a:p>
-            <a:pPr>
-              <a:spcAft>
-                <a:spcPts val="400"/>
-              </a:spcAft>
-              <a:defRPr sz="1300" b="1">
-                <a:solidFill>
-                  <a:srgbClr val="1F3A3D"/>
-                </a:solidFill>
-              </a:defRPr>
-            </a:pPr>
-            <a:r>
-              <a:t>Dit vlak</a:t>
+              <a:t>• Hoogtemodel-paren zijn altijd 3–5 jaar uit elkaar; SAM-paren 1 jaar → ruis</a:t>
             </a:r>
           </a:p>
           <a:p>
@@ -8500,52 +9409,7 @@
               </a:defRPr>
             </a:pPr>
             <a:r>
-              <a:t>• Eén getal zegt −9,7 m/jr; de vijf segmenten lopen van −17,1 tot +1,4</a:t>
-            </a:r>
-          </a:p>
-          <a:p>
-            <a:pPr>
-              <a:spcAft>
-                <a:spcPts val="400"/>
-              </a:spcAft>
-              <a:defRPr sz="1300" b="0">
-                <a:solidFill>
-                  <a:srgbClr val="1F3A3D"/>
-                </a:solidFill>
-              </a:defRPr>
-            </a:pPr>
-            <a:r>
-              <a:t>• Het bovenste segment nadert de VVR; de rest niet — het alarm hoort per segment te kijken</a:t>
-            </a:r>
-          </a:p>
-          <a:p>
-            <a:pPr>
-              <a:spcAft>
-                <a:spcPts val="400"/>
-              </a:spcAft>
-              <a:defRPr sz="1300" b="1">
-                <a:solidFill>
-                  <a:srgbClr val="1F3A3D"/>
-                </a:solidFill>
-              </a:defRPr>
-            </a:pPr>
-            <a:r>
-              <a:t>Vandaag</a:t>
-            </a:r>
-          </a:p>
-          <a:p>
-            <a:pPr>
-              <a:spcAft>
-                <a:spcPts val="400"/>
-              </a:spcAft>
-              <a:defRPr sz="1300" b="0">
-                <a:solidFill>
-                  <a:srgbClr val="1F3A3D"/>
-                </a:solidFill>
-              </a:defRPr>
-            </a:pPr>
-            <a:r>
-              <a:t>• VVR-jaar = één drempel per vlak (het verst gelegen punt van de signaleringslijn) tegen één scalar → per definitie laat</a:t>
+              <a:t>• Zelfde doel (m/jr), zelfde fout, alleen paren ≥ 2 jaar: 1 vlak met 6 metingen = 10 leervoorbeelden</a:t>
             </a:r>
           </a:p>
         </p:txBody>

</xml_diff>

<commit_message>
docs(presentation): dot decimals, thin-space thousands everywhere
</commit_message>
<xml_diff>
--- a/docs/presentations/20260826_update_v2.pptx
+++ b/docs/presentations/20260826_update_v2.pptx
@@ -3968,7 +3968,7 @@
               </a:defRPr>
             </a:pPr>
             <a:r>
-              <a:t>• Eén getal zegt −9,7 m/jr; de vijf segmenten lopen van −17,1 tot +1,4</a:t>
+              <a:t>• Eén getal zegt −9.7 m/jr; de vijf segmenten lopen van −17.1 tot +1.4</a:t>
             </a:r>
           </a:p>
           <a:p>
@@ -4172,9 +4172,92 @@
           </a:prstGeom>
         </p:spPr>
       </p:pic>
+      <p:sp>
+        <p:nvSpPr>
+          <p:cNvPr id="7" name="TextBox 6"/>
+          <p:cNvSpPr txBox="1"/>
+          <p:nvPr/>
+        </p:nvSpPr>
+        <p:spPr>
+          <a:xfrm>
+            <a:off x="548640" y="4754880"/>
+            <a:ext cx="11430000" cy="1645920"/>
+          </a:xfrm>
+          <a:prstGeom prst="rect">
+            <a:avLst/>
+          </a:prstGeom>
+          <a:noFill/>
+        </p:spPr>
+        <p:txBody>
+          <a:bodyPr wrap="square">
+            <a:spAutoFit/>
+          </a:bodyPr>
+          <a:lstStyle/>
+          <a:p>
+            <a:pPr>
+              <a:spcAft>
+                <a:spcPts val="300"/>
+              </a:spcAft>
+              <a:defRPr sz="1200" b="0">
+                <a:solidFill>
+                  <a:srgbClr val="1F3A3D"/>
+                </a:solidFill>
+              </a:defRPr>
+            </a:pPr>
+            <a:r>
+              <a:t>• De segment-representatie (bruin) volgt de gemeten oever vanaf R ≈ 5–10; bij R = 50–100 raken segmenten leeg (rood)</a:t>
+            </a:r>
+          </a:p>
+          <a:p>
+            <a:pPr>
+              <a:spcAft>
+                <a:spcPts val="300"/>
+              </a:spcAft>
+              <a:defRPr sz="1200" b="0">
+                <a:solidFill>
+                  <a:srgbClr val="1F3A3D"/>
+                </a:solidFill>
+              </a:defRPr>
+            </a:pPr>
+            <a:r>
+              <a:t>• Fout per segment daalt van 2.25 (R = 1) naar 1.88 (R = 5) en 1.61 (R = 20) — kleiner wordt nauwkeuriger, niet ruiziger</a:t>
+            </a:r>
+          </a:p>
+          <a:p>
+            <a:pPr>
+              <a:spcAft>
+                <a:spcPts val="300"/>
+              </a:spcAft>
+              <a:defRPr sz="1200" b="0">
+                <a:solidFill>
+                  <a:srgbClr val="1F3A3D"/>
+                </a:solidFill>
+              </a:defRPr>
+            </a:pPr>
+            <a:r>
+              <a:t>• Terug-samengevoegd per vlak blijft de fout ≈ 2.1–2.2: het vlak-getal zelf heeft een vloer (0.5–1.1 m/jr representatiefout)</a:t>
+            </a:r>
+          </a:p>
+          <a:p>
+            <a:pPr>
+              <a:spcAft>
+                <a:spcPts val="300"/>
+              </a:spcAft>
+              <a:defRPr sz="1200" b="0">
+                <a:solidFill>
+                  <a:srgbClr val="1F3A3D"/>
+                </a:solidFill>
+              </a:defRPr>
+            </a:pPr>
+            <a:r>
+              <a:t>• Grens ligt bij de lijnbemonstering (60 punten per lijn), niet bij het model · praktisch: R = 5–10 (≈ 10–20 m)</a:t>
+            </a:r>
+          </a:p>
+        </p:txBody>
+      </p:sp>
       <p:pic>
         <p:nvPicPr>
-          <p:cNvPr id="6" name="Picture 5" descr="resolution_sweep.png"/>
+          <p:cNvPr id="8" name="Picture 7" descr="image.png"/>
           <p:cNvPicPr>
             <a:picLocks noChangeAspect="1"/>
           </p:cNvPicPr>
@@ -4196,89 +4279,6 @@
           </a:prstGeom>
         </p:spPr>
       </p:pic>
-      <p:sp>
-        <p:nvSpPr>
-          <p:cNvPr id="7" name="TextBox 6"/>
-          <p:cNvSpPr txBox="1"/>
-          <p:nvPr/>
-        </p:nvSpPr>
-        <p:spPr>
-          <a:xfrm>
-            <a:off x="548640" y="4754880"/>
-            <a:ext cx="11430000" cy="1645920"/>
-          </a:xfrm>
-          <a:prstGeom prst="rect">
-            <a:avLst/>
-          </a:prstGeom>
-          <a:noFill/>
-        </p:spPr>
-        <p:txBody>
-          <a:bodyPr wrap="square">
-            <a:spAutoFit/>
-          </a:bodyPr>
-          <a:lstStyle/>
-          <a:p>
-            <a:pPr>
-              <a:spcAft>
-                <a:spcPts val="300"/>
-              </a:spcAft>
-              <a:defRPr sz="1200" b="0">
-                <a:solidFill>
-                  <a:srgbClr val="1F3A3D"/>
-                </a:solidFill>
-              </a:defRPr>
-            </a:pPr>
-            <a:r>
-              <a:t>• De segment-representatie (bruin) volgt de gemeten oever vanaf R ≈ 5–10; bij R = 50–100 raken segmenten leeg (rood)</a:t>
-            </a:r>
-          </a:p>
-          <a:p>
-            <a:pPr>
-              <a:spcAft>
-                <a:spcPts val="300"/>
-              </a:spcAft>
-              <a:defRPr sz="1200" b="0">
-                <a:solidFill>
-                  <a:srgbClr val="1F3A3D"/>
-                </a:solidFill>
-              </a:defRPr>
-            </a:pPr>
-            <a:r>
-              <a:t>• Fout per segment daalt van 2,25 (R = 1) naar 1,88 (R = 5) en 1,61 (R = 20) — kleiner wordt nauwkeuriger, niet ruiziger</a:t>
-            </a:r>
-          </a:p>
-          <a:p>
-            <a:pPr>
-              <a:spcAft>
-                <a:spcPts val="300"/>
-              </a:spcAft>
-              <a:defRPr sz="1200" b="0">
-                <a:solidFill>
-                  <a:srgbClr val="1F3A3D"/>
-                </a:solidFill>
-              </a:defRPr>
-            </a:pPr>
-            <a:r>
-              <a:t>• Terug-samengevoegd per vlak blijft de fout ≈ 2,1–2,2: het vlak-getal zelf heeft een vloer (0,5–1,1 m/jr representatiefout)</a:t>
-            </a:r>
-          </a:p>
-          <a:p>
-            <a:pPr>
-              <a:spcAft>
-                <a:spcPts val="300"/>
-              </a:spcAft>
-              <a:defRPr sz="1200" b="0">
-                <a:solidFill>
-                  <a:srgbClr val="1F3A3D"/>
-                </a:solidFill>
-              </a:defRPr>
-            </a:pPr>
-            <a:r>
-              <a:t>• Grens ligt bij de lijnbemonstering (60 punten per lijn), niet bij het model · praktisch: R = 5–10 (≈ 10–20 m)</a:t>
-            </a:r>
-          </a:p>
-        </p:txBody>
-      </p:sp>
     </p:spTree>
   </p:cSld>
   <p:clrMapOvr>
@@ -4409,9 +4409,62 @@
           </a:p>
         </p:txBody>
       </p:sp>
+      <p:sp>
+        <p:nvSpPr>
+          <p:cNvPr id="6" name="TextBox 5"/>
+          <p:cNvSpPr txBox="1"/>
+          <p:nvPr/>
+        </p:nvSpPr>
+        <p:spPr>
+          <a:xfrm>
+            <a:off x="548640" y="5303520"/>
+            <a:ext cx="11064240" cy="1097280"/>
+          </a:xfrm>
+          <a:prstGeom prst="rect">
+            <a:avLst/>
+          </a:prstGeom>
+          <a:noFill/>
+        </p:spPr>
+        <p:txBody>
+          <a:bodyPr wrap="square">
+            <a:spAutoFit/>
+          </a:bodyPr>
+          <a:lstStyle/>
+          <a:p>
+            <a:pPr>
+              <a:spcAft>
+                <a:spcPts val="400"/>
+              </a:spcAft>
+              <a:defRPr sz="1400" b="0">
+                <a:solidFill>
+                  <a:srgbClr val="1F3A3D"/>
+                </a:solidFill>
+              </a:defRPr>
+            </a:pPr>
+            <a:r>
+              <a:t>• Opschonen: −1.72 m/jr (−43 %) · historie-features: −0.14 · structurenlaag: ±0 (dekking/juistheid) · resolutie: andere eenheid, −0.25 per segment</a:t>
+            </a:r>
+          </a:p>
+          <a:p>
+            <a:pPr>
+              <a:spcAft>
+                <a:spcPts val="400"/>
+              </a:spcAft>
+              <a:defRPr sz="1400" b="1">
+                <a:solidFill>
+                  <a:srgbClr val="1F3A3D"/>
+                </a:solidFill>
+              </a:defRPr>
+            </a:pPr>
+            <a:r>
+              <a:t>Het model was nooit de bottleneck — de labels waren het. En de regels raken op: wat overblijft, kan alleen een mens zien.</a:t>
+            </a:r>
+          </a:p>
+        </p:txBody>
+      </p:sp>
       <p:pic>
         <p:nvPicPr>
-          <p:cNvPr id="5" name="Picture 4" descr="matrix.png"/>
+          <p:cNvPr id="7" name="Picture 6" descr="image.png"/>
           <p:cNvPicPr>
             <a:picLocks noChangeAspect="1"/>
           </p:cNvPicPr>
@@ -4433,59 +4486,6 @@
           </a:prstGeom>
         </p:spPr>
       </p:pic>
-      <p:sp>
-        <p:nvSpPr>
-          <p:cNvPr id="6" name="TextBox 5"/>
-          <p:cNvSpPr txBox="1"/>
-          <p:nvPr/>
-        </p:nvSpPr>
-        <p:spPr>
-          <a:xfrm>
-            <a:off x="548640" y="5303520"/>
-            <a:ext cx="11064240" cy="1097280"/>
-          </a:xfrm>
-          <a:prstGeom prst="rect">
-            <a:avLst/>
-          </a:prstGeom>
-          <a:noFill/>
-        </p:spPr>
-        <p:txBody>
-          <a:bodyPr wrap="square">
-            <a:spAutoFit/>
-          </a:bodyPr>
-          <a:lstStyle/>
-          <a:p>
-            <a:pPr>
-              <a:spcAft>
-                <a:spcPts val="400"/>
-              </a:spcAft>
-              <a:defRPr sz="1400" b="0">
-                <a:solidFill>
-                  <a:srgbClr val="1F3A3D"/>
-                </a:solidFill>
-              </a:defRPr>
-            </a:pPr>
-            <a:r>
-              <a:t>• Opschonen: −1,72 m/jr (−43 %) · historie-features: −0,14 · structurenlaag: ±0 (dekking/juistheid) · resolutie: andere eenheid, −0,25 per segment</a:t>
-            </a:r>
-          </a:p>
-          <a:p>
-            <a:pPr>
-              <a:spcAft>
-                <a:spcPts val="400"/>
-              </a:spcAft>
-              <a:defRPr sz="1400" b="1">
-                <a:solidFill>
-                  <a:srgbClr val="1F3A3D"/>
-                </a:solidFill>
-              </a:defRPr>
-            </a:pPr>
-            <a:r>
-              <a:t>Het model was nooit de bottleneck — de labels waren het. En de regels raken op: wat overblijft, kan alleen een mens zien.</a:t>
-            </a:r>
-          </a:p>
-        </p:txBody>
-      </p:sp>
     </p:spTree>
   </p:cSld>
   <p:clrMapOvr>
@@ -4805,7 +4805,7 @@
                         </a:defRPr>
                       </a:pPr>
                       <a:r>
-                        <a:t>0,78</a:t>
+                        <a:t>0.78</a:t>
                       </a:r>
                     </a:p>
                   </a:txBody>
@@ -4828,7 +4828,7 @@
                         </a:defRPr>
                       </a:pPr>
                       <a:r>
-                        <a:t>0,94  (−20 %)</a:t>
+                        <a:t>0.94  (−20 %)</a:t>
                       </a:r>
                     </a:p>
                   </a:txBody>
@@ -4851,7 +4851,7 @@
                         </a:defRPr>
                       </a:pPr>
                       <a:r>
-                        <a:t>4,6 / 5,5</a:t>
+                        <a:t>4.6 / 5.5</a:t>
                       </a:r>
                     </a:p>
                   </a:txBody>
@@ -4904,7 +4904,7 @@
                         </a:defRPr>
                       </a:pPr>
                       <a:r>
-                        <a:t>4,79</a:t>
+                        <a:t>4.79</a:t>
                       </a:r>
                     </a:p>
                   </a:txBody>
@@ -4927,7 +4927,7 @@
                         </a:defRPr>
                       </a:pPr>
                       <a:r>
-                        <a:t>4,12  (+14 %)</a:t>
+                        <a:t>4.12  (+14 %)</a:t>
                       </a:r>
                     </a:p>
                   </a:txBody>
@@ -4950,7 +4950,7 @@
                         </a:defRPr>
                       </a:pPr>
                       <a:r>
-                        <a:t>≈ 8,3</a:t>
+                        <a:t>≈ 8.3</a:t>
                       </a:r>
                     </a:p>
                   </a:txBody>
@@ -5003,7 +5003,7 @@
                         </a:defRPr>
                       </a:pPr>
                       <a:r>
-                        <a:t>2,86</a:t>
+                        <a:t>2.86</a:t>
                       </a:r>
                     </a:p>
                   </a:txBody>
@@ -5026,7 +5026,7 @@
                         </a:defRPr>
                       </a:pPr>
                       <a:r>
-                        <a:t>2,47  (+13 %)</a:t>
+                        <a:t>2.47  (+13 %)</a:t>
                       </a:r>
                     </a:p>
                   </a:txBody>
@@ -5049,7 +5049,7 @@
                         </a:defRPr>
                       </a:pPr>
                       <a:r>
-                        <a:t>5,0 / 6,3</a:t>
+                        <a:t>5.0 / 6.3</a:t>
                       </a:r>
                     </a:p>
                   </a:txBody>
@@ -5102,7 +5102,7 @@
                         </a:defRPr>
                       </a:pPr>
                       <a:r>
-                        <a:t>1,79</a:t>
+                        <a:t>1.79</a:t>
                       </a:r>
                     </a:p>
                   </a:txBody>
@@ -5125,7 +5125,7 @@
                         </a:defRPr>
                       </a:pPr>
                       <a:r>
-                        <a:t>1,23  (+31 %)</a:t>
+                        <a:t>1.23  (+31 %)</a:t>
                       </a:r>
                     </a:p>
                   </a:txBody>
@@ -5148,7 +5148,7 @@
                         </a:defRPr>
                       </a:pPr>
                       <a:r>
-                        <a:t>3,5</a:t>
+                        <a:t>3.5</a:t>
                       </a:r>
                     </a:p>
                   </a:txBody>
@@ -5216,7 +5216,7 @@
               </a:defRPr>
             </a:pPr>
             <a:r>
-              <a:t>• Vlakken met voorspelling 8.006 → 10.721</a:t>
+              <a:t>• Vlakken met voorspelling 8 006 → 10 721</a:t>
             </a:r>
           </a:p>
           <a:p>
@@ -5231,7 +5231,7 @@
               </a:defRPr>
             </a:pPr>
             <a:r>
-              <a:t>• 1,23 is m/jr op een gladdere meetlat — lees het als '31 % beter dan niets doen', niet als '2× beter dan 2,47'</a:t>
+              <a:t>• 1.23 is m/jr op een gladdere meetlat — lees het als '31 % beter dan niets doen', niet als '2× beter dan 2.47'</a:t>
             </a:r>
           </a:p>
           <a:p>
@@ -5246,7 +5246,7 @@
               </a:defRPr>
             </a:pPr>
             <a:r>
-              <a:t>• Toezegging 10× (op 4,12): nu 1,7× op die exacte meetlat, met strengere validatie</a:t>
+              <a:t>• Toezegging 10× (op 4.12): nu 1.7× op die exacte meetlat, met strengere validatie</a:t>
             </a:r>
           </a:p>
         </p:txBody>
@@ -5928,7 +5928,7 @@
               </a:defRPr>
             </a:pPr>
             <a:r>
-              <a:t>• Per segment een verwachte positie ≥ 2 jaar vooruit (48.000 segmenten, 10.000 vlakken)</a:t>
+              <a:t>• Per segment een verwachte positie ≥ 2 jaar vooruit (48 000 segmenten, 10 000 vlakken)</a:t>
             </a:r>
           </a:p>
           <a:p>
@@ -6804,8 +6804,8 @@
         </p:nvSpPr>
         <p:spPr>
           <a:xfrm>
-            <a:off x="548640" y="5212080"/>
-            <a:ext cx="11064240" cy="1097280"/>
+            <a:off x="548640" y="5577840"/>
+            <a:ext cx="11064240" cy="461665"/>
           </a:xfrm>
           <a:prstGeom prst="rect">
             <a:avLst/>
@@ -6967,8 +6967,13 @@
             </a:r>
             <a:r>
               <a:rPr dirty="0"/>
-              <a:t> de baseline.</a:t>
-            </a:r>
+              <a:t> de baseline</a:t>
+            </a:r>
+            <a:r>
+              <a:rPr lang="en-US" dirty="0"/>
+              <a:t>.</a:t>
+            </a:r>
+            <a:endParaRPr dirty="0"/>
           </a:p>
         </p:txBody>
       </p:sp>
@@ -7013,11 +7018,17 @@
           <p:cNvGraphicFramePr>
             <a:graphicFrameLocks noGrp="1"/>
           </p:cNvGraphicFramePr>
-          <p:nvPr/>
+          <p:nvPr>
+            <p:extLst>
+              <p:ext uri="{D42A27DB-BD31-4B8C-83A1-F6EECF244321}">
+                <p14:modId xmlns:p14="http://schemas.microsoft.com/office/powerpoint/2010/main" val="1923351747"/>
+              </p:ext>
+            </p:extLst>
+          </p:nvPr>
         </p:nvGraphicFramePr>
         <p:xfrm>
           <a:off x="548640" y="1463040"/>
-          <a:ext cx="11064240" cy="3456432"/>
+          <a:ext cx="11064240" cy="3910584"/>
         </p:xfrm>
         <a:graphic>
           <a:graphicData uri="http://schemas.openxmlformats.org/drawingml/2006/table">
@@ -7026,10 +7037,34 @@
                 <a:tableStyleId>{5C22544A-7EE6-4342-B048-85BDC9FD1C3A}</a:tableStyleId>
               </a:tblPr>
               <a:tblGrid>
-                <a:gridCol w="4206240"/>
-                <a:gridCol w="2103120"/>
-                <a:gridCol w="2377440"/>
-                <a:gridCol w="2377440"/>
+                <a:gridCol w="4206240">
+                  <a:extLst>
+                    <a:ext uri="{9D8B030D-6E8A-4147-A177-3AD203B41FA5}">
+                      <a16:colId xmlns:a16="http://schemas.microsoft.com/office/drawing/2014/main" val="20000"/>
+                    </a:ext>
+                  </a:extLst>
+                </a:gridCol>
+                <a:gridCol w="2103120">
+                  <a:extLst>
+                    <a:ext uri="{9D8B030D-6E8A-4147-A177-3AD203B41FA5}">
+                      <a16:colId xmlns:a16="http://schemas.microsoft.com/office/drawing/2014/main" val="20001"/>
+                    </a:ext>
+                  </a:extLst>
+                </a:gridCol>
+                <a:gridCol w="2377440">
+                  <a:extLst>
+                    <a:ext uri="{9D8B030D-6E8A-4147-A177-3AD203B41FA5}">
+                      <a16:colId xmlns:a16="http://schemas.microsoft.com/office/drawing/2014/main" val="20002"/>
+                    </a:ext>
+                  </a:extLst>
+                </a:gridCol>
+                <a:gridCol w="2377440">
+                  <a:extLst>
+                    <a:ext uri="{9D8B030D-6E8A-4147-A177-3AD203B41FA5}">
+                      <a16:colId xmlns:a16="http://schemas.microsoft.com/office/drawing/2014/main" val="20003"/>
+                    </a:ext>
+                  </a:extLst>
+                </a:gridCol>
               </a:tblGrid>
               <a:tr h="384048">
                 <a:tc>
@@ -7037,13 +7072,18 @@
                     <a:bodyPr/>
                     <a:lstStyle/>
                     <a:p>
-                      <a:pPr>
+                      <a:pPr algn="ctr">
                         <a:defRPr sz="1300" b="1">
                           <a:solidFill>
                             <a:srgbClr val="1F3A3D"/>
                           </a:solidFill>
                         </a:defRPr>
                       </a:pPr>
+                      <a:endParaRPr>
+                        <a:solidFill>
+                          <a:schemeClr val="tx1"/>
+                        </a:solidFill>
+                      </a:endParaRPr>
                     </a:p>
                   </a:txBody>
                   <a:tcPr>
@@ -7065,11 +7105,22 @@
                         </a:defRPr>
                       </a:pPr>
                       <a:r>
+                        <a:rPr>
+                          <a:solidFill>
+                            <a:schemeClr val="tx1"/>
+                          </a:solidFill>
+                        </a:rPr>
                         <a:t>maart 2026</a:t>
                       </a:r>
                     </a:p>
                     <a:p>
+                      <a:pPr algn="ctr"/>
                       <a:r>
+                        <a:rPr>
+                          <a:solidFill>
+                            <a:schemeClr val="tx1"/>
+                          </a:solidFill>
+                        </a:rPr>
                         <a:t>alleen hoogtemodel</a:t>
                       </a:r>
                     </a:p>
@@ -7093,11 +7144,22 @@
                         </a:defRPr>
                       </a:pPr>
                       <a:r>
+                        <a:rPr>
+                          <a:solidFill>
+                            <a:schemeClr val="tx1"/>
+                          </a:solidFill>
+                        </a:rPr>
                         <a:t>19 augustus</a:t>
                       </a:r>
                     </a:p>
                     <a:p>
+                      <a:pPr algn="ctr"/>
                       <a:r>
+                        <a:rPr>
+                          <a:solidFill>
+                            <a:schemeClr val="tx1"/>
+                          </a:solidFill>
+                        </a:rPr>
                         <a:t>hybride (SAM + hoogtemodel)</a:t>
                       </a:r>
                     </a:p>
@@ -7121,13 +7183,74 @@
                         </a:defRPr>
                       </a:pPr>
                       <a:r>
-                        <a:t>nu: uitgangspunt</a:t>
+                        <a:rPr dirty="0">
+                          <a:solidFill>
+                            <a:schemeClr val="tx1"/>
+                          </a:solidFill>
+                        </a:rPr>
+                        <a:t>nu: </a:t>
                       </a:r>
+                      <a:r>
+                        <a:rPr dirty="0" err="1">
+                          <a:solidFill>
+                            <a:schemeClr val="tx1"/>
+                          </a:solidFill>
+                        </a:rPr>
+                        <a:t>uitgangspunt</a:t>
+                      </a:r>
+                      <a:endParaRPr dirty="0">
+                        <a:solidFill>
+                          <a:schemeClr val="tx1"/>
+                        </a:solidFill>
+                      </a:endParaRPr>
                     </a:p>
                     <a:p>
+                      <a:pPr algn="ctr"/>
                       <a:r>
-                        <a:t>zelfde model, vaste testset</a:t>
+                        <a:rPr dirty="0" err="1">
+                          <a:solidFill>
+                            <a:schemeClr val="tx1"/>
+                          </a:solidFill>
+                        </a:rPr>
+                        <a:t>zelfde</a:t>
                       </a:r>
+                      <a:r>
+                        <a:rPr dirty="0">
+                          <a:solidFill>
+                            <a:schemeClr val="tx1"/>
+                          </a:solidFill>
+                        </a:rPr>
+                        <a:t> model, </a:t>
+                      </a:r>
+                      <a:r>
+                        <a:rPr dirty="0" err="1">
+                          <a:solidFill>
+                            <a:schemeClr val="tx1"/>
+                          </a:solidFill>
+                        </a:rPr>
+                        <a:t>vaste</a:t>
+                      </a:r>
+                      <a:r>
+                        <a:rPr dirty="0">
+                          <a:solidFill>
+                            <a:schemeClr val="tx1"/>
+                          </a:solidFill>
+                        </a:rPr>
+                        <a:t> </a:t>
+                      </a:r>
+                      <a:r>
+                        <a:rPr dirty="0" err="1">
+                          <a:solidFill>
+                            <a:schemeClr val="tx1"/>
+                          </a:solidFill>
+                        </a:rPr>
+                        <a:t>testset</a:t>
+                      </a:r>
+                      <a:endParaRPr dirty="0">
+                        <a:solidFill>
+                          <a:schemeClr val="tx1"/>
+                        </a:solidFill>
+                      </a:endParaRPr>
                     </a:p>
                   </a:txBody>
                   <a:tcPr>
@@ -7136,6 +7259,11 @@
                     </a:solidFill>
                   </a:tcPr>
                 </a:tc>
+                <a:extLst>
+                  <a:ext uri="{0D108BD9-81ED-4DB2-BD59-A6C34878D82A}">
+                    <a16:rowId xmlns:a16="http://schemas.microsoft.com/office/drawing/2014/main" val="10000"/>
+                  </a:ext>
+                </a:extLst>
               </a:tr>
               <a:tr h="384048">
                 <a:tc>
@@ -7174,7 +7302,7 @@
                         </a:defRPr>
                       </a:pPr>
                       <a:r>
-                        <a:t>0,78</a:t>
+                        <a:t>0.78</a:t>
                       </a:r>
                     </a:p>
                   </a:txBody>
@@ -7197,7 +7325,7 @@
                         </a:defRPr>
                       </a:pPr>
                       <a:r>
-                        <a:t>4,79</a:t>
+                        <a:t>4.79</a:t>
                       </a:r>
                     </a:p>
                   </a:txBody>
@@ -7220,7 +7348,7 @@
                         </a:defRPr>
                       </a:pPr>
                       <a:r>
-                        <a:t>4,68</a:t>
+                        <a:t>4.68</a:t>
                       </a:r>
                     </a:p>
                   </a:txBody>
@@ -7230,6 +7358,11 @@
                     </a:solidFill>
                   </a:tcPr>
                 </a:tc>
+                <a:extLst>
+                  <a:ext uri="{0D108BD9-81ED-4DB2-BD59-A6C34878D82A}">
+                    <a16:rowId xmlns:a16="http://schemas.microsoft.com/office/drawing/2014/main" val="10001"/>
+                  </a:ext>
+                </a:extLst>
               </a:tr>
               <a:tr h="384048">
                 <a:tc>
@@ -7268,7 +7401,7 @@
                         </a:defRPr>
                       </a:pPr>
                       <a:r>
-                        <a:t>0,94</a:t>
+                        <a:t>0.94</a:t>
                       </a:r>
                     </a:p>
                   </a:txBody>
@@ -7291,7 +7424,7 @@
                         </a:defRPr>
                       </a:pPr>
                       <a:r>
-                        <a:t>4,12</a:t>
+                        <a:t>4.12</a:t>
                       </a:r>
                     </a:p>
                   </a:txBody>
@@ -7314,7 +7447,7 @@
                         </a:defRPr>
                       </a:pPr>
                       <a:r>
-                        <a:t>3,99</a:t>
+                        <a:t>3.99</a:t>
                       </a:r>
                     </a:p>
                   </a:txBody>
@@ -7324,6 +7457,11 @@
                     </a:solidFill>
                   </a:tcPr>
                 </a:tc>
+                <a:extLst>
+                  <a:ext uri="{0D108BD9-81ED-4DB2-BD59-A6C34878D82A}">
+                    <a16:rowId xmlns:a16="http://schemas.microsoft.com/office/drawing/2014/main" val="10002"/>
+                  </a:ext>
+                </a:extLst>
               </a:tr>
               <a:tr h="384048">
                 <a:tc>
@@ -7418,6 +7556,11 @@
                     </a:solidFill>
                   </a:tcPr>
                 </a:tc>
+                <a:extLst>
+                  <a:ext uri="{0D108BD9-81ED-4DB2-BD59-A6C34878D82A}">
+                    <a16:rowId xmlns:a16="http://schemas.microsoft.com/office/drawing/2014/main" val="10003"/>
+                  </a:ext>
+                </a:extLst>
               </a:tr>
               <a:tr h="384048">
                 <a:tc>
@@ -7456,7 +7599,7 @@
                         </a:defRPr>
                       </a:pPr>
                       <a:r>
-                        <a:t>4,61</a:t>
+                        <a:t>4.61</a:t>
                       </a:r>
                     </a:p>
                   </a:txBody>
@@ -7479,7 +7622,7 @@
                         </a:defRPr>
                       </a:pPr>
                       <a:r>
-                        <a:t>9,13</a:t>
+                        <a:t>9.13</a:t>
                       </a:r>
                     </a:p>
                   </a:txBody>
@@ -7502,7 +7645,7 @@
                         </a:defRPr>
                       </a:pPr>
                       <a:r>
-                        <a:t>8,30</a:t>
+                        <a:t>8.30</a:t>
                       </a:r>
                     </a:p>
                   </a:txBody>
@@ -7512,6 +7655,11 @@
                     </a:solidFill>
                   </a:tcPr>
                 </a:tc>
+                <a:extLst>
+                  <a:ext uri="{0D108BD9-81ED-4DB2-BD59-A6C34878D82A}">
+                    <a16:rowId xmlns:a16="http://schemas.microsoft.com/office/drawing/2014/main" val="10004"/>
+                  </a:ext>
+                </a:extLst>
               </a:tr>
               <a:tr h="384048">
                 <a:tc>
@@ -7550,7 +7698,7 @@
                         </a:defRPr>
                       </a:pPr>
                       <a:r>
-                        <a:t>2,2</a:t>
+                        <a:t>2.2</a:t>
                       </a:r>
                     </a:p>
                   </a:txBody>
@@ -7573,7 +7721,7 @@
                         </a:defRPr>
                       </a:pPr>
                       <a:r>
-                        <a:t>11,4</a:t>
+                        <a:t>11.4</a:t>
                       </a:r>
                     </a:p>
                   </a:txBody>
@@ -7596,7 +7744,7 @@
                         </a:defRPr>
                       </a:pPr>
                       <a:r>
-                        <a:t>9,2</a:t>
+                        <a:t>9.2</a:t>
                       </a:r>
                     </a:p>
                   </a:txBody>
@@ -7606,6 +7754,11 @@
                     </a:solidFill>
                   </a:tcPr>
                 </a:tc>
+                <a:extLst>
+                  <a:ext uri="{0D108BD9-81ED-4DB2-BD59-A6C34878D82A}">
+                    <a16:rowId xmlns:a16="http://schemas.microsoft.com/office/drawing/2014/main" val="10005"/>
+                  </a:ext>
+                </a:extLst>
               </a:tr>
               <a:tr h="384048">
                 <a:tc>
@@ -7700,6 +7853,11 @@
                     </a:solidFill>
                   </a:tcPr>
                 </a:tc>
+                <a:extLst>
+                  <a:ext uri="{0D108BD9-81ED-4DB2-BD59-A6C34878D82A}">
+                    <a16:rowId xmlns:a16="http://schemas.microsoft.com/office/drawing/2014/main" val="10006"/>
+                  </a:ext>
+                </a:extLst>
               </a:tr>
               <a:tr h="384048">
                 <a:tc>
@@ -7784,8 +7942,14 @@
                         </a:defRPr>
                       </a:pPr>
                       <a:r>
-                        <a:t>vast · 1.174 vlakken</a:t>
+                        <a:rPr dirty="0"/>
+                        <a:t>vast · 1 174 </a:t>
                       </a:r>
+                      <a:r>
+                        <a:rPr dirty="0" err="1"/>
+                        <a:t>vlakken</a:t>
+                      </a:r>
+                      <a:endParaRPr dirty="0"/>
                     </a:p>
                   </a:txBody>
                   <a:tcPr>
@@ -7794,6 +7958,11 @@
                     </a:solidFill>
                   </a:tcPr>
                 </a:tc>
+                <a:extLst>
+                  <a:ext uri="{0D108BD9-81ED-4DB2-BD59-A6C34878D82A}">
+                    <a16:rowId xmlns:a16="http://schemas.microsoft.com/office/drawing/2014/main" val="10007"/>
+                  </a:ext>
+                </a:extLst>
               </a:tr>
               <a:tr h="384048">
                 <a:tc>
@@ -7832,7 +8001,8 @@
                         </a:defRPr>
                       </a:pPr>
                       <a:r>
-                        <a:t>7.444</a:t>
+                        <a:rPr dirty="0"/>
+                        <a:t>7 444</a:t>
                       </a:r>
                     </a:p>
                   </a:txBody>
@@ -7855,7 +8025,7 @@
                         </a:defRPr>
                       </a:pPr>
                       <a:r>
-                        <a:t>8.006</a:t>
+                        <a:t>8 006</a:t>
                       </a:r>
                     </a:p>
                   </a:txBody>
@@ -7878,7 +8048,8 @@
                         </a:defRPr>
                       </a:pPr>
                       <a:r>
-                        <a:t>10.437</a:t>
+                        <a:rPr dirty="0"/>
+                        <a:t>10 437</a:t>
                       </a:r>
                     </a:p>
                   </a:txBody>
@@ -7888,6 +8059,11 @@
                     </a:solidFill>
                   </a:tcPr>
                 </a:tc>
+                <a:extLst>
+                  <a:ext uri="{0D108BD9-81ED-4DB2-BD59-A6C34878D82A}">
+                    <a16:rowId xmlns:a16="http://schemas.microsoft.com/office/drawing/2014/main" val="10008"/>
+                  </a:ext>
+                </a:extLst>
               </a:tr>
             </a:tbl>
           </a:graphicData>
@@ -8014,7 +8190,7 @@
               </a:defRPr>
             </a:pPr>
             <a:r>
-              <a:t>Uitgangspunt: het model van 19 augustus, resolutie 1, één vaste testset van 1.174 vlakken</a:t>
+              <a:t>Uitgangspunt: het model van 19 augustus, resolutie 1, één vaste testset van 1 174 vlakken</a:t>
             </a:r>
           </a:p>
         </p:txBody>
@@ -8399,7 +8575,7 @@
               </a:defRPr>
             </a:pPr>
             <a:r>
-              <a:t>Leeswijzer: op deze vaste testset scoort het model van 19 augustus 3,99 m/jr (4,12 op de eigen split van toen). Alle cijfers hierna zijn op deze set, zodat stappen optelbaar zijn.</a:t>
+              <a:t>Leeswijzer: op deze vaste testset scoort het model van 19 augustus 3.99 m/jr (4.12 op de eigen split van toen). Alle cijfers hierna zijn op deze set, zodat stappen optelbaar zijn.</a:t>
             </a:r>
           </a:p>
         </p:txBody>
@@ -8554,7 +8730,7 @@
               </a:defRPr>
             </a:pPr>
             <a:r>
-              <a:t>Daarnaast: nevengeulen en plassen (5,9 % van de metingen in 'normale' vlakken), fragmenten (&lt; 25 % van het vlak) en metingen die 15 m van de trend afwijken. Elk patroon = één opschoonregel; elke regel = een gok naar iets wat een mens zeker weet.</a:t>
+              <a:t>Daarnaast: nevengeulen en plassen (5.9 % van de metingen in 'normale' vlakken), fragmenten (&lt; 25 % van het vlak) en metingen die 15 m van de trend afwijken. Elk patroon = één opschoonregel; elke regel = een gok naar iets wat een mens zeker weet.</a:t>
             </a:r>
           </a:p>
         </p:txBody>
@@ -8649,7 +8825,7 @@
               </a:defRPr>
             </a:pPr>
             <a:r>
-              <a:t>As 1 · Opschonen: van 3,99 naar 2,27 op de vaste testset</a:t>
+              <a:t>As 1 · Opschonen: van 3.99 naar 2.27 op de vaste testset</a:t>
             </a:r>
           </a:p>
         </p:txBody>
@@ -8787,14 +8963,49 @@
               </a:defRPr>
             </a:pPr>
             <a:r>
-              <a:t>• Elke variant visueel gecontroleerd (50+ varianten, dekking blijft 0,94)</a:t>
+              <a:t>• Elke variant visueel gecontroleerd (50+ varianten, dekking blijft 0.94)</a:t>
+            </a:r>
+          </a:p>
+        </p:txBody>
+      </p:sp>
+      <p:sp>
+        <p:nvSpPr>
+          <p:cNvPr id="9" name="TextBox 8"/>
+          <p:cNvSpPr txBox="1"/>
+          <p:nvPr/>
+        </p:nvSpPr>
+        <p:spPr>
+          <a:xfrm>
+            <a:off x="9418320" y="1554480"/>
+            <a:ext cx="2560320" cy="3200400"/>
+          </a:xfrm>
+          <a:prstGeom prst="rect">
+            <a:avLst/>
+          </a:prstGeom>
+          <a:noFill/>
+        </p:spPr>
+        <p:txBody>
+          <a:bodyPr wrap="square">
+            <a:spAutoFit/>
+          </a:bodyPr>
+          <a:lstStyle/>
+          <a:p>
+            <a:pPr>
+              <a:defRPr sz="1100" b="0" i="1">
+                <a:solidFill>
+                  <a:srgbClr val="6B7778"/>
+                </a:solidFill>
+              </a:defRPr>
+            </a:pPr>
+            <a:r>
+              <a:t>Leeswijzer: 4.12 was de score van het 19 aug-model op zijn eigen willekeurige train/test-splitsing. Voor het experiment is één vaste testset van 1 174 vlakken bevroren zodat 50+ varianten vergelijkbaar zijn; datzelfde model scoort daarop 3.99. Alle stappen hierna zijn op deze set gemeten.</a:t>
             </a:r>
           </a:p>
         </p:txBody>
       </p:sp>
       <p:pic>
         <p:nvPicPr>
-          <p:cNvPr id="8" name="Picture 7" descr="image.png"/>
+          <p:cNvPr id="10" name="Picture 9" descr="image.png"/>
           <p:cNvPicPr>
             <a:picLocks noChangeAspect="1"/>
           </p:cNvPicPr>
@@ -8816,41 +9027,6 @@
           </a:prstGeom>
         </p:spPr>
       </p:pic>
-      <p:sp>
-        <p:nvSpPr>
-          <p:cNvPr id="9" name="TextBox 8"/>
-          <p:cNvSpPr txBox="1"/>
-          <p:nvPr/>
-        </p:nvSpPr>
-        <p:spPr>
-          <a:xfrm>
-            <a:off x="9418320" y="1554480"/>
-            <a:ext cx="2560320" cy="3200400"/>
-          </a:xfrm>
-          <a:prstGeom prst="rect">
-            <a:avLst/>
-          </a:prstGeom>
-          <a:noFill/>
-        </p:spPr>
-        <p:txBody>
-          <a:bodyPr wrap="square">
-            <a:spAutoFit/>
-          </a:bodyPr>
-          <a:lstStyle/>
-          <a:p>
-            <a:pPr>
-              <a:defRPr sz="1100" b="0" i="1">
-                <a:solidFill>
-                  <a:srgbClr val="6B7778"/>
-                </a:solidFill>
-              </a:defRPr>
-            </a:pPr>
-            <a:r>
-              <a:t>Leeswijzer: 4,12 was de score van het 19 aug-model op zijn eigen willekeurige train/test-splitsing. Voor het experiment is één vaste testset van 1.174 vlakken bevroren zodat 50+ varianten vergelijkbaar zijn; datzelfde model scoort daarop 3,99. Alle stappen hierna zijn op deze set gemeten.</a:t>
-            </a:r>
-          </a:p>
-        </p:txBody>
-      </p:sp>
     </p:spTree>
   </p:cSld>
   <p:clrMapOvr>
@@ -8941,7 +9117,7 @@
               </a:defRPr>
             </a:pPr>
             <a:r>
-              <a:t>Deze week geleverd: kribben landelijk (1.922 → 4.698) + 6.386 kunstwerken</a:t>
+              <a:t>Deze week geleverd: kribben landelijk (1 922 → 4 698) + 6 386 kunstwerken</a:t>
             </a:r>
           </a:p>
         </p:txBody>
@@ -9005,9 +9181,112 @@
           </a:prstGeom>
         </p:spPr>
       </p:pic>
+      <p:sp>
+        <p:nvSpPr>
+          <p:cNvPr id="7" name="TextBox 6"/>
+          <p:cNvSpPr txBox="1"/>
+          <p:nvPr/>
+        </p:nvSpPr>
+        <p:spPr>
+          <a:xfrm>
+            <a:off x="7406640" y="4023360"/>
+            <a:ext cx="4572000" cy="2286000"/>
+          </a:xfrm>
+          <a:prstGeom prst="rect">
+            <a:avLst/>
+          </a:prstGeom>
+          <a:noFill/>
+        </p:spPr>
+        <p:txBody>
+          <a:bodyPr wrap="square">
+            <a:spAutoFit/>
+          </a:bodyPr>
+          <a:lstStyle/>
+          <a:p>
+            <a:pPr>
+              <a:spcAft>
+                <a:spcPts val="400"/>
+              </a:spcAft>
+              <a:defRPr sz="1200" b="0">
+                <a:solidFill>
+                  <a:srgbClr val="1F3A3D"/>
+                </a:solidFill>
+              </a:defRPr>
+            </a:pPr>
+            <a:r>
+              <a:t>• Op de vaste testset is de laag metrisch neutraal: de opschoonregels vangen deze artefacten al</a:t>
+            </a:r>
+          </a:p>
+          <a:p>
+            <a:pPr>
+              <a:spcAft>
+                <a:spcPts val="400"/>
+              </a:spcAft>
+              <a:defRPr sz="1200" b="0">
+                <a:solidFill>
+                  <a:srgbClr val="1F3A3D"/>
+                </a:solidFill>
+              </a:defRPr>
+            </a:pPr>
+            <a:r>
+              <a:t>• Wél: 218 vlakken vallen af waarvan de 'oever' een constructie was — juistheid en dekking, geen foutwinst</a:t>
+            </a:r>
+          </a:p>
+          <a:p>
+            <a:pPr>
+              <a:spcAft>
+                <a:spcPts val="400"/>
+              </a:spcAft>
+              <a:defRPr sz="1200" b="0">
+                <a:solidFill>
+                  <a:srgbClr val="1F3A3D"/>
+                </a:solidFill>
+              </a:defRPr>
+            </a:pPr>
+            <a:r>
+              <a:t>• Les: wat een regel kan afleiden, hoeft niet gelabeld · wat een regel níet kan zien, wel</a:t>
+            </a:r>
+          </a:p>
+        </p:txBody>
+      </p:sp>
+      <p:sp>
+        <p:nvSpPr>
+          <p:cNvPr id="8" name="TextBox 7"/>
+          <p:cNvSpPr txBox="1"/>
+          <p:nvPr/>
+        </p:nvSpPr>
+        <p:spPr>
+          <a:xfrm>
+            <a:off x="548640" y="5760720"/>
+            <a:ext cx="6766560" cy="548640"/>
+          </a:xfrm>
+          <a:prstGeom prst="rect">
+            <a:avLst/>
+          </a:prstGeom>
+          <a:noFill/>
+        </p:spPr>
+        <p:txBody>
+          <a:bodyPr wrap="square">
+            <a:spAutoFit/>
+          </a:bodyPr>
+          <a:lstStyle/>
+          <a:p>
+            <a:pPr>
+              <a:defRPr sz="1100" i="1">
+                <a:solidFill>
+                  <a:srgbClr val="6B7778"/>
+                </a:solidFill>
+              </a:defRPr>
+            </a:pPr>
+            <a:r>
+              <a:t>links: zonder masker · rechts: met kribben + bruggen/kades/steigers (10 m) · grijs = constructie · paars = VVR</a:t>
+            </a:r>
+          </a:p>
+        </p:txBody>
+      </p:sp>
       <p:pic>
         <p:nvPicPr>
-          <p:cNvPr id="6" name="Picture 5" descr="structures_ablation.png"/>
+          <p:cNvPr id="9" name="Picture 8" descr="image.png"/>
           <p:cNvPicPr>
             <a:picLocks noChangeAspect="1"/>
           </p:cNvPicPr>
@@ -9029,109 +9308,6 @@
           </a:prstGeom>
         </p:spPr>
       </p:pic>
-      <p:sp>
-        <p:nvSpPr>
-          <p:cNvPr id="7" name="TextBox 6"/>
-          <p:cNvSpPr txBox="1"/>
-          <p:nvPr/>
-        </p:nvSpPr>
-        <p:spPr>
-          <a:xfrm>
-            <a:off x="7406640" y="4023360"/>
-            <a:ext cx="4572000" cy="2286000"/>
-          </a:xfrm>
-          <a:prstGeom prst="rect">
-            <a:avLst/>
-          </a:prstGeom>
-          <a:noFill/>
-        </p:spPr>
-        <p:txBody>
-          <a:bodyPr wrap="square">
-            <a:spAutoFit/>
-          </a:bodyPr>
-          <a:lstStyle/>
-          <a:p>
-            <a:pPr>
-              <a:spcAft>
-                <a:spcPts val="400"/>
-              </a:spcAft>
-              <a:defRPr sz="1200" b="0">
-                <a:solidFill>
-                  <a:srgbClr val="1F3A3D"/>
-                </a:solidFill>
-              </a:defRPr>
-            </a:pPr>
-            <a:r>
-              <a:t>• Op de vaste testset is de laag metrisch neutraal: de opschoonregels vangen deze artefacten al</a:t>
-            </a:r>
-          </a:p>
-          <a:p>
-            <a:pPr>
-              <a:spcAft>
-                <a:spcPts val="400"/>
-              </a:spcAft>
-              <a:defRPr sz="1200" b="0">
-                <a:solidFill>
-                  <a:srgbClr val="1F3A3D"/>
-                </a:solidFill>
-              </a:defRPr>
-            </a:pPr>
-            <a:r>
-              <a:t>• Wél: 218 vlakken vallen af waarvan de 'oever' een constructie was — juistheid en dekking, geen foutwinst</a:t>
-            </a:r>
-          </a:p>
-          <a:p>
-            <a:pPr>
-              <a:spcAft>
-                <a:spcPts val="400"/>
-              </a:spcAft>
-              <a:defRPr sz="1200" b="0">
-                <a:solidFill>
-                  <a:srgbClr val="1F3A3D"/>
-                </a:solidFill>
-              </a:defRPr>
-            </a:pPr>
-            <a:r>
-              <a:t>• Les: wat een regel kan afleiden, hoeft niet gelabeld · wat een regel níet kan zien, wel</a:t>
-            </a:r>
-          </a:p>
-        </p:txBody>
-      </p:sp>
-      <p:sp>
-        <p:nvSpPr>
-          <p:cNvPr id="8" name="TextBox 7"/>
-          <p:cNvSpPr txBox="1"/>
-          <p:nvPr/>
-        </p:nvSpPr>
-        <p:spPr>
-          <a:xfrm>
-            <a:off x="548640" y="5760720"/>
-            <a:ext cx="6766560" cy="548640"/>
-          </a:xfrm>
-          <a:prstGeom prst="rect">
-            <a:avLst/>
-          </a:prstGeom>
-          <a:noFill/>
-        </p:spPr>
-        <p:txBody>
-          <a:bodyPr wrap="square">
-            <a:spAutoFit/>
-          </a:bodyPr>
-          <a:lstStyle/>
-          <a:p>
-            <a:pPr>
-              <a:defRPr sz="1100" i="1">
-                <a:solidFill>
-                  <a:srgbClr val="6B7778"/>
-                </a:solidFill>
-              </a:defRPr>
-            </a:pPr>
-            <a:r>
-              <a:t>links: zonder masker · rechts: met kribben + bruggen/kades/steigers (10 m) · grijs = constructie · paars = VVR</a:t>
-            </a:r>
-          </a:p>
-        </p:txBody>
-      </p:sp>
     </p:spTree>
   </p:cSld>
   <p:clrMapOvr>
@@ -9187,7 +9363,7 @@
               </a:defRPr>
             </a:pPr>
             <a:r>
-              <a:t>As 2 · Meerdere t-punten: van 2,27 naar 2,13</a:t>
+              <a:t>As 2 · Meerdere t-punten: van 2.27 naar 2.13</a:t>
             </a:r>
           </a:p>
         </p:txBody>
@@ -9262,9 +9438,137 @@
           </a:p>
         </p:txBody>
       </p:sp>
+      <p:sp>
+        <p:nvSpPr>
+          <p:cNvPr id="6" name="TextBox 5"/>
+          <p:cNvSpPr txBox="1"/>
+          <p:nvPr/>
+        </p:nvSpPr>
+        <p:spPr>
+          <a:xfrm>
+            <a:off x="7498079" y="1554480"/>
+            <a:ext cx="4480560" cy="4754880"/>
+          </a:xfrm>
+          <a:prstGeom prst="rect">
+            <a:avLst/>
+          </a:prstGeom>
+          <a:noFill/>
+        </p:spPr>
+        <p:txBody>
+          <a:bodyPr wrap="square">
+            <a:spAutoFit/>
+          </a:bodyPr>
+          <a:lstStyle/>
+          <a:p>
+            <a:pPr>
+              <a:spcAft>
+                <a:spcPts val="400"/>
+              </a:spcAft>
+              <a:defRPr sz="1300" b="1">
+                <a:solidFill>
+                  <a:srgbClr val="1F3A3D"/>
+                </a:solidFill>
+              </a:defRPr>
+            </a:pPr>
+            <a:r>
+              <a:t>Features uit de hele meetreeks</a:t>
+            </a:r>
+          </a:p>
+          <a:p>
+            <a:pPr>
+              <a:spcAft>
+                <a:spcPts val="400"/>
+              </a:spcAft>
+              <a:defRPr sz="1300" b="0">
+                <a:solidFill>
+                  <a:srgbClr val="1F3A3D"/>
+                </a:solidFill>
+              </a:defRPr>
+            </a:pPr>
+            <a:r>
+              <a:t>• Trend (Theil–Sen), spreiding om de trend, versnelling, terugkeer naar gemiddelde, recente helling</a:t>
+            </a:r>
+          </a:p>
+          <a:p>
+            <a:pPr>
+              <a:spcAft>
+                <a:spcPts val="400"/>
+              </a:spcAft>
+              <a:defRPr sz="1300" b="1">
+                <a:solidFill>
+                  <a:srgbClr val="1F3A3D"/>
+                </a:solidFill>
+              </a:defRPr>
+            </a:pPr>
+            <a:r>
+              <a:t>Wat níet werkte</a:t>
+            </a:r>
+          </a:p>
+          <a:p>
+            <a:pPr>
+              <a:spcAft>
+                <a:spcPts val="400"/>
+              </a:spcAft>
+              <a:defRPr sz="1300" b="0">
+                <a:solidFill>
+                  <a:srgbClr val="1F3A3D"/>
+                </a:solidFill>
+              </a:defRPr>
+            </a:pPr>
+            <a:r>
+              <a:t>• Trainen op losse jaar-op-jaar stappen (sub-jaar ruis), huber-loss (beter gemiddeld, slechter op de staart), debiet</a:t>
+            </a:r>
+          </a:p>
+          <a:p>
+            <a:pPr>
+              <a:spcAft>
+                <a:spcPts val="400"/>
+              </a:spcAft>
+              <a:defRPr sz="1300" b="1">
+                <a:solidFill>
+                  <a:srgbClr val="1F3A3D"/>
+                </a:solidFill>
+              </a:defRPr>
+            </a:pPr>
+            <a:r>
+              <a:t>Horizon ≥ 2 jaar — voor het alarm</a:t>
+            </a:r>
+          </a:p>
+          <a:p>
+            <a:pPr>
+              <a:spcAft>
+                <a:spcPts val="400"/>
+              </a:spcAft>
+              <a:defRPr sz="1300" b="0">
+                <a:solidFill>
+                  <a:srgbClr val="1F3A3D"/>
+                </a:solidFill>
+              </a:defRPr>
+            </a:pPr>
+            <a:r>
+              <a:t>• Hoogtemodel-paren zijn altijd 3–5 jaar uit elkaar; SAM-paren 1 jaar → ruis</a:t>
+            </a:r>
+          </a:p>
+          <a:p>
+            <a:pPr>
+              <a:spcAft>
+                <a:spcPts val="400"/>
+              </a:spcAft>
+              <a:defRPr sz="1300" b="0">
+                <a:solidFill>
+                  <a:srgbClr val="1F3A3D"/>
+                </a:solidFill>
+              </a:defRPr>
+            </a:pPr>
+            <a:r>
+              <a:t>• Zelfde doel (m/jr), zelfde fout, alleen paren ≥ 2 jaar: 1 vlak met 6 metingen = 10 leervoorbeelden</a:t>
+            </a:r>
+          </a:p>
+        </p:txBody>
+      </p:sp>
       <p:pic>
         <p:nvPicPr>
-          <p:cNvPr id="5" name="Picture 4" descr="history.png"/>
+          <p:cNvPr id="7" name="Picture 6" descr="image.png"/>
           <p:cNvPicPr>
             <a:picLocks noChangeAspect="1"/>
           </p:cNvPicPr>
@@ -9286,134 +9590,6 @@
           </a:prstGeom>
         </p:spPr>
       </p:pic>
-      <p:sp>
-        <p:nvSpPr>
-          <p:cNvPr id="6" name="TextBox 5"/>
-          <p:cNvSpPr txBox="1"/>
-          <p:nvPr/>
-        </p:nvSpPr>
-        <p:spPr>
-          <a:xfrm>
-            <a:off x="7498079" y="1554480"/>
-            <a:ext cx="4480560" cy="4754880"/>
-          </a:xfrm>
-          <a:prstGeom prst="rect">
-            <a:avLst/>
-          </a:prstGeom>
-          <a:noFill/>
-        </p:spPr>
-        <p:txBody>
-          <a:bodyPr wrap="square">
-            <a:spAutoFit/>
-          </a:bodyPr>
-          <a:lstStyle/>
-          <a:p>
-            <a:pPr>
-              <a:spcAft>
-                <a:spcPts val="400"/>
-              </a:spcAft>
-              <a:defRPr sz="1300" b="1">
-                <a:solidFill>
-                  <a:srgbClr val="1F3A3D"/>
-                </a:solidFill>
-              </a:defRPr>
-            </a:pPr>
-            <a:r>
-              <a:t>Features uit de hele meetreeks</a:t>
-            </a:r>
-          </a:p>
-          <a:p>
-            <a:pPr>
-              <a:spcAft>
-                <a:spcPts val="400"/>
-              </a:spcAft>
-              <a:defRPr sz="1300" b="0">
-                <a:solidFill>
-                  <a:srgbClr val="1F3A3D"/>
-                </a:solidFill>
-              </a:defRPr>
-            </a:pPr>
-            <a:r>
-              <a:t>• Trend (Theil–Sen), spreiding om de trend, versnelling, terugkeer naar gemiddelde, recente helling</a:t>
-            </a:r>
-          </a:p>
-          <a:p>
-            <a:pPr>
-              <a:spcAft>
-                <a:spcPts val="400"/>
-              </a:spcAft>
-              <a:defRPr sz="1300" b="1">
-                <a:solidFill>
-                  <a:srgbClr val="1F3A3D"/>
-                </a:solidFill>
-              </a:defRPr>
-            </a:pPr>
-            <a:r>
-              <a:t>Wat níet werkte</a:t>
-            </a:r>
-          </a:p>
-          <a:p>
-            <a:pPr>
-              <a:spcAft>
-                <a:spcPts val="400"/>
-              </a:spcAft>
-              <a:defRPr sz="1300" b="0">
-                <a:solidFill>
-                  <a:srgbClr val="1F3A3D"/>
-                </a:solidFill>
-              </a:defRPr>
-            </a:pPr>
-            <a:r>
-              <a:t>• Trainen op losse jaar-op-jaar stappen (sub-jaar ruis), huber-loss (beter gemiddeld, slechter op de staart), debiet</a:t>
-            </a:r>
-          </a:p>
-          <a:p>
-            <a:pPr>
-              <a:spcAft>
-                <a:spcPts val="400"/>
-              </a:spcAft>
-              <a:defRPr sz="1300" b="1">
-                <a:solidFill>
-                  <a:srgbClr val="1F3A3D"/>
-                </a:solidFill>
-              </a:defRPr>
-            </a:pPr>
-            <a:r>
-              <a:t>Horizon ≥ 2 jaar — voor het alarm</a:t>
-            </a:r>
-          </a:p>
-          <a:p>
-            <a:pPr>
-              <a:spcAft>
-                <a:spcPts val="400"/>
-              </a:spcAft>
-              <a:defRPr sz="1300" b="0">
-                <a:solidFill>
-                  <a:srgbClr val="1F3A3D"/>
-                </a:solidFill>
-              </a:defRPr>
-            </a:pPr>
-            <a:r>
-              <a:t>• Hoogtemodel-paren zijn altijd 3–5 jaar uit elkaar; SAM-paren 1 jaar → ruis</a:t>
-            </a:r>
-          </a:p>
-          <a:p>
-            <a:pPr>
-              <a:spcAft>
-                <a:spcPts val="400"/>
-              </a:spcAft>
-              <a:defRPr sz="1300" b="0">
-                <a:solidFill>
-                  <a:srgbClr val="1F3A3D"/>
-                </a:solidFill>
-              </a:defRPr>
-            </a:pPr>
-            <a:r>
-              <a:t>• Zelfde doel (m/jr), zelfde fout, alleen paren ≥ 2 jaar: 1 vlak met 6 metingen = 10 leervoorbeelden</a:t>
-            </a:r>
-          </a:p>
-        </p:txBody>
-      </p:sp>
     </p:spTree>
   </p:cSld>
   <p:clrMapOvr>

</xml_diff>

<commit_message>
docs(presentation): fix decimal conversion (literals only), regenerate charts
</commit_message>
<xml_diff>
--- a/docs/presentations/20260826_update_v2.pptx
+++ b/docs/presentations/20260826_update_v2.pptx
@@ -9005,14 +9005,14 @@
       </p:sp>
       <p:pic>
         <p:nvPicPr>
-          <p:cNvPr id="10" name="Picture 9" descr="image.png"/>
+          <p:cNvPr id="10" name="Picture 9" descr="cleaning_ladder.png"/>
           <p:cNvPicPr>
             <a:picLocks noChangeAspect="1"/>
           </p:cNvPicPr>
           <p:nvPr/>
         </p:nvPicPr>
         <p:blipFill>
-          <a:blip r:embed="rId2"/>
+          <a:blip r:embed="rId3"/>
           <a:stretch>
             <a:fillRect/>
           </a:stretch>
@@ -9286,14 +9286,14 @@
       </p:sp>
       <p:pic>
         <p:nvPicPr>
-          <p:cNvPr id="9" name="Picture 8" descr="image.png"/>
+          <p:cNvPr id="9" name="Picture 8" descr="structures_ablation.png"/>
           <p:cNvPicPr>
             <a:picLocks noChangeAspect="1"/>
           </p:cNvPicPr>
           <p:nvPr/>
         </p:nvPicPr>
         <p:blipFill>
-          <a:blip r:embed="rId3"/>
+          <a:blip r:embed="rId4"/>
           <a:stretch>
             <a:fillRect/>
           </a:stretch>

</xml_diff>

<commit_message>
docs(presentation): kribben example before the As 1 calculations, ablation chart removed from it
</commit_message>
<xml_diff>
--- a/docs/presentations/20260826_update_v2.pptx
+++ b/docs/presentations/20260826_update_v2.pptx
@@ -14,8 +14,8 @@
     <p:sldId id="270" r:id="rId5"/>
     <p:sldId id="259" r:id="rId6"/>
     <p:sldId id="271" r:id="rId7"/>
+    <p:sldId id="261" r:id="rId9"/>
     <p:sldId id="260" r:id="rId8"/>
-    <p:sldId id="261" r:id="rId9"/>
     <p:sldId id="262" r:id="rId10"/>
     <p:sldId id="263" r:id="rId11"/>
     <p:sldId id="264" r:id="rId12"/>
@@ -8895,7 +8895,7 @@
               </a:defRPr>
             </a:pPr>
             <a:r>
-              <a:t>Oevererosietool · update 26-08-2026 · 7</a:t>
+              <a:t>Oevererosietool · update 26-08-2026 · 8</a:t>
             </a:r>
           </a:p>
         </p:txBody>
@@ -9082,7 +9082,7 @@
               </a:defRPr>
             </a:pPr>
             <a:r>
-              <a:t>As 1 · Kribben en kunstwerken: nu een laag, geen gok meer</a:t>
+              <a:t>As 1 · Voorbeeld: wat een opschoonregel doet</a:t>
             </a:r>
           </a:p>
         </p:txBody>
@@ -9117,7 +9117,7 @@
               </a:defRPr>
             </a:pPr>
             <a:r>
-              <a:t>Deze week geleverd: kribben landelijk (1 922 → 4 698) + 6 386 kunstwerken</a:t>
+              <a:t>Kribvak op de Nederrijn — zonder en met structurenmasker (kribben + kunstwerken, 10 m)</a:t>
             </a:r>
           </a:p>
         </p:txBody>
@@ -9152,7 +9152,7 @@
               </a:defRPr>
             </a:pPr>
             <a:r>
-              <a:t>Oevererosietool · update 26-08-2026 · 8</a:t>
+              <a:t>Oevererosietool · update 26-08-2026 · 7</a:t>
             </a:r>
           </a:p>
         </p:txBody>
@@ -9174,7 +9174,7 @@
         <p:spPr>
           <a:xfrm>
             <a:off x="548640" y="1463040"/>
-            <a:ext cx="6766560" cy="3566490"/>
+            <a:ext cx="7863840" cy="3566490"/>
           </a:xfrm>
           <a:prstGeom prst="rect">
             <a:avLst/>
@@ -9183,14 +9183,14 @@
       </p:pic>
       <p:sp>
         <p:nvSpPr>
-          <p:cNvPr id="7" name="TextBox 6"/>
+          <p:cNvPr id="8" name="TextBox 7"/>
           <p:cNvSpPr txBox="1"/>
           <p:nvPr/>
         </p:nvSpPr>
         <p:spPr>
           <a:xfrm>
-            <a:off x="7406640" y="4023360"/>
-            <a:ext cx="4572000" cy="2286000"/>
+            <a:off x="548640" y="5669280"/>
+            <a:ext cx="7863840" cy="548640"/>
           </a:xfrm>
           <a:prstGeom prst="rect">
             <a:avLst/>
@@ -9204,61 +9204,28 @@
           <a:lstStyle/>
           <a:p>
             <a:pPr>
-              <a:spcAft>
-                <a:spcPts val="400"/>
-              </a:spcAft>
-              <a:defRPr sz="1200" b="0">
-                <a:solidFill>
-                  <a:srgbClr val="1F3A3D"/>
-                </a:solidFill>
-              </a:defRPr>
-            </a:pPr>
-            <a:r>
-              <a:t>• Op de vaste testset is de laag metrisch neutraal: de opschoonregels vangen deze artefacten al</a:t>
-            </a:r>
-          </a:p>
-          <a:p>
-            <a:pPr>
-              <a:spcAft>
-                <a:spcPts val="400"/>
-              </a:spcAft>
-              <a:defRPr sz="1200" b="0">
-                <a:solidFill>
-                  <a:srgbClr val="1F3A3D"/>
-                </a:solidFill>
-              </a:defRPr>
-            </a:pPr>
-            <a:r>
-              <a:t>• Wél: 218 vlakken vallen af waarvan de 'oever' een constructie was — juistheid en dekking, geen foutwinst</a:t>
-            </a:r>
-          </a:p>
-          <a:p>
-            <a:pPr>
-              <a:spcAft>
-                <a:spcPts val="400"/>
-              </a:spcAft>
-              <a:defRPr sz="1200" b="0">
-                <a:solidFill>
-                  <a:srgbClr val="1F3A3D"/>
-                </a:solidFill>
-              </a:defRPr>
-            </a:pPr>
-            <a:r>
-              <a:t>• Les: wat een regel kan afleiden, hoeft niet gelabeld · wat een regel níet kan zien, wel</a:t>
-            </a:r>
-          </a:p>
-        </p:txBody>
-      </p:sp>
-      <p:sp>
-        <p:nvSpPr>
-          <p:cNvPr id="8" name="TextBox 7"/>
+              <a:defRPr sz="1100" i="1">
+                <a:solidFill>
+                  <a:srgbClr val="6B7778"/>
+                </a:solidFill>
+              </a:defRPr>
+            </a:pPr>
+            <a:r>
+              <a:t>links: zonder masker · rechts: met kribben + bruggen/kades/steigers (10 m) · grijs = constructie · paars = VVR</a:t>
+            </a:r>
+          </a:p>
+        </p:txBody>
+      </p:sp>
+      <p:sp>
+        <p:nvSpPr>
+          <p:cNvPr id="9" name="TextBox 8"/>
           <p:cNvSpPr txBox="1"/>
           <p:nvPr/>
         </p:nvSpPr>
         <p:spPr>
           <a:xfrm>
-            <a:off x="548640" y="5760720"/>
-            <a:ext cx="6766560" cy="548640"/>
+            <a:off x="8686800" y="1554480"/>
+            <a:ext cx="3291840" cy="4572000"/>
           </a:xfrm>
           <a:prstGeom prst="rect">
             <a:avLst/>
@@ -9272,42 +9239,66 @@
           <a:lstStyle/>
           <a:p>
             <a:pPr>
-              <a:defRPr sz="1100" i="1">
-                <a:solidFill>
-                  <a:srgbClr val="6B7778"/>
-                </a:solidFill>
-              </a:defRPr>
-            </a:pPr>
-            <a:r>
-              <a:t>links: zonder masker · rechts: met kribben + bruggen/kades/steigers (10 m) · grijs = constructie · paars = VVR</a:t>
-            </a:r>
-          </a:p>
-        </p:txBody>
-      </p:sp>
-      <p:pic>
-        <p:nvPicPr>
-          <p:cNvPr id="9" name="Picture 8" descr="structures_ablation.png"/>
-          <p:cNvPicPr>
-            <a:picLocks noChangeAspect="1"/>
-          </p:cNvPicPr>
-          <p:nvPr/>
-        </p:nvPicPr>
-        <p:blipFill>
-          <a:blip r:embed="rId4"/>
-          <a:stretch>
-            <a:fillRect/>
-          </a:stretch>
-        </p:blipFill>
-        <p:spPr>
-          <a:xfrm>
-            <a:off x="7406640" y="1463040"/>
-            <a:ext cx="4572000" cy="1909849"/>
-          </a:xfrm>
-          <a:prstGeom prst="rect">
-            <a:avLst/>
-          </a:prstGeom>
-        </p:spPr>
-      </p:pic>
+              <a:spcAft>
+                <a:spcPts val="600"/>
+              </a:spcAft>
+              <a:defRPr sz="1300">
+                <a:solidFill>
+                  <a:srgbClr val="1F3A3D"/>
+                </a:solidFill>
+              </a:defRPr>
+            </a:pPr>
+            <a:r>
+              <a:t>• Zonder masker volgt de 'oever' de kribflank: het ene getal per jaar (gestippeld) springt heen en weer — +7.7 m/jr</a:t>
+            </a:r>
+          </a:p>
+          <a:p>
+            <a:pPr>
+              <a:spcAft>
+                <a:spcPts val="600"/>
+              </a:spcAft>
+              <a:defRPr sz="1300">
+                <a:solidFill>
+                  <a:srgbClr val="1F3A3D"/>
+                </a:solidFill>
+              </a:defRPr>
+            </a:pPr>
+            <a:r>
+              <a:t>• Met masker vallen de kribpunten weg en blijft de echte oever over: −22.2 m/jr, consistent over de jaren</a:t>
+            </a:r>
+          </a:p>
+          <a:p>
+            <a:pPr>
+              <a:spcAft>
+                <a:spcPts val="600"/>
+              </a:spcAft>
+              <a:defRPr sz="1300">
+                <a:solidFill>
+                  <a:srgbClr val="1F3A3D"/>
+                </a:solidFill>
+              </a:defRPr>
+            </a:pPr>
+            <a:r>
+              <a:t>• Zo werkt elke regel: niet de meting weggooien, maar het deel dat geen oever is</a:t>
+            </a:r>
+          </a:p>
+          <a:p>
+            <a:pPr>
+              <a:spcAft>
+                <a:spcPts val="600"/>
+              </a:spcAft>
+              <a:defRPr sz="1300">
+                <a:solidFill>
+                  <a:srgbClr val="1F3A3D"/>
+                </a:solidFill>
+              </a:defRPr>
+            </a:pPr>
+            <a:r>
+              <a:t>• Deze week: kribben landelijk (1 922 → 4 698) en 6 386 kunstwerken als laag — geen gok meer</a:t>
+            </a:r>
+          </a:p>
+        </p:txBody>
+      </p:sp>
     </p:spTree>
   </p:cSld>
   <p:clrMapOvr>

</xml_diff>

<commit_message>
docs(presentation): As 1 — regions touched per rule, single-rule ablation; ledger r1-r6
</commit_message>
<xml_diff>
--- a/docs/presentations/20260826_update_v2.pptx
+++ b/docs/presentations/20260826_update_v2.pptx
@@ -15,6 +15,8 @@
     <p:sldId id="259" r:id="rId6"/>
     <p:sldId id="271" r:id="rId7"/>
     <p:sldId id="261" r:id="rId9"/>
+    <p:sldId id="272" r:id="rId23"/>
+    <p:sldId id="273" r:id="rId24"/>
     <p:sldId id="260" r:id="rId8"/>
     <p:sldId id="262" r:id="rId10"/>
     <p:sldId id="263" r:id="rId11"/>
@@ -3831,7 +3833,7 @@
               </a:defRPr>
             </a:pPr>
             <a:r>
-              <a:t>Oevererosietool · update 26-08-2026 · 10</a:t>
+              <a:t>Oevererosietool · update 26-08-2026 · 12</a:t>
             </a:r>
           </a:p>
         </p:txBody>
@@ -4143,7 +4145,7 @@
               </a:defRPr>
             </a:pPr>
             <a:r>
-              <a:t>Oevererosietool · update 26-08-2026 · 11</a:t>
+              <a:t>Oevererosietool · update 26-08-2026 · 13</a:t>
             </a:r>
           </a:p>
         </p:txBody>
@@ -4404,7 +4406,7 @@
               </a:defRPr>
             </a:pPr>
             <a:r>
-              <a:t>Oevererosietool · update 26-08-2026 · 12</a:t>
+              <a:t>Oevererosietool · update 26-08-2026 · 14</a:t>
             </a:r>
           </a:p>
         </p:txBody>
@@ -4611,7 +4613,7 @@
               </a:defRPr>
             </a:pPr>
             <a:r>
-              <a:t>Oevererosietool · update 26-08-2026 · 13</a:t>
+              <a:t>Oevererosietool · update 26-08-2026 · 15</a:t>
             </a:r>
           </a:p>
         </p:txBody>
@@ -5376,7 +5378,7 @@
               </a:defRPr>
             </a:pPr>
             <a:r>
-              <a:t>Oevererosietool · update 26-08-2026 · 14</a:t>
+              <a:t>Oevererosietool · update 26-08-2026 · 16</a:t>
             </a:r>
           </a:p>
         </p:txBody>
@@ -5866,7 +5868,7 @@
               </a:defRPr>
             </a:pPr>
             <a:r>
-              <a:t>Oevererosietool · update 26-08-2026 · 15</a:t>
+              <a:t>Oevererosietool · update 26-08-2026 · 17</a:t>
             </a:r>
           </a:p>
         </p:txBody>
@@ -6083,7 +6085,7 @@
               </a:defRPr>
             </a:pPr>
             <a:r>
-              <a:t>Oevererosietool · update 26-08-2026 · 16</a:t>
+              <a:t>Oevererosietool · update 26-08-2026 · 18</a:t>
             </a:r>
           </a:p>
         </p:txBody>
@@ -6227,6 +6229,466 @@
             </a:pPr>
             <a:r>
               <a:t>• Labelronde met SAM- en hoogtemodel-engineers · VVR-alarm op segmentniveau · daarna opnieuw meten</a:t>
+            </a:r>
+          </a:p>
+        </p:txBody>
+      </p:sp>
+    </p:spTree>
+  </p:cSld>
+  <p:clrMapOvr>
+    <a:masterClrMapping/>
+  </p:clrMapOvr>
+</p:sld>
+</file>
+
+<file path=ppt/slides/slide17.xml><?xml version="1.0" encoding="utf-8"?>
+<p:sld xmlns:a="http://schemas.openxmlformats.org/drawingml/2006/main" xmlns:p="http://schemas.openxmlformats.org/presentationml/2006/main" xmlns:r="http://schemas.openxmlformats.org/officeDocument/2006/relationships">
+  <p:cSld>
+    <p:spTree>
+      <p:nvGrpSpPr>
+        <p:cNvPr id="1" name=""/>
+        <p:cNvGrpSpPr/>
+        <p:nvPr/>
+      </p:nvGrpSpPr>
+      <p:grpSpPr/>
+      <p:sp>
+        <p:nvSpPr>
+          <p:cNvPr id="2" name="TextBox 1"/>
+          <p:cNvSpPr txBox="1"/>
+          <p:nvPr/>
+        </p:nvSpPr>
+        <p:spPr>
+          <a:xfrm>
+            <a:off x="548640" y="320040"/>
+            <a:ext cx="10972800" cy="731520"/>
+          </a:xfrm>
+          <a:prstGeom prst="rect">
+            <a:avLst/>
+          </a:prstGeom>
+          <a:noFill/>
+        </p:spPr>
+        <p:txBody>
+          <a:bodyPr wrap="square">
+            <a:spAutoFit/>
+          </a:bodyPr>
+          <a:lstStyle/>
+          <a:p>
+            <a:pPr>
+              <a:defRPr sz="3000" b="1" i="0">
+                <a:solidFill>
+                  <a:srgbClr val="2BB5A6"/>
+                </a:solidFill>
+              </a:defRPr>
+            </a:pPr>
+            <a:r>
+              <a:t>As 1 · Hoeveel vlakken raakt elke regel?</a:t>
+            </a:r>
+          </a:p>
+        </p:txBody>
+      </p:sp>
+      <p:sp>
+        <p:nvSpPr>
+          <p:cNvPr id="3" name="TextBox 2"/>
+          <p:cNvSpPr txBox="1"/>
+          <p:nvPr/>
+        </p:nvSpPr>
+        <p:spPr>
+          <a:xfrm>
+            <a:off x="548640" y="960120"/>
+            <a:ext cx="10972800" cy="548640"/>
+          </a:xfrm>
+          <a:prstGeom prst="rect">
+            <a:avLst/>
+          </a:prstGeom>
+          <a:noFill/>
+        </p:spPr>
+        <p:txBody>
+          <a:bodyPr wrap="square">
+            <a:spAutoFit/>
+          </a:bodyPr>
+          <a:lstStyle/>
+          <a:p>
+            <a:pPr>
+              <a:defRPr sz="1700" b="0" i="0">
+                <a:solidFill>
+                  <a:srgbClr val="1F3A3D"/>
+                </a:solidFill>
+              </a:defRPr>
+            </a:pPr>
+            <a:r>
+              <a:t>Elke regel apart op de basisdata · een vlak kan in meerdere balken staan</a:t>
+            </a:r>
+          </a:p>
+        </p:txBody>
+      </p:sp>
+      <p:pic>
+        <p:nvPicPr>
+          <p:cNvPr id="4" name="Picture 3" descr="rule_touched.png"/>
+          <p:cNvPicPr>
+            <a:picLocks noChangeAspect="1"/>
+          </p:cNvPicPr>
+          <p:nvPr/>
+        </p:nvPicPr>
+        <p:blipFill>
+          <a:blip r:embed="rId2"/>
+          <a:stretch>
+            <a:fillRect/>
+          </a:stretch>
+        </p:blipFill>
+        <p:spPr>
+          <a:xfrm>
+            <a:off x="365760" y="1554480"/>
+            <a:ext cx="7863840" cy="3431494"/>
+          </a:xfrm>
+          <a:prstGeom prst="rect">
+            <a:avLst/>
+          </a:prstGeom>
+        </p:spPr>
+      </p:pic>
+      <p:sp>
+        <p:nvSpPr>
+          <p:cNvPr id="5" name="TextBox 4"/>
+          <p:cNvSpPr txBox="1"/>
+          <p:nvPr/>
+        </p:nvSpPr>
+        <p:spPr>
+          <a:xfrm>
+            <a:off x="8503920" y="1645920"/>
+            <a:ext cx="3474720" cy="4572000"/>
+          </a:xfrm>
+          <a:prstGeom prst="rect">
+            <a:avLst/>
+          </a:prstGeom>
+          <a:noFill/>
+        </p:spPr>
+        <p:txBody>
+          <a:bodyPr wrap="square">
+            <a:spAutoFit/>
+          </a:bodyPr>
+          <a:lstStyle/>
+          <a:p>
+            <a:pPr>
+              <a:spcAft>
+                <a:spcPts val="500"/>
+              </a:spcAft>
+              <a:defRPr sz="1300">
+                <a:solidFill>
+                  <a:srgbClr val="1F3A3D"/>
+                </a:solidFill>
+              </a:defRPr>
+            </a:pPr>
+            <a:r>
+              <a:t>• 5 165 van de 11 517 vlakken worden door ≥ 1 regel geraakt; 284 verdwijnen helemaal</a:t>
+            </a:r>
+          </a:p>
+          <a:p>
+            <a:pPr>
+              <a:spcAft>
+                <a:spcPts val="500"/>
+              </a:spcAft>
+              <a:defRPr sz="1300">
+                <a:solidFill>
+                  <a:srgbClr val="1F3A3D"/>
+                </a:solidFill>
+              </a:defRPr>
+            </a:pPr>
+            <a:r>
+              <a:t>• Kronkelende lijnen, doolhoven en uitschieters in de tijd zijn púúr SAM-verschijnselen</a:t>
+            </a:r>
+          </a:p>
+          <a:p>
+            <a:pPr>
+              <a:spcAft>
+                <a:spcPts val="500"/>
+              </a:spcAft>
+              <a:defRPr sz="1300">
+                <a:solidFill>
+                  <a:srgbClr val="1F3A3D"/>
+                </a:solidFill>
+              </a:defRPr>
+            </a:pPr>
+            <a:r>
+              <a:t>• Hoogtemodel-vlakken worden vrijwel alleen door het kribbenmasker en fragmenten geraakt (429 van 2 033)</a:t>
+            </a:r>
+          </a:p>
+          <a:p>
+            <a:pPr>
+              <a:spcAft>
+                <a:spcPts val="500"/>
+              </a:spcAft>
+              <a:defRPr sz="1300">
+                <a:solidFill>
+                  <a:srgbClr val="1F3A3D"/>
+                </a:solidFill>
+              </a:defRPr>
+            </a:pPr>
+            <a:r>
+              <a:t>• 'Te weinig punten' raakt op zichzelf niets — het bijt pas nadat andere regels een meting uitdunnen</a:t>
+            </a:r>
+          </a:p>
+        </p:txBody>
+      </p:sp>
+      <p:sp>
+        <p:nvSpPr>
+          <p:cNvPr id="6" name="TextBox 5"/>
+          <p:cNvSpPr txBox="1"/>
+          <p:nvPr/>
+        </p:nvSpPr>
+        <p:spPr>
+          <a:xfrm>
+            <a:off x="548640" y="6400800"/>
+            <a:ext cx="10972800" cy="274320"/>
+          </a:xfrm>
+          <a:prstGeom prst="rect">
+            <a:avLst/>
+          </a:prstGeom>
+          <a:noFill/>
+        </p:spPr>
+        <p:txBody>
+          <a:bodyPr wrap="square">
+            <a:spAutoFit/>
+          </a:bodyPr>
+          <a:lstStyle/>
+          <a:p>
+            <a:pPr>
+              <a:defRPr sz="1000" b="0" i="0">
+                <a:solidFill>
+                  <a:srgbClr val="6B7778"/>
+                </a:solidFill>
+              </a:defRPr>
+            </a:pPr>
+            <a:r>
+              <a:t>Oevererosietool · update 26-08-2026 · 8</a:t>
+            </a:r>
+          </a:p>
+        </p:txBody>
+      </p:sp>
+    </p:spTree>
+  </p:cSld>
+  <p:clrMapOvr>
+    <a:masterClrMapping/>
+  </p:clrMapOvr>
+</p:sld>
+</file>
+
+<file path=ppt/slides/slide18.xml><?xml version="1.0" encoding="utf-8"?>
+<p:sld xmlns:a="http://schemas.openxmlformats.org/drawingml/2006/main" xmlns:p="http://schemas.openxmlformats.org/presentationml/2006/main" xmlns:r="http://schemas.openxmlformats.org/officeDocument/2006/relationships">
+  <p:cSld>
+    <p:spTree>
+      <p:nvGrpSpPr>
+        <p:cNvPr id="1" name=""/>
+        <p:cNvGrpSpPr/>
+        <p:nvPr/>
+      </p:nvGrpSpPr>
+      <p:grpSpPr/>
+      <p:sp>
+        <p:nvSpPr>
+          <p:cNvPr id="2" name="TextBox 1"/>
+          <p:cNvSpPr txBox="1"/>
+          <p:nvPr/>
+        </p:nvSpPr>
+        <p:spPr>
+          <a:xfrm>
+            <a:off x="548640" y="320040"/>
+            <a:ext cx="10972800" cy="731520"/>
+          </a:xfrm>
+          <a:prstGeom prst="rect">
+            <a:avLst/>
+          </a:prstGeom>
+          <a:noFill/>
+        </p:spPr>
+        <p:txBody>
+          <a:bodyPr wrap="square">
+            <a:spAutoFit/>
+          </a:bodyPr>
+          <a:lstStyle/>
+          <a:p>
+            <a:pPr>
+              <a:defRPr sz="3000" b="1" i="0">
+                <a:solidFill>
+                  <a:srgbClr val="2BB5A6"/>
+                </a:solidFill>
+              </a:defRPr>
+            </a:pPr>
+            <a:r>
+              <a:t>As 1 · Wat doet elke regel alleen?</a:t>
+            </a:r>
+          </a:p>
+        </p:txBody>
+      </p:sp>
+      <p:sp>
+        <p:nvSpPr>
+          <p:cNvPr id="3" name="TextBox 2"/>
+          <p:cNvSpPr txBox="1"/>
+          <p:nvPr/>
+        </p:nvSpPr>
+        <p:spPr>
+          <a:xfrm>
+            <a:off x="548640" y="960120"/>
+            <a:ext cx="10972800" cy="548640"/>
+          </a:xfrm>
+          <a:prstGeom prst="rect">
+            <a:avLst/>
+          </a:prstGeom>
+          <a:noFill/>
+        </p:spPr>
+        <p:txBody>
+          <a:bodyPr wrap="square">
+            <a:spAutoFit/>
+          </a:bodyPr>
+          <a:lstStyle/>
+          <a:p>
+            <a:pPr>
+              <a:defRPr sz="1700" b="0" i="0">
+                <a:solidFill>
+                  <a:srgbClr val="1F3A3D"/>
+                </a:solidFill>
+              </a:defRPr>
+            </a:pPr>
+            <a:r>
+              <a:t>Elke regel apart op het 19 aug-model · vaste testset · resolutie 1</a:t>
+            </a:r>
+          </a:p>
+        </p:txBody>
+      </p:sp>
+      <p:pic>
+        <p:nvPicPr>
+          <p:cNvPr id="4" name="Picture 3" descr="rule_ablation.png"/>
+          <p:cNvPicPr>
+            <a:picLocks noChangeAspect="1"/>
+          </p:cNvPicPr>
+          <p:nvPr/>
+        </p:nvPicPr>
+        <p:blipFill>
+          <a:blip r:embed="rId2"/>
+          <a:stretch>
+            <a:fillRect/>
+          </a:stretch>
+        </p:blipFill>
+        <p:spPr>
+          <a:xfrm>
+            <a:off x="365760" y="1554480"/>
+            <a:ext cx="7863840" cy="3431494"/>
+          </a:xfrm>
+          <a:prstGeom prst="rect">
+            <a:avLst/>
+          </a:prstGeom>
+        </p:spPr>
+      </p:pic>
+      <p:sp>
+        <p:nvSpPr>
+          <p:cNvPr id="5" name="TextBox 4"/>
+          <p:cNvSpPr txBox="1"/>
+          <p:nvPr/>
+        </p:nvSpPr>
+        <p:spPr>
+          <a:xfrm>
+            <a:off x="8503920" y="1645920"/>
+            <a:ext cx="3474720" cy="4572000"/>
+          </a:xfrm>
+          <a:prstGeom prst="rect">
+            <a:avLst/>
+          </a:prstGeom>
+          <a:noFill/>
+        </p:spPr>
+        <p:txBody>
+          <a:bodyPr wrap="square">
+            <a:spAutoFit/>
+          </a:bodyPr>
+          <a:lstStyle/>
+          <a:p>
+            <a:pPr>
+              <a:spcAft>
+                <a:spcPts val="500"/>
+              </a:spcAft>
+              <a:defRPr sz="1300">
+                <a:solidFill>
+                  <a:srgbClr val="1F3A3D"/>
+                </a:solidFill>
+              </a:defRPr>
+            </a:pPr>
+            <a:r>
+              <a:t>• Grootste winst: de uitschieter in de tijd (3.99 → 3.03) — één afwijkende meting vervuilde het hele vlak</a:t>
+            </a:r>
+          </a:p>
+          <a:p>
+            <a:pPr>
+              <a:spcAft>
+                <a:spcPts val="500"/>
+              </a:spcAft>
+              <a:defRPr sz="1300">
+                <a:solidFill>
+                  <a:srgbClr val="1F3A3D"/>
+                </a:solidFill>
+              </a:defRPr>
+            </a:pPr>
+            <a:r>
+              <a:t>• Doolhof, fragment en kronkelende lijn elk ≈ −0.3 tot −0.4</a:t>
+            </a:r>
+          </a:p>
+          <a:p>
+            <a:pPr>
+              <a:spcAft>
+                <a:spcPts val="500"/>
+              </a:spcAft>
+              <a:defRPr sz="1300">
+                <a:solidFill>
+                  <a:srgbClr val="1F3A3D"/>
+                </a:solidFill>
+              </a:defRPr>
+            </a:pPr>
+            <a:r>
+              <a:t>• Verkeerde oever en te weinig punten alleen: nauwelijks — ze werken pas in combinatie</a:t>
+            </a:r>
+          </a:p>
+          <a:p>
+            <a:pPr>
+              <a:spcAft>
+                <a:spcPts val="500"/>
+              </a:spcAft>
+              <a:defRPr sz="1300">
+                <a:solidFill>
+                  <a:srgbClr val="1F3A3D"/>
+                </a:solidFill>
+              </a:defRPr>
+            </a:pPr>
+            <a:r>
+              <a:t>• Samen: 2.27 — meer dan de som van de delen, omdat de regels elkaars ruis wegnemen</a:t>
+            </a:r>
+          </a:p>
+        </p:txBody>
+      </p:sp>
+      <p:sp>
+        <p:nvSpPr>
+          <p:cNvPr id="6" name="TextBox 5"/>
+          <p:cNvSpPr txBox="1"/>
+          <p:nvPr/>
+        </p:nvSpPr>
+        <p:spPr>
+          <a:xfrm>
+            <a:off x="548640" y="6400800"/>
+            <a:ext cx="10972800" cy="274320"/>
+          </a:xfrm>
+          <a:prstGeom prst="rect">
+            <a:avLst/>
+          </a:prstGeom>
+          <a:noFill/>
+        </p:spPr>
+        <p:txBody>
+          <a:bodyPr wrap="square">
+            <a:spAutoFit/>
+          </a:bodyPr>
+          <a:lstStyle/>
+          <a:p>
+            <a:pPr>
+              <a:defRPr sz="1000" b="0" i="0">
+                <a:solidFill>
+                  <a:srgbClr val="6B7778"/>
+                </a:solidFill>
+              </a:defRPr>
+            </a:pPr>
+            <a:r>
+              <a:t>Oevererosietool · update 26-08-2026 · 9</a:t>
             </a:r>
           </a:p>
         </p:txBody>
@@ -8825,7 +9287,7 @@
               </a:defRPr>
             </a:pPr>
             <a:r>
-              <a:t>As 1 · Opschonen: van 3.99 naar 2.27 op de vaste testset</a:t>
+              <a:t>As 1 · Voorbeeld: wat een opschoonregel doet</a:t>
             </a:r>
           </a:p>
         </p:txBody>
@@ -8860,7 +9322,7 @@
               </a:defRPr>
             </a:pPr>
             <a:r>
-              <a:t>Zeven regels — herstellen in plaats van weggooien</a:t>
+              <a:t>Kribvak op de Nederrijn — zonder en met structurenmasker (kribben + kunstwerken, 10 m)</a:t>
             </a:r>
           </a:p>
         </p:txBody>
@@ -8895,124 +9357,21 @@
               </a:defRPr>
             </a:pPr>
             <a:r>
-              <a:t>Oevererosietool · update 26-08-2026 · 8</a:t>
-            </a:r>
-          </a:p>
-        </p:txBody>
-      </p:sp>
-      <p:sp>
-        <p:nvSpPr>
-          <p:cNvPr id="7" name="TextBox 6"/>
-          <p:cNvSpPr txBox="1"/>
-          <p:nvPr/>
-        </p:nvSpPr>
-        <p:spPr>
-          <a:xfrm>
-            <a:off x="548640" y="4572000"/>
-            <a:ext cx="6949440" cy="1737360"/>
-          </a:xfrm>
-          <a:prstGeom prst="rect">
-            <a:avLst/>
-          </a:prstGeom>
-          <a:noFill/>
-        </p:spPr>
-        <p:txBody>
-          <a:bodyPr wrap="square">
-            <a:spAutoFit/>
-          </a:bodyPr>
-          <a:lstStyle/>
-          <a:p>
-            <a:pPr>
-              <a:spcAft>
-                <a:spcPts val="400"/>
-              </a:spcAft>
-              <a:defRPr sz="1300" b="0">
-                <a:solidFill>
-                  <a:srgbClr val="1F3A3D"/>
-                </a:solidFill>
-              </a:defRPr>
-            </a:pPr>
-            <a:r>
-              <a:t>• Kronkelende lijnen, verkeerde oever, doolhoven, fragmenten, te weinig punten, uitschieters t.o.v. de trend</a:t>
-            </a:r>
-          </a:p>
-          <a:p>
-            <a:pPr>
-              <a:spcAft>
-                <a:spcPts val="400"/>
-              </a:spcAft>
-              <a:defRPr sz="1300" b="0">
-                <a:solidFill>
-                  <a:srgbClr val="1F3A3D"/>
-                </a:solidFill>
-              </a:defRPr>
-            </a:pPr>
-            <a:r>
-              <a:t>• Een uitschieter kost één meting, niet het hele vlak: +511 vlakken t.o.v. de oude |v| &gt; 50-filter</a:t>
-            </a:r>
-          </a:p>
-          <a:p>
-            <a:pPr>
-              <a:spcAft>
-                <a:spcPts val="400"/>
-              </a:spcAft>
-              <a:defRPr sz="1300" b="0">
-                <a:solidFill>
-                  <a:srgbClr val="1F3A3D"/>
-                </a:solidFill>
-              </a:defRPr>
-            </a:pPr>
-            <a:r>
-              <a:t>• Elke variant visueel gecontroleerd (50+ varianten, dekking blijft 0.94)</a:t>
-            </a:r>
-          </a:p>
-        </p:txBody>
-      </p:sp>
-      <p:sp>
-        <p:nvSpPr>
-          <p:cNvPr id="9" name="TextBox 8"/>
-          <p:cNvSpPr txBox="1"/>
-          <p:nvPr/>
-        </p:nvSpPr>
-        <p:spPr>
-          <a:xfrm>
-            <a:off x="9418320" y="1554480"/>
-            <a:ext cx="2560320" cy="3200400"/>
-          </a:xfrm>
-          <a:prstGeom prst="rect">
-            <a:avLst/>
-          </a:prstGeom>
-          <a:noFill/>
-        </p:spPr>
-        <p:txBody>
-          <a:bodyPr wrap="square">
-            <a:spAutoFit/>
-          </a:bodyPr>
-          <a:lstStyle/>
-          <a:p>
-            <a:pPr>
-              <a:defRPr sz="1100" b="0" i="1">
-                <a:solidFill>
-                  <a:srgbClr val="6B7778"/>
-                </a:solidFill>
-              </a:defRPr>
-            </a:pPr>
-            <a:r>
-              <a:t>Leeswijzer: 4.12 was de score van het 19 aug-model op zijn eigen willekeurige train/test-splitsing. Voor het experiment is één vaste testset van 1 174 vlakken bevroren zodat 50+ varianten vergelijkbaar zijn; datzelfde model scoort daarop 3.99. Alle stappen hierna zijn op deze set gemeten.</a:t>
+              <a:t>Oevererosietool · update 26-08-2026 · 7</a:t>
             </a:r>
           </a:p>
         </p:txBody>
       </p:sp>
       <p:pic>
         <p:nvPicPr>
-          <p:cNvPr id="10" name="Picture 9" descr="cleaning_ladder.png"/>
+          <p:cNvPr id="5" name="Picture 4" descr="nederrijn_r_4780_4790.png"/>
           <p:cNvPicPr>
             <a:picLocks noChangeAspect="1"/>
           </p:cNvPicPr>
           <p:nvPr/>
         </p:nvPicPr>
         <p:blipFill>
-          <a:blip r:embed="rId4"/>
+          <a:blip r:embed="rId2"/>
           <a:stretch>
             <a:fillRect/>
           </a:stretch>
@@ -9020,13 +9379,131 @@
         <p:spPr>
           <a:xfrm>
             <a:off x="548640" y="1463040"/>
-            <a:ext cx="8686800" cy="3628713"/>
+            <a:ext cx="7863840" cy="3566490"/>
           </a:xfrm>
           <a:prstGeom prst="rect">
             <a:avLst/>
           </a:prstGeom>
         </p:spPr>
       </p:pic>
+      <p:sp>
+        <p:nvSpPr>
+          <p:cNvPr id="8" name="TextBox 7"/>
+          <p:cNvSpPr txBox="1"/>
+          <p:nvPr/>
+        </p:nvSpPr>
+        <p:spPr>
+          <a:xfrm>
+            <a:off x="548640" y="5669280"/>
+            <a:ext cx="7863840" cy="548640"/>
+          </a:xfrm>
+          <a:prstGeom prst="rect">
+            <a:avLst/>
+          </a:prstGeom>
+          <a:noFill/>
+        </p:spPr>
+        <p:txBody>
+          <a:bodyPr wrap="square">
+            <a:spAutoFit/>
+          </a:bodyPr>
+          <a:lstStyle/>
+          <a:p>
+            <a:pPr>
+              <a:defRPr sz="1100" i="1">
+                <a:solidFill>
+                  <a:srgbClr val="6B7778"/>
+                </a:solidFill>
+              </a:defRPr>
+            </a:pPr>
+            <a:r>
+              <a:t>links: zonder masker · rechts: met kribben + bruggen/kades/steigers (10 m) · grijs = constructie · paars = VVR</a:t>
+            </a:r>
+          </a:p>
+        </p:txBody>
+      </p:sp>
+      <p:sp>
+        <p:nvSpPr>
+          <p:cNvPr id="9" name="TextBox 8"/>
+          <p:cNvSpPr txBox="1"/>
+          <p:nvPr/>
+        </p:nvSpPr>
+        <p:spPr>
+          <a:xfrm>
+            <a:off x="8686800" y="1554480"/>
+            <a:ext cx="3291840" cy="4572000"/>
+          </a:xfrm>
+          <a:prstGeom prst="rect">
+            <a:avLst/>
+          </a:prstGeom>
+          <a:noFill/>
+        </p:spPr>
+        <p:txBody>
+          <a:bodyPr wrap="square">
+            <a:spAutoFit/>
+          </a:bodyPr>
+          <a:lstStyle/>
+          <a:p>
+            <a:pPr>
+              <a:spcAft>
+                <a:spcPts val="600"/>
+              </a:spcAft>
+              <a:defRPr sz="1300">
+                <a:solidFill>
+                  <a:srgbClr val="1F3A3D"/>
+                </a:solidFill>
+              </a:defRPr>
+            </a:pPr>
+            <a:r>
+              <a:t>• Zonder masker volgt de 'oever' de kribflank: het ene getal per jaar (gestippeld) springt heen en weer — +7.7 m/jr</a:t>
+            </a:r>
+          </a:p>
+          <a:p>
+            <a:pPr>
+              <a:spcAft>
+                <a:spcPts val="600"/>
+              </a:spcAft>
+              <a:defRPr sz="1300">
+                <a:solidFill>
+                  <a:srgbClr val="1F3A3D"/>
+                </a:solidFill>
+              </a:defRPr>
+            </a:pPr>
+            <a:r>
+              <a:t>• Met masker vallen de kribpunten weg en blijft de echte oever over: −22.2 m/jr, consistent over de jaren</a:t>
+            </a:r>
+          </a:p>
+          <a:p>
+            <a:pPr>
+              <a:spcAft>
+                <a:spcPts val="600"/>
+              </a:spcAft>
+              <a:defRPr sz="1300">
+                <a:solidFill>
+                  <a:srgbClr val="1F3A3D"/>
+                </a:solidFill>
+              </a:defRPr>
+            </a:pPr>
+            <a:r>
+              <a:t>• Zo werkt elke regel: niet de meting weggooien, maar het deel dat geen oever is</a:t>
+            </a:r>
+          </a:p>
+          <a:p>
+            <a:pPr>
+              <a:spcAft>
+                <a:spcPts val="600"/>
+              </a:spcAft>
+              <a:defRPr sz="1300">
+                <a:solidFill>
+                  <a:srgbClr val="1F3A3D"/>
+                </a:solidFill>
+              </a:defRPr>
+            </a:pPr>
+            <a:r>
+              <a:t>• Deze week: kribben landelijk (1 922 → 4 698) en 6 386 kunstwerken als laag — geen gok meer</a:t>
+            </a:r>
+          </a:p>
+        </p:txBody>
+      </p:sp>
     </p:spTree>
   </p:cSld>
   <p:clrMapOvr>
@@ -9082,7 +9559,7 @@
               </a:defRPr>
             </a:pPr>
             <a:r>
-              <a:t>As 1 · Voorbeeld: wat een opschoonregel doet</a:t>
+              <a:t>As 1 · Opschonen: van 3.99 naar 2.27 op de vaste testset</a:t>
             </a:r>
           </a:p>
         </p:txBody>
@@ -9117,7 +9594,7 @@
               </a:defRPr>
             </a:pPr>
             <a:r>
-              <a:t>Kribvak op de Nederrijn — zonder en met structurenmasker (kribben + kunstwerken, 10 m)</a:t>
+              <a:t>Zeven regels — herstellen in plaats van weggooien</a:t>
             </a:r>
           </a:p>
         </p:txBody>
@@ -9152,21 +9629,124 @@
               </a:defRPr>
             </a:pPr>
             <a:r>
-              <a:t>Oevererosietool · update 26-08-2026 · 7</a:t>
+              <a:t>Oevererosietool · update 26-08-2026 · 10</a:t>
+            </a:r>
+          </a:p>
+        </p:txBody>
+      </p:sp>
+      <p:sp>
+        <p:nvSpPr>
+          <p:cNvPr id="7" name="TextBox 6"/>
+          <p:cNvSpPr txBox="1"/>
+          <p:nvPr/>
+        </p:nvSpPr>
+        <p:spPr>
+          <a:xfrm>
+            <a:off x="548640" y="4572000"/>
+            <a:ext cx="6949440" cy="1737360"/>
+          </a:xfrm>
+          <a:prstGeom prst="rect">
+            <a:avLst/>
+          </a:prstGeom>
+          <a:noFill/>
+        </p:spPr>
+        <p:txBody>
+          <a:bodyPr wrap="square">
+            <a:spAutoFit/>
+          </a:bodyPr>
+          <a:lstStyle/>
+          <a:p>
+            <a:pPr>
+              <a:spcAft>
+                <a:spcPts val="400"/>
+              </a:spcAft>
+              <a:defRPr sz="1300" b="0">
+                <a:solidFill>
+                  <a:srgbClr val="1F3A3D"/>
+                </a:solidFill>
+              </a:defRPr>
+            </a:pPr>
+            <a:r>
+              <a:t>• Kronkelende lijnen, verkeerde oever, doolhoven, fragmenten, te weinig punten, uitschieters t.o.v. de trend</a:t>
+            </a:r>
+          </a:p>
+          <a:p>
+            <a:pPr>
+              <a:spcAft>
+                <a:spcPts val="400"/>
+              </a:spcAft>
+              <a:defRPr sz="1300" b="0">
+                <a:solidFill>
+                  <a:srgbClr val="1F3A3D"/>
+                </a:solidFill>
+              </a:defRPr>
+            </a:pPr>
+            <a:r>
+              <a:t>• Een uitschieter kost één meting, niet het hele vlak: +511 vlakken t.o.v. de oude |v| &gt; 50-filter</a:t>
+            </a:r>
+          </a:p>
+          <a:p>
+            <a:pPr>
+              <a:spcAft>
+                <a:spcPts val="400"/>
+              </a:spcAft>
+              <a:defRPr sz="1300" b="0">
+                <a:solidFill>
+                  <a:srgbClr val="1F3A3D"/>
+                </a:solidFill>
+              </a:defRPr>
+            </a:pPr>
+            <a:r>
+              <a:t>• Elke variant visueel gecontroleerd (50+ varianten, dekking blijft 0.94)</a:t>
+            </a:r>
+          </a:p>
+        </p:txBody>
+      </p:sp>
+      <p:sp>
+        <p:nvSpPr>
+          <p:cNvPr id="9" name="TextBox 8"/>
+          <p:cNvSpPr txBox="1"/>
+          <p:nvPr/>
+        </p:nvSpPr>
+        <p:spPr>
+          <a:xfrm>
+            <a:off x="9418320" y="1554480"/>
+            <a:ext cx="2560320" cy="3200400"/>
+          </a:xfrm>
+          <a:prstGeom prst="rect">
+            <a:avLst/>
+          </a:prstGeom>
+          <a:noFill/>
+        </p:spPr>
+        <p:txBody>
+          <a:bodyPr wrap="square">
+            <a:spAutoFit/>
+          </a:bodyPr>
+          <a:lstStyle/>
+          <a:p>
+            <a:pPr>
+              <a:defRPr sz="1100" b="0" i="1">
+                <a:solidFill>
+                  <a:srgbClr val="6B7778"/>
+                </a:solidFill>
+              </a:defRPr>
+            </a:pPr>
+            <a:r>
+              <a:t>Leeswijzer: 4.12 was de score van het 19 aug-model op zijn eigen willekeurige train/test-splitsing. Voor het experiment is één vaste testset van 1 174 vlakken bevroren zodat 50+ varianten vergelijkbaar zijn; datzelfde model scoort daarop 3.99. Alle stappen hierna zijn op deze set gemeten.</a:t>
             </a:r>
           </a:p>
         </p:txBody>
       </p:sp>
       <p:pic>
         <p:nvPicPr>
-          <p:cNvPr id="5" name="Picture 4" descr="nederrijn_r_4780_4790.png"/>
+          <p:cNvPr id="10" name="Picture 9" descr="cleaning_ladder.png"/>
           <p:cNvPicPr>
             <a:picLocks noChangeAspect="1"/>
           </p:cNvPicPr>
           <p:nvPr/>
         </p:nvPicPr>
         <p:blipFill>
-          <a:blip r:embed="rId2"/>
+          <a:blip r:embed="rId4"/>
           <a:stretch>
             <a:fillRect/>
           </a:stretch>
@@ -9174,131 +9754,13 @@
         <p:spPr>
           <a:xfrm>
             <a:off x="548640" y="1463040"/>
-            <a:ext cx="7863840" cy="3566490"/>
+            <a:ext cx="8686800" cy="3628713"/>
           </a:xfrm>
           <a:prstGeom prst="rect">
             <a:avLst/>
           </a:prstGeom>
         </p:spPr>
       </p:pic>
-      <p:sp>
-        <p:nvSpPr>
-          <p:cNvPr id="8" name="TextBox 7"/>
-          <p:cNvSpPr txBox="1"/>
-          <p:nvPr/>
-        </p:nvSpPr>
-        <p:spPr>
-          <a:xfrm>
-            <a:off x="548640" y="5669280"/>
-            <a:ext cx="7863840" cy="548640"/>
-          </a:xfrm>
-          <a:prstGeom prst="rect">
-            <a:avLst/>
-          </a:prstGeom>
-          <a:noFill/>
-        </p:spPr>
-        <p:txBody>
-          <a:bodyPr wrap="square">
-            <a:spAutoFit/>
-          </a:bodyPr>
-          <a:lstStyle/>
-          <a:p>
-            <a:pPr>
-              <a:defRPr sz="1100" i="1">
-                <a:solidFill>
-                  <a:srgbClr val="6B7778"/>
-                </a:solidFill>
-              </a:defRPr>
-            </a:pPr>
-            <a:r>
-              <a:t>links: zonder masker · rechts: met kribben + bruggen/kades/steigers (10 m) · grijs = constructie · paars = VVR</a:t>
-            </a:r>
-          </a:p>
-        </p:txBody>
-      </p:sp>
-      <p:sp>
-        <p:nvSpPr>
-          <p:cNvPr id="9" name="TextBox 8"/>
-          <p:cNvSpPr txBox="1"/>
-          <p:nvPr/>
-        </p:nvSpPr>
-        <p:spPr>
-          <a:xfrm>
-            <a:off x="8686800" y="1554480"/>
-            <a:ext cx="3291840" cy="4572000"/>
-          </a:xfrm>
-          <a:prstGeom prst="rect">
-            <a:avLst/>
-          </a:prstGeom>
-          <a:noFill/>
-        </p:spPr>
-        <p:txBody>
-          <a:bodyPr wrap="square">
-            <a:spAutoFit/>
-          </a:bodyPr>
-          <a:lstStyle/>
-          <a:p>
-            <a:pPr>
-              <a:spcAft>
-                <a:spcPts val="600"/>
-              </a:spcAft>
-              <a:defRPr sz="1300">
-                <a:solidFill>
-                  <a:srgbClr val="1F3A3D"/>
-                </a:solidFill>
-              </a:defRPr>
-            </a:pPr>
-            <a:r>
-              <a:t>• Zonder masker volgt de 'oever' de kribflank: het ene getal per jaar (gestippeld) springt heen en weer — +7.7 m/jr</a:t>
-            </a:r>
-          </a:p>
-          <a:p>
-            <a:pPr>
-              <a:spcAft>
-                <a:spcPts val="600"/>
-              </a:spcAft>
-              <a:defRPr sz="1300">
-                <a:solidFill>
-                  <a:srgbClr val="1F3A3D"/>
-                </a:solidFill>
-              </a:defRPr>
-            </a:pPr>
-            <a:r>
-              <a:t>• Met masker vallen de kribpunten weg en blijft de echte oever over: −22.2 m/jr, consistent over de jaren</a:t>
-            </a:r>
-          </a:p>
-          <a:p>
-            <a:pPr>
-              <a:spcAft>
-                <a:spcPts val="600"/>
-              </a:spcAft>
-              <a:defRPr sz="1300">
-                <a:solidFill>
-                  <a:srgbClr val="1F3A3D"/>
-                </a:solidFill>
-              </a:defRPr>
-            </a:pPr>
-            <a:r>
-              <a:t>• Zo werkt elke regel: niet de meting weggooien, maar het deel dat geen oever is</a:t>
-            </a:r>
-          </a:p>
-          <a:p>
-            <a:pPr>
-              <a:spcAft>
-                <a:spcPts val="600"/>
-              </a:spcAft>
-              <a:defRPr sz="1300">
-                <a:solidFill>
-                  <a:srgbClr val="1F3A3D"/>
-                </a:solidFill>
-              </a:defRPr>
-            </a:pPr>
-            <a:r>
-              <a:t>• Deze week: kribben landelijk (1 922 → 4 698) en 6 386 kunstwerken als laag — geen gok meer</a:t>
-            </a:r>
-          </a:p>
-        </p:txBody>
-      </p:sp>
     </p:spTree>
   </p:cSld>
   <p:clrMapOvr>
@@ -9424,7 +9886,7 @@
               </a:defRPr>
             </a:pPr>
             <a:r>
-              <a:t>Oevererosietool · update 26-08-2026 · 9</a:t>
+              <a:t>Oevererosietool · update 26-08-2026 · 11</a:t>
             </a:r>
           </a:p>
         </p:txBody>

</xml_diff>

<commit_message>
docs(presentation): As 2 = features + horizon ruler on the frozen set (k5), naive shown per bar
</commit_message>
<xml_diff>
--- a/docs/presentations/20260826_update_v2.pptx
+++ b/docs/presentations/20260826_update_v2.pptx
@@ -3763,7 +3763,7 @@
               </a:defRPr>
             </a:pPr>
             <a:r>
-              <a:t>As 3 · Resolutie: van scalar naar oeverlijn</a:t>
+              <a:t>As 1 · Opschonen: van 3.99 naar 2.27 op de vaste testset</a:t>
             </a:r>
           </a:p>
         </p:txBody>
@@ -3798,7 +3798,7 @@
               </a:defRPr>
             </a:pPr>
             <a:r>
-              <a:t>Eén afstand per vlak verbergt dat 20 m hard erodeert en 80 m stil ligt</a:t>
+              <a:t>Zeven regels — herstellen in plaats van weggooien</a:t>
             </a:r>
           </a:p>
         </p:txBody>
@@ -3833,21 +3833,124 @@
               </a:defRPr>
             </a:pPr>
             <a:r>
-              <a:t>Oevererosietool · update 26-08-2026 · 12</a:t>
+              <a:t>Oevererosietool · update 26-08-2026 · 10</a:t>
+            </a:r>
+          </a:p>
+        </p:txBody>
+      </p:sp>
+      <p:sp>
+        <p:nvSpPr>
+          <p:cNvPr id="7" name="TextBox 6"/>
+          <p:cNvSpPr txBox="1"/>
+          <p:nvPr/>
+        </p:nvSpPr>
+        <p:spPr>
+          <a:xfrm>
+            <a:off x="548640" y="4572000"/>
+            <a:ext cx="6949440" cy="1737360"/>
+          </a:xfrm>
+          <a:prstGeom prst="rect">
+            <a:avLst/>
+          </a:prstGeom>
+          <a:noFill/>
+        </p:spPr>
+        <p:txBody>
+          <a:bodyPr wrap="square">
+            <a:spAutoFit/>
+          </a:bodyPr>
+          <a:lstStyle/>
+          <a:p>
+            <a:pPr>
+              <a:spcAft>
+                <a:spcPts val="400"/>
+              </a:spcAft>
+              <a:defRPr sz="1300" b="0">
+                <a:solidFill>
+                  <a:srgbClr val="1F3A3D"/>
+                </a:solidFill>
+              </a:defRPr>
+            </a:pPr>
+            <a:r>
+              <a:t>• Kronkelende lijnen, verkeerde oever, doolhoven, fragmenten, te weinig punten, uitschieters t.o.v. de trend</a:t>
+            </a:r>
+          </a:p>
+          <a:p>
+            <a:pPr>
+              <a:spcAft>
+                <a:spcPts val="400"/>
+              </a:spcAft>
+              <a:defRPr sz="1300" b="0">
+                <a:solidFill>
+                  <a:srgbClr val="1F3A3D"/>
+                </a:solidFill>
+              </a:defRPr>
+            </a:pPr>
+            <a:r>
+              <a:t>• Een uitschieter kost één meting, niet het hele vlak: +511 vlakken t.o.v. de oude |v| &gt; 50-filter</a:t>
+            </a:r>
+          </a:p>
+          <a:p>
+            <a:pPr>
+              <a:spcAft>
+                <a:spcPts val="400"/>
+              </a:spcAft>
+              <a:defRPr sz="1300" b="0">
+                <a:solidFill>
+                  <a:srgbClr val="1F3A3D"/>
+                </a:solidFill>
+              </a:defRPr>
+            </a:pPr>
+            <a:r>
+              <a:t>• Elke variant visueel gecontroleerd (50+ varianten, dekking blijft 0.94)</a:t>
+            </a:r>
+          </a:p>
+        </p:txBody>
+      </p:sp>
+      <p:sp>
+        <p:nvSpPr>
+          <p:cNvPr id="9" name="TextBox 8"/>
+          <p:cNvSpPr txBox="1"/>
+          <p:nvPr/>
+        </p:nvSpPr>
+        <p:spPr>
+          <a:xfrm>
+            <a:off x="9418320" y="1554480"/>
+            <a:ext cx="2560320" cy="3200400"/>
+          </a:xfrm>
+          <a:prstGeom prst="rect">
+            <a:avLst/>
+          </a:prstGeom>
+          <a:noFill/>
+        </p:spPr>
+        <p:txBody>
+          <a:bodyPr wrap="square">
+            <a:spAutoFit/>
+          </a:bodyPr>
+          <a:lstStyle/>
+          <a:p>
+            <a:pPr>
+              <a:defRPr sz="1100" b="0" i="1">
+                <a:solidFill>
+                  <a:srgbClr val="6B7778"/>
+                </a:solidFill>
+              </a:defRPr>
+            </a:pPr>
+            <a:r>
+              <a:t>Leeswijzer: 4.12 was de score van het 19 aug-model op zijn eigen willekeurige train/test-splitsing. Voor het experiment is één vaste testset van 1 174 vlakken bevroren zodat 50+ varianten vergelijkbaar zijn; datzelfde model scoort daarop 3.99. Alle stappen hierna zijn op deze set gemeten.</a:t>
             </a:r>
           </a:p>
         </p:txBody>
       </p:sp>
       <p:pic>
         <p:nvPicPr>
-          <p:cNvPr id="5" name="Picture 4" descr="maas3_r_8930_8940.png"/>
+          <p:cNvPr id="10" name="Picture 9" descr="cleaning_ladder.png"/>
           <p:cNvPicPr>
             <a:picLocks noChangeAspect="1"/>
           </p:cNvPicPr>
           <p:nvPr/>
         </p:nvPicPr>
         <p:blipFill>
-          <a:blip r:embed="rId2"/>
+          <a:blip r:embed="rId4"/>
           <a:stretch>
             <a:fillRect/>
           </a:stretch>
@@ -3855,171 +3958,13 @@
         <p:spPr>
           <a:xfrm>
             <a:off x="548640" y="1463040"/>
-            <a:ext cx="6216996" cy="4846320"/>
+            <a:ext cx="8686800" cy="3628713"/>
           </a:xfrm>
           <a:prstGeom prst="rect">
             <a:avLst/>
           </a:prstGeom>
         </p:spPr>
       </p:pic>
-      <p:sp>
-        <p:nvSpPr>
-          <p:cNvPr id="6" name="TextBox 5"/>
-          <p:cNvSpPr txBox="1"/>
-          <p:nvPr/>
-        </p:nvSpPr>
-        <p:spPr>
-          <a:xfrm>
-            <a:off x="6035040" y="1554480"/>
-            <a:ext cx="5943600" cy="4754880"/>
-          </a:xfrm>
-          <a:prstGeom prst="rect">
-            <a:avLst/>
-          </a:prstGeom>
-          <a:noFill/>
-        </p:spPr>
-        <p:txBody>
-          <a:bodyPr wrap="square">
-            <a:spAutoFit/>
-          </a:bodyPr>
-          <a:lstStyle/>
-          <a:p>
-            <a:pPr>
-              <a:spcAft>
-                <a:spcPts val="400"/>
-              </a:spcAft>
-              <a:defRPr sz="1300" b="1">
-                <a:solidFill>
-                  <a:srgbClr val="1F3A3D"/>
-                </a:solidFill>
-              </a:defRPr>
-            </a:pPr>
-            <a:r>
-              <a:t>Wat je ziet</a:t>
-            </a:r>
-          </a:p>
-          <a:p>
-            <a:pPr>
-              <a:spcAft>
-                <a:spcPts val="400"/>
-              </a:spcAft>
-              <a:defRPr sz="1300" b="0">
-                <a:solidFill>
-                  <a:srgbClr val="1F3A3D"/>
-                </a:solidFill>
-              </a:defRPr>
-            </a:pPr>
-            <a:r>
-              <a:t>• groen = gemeten oever per segment (2026) · bruin = voorspeld 2027 per segment</a:t>
-            </a:r>
-          </a:p>
-          <a:p>
-            <a:pPr>
-              <a:spcAft>
-                <a:spcPts val="400"/>
-              </a:spcAft>
-              <a:defRPr sz="1300" b="0">
-                <a:solidFill>
-                  <a:srgbClr val="1F3A3D"/>
-                </a:solidFill>
-              </a:defRPr>
-            </a:pPr>
-            <a:r>
-              <a:t>• gestippeld = de oude voorspelling: één getal voor het hele vlak</a:t>
-            </a:r>
-          </a:p>
-          <a:p>
-            <a:pPr>
-              <a:spcAft>
-                <a:spcPts val="400"/>
-              </a:spcAft>
-              <a:defRPr sz="1300" b="0">
-                <a:solidFill>
-                  <a:srgbClr val="1F3A3D"/>
-                </a:solidFill>
-              </a:defRPr>
-            </a:pPr>
-            <a:r>
-              <a:t>• paars = VVR / signaleringslijn</a:t>
-            </a:r>
-          </a:p>
-          <a:p>
-            <a:pPr>
-              <a:spcAft>
-                <a:spcPts val="400"/>
-              </a:spcAft>
-              <a:defRPr sz="1300" b="1">
-                <a:solidFill>
-                  <a:srgbClr val="1F3A3D"/>
-                </a:solidFill>
-              </a:defRPr>
-            </a:pPr>
-            <a:r>
-              <a:t>Dit vlak</a:t>
-            </a:r>
-          </a:p>
-          <a:p>
-            <a:pPr>
-              <a:spcAft>
-                <a:spcPts val="400"/>
-              </a:spcAft>
-              <a:defRPr sz="1300" b="0">
-                <a:solidFill>
-                  <a:srgbClr val="1F3A3D"/>
-                </a:solidFill>
-              </a:defRPr>
-            </a:pPr>
-            <a:r>
-              <a:t>• Eén getal zegt −9.7 m/jr; de vijf segmenten lopen van −17.1 tot +1.4</a:t>
-            </a:r>
-          </a:p>
-          <a:p>
-            <a:pPr>
-              <a:spcAft>
-                <a:spcPts val="400"/>
-              </a:spcAft>
-              <a:defRPr sz="1300" b="0">
-                <a:solidFill>
-                  <a:srgbClr val="1F3A3D"/>
-                </a:solidFill>
-              </a:defRPr>
-            </a:pPr>
-            <a:r>
-              <a:t>• Het bovenste segment nadert de VVR; de rest niet — het alarm hoort per segment te kijken</a:t>
-            </a:r>
-          </a:p>
-          <a:p>
-            <a:pPr>
-              <a:spcAft>
-                <a:spcPts val="400"/>
-              </a:spcAft>
-              <a:defRPr sz="1300" b="1">
-                <a:solidFill>
-                  <a:srgbClr val="1F3A3D"/>
-                </a:solidFill>
-              </a:defRPr>
-            </a:pPr>
-            <a:r>
-              <a:t>Vandaag</a:t>
-            </a:r>
-          </a:p>
-          <a:p>
-            <a:pPr>
-              <a:spcAft>
-                <a:spcPts val="400"/>
-              </a:spcAft>
-              <a:defRPr sz="1300" b="0">
-                <a:solidFill>
-                  <a:srgbClr val="1F3A3D"/>
-                </a:solidFill>
-              </a:defRPr>
-            </a:pPr>
-            <a:r>
-              <a:t>• VVR-jaar = één drempel per vlak (het verst gelegen punt van de signaleringslijn) tegen één scalar → per definitie laat</a:t>
-            </a:r>
-          </a:p>
-        </p:txBody>
-      </p:sp>
     </p:spTree>
   </p:cSld>
   <p:clrMapOvr>
@@ -4075,7 +4020,7 @@
               </a:defRPr>
             </a:pPr>
             <a:r>
-              <a:t>As 3 · Hoe fijn kan het?</a:t>
+              <a:t>As 2 · Meerdere t-punten: als feature én als meetlat</a:t>
             </a:r>
           </a:p>
         </p:txBody>
@@ -4110,7 +4055,7 @@
               </a:defRPr>
             </a:pPr>
             <a:r>
-              <a:t>Zelfde vlak, R = 1 … 100 · en de fout op de vaste testset per R</a:t>
+              <a:t>2a · de hele meetreeks als feature: 2.27 → 2.13   ·   2b · paren ≥ 2 jaar als meetlat: 1.37</a:t>
             </a:r>
           </a:p>
         </p:txBody>
@@ -4145,45 +4090,21 @@
               </a:defRPr>
             </a:pPr>
             <a:r>
-              <a:t>Oevererosietool · update 26-08-2026 · 13</a:t>
-            </a:r>
-          </a:p>
-        </p:txBody>
-      </p:sp>
-      <p:pic>
-        <p:nvPicPr>
-          <p:cNvPr id="5" name="Picture 4" descr="maas3_r_8930_8940.png"/>
-          <p:cNvPicPr>
-            <a:picLocks noChangeAspect="1"/>
-          </p:cNvPicPr>
-          <p:nvPr/>
-        </p:nvPicPr>
-        <p:blipFill>
-          <a:blip r:embed="rId2"/>
-          <a:stretch>
-            <a:fillRect/>
-          </a:stretch>
-        </p:blipFill>
-        <p:spPr>
-          <a:xfrm>
-            <a:off x="548640" y="1371600"/>
-            <a:ext cx="5760720" cy="3280921"/>
-          </a:xfrm>
-          <a:prstGeom prst="rect">
-            <a:avLst/>
-          </a:prstGeom>
-        </p:spPr>
-      </p:pic>
-      <p:sp>
-        <p:nvSpPr>
-          <p:cNvPr id="7" name="TextBox 6"/>
+              <a:t>Oevererosietool · update 26-08-2026 · 11</a:t>
+            </a:r>
+          </a:p>
+        </p:txBody>
+      </p:sp>
+      <p:sp>
+        <p:nvSpPr>
+          <p:cNvPr id="6" name="TextBox 5"/>
           <p:cNvSpPr txBox="1"/>
           <p:nvPr/>
         </p:nvSpPr>
         <p:spPr>
           <a:xfrm>
-            <a:off x="548640" y="4754880"/>
-            <a:ext cx="11430000" cy="1645920"/>
+            <a:off x="7498079" y="1554480"/>
+            <a:ext cx="4480560" cy="4754880"/>
           </a:xfrm>
           <a:prstGeom prst="rect">
             <a:avLst/>
@@ -4198,7 +4119,22 @@
           <a:p>
             <a:pPr>
               <a:spcAft>
-                <a:spcPts val="300"/>
+                <a:spcPts val="400"/>
+              </a:spcAft>
+              <a:defRPr sz="1200" b="1">
+                <a:solidFill>
+                  <a:srgbClr val="1F3A3D"/>
+                </a:solidFill>
+              </a:defRPr>
+            </a:pPr>
+            <a:r>
+              <a:t>2a · Features uit de hele meetreeks</a:t>
+            </a:r>
+          </a:p>
+          <a:p>
+            <a:pPr>
+              <a:spcAft>
+                <a:spcPts val="400"/>
               </a:spcAft>
               <a:defRPr sz="1200" b="0">
                 <a:solidFill>
@@ -4207,13 +4143,28 @@
               </a:defRPr>
             </a:pPr>
             <a:r>
-              <a:t>• De segment-representatie (bruin) volgt de gemeten oever vanaf R ≈ 5–10; bij R = 50–100 raken segmenten leeg (rood)</a:t>
+              <a:t>• Trend (Theil–Sen), spreiding om de trend, versnelling, terugkeer naar gemiddelde, recente helling — zelfde doel, zelfde split: 2.27 → 2.13</a:t>
             </a:r>
           </a:p>
           <a:p>
             <a:pPr>
               <a:spcAft>
-                <a:spcPts val="300"/>
+                <a:spcPts val="400"/>
+              </a:spcAft>
+              <a:defRPr sz="1200" b="1">
+                <a:solidFill>
+                  <a:srgbClr val="1F3A3D"/>
+                </a:solidFill>
+              </a:defRPr>
+            </a:pPr>
+            <a:r>
+              <a:t>2b · Paren ≥ 2 jaar als meetlat</a:t>
+            </a:r>
+          </a:p>
+          <a:p>
+            <a:pPr>
+              <a:spcAft>
+                <a:spcPts val="400"/>
               </a:spcAft>
               <a:defRPr sz="1200" b="0">
                 <a:solidFill>
@@ -4222,13 +4173,13 @@
               </a:defRPr>
             </a:pPr>
             <a:r>
-              <a:t>• Fout per segment daalt van 2.25 (R = 1) naar 1.88 (R = 5) en 1.61 (R = 20) — kleiner wordt nauwkeuriger, niet ruiziger</a:t>
+              <a:t>• Hoogtemodel-opnames liggen 3–5 jaar uit elkaar; SAM 1 jaar → dezelfde meetruis ÷ 1 jaar = ruis</a:t>
             </a:r>
           </a:p>
           <a:p>
             <a:pPr>
               <a:spcAft>
-                <a:spcPts val="300"/>
+                <a:spcPts val="400"/>
               </a:spcAft>
               <a:defRPr sz="1200" b="0">
                 <a:solidFill>
@@ -4237,13 +4188,13 @@
               </a:defRPr>
             </a:pPr>
             <a:r>
-              <a:t>• Terug-samengevoegd per vlak blijft de fout ≈ 2.1–2.2: het vlak-getal zelf heeft een vloer (0.5–1.1 m/jr representatiefout)</a:t>
+              <a:t>• Zelfde doel (m/jr), alleen paren ≥ 2 jaar, álle paren: 1 vlak met 6 metingen = 10 leervoorbeelden</a:t>
             </a:r>
           </a:p>
           <a:p>
             <a:pPr>
               <a:spcAft>
-                <a:spcPts val="300"/>
+                <a:spcPts val="400"/>
               </a:spcAft>
               <a:defRPr sz="1200" b="0">
                 <a:solidFill>
@@ -4252,14 +4203,44 @@
               </a:defRPr>
             </a:pPr>
             <a:r>
-              <a:t>• Grens ligt bij de lijnbemonstering (60 punten per lijn), niet bij het model · praktisch: R = 5–10 (≈ 10–20 m)</a:t>
+              <a:t>• Eerlijk: de naïeve fout zakt mee (2.67 → 1.77); de skill gaat van +20 % naar +23 %. Dit is 'meten wat we kunnen voorspellen', geen 35 % beter model</a:t>
+            </a:r>
+          </a:p>
+          <a:p>
+            <a:pPr>
+              <a:spcAft>
+                <a:spcPts val="400"/>
+              </a:spcAft>
+              <a:defRPr sz="1200" b="0">
+                <a:solidFill>
+                  <a:srgbClr val="1F3A3D"/>
+                </a:solidFill>
+              </a:defRPr>
+            </a:pPr>
+            <a:r>
+              <a:t>• Nog niet overal: 715 van 1 174 testvlakken hebben zo'n paar — groeit met elk SAM-jaar</a:t>
+            </a:r>
+          </a:p>
+          <a:p>
+            <a:pPr>
+              <a:spcAft>
+                <a:spcPts val="400"/>
+              </a:spcAft>
+              <a:defRPr sz="1200" b="0">
+                <a:solidFill>
+                  <a:srgbClr val="1F3A3D"/>
+                </a:solidFill>
+              </a:defRPr>
+            </a:pPr>
+            <a:r>
+              <a:t>• Wat niet werkte: losse jaar-op-jaar stappen als doel, huber-loss, debiet</a:t>
             </a:r>
           </a:p>
         </p:txBody>
       </p:sp>
       <p:pic>
         <p:nvPicPr>
-          <p:cNvPr id="8" name="Picture 7" descr="image.png"/>
+          <p:cNvPr id="7" name="Picture 6" descr="history.png"/>
           <p:cNvPicPr>
             <a:picLocks noChangeAspect="1"/>
           </p:cNvPicPr>
@@ -4273,8 +4254,8 @@
         </p:blipFill>
         <p:spPr>
           <a:xfrm>
-            <a:off x="6400800" y="1371600"/>
-            <a:ext cx="5577840" cy="2330016"/>
+            <a:off x="548640" y="1463040"/>
+            <a:ext cx="6766560" cy="2952681"/>
           </a:xfrm>
           <a:prstGeom prst="rect">
             <a:avLst/>
@@ -4336,6 +4317,579 @@
               </a:defRPr>
             </a:pPr>
             <a:r>
+              <a:t>As 3 · Resolutie: van scalar naar oeverlijn</a:t>
+            </a:r>
+          </a:p>
+        </p:txBody>
+      </p:sp>
+      <p:sp>
+        <p:nvSpPr>
+          <p:cNvPr id="3" name="TextBox 2"/>
+          <p:cNvSpPr txBox="1"/>
+          <p:nvPr/>
+        </p:nvSpPr>
+        <p:spPr>
+          <a:xfrm>
+            <a:off x="548640" y="960120"/>
+            <a:ext cx="10972800" cy="548640"/>
+          </a:xfrm>
+          <a:prstGeom prst="rect">
+            <a:avLst/>
+          </a:prstGeom>
+          <a:noFill/>
+        </p:spPr>
+        <p:txBody>
+          <a:bodyPr wrap="none">
+            <a:spAutoFit/>
+          </a:bodyPr>
+          <a:lstStyle/>
+          <a:p>
+            <a:pPr>
+              <a:defRPr sz="1700">
+                <a:solidFill>
+                  <a:srgbClr val="1F3A3D"/>
+                </a:solidFill>
+              </a:defRPr>
+            </a:pPr>
+            <a:r>
+              <a:t>Eén afstand per vlak verbergt dat 20 m hard erodeert en 80 m stil ligt</a:t>
+            </a:r>
+          </a:p>
+        </p:txBody>
+      </p:sp>
+      <p:sp>
+        <p:nvSpPr>
+          <p:cNvPr id="4" name="TextBox 3"/>
+          <p:cNvSpPr txBox="1"/>
+          <p:nvPr/>
+        </p:nvSpPr>
+        <p:spPr>
+          <a:xfrm>
+            <a:off x="548640" y="6400800"/>
+            <a:ext cx="10972800" cy="274320"/>
+          </a:xfrm>
+          <a:prstGeom prst="rect">
+            <a:avLst/>
+          </a:prstGeom>
+          <a:noFill/>
+        </p:spPr>
+        <p:txBody>
+          <a:bodyPr wrap="none">
+            <a:spAutoFit/>
+          </a:bodyPr>
+          <a:lstStyle/>
+          <a:p>
+            <a:pPr>
+              <a:defRPr sz="1000">
+                <a:solidFill>
+                  <a:srgbClr val="6B7778"/>
+                </a:solidFill>
+              </a:defRPr>
+            </a:pPr>
+            <a:r>
+              <a:t>Oevererosietool · update 26-08-2026 · 12</a:t>
+            </a:r>
+          </a:p>
+        </p:txBody>
+      </p:sp>
+      <p:pic>
+        <p:nvPicPr>
+          <p:cNvPr id="5" name="Picture 4" descr="maas3_r_8930_8940.png"/>
+          <p:cNvPicPr>
+            <a:picLocks noChangeAspect="1"/>
+          </p:cNvPicPr>
+          <p:nvPr/>
+        </p:nvPicPr>
+        <p:blipFill>
+          <a:blip r:embed="rId2"/>
+          <a:stretch>
+            <a:fillRect/>
+          </a:stretch>
+        </p:blipFill>
+        <p:spPr>
+          <a:xfrm>
+            <a:off x="548640" y="1463040"/>
+            <a:ext cx="6216996" cy="4846320"/>
+          </a:xfrm>
+          <a:prstGeom prst="rect">
+            <a:avLst/>
+          </a:prstGeom>
+        </p:spPr>
+      </p:pic>
+      <p:sp>
+        <p:nvSpPr>
+          <p:cNvPr id="6" name="TextBox 5"/>
+          <p:cNvSpPr txBox="1"/>
+          <p:nvPr/>
+        </p:nvSpPr>
+        <p:spPr>
+          <a:xfrm>
+            <a:off x="6035040" y="1554480"/>
+            <a:ext cx="5943600" cy="4754880"/>
+          </a:xfrm>
+          <a:prstGeom prst="rect">
+            <a:avLst/>
+          </a:prstGeom>
+          <a:noFill/>
+        </p:spPr>
+        <p:txBody>
+          <a:bodyPr wrap="square">
+            <a:spAutoFit/>
+          </a:bodyPr>
+          <a:lstStyle/>
+          <a:p>
+            <a:pPr>
+              <a:spcAft>
+                <a:spcPts val="400"/>
+              </a:spcAft>
+              <a:defRPr sz="1300" b="1">
+                <a:solidFill>
+                  <a:srgbClr val="1F3A3D"/>
+                </a:solidFill>
+              </a:defRPr>
+            </a:pPr>
+            <a:r>
+              <a:t>Wat je ziet</a:t>
+            </a:r>
+          </a:p>
+          <a:p>
+            <a:pPr>
+              <a:spcAft>
+                <a:spcPts val="400"/>
+              </a:spcAft>
+              <a:defRPr sz="1300" b="0">
+                <a:solidFill>
+                  <a:srgbClr val="1F3A3D"/>
+                </a:solidFill>
+              </a:defRPr>
+            </a:pPr>
+            <a:r>
+              <a:t>• groen = gemeten oever per segment (2026) · bruin = voorspeld 2027 per segment</a:t>
+            </a:r>
+          </a:p>
+          <a:p>
+            <a:pPr>
+              <a:spcAft>
+                <a:spcPts val="400"/>
+              </a:spcAft>
+              <a:defRPr sz="1300" b="0">
+                <a:solidFill>
+                  <a:srgbClr val="1F3A3D"/>
+                </a:solidFill>
+              </a:defRPr>
+            </a:pPr>
+            <a:r>
+              <a:t>• gestippeld = de oude voorspelling: één getal voor het hele vlak</a:t>
+            </a:r>
+          </a:p>
+          <a:p>
+            <a:pPr>
+              <a:spcAft>
+                <a:spcPts val="400"/>
+              </a:spcAft>
+              <a:defRPr sz="1300" b="0">
+                <a:solidFill>
+                  <a:srgbClr val="1F3A3D"/>
+                </a:solidFill>
+              </a:defRPr>
+            </a:pPr>
+            <a:r>
+              <a:t>• paars = VVR / signaleringslijn</a:t>
+            </a:r>
+          </a:p>
+          <a:p>
+            <a:pPr>
+              <a:spcAft>
+                <a:spcPts val="400"/>
+              </a:spcAft>
+              <a:defRPr sz="1300" b="1">
+                <a:solidFill>
+                  <a:srgbClr val="1F3A3D"/>
+                </a:solidFill>
+              </a:defRPr>
+            </a:pPr>
+            <a:r>
+              <a:t>Dit vlak</a:t>
+            </a:r>
+          </a:p>
+          <a:p>
+            <a:pPr>
+              <a:spcAft>
+                <a:spcPts val="400"/>
+              </a:spcAft>
+              <a:defRPr sz="1300" b="0">
+                <a:solidFill>
+                  <a:srgbClr val="1F3A3D"/>
+                </a:solidFill>
+              </a:defRPr>
+            </a:pPr>
+            <a:r>
+              <a:t>• Eén getal zegt −9.7 m/jr; de vijf segmenten lopen van −17.1 tot +1.4</a:t>
+            </a:r>
+          </a:p>
+          <a:p>
+            <a:pPr>
+              <a:spcAft>
+                <a:spcPts val="400"/>
+              </a:spcAft>
+              <a:defRPr sz="1300" b="0">
+                <a:solidFill>
+                  <a:srgbClr val="1F3A3D"/>
+                </a:solidFill>
+              </a:defRPr>
+            </a:pPr>
+            <a:r>
+              <a:t>• Het bovenste segment nadert de VVR; de rest niet — het alarm hoort per segment te kijken</a:t>
+            </a:r>
+          </a:p>
+          <a:p>
+            <a:pPr>
+              <a:spcAft>
+                <a:spcPts val="400"/>
+              </a:spcAft>
+              <a:defRPr sz="1300" b="1">
+                <a:solidFill>
+                  <a:srgbClr val="1F3A3D"/>
+                </a:solidFill>
+              </a:defRPr>
+            </a:pPr>
+            <a:r>
+              <a:t>Vandaag</a:t>
+            </a:r>
+          </a:p>
+          <a:p>
+            <a:pPr>
+              <a:spcAft>
+                <a:spcPts val="400"/>
+              </a:spcAft>
+              <a:defRPr sz="1300" b="0">
+                <a:solidFill>
+                  <a:srgbClr val="1F3A3D"/>
+                </a:solidFill>
+              </a:defRPr>
+            </a:pPr>
+            <a:r>
+              <a:t>• VVR-jaar = één drempel per vlak (het verst gelegen punt van de signaleringslijn) tegen één scalar → per definitie laat</a:t>
+            </a:r>
+          </a:p>
+        </p:txBody>
+      </p:sp>
+    </p:spTree>
+  </p:cSld>
+  <p:clrMapOvr>
+    <a:masterClrMapping/>
+  </p:clrMapOvr>
+</p:sld>
+</file>
+
+<file path=ppt/slides/slide13.xml><?xml version="1.0" encoding="utf-8"?>
+<p:sld xmlns:a="http://schemas.openxmlformats.org/drawingml/2006/main" xmlns:r="http://schemas.openxmlformats.org/officeDocument/2006/relationships" xmlns:p="http://schemas.openxmlformats.org/presentationml/2006/main">
+  <p:cSld>
+    <p:spTree>
+      <p:nvGrpSpPr>
+        <p:cNvPr id="1" name=""/>
+        <p:cNvGrpSpPr/>
+        <p:nvPr/>
+      </p:nvGrpSpPr>
+      <p:grpSpPr>
+        <a:xfrm>
+          <a:off x="0" y="0"/>
+          <a:ext cx="0" cy="0"/>
+          <a:chOff x="0" y="0"/>
+          <a:chExt cx="0" cy="0"/>
+        </a:xfrm>
+      </p:grpSpPr>
+      <p:sp>
+        <p:nvSpPr>
+          <p:cNvPr id="2" name="TextBox 1"/>
+          <p:cNvSpPr txBox="1"/>
+          <p:nvPr/>
+        </p:nvSpPr>
+        <p:spPr>
+          <a:xfrm>
+            <a:off x="548640" y="320040"/>
+            <a:ext cx="10972800" cy="731520"/>
+          </a:xfrm>
+          <a:prstGeom prst="rect">
+            <a:avLst/>
+          </a:prstGeom>
+          <a:noFill/>
+        </p:spPr>
+        <p:txBody>
+          <a:bodyPr wrap="none">
+            <a:spAutoFit/>
+          </a:bodyPr>
+          <a:lstStyle/>
+          <a:p>
+            <a:pPr>
+              <a:defRPr sz="3000" b="1">
+                <a:solidFill>
+                  <a:srgbClr val="2BB5A6"/>
+                </a:solidFill>
+              </a:defRPr>
+            </a:pPr>
+            <a:r>
+              <a:t>As 3 · Hoe fijn kan het?</a:t>
+            </a:r>
+          </a:p>
+        </p:txBody>
+      </p:sp>
+      <p:sp>
+        <p:nvSpPr>
+          <p:cNvPr id="3" name="TextBox 2"/>
+          <p:cNvSpPr txBox="1"/>
+          <p:nvPr/>
+        </p:nvSpPr>
+        <p:spPr>
+          <a:xfrm>
+            <a:off x="548640" y="960120"/>
+            <a:ext cx="10972800" cy="548640"/>
+          </a:xfrm>
+          <a:prstGeom prst="rect">
+            <a:avLst/>
+          </a:prstGeom>
+          <a:noFill/>
+        </p:spPr>
+        <p:txBody>
+          <a:bodyPr wrap="none">
+            <a:spAutoFit/>
+          </a:bodyPr>
+          <a:lstStyle/>
+          <a:p>
+            <a:pPr>
+              <a:defRPr sz="1700">
+                <a:solidFill>
+                  <a:srgbClr val="1F3A3D"/>
+                </a:solidFill>
+              </a:defRPr>
+            </a:pPr>
+            <a:r>
+              <a:t>Zelfde vlak, R = 1 … 100 · en de fout op de vaste testset per R</a:t>
+            </a:r>
+          </a:p>
+        </p:txBody>
+      </p:sp>
+      <p:sp>
+        <p:nvSpPr>
+          <p:cNvPr id="4" name="TextBox 3"/>
+          <p:cNvSpPr txBox="1"/>
+          <p:nvPr/>
+        </p:nvSpPr>
+        <p:spPr>
+          <a:xfrm>
+            <a:off x="548640" y="6400800"/>
+            <a:ext cx="10972800" cy="274320"/>
+          </a:xfrm>
+          <a:prstGeom prst="rect">
+            <a:avLst/>
+          </a:prstGeom>
+          <a:noFill/>
+        </p:spPr>
+        <p:txBody>
+          <a:bodyPr wrap="none">
+            <a:spAutoFit/>
+          </a:bodyPr>
+          <a:lstStyle/>
+          <a:p>
+            <a:pPr>
+              <a:defRPr sz="1000">
+                <a:solidFill>
+                  <a:srgbClr val="6B7778"/>
+                </a:solidFill>
+              </a:defRPr>
+            </a:pPr>
+            <a:r>
+              <a:t>Oevererosietool · update 26-08-2026 · 13</a:t>
+            </a:r>
+          </a:p>
+        </p:txBody>
+      </p:sp>
+      <p:pic>
+        <p:nvPicPr>
+          <p:cNvPr id="5" name="Picture 4" descr="maas3_r_8930_8940.png"/>
+          <p:cNvPicPr>
+            <a:picLocks noChangeAspect="1"/>
+          </p:cNvPicPr>
+          <p:nvPr/>
+        </p:nvPicPr>
+        <p:blipFill>
+          <a:blip r:embed="rId2"/>
+          <a:stretch>
+            <a:fillRect/>
+          </a:stretch>
+        </p:blipFill>
+        <p:spPr>
+          <a:xfrm>
+            <a:off x="548640" y="1371600"/>
+            <a:ext cx="5760720" cy="3280921"/>
+          </a:xfrm>
+          <a:prstGeom prst="rect">
+            <a:avLst/>
+          </a:prstGeom>
+        </p:spPr>
+      </p:pic>
+      <p:sp>
+        <p:nvSpPr>
+          <p:cNvPr id="7" name="TextBox 6"/>
+          <p:cNvSpPr txBox="1"/>
+          <p:nvPr/>
+        </p:nvSpPr>
+        <p:spPr>
+          <a:xfrm>
+            <a:off x="548640" y="4754880"/>
+            <a:ext cx="11430000" cy="1645920"/>
+          </a:xfrm>
+          <a:prstGeom prst="rect">
+            <a:avLst/>
+          </a:prstGeom>
+          <a:noFill/>
+        </p:spPr>
+        <p:txBody>
+          <a:bodyPr wrap="square">
+            <a:spAutoFit/>
+          </a:bodyPr>
+          <a:lstStyle/>
+          <a:p>
+            <a:pPr>
+              <a:spcAft>
+                <a:spcPts val="300"/>
+              </a:spcAft>
+              <a:defRPr sz="1200" b="0">
+                <a:solidFill>
+                  <a:srgbClr val="1F3A3D"/>
+                </a:solidFill>
+              </a:defRPr>
+            </a:pPr>
+            <a:r>
+              <a:t>• De segment-representatie (bruin) volgt de gemeten oever vanaf R ≈ 5–10; bij R = 50–100 raken segmenten leeg (rood)</a:t>
+            </a:r>
+          </a:p>
+          <a:p>
+            <a:pPr>
+              <a:spcAft>
+                <a:spcPts val="300"/>
+              </a:spcAft>
+              <a:defRPr sz="1200" b="0">
+                <a:solidFill>
+                  <a:srgbClr val="1F3A3D"/>
+                </a:solidFill>
+              </a:defRPr>
+            </a:pPr>
+            <a:r>
+              <a:t>• Fout per segment daalt van 2.25 (R = 1) naar 1.88 (R = 5) en 1.61 (R = 20) — kleiner wordt nauwkeuriger, niet ruiziger</a:t>
+            </a:r>
+          </a:p>
+          <a:p>
+            <a:pPr>
+              <a:spcAft>
+                <a:spcPts val="300"/>
+              </a:spcAft>
+              <a:defRPr sz="1200" b="0">
+                <a:solidFill>
+                  <a:srgbClr val="1F3A3D"/>
+                </a:solidFill>
+              </a:defRPr>
+            </a:pPr>
+            <a:r>
+              <a:t>• Terug-samengevoegd per vlak blijft de fout ≈ 2.1–2.2: het vlak-getal zelf heeft een vloer (0.5–1.1 m/jr representatiefout)</a:t>
+            </a:r>
+          </a:p>
+          <a:p>
+            <a:pPr>
+              <a:spcAft>
+                <a:spcPts val="300"/>
+              </a:spcAft>
+              <a:defRPr sz="1200" b="0">
+                <a:solidFill>
+                  <a:srgbClr val="1F3A3D"/>
+                </a:solidFill>
+              </a:defRPr>
+            </a:pPr>
+            <a:r>
+              <a:t>• Grens ligt bij de lijnbemonstering (60 punten per lijn), niet bij het model · praktisch: R = 5–10 (≈ 10–20 m)</a:t>
+            </a:r>
+          </a:p>
+        </p:txBody>
+      </p:sp>
+      <p:pic>
+        <p:nvPicPr>
+          <p:cNvPr id="8" name="Picture 7" descr="image.png"/>
+          <p:cNvPicPr>
+            <a:picLocks noChangeAspect="1"/>
+          </p:cNvPicPr>
+          <p:nvPr/>
+        </p:nvPicPr>
+        <p:blipFill>
+          <a:blip r:embed="rId3"/>
+          <a:stretch>
+            <a:fillRect/>
+          </a:stretch>
+        </p:blipFill>
+        <p:spPr>
+          <a:xfrm>
+            <a:off x="6400800" y="1371600"/>
+            <a:ext cx="5577840" cy="2330016"/>
+          </a:xfrm>
+          <a:prstGeom prst="rect">
+            <a:avLst/>
+          </a:prstGeom>
+        </p:spPr>
+      </p:pic>
+    </p:spTree>
+  </p:cSld>
+  <p:clrMapOvr>
+    <a:masterClrMapping/>
+  </p:clrMapOvr>
+</p:sld>
+</file>
+
+<file path=ppt/slides/slide14.xml><?xml version="1.0" encoding="utf-8"?>
+<p:sld xmlns:a="http://schemas.openxmlformats.org/drawingml/2006/main" xmlns:r="http://schemas.openxmlformats.org/officeDocument/2006/relationships" xmlns:p="http://schemas.openxmlformats.org/presentationml/2006/main">
+  <p:cSld>
+    <p:spTree>
+      <p:nvGrpSpPr>
+        <p:cNvPr id="1" name=""/>
+        <p:cNvGrpSpPr/>
+        <p:nvPr/>
+      </p:nvGrpSpPr>
+      <p:grpSpPr>
+        <a:xfrm>
+          <a:off x="0" y="0"/>
+          <a:ext cx="0" cy="0"/>
+          <a:chOff x="0" y="0"/>
+          <a:chExt cx="0" cy="0"/>
+        </a:xfrm>
+      </p:grpSpPr>
+      <p:sp>
+        <p:nvSpPr>
+          <p:cNvPr id="2" name="TextBox 1"/>
+          <p:cNvSpPr txBox="1"/>
+          <p:nvPr/>
+        </p:nvSpPr>
+        <p:spPr>
+          <a:xfrm>
+            <a:off x="548640" y="320040"/>
+            <a:ext cx="10972800" cy="731520"/>
+          </a:xfrm>
+          <a:prstGeom prst="rect">
+            <a:avLst/>
+          </a:prstGeom>
+          <a:noFill/>
+        </p:spPr>
+        <p:txBody>
+          <a:bodyPr wrap="none">
+            <a:spAutoFit/>
+          </a:bodyPr>
+          <a:lstStyle/>
+          <a:p>
+            <a:pPr>
+              <a:defRPr sz="3000" b="1">
+                <a:solidFill>
+                  <a:srgbClr val="2BB5A6"/>
+                </a:solidFill>
+              </a:defRPr>
+            </a:pPr>
+            <a:r>
               <a:t>Alles bij elkaar</a:t>
             </a:r>
           </a:p>
@@ -4496,7 +5050,7 @@
 </p:sld>
 </file>
 
-<file path=ppt/slides/slide13.xml><?xml version="1.0" encoding="utf-8"?>
+<file path=ppt/slides/slide15.xml><?xml version="1.0" encoding="utf-8"?>
 <p:sld xmlns:a="http://schemas.openxmlformats.org/drawingml/2006/main" xmlns:r="http://schemas.openxmlformats.org/officeDocument/2006/relationships" xmlns:p="http://schemas.openxmlformats.org/presentationml/2006/main">
   <p:cSld>
     <p:spTree>
@@ -5261,748 +5815,6 @@
 </p:sld>
 </file>
 
-<file path=ppt/slides/slide14.xml><?xml version="1.0" encoding="utf-8"?>
-<p:sld xmlns:a="http://schemas.openxmlformats.org/drawingml/2006/main" xmlns:r="http://schemas.openxmlformats.org/officeDocument/2006/relationships" xmlns:p="http://schemas.openxmlformats.org/presentationml/2006/main">
-  <p:cSld>
-    <p:spTree>
-      <p:nvGrpSpPr>
-        <p:cNvPr id="1" name=""/>
-        <p:cNvGrpSpPr/>
-        <p:nvPr/>
-      </p:nvGrpSpPr>
-      <p:grpSpPr>
-        <a:xfrm>
-          <a:off x="0" y="0"/>
-          <a:ext cx="0" cy="0"/>
-          <a:chOff x="0" y="0"/>
-          <a:chExt cx="0" cy="0"/>
-        </a:xfrm>
-      </p:grpSpPr>
-      <p:sp>
-        <p:nvSpPr>
-          <p:cNvPr id="2" name="TextBox 1"/>
-          <p:cNvSpPr txBox="1"/>
-          <p:nvPr/>
-        </p:nvSpPr>
-        <p:spPr>
-          <a:xfrm>
-            <a:off x="548640" y="320040"/>
-            <a:ext cx="10972800" cy="731520"/>
-          </a:xfrm>
-          <a:prstGeom prst="rect">
-            <a:avLst/>
-          </a:prstGeom>
-          <a:noFill/>
-        </p:spPr>
-        <p:txBody>
-          <a:bodyPr wrap="none">
-            <a:spAutoFit/>
-          </a:bodyPr>
-          <a:lstStyle/>
-          <a:p>
-            <a:pPr>
-              <a:defRPr sz="3000" b="1">
-                <a:solidFill>
-                  <a:srgbClr val="2BB5A6"/>
-                </a:solidFill>
-              </a:defRPr>
-            </a:pPr>
-            <a:r>
-              <a:t>Wat we vragen</a:t>
-            </a:r>
-          </a:p>
-        </p:txBody>
-      </p:sp>
-      <p:sp>
-        <p:nvSpPr>
-          <p:cNvPr id="3" name="TextBox 2"/>
-          <p:cNvSpPr txBox="1"/>
-          <p:nvPr/>
-        </p:nvSpPr>
-        <p:spPr>
-          <a:xfrm>
-            <a:off x="548640" y="960120"/>
-            <a:ext cx="10972800" cy="548640"/>
-          </a:xfrm>
-          <a:prstGeom prst="rect">
-            <a:avLst/>
-          </a:prstGeom>
-          <a:noFill/>
-        </p:spPr>
-        <p:txBody>
-          <a:bodyPr wrap="none">
-            <a:spAutoFit/>
-          </a:bodyPr>
-          <a:lstStyle/>
-          <a:p>
-            <a:pPr>
-              <a:defRPr sz="1700">
-                <a:solidFill>
-                  <a:srgbClr val="1F3A3D"/>
-                </a:solidFill>
-              </a:defRPr>
-            </a:pPr>
-            <a:r>
-              <a:t>Labelen is trial-and-error — geen eenmalige levering</a:t>
-            </a:r>
-          </a:p>
-        </p:txBody>
-      </p:sp>
-      <p:sp>
-        <p:nvSpPr>
-          <p:cNvPr id="4" name="TextBox 3"/>
-          <p:cNvSpPr txBox="1"/>
-          <p:nvPr/>
-        </p:nvSpPr>
-        <p:spPr>
-          <a:xfrm>
-            <a:off x="548640" y="6400800"/>
-            <a:ext cx="10972800" cy="274320"/>
-          </a:xfrm>
-          <a:prstGeom prst="rect">
-            <a:avLst/>
-          </a:prstGeom>
-          <a:noFill/>
-        </p:spPr>
-        <p:txBody>
-          <a:bodyPr wrap="none">
-            <a:spAutoFit/>
-          </a:bodyPr>
-          <a:lstStyle/>
-          <a:p>
-            <a:pPr>
-              <a:defRPr sz="1000">
-                <a:solidFill>
-                  <a:srgbClr val="6B7778"/>
-                </a:solidFill>
-              </a:defRPr>
-            </a:pPr>
-            <a:r>
-              <a:t>Oevererosietool · update 26-08-2026 · 16</a:t>
-            </a:r>
-          </a:p>
-        </p:txBody>
-      </p:sp>
-      <p:sp>
-        <p:nvSpPr>
-          <p:cNvPr id="5" name="Rectangle 4"/>
-          <p:cNvSpPr/>
-          <p:nvPr/>
-        </p:nvSpPr>
-        <p:spPr>
-          <a:xfrm>
-            <a:off x="548640" y="1645920"/>
-            <a:ext cx="3566160" cy="548640"/>
-          </a:xfrm>
-          <a:prstGeom prst="rect">
-            <a:avLst/>
-          </a:prstGeom>
-          <a:solidFill>
-            <a:srgbClr val="2BB5A6"/>
-          </a:solidFill>
-          <a:ln>
-            <a:noFill/>
-          </a:ln>
-        </p:spPr>
-        <p:style>
-          <a:lnRef idx="1">
-            <a:schemeClr val="accent1"/>
-          </a:lnRef>
-          <a:fillRef idx="3">
-            <a:schemeClr val="accent1"/>
-          </a:fillRef>
-          <a:effectRef idx="2">
-            <a:schemeClr val="accent1"/>
-          </a:effectRef>
-          <a:fontRef idx="minor">
-            <a:schemeClr val="lt1"/>
-          </a:fontRef>
-        </p:style>
-        <p:txBody>
-          <a:bodyPr rtlCol="0" anchor="ctr"/>
-          <a:lstStyle/>
-          <a:p>
-            <a:pPr algn="ctr">
-              <a:defRPr sz="1800" b="1">
-                <a:solidFill>
-                  <a:srgbClr val="FFFFFF"/>
-                </a:solidFill>
-              </a:defRPr>
-            </a:pPr>
-            <a:r>
-              <a:t>Hoogtemodel-engineers</a:t>
-            </a:r>
-          </a:p>
-        </p:txBody>
-      </p:sp>
-      <p:sp>
-        <p:nvSpPr>
-          <p:cNvPr id="6" name="TextBox 5"/>
-          <p:cNvSpPr txBox="1"/>
-          <p:nvPr/>
-        </p:nvSpPr>
-        <p:spPr>
-          <a:xfrm>
-            <a:off x="548640" y="2377440"/>
-            <a:ext cx="3566160" cy="3474720"/>
-          </a:xfrm>
-          <a:prstGeom prst="rect">
-            <a:avLst/>
-          </a:prstGeom>
-          <a:noFill/>
-        </p:spPr>
-        <p:txBody>
-          <a:bodyPr wrap="square">
-            <a:spAutoFit/>
-          </a:bodyPr>
-          <a:lstStyle/>
-          <a:p>
-            <a:pPr>
-              <a:spcAft>
-                <a:spcPts val="600"/>
-              </a:spcAft>
-              <a:defRPr sz="1500" b="0">
-                <a:solidFill>
-                  <a:srgbClr val="1F3A3D"/>
-                </a:solidFill>
-              </a:defRPr>
-            </a:pPr>
-            <a:r>
-              <a:t>• De vijfdeling (scope_coverage) meeleveren</a:t>
-            </a:r>
-          </a:p>
-          <a:p>
-            <a:pPr>
-              <a:spcAft>
-                <a:spcPts val="600"/>
-              </a:spcAft>
-              <a:defRPr sz="1500" b="0">
-                <a:solidFill>
-                  <a:srgbClr val="1F3A3D"/>
-                </a:solidFill>
-              </a:defRPr>
-            </a:pPr>
-            <a:r>
-              <a:t>• Per lijn een vlag: 'dit is een constructie / verkeerde oever'</a:t>
-            </a:r>
-          </a:p>
-          <a:p>
-            <a:pPr>
-              <a:spcAft>
-                <a:spcPts val="600"/>
-              </a:spcAft>
-              <a:defRPr sz="1500" b="0">
-                <a:solidFill>
-                  <a:srgbClr val="1F3A3D"/>
-                </a:solidFill>
-              </a:defRPr>
-            </a:pPr>
-            <a:r>
-              <a:t>• Bekende randgevallen: meeroeverig, hoogwater</a:t>
-            </a:r>
-          </a:p>
-        </p:txBody>
-      </p:sp>
-      <p:sp>
-        <p:nvSpPr>
-          <p:cNvPr id="7" name="Rectangle 6"/>
-          <p:cNvSpPr/>
-          <p:nvPr/>
-        </p:nvSpPr>
-        <p:spPr>
-          <a:xfrm>
-            <a:off x="4389120" y="1645920"/>
-            <a:ext cx="3566160" cy="548640"/>
-          </a:xfrm>
-          <a:prstGeom prst="rect">
-            <a:avLst/>
-          </a:prstGeom>
-          <a:solidFill>
-            <a:srgbClr val="2BB5A6"/>
-          </a:solidFill>
-          <a:ln>
-            <a:noFill/>
-          </a:ln>
-        </p:spPr>
-        <p:style>
-          <a:lnRef idx="1">
-            <a:schemeClr val="accent1"/>
-          </a:lnRef>
-          <a:fillRef idx="3">
-            <a:schemeClr val="accent1"/>
-          </a:fillRef>
-          <a:effectRef idx="2">
-            <a:schemeClr val="accent1"/>
-          </a:effectRef>
-          <a:fontRef idx="minor">
-            <a:schemeClr val="lt1"/>
-          </a:fontRef>
-        </p:style>
-        <p:txBody>
-          <a:bodyPr rtlCol="0" anchor="ctr"/>
-          <a:lstStyle/>
-          <a:p>
-            <a:pPr algn="ctr">
-              <a:defRPr sz="1800" b="1">
-                <a:solidFill>
-                  <a:srgbClr val="FFFFFF"/>
-                </a:solidFill>
-              </a:defRPr>
-            </a:pPr>
-            <a:r>
-              <a:t>SAM-engineers</a:t>
-            </a:r>
-          </a:p>
-        </p:txBody>
-      </p:sp>
-      <p:sp>
-        <p:nvSpPr>
-          <p:cNvPr id="8" name="TextBox 7"/>
-          <p:cNvSpPr txBox="1"/>
-          <p:nvPr/>
-        </p:nvSpPr>
-        <p:spPr>
-          <a:xfrm>
-            <a:off x="4389120" y="2377440"/>
-            <a:ext cx="3566160" cy="3474720"/>
-          </a:xfrm>
-          <a:prstGeom prst="rect">
-            <a:avLst/>
-          </a:prstGeom>
-          <a:noFill/>
-        </p:spPr>
-        <p:txBody>
-          <a:bodyPr wrap="square">
-            <a:spAutoFit/>
-          </a:bodyPr>
-          <a:lstStyle/>
-          <a:p>
-            <a:pPr>
-              <a:spcAft>
-                <a:spcPts val="600"/>
-              </a:spcAft>
-              <a:defRPr sz="1500" b="0">
-                <a:solidFill>
-                  <a:srgbClr val="1F3A3D"/>
-                </a:solidFill>
-              </a:defRPr>
-            </a:pPr>
-            <a:r>
-              <a:t>• Kwaliteitsvlag per meting</a:t>
-            </a:r>
-          </a:p>
-          <a:p>
-            <a:pPr>
-              <a:spcAft>
-                <a:spcPts val="600"/>
-              </a:spcAft>
-              <a:defRPr sz="1500" b="0">
-                <a:solidFill>
-                  <a:srgbClr val="1F3A3D"/>
-                </a:solidFill>
-              </a:defRPr>
-            </a:pPr>
-            <a:r>
-              <a:t>• Vooral: méér jaren — elk jaar maakt het model vanzelf beter</a:t>
-            </a:r>
-          </a:p>
-          <a:p>
-            <a:pPr>
-              <a:spcAft>
-                <a:spcPts val="600"/>
-              </a:spcAft>
-              <a:defRPr sz="1500" b="0">
-                <a:solidFill>
-                  <a:srgbClr val="1F3A3D"/>
-                </a:solidFill>
-              </a:defRPr>
-            </a:pPr>
-            <a:r>
-              <a:t>• Waar mogelijk: één lijn per meetmoment</a:t>
-            </a:r>
-          </a:p>
-        </p:txBody>
-      </p:sp>
-      <p:sp>
-        <p:nvSpPr>
-          <p:cNvPr id="9" name="Rectangle 8"/>
-          <p:cNvSpPr/>
-          <p:nvPr/>
-        </p:nvSpPr>
-        <p:spPr>
-          <a:xfrm>
-            <a:off x="8229600" y="1645920"/>
-            <a:ext cx="3566160" cy="548640"/>
-          </a:xfrm>
-          <a:prstGeom prst="rect">
-            <a:avLst/>
-          </a:prstGeom>
-          <a:solidFill>
-            <a:srgbClr val="E07A3F"/>
-          </a:solidFill>
-          <a:ln>
-            <a:noFill/>
-          </a:ln>
-        </p:spPr>
-        <p:style>
-          <a:lnRef idx="1">
-            <a:schemeClr val="accent1"/>
-          </a:lnRef>
-          <a:fillRef idx="3">
-            <a:schemeClr val="accent1"/>
-          </a:fillRef>
-          <a:effectRef idx="2">
-            <a:schemeClr val="accent1"/>
-          </a:effectRef>
-          <a:fontRef idx="minor">
-            <a:schemeClr val="lt1"/>
-          </a:fontRef>
-        </p:style>
-        <p:txBody>
-          <a:bodyPr rtlCol="0" anchor="ctr"/>
-          <a:lstStyle/>
-          <a:p>
-            <a:pPr algn="ctr">
-              <a:defRPr sz="1800" b="1">
-                <a:solidFill>
-                  <a:srgbClr val="FFFFFF"/>
-                </a:solidFill>
-              </a:defRPr>
-            </a:pPr>
-            <a:r>
-              <a:t>Samen</a:t>
-            </a:r>
-          </a:p>
-        </p:txBody>
-      </p:sp>
-      <p:sp>
-        <p:nvSpPr>
-          <p:cNvPr id="10" name="TextBox 9"/>
-          <p:cNvSpPr txBox="1"/>
-          <p:nvPr/>
-        </p:nvSpPr>
-        <p:spPr>
-          <a:xfrm>
-            <a:off x="8229600" y="2377440"/>
-            <a:ext cx="3566160" cy="3474720"/>
-          </a:xfrm>
-          <a:prstGeom prst="rect">
-            <a:avLst/>
-          </a:prstGeom>
-          <a:noFill/>
-        </p:spPr>
-        <p:txBody>
-          <a:bodyPr wrap="square">
-            <a:spAutoFit/>
-          </a:bodyPr>
-          <a:lstStyle/>
-          <a:p>
-            <a:pPr>
-              <a:spcAft>
-                <a:spcPts val="600"/>
-              </a:spcAft>
-              <a:defRPr sz="1500" b="0">
-                <a:solidFill>
-                  <a:srgbClr val="1F3A3D"/>
-                </a:solidFill>
-              </a:defRPr>
-            </a:pPr>
-            <a:r>
-              <a:t>• Labelronde in QGIS: wij leveren de gesorteerde lijst twijfelgevallen, jullie het oordeel</a:t>
-            </a:r>
-          </a:p>
-          <a:p>
-            <a:pPr>
-              <a:spcAft>
-                <a:spcPts val="600"/>
-              </a:spcAft>
-              <a:defRPr sz="1500" b="0">
-                <a:solidFill>
-                  <a:srgbClr val="1F3A3D"/>
-                </a:solidFill>
-              </a:defRPr>
-            </a:pPr>
-            <a:r>
-              <a:t>• Eerste ronde: ~200 vlakken, twee uur</a:t>
-            </a:r>
-          </a:p>
-          <a:p>
-            <a:pPr>
-              <a:spcAft>
-                <a:spcPts val="600"/>
-              </a:spcAft>
-              <a:defRPr sz="1500" b="0">
-                <a:solidFill>
-                  <a:srgbClr val="1F3A3D"/>
-                </a:solidFill>
-              </a:defRPr>
-            </a:pPr>
-            <a:r>
-              <a:t>• Daarna meten we opnieuw</a:t>
-            </a:r>
-          </a:p>
-        </p:txBody>
-      </p:sp>
-    </p:spTree>
-  </p:cSld>
-  <p:clrMapOvr>
-    <a:masterClrMapping/>
-  </p:clrMapOvr>
-</p:sld>
-</file>
-
-<file path=ppt/slides/slide15.xml><?xml version="1.0" encoding="utf-8"?>
-<p:sld xmlns:a="http://schemas.openxmlformats.org/drawingml/2006/main" xmlns:r="http://schemas.openxmlformats.org/officeDocument/2006/relationships" xmlns:p="http://schemas.openxmlformats.org/presentationml/2006/main">
-  <p:cSld>
-    <p:spTree>
-      <p:nvGrpSpPr>
-        <p:cNvPr id="1" name=""/>
-        <p:cNvGrpSpPr/>
-        <p:nvPr/>
-      </p:nvGrpSpPr>
-      <p:grpSpPr>
-        <a:xfrm>
-          <a:off x="0" y="0"/>
-          <a:ext cx="0" cy="0"/>
-          <a:chOff x="0" y="0"/>
-          <a:chExt cx="0" cy="0"/>
-        </a:xfrm>
-      </p:grpSpPr>
-      <p:sp>
-        <p:nvSpPr>
-          <p:cNvPr id="2" name="TextBox 1"/>
-          <p:cNvSpPr txBox="1"/>
-          <p:nvPr/>
-        </p:nvSpPr>
-        <p:spPr>
-          <a:xfrm>
-            <a:off x="548640" y="320040"/>
-            <a:ext cx="10972800" cy="731520"/>
-          </a:xfrm>
-          <a:prstGeom prst="rect">
-            <a:avLst/>
-          </a:prstGeom>
-          <a:noFill/>
-        </p:spPr>
-        <p:txBody>
-          <a:bodyPr wrap="none">
-            <a:spAutoFit/>
-          </a:bodyPr>
-          <a:lstStyle/>
-          <a:p>
-            <a:pPr>
-              <a:defRPr sz="3000" b="1">
-                <a:solidFill>
-                  <a:srgbClr val="2BB5A6"/>
-                </a:solidFill>
-              </a:defRPr>
-            </a:pPr>
-            <a:r>
-              <a:t>Wat dit oplevert voor asset management</a:t>
-            </a:r>
-          </a:p>
-        </p:txBody>
-      </p:sp>
-      <p:sp>
-        <p:nvSpPr>
-          <p:cNvPr id="3" name="TextBox 2"/>
-          <p:cNvSpPr txBox="1"/>
-          <p:nvPr/>
-        </p:nvSpPr>
-        <p:spPr>
-          <a:xfrm>
-            <a:off x="548640" y="960120"/>
-            <a:ext cx="10972800" cy="548640"/>
-          </a:xfrm>
-          <a:prstGeom prst="rect">
-            <a:avLst/>
-          </a:prstGeom>
-          <a:noFill/>
-        </p:spPr>
-        <p:txBody>
-          <a:bodyPr wrap="none">
-            <a:spAutoFit/>
-          </a:bodyPr>
-          <a:lstStyle/>
-          <a:p>
-            <a:pPr>
-              <a:defRPr sz="1700">
-                <a:solidFill>
-                  <a:srgbClr val="1F3A3D"/>
-                </a:solidFill>
-              </a:defRPr>
-            </a:pPr>
-            <a:r>
-              <a:t>Van 'dit vlak gemiddeld' naar 'deze 20 meter'</a:t>
-            </a:r>
-          </a:p>
-        </p:txBody>
-      </p:sp>
-      <p:sp>
-        <p:nvSpPr>
-          <p:cNvPr id="4" name="TextBox 3"/>
-          <p:cNvSpPr txBox="1"/>
-          <p:nvPr/>
-        </p:nvSpPr>
-        <p:spPr>
-          <a:xfrm>
-            <a:off x="548640" y="6400800"/>
-            <a:ext cx="10972800" cy="274320"/>
-          </a:xfrm>
-          <a:prstGeom prst="rect">
-            <a:avLst/>
-          </a:prstGeom>
-          <a:noFill/>
-        </p:spPr>
-        <p:txBody>
-          <a:bodyPr wrap="none">
-            <a:spAutoFit/>
-          </a:bodyPr>
-          <a:lstStyle/>
-          <a:p>
-            <a:pPr>
-              <a:defRPr sz="1000">
-                <a:solidFill>
-                  <a:srgbClr val="6B7778"/>
-                </a:solidFill>
-              </a:defRPr>
-            </a:pPr>
-            <a:r>
-              <a:t>Oevererosietool · update 26-08-2026 · 17</a:t>
-            </a:r>
-          </a:p>
-        </p:txBody>
-      </p:sp>
-      <p:pic>
-        <p:nvPicPr>
-          <p:cNvPr id="5" name="Picture 4" descr="r5_rijn_1220.png"/>
-          <p:cNvPicPr>
-            <a:picLocks noChangeAspect="1"/>
-          </p:cNvPicPr>
-          <p:nvPr/>
-        </p:nvPicPr>
-        <p:blipFill>
-          <a:blip r:embed="rId2"/>
-          <a:stretch>
-            <a:fillRect/>
-          </a:stretch>
-        </p:blipFill>
-        <p:spPr>
-          <a:xfrm>
-            <a:off x="548640" y="1554480"/>
-            <a:ext cx="3388524" cy="4480560"/>
-          </a:xfrm>
-          <a:prstGeom prst="rect">
-            <a:avLst/>
-          </a:prstGeom>
-        </p:spPr>
-      </p:pic>
-      <p:sp>
-        <p:nvSpPr>
-          <p:cNvPr id="6" name="TextBox 5"/>
-          <p:cNvSpPr txBox="1"/>
-          <p:nvPr/>
-        </p:nvSpPr>
-        <p:spPr>
-          <a:xfrm>
-            <a:off x="5120640" y="1737360"/>
-            <a:ext cx="6858000" cy="4114800"/>
-          </a:xfrm>
-          <a:prstGeom prst="rect">
-            <a:avLst/>
-          </a:prstGeom>
-          <a:noFill/>
-        </p:spPr>
-        <p:txBody>
-          <a:bodyPr wrap="square">
-            <a:spAutoFit/>
-          </a:bodyPr>
-          <a:lstStyle/>
-          <a:p>
-            <a:pPr>
-              <a:spcAft>
-                <a:spcPts val="600"/>
-              </a:spcAft>
-              <a:defRPr sz="1500" b="0">
-                <a:solidFill>
-                  <a:srgbClr val="1F3A3D"/>
-                </a:solidFill>
-              </a:defRPr>
-            </a:pPr>
-            <a:r>
-              <a:t>• Per segment een verwachte positie ≥ 2 jaar vooruit (48 000 segmenten, 10 000 vlakken)</a:t>
-            </a:r>
-          </a:p>
-          <a:p>
-            <a:pPr>
-              <a:spcAft>
-                <a:spcPts val="600"/>
-              </a:spcAft>
-              <a:defRPr sz="1500" b="0">
-                <a:solidFill>
-                  <a:srgbClr val="1F3A3D"/>
-                </a:solidFill>
-              </a:defRPr>
-            </a:pPr>
-            <a:r>
-              <a:t>• Een vlak kleurt rood zodra énig segment de signaleringslijn nadert — met het segment erbij</a:t>
-            </a:r>
-          </a:p>
-          <a:p>
-            <a:pPr>
-              <a:spcAft>
-                <a:spcPts val="600"/>
-              </a:spcAft>
-              <a:defRPr sz="1500" b="0">
-                <a:solidFill>
-                  <a:srgbClr val="1F3A3D"/>
-                </a:solidFill>
-              </a:defRPr>
-            </a:pPr>
-            <a:r>
-              <a:t>• Kribvakken en meerdelige vlakken worden daarmee vanzelf goed behandeld</a:t>
-            </a:r>
-          </a:p>
-          <a:p>
-            <a:pPr>
-              <a:spcAft>
-                <a:spcPts val="600"/>
-              </a:spcAft>
-              <a:defRPr sz="1500" b="0">
-                <a:solidFill>
-                  <a:srgbClr val="1F3A3D"/>
-                </a:solidFill>
-              </a:defRPr>
-            </a:pPr>
-            <a:r>
-              <a:t>• Bestaande stoplicht-kaart en tijdslider blijven; dit komt er als laag bij</a:t>
-            </a:r>
-          </a:p>
-          <a:p>
-            <a:pPr>
-              <a:spcAft>
-                <a:spcPts val="600"/>
-              </a:spcAft>
-              <a:defRPr sz="1500" b="1">
-                <a:solidFill>
-                  <a:srgbClr val="1F3A3D"/>
-                </a:solidFill>
-              </a:defRPr>
-            </a:pPr>
-            <a:r>
-              <a:t>Status: segmentvoorspellingen staan klaar; koppeling aan het VVR-alarm is de volgende stap</a:t>
-            </a:r>
-          </a:p>
-        </p:txBody>
-      </p:sp>
-    </p:spTree>
-  </p:cSld>
-  <p:clrMapOvr>
-    <a:masterClrMapping/>
-  </p:clrMapOvr>
-</p:sld>
-</file>
-
 <file path=ppt/slides/slide16.xml><?xml version="1.0" encoding="utf-8"?>
 <p:sld xmlns:a="http://schemas.openxmlformats.org/drawingml/2006/main" xmlns:r="http://schemas.openxmlformats.org/officeDocument/2006/relationships" xmlns:p="http://schemas.openxmlformats.org/presentationml/2006/main">
   <p:cSld>
@@ -6050,7 +5862,7 @@
               </a:defRPr>
             </a:pPr>
             <a:r>
-              <a:t>Samenvattend</a:t>
+              <a:t>Wat we vragen</a:t>
             </a:r>
           </a:p>
         </p:txBody>
@@ -6063,8 +5875,8 @@
         </p:nvSpPr>
         <p:spPr>
           <a:xfrm>
-            <a:off x="548640" y="6400800"/>
-            <a:ext cx="10972800" cy="274320"/>
+            <a:off x="548640" y="960120"/>
+            <a:ext cx="10972800" cy="548640"/>
           </a:xfrm>
           <a:prstGeom prst="rect">
             <a:avLst/>
@@ -6078,14 +5890,14 @@
           <a:lstStyle/>
           <a:p>
             <a:pPr>
-              <a:defRPr sz="1000">
-                <a:solidFill>
-                  <a:srgbClr val="6B7778"/>
-                </a:solidFill>
-              </a:defRPr>
-            </a:pPr>
-            <a:r>
-              <a:t>Oevererosietool · update 26-08-2026 · 18</a:t>
+              <a:defRPr sz="1700">
+                <a:solidFill>
+                  <a:srgbClr val="1F3A3D"/>
+                </a:solidFill>
+              </a:defRPr>
+            </a:pPr>
+            <a:r>
+              <a:t>Labelen is trial-and-error — geen eenmalige levering</a:t>
             </a:r>
           </a:p>
         </p:txBody>
@@ -6098,8 +5910,8 @@
         </p:nvSpPr>
         <p:spPr>
           <a:xfrm>
-            <a:off x="548640" y="1463040"/>
-            <a:ext cx="10972800" cy="4754880"/>
+            <a:off x="548640" y="6400800"/>
+            <a:ext cx="10972800" cy="274320"/>
           </a:xfrm>
           <a:prstGeom prst="rect">
             <a:avLst/>
@@ -6107,6 +5919,93 @@
           <a:noFill/>
         </p:spPr>
         <p:txBody>
+          <a:bodyPr wrap="none">
+            <a:spAutoFit/>
+          </a:bodyPr>
+          <a:lstStyle/>
+          <a:p>
+            <a:pPr>
+              <a:defRPr sz="1000">
+                <a:solidFill>
+                  <a:srgbClr val="6B7778"/>
+                </a:solidFill>
+              </a:defRPr>
+            </a:pPr>
+            <a:r>
+              <a:t>Oevererosietool · update 26-08-2026 · 16</a:t>
+            </a:r>
+          </a:p>
+        </p:txBody>
+      </p:sp>
+      <p:sp>
+        <p:nvSpPr>
+          <p:cNvPr id="5" name="Rectangle 4"/>
+          <p:cNvSpPr/>
+          <p:nvPr/>
+        </p:nvSpPr>
+        <p:spPr>
+          <a:xfrm>
+            <a:off x="548640" y="1645920"/>
+            <a:ext cx="3566160" cy="548640"/>
+          </a:xfrm>
+          <a:prstGeom prst="rect">
+            <a:avLst/>
+          </a:prstGeom>
+          <a:solidFill>
+            <a:srgbClr val="2BB5A6"/>
+          </a:solidFill>
+          <a:ln>
+            <a:noFill/>
+          </a:ln>
+        </p:spPr>
+        <p:style>
+          <a:lnRef idx="1">
+            <a:schemeClr val="accent1"/>
+          </a:lnRef>
+          <a:fillRef idx="3">
+            <a:schemeClr val="accent1"/>
+          </a:fillRef>
+          <a:effectRef idx="2">
+            <a:schemeClr val="accent1"/>
+          </a:effectRef>
+          <a:fontRef idx="minor">
+            <a:schemeClr val="lt1"/>
+          </a:fontRef>
+        </p:style>
+        <p:txBody>
+          <a:bodyPr rtlCol="0" anchor="ctr"/>
+          <a:lstStyle/>
+          <a:p>
+            <a:pPr algn="ctr">
+              <a:defRPr sz="1800" b="1">
+                <a:solidFill>
+                  <a:srgbClr val="FFFFFF"/>
+                </a:solidFill>
+              </a:defRPr>
+            </a:pPr>
+            <a:r>
+              <a:t>Hoogtemodel-engineers</a:t>
+            </a:r>
+          </a:p>
+        </p:txBody>
+      </p:sp>
+      <p:sp>
+        <p:nvSpPr>
+          <p:cNvPr id="6" name="TextBox 5"/>
+          <p:cNvSpPr txBox="1"/>
+          <p:nvPr/>
+        </p:nvSpPr>
+        <p:spPr>
+          <a:xfrm>
+            <a:off x="548640" y="2377440"/>
+            <a:ext cx="3566160" cy="3474720"/>
+          </a:xfrm>
+          <a:prstGeom prst="rect">
+            <a:avLst/>
+          </a:prstGeom>
+          <a:noFill/>
+        </p:spPr>
+        <p:txBody>
           <a:bodyPr wrap="square">
             <a:spAutoFit/>
           </a:bodyPr>
@@ -6114,121 +6013,286 @@
           <a:p>
             <a:pPr>
               <a:spcAft>
-                <a:spcPts val="800"/>
+                <a:spcPts val="600"/>
               </a:spcAft>
+              <a:defRPr sz="1500" b="0">
+                <a:solidFill>
+                  <a:srgbClr val="1F3A3D"/>
+                </a:solidFill>
+              </a:defRPr>
+            </a:pPr>
+            <a:r>
+              <a:t>• De vijfdeling (scope_coverage) meeleveren</a:t>
+            </a:r>
+          </a:p>
+          <a:p>
+            <a:pPr>
+              <a:spcAft>
+                <a:spcPts val="600"/>
+              </a:spcAft>
+              <a:defRPr sz="1500" b="0">
+                <a:solidFill>
+                  <a:srgbClr val="1F3A3D"/>
+                </a:solidFill>
+              </a:defRPr>
+            </a:pPr>
+            <a:r>
+              <a:t>• Per lijn een vlag: 'dit is een constructie / verkeerde oever'</a:t>
+            </a:r>
+          </a:p>
+          <a:p>
+            <a:pPr>
+              <a:spcAft>
+                <a:spcPts val="600"/>
+              </a:spcAft>
+              <a:defRPr sz="1500" b="0">
+                <a:solidFill>
+                  <a:srgbClr val="1F3A3D"/>
+                </a:solidFill>
+              </a:defRPr>
+            </a:pPr>
+            <a:r>
+              <a:t>• Bekende randgevallen: meeroeverig, hoogwater</a:t>
+            </a:r>
+          </a:p>
+        </p:txBody>
+      </p:sp>
+      <p:sp>
+        <p:nvSpPr>
+          <p:cNvPr id="7" name="Rectangle 6"/>
+          <p:cNvSpPr/>
+          <p:nvPr/>
+        </p:nvSpPr>
+        <p:spPr>
+          <a:xfrm>
+            <a:off x="4389120" y="1645920"/>
+            <a:ext cx="3566160" cy="548640"/>
+          </a:xfrm>
+          <a:prstGeom prst="rect">
+            <a:avLst/>
+          </a:prstGeom>
+          <a:solidFill>
+            <a:srgbClr val="2BB5A6"/>
+          </a:solidFill>
+          <a:ln>
+            <a:noFill/>
+          </a:ln>
+        </p:spPr>
+        <p:style>
+          <a:lnRef idx="1">
+            <a:schemeClr val="accent1"/>
+          </a:lnRef>
+          <a:fillRef idx="3">
+            <a:schemeClr val="accent1"/>
+          </a:fillRef>
+          <a:effectRef idx="2">
+            <a:schemeClr val="accent1"/>
+          </a:effectRef>
+          <a:fontRef idx="minor">
+            <a:schemeClr val="lt1"/>
+          </a:fontRef>
+        </p:style>
+        <p:txBody>
+          <a:bodyPr rtlCol="0" anchor="ctr"/>
+          <a:lstStyle/>
+          <a:p>
+            <a:pPr algn="ctr">
               <a:defRPr sz="1800" b="1">
                 <a:solidFill>
+                  <a:srgbClr val="FFFFFF"/>
+                </a:solidFill>
+              </a:defRPr>
+            </a:pPr>
+            <a:r>
+              <a:t>SAM-engineers</a:t>
+            </a:r>
+          </a:p>
+        </p:txBody>
+      </p:sp>
+      <p:sp>
+        <p:nvSpPr>
+          <p:cNvPr id="8" name="TextBox 7"/>
+          <p:cNvSpPr txBox="1"/>
+          <p:nvPr/>
+        </p:nvSpPr>
+        <p:spPr>
+          <a:xfrm>
+            <a:off x="4389120" y="2377440"/>
+            <a:ext cx="3566160" cy="3474720"/>
+          </a:xfrm>
+          <a:prstGeom prst="rect">
+            <a:avLst/>
+          </a:prstGeom>
+          <a:noFill/>
+        </p:spPr>
+        <p:txBody>
+          <a:bodyPr wrap="square">
+            <a:spAutoFit/>
+          </a:bodyPr>
+          <a:lstStyle/>
+          <a:p>
+            <a:pPr>
+              <a:spcAft>
+                <a:spcPts val="600"/>
+              </a:spcAft>
+              <a:defRPr sz="1500" b="0">
+                <a:solidFill>
                   <a:srgbClr val="1F3A3D"/>
                 </a:solidFill>
               </a:defRPr>
             </a:pPr>
             <a:r>
-              <a:t>Model: klaar en eerlijk gevalideerd</a:t>
+              <a:t>• Kwaliteitsvlag per meting</a:t>
             </a:r>
           </a:p>
           <a:p>
             <a:pPr>
               <a:spcAft>
-                <a:spcPts val="800"/>
+                <a:spcPts val="600"/>
               </a:spcAft>
-              <a:defRPr sz="1800" b="0">
+              <a:defRPr sz="1500" b="0">
                 <a:solidFill>
                   <a:srgbClr val="1F3A3D"/>
                 </a:solidFill>
               </a:defRPr>
             </a:pPr>
             <a:r>
-              <a:t>• Hybride bron, opschoonregels, historie-features, testset buiten de training</a:t>
+              <a:t>• Vooral: méér jaren — elk jaar maakt het model vanzelf beter</a:t>
             </a:r>
           </a:p>
           <a:p>
             <a:pPr>
               <a:spcAft>
-                <a:spcPts val="800"/>
+                <a:spcPts val="600"/>
               </a:spcAft>
+              <a:defRPr sz="1500" b="0">
+                <a:solidFill>
+                  <a:srgbClr val="1F3A3D"/>
+                </a:solidFill>
+              </a:defRPr>
+            </a:pPr>
+            <a:r>
+              <a:t>• Waar mogelijk: één lijn per meetmoment</a:t>
+            </a:r>
+          </a:p>
+        </p:txBody>
+      </p:sp>
+      <p:sp>
+        <p:nvSpPr>
+          <p:cNvPr id="9" name="Rectangle 8"/>
+          <p:cNvSpPr/>
+          <p:nvPr/>
+        </p:nvSpPr>
+        <p:spPr>
+          <a:xfrm>
+            <a:off x="8229600" y="1645920"/>
+            <a:ext cx="3566160" cy="548640"/>
+          </a:xfrm>
+          <a:prstGeom prst="rect">
+            <a:avLst/>
+          </a:prstGeom>
+          <a:solidFill>
+            <a:srgbClr val="E07A3F"/>
+          </a:solidFill>
+          <a:ln>
+            <a:noFill/>
+          </a:ln>
+        </p:spPr>
+        <p:style>
+          <a:lnRef idx="1">
+            <a:schemeClr val="accent1"/>
+          </a:lnRef>
+          <a:fillRef idx="3">
+            <a:schemeClr val="accent1"/>
+          </a:fillRef>
+          <a:effectRef idx="2">
+            <a:schemeClr val="accent1"/>
+          </a:effectRef>
+          <a:fontRef idx="minor">
+            <a:schemeClr val="lt1"/>
+          </a:fontRef>
+        </p:style>
+        <p:txBody>
+          <a:bodyPr rtlCol="0" anchor="ctr"/>
+          <a:lstStyle/>
+          <a:p>
+            <a:pPr algn="ctr">
               <a:defRPr sz="1800" b="1">
                 <a:solidFill>
+                  <a:srgbClr val="FFFFFF"/>
+                </a:solidFill>
+              </a:defRPr>
+            </a:pPr>
+            <a:r>
+              <a:t>Samen</a:t>
+            </a:r>
+          </a:p>
+        </p:txBody>
+      </p:sp>
+      <p:sp>
+        <p:nvSpPr>
+          <p:cNvPr id="10" name="TextBox 9"/>
+          <p:cNvSpPr txBox="1"/>
+          <p:nvPr/>
+        </p:nvSpPr>
+        <p:spPr>
+          <a:xfrm>
+            <a:off x="8229600" y="2377440"/>
+            <a:ext cx="3566160" cy="3474720"/>
+          </a:xfrm>
+          <a:prstGeom prst="rect">
+            <a:avLst/>
+          </a:prstGeom>
+          <a:noFill/>
+        </p:spPr>
+        <p:txBody>
+          <a:bodyPr wrap="square">
+            <a:spAutoFit/>
+          </a:bodyPr>
+          <a:lstStyle/>
+          <a:p>
+            <a:pPr>
+              <a:spcAft>
+                <a:spcPts val="600"/>
+              </a:spcAft>
+              <a:defRPr sz="1500" b="0">
+                <a:solidFill>
                   <a:srgbClr val="1F3A3D"/>
                 </a:solidFill>
               </a:defRPr>
             </a:pPr>
             <a:r>
-              <a:t>Van lijn naar oever</a:t>
+              <a:t>• Labelronde in QGIS: wij leveren de gesorteerde lijst twijfelgevallen, jullie het oordeel</a:t>
             </a:r>
           </a:p>
           <a:p>
             <a:pPr>
               <a:spcAft>
-                <a:spcPts val="800"/>
+                <a:spcPts val="600"/>
               </a:spcAft>
-              <a:defRPr sz="1800" b="0">
+              <a:defRPr sz="1500" b="0">
                 <a:solidFill>
                   <a:srgbClr val="1F3A3D"/>
                 </a:solidFill>
               </a:defRPr>
             </a:pPr>
             <a:r>
-              <a:t>• Vijf segmenten per vlak; gemeten én voorspelde oever als lijn; positiefout ≈ 1 m</a:t>
+              <a:t>• Eerste ronde: ~200 vlakken, twee uur</a:t>
             </a:r>
           </a:p>
           <a:p>
             <a:pPr>
               <a:spcAft>
-                <a:spcPts val="800"/>
+                <a:spcPts val="600"/>
               </a:spcAft>
-              <a:defRPr sz="1800" b="1">
+              <a:defRPr sz="1500" b="0">
                 <a:solidFill>
                   <a:srgbClr val="1F3A3D"/>
                 </a:solidFill>
               </a:defRPr>
             </a:pPr>
             <a:r>
-              <a:t>Bottleneck: gelabelde input, niet het algoritme</a:t>
-            </a:r>
-          </a:p>
-          <a:p>
-            <a:pPr>
-              <a:spcAft>
-                <a:spcPts val="800"/>
-              </a:spcAft>
-              <a:defRPr sz="1800" b="0">
-                <a:solidFill>
-                  <a:srgbClr val="1F3A3D"/>
-                </a:solidFill>
-              </a:defRPr>
-            </a:pPr>
-            <a:r>
-              <a:t>• Opschonen leverde 12× zoveel als modelleren; de regels raken op — wat overblijft vraagt een oordeel</a:t>
-            </a:r>
-          </a:p>
-          <a:p>
-            <a:pPr>
-              <a:spcAft>
-                <a:spcPts val="800"/>
-              </a:spcAft>
-              <a:defRPr sz="1800" b="1">
-                <a:solidFill>
-                  <a:srgbClr val="1F3A3D"/>
-                </a:solidFill>
-              </a:defRPr>
-            </a:pPr>
-            <a:r>
-              <a:t>Volgende stap</a:t>
-            </a:r>
-          </a:p>
-          <a:p>
-            <a:pPr>
-              <a:spcAft>
-                <a:spcPts val="800"/>
-              </a:spcAft>
-              <a:defRPr sz="1800" b="0">
-                <a:solidFill>
-                  <a:srgbClr val="1F3A3D"/>
-                </a:solidFill>
-              </a:defRPr>
-            </a:pPr>
-            <a:r>
-              <a:t>• Labelronde met SAM- en hoogtemodel-engineers · VVR-alarm op segmentniveau · daarna opnieuw meten</a:t>
+              <a:t>• Daarna meten we opnieuw</a:t>
             </a:r>
           </a:p>
         </p:txBody>
@@ -6242,7 +6306,7 @@
 </file>
 
 <file path=ppt/slides/slide17.xml><?xml version="1.0" encoding="utf-8"?>
-<p:sld xmlns:a="http://schemas.openxmlformats.org/drawingml/2006/main" xmlns:p="http://schemas.openxmlformats.org/presentationml/2006/main" xmlns:r="http://schemas.openxmlformats.org/officeDocument/2006/relationships">
+<p:sld xmlns:a="http://schemas.openxmlformats.org/drawingml/2006/main" xmlns:r="http://schemas.openxmlformats.org/officeDocument/2006/relationships" xmlns:p="http://schemas.openxmlformats.org/presentationml/2006/main">
   <p:cSld>
     <p:spTree>
       <p:nvGrpSpPr>
@@ -6250,7 +6314,14 @@
         <p:cNvGrpSpPr/>
         <p:nvPr/>
       </p:nvGrpSpPr>
-      <p:grpSpPr/>
+      <p:grpSpPr>
+        <a:xfrm>
+          <a:off x="0" y="0"/>
+          <a:ext cx="0" cy="0"/>
+          <a:chOff x="0" y="0"/>
+          <a:chExt cx="0" cy="0"/>
+        </a:xfrm>
+      </p:grpSpPr>
       <p:sp>
         <p:nvSpPr>
           <p:cNvPr id="2" name="TextBox 1"/>
@@ -6268,20 +6339,20 @@
           <a:noFill/>
         </p:spPr>
         <p:txBody>
-          <a:bodyPr wrap="square">
+          <a:bodyPr wrap="none">
             <a:spAutoFit/>
           </a:bodyPr>
           <a:lstStyle/>
           <a:p>
             <a:pPr>
-              <a:defRPr sz="3000" b="1" i="0">
+              <a:defRPr sz="3000" b="1">
                 <a:solidFill>
                   <a:srgbClr val="2BB5A6"/>
                 </a:solidFill>
               </a:defRPr>
             </a:pPr>
             <a:r>
-              <a:t>As 1 · Hoeveel vlakken raakt elke regel?</a:t>
+              <a:t>Wat dit oplevert voor asset management</a:t>
             </a:r>
           </a:p>
         </p:txBody>
@@ -6303,27 +6374,62 @@
           <a:noFill/>
         </p:spPr>
         <p:txBody>
-          <a:bodyPr wrap="square">
+          <a:bodyPr wrap="none">
             <a:spAutoFit/>
           </a:bodyPr>
           <a:lstStyle/>
           <a:p>
             <a:pPr>
-              <a:defRPr sz="1700" b="0" i="0">
+              <a:defRPr sz="1700">
                 <a:solidFill>
                   <a:srgbClr val="1F3A3D"/>
                 </a:solidFill>
               </a:defRPr>
             </a:pPr>
             <a:r>
-              <a:t>Elke regel apart op de basisdata · een vlak kan in meerdere balken staan</a:t>
+              <a:t>Van 'dit vlak gemiddeld' naar 'deze 20 meter'</a:t>
+            </a:r>
+          </a:p>
+        </p:txBody>
+      </p:sp>
+      <p:sp>
+        <p:nvSpPr>
+          <p:cNvPr id="4" name="TextBox 3"/>
+          <p:cNvSpPr txBox="1"/>
+          <p:nvPr/>
+        </p:nvSpPr>
+        <p:spPr>
+          <a:xfrm>
+            <a:off x="548640" y="6400800"/>
+            <a:ext cx="10972800" cy="274320"/>
+          </a:xfrm>
+          <a:prstGeom prst="rect">
+            <a:avLst/>
+          </a:prstGeom>
+          <a:noFill/>
+        </p:spPr>
+        <p:txBody>
+          <a:bodyPr wrap="none">
+            <a:spAutoFit/>
+          </a:bodyPr>
+          <a:lstStyle/>
+          <a:p>
+            <a:pPr>
+              <a:defRPr sz="1000">
+                <a:solidFill>
+                  <a:srgbClr val="6B7778"/>
+                </a:solidFill>
+              </a:defRPr>
+            </a:pPr>
+            <a:r>
+              <a:t>Oevererosietool · update 26-08-2026 · 17</a:t>
             </a:r>
           </a:p>
         </p:txBody>
       </p:sp>
       <p:pic>
         <p:nvPicPr>
-          <p:cNvPr id="4" name="Picture 3" descr="rule_touched.png"/>
+          <p:cNvPr id="5" name="Picture 4" descr="r5_rijn_1220.png"/>
           <p:cNvPicPr>
             <a:picLocks noChangeAspect="1"/>
           </p:cNvPicPr>
@@ -6337,8 +6443,8 @@
         </p:blipFill>
         <p:spPr>
           <a:xfrm>
-            <a:off x="365760" y="1554480"/>
-            <a:ext cx="7863840" cy="3431494"/>
+            <a:off x="548640" y="1554480"/>
+            <a:ext cx="3388524" cy="4480560"/>
           </a:xfrm>
           <a:prstGeom prst="rect">
             <a:avLst/>
@@ -6347,14 +6453,14 @@
       </p:pic>
       <p:sp>
         <p:nvSpPr>
-          <p:cNvPr id="5" name="TextBox 4"/>
+          <p:cNvPr id="6" name="TextBox 5"/>
           <p:cNvSpPr txBox="1"/>
           <p:nvPr/>
         </p:nvSpPr>
         <p:spPr>
           <a:xfrm>
-            <a:off x="8503920" y="1645920"/>
-            <a:ext cx="3474720" cy="4572000"/>
+            <a:off x="5120640" y="1737360"/>
+            <a:ext cx="6858000" cy="4114800"/>
           </a:xfrm>
           <a:prstGeom prst="rect">
             <a:avLst/>
@@ -6369,96 +6475,76 @@
           <a:p>
             <a:pPr>
               <a:spcAft>
-                <a:spcPts val="500"/>
+                <a:spcPts val="600"/>
               </a:spcAft>
-              <a:defRPr sz="1300">
+              <a:defRPr sz="1500" b="0">
                 <a:solidFill>
                   <a:srgbClr val="1F3A3D"/>
                 </a:solidFill>
               </a:defRPr>
             </a:pPr>
             <a:r>
-              <a:t>• 5 165 van de 11 517 vlakken worden door ≥ 1 regel geraakt; 284 verdwijnen helemaal</a:t>
+              <a:t>• Per segment een verwachte positie ≥ 2 jaar vooruit (48 000 segmenten, 10 000 vlakken)</a:t>
             </a:r>
           </a:p>
           <a:p>
             <a:pPr>
               <a:spcAft>
-                <a:spcPts val="500"/>
+                <a:spcPts val="600"/>
               </a:spcAft>
-              <a:defRPr sz="1300">
+              <a:defRPr sz="1500" b="0">
                 <a:solidFill>
                   <a:srgbClr val="1F3A3D"/>
                 </a:solidFill>
               </a:defRPr>
             </a:pPr>
             <a:r>
-              <a:t>• Kronkelende lijnen, doolhoven en uitschieters in de tijd zijn púúr SAM-verschijnselen</a:t>
+              <a:t>• Een vlak kleurt rood zodra énig segment de signaleringslijn nadert — met het segment erbij</a:t>
             </a:r>
           </a:p>
           <a:p>
             <a:pPr>
               <a:spcAft>
-                <a:spcPts val="500"/>
+                <a:spcPts val="600"/>
               </a:spcAft>
-              <a:defRPr sz="1300">
+              <a:defRPr sz="1500" b="0">
                 <a:solidFill>
                   <a:srgbClr val="1F3A3D"/>
                 </a:solidFill>
               </a:defRPr>
             </a:pPr>
             <a:r>
-              <a:t>• Hoogtemodel-vlakken worden vrijwel alleen door het kribbenmasker en fragmenten geraakt (429 van 2 033)</a:t>
+              <a:t>• Kribvakken en meerdelige vlakken worden daarmee vanzelf goed behandeld</a:t>
             </a:r>
           </a:p>
           <a:p>
             <a:pPr>
               <a:spcAft>
-                <a:spcPts val="500"/>
+                <a:spcPts val="600"/>
               </a:spcAft>
-              <a:defRPr sz="1300">
+              <a:defRPr sz="1500" b="0">
                 <a:solidFill>
                   <a:srgbClr val="1F3A3D"/>
                 </a:solidFill>
               </a:defRPr>
             </a:pPr>
             <a:r>
-              <a:t>• 'Te weinig punten' raakt op zichzelf niets — het bijt pas nadat andere regels een meting uitdunnen</a:t>
-            </a:r>
-          </a:p>
-        </p:txBody>
-      </p:sp>
-      <p:sp>
-        <p:nvSpPr>
-          <p:cNvPr id="6" name="TextBox 5"/>
-          <p:cNvSpPr txBox="1"/>
-          <p:nvPr/>
-        </p:nvSpPr>
-        <p:spPr>
-          <a:xfrm>
-            <a:off x="548640" y="6400800"/>
-            <a:ext cx="10972800" cy="274320"/>
-          </a:xfrm>
-          <a:prstGeom prst="rect">
-            <a:avLst/>
-          </a:prstGeom>
-          <a:noFill/>
-        </p:spPr>
-        <p:txBody>
-          <a:bodyPr wrap="square">
-            <a:spAutoFit/>
-          </a:bodyPr>
-          <a:lstStyle/>
-          <a:p>
-            <a:pPr>
-              <a:defRPr sz="1000" b="0" i="0">
-                <a:solidFill>
-                  <a:srgbClr val="6B7778"/>
-                </a:solidFill>
-              </a:defRPr>
-            </a:pPr>
-            <a:r>
-              <a:t>Oevererosietool · update 26-08-2026 · 8</a:t>
+              <a:t>• Bestaande stoplicht-kaart en tijdslider blijven; dit komt er als laag bij</a:t>
+            </a:r>
+          </a:p>
+          <a:p>
+            <a:pPr>
+              <a:spcAft>
+                <a:spcPts val="600"/>
+              </a:spcAft>
+              <a:defRPr sz="1500" b="1">
+                <a:solidFill>
+                  <a:srgbClr val="1F3A3D"/>
+                </a:solidFill>
+              </a:defRPr>
+            </a:pPr>
+            <a:r>
+              <a:t>Status: segmentvoorspellingen staan klaar; koppeling aan het VVR-alarm is de volgende stap</a:t>
             </a:r>
           </a:p>
         </p:txBody>
@@ -6472,7 +6558,7 @@
 </file>
 
 <file path=ppt/slides/slide18.xml><?xml version="1.0" encoding="utf-8"?>
-<p:sld xmlns:a="http://schemas.openxmlformats.org/drawingml/2006/main" xmlns:p="http://schemas.openxmlformats.org/presentationml/2006/main" xmlns:r="http://schemas.openxmlformats.org/officeDocument/2006/relationships">
+<p:sld xmlns:a="http://schemas.openxmlformats.org/drawingml/2006/main" xmlns:r="http://schemas.openxmlformats.org/officeDocument/2006/relationships" xmlns:p="http://schemas.openxmlformats.org/presentationml/2006/main">
   <p:cSld>
     <p:spTree>
       <p:nvGrpSpPr>
@@ -6480,7 +6566,14 @@
         <p:cNvGrpSpPr/>
         <p:nvPr/>
       </p:nvGrpSpPr>
-      <p:grpSpPr/>
+      <p:grpSpPr>
+        <a:xfrm>
+          <a:off x="0" y="0"/>
+          <a:ext cx="0" cy="0"/>
+          <a:chOff x="0" y="0"/>
+          <a:chExt cx="0" cy="0"/>
+        </a:xfrm>
+      </p:grpSpPr>
       <p:sp>
         <p:nvSpPr>
           <p:cNvPr id="2" name="TextBox 1"/>
@@ -6498,20 +6591,20 @@
           <a:noFill/>
         </p:spPr>
         <p:txBody>
-          <a:bodyPr wrap="square">
+          <a:bodyPr wrap="none">
             <a:spAutoFit/>
           </a:bodyPr>
           <a:lstStyle/>
           <a:p>
             <a:pPr>
-              <a:defRPr sz="3000" b="1" i="0">
+              <a:defRPr sz="3000" b="1">
                 <a:solidFill>
                   <a:srgbClr val="2BB5A6"/>
                 </a:solidFill>
               </a:defRPr>
             </a:pPr>
             <a:r>
-              <a:t>As 1 · Wat doet elke regel alleen?</a:t>
+              <a:t>Samenvattend</a:t>
             </a:r>
           </a:p>
         </p:txBody>
@@ -6524,8 +6617,8 @@
         </p:nvSpPr>
         <p:spPr>
           <a:xfrm>
-            <a:off x="548640" y="960120"/>
-            <a:ext cx="10972800" cy="548640"/>
+            <a:off x="548640" y="6400800"/>
+            <a:ext cx="10972800" cy="274320"/>
           </a:xfrm>
           <a:prstGeom prst="rect">
             <a:avLst/>
@@ -6533,58 +6626,34 @@
           <a:noFill/>
         </p:spPr>
         <p:txBody>
-          <a:bodyPr wrap="square">
+          <a:bodyPr wrap="none">
             <a:spAutoFit/>
           </a:bodyPr>
           <a:lstStyle/>
           <a:p>
             <a:pPr>
-              <a:defRPr sz="1700" b="0" i="0">
-                <a:solidFill>
-                  <a:srgbClr val="1F3A3D"/>
-                </a:solidFill>
-              </a:defRPr>
-            </a:pPr>
-            <a:r>
-              <a:t>Elke regel apart op het 19 aug-model · vaste testset · resolutie 1</a:t>
-            </a:r>
-          </a:p>
-        </p:txBody>
-      </p:sp>
-      <p:pic>
-        <p:nvPicPr>
-          <p:cNvPr id="4" name="Picture 3" descr="rule_ablation.png"/>
-          <p:cNvPicPr>
-            <a:picLocks noChangeAspect="1"/>
-          </p:cNvPicPr>
-          <p:nvPr/>
-        </p:nvPicPr>
-        <p:blipFill>
-          <a:blip r:embed="rId2"/>
-          <a:stretch>
-            <a:fillRect/>
-          </a:stretch>
-        </p:blipFill>
-        <p:spPr>
-          <a:xfrm>
-            <a:off x="365760" y="1554480"/>
-            <a:ext cx="7863840" cy="3431494"/>
-          </a:xfrm>
-          <a:prstGeom prst="rect">
-            <a:avLst/>
-          </a:prstGeom>
-        </p:spPr>
-      </p:pic>
-      <p:sp>
-        <p:nvSpPr>
-          <p:cNvPr id="5" name="TextBox 4"/>
+              <a:defRPr sz="1000">
+                <a:solidFill>
+                  <a:srgbClr val="6B7778"/>
+                </a:solidFill>
+              </a:defRPr>
+            </a:pPr>
+            <a:r>
+              <a:t>Oevererosietool · update 26-08-2026 · 18</a:t>
+            </a:r>
+          </a:p>
+        </p:txBody>
+      </p:sp>
+      <p:sp>
+        <p:nvSpPr>
+          <p:cNvPr id="4" name="TextBox 3"/>
           <p:cNvSpPr txBox="1"/>
           <p:nvPr/>
         </p:nvSpPr>
         <p:spPr>
           <a:xfrm>
-            <a:off x="8503920" y="1645920"/>
-            <a:ext cx="3474720" cy="4572000"/>
+            <a:off x="548640" y="1463040"/>
+            <a:ext cx="10972800" cy="4754880"/>
           </a:xfrm>
           <a:prstGeom prst="rect">
             <a:avLst/>
@@ -6599,96 +6668,121 @@
           <a:p>
             <a:pPr>
               <a:spcAft>
-                <a:spcPts val="500"/>
+                <a:spcPts val="800"/>
               </a:spcAft>
-              <a:defRPr sz="1300">
+              <a:defRPr sz="1800" b="1">
                 <a:solidFill>
                   <a:srgbClr val="1F3A3D"/>
                 </a:solidFill>
               </a:defRPr>
             </a:pPr>
             <a:r>
-              <a:t>• Grootste winst: de uitschieter in de tijd (3.99 → 3.03) — één afwijkende meting vervuilde het hele vlak</a:t>
+              <a:t>Model: klaar en eerlijk gevalideerd</a:t>
             </a:r>
           </a:p>
           <a:p>
             <a:pPr>
               <a:spcAft>
-                <a:spcPts val="500"/>
+                <a:spcPts val="800"/>
               </a:spcAft>
-              <a:defRPr sz="1300">
+              <a:defRPr sz="1800" b="0">
                 <a:solidFill>
                   <a:srgbClr val="1F3A3D"/>
                 </a:solidFill>
               </a:defRPr>
             </a:pPr>
             <a:r>
-              <a:t>• Doolhof, fragment en kronkelende lijn elk ≈ −0.3 tot −0.4</a:t>
+              <a:t>• Hybride bron, opschoonregels, historie-features, testset buiten de training</a:t>
             </a:r>
           </a:p>
           <a:p>
             <a:pPr>
               <a:spcAft>
-                <a:spcPts val="500"/>
+                <a:spcPts val="800"/>
               </a:spcAft>
-              <a:defRPr sz="1300">
+              <a:defRPr sz="1800" b="1">
                 <a:solidFill>
                   <a:srgbClr val="1F3A3D"/>
                 </a:solidFill>
               </a:defRPr>
             </a:pPr>
             <a:r>
-              <a:t>• Verkeerde oever en te weinig punten alleen: nauwelijks — ze werken pas in combinatie</a:t>
+              <a:t>Van lijn naar oever</a:t>
             </a:r>
           </a:p>
           <a:p>
             <a:pPr>
               <a:spcAft>
-                <a:spcPts val="500"/>
+                <a:spcPts val="800"/>
               </a:spcAft>
-              <a:defRPr sz="1300">
+              <a:defRPr sz="1800" b="0">
                 <a:solidFill>
                   <a:srgbClr val="1F3A3D"/>
                 </a:solidFill>
               </a:defRPr>
             </a:pPr>
             <a:r>
-              <a:t>• Samen: 2.27 — meer dan de som van de delen, omdat de regels elkaars ruis wegnemen</a:t>
-            </a:r>
-          </a:p>
-        </p:txBody>
-      </p:sp>
-      <p:sp>
-        <p:nvSpPr>
-          <p:cNvPr id="6" name="TextBox 5"/>
-          <p:cNvSpPr txBox="1"/>
-          <p:nvPr/>
-        </p:nvSpPr>
-        <p:spPr>
-          <a:xfrm>
-            <a:off x="548640" y="6400800"/>
-            <a:ext cx="10972800" cy="274320"/>
-          </a:xfrm>
-          <a:prstGeom prst="rect">
-            <a:avLst/>
-          </a:prstGeom>
-          <a:noFill/>
-        </p:spPr>
-        <p:txBody>
-          <a:bodyPr wrap="square">
-            <a:spAutoFit/>
-          </a:bodyPr>
-          <a:lstStyle/>
-          <a:p>
-            <a:pPr>
-              <a:defRPr sz="1000" b="0" i="0">
-                <a:solidFill>
-                  <a:srgbClr val="6B7778"/>
-                </a:solidFill>
-              </a:defRPr>
-            </a:pPr>
-            <a:r>
-              <a:t>Oevererosietool · update 26-08-2026 · 9</a:t>
+              <a:t>• Vijf segmenten per vlak; gemeten én voorspelde oever als lijn; positiefout ≈ 1 m</a:t>
+            </a:r>
+          </a:p>
+          <a:p>
+            <a:pPr>
+              <a:spcAft>
+                <a:spcPts val="800"/>
+              </a:spcAft>
+              <a:defRPr sz="1800" b="1">
+                <a:solidFill>
+                  <a:srgbClr val="1F3A3D"/>
+                </a:solidFill>
+              </a:defRPr>
+            </a:pPr>
+            <a:r>
+              <a:t>Bottleneck: gelabelde input, niet het algoritme</a:t>
+            </a:r>
+          </a:p>
+          <a:p>
+            <a:pPr>
+              <a:spcAft>
+                <a:spcPts val="800"/>
+              </a:spcAft>
+              <a:defRPr sz="1800" b="0">
+                <a:solidFill>
+                  <a:srgbClr val="1F3A3D"/>
+                </a:solidFill>
+              </a:defRPr>
+            </a:pPr>
+            <a:r>
+              <a:t>• Opschonen leverde 12× zoveel als modelleren; de regels raken op — wat overblijft vraagt een oordeel</a:t>
+            </a:r>
+          </a:p>
+          <a:p>
+            <a:pPr>
+              <a:spcAft>
+                <a:spcPts val="800"/>
+              </a:spcAft>
+              <a:defRPr sz="1800" b="1">
+                <a:solidFill>
+                  <a:srgbClr val="1F3A3D"/>
+                </a:solidFill>
+              </a:defRPr>
+            </a:pPr>
+            <a:r>
+              <a:t>Volgende stap</a:t>
+            </a:r>
+          </a:p>
+          <a:p>
+            <a:pPr>
+              <a:spcAft>
+                <a:spcPts val="800"/>
+              </a:spcAft>
+              <a:defRPr sz="1800" b="0">
+                <a:solidFill>
+                  <a:srgbClr val="1F3A3D"/>
+                </a:solidFill>
+              </a:defRPr>
+            </a:pPr>
+            <a:r>
+              <a:t>• Labelronde met SAM- en hoogtemodel-engineers · VVR-alarm op segmentniveau · daarna opnieuw meten</a:t>
             </a:r>
           </a:p>
         </p:txBody>
@@ -9513,7 +9607,7 @@
 </file>
 
 <file path=ppt/slides/slide8.xml><?xml version="1.0" encoding="utf-8"?>
-<p:sld xmlns:a="http://schemas.openxmlformats.org/drawingml/2006/main" xmlns:r="http://schemas.openxmlformats.org/officeDocument/2006/relationships" xmlns:p="http://schemas.openxmlformats.org/presentationml/2006/main">
+<p:sld xmlns:a="http://schemas.openxmlformats.org/drawingml/2006/main" xmlns:p="http://schemas.openxmlformats.org/presentationml/2006/main" xmlns:r="http://schemas.openxmlformats.org/officeDocument/2006/relationships">
   <p:cSld>
     <p:spTree>
       <p:nvGrpSpPr>
@@ -9521,14 +9615,7 @@
         <p:cNvGrpSpPr/>
         <p:nvPr/>
       </p:nvGrpSpPr>
-      <p:grpSpPr>
-        <a:xfrm>
-          <a:off x="0" y="0"/>
-          <a:ext cx="0" cy="0"/>
-          <a:chOff x="0" y="0"/>
-          <a:chExt cx="0" cy="0"/>
-        </a:xfrm>
-      </p:grpSpPr>
+      <p:grpSpPr/>
       <p:sp>
         <p:nvSpPr>
           <p:cNvPr id="2" name="TextBox 1"/>
@@ -9546,20 +9633,20 @@
           <a:noFill/>
         </p:spPr>
         <p:txBody>
-          <a:bodyPr wrap="none">
+          <a:bodyPr wrap="square">
             <a:spAutoFit/>
           </a:bodyPr>
           <a:lstStyle/>
           <a:p>
             <a:pPr>
-              <a:defRPr sz="3000" b="1">
+              <a:defRPr sz="3000" b="1" i="0">
                 <a:solidFill>
                   <a:srgbClr val="2BB5A6"/>
                 </a:solidFill>
               </a:defRPr>
             </a:pPr>
             <a:r>
-              <a:t>As 1 · Opschonen: van 3.99 naar 2.27 op de vaste testset</a:t>
+              <a:t>As 1 · Hoeveel vlakken raakt elke regel?</a:t>
             </a:r>
           </a:p>
         </p:txBody>
@@ -9581,447 +9668,27 @@
           <a:noFill/>
         </p:spPr>
         <p:txBody>
-          <a:bodyPr wrap="none">
-            <a:spAutoFit/>
-          </a:bodyPr>
-          <a:lstStyle/>
-          <a:p>
-            <a:pPr>
-              <a:defRPr sz="1700">
-                <a:solidFill>
-                  <a:srgbClr val="1F3A3D"/>
-                </a:solidFill>
-              </a:defRPr>
-            </a:pPr>
-            <a:r>
-              <a:t>Zeven regels — herstellen in plaats van weggooien</a:t>
-            </a:r>
-          </a:p>
-        </p:txBody>
-      </p:sp>
-      <p:sp>
-        <p:nvSpPr>
-          <p:cNvPr id="4" name="TextBox 3"/>
-          <p:cNvSpPr txBox="1"/>
-          <p:nvPr/>
-        </p:nvSpPr>
-        <p:spPr>
-          <a:xfrm>
-            <a:off x="548640" y="6400800"/>
-            <a:ext cx="10972800" cy="274320"/>
-          </a:xfrm>
-          <a:prstGeom prst="rect">
-            <a:avLst/>
-          </a:prstGeom>
-          <a:noFill/>
-        </p:spPr>
-        <p:txBody>
-          <a:bodyPr wrap="none">
-            <a:spAutoFit/>
-          </a:bodyPr>
-          <a:lstStyle/>
-          <a:p>
-            <a:pPr>
-              <a:defRPr sz="1000">
-                <a:solidFill>
-                  <a:srgbClr val="6B7778"/>
-                </a:solidFill>
-              </a:defRPr>
-            </a:pPr>
-            <a:r>
-              <a:t>Oevererosietool · update 26-08-2026 · 10</a:t>
-            </a:r>
-          </a:p>
-        </p:txBody>
-      </p:sp>
-      <p:sp>
-        <p:nvSpPr>
-          <p:cNvPr id="7" name="TextBox 6"/>
-          <p:cNvSpPr txBox="1"/>
-          <p:nvPr/>
-        </p:nvSpPr>
-        <p:spPr>
-          <a:xfrm>
-            <a:off x="548640" y="4572000"/>
-            <a:ext cx="6949440" cy="1737360"/>
-          </a:xfrm>
-          <a:prstGeom prst="rect">
-            <a:avLst/>
-          </a:prstGeom>
-          <a:noFill/>
-        </p:spPr>
-        <p:txBody>
           <a:bodyPr wrap="square">
             <a:spAutoFit/>
           </a:bodyPr>
           <a:lstStyle/>
           <a:p>
             <a:pPr>
-              <a:spcAft>
-                <a:spcPts val="400"/>
-              </a:spcAft>
-              <a:defRPr sz="1300" b="0">
+              <a:defRPr sz="1700" b="0" i="0">
                 <a:solidFill>
                   <a:srgbClr val="1F3A3D"/>
                 </a:solidFill>
               </a:defRPr>
             </a:pPr>
             <a:r>
-              <a:t>• Kronkelende lijnen, verkeerde oever, doolhoven, fragmenten, te weinig punten, uitschieters t.o.v. de trend</a:t>
-            </a:r>
-          </a:p>
-          <a:p>
-            <a:pPr>
-              <a:spcAft>
-                <a:spcPts val="400"/>
-              </a:spcAft>
-              <a:defRPr sz="1300" b="0">
-                <a:solidFill>
-                  <a:srgbClr val="1F3A3D"/>
-                </a:solidFill>
-              </a:defRPr>
-            </a:pPr>
-            <a:r>
-              <a:t>• Een uitschieter kost één meting, niet het hele vlak: +511 vlakken t.o.v. de oude |v| &gt; 50-filter</a:t>
-            </a:r>
-          </a:p>
-          <a:p>
-            <a:pPr>
-              <a:spcAft>
-                <a:spcPts val="400"/>
-              </a:spcAft>
-              <a:defRPr sz="1300" b="0">
-                <a:solidFill>
-                  <a:srgbClr val="1F3A3D"/>
-                </a:solidFill>
-              </a:defRPr>
-            </a:pPr>
-            <a:r>
-              <a:t>• Elke variant visueel gecontroleerd (50+ varianten, dekking blijft 0.94)</a:t>
-            </a:r>
-          </a:p>
-        </p:txBody>
-      </p:sp>
-      <p:sp>
-        <p:nvSpPr>
-          <p:cNvPr id="9" name="TextBox 8"/>
-          <p:cNvSpPr txBox="1"/>
-          <p:nvPr/>
-        </p:nvSpPr>
-        <p:spPr>
-          <a:xfrm>
-            <a:off x="9418320" y="1554480"/>
-            <a:ext cx="2560320" cy="3200400"/>
-          </a:xfrm>
-          <a:prstGeom prst="rect">
-            <a:avLst/>
-          </a:prstGeom>
-          <a:noFill/>
-        </p:spPr>
-        <p:txBody>
-          <a:bodyPr wrap="square">
-            <a:spAutoFit/>
-          </a:bodyPr>
-          <a:lstStyle/>
-          <a:p>
-            <a:pPr>
-              <a:defRPr sz="1100" b="0" i="1">
-                <a:solidFill>
-                  <a:srgbClr val="6B7778"/>
-                </a:solidFill>
-              </a:defRPr>
-            </a:pPr>
-            <a:r>
-              <a:t>Leeswijzer: 4.12 was de score van het 19 aug-model op zijn eigen willekeurige train/test-splitsing. Voor het experiment is één vaste testset van 1 174 vlakken bevroren zodat 50+ varianten vergelijkbaar zijn; datzelfde model scoort daarop 3.99. Alle stappen hierna zijn op deze set gemeten.</a:t>
+              <a:t>Elke regel apart op de basisdata · een vlak kan in meerdere balken staan</a:t>
             </a:r>
           </a:p>
         </p:txBody>
       </p:sp>
       <p:pic>
         <p:nvPicPr>
-          <p:cNvPr id="10" name="Picture 9" descr="cleaning_ladder.png"/>
-          <p:cNvPicPr>
-            <a:picLocks noChangeAspect="1"/>
-          </p:cNvPicPr>
-          <p:nvPr/>
-        </p:nvPicPr>
-        <p:blipFill>
-          <a:blip r:embed="rId4"/>
-          <a:stretch>
-            <a:fillRect/>
-          </a:stretch>
-        </p:blipFill>
-        <p:spPr>
-          <a:xfrm>
-            <a:off x="548640" y="1463040"/>
-            <a:ext cx="8686800" cy="3628713"/>
-          </a:xfrm>
-          <a:prstGeom prst="rect">
-            <a:avLst/>
-          </a:prstGeom>
-        </p:spPr>
-      </p:pic>
-    </p:spTree>
-  </p:cSld>
-  <p:clrMapOvr>
-    <a:masterClrMapping/>
-  </p:clrMapOvr>
-</p:sld>
-</file>
-
-<file path=ppt/slides/slide9.xml><?xml version="1.0" encoding="utf-8"?>
-<p:sld xmlns:a="http://schemas.openxmlformats.org/drawingml/2006/main" xmlns:r="http://schemas.openxmlformats.org/officeDocument/2006/relationships" xmlns:p="http://schemas.openxmlformats.org/presentationml/2006/main">
-  <p:cSld>
-    <p:spTree>
-      <p:nvGrpSpPr>
-        <p:cNvPr id="1" name=""/>
-        <p:cNvGrpSpPr/>
-        <p:nvPr/>
-      </p:nvGrpSpPr>
-      <p:grpSpPr>
-        <a:xfrm>
-          <a:off x="0" y="0"/>
-          <a:ext cx="0" cy="0"/>
-          <a:chOff x="0" y="0"/>
-          <a:chExt cx="0" cy="0"/>
-        </a:xfrm>
-      </p:grpSpPr>
-      <p:sp>
-        <p:nvSpPr>
-          <p:cNvPr id="2" name="TextBox 1"/>
-          <p:cNvSpPr txBox="1"/>
-          <p:nvPr/>
-        </p:nvSpPr>
-        <p:spPr>
-          <a:xfrm>
-            <a:off x="548640" y="320040"/>
-            <a:ext cx="10972800" cy="731520"/>
-          </a:xfrm>
-          <a:prstGeom prst="rect">
-            <a:avLst/>
-          </a:prstGeom>
-          <a:noFill/>
-        </p:spPr>
-        <p:txBody>
-          <a:bodyPr wrap="none">
-            <a:spAutoFit/>
-          </a:bodyPr>
-          <a:lstStyle/>
-          <a:p>
-            <a:pPr>
-              <a:defRPr sz="3000" b="1">
-                <a:solidFill>
-                  <a:srgbClr val="2BB5A6"/>
-                </a:solidFill>
-              </a:defRPr>
-            </a:pPr>
-            <a:r>
-              <a:t>As 2 · Meerdere t-punten: van 2.27 naar 2.13</a:t>
-            </a:r>
-          </a:p>
-        </p:txBody>
-      </p:sp>
-      <p:sp>
-        <p:nvSpPr>
-          <p:cNvPr id="3" name="TextBox 2"/>
-          <p:cNvSpPr txBox="1"/>
-          <p:nvPr/>
-        </p:nvSpPr>
-        <p:spPr>
-          <a:xfrm>
-            <a:off x="548640" y="960120"/>
-            <a:ext cx="10972800" cy="548640"/>
-          </a:xfrm>
-          <a:prstGeom prst="rect">
-            <a:avLst/>
-          </a:prstGeom>
-          <a:noFill/>
-        </p:spPr>
-        <p:txBody>
-          <a:bodyPr wrap="none">
-            <a:spAutoFit/>
-          </a:bodyPr>
-          <a:lstStyle/>
-          <a:p>
-            <a:pPr>
-              <a:defRPr sz="1700">
-                <a:solidFill>
-                  <a:srgbClr val="1F3A3D"/>
-                </a:solidFill>
-              </a:defRPr>
-            </a:pPr>
-            <a:r>
-              <a:t>Historie-features op resolutie 1 — en de horizon als meetlat voor het alarm</a:t>
-            </a:r>
-          </a:p>
-        </p:txBody>
-      </p:sp>
-      <p:sp>
-        <p:nvSpPr>
-          <p:cNvPr id="4" name="TextBox 3"/>
-          <p:cNvSpPr txBox="1"/>
-          <p:nvPr/>
-        </p:nvSpPr>
-        <p:spPr>
-          <a:xfrm>
-            <a:off x="548640" y="6400800"/>
-            <a:ext cx="10972800" cy="274320"/>
-          </a:xfrm>
-          <a:prstGeom prst="rect">
-            <a:avLst/>
-          </a:prstGeom>
-          <a:noFill/>
-        </p:spPr>
-        <p:txBody>
-          <a:bodyPr wrap="none">
-            <a:spAutoFit/>
-          </a:bodyPr>
-          <a:lstStyle/>
-          <a:p>
-            <a:pPr>
-              <a:defRPr sz="1000">
-                <a:solidFill>
-                  <a:srgbClr val="6B7778"/>
-                </a:solidFill>
-              </a:defRPr>
-            </a:pPr>
-            <a:r>
-              <a:t>Oevererosietool · update 26-08-2026 · 11</a:t>
-            </a:r>
-          </a:p>
-        </p:txBody>
-      </p:sp>
-      <p:sp>
-        <p:nvSpPr>
-          <p:cNvPr id="6" name="TextBox 5"/>
-          <p:cNvSpPr txBox="1"/>
-          <p:nvPr/>
-        </p:nvSpPr>
-        <p:spPr>
-          <a:xfrm>
-            <a:off x="7498079" y="1554480"/>
-            <a:ext cx="4480560" cy="4754880"/>
-          </a:xfrm>
-          <a:prstGeom prst="rect">
-            <a:avLst/>
-          </a:prstGeom>
-          <a:noFill/>
-        </p:spPr>
-        <p:txBody>
-          <a:bodyPr wrap="square">
-            <a:spAutoFit/>
-          </a:bodyPr>
-          <a:lstStyle/>
-          <a:p>
-            <a:pPr>
-              <a:spcAft>
-                <a:spcPts val="400"/>
-              </a:spcAft>
-              <a:defRPr sz="1300" b="1">
-                <a:solidFill>
-                  <a:srgbClr val="1F3A3D"/>
-                </a:solidFill>
-              </a:defRPr>
-            </a:pPr>
-            <a:r>
-              <a:t>Features uit de hele meetreeks</a:t>
-            </a:r>
-          </a:p>
-          <a:p>
-            <a:pPr>
-              <a:spcAft>
-                <a:spcPts val="400"/>
-              </a:spcAft>
-              <a:defRPr sz="1300" b="0">
-                <a:solidFill>
-                  <a:srgbClr val="1F3A3D"/>
-                </a:solidFill>
-              </a:defRPr>
-            </a:pPr>
-            <a:r>
-              <a:t>• Trend (Theil–Sen), spreiding om de trend, versnelling, terugkeer naar gemiddelde, recente helling</a:t>
-            </a:r>
-          </a:p>
-          <a:p>
-            <a:pPr>
-              <a:spcAft>
-                <a:spcPts val="400"/>
-              </a:spcAft>
-              <a:defRPr sz="1300" b="1">
-                <a:solidFill>
-                  <a:srgbClr val="1F3A3D"/>
-                </a:solidFill>
-              </a:defRPr>
-            </a:pPr>
-            <a:r>
-              <a:t>Wat níet werkte</a:t>
-            </a:r>
-          </a:p>
-          <a:p>
-            <a:pPr>
-              <a:spcAft>
-                <a:spcPts val="400"/>
-              </a:spcAft>
-              <a:defRPr sz="1300" b="0">
-                <a:solidFill>
-                  <a:srgbClr val="1F3A3D"/>
-                </a:solidFill>
-              </a:defRPr>
-            </a:pPr>
-            <a:r>
-              <a:t>• Trainen op losse jaar-op-jaar stappen (sub-jaar ruis), huber-loss (beter gemiddeld, slechter op de staart), debiet</a:t>
-            </a:r>
-          </a:p>
-          <a:p>
-            <a:pPr>
-              <a:spcAft>
-                <a:spcPts val="400"/>
-              </a:spcAft>
-              <a:defRPr sz="1300" b="1">
-                <a:solidFill>
-                  <a:srgbClr val="1F3A3D"/>
-                </a:solidFill>
-              </a:defRPr>
-            </a:pPr>
-            <a:r>
-              <a:t>Horizon ≥ 2 jaar — voor het alarm</a:t>
-            </a:r>
-          </a:p>
-          <a:p>
-            <a:pPr>
-              <a:spcAft>
-                <a:spcPts val="400"/>
-              </a:spcAft>
-              <a:defRPr sz="1300" b="0">
-                <a:solidFill>
-                  <a:srgbClr val="1F3A3D"/>
-                </a:solidFill>
-              </a:defRPr>
-            </a:pPr>
-            <a:r>
-              <a:t>• Hoogtemodel-paren zijn altijd 3–5 jaar uit elkaar; SAM-paren 1 jaar → ruis</a:t>
-            </a:r>
-          </a:p>
-          <a:p>
-            <a:pPr>
-              <a:spcAft>
-                <a:spcPts val="400"/>
-              </a:spcAft>
-              <a:defRPr sz="1300" b="0">
-                <a:solidFill>
-                  <a:srgbClr val="1F3A3D"/>
-                </a:solidFill>
-              </a:defRPr>
-            </a:pPr>
-            <a:r>
-              <a:t>• Zelfde doel (m/jr), zelfde fout, alleen paren ≥ 2 jaar: 1 vlak met 6 metingen = 10 leervoorbeelden</a:t>
-            </a:r>
-          </a:p>
-        </p:txBody>
-      </p:sp>
-      <p:pic>
-        <p:nvPicPr>
-          <p:cNvPr id="7" name="Picture 6" descr="image.png"/>
+          <p:cNvPr id="4" name="Picture 3" descr="rule_touched.png"/>
           <p:cNvPicPr>
             <a:picLocks noChangeAspect="1"/>
           </p:cNvPicPr>
@@ -10035,14 +9702,362 @@
         </p:blipFill>
         <p:spPr>
           <a:xfrm>
-            <a:off x="548640" y="1463040"/>
-            <a:ext cx="6766560" cy="2826577"/>
+            <a:off x="365760" y="1554480"/>
+            <a:ext cx="7863840" cy="3431494"/>
           </a:xfrm>
           <a:prstGeom prst="rect">
             <a:avLst/>
           </a:prstGeom>
         </p:spPr>
       </p:pic>
+      <p:sp>
+        <p:nvSpPr>
+          <p:cNvPr id="5" name="TextBox 4"/>
+          <p:cNvSpPr txBox="1"/>
+          <p:nvPr/>
+        </p:nvSpPr>
+        <p:spPr>
+          <a:xfrm>
+            <a:off x="8503920" y="1645920"/>
+            <a:ext cx="3474720" cy="4572000"/>
+          </a:xfrm>
+          <a:prstGeom prst="rect">
+            <a:avLst/>
+          </a:prstGeom>
+          <a:noFill/>
+        </p:spPr>
+        <p:txBody>
+          <a:bodyPr wrap="square">
+            <a:spAutoFit/>
+          </a:bodyPr>
+          <a:lstStyle/>
+          <a:p>
+            <a:pPr>
+              <a:spcAft>
+                <a:spcPts val="500"/>
+              </a:spcAft>
+              <a:defRPr sz="1300">
+                <a:solidFill>
+                  <a:srgbClr val="1F3A3D"/>
+                </a:solidFill>
+              </a:defRPr>
+            </a:pPr>
+            <a:r>
+              <a:t>• 5 165 van de 11 517 vlakken worden door ≥ 1 regel geraakt; 284 verdwijnen helemaal</a:t>
+            </a:r>
+          </a:p>
+          <a:p>
+            <a:pPr>
+              <a:spcAft>
+                <a:spcPts val="500"/>
+              </a:spcAft>
+              <a:defRPr sz="1300">
+                <a:solidFill>
+                  <a:srgbClr val="1F3A3D"/>
+                </a:solidFill>
+              </a:defRPr>
+            </a:pPr>
+            <a:r>
+              <a:t>• Kronkelende lijnen, doolhoven en uitschieters in de tijd zijn púúr SAM-verschijnselen</a:t>
+            </a:r>
+          </a:p>
+          <a:p>
+            <a:pPr>
+              <a:spcAft>
+                <a:spcPts val="500"/>
+              </a:spcAft>
+              <a:defRPr sz="1300">
+                <a:solidFill>
+                  <a:srgbClr val="1F3A3D"/>
+                </a:solidFill>
+              </a:defRPr>
+            </a:pPr>
+            <a:r>
+              <a:t>• Hoogtemodel-vlakken worden vrijwel alleen door het kribbenmasker en fragmenten geraakt (429 van 2 033)</a:t>
+            </a:r>
+          </a:p>
+          <a:p>
+            <a:pPr>
+              <a:spcAft>
+                <a:spcPts val="500"/>
+              </a:spcAft>
+              <a:defRPr sz="1300">
+                <a:solidFill>
+                  <a:srgbClr val="1F3A3D"/>
+                </a:solidFill>
+              </a:defRPr>
+            </a:pPr>
+            <a:r>
+              <a:t>• 'Te weinig punten' raakt op zichzelf niets — het bijt pas nadat andere regels een meting uitdunnen</a:t>
+            </a:r>
+          </a:p>
+        </p:txBody>
+      </p:sp>
+      <p:sp>
+        <p:nvSpPr>
+          <p:cNvPr id="6" name="TextBox 5"/>
+          <p:cNvSpPr txBox="1"/>
+          <p:nvPr/>
+        </p:nvSpPr>
+        <p:spPr>
+          <a:xfrm>
+            <a:off x="548640" y="6400800"/>
+            <a:ext cx="10972800" cy="274320"/>
+          </a:xfrm>
+          <a:prstGeom prst="rect">
+            <a:avLst/>
+          </a:prstGeom>
+          <a:noFill/>
+        </p:spPr>
+        <p:txBody>
+          <a:bodyPr wrap="square">
+            <a:spAutoFit/>
+          </a:bodyPr>
+          <a:lstStyle/>
+          <a:p>
+            <a:pPr>
+              <a:defRPr sz="1000" b="0" i="0">
+                <a:solidFill>
+                  <a:srgbClr val="6B7778"/>
+                </a:solidFill>
+              </a:defRPr>
+            </a:pPr>
+            <a:r>
+              <a:t>Oevererosietool · update 26-08-2026 · 8</a:t>
+            </a:r>
+          </a:p>
+        </p:txBody>
+      </p:sp>
+    </p:spTree>
+  </p:cSld>
+  <p:clrMapOvr>
+    <a:masterClrMapping/>
+  </p:clrMapOvr>
+</p:sld>
+</file>
+
+<file path=ppt/slides/slide9.xml><?xml version="1.0" encoding="utf-8"?>
+<p:sld xmlns:a="http://schemas.openxmlformats.org/drawingml/2006/main" xmlns:p="http://schemas.openxmlformats.org/presentationml/2006/main" xmlns:r="http://schemas.openxmlformats.org/officeDocument/2006/relationships">
+  <p:cSld>
+    <p:spTree>
+      <p:nvGrpSpPr>
+        <p:cNvPr id="1" name=""/>
+        <p:cNvGrpSpPr/>
+        <p:nvPr/>
+      </p:nvGrpSpPr>
+      <p:grpSpPr/>
+      <p:sp>
+        <p:nvSpPr>
+          <p:cNvPr id="2" name="TextBox 1"/>
+          <p:cNvSpPr txBox="1"/>
+          <p:nvPr/>
+        </p:nvSpPr>
+        <p:spPr>
+          <a:xfrm>
+            <a:off x="548640" y="320040"/>
+            <a:ext cx="10972800" cy="731520"/>
+          </a:xfrm>
+          <a:prstGeom prst="rect">
+            <a:avLst/>
+          </a:prstGeom>
+          <a:noFill/>
+        </p:spPr>
+        <p:txBody>
+          <a:bodyPr wrap="square">
+            <a:spAutoFit/>
+          </a:bodyPr>
+          <a:lstStyle/>
+          <a:p>
+            <a:pPr>
+              <a:defRPr sz="3000" b="1" i="0">
+                <a:solidFill>
+                  <a:srgbClr val="2BB5A6"/>
+                </a:solidFill>
+              </a:defRPr>
+            </a:pPr>
+            <a:r>
+              <a:t>As 1 · Wat doet elke regel alleen?</a:t>
+            </a:r>
+          </a:p>
+        </p:txBody>
+      </p:sp>
+      <p:sp>
+        <p:nvSpPr>
+          <p:cNvPr id="3" name="TextBox 2"/>
+          <p:cNvSpPr txBox="1"/>
+          <p:nvPr/>
+        </p:nvSpPr>
+        <p:spPr>
+          <a:xfrm>
+            <a:off x="548640" y="960120"/>
+            <a:ext cx="10972800" cy="548640"/>
+          </a:xfrm>
+          <a:prstGeom prst="rect">
+            <a:avLst/>
+          </a:prstGeom>
+          <a:noFill/>
+        </p:spPr>
+        <p:txBody>
+          <a:bodyPr wrap="square">
+            <a:spAutoFit/>
+          </a:bodyPr>
+          <a:lstStyle/>
+          <a:p>
+            <a:pPr>
+              <a:defRPr sz="1700" b="0" i="0">
+                <a:solidFill>
+                  <a:srgbClr val="1F3A3D"/>
+                </a:solidFill>
+              </a:defRPr>
+            </a:pPr>
+            <a:r>
+              <a:t>Elke regel apart op het 19 aug-model · vaste testset · resolutie 1</a:t>
+            </a:r>
+          </a:p>
+        </p:txBody>
+      </p:sp>
+      <p:pic>
+        <p:nvPicPr>
+          <p:cNvPr id="4" name="Picture 3" descr="rule_ablation.png"/>
+          <p:cNvPicPr>
+            <a:picLocks noChangeAspect="1"/>
+          </p:cNvPicPr>
+          <p:nvPr/>
+        </p:nvPicPr>
+        <p:blipFill>
+          <a:blip r:embed="rId2"/>
+          <a:stretch>
+            <a:fillRect/>
+          </a:stretch>
+        </p:blipFill>
+        <p:spPr>
+          <a:xfrm>
+            <a:off x="365760" y="1554480"/>
+            <a:ext cx="7863840" cy="3431494"/>
+          </a:xfrm>
+          <a:prstGeom prst="rect">
+            <a:avLst/>
+          </a:prstGeom>
+        </p:spPr>
+      </p:pic>
+      <p:sp>
+        <p:nvSpPr>
+          <p:cNvPr id="5" name="TextBox 4"/>
+          <p:cNvSpPr txBox="1"/>
+          <p:nvPr/>
+        </p:nvSpPr>
+        <p:spPr>
+          <a:xfrm>
+            <a:off x="8503920" y="1645920"/>
+            <a:ext cx="3474720" cy="4572000"/>
+          </a:xfrm>
+          <a:prstGeom prst="rect">
+            <a:avLst/>
+          </a:prstGeom>
+          <a:noFill/>
+        </p:spPr>
+        <p:txBody>
+          <a:bodyPr wrap="square">
+            <a:spAutoFit/>
+          </a:bodyPr>
+          <a:lstStyle/>
+          <a:p>
+            <a:pPr>
+              <a:spcAft>
+                <a:spcPts val="500"/>
+              </a:spcAft>
+              <a:defRPr sz="1300">
+                <a:solidFill>
+                  <a:srgbClr val="1F3A3D"/>
+                </a:solidFill>
+              </a:defRPr>
+            </a:pPr>
+            <a:r>
+              <a:t>• Grootste winst: de uitschieter in de tijd (3.99 → 3.03) — één afwijkende meting vervuilde het hele vlak</a:t>
+            </a:r>
+          </a:p>
+          <a:p>
+            <a:pPr>
+              <a:spcAft>
+                <a:spcPts val="500"/>
+              </a:spcAft>
+              <a:defRPr sz="1300">
+                <a:solidFill>
+                  <a:srgbClr val="1F3A3D"/>
+                </a:solidFill>
+              </a:defRPr>
+            </a:pPr>
+            <a:r>
+              <a:t>• Doolhof, fragment en kronkelende lijn elk ≈ −0.3 tot −0.4</a:t>
+            </a:r>
+          </a:p>
+          <a:p>
+            <a:pPr>
+              <a:spcAft>
+                <a:spcPts val="500"/>
+              </a:spcAft>
+              <a:defRPr sz="1300">
+                <a:solidFill>
+                  <a:srgbClr val="1F3A3D"/>
+                </a:solidFill>
+              </a:defRPr>
+            </a:pPr>
+            <a:r>
+              <a:t>• Verkeerde oever en te weinig punten alleen: nauwelijks — ze werken pas in combinatie</a:t>
+            </a:r>
+          </a:p>
+          <a:p>
+            <a:pPr>
+              <a:spcAft>
+                <a:spcPts val="500"/>
+              </a:spcAft>
+              <a:defRPr sz="1300">
+                <a:solidFill>
+                  <a:srgbClr val="1F3A3D"/>
+                </a:solidFill>
+              </a:defRPr>
+            </a:pPr>
+            <a:r>
+              <a:t>• Samen: 2.27 — meer dan de som van de delen, omdat de regels elkaars ruis wegnemen</a:t>
+            </a:r>
+          </a:p>
+        </p:txBody>
+      </p:sp>
+      <p:sp>
+        <p:nvSpPr>
+          <p:cNvPr id="6" name="TextBox 5"/>
+          <p:cNvSpPr txBox="1"/>
+          <p:nvPr/>
+        </p:nvSpPr>
+        <p:spPr>
+          <a:xfrm>
+            <a:off x="548640" y="6400800"/>
+            <a:ext cx="10972800" cy="274320"/>
+          </a:xfrm>
+          <a:prstGeom prst="rect">
+            <a:avLst/>
+          </a:prstGeom>
+          <a:noFill/>
+        </p:spPr>
+        <p:txBody>
+          <a:bodyPr wrap="square">
+            <a:spAutoFit/>
+          </a:bodyPr>
+          <a:lstStyle/>
+          <a:p>
+            <a:pPr>
+              <a:defRPr sz="1000" b="0" i="0">
+                <a:solidFill>
+                  <a:srgbClr val="6B7778"/>
+                </a:solidFill>
+              </a:defRPr>
+            </a:pPr>
+            <a:r>
+              <a:t>Oevererosietool · update 26-08-2026 · 9</a:t>
+            </a:r>
+          </a:p>
+        </p:txBody>
+      </p:sp>
     </p:spTree>
   </p:cSld>
   <p:clrMapOvr>

</xml_diff>

<commit_message>
docs(presentation): As 3 on the horizon ruler (R sweep, R=10 pick), matrix with horizon steps, eindrun scorebord; ledger hz-R*
</commit_message>
<xml_diff>
--- a/docs/presentations/20260826_update_v2.pptx
+++ b/docs/presentations/20260826_update_v2.pptx
@@ -4524,7 +4524,7 @@
               </a:defRPr>
             </a:pPr>
             <a:r>
-              <a:t>• Eén getal zegt −9.7 m/jr; de vijf segmenten lopen van −17.1 tot +1.4</a:t>
+              <a:t>• Eén getal zegt −9.7 m/jr; de vijf segmenten lopen van −17.1 tot +1.4 (voorbeeld op R = 5; gekozen resolutie R = 10)</a:t>
             </a:r>
           </a:p>
           <a:p>
@@ -4664,7 +4664,7 @@
               </a:defRPr>
             </a:pPr>
             <a:r>
-              <a:t>Zelfde vlak, R = 1 … 100 · en de fout op de vaste testset per R</a:t>
+              <a:t>Zelfde vlak, R = 1 … 100 · en de fout per segment op de As 2-meetlat (paren ≥ 2 jaar), per R</a:t>
             </a:r>
           </a:p>
         </p:txBody>
@@ -4752,7 +4752,7 @@
           <a:p>
             <a:pPr>
               <a:spcAft>
-                <a:spcPts val="300"/>
+                <a:spcPts val="400"/>
               </a:spcAft>
               <a:defRPr sz="1200" b="0">
                 <a:solidFill>
@@ -4762,6 +4762,36 @@
             </a:pPr>
             <a:r>
               <a:t>• De segment-representatie (bruin) volgt de gemeten oever vanaf R ≈ 5–10; bij R = 50–100 raken segmenten leeg (rood)</a:t>
+            </a:r>
+          </a:p>
+          <a:p>
+            <a:pPr>
+              <a:spcAft>
+                <a:spcPts val="400"/>
+              </a:spcAft>
+              <a:defRPr sz="1200" b="0">
+                <a:solidFill>
+                  <a:srgbClr val="1F3A3D"/>
+                </a:solidFill>
+              </a:defRPr>
+            </a:pPr>
+            <a:r>
+              <a:t>• Fout per segment daalt van 1.37 (R = 1) naar 1.03 (R = 10) en 0.85 (R = 20) — maar de naïeve fout zakt mee: de skill piekt bij R = 10 (+30 %) en bij R = 20 heeft 31 % van de segment-datums geen meting</a:t>
+            </a:r>
+          </a:p>
+          <a:p>
+            <a:pPr>
+              <a:spcAft>
+                <a:spcPts val="400"/>
+              </a:spcAft>
+              <a:defRPr sz="1200" b="0">
+                <a:solidFill>
+                  <a:srgbClr val="1F3A3D"/>
+                </a:solidFill>
+              </a:defRPr>
+            </a:pPr>
+            <a:r>
+              <a:t>• Keuze: R = 10 (≈ 10 m). Fijner is alleen een gladdere meetlat, geen beter model — tot de lijnbemonstering (60 punten per lijn) verdicht wordt</a:t>
             </a:r>
           </a:p>
           <a:p>
@@ -4775,52 +4805,19 @@
                 </a:solidFill>
               </a:defRPr>
             </a:pPr>
-            <a:r>
-              <a:t>• Fout per segment daalt van 2.25 (R = 1) naar 1.88 (R = 5) en 1.61 (R = 20) — kleiner wordt nauwkeuriger, niet ruiziger</a:t>
-            </a:r>
-          </a:p>
-          <a:p>
-            <a:pPr>
-              <a:spcAft>
-                <a:spcPts val="300"/>
-              </a:spcAft>
-              <a:defRPr sz="1200" b="0">
-                <a:solidFill>
-                  <a:srgbClr val="1F3A3D"/>
-                </a:solidFill>
-              </a:defRPr>
-            </a:pPr>
-            <a:r>
-              <a:t>• Terug-samengevoegd per vlak blijft de fout ≈ 2.1–2.2: het vlak-getal zelf heeft een vloer (0.5–1.1 m/jr representatiefout)</a:t>
-            </a:r>
-          </a:p>
-          <a:p>
-            <a:pPr>
-              <a:spcAft>
-                <a:spcPts val="300"/>
-              </a:spcAft>
-              <a:defRPr sz="1200" b="0">
-                <a:solidFill>
-                  <a:srgbClr val="1F3A3D"/>
-                </a:solidFill>
-              </a:defRPr>
-            </a:pPr>
-            <a:r>
-              <a:t>• Grens ligt bij de lijnbemonstering (60 punten per lijn), niet bij het model · praktisch: R = 5–10 (≈ 10–20 m)</a:t>
-            </a:r>
           </a:p>
         </p:txBody>
       </p:sp>
       <p:pic>
         <p:nvPicPr>
-          <p:cNvPr id="8" name="Picture 7" descr="image.png"/>
+          <p:cNvPr id="8" name="Picture 7" descr="horizon_sweep.png"/>
           <p:cNvPicPr>
             <a:picLocks noChangeAspect="1"/>
           </p:cNvPicPr>
           <p:nvPr/>
         </p:nvPicPr>
         <p:blipFill>
-          <a:blip r:embed="rId3"/>
+          <a:blip r:embed="rId4"/>
           <a:stretch>
             <a:fillRect/>
           </a:stretch>
@@ -4828,7 +4825,7 @@
         <p:spPr>
           <a:xfrm>
             <a:off x="6400800" y="1371600"/>
-            <a:ext cx="5577840" cy="2330016"/>
+            <a:ext cx="5577840" cy="2433967"/>
           </a:xfrm>
           <a:prstGeom prst="rect">
             <a:avLst/>
@@ -4998,7 +4995,7 @@
               </a:defRPr>
             </a:pPr>
             <a:r>
-              <a:t>• Opschonen: −1.72 m/jr (−43 %) · historie-features: −0.14 · structurenlaag: ±0 (dekking/juistheid) · resolutie: andere eenheid, −0.25 per segment</a:t>
+              <a:t>• Opschonen: −1.72 m/jr (−43 %) · structurenlaag: ±0 (juistheid/dekking) · historie-features: −0.14 · paren ≥ 2 jaar: andere meetlat, skill +20 → +23 % · segmenten R = 10: skill +30 %, positiefout 1.05 m</a:t>
             </a:r>
           </a:p>
           <a:p>
@@ -5013,21 +5010,21 @@
               </a:defRPr>
             </a:pPr>
             <a:r>
-              <a:t>Het model was nooit de bottleneck — de labels waren het. En de regels raken op: wat overblijft, kan alleen een mens zien.</a:t>
+              <a:t>Het model was nooit de bottleneck — de labels waren het. De regels raken op: wat overblijft, kan alleen een mens zien.</a:t>
             </a:r>
           </a:p>
         </p:txBody>
       </p:sp>
       <p:pic>
         <p:nvPicPr>
-          <p:cNvPr id="7" name="Picture 6" descr="image.png"/>
+          <p:cNvPr id="7" name="Picture 6" descr="matrix.png"/>
           <p:cNvPicPr>
             <a:picLocks noChangeAspect="1"/>
           </p:cNvPicPr>
           <p:nvPr/>
         </p:nvPicPr>
         <p:blipFill>
-          <a:blip r:embed="rId3"/>
+          <a:blip r:embed="rId4"/>
           <a:stretch>
             <a:fillRect/>
           </a:stretch>
@@ -5097,7 +5094,7 @@
               </a:defRPr>
             </a:pPr>
             <a:r>
-              <a:t>Scorebord — eerlijk gemeten</a:t>
+              <a:t>Eindrun — eerlijk gemeten, nieuwe splitsing</a:t>
             </a:r>
           </a:p>
         </p:txBody>
@@ -5132,7 +5129,7 @@
               </a:defRPr>
             </a:pPr>
             <a:r>
-              <a:t>Alleen binnen een rij vergelijken: elke rij is een andere meetlat</a:t>
+              <a:t>Volledige pipeline op een nieuwe 80/20-splitsing, testset buiten de training · alleen binnen een rij vergelijken</a:t>
             </a:r>
           </a:p>
         </p:txBody>
@@ -5536,7 +5533,7 @@
                         </a:defRPr>
                       </a:pPr>
                       <a:r>
-                        <a:t>nu · zelfde 1-jr meetlat · eerlijke validatie</a:t>
+                        <a:t>nu · zelfde 1-jr meetlat · eindrun, eerlijk</a:t>
                       </a:r>
                     </a:p>
                   </a:txBody>
@@ -5635,7 +5632,7 @@
                         </a:defRPr>
                       </a:pPr>
                       <a:r>
-                        <a:t>nu · segment · ≥ 2 jr · eerlijke validatie</a:t>
+                        <a:t>nu · segment R = 5 · paren ≥ 2 jr · eindrun, eerlijk</a:t>
                       </a:r>
                     </a:p>
                   </a:txBody>
@@ -5748,54 +5745,54 @@
           <a:p>
             <a:pPr>
               <a:spcAft>
-                <a:spcPts val="600"/>
+                <a:spcPts val="400"/>
               </a:spcAft>
-              <a:defRPr sz="1400" b="0">
+              <a:defRPr sz="1300" b="0">
                 <a:solidFill>
                   <a:srgbClr val="1F3A3D"/>
                 </a:solidFill>
               </a:defRPr>
             </a:pPr>
             <a:r>
-              <a:t>• Eerlijk: de testset speelt geen rol meer bij het trainen (in maart en augustus wél) — strenger, en tóch lager</a:t>
+              <a:t>• Slide 14 = het experiment op de vaste testset (met test-set early stopping); dit = de volledige pipeline op een nieuwe splitsing zónder de testset in de training — strenger, en daarom hoger: 2.13 → 2.47 en 1.07 → 1.23 (R = 5; R = 10 volgt in de volgende run)</a:t>
             </a:r>
           </a:p>
           <a:p>
             <a:pPr>
               <a:spcAft>
-                <a:spcPts val="600"/>
+                <a:spcPts val="400"/>
               </a:spcAft>
-              <a:defRPr sz="1400" b="0">
+              <a:defRPr sz="1300" b="0">
                 <a:solidFill>
                   <a:srgbClr val="1F3A3D"/>
                 </a:solidFill>
               </a:defRPr>
             </a:pPr>
             <a:r>
-              <a:t>• Vlakken met voorspelling 8 006 → 10 721</a:t>
+              <a:t>• Vlakken met voorspelling 8 006 → 10 721</a:t>
             </a:r>
           </a:p>
           <a:p>
             <a:pPr>
               <a:spcAft>
-                <a:spcPts val="600"/>
+                <a:spcPts val="400"/>
               </a:spcAft>
-              <a:defRPr sz="1400" b="0">
+              <a:defRPr sz="1300" b="0">
                 <a:solidFill>
                   <a:srgbClr val="1F3A3D"/>
                 </a:solidFill>
               </a:defRPr>
             </a:pPr>
             <a:r>
-              <a:t>• 1.23 is m/jr op een gladdere meetlat — lees het als '31 % beter dan niets doen', niet als '2× beter dan 2.47'</a:t>
+              <a:t>• 1.23 is m/jr op de ≥ 2-jaar-meetlat — lees het als '31 % beter dan niets doen', niet als '2× beter dan 2.47'</a:t>
             </a:r>
           </a:p>
           <a:p>
             <a:pPr>
               <a:spcAft>
-                <a:spcPts val="600"/>
+                <a:spcPts val="400"/>
               </a:spcAft>
-              <a:defRPr sz="1400" b="0">
+              <a:defRPr sz="1300" b="0">
                 <a:solidFill>
                   <a:srgbClr val="1F3A3D"/>
                 </a:solidFill>
@@ -6484,7 +6481,7 @@
               </a:defRPr>
             </a:pPr>
             <a:r>
-              <a:t>• Per segment een verwachte positie ≥ 2 jaar vooruit (48 000 segmenten, 10 000 vlakken)</a:t>
+              <a:t>• Per segment (≈ 10–20 m) een verwachte positie ≥ 2 jaar vooruit — mediane positiefout ≈ 1 m</a:t>
             </a:r>
           </a:p>
           <a:p>
@@ -6722,7 +6719,7 @@
               </a:defRPr>
             </a:pPr>
             <a:r>
-              <a:t>• Vijf segmenten per vlak; gemeten én voorspelde oever als lijn; positiefout ≈ 1 m</a:t>
+              <a:t>• Tien segmenten per vlak (≈ 10 m); gemeten én voorspelde oever als lijn; positiefout ≈ 1 m op ≥ 2 jaar</a:t>
             </a:r>
           </a:p>
           <a:p>

</xml_diff>

<commit_message>
docs(presentation): slide 6 picture fits
</commit_message>
<xml_diff>
--- a/docs/presentations/20260826_update_v2.pptx
+++ b/docs/presentations/20260826_update_v2.pptx
@@ -9245,8 +9245,8 @@
         </p:blipFill>
         <p:spPr>
           <a:xfrm>
-            <a:off x="289560" y="1993900"/>
-            <a:ext cx="11612880" cy="5222661"/>
+            <a:off x="1826239" y="1554480"/>
+            <a:ext cx="8539522" cy="3840480"/>
           </a:xfrm>
           <a:prstGeom prst="rect">
             <a:avLst/>

</xml_diff>

<commit_message>
docs(presentation): merge As 1 ablation + ladder; structures mask bar (r0-newstructures)
</commit_message>
<xml_diff>
--- a/docs/presentations/20260826_update_v2.pptx
+++ b/docs/presentations/20260826_update_v2.pptx
@@ -5,27 +5,26 @@
     <p:sldMasterId id="2147483648" r:id="rId1"/>
   </p:sldMasterIdLst>
   <p:notesMasterIdLst>
-    <p:notesMasterId r:id="rId18"/>
+    <p:notesMasterId r:id="rId20"/>
   </p:notesMasterIdLst>
   <p:sldIdLst>
     <p:sldId id="256" r:id="rId2"/>
     <p:sldId id="257" r:id="rId3"/>
-    <p:sldId id="258" r:id="rId4"/>
-    <p:sldId id="270" r:id="rId5"/>
-    <p:sldId id="259" r:id="rId6"/>
+    <p:sldId id="270" r:id="rId4"/>
+    <p:sldId id="259" r:id="rId5"/>
+    <p:sldId id="258" r:id="rId6"/>
     <p:sldId id="271" r:id="rId7"/>
-    <p:sldId id="261" r:id="rId9"/>
-    <p:sldId id="272" r:id="rId23"/>
-    <p:sldId id="273" r:id="rId24"/>
-    <p:sldId id="260" r:id="rId8"/>
-    <p:sldId id="262" r:id="rId10"/>
-    <p:sldId id="263" r:id="rId11"/>
-    <p:sldId id="264" r:id="rId12"/>
-    <p:sldId id="265" r:id="rId13"/>
-    <p:sldId id="266" r:id="rId14"/>
-    <p:sldId id="267" r:id="rId15"/>
-    <p:sldId id="268" r:id="rId16"/>
-    <p:sldId id="269" r:id="rId17"/>
+    <p:sldId id="261" r:id="rId8"/>
+    <p:sldId id="272" r:id="rId9"/>
+    <p:sldId id="273" r:id="rId10"/>
+    <p:sldId id="262" r:id="rId12"/>
+    <p:sldId id="263" r:id="rId13"/>
+    <p:sldId id="264" r:id="rId14"/>
+    <p:sldId id="265" r:id="rId15"/>
+    <p:sldId id="266" r:id="rId16"/>
+    <p:sldId id="267" r:id="rId17"/>
+    <p:sldId id="268" r:id="rId18"/>
+    <p:sldId id="269" r:id="rId19"/>
   </p:sldIdLst>
   <p:sldSz cx="12192000" cy="6858000"/>
   <p:notesSz cx="6858000" cy="9144000"/>
@@ -3652,7 +3651,7 @@
         <p:spPr>
           <a:xfrm>
             <a:off x="822960" y="2103120"/>
-            <a:ext cx="10515600" cy="2743200"/>
+            <a:ext cx="8246873" cy="1569660"/>
           </a:xfrm>
           <a:prstGeom prst="rect">
             <a:avLst/>
@@ -3673,8 +3672,34 @@
               </a:defRPr>
             </a:pPr>
             <a:r>
-              <a:t>Oevererosietool — van lijn naar oever</a:t>
-            </a:r>
+              <a:rPr dirty="0" err="1"/>
+              <a:t>Oevererosietool</a:t>
+            </a:r>
+            <a:r>
+              <a:rPr dirty="0"/>
+              <a:t> — van </a:t>
+            </a:r>
+            <a:r>
+              <a:rPr dirty="0" err="1"/>
+              <a:t>lijn</a:t>
+            </a:r>
+            <a:r>
+              <a:rPr dirty="0"/>
+              <a:t> </a:t>
+            </a:r>
+            <a:r>
+              <a:rPr dirty="0" err="1"/>
+              <a:t>naar</a:t>
+            </a:r>
+            <a:r>
+              <a:rPr dirty="0"/>
+              <a:t> </a:t>
+            </a:r>
+            <a:r>
+              <a:rPr dirty="0" err="1"/>
+              <a:t>oever</a:t>
+            </a:r>
+            <a:endParaRPr dirty="0"/>
           </a:p>
           <a:p>
             <a:pPr>
@@ -3688,7 +3713,20 @@
               </a:defRPr>
             </a:pPr>
             <a:r>
-              <a:t>Voortgang voorspellend model · wat we vonden · wat we nodig hebben</a:t>
+              <a:rPr dirty="0" err="1"/>
+              <a:t>Voortgang</a:t>
+            </a:r>
+            <a:r>
+              <a:rPr dirty="0"/>
+              <a:t> </a:t>
+            </a:r>
+            <a:r>
+              <a:rPr dirty="0" err="1"/>
+              <a:t>voorspellend</a:t>
+            </a:r>
+            <a:r>
+              <a:rPr dirty="0"/>
+              <a:t> model</a:t>
             </a:r>
           </a:p>
           <a:p>
@@ -3703,268 +3741,20 @@
               </a:defRPr>
             </a:pPr>
             <a:r>
-              <a:t>Update 26 augustus 2026</a:t>
-            </a:r>
-          </a:p>
-        </p:txBody>
-      </p:sp>
-    </p:spTree>
-  </p:cSld>
-  <p:clrMapOvr>
-    <a:masterClrMapping/>
-  </p:clrMapOvr>
-</p:sld>
-</file>
-
-<file path=ppt/slides/slide10.xml><?xml version="1.0" encoding="utf-8"?>
-<p:sld xmlns:a="http://schemas.openxmlformats.org/drawingml/2006/main" xmlns:r="http://schemas.openxmlformats.org/officeDocument/2006/relationships" xmlns:p="http://schemas.openxmlformats.org/presentationml/2006/main">
-  <p:cSld>
-    <p:spTree>
-      <p:nvGrpSpPr>
-        <p:cNvPr id="1" name=""/>
-        <p:cNvGrpSpPr/>
-        <p:nvPr/>
-      </p:nvGrpSpPr>
-      <p:grpSpPr>
-        <a:xfrm>
-          <a:off x="0" y="0"/>
-          <a:ext cx="0" cy="0"/>
-          <a:chOff x="0" y="0"/>
-          <a:chExt cx="0" cy="0"/>
-        </a:xfrm>
-      </p:grpSpPr>
-      <p:sp>
-        <p:nvSpPr>
-          <p:cNvPr id="2" name="TextBox 1"/>
-          <p:cNvSpPr txBox="1"/>
-          <p:nvPr/>
-        </p:nvSpPr>
-        <p:spPr>
-          <a:xfrm>
-            <a:off x="548640" y="320040"/>
-            <a:ext cx="10972800" cy="731520"/>
-          </a:xfrm>
-          <a:prstGeom prst="rect">
-            <a:avLst/>
-          </a:prstGeom>
-          <a:noFill/>
-        </p:spPr>
-        <p:txBody>
-          <a:bodyPr wrap="none">
-            <a:spAutoFit/>
-          </a:bodyPr>
-          <a:lstStyle/>
-          <a:p>
-            <a:pPr>
-              <a:defRPr sz="3000" b="1">
-                <a:solidFill>
-                  <a:srgbClr val="2BB5A6"/>
-                </a:solidFill>
-              </a:defRPr>
-            </a:pPr>
-            <a:r>
-              <a:t>As 1 · Opschonen: van 3.99 naar 2.27 op de vaste testset</a:t>
-            </a:r>
-          </a:p>
-        </p:txBody>
-      </p:sp>
-      <p:sp>
-        <p:nvSpPr>
-          <p:cNvPr id="3" name="TextBox 2"/>
-          <p:cNvSpPr txBox="1"/>
-          <p:nvPr/>
-        </p:nvSpPr>
-        <p:spPr>
-          <a:xfrm>
-            <a:off x="548640" y="960120"/>
-            <a:ext cx="10972800" cy="548640"/>
-          </a:xfrm>
-          <a:prstGeom prst="rect">
-            <a:avLst/>
-          </a:prstGeom>
-          <a:noFill/>
-        </p:spPr>
-        <p:txBody>
-          <a:bodyPr wrap="none">
-            <a:spAutoFit/>
-          </a:bodyPr>
-          <a:lstStyle/>
-          <a:p>
-            <a:pPr>
-              <a:defRPr sz="1700">
-                <a:solidFill>
-                  <a:srgbClr val="1F3A3D"/>
-                </a:solidFill>
-              </a:defRPr>
-            </a:pPr>
-            <a:r>
-              <a:t>Zeven regels — herstellen in plaats van weggooien</a:t>
-            </a:r>
-          </a:p>
-        </p:txBody>
-      </p:sp>
-      <p:sp>
-        <p:nvSpPr>
-          <p:cNvPr id="4" name="TextBox 3"/>
-          <p:cNvSpPr txBox="1"/>
-          <p:nvPr/>
-        </p:nvSpPr>
-        <p:spPr>
-          <a:xfrm>
-            <a:off x="548640" y="6400800"/>
-            <a:ext cx="10972800" cy="274320"/>
-          </a:xfrm>
-          <a:prstGeom prst="rect">
-            <a:avLst/>
-          </a:prstGeom>
-          <a:noFill/>
-        </p:spPr>
-        <p:txBody>
-          <a:bodyPr wrap="none">
-            <a:spAutoFit/>
-          </a:bodyPr>
-          <a:lstStyle/>
-          <a:p>
-            <a:pPr>
-              <a:defRPr sz="1000">
-                <a:solidFill>
-                  <a:srgbClr val="6B7778"/>
-                </a:solidFill>
-              </a:defRPr>
-            </a:pPr>
-            <a:r>
-              <a:t>Oevererosietool · update 26-08-2026 · 10</a:t>
-            </a:r>
-          </a:p>
-        </p:txBody>
-      </p:sp>
-      <p:sp>
-        <p:nvSpPr>
-          <p:cNvPr id="7" name="TextBox 6"/>
-          <p:cNvSpPr txBox="1"/>
-          <p:nvPr/>
-        </p:nvSpPr>
-        <p:spPr>
-          <a:xfrm>
-            <a:off x="548640" y="4572000"/>
-            <a:ext cx="6949440" cy="1737360"/>
-          </a:xfrm>
-          <a:prstGeom prst="rect">
-            <a:avLst/>
-          </a:prstGeom>
-          <a:noFill/>
-        </p:spPr>
-        <p:txBody>
-          <a:bodyPr wrap="square">
-            <a:spAutoFit/>
-          </a:bodyPr>
-          <a:lstStyle/>
-          <a:p>
-            <a:pPr>
-              <a:spcAft>
-                <a:spcPts val="400"/>
-              </a:spcAft>
-              <a:defRPr sz="1300" b="0">
-                <a:solidFill>
-                  <a:srgbClr val="1F3A3D"/>
-                </a:solidFill>
-              </a:defRPr>
-            </a:pPr>
-            <a:r>
-              <a:t>• Kronkelende lijnen, verkeerde oever, doolhoven, fragmenten, te weinig punten, uitschieters t.o.v. de trend</a:t>
-            </a:r>
-          </a:p>
-          <a:p>
-            <a:pPr>
-              <a:spcAft>
-                <a:spcPts val="400"/>
-              </a:spcAft>
-              <a:defRPr sz="1300" b="0">
-                <a:solidFill>
-                  <a:srgbClr val="1F3A3D"/>
-                </a:solidFill>
-              </a:defRPr>
-            </a:pPr>
-            <a:r>
-              <a:t>• Een uitschieter kost één meting, niet het hele vlak: +511 vlakken t.o.v. de oude |v| &gt; 50-filter</a:t>
-            </a:r>
-          </a:p>
-          <a:p>
-            <a:pPr>
-              <a:spcAft>
-                <a:spcPts val="400"/>
-              </a:spcAft>
-              <a:defRPr sz="1300" b="0">
-                <a:solidFill>
-                  <a:srgbClr val="1F3A3D"/>
-                </a:solidFill>
-              </a:defRPr>
-            </a:pPr>
-            <a:r>
-              <a:t>• Elke variant visueel gecontroleerd (50+ varianten, dekking blijft 0.94)</a:t>
-            </a:r>
-          </a:p>
-        </p:txBody>
-      </p:sp>
-      <p:sp>
-        <p:nvSpPr>
-          <p:cNvPr id="9" name="TextBox 8"/>
-          <p:cNvSpPr txBox="1"/>
-          <p:nvPr/>
-        </p:nvSpPr>
-        <p:spPr>
-          <a:xfrm>
-            <a:off x="9418320" y="1554480"/>
-            <a:ext cx="2560320" cy="3200400"/>
-          </a:xfrm>
-          <a:prstGeom prst="rect">
-            <a:avLst/>
-          </a:prstGeom>
-          <a:noFill/>
-        </p:spPr>
-        <p:txBody>
-          <a:bodyPr wrap="square">
-            <a:spAutoFit/>
-          </a:bodyPr>
-          <a:lstStyle/>
-          <a:p>
-            <a:pPr>
-              <a:defRPr sz="1100" b="0" i="1">
-                <a:solidFill>
-                  <a:srgbClr val="6B7778"/>
-                </a:solidFill>
-              </a:defRPr>
-            </a:pPr>
-            <a:r>
-              <a:t>Leeswijzer: 4.12 was de score van het 19 aug-model op zijn eigen willekeurige train/test-splitsing. Voor het experiment is één vaste testset van 1 174 vlakken bevroren zodat 50+ varianten vergelijkbaar zijn; datzelfde model scoort daarop 3.99. Alle stappen hierna zijn op deze set gemeten.</a:t>
-            </a:r>
-          </a:p>
-        </p:txBody>
-      </p:sp>
-      <p:pic>
-        <p:nvPicPr>
-          <p:cNvPr id="10" name="Picture 9" descr="cleaning_ladder.png"/>
-          <p:cNvPicPr>
-            <a:picLocks noChangeAspect="1"/>
-          </p:cNvPicPr>
-          <p:nvPr/>
-        </p:nvPicPr>
-        <p:blipFill>
-          <a:blip r:embed="rId4"/>
-          <a:stretch>
-            <a:fillRect/>
-          </a:stretch>
-        </p:blipFill>
-        <p:spPr>
-          <a:xfrm>
-            <a:off x="548640" y="1463040"/>
-            <a:ext cx="8686800" cy="3628713"/>
-          </a:xfrm>
-          <a:prstGeom prst="rect">
-            <a:avLst/>
-          </a:prstGeom>
-        </p:spPr>
-      </p:pic>
+              <a:rPr dirty="0"/>
+              <a:t>Update 26 </a:t>
+            </a:r>
+            <a:r>
+              <a:rPr dirty="0" err="1"/>
+              <a:t>augustus</a:t>
+            </a:r>
+            <a:r>
+              <a:rPr dirty="0"/>
+              <a:t> 2026</a:t>
+            </a:r>
+          </a:p>
+        </p:txBody>
+      </p:sp>
     </p:spTree>
   </p:cSld>
   <p:clrMapOvr>
@@ -4090,7 +3880,7 @@
               </a:defRPr>
             </a:pPr>
             <a:r>
-              <a:t>Oevererosietool · update 26-08-2026 · 11</a:t>
+              <a:t>Oevererosietool · update 26-08-2026 · 10</a:t>
             </a:r>
           </a:p>
         </p:txBody>
@@ -4247,7 +4037,7 @@
           <p:nvPr/>
         </p:nvPicPr>
         <p:blipFill>
-          <a:blip r:embed="rId4"/>
+          <a:blip r:embed="rId2"/>
           <a:stretch>
             <a:fillRect/>
           </a:stretch>
@@ -4387,7 +4177,7 @@
               </a:defRPr>
             </a:pPr>
             <a:r>
-              <a:t>Oevererosietool · update 26-08-2026 · 12</a:t>
+              <a:t>Oevererosietool · update 26-08-2026 · 11</a:t>
             </a:r>
           </a:p>
         </p:txBody>
@@ -4699,7 +4489,7 @@
               </a:defRPr>
             </a:pPr>
             <a:r>
-              <a:t>Oevererosietool · update 26-08-2026 · 13</a:t>
+              <a:t>Oevererosietool · update 26-08-2026 · 12</a:t>
             </a:r>
           </a:p>
         </p:txBody>
@@ -4805,6 +4595,7 @@
                 </a:solidFill>
               </a:defRPr>
             </a:pPr>
+            <a:endParaRPr/>
           </a:p>
         </p:txBody>
       </p:sp>
@@ -4817,7 +4608,7 @@
           <p:nvPr/>
         </p:nvPicPr>
         <p:blipFill>
-          <a:blip r:embed="rId4"/>
+          <a:blip r:embed="rId3"/>
           <a:stretch>
             <a:fillRect/>
           </a:stretch>
@@ -4957,7 +4748,7 @@
               </a:defRPr>
             </a:pPr>
             <a:r>
-              <a:t>Oevererosietool · update 26-08-2026 · 14</a:t>
+              <a:t>Oevererosietool · update 26-08-2026 · 13</a:t>
             </a:r>
           </a:p>
         </p:txBody>
@@ -5024,7 +4815,7 @@
           <p:nvPr/>
         </p:nvPicPr>
         <p:blipFill>
-          <a:blip r:embed="rId4"/>
+          <a:blip r:embed="rId3"/>
           <a:stretch>
             <a:fillRect/>
           </a:stretch>
@@ -5164,7 +4955,7 @@
               </a:defRPr>
             </a:pPr>
             <a:r>
-              <a:t>Oevererosietool · update 26-08-2026 · 15</a:t>
+              <a:t>Oevererosietool · update 26-08-2026 · 14</a:t>
             </a:r>
           </a:p>
         </p:txBody>
@@ -5929,7 +5720,7 @@
               </a:defRPr>
             </a:pPr>
             <a:r>
-              <a:t>Oevererosietool · update 26-08-2026 · 16</a:t>
+              <a:t>Oevererosietool · update 26-08-2026 · 15</a:t>
             </a:r>
           </a:p>
         </p:txBody>
@@ -6419,7 +6210,7 @@
               </a:defRPr>
             </a:pPr>
             <a:r>
-              <a:t>Oevererosietool · update 26-08-2026 · 17</a:t>
+              <a:t>Oevererosietool · update 26-08-2026 · 16</a:t>
             </a:r>
           </a:p>
         </p:txBody>
@@ -6636,7 +6427,7 @@
               </a:defRPr>
             </a:pPr>
             <a:r>
-              <a:t>Oevererosietool · update 26-08-2026 · 18</a:t>
+              <a:t>Oevererosietool · update 26-08-2026 · 17</a:t>
             </a:r>
           </a:p>
         </p:txBody>
@@ -6853,7 +6644,7 @@
         <p:spPr>
           <a:xfrm>
             <a:off x="548640" y="960120"/>
-            <a:ext cx="10972800" cy="548640"/>
+            <a:ext cx="4851456" cy="353943"/>
           </a:xfrm>
           <a:prstGeom prst="rect">
             <a:avLst/>
@@ -6874,8 +6665,62 @@
               </a:defRPr>
             </a:pPr>
             <a:r>
-              <a:t>Eén afstand per scopevlak — en een oever is geen rechte lijn</a:t>
-            </a:r>
+              <a:rPr dirty="0" err="1"/>
+              <a:t>Eén</a:t>
+            </a:r>
+            <a:r>
+              <a:rPr dirty="0"/>
+              <a:t> </a:t>
+            </a:r>
+            <a:r>
+              <a:rPr dirty="0" err="1"/>
+              <a:t>afstand</a:t>
+            </a:r>
+            <a:r>
+              <a:rPr dirty="0"/>
+              <a:t> per </a:t>
+            </a:r>
+            <a:r>
+              <a:rPr dirty="0" err="1"/>
+              <a:t>scopevlak</a:t>
+            </a:r>
+            <a:r>
+              <a:rPr dirty="0"/>
+              <a:t> </a:t>
+            </a:r>
+            <a:r>
+              <a:rPr lang="en-US" dirty="0"/>
+              <a:t>-&gt; </a:t>
+            </a:r>
+            <a:r>
+              <a:rPr dirty="0" err="1"/>
+              <a:t>oever</a:t>
+            </a:r>
+            <a:r>
+              <a:rPr dirty="0"/>
+              <a:t> is </a:t>
+            </a:r>
+            <a:r>
+              <a:rPr dirty="0" err="1"/>
+              <a:t>geen</a:t>
+            </a:r>
+            <a:r>
+              <a:rPr dirty="0"/>
+              <a:t> </a:t>
+            </a:r>
+            <a:r>
+              <a:rPr dirty="0" err="1"/>
+              <a:t>rechte</a:t>
+            </a:r>
+            <a:r>
+              <a:rPr dirty="0"/>
+              <a:t> </a:t>
+            </a:r>
+            <a:r>
+              <a:rPr dirty="0" err="1"/>
+              <a:t>lijn</a:t>
+            </a:r>
+            <a:endParaRPr dirty="0"/>
           </a:p>
         </p:txBody>
       </p:sp>
@@ -6992,8 +6837,74 @@
               </a:defRPr>
             </a:pPr>
             <a:r>
-              <a:t>hoogtemodel (maart): de ene afstand (gestippeld) ligt 38 m naast de gemeten oever</a:t>
-            </a:r>
+              <a:rPr dirty="0" err="1"/>
+              <a:t>hoogtemodel</a:t>
+            </a:r>
+            <a:r>
+              <a:rPr dirty="0"/>
+              <a:t> (</a:t>
+            </a:r>
+            <a:r>
+              <a:rPr dirty="0" err="1"/>
+              <a:t>maart</a:t>
+            </a:r>
+            <a:r>
+              <a:rPr dirty="0"/>
+              <a:t>): de </a:t>
+            </a:r>
+            <a:r>
+              <a:rPr dirty="0" err="1"/>
+              <a:t>ene</a:t>
+            </a:r>
+            <a:r>
+              <a:rPr dirty="0"/>
+              <a:t> </a:t>
+            </a:r>
+            <a:r>
+              <a:rPr dirty="0" err="1"/>
+              <a:t>afstand</a:t>
+            </a:r>
+            <a:r>
+              <a:rPr dirty="0"/>
+              <a:t> (</a:t>
+            </a:r>
+            <a:r>
+              <a:rPr dirty="0" err="1"/>
+              <a:t>gestippeld</a:t>
+            </a:r>
+            <a:r>
+              <a:rPr dirty="0"/>
+              <a:t>) </a:t>
+            </a:r>
+            <a:r>
+              <a:rPr dirty="0" err="1"/>
+              <a:t>ligt</a:t>
+            </a:r>
+            <a:r>
+              <a:rPr dirty="0"/>
+              <a:t> 38 m </a:t>
+            </a:r>
+            <a:r>
+              <a:rPr dirty="0" err="1"/>
+              <a:t>naast</a:t>
+            </a:r>
+            <a:r>
+              <a:rPr dirty="0"/>
+              <a:t> de </a:t>
+            </a:r>
+            <a:r>
+              <a:rPr dirty="0" err="1"/>
+              <a:t>gemeten</a:t>
+            </a:r>
+            <a:r>
+              <a:rPr dirty="0"/>
+              <a:t> </a:t>
+            </a:r>
+            <a:r>
+              <a:rPr dirty="0" err="1"/>
+              <a:t>oever</a:t>
+            </a:r>
+            <a:endParaRPr dirty="0"/>
           </a:p>
         </p:txBody>
       </p:sp>
@@ -7006,7 +6917,7 @@
         <p:spPr>
           <a:xfrm>
             <a:off x="6096000" y="5664270"/>
-            <a:ext cx="4023360" cy="548640"/>
+            <a:ext cx="5143500" cy="261610"/>
           </a:xfrm>
           <a:prstGeom prst="rect">
             <a:avLst/>
@@ -7132,160 +7043,6 @@
       </p:grpSpPr>
       <p:sp>
         <p:nvSpPr>
-          <p:cNvPr id="2" name="TextBox 1"/>
-          <p:cNvSpPr txBox="1"/>
-          <p:nvPr/>
-        </p:nvSpPr>
-        <p:spPr>
-          <a:xfrm>
-            <a:off x="548640" y="320040"/>
-            <a:ext cx="10972800" cy="731520"/>
-          </a:xfrm>
-          <a:prstGeom prst="rect">
-            <a:avLst/>
-          </a:prstGeom>
-          <a:noFill/>
-        </p:spPr>
-        <p:txBody>
-          <a:bodyPr wrap="none">
-            <a:spAutoFit/>
-          </a:bodyPr>
-          <a:lstStyle/>
-          <a:p>
-            <a:pPr>
-              <a:defRPr sz="3000" b="1">
-                <a:solidFill>
-                  <a:srgbClr val="2BB5A6"/>
-                </a:solidFill>
-              </a:defRPr>
-            </a:pPr>
-            <a:r>
-              <a:t>Wat er sindsdien binnenkwam</a:t>
-            </a:r>
-          </a:p>
-        </p:txBody>
-      </p:sp>
-      <p:sp>
-        <p:nvSpPr>
-          <p:cNvPr id="3" name="TextBox 2"/>
-          <p:cNvSpPr txBox="1"/>
-          <p:nvPr/>
-        </p:nvSpPr>
-        <p:spPr>
-          <a:xfrm>
-            <a:off x="548640" y="960120"/>
-            <a:ext cx="10972800" cy="548640"/>
-          </a:xfrm>
-          <a:prstGeom prst="rect">
-            <a:avLst/>
-          </a:prstGeom>
-          <a:noFill/>
-        </p:spPr>
-        <p:txBody>
-          <a:bodyPr wrap="none">
-            <a:spAutoFit/>
-          </a:bodyPr>
-          <a:lstStyle/>
-          <a:p>
-            <a:pPr>
-              <a:defRPr sz="1700">
-                <a:solidFill>
-                  <a:srgbClr val="1F3A3D"/>
-                </a:solidFill>
-              </a:defRPr>
-            </a:pPr>
-            <a:r>
-              <a:t>Hybride levering: SAM + hoogtemodel · tot 11 meetmomenten · 1 jaar tussen t-punten</a:t>
-            </a:r>
-          </a:p>
-        </p:txBody>
-      </p:sp>
-      <p:sp>
-        <p:nvSpPr>
-          <p:cNvPr id="4" name="TextBox 3"/>
-          <p:cNvSpPr txBox="1"/>
-          <p:nvPr/>
-        </p:nvSpPr>
-        <p:spPr>
-          <a:xfrm>
-            <a:off x="548640" y="6400800"/>
-            <a:ext cx="10972800" cy="274320"/>
-          </a:xfrm>
-          <a:prstGeom prst="rect">
-            <a:avLst/>
-          </a:prstGeom>
-          <a:noFill/>
-        </p:spPr>
-        <p:txBody>
-          <a:bodyPr wrap="none">
-            <a:spAutoFit/>
-          </a:bodyPr>
-          <a:lstStyle/>
-          <a:p>
-            <a:pPr>
-              <a:defRPr sz="1000">
-                <a:solidFill>
-                  <a:srgbClr val="6B7778"/>
-                </a:solidFill>
-              </a:defRPr>
-            </a:pPr>
-            <a:r>
-              <a:t>Oevererosietool · update 26-08-2026 · 3</a:t>
-            </a:r>
-          </a:p>
-        </p:txBody>
-      </p:sp>
-      <p:pic>
-        <p:nvPicPr>
-          <p:cNvPr id="5" name="Picture 4" descr="aug-2.png"/>
-          <p:cNvPicPr>
-            <a:picLocks noChangeAspect="1"/>
-          </p:cNvPicPr>
-          <p:nvPr/>
-        </p:nvPicPr>
-        <p:blipFill>
-          <a:blip r:embed="rId2"/>
-          <a:stretch>
-            <a:fillRect/>
-          </a:stretch>
-        </p:blipFill>
-        <p:spPr>
-          <a:xfrm>
-            <a:off x="1012102" y="1426122"/>
-            <a:ext cx="8845881" cy="4974678"/>
-          </a:xfrm>
-          <a:prstGeom prst="rect">
-            <a:avLst/>
-          </a:prstGeom>
-        </p:spPr>
-      </p:pic>
-    </p:spTree>
-  </p:cSld>
-  <p:clrMapOvr>
-    <a:masterClrMapping/>
-  </p:clrMapOvr>
-</p:sld>
-</file>
-
-<file path=ppt/slides/slide4.xml><?xml version="1.0" encoding="utf-8"?>
-<p:sld xmlns:a="http://schemas.openxmlformats.org/drawingml/2006/main" xmlns:r="http://schemas.openxmlformats.org/officeDocument/2006/relationships" xmlns:p="http://schemas.openxmlformats.org/presentationml/2006/main">
-  <p:cSld>
-    <p:spTree>
-      <p:nvGrpSpPr>
-        <p:cNvPr id="1" name=""/>
-        <p:cNvGrpSpPr/>
-        <p:nvPr/>
-      </p:nvGrpSpPr>
-      <p:grpSpPr>
-        <a:xfrm>
-          <a:off x="0" y="0"/>
-          <a:ext cx="0" cy="0"/>
-          <a:chOff x="0" y="0"/>
-          <a:chExt cx="0" cy="0"/>
-        </a:xfrm>
-      </p:grpSpPr>
-      <p:sp>
-        <p:nvSpPr>
           <p:cNvPr id="6" name="TextBox 5">
             <a:extLst>
               <a:ext uri="{FF2B5EF4-FFF2-40B4-BE49-F238E27FC236}">
@@ -7358,7 +7115,7 @@
         <p:spPr>
           <a:xfrm>
             <a:off x="548640" y="5577840"/>
-            <a:ext cx="11064240" cy="461665"/>
+            <a:ext cx="11064240" cy="276999"/>
           </a:xfrm>
           <a:prstGeom prst="rect">
             <a:avLst/>
@@ -7480,15 +7237,11 @@
             </a:r>
             <a:r>
               <a:rPr dirty="0"/>
-              <a:t> mee — </a:t>
-            </a:r>
-            <a:r>
-              <a:rPr dirty="0" err="1"/>
-              <a:t>ook</a:t>
-            </a:r>
-            <a:r>
-              <a:rPr dirty="0"/>
-              <a:t> die van de baseline. </a:t>
+              <a:t> mee</a:t>
+            </a:r>
+            <a:r>
+              <a:rPr lang="en-US" dirty="0"/>
+              <a:t>. </a:t>
             </a:r>
             <a:r>
               <a:rPr dirty="0" err="1"/>
@@ -7539,7 +7292,7 @@
         <p:spPr>
           <a:xfrm>
             <a:off x="548640" y="6400800"/>
-            <a:ext cx="10972800" cy="274320"/>
+            <a:ext cx="10972800" cy="246221"/>
           </a:xfrm>
           <a:prstGeom prst="rect">
             <a:avLst/>
@@ -7560,8 +7313,9 @@
               </a:defRPr>
             </a:pPr>
             <a:r>
-              <a:t>Oevererosietool · update 26-08-2026 · 4</a:t>
-            </a:r>
+              <a:t>Oevererosietool · update 26-08-2026 · 3</a:t>
+            </a:r>
+            <a:endParaRPr dirty="0"/>
           </a:p>
         </p:txBody>
       </p:sp>
@@ -8635,6 +8389,788 @@
 </p:sld>
 </file>
 
+<file path=ppt/slides/slide4.xml><?xml version="1.0" encoding="utf-8"?>
+<p:sld xmlns:a="http://schemas.openxmlformats.org/drawingml/2006/main" xmlns:r="http://schemas.openxmlformats.org/officeDocument/2006/relationships" xmlns:p="http://schemas.openxmlformats.org/presentationml/2006/main">
+  <p:cSld>
+    <p:spTree>
+      <p:nvGrpSpPr>
+        <p:cNvPr id="1" name=""/>
+        <p:cNvGrpSpPr/>
+        <p:nvPr/>
+      </p:nvGrpSpPr>
+      <p:grpSpPr>
+        <a:xfrm>
+          <a:off x="0" y="0"/>
+          <a:ext cx="0" cy="0"/>
+          <a:chOff x="0" y="0"/>
+          <a:chExt cx="0" cy="0"/>
+        </a:xfrm>
+      </p:grpSpPr>
+      <p:sp>
+        <p:nvSpPr>
+          <p:cNvPr id="2" name="TextBox 1"/>
+          <p:cNvSpPr txBox="1"/>
+          <p:nvPr/>
+        </p:nvSpPr>
+        <p:spPr>
+          <a:xfrm>
+            <a:off x="548640" y="320040"/>
+            <a:ext cx="10972800" cy="731520"/>
+          </a:xfrm>
+          <a:prstGeom prst="rect">
+            <a:avLst/>
+          </a:prstGeom>
+          <a:noFill/>
+        </p:spPr>
+        <p:txBody>
+          <a:bodyPr wrap="none">
+            <a:spAutoFit/>
+          </a:bodyPr>
+          <a:lstStyle/>
+          <a:p>
+            <a:pPr>
+              <a:defRPr sz="3000" b="1">
+                <a:solidFill>
+                  <a:srgbClr val="2BB5A6"/>
+                </a:solidFill>
+              </a:defRPr>
+            </a:pPr>
+            <a:r>
+              <a:rPr dirty="0" err="1"/>
+              <a:t>Drie</a:t>
+            </a:r>
+            <a:r>
+              <a:rPr dirty="0"/>
+              <a:t> </a:t>
+            </a:r>
+            <a:r>
+              <a:rPr dirty="0" err="1"/>
+              <a:t>assen</a:t>
+            </a:r>
+            <a:r>
+              <a:rPr dirty="0"/>
+              <a:t> om </a:t>
+            </a:r>
+            <a:r>
+              <a:rPr dirty="0" err="1"/>
+              <a:t>te</a:t>
+            </a:r>
+            <a:r>
+              <a:rPr dirty="0"/>
+              <a:t> </a:t>
+            </a:r>
+            <a:r>
+              <a:rPr dirty="0" err="1"/>
+              <a:t>verbeteren</a:t>
+            </a:r>
+            <a:endParaRPr dirty="0"/>
+          </a:p>
+        </p:txBody>
+      </p:sp>
+      <p:sp>
+        <p:nvSpPr>
+          <p:cNvPr id="3" name="TextBox 2"/>
+          <p:cNvSpPr txBox="1"/>
+          <p:nvPr/>
+        </p:nvSpPr>
+        <p:spPr>
+          <a:xfrm>
+            <a:off x="548640" y="960120"/>
+            <a:ext cx="8065093" cy="353943"/>
+          </a:xfrm>
+          <a:prstGeom prst="rect">
+            <a:avLst/>
+          </a:prstGeom>
+          <a:noFill/>
+        </p:spPr>
+        <p:txBody>
+          <a:bodyPr wrap="none">
+            <a:spAutoFit/>
+          </a:bodyPr>
+          <a:lstStyle/>
+          <a:p>
+            <a:pPr>
+              <a:defRPr sz="1700">
+                <a:solidFill>
+                  <a:srgbClr val="1F3A3D"/>
+                </a:solidFill>
+              </a:defRPr>
+            </a:pPr>
+            <a:r>
+              <a:rPr dirty="0" err="1"/>
+              <a:t>Uitgangspunt</a:t>
+            </a:r>
+            <a:r>
+              <a:rPr dirty="0"/>
+              <a:t>: het model van 19 </a:t>
+            </a:r>
+            <a:r>
+              <a:rPr dirty="0" err="1"/>
+              <a:t>augustus</a:t>
+            </a:r>
+            <a:r>
+              <a:rPr dirty="0"/>
+              <a:t>, </a:t>
+            </a:r>
+            <a:r>
+              <a:rPr dirty="0" err="1"/>
+              <a:t>resolutie</a:t>
+            </a:r>
+            <a:r>
+              <a:rPr dirty="0"/>
+              <a:t> 1, </a:t>
+            </a:r>
+            <a:r>
+              <a:rPr dirty="0" err="1"/>
+              <a:t>één</a:t>
+            </a:r>
+            <a:r>
+              <a:rPr dirty="0"/>
+              <a:t> </a:t>
+            </a:r>
+            <a:r>
+              <a:rPr dirty="0" err="1"/>
+              <a:t>vaste</a:t>
+            </a:r>
+            <a:r>
+              <a:rPr dirty="0"/>
+              <a:t> </a:t>
+            </a:r>
+            <a:r>
+              <a:rPr dirty="0" err="1"/>
+              <a:t>testset</a:t>
+            </a:r>
+            <a:r>
+              <a:rPr dirty="0"/>
+              <a:t> van 1174 </a:t>
+            </a:r>
+            <a:r>
+              <a:rPr dirty="0" err="1"/>
+              <a:t>vlakken</a:t>
+            </a:r>
+            <a:endParaRPr dirty="0"/>
+          </a:p>
+        </p:txBody>
+      </p:sp>
+      <p:sp>
+        <p:nvSpPr>
+          <p:cNvPr id="4" name="TextBox 3"/>
+          <p:cNvSpPr txBox="1"/>
+          <p:nvPr/>
+        </p:nvSpPr>
+        <p:spPr>
+          <a:xfrm>
+            <a:off x="548640" y="6400800"/>
+            <a:ext cx="2273379" cy="246221"/>
+          </a:xfrm>
+          <a:prstGeom prst="rect">
+            <a:avLst/>
+          </a:prstGeom>
+          <a:noFill/>
+        </p:spPr>
+        <p:txBody>
+          <a:bodyPr wrap="none">
+            <a:spAutoFit/>
+          </a:bodyPr>
+          <a:lstStyle/>
+          <a:p>
+            <a:pPr>
+              <a:defRPr sz="1000">
+                <a:solidFill>
+                  <a:srgbClr val="6B7778"/>
+                </a:solidFill>
+              </a:defRPr>
+            </a:pPr>
+            <a:r>
+              <a:t>Oevererosietool · update 26-08-2026 · 4</a:t>
+            </a:r>
+            <a:endParaRPr dirty="0"/>
+          </a:p>
+        </p:txBody>
+      </p:sp>
+      <p:sp>
+        <p:nvSpPr>
+          <p:cNvPr id="5" name="Rectangle 4"/>
+          <p:cNvSpPr/>
+          <p:nvPr/>
+        </p:nvSpPr>
+        <p:spPr>
+          <a:xfrm>
+            <a:off x="548640" y="1645920"/>
+            <a:ext cx="3566160" cy="548640"/>
+          </a:xfrm>
+          <a:prstGeom prst="rect">
+            <a:avLst/>
+          </a:prstGeom>
+          <a:solidFill>
+            <a:srgbClr val="2BB5A6"/>
+          </a:solidFill>
+          <a:ln>
+            <a:noFill/>
+          </a:ln>
+        </p:spPr>
+        <p:style>
+          <a:lnRef idx="1">
+            <a:schemeClr val="accent1"/>
+          </a:lnRef>
+          <a:fillRef idx="3">
+            <a:schemeClr val="accent1"/>
+          </a:fillRef>
+          <a:effectRef idx="2">
+            <a:schemeClr val="accent1"/>
+          </a:effectRef>
+          <a:fontRef idx="minor">
+            <a:schemeClr val="lt1"/>
+          </a:fontRef>
+        </p:style>
+        <p:txBody>
+          <a:bodyPr rtlCol="0" anchor="ctr"/>
+          <a:lstStyle/>
+          <a:p>
+            <a:pPr algn="ctr">
+              <a:defRPr sz="1800" b="1">
+                <a:solidFill>
+                  <a:srgbClr val="FFFFFF"/>
+                </a:solidFill>
+              </a:defRPr>
+            </a:pPr>
+            <a:r>
+              <a:t>1 · Opschonen</a:t>
+            </a:r>
+          </a:p>
+        </p:txBody>
+      </p:sp>
+      <p:sp>
+        <p:nvSpPr>
+          <p:cNvPr id="6" name="TextBox 5"/>
+          <p:cNvSpPr txBox="1"/>
+          <p:nvPr/>
+        </p:nvSpPr>
+        <p:spPr>
+          <a:xfrm>
+            <a:off x="548640" y="2377440"/>
+            <a:ext cx="3566160" cy="3474720"/>
+          </a:xfrm>
+          <a:prstGeom prst="rect">
+            <a:avLst/>
+          </a:prstGeom>
+          <a:noFill/>
+        </p:spPr>
+        <p:txBody>
+          <a:bodyPr wrap="square">
+            <a:spAutoFit/>
+          </a:bodyPr>
+          <a:lstStyle/>
+          <a:p>
+            <a:pPr>
+              <a:spcAft>
+                <a:spcPts val="600"/>
+              </a:spcAft>
+              <a:defRPr sz="1500" b="0">
+                <a:solidFill>
+                  <a:srgbClr val="1F3A3D"/>
+                </a:solidFill>
+              </a:defRPr>
+            </a:pPr>
+            <a:r>
+              <a:rPr dirty="0"/>
+              <a:t>• </a:t>
+            </a:r>
+            <a:r>
+              <a:rPr dirty="0" err="1"/>
+              <a:t>Verkeerde-oever-detecties</a:t>
+            </a:r>
+            <a:r>
+              <a:rPr dirty="0"/>
+              <a:t> </a:t>
+            </a:r>
+            <a:r>
+              <a:rPr dirty="0" err="1"/>
+              <a:t>weghalen</a:t>
+            </a:r>
+            <a:r>
+              <a:rPr dirty="0"/>
+              <a:t> </a:t>
+            </a:r>
+            <a:r>
+              <a:rPr dirty="0" err="1"/>
+              <a:t>zónder</a:t>
+            </a:r>
+            <a:r>
+              <a:rPr dirty="0"/>
+              <a:t> de meting </a:t>
+            </a:r>
+            <a:r>
+              <a:rPr dirty="0" err="1"/>
+              <a:t>weg</a:t>
+            </a:r>
+            <a:r>
+              <a:rPr dirty="0"/>
+              <a:t> </a:t>
+            </a:r>
+            <a:r>
+              <a:rPr dirty="0" err="1"/>
+              <a:t>te</a:t>
+            </a:r>
+            <a:r>
+              <a:rPr dirty="0"/>
+              <a:t> </a:t>
+            </a:r>
+            <a:r>
+              <a:rPr dirty="0" err="1"/>
+              <a:t>gooien</a:t>
+            </a:r>
+            <a:endParaRPr dirty="0"/>
+          </a:p>
+          <a:p>
+            <a:pPr>
+              <a:spcAft>
+                <a:spcPts val="600"/>
+              </a:spcAft>
+              <a:defRPr sz="1500" b="0">
+                <a:solidFill>
+                  <a:srgbClr val="1F3A3D"/>
+                </a:solidFill>
+              </a:defRPr>
+            </a:pPr>
+            <a:r>
+              <a:rPr dirty="0"/>
+              <a:t>• </a:t>
+            </a:r>
+            <a:r>
+              <a:rPr dirty="0" err="1"/>
+              <a:t>Kribben</a:t>
+            </a:r>
+            <a:r>
+              <a:rPr dirty="0"/>
+              <a:t>, </a:t>
+            </a:r>
+            <a:r>
+              <a:rPr dirty="0" err="1"/>
+              <a:t>bruggen</a:t>
+            </a:r>
+            <a:r>
+              <a:rPr dirty="0"/>
+              <a:t>, </a:t>
+            </a:r>
+            <a:r>
+              <a:rPr dirty="0" err="1"/>
+              <a:t>nevengeulen</a:t>
+            </a:r>
+            <a:r>
+              <a:rPr dirty="0"/>
+              <a:t>, </a:t>
+            </a:r>
+            <a:r>
+              <a:rPr dirty="0" err="1"/>
+              <a:t>doolhoven</a:t>
+            </a:r>
+            <a:r>
+              <a:rPr dirty="0"/>
+              <a:t>, </a:t>
+            </a:r>
+            <a:r>
+              <a:rPr dirty="0" err="1"/>
+              <a:t>fragmenten</a:t>
+            </a:r>
+            <a:r>
+              <a:rPr dirty="0"/>
+              <a:t>, </a:t>
+            </a:r>
+            <a:r>
+              <a:rPr dirty="0" err="1"/>
+              <a:t>uitschieters</a:t>
+            </a:r>
+            <a:r>
+              <a:rPr dirty="0"/>
+              <a:t> in de </a:t>
+            </a:r>
+            <a:r>
+              <a:rPr dirty="0" err="1"/>
+              <a:t>tijd</a:t>
+            </a:r>
+            <a:endParaRPr dirty="0"/>
+          </a:p>
+        </p:txBody>
+      </p:sp>
+      <p:sp>
+        <p:nvSpPr>
+          <p:cNvPr id="7" name="Rectangle 6"/>
+          <p:cNvSpPr/>
+          <p:nvPr/>
+        </p:nvSpPr>
+        <p:spPr>
+          <a:xfrm>
+            <a:off x="4389120" y="1645920"/>
+            <a:ext cx="3566160" cy="548640"/>
+          </a:xfrm>
+          <a:prstGeom prst="rect">
+            <a:avLst/>
+          </a:prstGeom>
+          <a:solidFill>
+            <a:srgbClr val="2BB5A6"/>
+          </a:solidFill>
+          <a:ln>
+            <a:noFill/>
+          </a:ln>
+        </p:spPr>
+        <p:style>
+          <a:lnRef idx="1">
+            <a:schemeClr val="accent1"/>
+          </a:lnRef>
+          <a:fillRef idx="3">
+            <a:schemeClr val="accent1"/>
+          </a:fillRef>
+          <a:effectRef idx="2">
+            <a:schemeClr val="accent1"/>
+          </a:effectRef>
+          <a:fontRef idx="minor">
+            <a:schemeClr val="lt1"/>
+          </a:fontRef>
+        </p:style>
+        <p:txBody>
+          <a:bodyPr rtlCol="0" anchor="ctr"/>
+          <a:lstStyle/>
+          <a:p>
+            <a:pPr algn="ctr">
+              <a:defRPr sz="1800" b="1">
+                <a:solidFill>
+                  <a:srgbClr val="FFFFFF"/>
+                </a:solidFill>
+              </a:defRPr>
+            </a:pPr>
+            <a:r>
+              <a:t>2 · Meerdere t-punten</a:t>
+            </a:r>
+          </a:p>
+        </p:txBody>
+      </p:sp>
+      <p:sp>
+        <p:nvSpPr>
+          <p:cNvPr id="8" name="TextBox 7"/>
+          <p:cNvSpPr txBox="1"/>
+          <p:nvPr/>
+        </p:nvSpPr>
+        <p:spPr>
+          <a:xfrm>
+            <a:off x="4389120" y="2377440"/>
+            <a:ext cx="3566160" cy="3474720"/>
+          </a:xfrm>
+          <a:prstGeom prst="rect">
+            <a:avLst/>
+          </a:prstGeom>
+          <a:noFill/>
+        </p:spPr>
+        <p:txBody>
+          <a:bodyPr wrap="square">
+            <a:spAutoFit/>
+          </a:bodyPr>
+          <a:lstStyle/>
+          <a:p>
+            <a:pPr>
+              <a:spcAft>
+                <a:spcPts val="600"/>
+              </a:spcAft>
+              <a:defRPr sz="1500" b="0">
+                <a:solidFill>
+                  <a:srgbClr val="1F3A3D"/>
+                </a:solidFill>
+              </a:defRPr>
+            </a:pPr>
+            <a:r>
+              <a:t>• Snelheid als trend over álle metingen</a:t>
+            </a:r>
+          </a:p>
+          <a:p>
+            <a:pPr>
+              <a:spcAft>
+                <a:spcPts val="600"/>
+              </a:spcAft>
+              <a:defRPr sz="1500" b="0">
+                <a:solidFill>
+                  <a:srgbClr val="1F3A3D"/>
+                </a:solidFill>
+              </a:defRPr>
+            </a:pPr>
+            <a:r>
+              <a:t>• Versnelling, terugkeer naar gemiddelde, recente helling als feature</a:t>
+            </a:r>
+          </a:p>
+        </p:txBody>
+      </p:sp>
+      <p:sp>
+        <p:nvSpPr>
+          <p:cNvPr id="9" name="Rectangle 8"/>
+          <p:cNvSpPr/>
+          <p:nvPr/>
+        </p:nvSpPr>
+        <p:spPr>
+          <a:xfrm>
+            <a:off x="8229600" y="1645920"/>
+            <a:ext cx="3566160" cy="548640"/>
+          </a:xfrm>
+          <a:prstGeom prst="rect">
+            <a:avLst/>
+          </a:prstGeom>
+          <a:solidFill>
+            <a:srgbClr val="2BB5A6"/>
+          </a:solidFill>
+          <a:ln>
+            <a:noFill/>
+          </a:ln>
+        </p:spPr>
+        <p:style>
+          <a:lnRef idx="1">
+            <a:schemeClr val="accent1"/>
+          </a:lnRef>
+          <a:fillRef idx="3">
+            <a:schemeClr val="accent1"/>
+          </a:fillRef>
+          <a:effectRef idx="2">
+            <a:schemeClr val="accent1"/>
+          </a:effectRef>
+          <a:fontRef idx="minor">
+            <a:schemeClr val="lt1"/>
+          </a:fontRef>
+        </p:style>
+        <p:txBody>
+          <a:bodyPr rtlCol="0" anchor="ctr"/>
+          <a:lstStyle/>
+          <a:p>
+            <a:pPr algn="ctr">
+              <a:defRPr sz="1800" b="1">
+                <a:solidFill>
+                  <a:srgbClr val="FFFFFF"/>
+                </a:solidFill>
+              </a:defRPr>
+            </a:pPr>
+            <a:r>
+              <a:t>3 · Resolutie</a:t>
+            </a:r>
+          </a:p>
+        </p:txBody>
+      </p:sp>
+      <p:sp>
+        <p:nvSpPr>
+          <p:cNvPr id="10" name="TextBox 9"/>
+          <p:cNvSpPr txBox="1"/>
+          <p:nvPr/>
+        </p:nvSpPr>
+        <p:spPr>
+          <a:xfrm>
+            <a:off x="8229600" y="2377440"/>
+            <a:ext cx="3566160" cy="3474720"/>
+          </a:xfrm>
+          <a:prstGeom prst="rect">
+            <a:avLst/>
+          </a:prstGeom>
+          <a:noFill/>
+        </p:spPr>
+        <p:txBody>
+          <a:bodyPr wrap="square">
+            <a:spAutoFit/>
+          </a:bodyPr>
+          <a:lstStyle/>
+          <a:p>
+            <a:pPr>
+              <a:spcAft>
+                <a:spcPts val="600"/>
+              </a:spcAft>
+              <a:defRPr sz="1500" b="0">
+                <a:solidFill>
+                  <a:srgbClr val="1F3A3D"/>
+                </a:solidFill>
+              </a:defRPr>
+            </a:pPr>
+            <a:r>
+              <a:t>• Meerdere segmenten per vlak in plaats van één afstand</a:t>
+            </a:r>
+          </a:p>
+          <a:p>
+            <a:pPr>
+              <a:spcAft>
+                <a:spcPts val="600"/>
+              </a:spcAft>
+              <a:defRPr sz="1500" b="0">
+                <a:solidFill>
+                  <a:srgbClr val="1F3A3D"/>
+                </a:solidFill>
+              </a:defRPr>
+            </a:pPr>
+            <a:r>
+              <a:t>• Gemeten én voorspelde oever als lijn</a:t>
+            </a:r>
+          </a:p>
+        </p:txBody>
+      </p:sp>
+      <p:sp>
+        <p:nvSpPr>
+          <p:cNvPr id="11" name="TextBox 10"/>
+          <p:cNvSpPr txBox="1"/>
+          <p:nvPr/>
+        </p:nvSpPr>
+        <p:spPr>
+          <a:xfrm>
+            <a:off x="548640" y="5577840"/>
+            <a:ext cx="10972800" cy="548640"/>
+          </a:xfrm>
+          <a:prstGeom prst="rect">
+            <a:avLst/>
+          </a:prstGeom>
+          <a:noFill/>
+        </p:spPr>
+        <p:txBody>
+          <a:bodyPr wrap="square">
+            <a:spAutoFit/>
+          </a:bodyPr>
+          <a:lstStyle/>
+          <a:p>
+            <a:pPr>
+              <a:defRPr sz="1300" i="0">
+                <a:solidFill>
+                  <a:srgbClr val="1F3A3D"/>
+                </a:solidFill>
+              </a:defRPr>
+            </a:pPr>
+            <a:r>
+              <a:rPr dirty="0" err="1"/>
+              <a:t>Leeswijzer</a:t>
+            </a:r>
+            <a:r>
+              <a:rPr dirty="0"/>
+              <a:t>: op </a:t>
+            </a:r>
+            <a:r>
+              <a:rPr dirty="0" err="1"/>
+              <a:t>deze</a:t>
+            </a:r>
+            <a:r>
+              <a:rPr dirty="0"/>
+              <a:t> </a:t>
+            </a:r>
+            <a:r>
+              <a:rPr dirty="0" err="1"/>
+              <a:t>vaste</a:t>
+            </a:r>
+            <a:r>
+              <a:rPr dirty="0"/>
+              <a:t> </a:t>
+            </a:r>
+            <a:r>
+              <a:rPr dirty="0" err="1"/>
+              <a:t>testset</a:t>
+            </a:r>
+            <a:r>
+              <a:rPr dirty="0"/>
+              <a:t> </a:t>
+            </a:r>
+            <a:r>
+              <a:rPr dirty="0" err="1"/>
+              <a:t>scoort</a:t>
+            </a:r>
+            <a:r>
+              <a:rPr dirty="0"/>
+              <a:t> het model van 19 </a:t>
+            </a:r>
+            <a:r>
+              <a:rPr dirty="0" err="1"/>
+              <a:t>augustus</a:t>
+            </a:r>
+            <a:r>
+              <a:rPr dirty="0"/>
+              <a:t> 3.99 m/</a:t>
+            </a:r>
+            <a:r>
+              <a:rPr dirty="0" err="1"/>
+              <a:t>jr</a:t>
+            </a:r>
+            <a:r>
+              <a:rPr dirty="0"/>
+              <a:t> (4.12 op de eigen split van </a:t>
+            </a:r>
+            <a:r>
+              <a:rPr dirty="0" err="1"/>
+              <a:t>toen</a:t>
+            </a:r>
+            <a:r>
+              <a:rPr dirty="0"/>
+              <a:t>). Alle </a:t>
+            </a:r>
+            <a:r>
+              <a:rPr dirty="0" err="1"/>
+              <a:t>cijfers</a:t>
+            </a:r>
+            <a:r>
+              <a:rPr dirty="0"/>
+              <a:t> </a:t>
+            </a:r>
+            <a:r>
+              <a:rPr dirty="0" err="1"/>
+              <a:t>hierna</a:t>
+            </a:r>
+            <a:r>
+              <a:rPr dirty="0"/>
+              <a:t> </a:t>
+            </a:r>
+            <a:r>
+              <a:rPr dirty="0" err="1"/>
+              <a:t>zijn</a:t>
+            </a:r>
+            <a:r>
+              <a:rPr dirty="0"/>
+              <a:t> op </a:t>
+            </a:r>
+            <a:r>
+              <a:rPr dirty="0" err="1"/>
+              <a:t>deze</a:t>
+            </a:r>
+            <a:r>
+              <a:rPr dirty="0"/>
+              <a:t> set, </a:t>
+            </a:r>
+            <a:r>
+              <a:rPr dirty="0" err="1"/>
+              <a:t>zodat</a:t>
+            </a:r>
+            <a:r>
+              <a:rPr dirty="0"/>
+              <a:t> </a:t>
+            </a:r>
+            <a:r>
+              <a:rPr dirty="0" err="1"/>
+              <a:t>stappen</a:t>
+            </a:r>
+            <a:r>
+              <a:rPr dirty="0"/>
+              <a:t> </a:t>
+            </a:r>
+            <a:r>
+              <a:rPr dirty="0" err="1"/>
+              <a:t>optelbaar</a:t>
+            </a:r>
+            <a:r>
+              <a:rPr dirty="0"/>
+              <a:t> </a:t>
+            </a:r>
+            <a:r>
+              <a:rPr dirty="0" err="1"/>
+              <a:t>zijn</a:t>
+            </a:r>
+            <a:r>
+              <a:rPr dirty="0"/>
+              <a:t>.</a:t>
+            </a:r>
+          </a:p>
+        </p:txBody>
+      </p:sp>
+    </p:spTree>
+  </p:cSld>
+  <p:clrMapOvr>
+    <a:masterClrMapping/>
+  </p:clrMapOvr>
+</p:sld>
+</file>
+
 <file path=ppt/slides/slide5.xml><?xml version="1.0" encoding="utf-8"?>
 <p:sld xmlns:a="http://schemas.openxmlformats.org/drawingml/2006/main" xmlns:r="http://schemas.openxmlformats.org/officeDocument/2006/relationships" xmlns:p="http://schemas.openxmlformats.org/presentationml/2006/main">
   <p:cSld>
@@ -8661,7 +9197,7 @@
         <p:spPr>
           <a:xfrm>
             <a:off x="548640" y="320040"/>
-            <a:ext cx="10972800" cy="731520"/>
+            <a:ext cx="6350585" cy="553998"/>
           </a:xfrm>
           <a:prstGeom prst="rect">
             <a:avLst/>
@@ -8682,32 +9218,24 @@
               </a:defRPr>
             </a:pPr>
             <a:r>
-              <a:rPr dirty="0" err="1"/>
-              <a:t>Drie</a:t>
-            </a:r>
-            <a:r>
-              <a:rPr dirty="0"/>
+              <a:rPr lang="en-US" dirty="0" err="1"/>
+              <a:t>Verkennende</a:t>
+            </a:r>
+            <a:r>
+              <a:rPr lang="en-US" dirty="0"/>
               <a:t> </a:t>
             </a:r>
             <a:r>
-              <a:rPr dirty="0" err="1"/>
-              <a:t>assen</a:t>
-            </a:r>
-            <a:r>
-              <a:rPr dirty="0"/>
-              <a:t> om </a:t>
-            </a:r>
-            <a:r>
-              <a:rPr dirty="0" err="1"/>
-              <a:t>te</a:t>
-            </a:r>
-            <a:r>
-              <a:rPr dirty="0"/>
-              <a:t> </a:t>
-            </a:r>
-            <a:r>
-              <a:rPr dirty="0" err="1"/>
-              <a:t>verbeteren</a:t>
+              <a:rPr lang="en-US" dirty="0" err="1"/>
+              <a:t>analyse</a:t>
+            </a:r>
+            <a:r>
+              <a:rPr lang="en-US" dirty="0"/>
+              <a:t> SAM </a:t>
+            </a:r>
+            <a:r>
+              <a:rPr lang="en-US" dirty="0" err="1"/>
+              <a:t>resultaten</a:t>
             </a:r>
             <a:endParaRPr dirty="0"/>
           </a:p>
@@ -8743,7 +9271,7 @@
               </a:defRPr>
             </a:pPr>
             <a:r>
-              <a:t>Uitgangspunt: het model van 19 augustus, resolutie 1, één vaste testset van 1 174 vlakken</a:t>
+              <a:t>Hybride levering: SAM + hoogtemodel · tot 11 meetmomenten · 1 jaar tussen t-punten</a:t>
             </a:r>
           </a:p>
         </p:txBody>
@@ -8757,7 +9285,7 @@
         <p:spPr>
           <a:xfrm>
             <a:off x="548640" y="6400800"/>
-            <a:ext cx="10972800" cy="274320"/>
+            <a:ext cx="2273379" cy="246221"/>
           </a:xfrm>
           <a:prstGeom prst="rect">
             <a:avLst/>
@@ -8780,359 +9308,34 @@
             <a:r>
               <a:t>Oevererosietool · update 26-08-2026 · 5</a:t>
             </a:r>
-          </a:p>
-        </p:txBody>
-      </p:sp>
-      <p:sp>
-        <p:nvSpPr>
-          <p:cNvPr id="5" name="Rectangle 4"/>
-          <p:cNvSpPr/>
+            <a:endParaRPr dirty="0"/>
+          </a:p>
+        </p:txBody>
+      </p:sp>
+      <p:pic>
+        <p:nvPicPr>
+          <p:cNvPr id="5" name="Picture 4" descr="aug-2.png"/>
+          <p:cNvPicPr>
+            <a:picLocks noChangeAspect="1"/>
+          </p:cNvPicPr>
           <p:nvPr/>
-        </p:nvSpPr>
-        <p:spPr>
-          <a:xfrm>
-            <a:off x="548640" y="1645920"/>
-            <a:ext cx="3566160" cy="548640"/>
+        </p:nvPicPr>
+        <p:blipFill>
+          <a:blip r:embed="rId2"/>
+          <a:stretch>
+            <a:fillRect/>
+          </a:stretch>
+        </p:blipFill>
+        <p:spPr>
+          <a:xfrm>
+            <a:off x="1012102" y="1426122"/>
+            <a:ext cx="8845881" cy="4974678"/>
           </a:xfrm>
           <a:prstGeom prst="rect">
             <a:avLst/>
           </a:prstGeom>
-          <a:solidFill>
-            <a:srgbClr val="2BB5A6"/>
-          </a:solidFill>
-          <a:ln>
-            <a:noFill/>
-          </a:ln>
-        </p:spPr>
-        <p:style>
-          <a:lnRef idx="1">
-            <a:schemeClr val="accent1"/>
-          </a:lnRef>
-          <a:fillRef idx="3">
-            <a:schemeClr val="accent1"/>
-          </a:fillRef>
-          <a:effectRef idx="2">
-            <a:schemeClr val="accent1"/>
-          </a:effectRef>
-          <a:fontRef idx="minor">
-            <a:schemeClr val="lt1"/>
-          </a:fontRef>
-        </p:style>
-        <p:txBody>
-          <a:bodyPr rtlCol="0" anchor="ctr"/>
-          <a:lstStyle/>
-          <a:p>
-            <a:pPr algn="ctr">
-              <a:defRPr sz="1800" b="1">
-                <a:solidFill>
-                  <a:srgbClr val="FFFFFF"/>
-                </a:solidFill>
-              </a:defRPr>
-            </a:pPr>
-            <a:r>
-              <a:t>1 · Opschonen</a:t>
-            </a:r>
-          </a:p>
-        </p:txBody>
-      </p:sp>
-      <p:sp>
-        <p:nvSpPr>
-          <p:cNvPr id="6" name="TextBox 5"/>
-          <p:cNvSpPr txBox="1"/>
-          <p:nvPr/>
-        </p:nvSpPr>
-        <p:spPr>
-          <a:xfrm>
-            <a:off x="548640" y="2377440"/>
-            <a:ext cx="3566160" cy="3474720"/>
-          </a:xfrm>
-          <a:prstGeom prst="rect">
-            <a:avLst/>
-          </a:prstGeom>
-          <a:noFill/>
-        </p:spPr>
-        <p:txBody>
-          <a:bodyPr wrap="square">
-            <a:spAutoFit/>
-          </a:bodyPr>
-          <a:lstStyle/>
-          <a:p>
-            <a:pPr>
-              <a:spcAft>
-                <a:spcPts val="600"/>
-              </a:spcAft>
-              <a:defRPr sz="1500" b="0">
-                <a:solidFill>
-                  <a:srgbClr val="1F3A3D"/>
-                </a:solidFill>
-              </a:defRPr>
-            </a:pPr>
-            <a:r>
-              <a:t>• Verkeerde-oever-detecties weghalen zónder de meting weg te gooien</a:t>
-            </a:r>
-          </a:p>
-          <a:p>
-            <a:pPr>
-              <a:spcAft>
-                <a:spcPts val="600"/>
-              </a:spcAft>
-              <a:defRPr sz="1500" b="0">
-                <a:solidFill>
-                  <a:srgbClr val="1F3A3D"/>
-                </a:solidFill>
-              </a:defRPr>
-            </a:pPr>
-            <a:r>
-              <a:t>• Kribben, bruggen, nevengeulen, doolhoven, fragmenten, uitschieters in de tijd</a:t>
-            </a:r>
-          </a:p>
-        </p:txBody>
-      </p:sp>
-      <p:sp>
-        <p:nvSpPr>
-          <p:cNvPr id="7" name="Rectangle 6"/>
-          <p:cNvSpPr/>
-          <p:nvPr/>
-        </p:nvSpPr>
-        <p:spPr>
-          <a:xfrm>
-            <a:off x="4389120" y="1645920"/>
-            <a:ext cx="3566160" cy="548640"/>
-          </a:xfrm>
-          <a:prstGeom prst="rect">
-            <a:avLst/>
-          </a:prstGeom>
-          <a:solidFill>
-            <a:srgbClr val="2BB5A6"/>
-          </a:solidFill>
-          <a:ln>
-            <a:noFill/>
-          </a:ln>
-        </p:spPr>
-        <p:style>
-          <a:lnRef idx="1">
-            <a:schemeClr val="accent1"/>
-          </a:lnRef>
-          <a:fillRef idx="3">
-            <a:schemeClr val="accent1"/>
-          </a:fillRef>
-          <a:effectRef idx="2">
-            <a:schemeClr val="accent1"/>
-          </a:effectRef>
-          <a:fontRef idx="minor">
-            <a:schemeClr val="lt1"/>
-          </a:fontRef>
-        </p:style>
-        <p:txBody>
-          <a:bodyPr rtlCol="0" anchor="ctr"/>
-          <a:lstStyle/>
-          <a:p>
-            <a:pPr algn="ctr">
-              <a:defRPr sz="1800" b="1">
-                <a:solidFill>
-                  <a:srgbClr val="FFFFFF"/>
-                </a:solidFill>
-              </a:defRPr>
-            </a:pPr>
-            <a:r>
-              <a:t>2 · Meerdere t-punten</a:t>
-            </a:r>
-          </a:p>
-        </p:txBody>
-      </p:sp>
-      <p:sp>
-        <p:nvSpPr>
-          <p:cNvPr id="8" name="TextBox 7"/>
-          <p:cNvSpPr txBox="1"/>
-          <p:nvPr/>
-        </p:nvSpPr>
-        <p:spPr>
-          <a:xfrm>
-            <a:off x="4389120" y="2377440"/>
-            <a:ext cx="3566160" cy="3474720"/>
-          </a:xfrm>
-          <a:prstGeom prst="rect">
-            <a:avLst/>
-          </a:prstGeom>
-          <a:noFill/>
-        </p:spPr>
-        <p:txBody>
-          <a:bodyPr wrap="square">
-            <a:spAutoFit/>
-          </a:bodyPr>
-          <a:lstStyle/>
-          <a:p>
-            <a:pPr>
-              <a:spcAft>
-                <a:spcPts val="600"/>
-              </a:spcAft>
-              <a:defRPr sz="1500" b="0">
-                <a:solidFill>
-                  <a:srgbClr val="1F3A3D"/>
-                </a:solidFill>
-              </a:defRPr>
-            </a:pPr>
-            <a:r>
-              <a:t>• Snelheid als trend over álle metingen</a:t>
-            </a:r>
-          </a:p>
-          <a:p>
-            <a:pPr>
-              <a:spcAft>
-                <a:spcPts val="600"/>
-              </a:spcAft>
-              <a:defRPr sz="1500" b="0">
-                <a:solidFill>
-                  <a:srgbClr val="1F3A3D"/>
-                </a:solidFill>
-              </a:defRPr>
-            </a:pPr>
-            <a:r>
-              <a:t>• Versnelling, terugkeer naar gemiddelde, recente helling als feature</a:t>
-            </a:r>
-          </a:p>
-        </p:txBody>
-      </p:sp>
-      <p:sp>
-        <p:nvSpPr>
-          <p:cNvPr id="9" name="Rectangle 8"/>
-          <p:cNvSpPr/>
-          <p:nvPr/>
-        </p:nvSpPr>
-        <p:spPr>
-          <a:xfrm>
-            <a:off x="8229600" y="1645920"/>
-            <a:ext cx="3566160" cy="548640"/>
-          </a:xfrm>
-          <a:prstGeom prst="rect">
-            <a:avLst/>
-          </a:prstGeom>
-          <a:solidFill>
-            <a:srgbClr val="2BB5A6"/>
-          </a:solidFill>
-          <a:ln>
-            <a:noFill/>
-          </a:ln>
-        </p:spPr>
-        <p:style>
-          <a:lnRef idx="1">
-            <a:schemeClr val="accent1"/>
-          </a:lnRef>
-          <a:fillRef idx="3">
-            <a:schemeClr val="accent1"/>
-          </a:fillRef>
-          <a:effectRef idx="2">
-            <a:schemeClr val="accent1"/>
-          </a:effectRef>
-          <a:fontRef idx="minor">
-            <a:schemeClr val="lt1"/>
-          </a:fontRef>
-        </p:style>
-        <p:txBody>
-          <a:bodyPr rtlCol="0" anchor="ctr"/>
-          <a:lstStyle/>
-          <a:p>
-            <a:pPr algn="ctr">
-              <a:defRPr sz="1800" b="1">
-                <a:solidFill>
-                  <a:srgbClr val="FFFFFF"/>
-                </a:solidFill>
-              </a:defRPr>
-            </a:pPr>
-            <a:r>
-              <a:t>3 · Resolutie</a:t>
-            </a:r>
-          </a:p>
-        </p:txBody>
-      </p:sp>
-      <p:sp>
-        <p:nvSpPr>
-          <p:cNvPr id="10" name="TextBox 9"/>
-          <p:cNvSpPr txBox="1"/>
-          <p:nvPr/>
-        </p:nvSpPr>
-        <p:spPr>
-          <a:xfrm>
-            <a:off x="8229600" y="2377440"/>
-            <a:ext cx="3566160" cy="3474720"/>
-          </a:xfrm>
-          <a:prstGeom prst="rect">
-            <a:avLst/>
-          </a:prstGeom>
-          <a:noFill/>
-        </p:spPr>
-        <p:txBody>
-          <a:bodyPr wrap="square">
-            <a:spAutoFit/>
-          </a:bodyPr>
-          <a:lstStyle/>
-          <a:p>
-            <a:pPr>
-              <a:spcAft>
-                <a:spcPts val="600"/>
-              </a:spcAft>
-              <a:defRPr sz="1500" b="0">
-                <a:solidFill>
-                  <a:srgbClr val="1F3A3D"/>
-                </a:solidFill>
-              </a:defRPr>
-            </a:pPr>
-            <a:r>
-              <a:t>• Meerdere segmenten per vlak in plaats van één afstand</a:t>
-            </a:r>
-          </a:p>
-          <a:p>
-            <a:pPr>
-              <a:spcAft>
-                <a:spcPts val="600"/>
-              </a:spcAft>
-              <a:defRPr sz="1500" b="0">
-                <a:solidFill>
-                  <a:srgbClr val="1F3A3D"/>
-                </a:solidFill>
-              </a:defRPr>
-            </a:pPr>
-            <a:r>
-              <a:t>• Gemeten én voorspelde oever als lijn</a:t>
-            </a:r>
-          </a:p>
-        </p:txBody>
-      </p:sp>
-      <p:sp>
-        <p:nvSpPr>
-          <p:cNvPr id="11" name="TextBox 10"/>
-          <p:cNvSpPr txBox="1"/>
-          <p:nvPr/>
-        </p:nvSpPr>
-        <p:spPr>
-          <a:xfrm>
-            <a:off x="548640" y="5577840"/>
-            <a:ext cx="10972800" cy="548640"/>
-          </a:xfrm>
-          <a:prstGeom prst="rect">
-            <a:avLst/>
-          </a:prstGeom>
-          <a:noFill/>
-        </p:spPr>
-        <p:txBody>
-          <a:bodyPr wrap="square">
-            <a:spAutoFit/>
-          </a:bodyPr>
-          <a:lstStyle/>
-          <a:p>
-            <a:pPr>
-              <a:defRPr sz="1300" i="0">
-                <a:solidFill>
-                  <a:srgbClr val="1F3A3D"/>
-                </a:solidFill>
-              </a:defRPr>
-            </a:pPr>
-            <a:r>
-              <a:t>Leeswijzer: op deze vaste testset scoort het model van 19 augustus 3.99 m/jr (4.12 op de eigen split van toen). Alle cijfers hierna zijn op deze set, zodat stappen optelbaar zijn.</a:t>
-            </a:r>
-          </a:p>
-        </p:txBody>
-      </p:sp>
+        </p:spPr>
+      </p:pic>
     </p:spTree>
   </p:cSld>
   <p:clrMapOvr>
@@ -9202,7 +9405,7 @@
         <p:spPr>
           <a:xfrm>
             <a:off x="548640" y="960120"/>
-            <a:ext cx="10972800" cy="548640"/>
+            <a:ext cx="10972800" cy="353943"/>
           </a:xfrm>
           <a:prstGeom prst="rect">
             <a:avLst/>
@@ -9223,7 +9426,52 @@
               </a:defRPr>
             </a:pPr>
             <a:r>
-              <a:t>Vijf terugkerende patronen — elk een 'oever' die geen oever is</a:t>
+              <a:rPr lang="en-US" dirty="0" err="1"/>
+              <a:t>Terugkerende</a:t>
+            </a:r>
+            <a:r>
+              <a:rPr dirty="0"/>
+              <a:t> </a:t>
+            </a:r>
+            <a:r>
+              <a:rPr dirty="0" err="1"/>
+              <a:t>patronen</a:t>
+            </a:r>
+            <a:r>
+              <a:rPr dirty="0"/>
+              <a:t> — elk </a:t>
+            </a:r>
+            <a:r>
+              <a:rPr dirty="0" err="1"/>
+              <a:t>een</a:t>
+            </a:r>
+            <a:r>
+              <a:rPr dirty="0"/>
+              <a:t> '</a:t>
+            </a:r>
+            <a:r>
+              <a:rPr dirty="0" err="1"/>
+              <a:t>oever</a:t>
+            </a:r>
+            <a:r>
+              <a:rPr dirty="0"/>
+              <a:t>' die </a:t>
+            </a:r>
+            <a:r>
+              <a:rPr dirty="0" err="1"/>
+              <a:t>geen</a:t>
+            </a:r>
+            <a:r>
+              <a:rPr dirty="0"/>
+              <a:t> </a:t>
+            </a:r>
+            <a:r>
+              <a:rPr dirty="0" err="1"/>
+              <a:t>oever</a:t>
+            </a:r>
+            <a:r>
+              <a:rPr dirty="0"/>
+              <a:t> is</a:t>
             </a:r>
           </a:p>
         </p:txBody>
@@ -9238,15 +9486,15 @@
         </p:nvPicPr>
         <p:blipFill>
           <a:blip r:embed="rId2"/>
-          <a:srcRect t="20030"/>
+          <a:srcRect t="20030" b="27893"/>
           <a:stretch>
             <a:fillRect/>
           </a:stretch>
         </p:blipFill>
         <p:spPr>
           <a:xfrm>
-            <a:off x="1826239" y="1554480"/>
-            <a:ext cx="8539522" cy="3840480"/>
+            <a:off x="289560" y="1993901"/>
+            <a:ext cx="11612880" cy="3401059"/>
           </a:xfrm>
           <a:prstGeom prst="rect">
             <a:avLst/>
@@ -9604,7 +9852,7 @@
 </file>
 
 <file path=ppt/slides/slide8.xml><?xml version="1.0" encoding="utf-8"?>
-<p:sld xmlns:a="http://schemas.openxmlformats.org/drawingml/2006/main" xmlns:p="http://schemas.openxmlformats.org/presentationml/2006/main" xmlns:r="http://schemas.openxmlformats.org/officeDocument/2006/relationships">
+<p:sld xmlns:a="http://schemas.openxmlformats.org/drawingml/2006/main" xmlns:r="http://schemas.openxmlformats.org/officeDocument/2006/relationships" xmlns:p="http://schemas.openxmlformats.org/presentationml/2006/main">
   <p:cSld>
     <p:spTree>
       <p:nvGrpSpPr>
@@ -9612,7 +9860,14 @@
         <p:cNvGrpSpPr/>
         <p:nvPr/>
       </p:nvGrpSpPr>
-      <p:grpSpPr/>
+      <p:grpSpPr>
+        <a:xfrm>
+          <a:off x="0" y="0"/>
+          <a:ext cx="0" cy="0"/>
+          <a:chOff x="0" y="0"/>
+          <a:chExt cx="0" cy="0"/>
+        </a:xfrm>
+      </p:grpSpPr>
       <p:sp>
         <p:nvSpPr>
           <p:cNvPr id="2" name="TextBox 1"/>
@@ -9834,7 +10089,7 @@
 </file>
 
 <file path=ppt/slides/slide9.xml><?xml version="1.0" encoding="utf-8"?>
-<p:sld xmlns:a="http://schemas.openxmlformats.org/drawingml/2006/main" xmlns:p="http://schemas.openxmlformats.org/presentationml/2006/main" xmlns:r="http://schemas.openxmlformats.org/officeDocument/2006/relationships">
+<p:sld xmlns:a="http://schemas.openxmlformats.org/drawingml/2006/main" xmlns:r="http://schemas.openxmlformats.org/officeDocument/2006/relationships" xmlns:p="http://schemas.openxmlformats.org/presentationml/2006/main">
   <p:cSld>
     <p:spTree>
       <p:nvGrpSpPr>
@@ -9842,7 +10097,14 @@
         <p:cNvGrpSpPr/>
         <p:nvPr/>
       </p:nvGrpSpPr>
-      <p:grpSpPr/>
+      <p:grpSpPr>
+        <a:xfrm>
+          <a:off x="0" y="0"/>
+          <a:ext cx="0" cy="0"/>
+          <a:chOff x="0" y="0"/>
+          <a:chExt cx="0" cy="0"/>
+        </a:xfrm>
+      </p:grpSpPr>
       <p:sp>
         <p:nvSpPr>
           <p:cNvPr id="2" name="TextBox 1"/>
@@ -9873,7 +10135,7 @@
               </a:defRPr>
             </a:pPr>
             <a:r>
-              <a:t>As 1 · Wat doet elke regel alleen?</a:t>
+              <a:t>As 1 · Wat doet elke regel alleen — en alles samen: 3.99 → 2.27</a:t>
             </a:r>
           </a:p>
         </p:txBody>
@@ -9913,24 +10175,142 @@
           </a:p>
         </p:txBody>
       </p:sp>
+      <p:sp>
+        <p:nvSpPr>
+          <p:cNvPr id="5" name="TextBox 4"/>
+          <p:cNvSpPr txBox="1"/>
+          <p:nvPr/>
+        </p:nvSpPr>
+        <p:spPr>
+          <a:xfrm>
+            <a:off x="8961120" y="1554480"/>
+            <a:ext cx="3017520" cy="4572000"/>
+          </a:xfrm>
+          <a:prstGeom prst="rect">
+            <a:avLst/>
+          </a:prstGeom>
+          <a:noFill/>
+        </p:spPr>
+        <p:txBody>
+          <a:bodyPr wrap="square">
+            <a:spAutoFit/>
+          </a:bodyPr>
+          <a:lstStyle/>
+          <a:p>
+            <a:pPr>
+              <a:spcAft>
+                <a:spcPts val="500"/>
+              </a:spcAft>
+              <a:defRPr sz="1200" b="0">
+                <a:solidFill>
+                  <a:srgbClr val="1F3A3D"/>
+                </a:solidFill>
+              </a:defRPr>
+            </a:pPr>
+            <a:r>
+              <a:t>• Grootste winst: uitschieter in de tijd (3.99 → 3.03) — één afwijkende meting vervuilde het hele vlak</a:t>
+            </a:r>
+          </a:p>
+          <a:p>
+            <a:pPr>
+              <a:spcAft>
+                <a:spcPts val="500"/>
+              </a:spcAft>
+              <a:defRPr sz="1200" b="0">
+                <a:solidFill>
+                  <a:srgbClr val="1F3A3D"/>
+                </a:solidFill>
+              </a:defRPr>
+            </a:pPr>
+            <a:r>
+              <a:t>• Doolhof, fragment, kronkelende lijn: elk ≈ −0.3 tot −0.4</a:t>
+            </a:r>
+          </a:p>
+          <a:p>
+            <a:pPr>
+              <a:spcAft>
+                <a:spcPts val="500"/>
+              </a:spcAft>
+              <a:defRPr sz="1200" b="0">
+                <a:solidFill>
+                  <a:srgbClr val="1F3A3D"/>
+                </a:solidFill>
+              </a:defRPr>
+            </a:pPr>
+            <a:r>
+              <a:t>• Kribben &amp; kunstwerken landelijk: 3.89 / 8.52 — geen foutwinst, wél 10 % minder vlakken: het masker haalt alleen de lijnen het dichtst bij de hartlijn weg, en rond kribben blijft geen vlak over om te voorspellen</a:t>
+            </a:r>
+          </a:p>
+          <a:p>
+            <a:pPr>
+              <a:spcAft>
+                <a:spcPts val="500"/>
+              </a:spcAft>
+              <a:defRPr sz="1200" b="0">
+                <a:solidFill>
+                  <a:srgbClr val="1F3A3D"/>
+                </a:solidFill>
+              </a:defRPr>
+            </a:pPr>
+            <a:r>
+              <a:t>• Samen: 2.27 / 4.54 bij dekking 0.94 — meer dan de som van de delen</a:t>
+            </a:r>
+          </a:p>
+        </p:txBody>
+      </p:sp>
+      <p:sp>
+        <p:nvSpPr>
+          <p:cNvPr id="6" name="TextBox 5"/>
+          <p:cNvSpPr txBox="1"/>
+          <p:nvPr/>
+        </p:nvSpPr>
+        <p:spPr>
+          <a:xfrm>
+            <a:off x="548640" y="6400800"/>
+            <a:ext cx="10972800" cy="274320"/>
+          </a:xfrm>
+          <a:prstGeom prst="rect">
+            <a:avLst/>
+          </a:prstGeom>
+          <a:noFill/>
+        </p:spPr>
+        <p:txBody>
+          <a:bodyPr wrap="square">
+            <a:spAutoFit/>
+          </a:bodyPr>
+          <a:lstStyle/>
+          <a:p>
+            <a:pPr>
+              <a:defRPr sz="1000" b="0" i="0">
+                <a:solidFill>
+                  <a:srgbClr val="6B7778"/>
+                </a:solidFill>
+              </a:defRPr>
+            </a:pPr>
+            <a:r>
+              <a:t>Oevererosietool · update 26-08-2026 · 9</a:t>
+            </a:r>
+          </a:p>
+        </p:txBody>
+      </p:sp>
       <p:pic>
         <p:nvPicPr>
-          <p:cNvPr id="4" name="Picture 3" descr="rule_ablation.png"/>
+          <p:cNvPr id="7" name="Picture 6" descr="rule_ablation.png"/>
           <p:cNvPicPr>
             <a:picLocks noChangeAspect="1"/>
           </p:cNvPicPr>
           <p:nvPr/>
         </p:nvPicPr>
         <p:blipFill>
-          <a:blip r:embed="rId2"/>
+          <a:blip r:embed="rId3"/>
           <a:stretch>
             <a:fillRect/>
           </a:stretch>
         </p:blipFill>
         <p:spPr>
           <a:xfrm>
-            <a:off x="365760" y="1554480"/>
-            <a:ext cx="7863840" cy="3431494"/>
+            <a:off x="365760" y="1463040"/>
+            <a:ext cx="8412480" cy="3364992"/>
           </a:xfrm>
           <a:prstGeom prst="rect">
             <a:avLst/>
@@ -9939,14 +10319,14 @@
       </p:pic>
       <p:sp>
         <p:nvSpPr>
-          <p:cNvPr id="5" name="TextBox 4"/>
+          <p:cNvPr id="8" name="TextBox 7"/>
           <p:cNvSpPr txBox="1"/>
           <p:nvPr/>
         </p:nvSpPr>
         <p:spPr>
           <a:xfrm>
-            <a:off x="8503920" y="1645920"/>
-            <a:ext cx="3474720" cy="4572000"/>
+            <a:off x="365760" y="5577840"/>
+            <a:ext cx="8412480" cy="731520"/>
           </a:xfrm>
           <a:prstGeom prst="rect">
             <a:avLst/>
@@ -9960,97 +10340,14 @@
           <a:lstStyle/>
           <a:p>
             <a:pPr>
-              <a:spcAft>
-                <a:spcPts val="500"/>
-              </a:spcAft>
-              <a:defRPr sz="1300">
-                <a:solidFill>
-                  <a:srgbClr val="1F3A3D"/>
-                </a:solidFill>
-              </a:defRPr>
-            </a:pPr>
-            <a:r>
-              <a:t>• Grootste winst: de uitschieter in de tijd (3.99 → 3.03) — één afwijkende meting vervuilde het hele vlak</a:t>
-            </a:r>
-          </a:p>
-          <a:p>
-            <a:pPr>
-              <a:spcAft>
-                <a:spcPts val="500"/>
-              </a:spcAft>
-              <a:defRPr sz="1300">
-                <a:solidFill>
-                  <a:srgbClr val="1F3A3D"/>
-                </a:solidFill>
-              </a:defRPr>
-            </a:pPr>
-            <a:r>
-              <a:t>• Doolhof, fragment en kronkelende lijn elk ≈ −0.3 tot −0.4</a:t>
-            </a:r>
-          </a:p>
-          <a:p>
-            <a:pPr>
-              <a:spcAft>
-                <a:spcPts val="500"/>
-              </a:spcAft>
-              <a:defRPr sz="1300">
-                <a:solidFill>
-                  <a:srgbClr val="1F3A3D"/>
-                </a:solidFill>
-              </a:defRPr>
-            </a:pPr>
-            <a:r>
-              <a:t>• Verkeerde oever en te weinig punten alleen: nauwelijks — ze werken pas in combinatie</a:t>
-            </a:r>
-          </a:p>
-          <a:p>
-            <a:pPr>
-              <a:spcAft>
-                <a:spcPts val="500"/>
-              </a:spcAft>
-              <a:defRPr sz="1300">
-                <a:solidFill>
-                  <a:srgbClr val="1F3A3D"/>
-                </a:solidFill>
-              </a:defRPr>
-            </a:pPr>
-            <a:r>
-              <a:t>• Samen: 2.27 — meer dan de som van de delen, omdat de regels elkaars ruis wegnemen</a:t>
-            </a:r>
-          </a:p>
-        </p:txBody>
-      </p:sp>
-      <p:sp>
-        <p:nvSpPr>
-          <p:cNvPr id="6" name="TextBox 5"/>
-          <p:cNvSpPr txBox="1"/>
-          <p:nvPr/>
-        </p:nvSpPr>
-        <p:spPr>
-          <a:xfrm>
-            <a:off x="548640" y="6400800"/>
-            <a:ext cx="10972800" cy="274320"/>
-          </a:xfrm>
-          <a:prstGeom prst="rect">
-            <a:avLst/>
-          </a:prstGeom>
-          <a:noFill/>
-        </p:spPr>
-        <p:txBody>
-          <a:bodyPr wrap="square">
-            <a:spAutoFit/>
-          </a:bodyPr>
-          <a:lstStyle/>
-          <a:p>
-            <a:pPr>
-              <a:defRPr sz="1000" b="0" i="0">
+              <a:defRPr sz="1000" i="1">
                 <a:solidFill>
                   <a:srgbClr val="6B7778"/>
                 </a:solidFill>
               </a:defRPr>
             </a:pPr>
             <a:r>
-              <a:t>Oevererosietool · update 26-08-2026 · 9</a:t>
+              <a:t>Leeswijzer: 4.12 was de score van het 19 aug-model op zijn eigen willekeurige splitsing; op de bevroren testset van 1 174 vlakken scoort datzelfde model 3.99. Alle stappen in As 1–3 zijn op deze vaste set gemeten.</a:t>
             </a:r>
           </a:p>
         </p:txBody>

</xml_diff>

<commit_message>
docs(presentation): ablation chart stacked layout
</commit_message>
<xml_diff>
--- a/docs/presentations/20260826_update_v2.pptx
+++ b/docs/presentations/20260826_update_v2.pptx
@@ -3763,6 +3763,303 @@
 </p:sld>
 </file>
 
+<file path=ppt/slides/slide10.xml><?xml version="1.0" encoding="utf-8"?>
+<p:sld xmlns:a="http://schemas.openxmlformats.org/drawingml/2006/main" xmlns:r="http://schemas.openxmlformats.org/officeDocument/2006/relationships" xmlns:p="http://schemas.openxmlformats.org/presentationml/2006/main">
+  <p:cSld>
+    <p:spTree>
+      <p:nvGrpSpPr>
+        <p:cNvPr id="1" name=""/>
+        <p:cNvGrpSpPr/>
+        <p:nvPr/>
+      </p:nvGrpSpPr>
+      <p:grpSpPr>
+        <a:xfrm>
+          <a:off x="0" y="0"/>
+          <a:ext cx="0" cy="0"/>
+          <a:chOff x="0" y="0"/>
+          <a:chExt cx="0" cy="0"/>
+        </a:xfrm>
+      </p:grpSpPr>
+      <p:sp>
+        <p:nvSpPr>
+          <p:cNvPr id="2" name="TextBox 1"/>
+          <p:cNvSpPr txBox="1"/>
+          <p:nvPr/>
+        </p:nvSpPr>
+        <p:spPr>
+          <a:xfrm>
+            <a:off x="548640" y="320040"/>
+            <a:ext cx="10972800" cy="731520"/>
+          </a:xfrm>
+          <a:prstGeom prst="rect">
+            <a:avLst/>
+          </a:prstGeom>
+          <a:noFill/>
+        </p:spPr>
+        <p:txBody>
+          <a:bodyPr wrap="none">
+            <a:spAutoFit/>
+          </a:bodyPr>
+          <a:lstStyle/>
+          <a:p>
+            <a:pPr>
+              <a:defRPr sz="3000" b="1">
+                <a:solidFill>
+                  <a:srgbClr val="2BB5A6"/>
+                </a:solidFill>
+              </a:defRPr>
+            </a:pPr>
+            <a:r>
+              <a:t>As 2 · Meerdere t-punten: als feature én als meetlat</a:t>
+            </a:r>
+          </a:p>
+        </p:txBody>
+      </p:sp>
+      <p:sp>
+        <p:nvSpPr>
+          <p:cNvPr id="3" name="TextBox 2"/>
+          <p:cNvSpPr txBox="1"/>
+          <p:nvPr/>
+        </p:nvSpPr>
+        <p:spPr>
+          <a:xfrm>
+            <a:off x="548640" y="960120"/>
+            <a:ext cx="10972800" cy="548640"/>
+          </a:xfrm>
+          <a:prstGeom prst="rect">
+            <a:avLst/>
+          </a:prstGeom>
+          <a:noFill/>
+        </p:spPr>
+        <p:txBody>
+          <a:bodyPr wrap="none">
+            <a:spAutoFit/>
+          </a:bodyPr>
+          <a:lstStyle/>
+          <a:p>
+            <a:pPr>
+              <a:defRPr sz="1700">
+                <a:solidFill>
+                  <a:srgbClr val="1F3A3D"/>
+                </a:solidFill>
+              </a:defRPr>
+            </a:pPr>
+            <a:r>
+              <a:t>2a · de hele meetreeks als feature: 2.27 → 2.13   ·   2b · paren ≥ 2 jaar als meetlat: 1.37</a:t>
+            </a:r>
+          </a:p>
+        </p:txBody>
+      </p:sp>
+      <p:sp>
+        <p:nvSpPr>
+          <p:cNvPr id="4" name="TextBox 3"/>
+          <p:cNvSpPr txBox="1"/>
+          <p:nvPr/>
+        </p:nvSpPr>
+        <p:spPr>
+          <a:xfrm>
+            <a:off x="548640" y="6400800"/>
+            <a:ext cx="10972800" cy="274320"/>
+          </a:xfrm>
+          <a:prstGeom prst="rect">
+            <a:avLst/>
+          </a:prstGeom>
+          <a:noFill/>
+        </p:spPr>
+        <p:txBody>
+          <a:bodyPr wrap="none">
+            <a:spAutoFit/>
+          </a:bodyPr>
+          <a:lstStyle/>
+          <a:p>
+            <a:pPr>
+              <a:defRPr sz="1000">
+                <a:solidFill>
+                  <a:srgbClr val="6B7778"/>
+                </a:solidFill>
+              </a:defRPr>
+            </a:pPr>
+            <a:r>
+              <a:t>Oevererosietool · update 26-08-2026 · 10</a:t>
+            </a:r>
+          </a:p>
+        </p:txBody>
+      </p:sp>
+      <p:sp>
+        <p:nvSpPr>
+          <p:cNvPr id="6" name="TextBox 5"/>
+          <p:cNvSpPr txBox="1"/>
+          <p:nvPr/>
+        </p:nvSpPr>
+        <p:spPr>
+          <a:xfrm>
+            <a:off x="7498079" y="1554480"/>
+            <a:ext cx="4480560" cy="4754880"/>
+          </a:xfrm>
+          <a:prstGeom prst="rect">
+            <a:avLst/>
+          </a:prstGeom>
+          <a:noFill/>
+        </p:spPr>
+        <p:txBody>
+          <a:bodyPr wrap="square">
+            <a:spAutoFit/>
+          </a:bodyPr>
+          <a:lstStyle/>
+          <a:p>
+            <a:pPr>
+              <a:spcAft>
+                <a:spcPts val="400"/>
+              </a:spcAft>
+              <a:defRPr sz="1200" b="1">
+                <a:solidFill>
+                  <a:srgbClr val="1F3A3D"/>
+                </a:solidFill>
+              </a:defRPr>
+            </a:pPr>
+            <a:r>
+              <a:t>2a · Features uit de hele meetreeks</a:t>
+            </a:r>
+          </a:p>
+          <a:p>
+            <a:pPr>
+              <a:spcAft>
+                <a:spcPts val="400"/>
+              </a:spcAft>
+              <a:defRPr sz="1200" b="0">
+                <a:solidFill>
+                  <a:srgbClr val="1F3A3D"/>
+                </a:solidFill>
+              </a:defRPr>
+            </a:pPr>
+            <a:r>
+              <a:t>• Trend (Theil–Sen), spreiding om de trend, versnelling, terugkeer naar gemiddelde, recente helling — zelfde doel, zelfde split: 2.27 → 2.13</a:t>
+            </a:r>
+          </a:p>
+          <a:p>
+            <a:pPr>
+              <a:spcAft>
+                <a:spcPts val="400"/>
+              </a:spcAft>
+              <a:defRPr sz="1200" b="1">
+                <a:solidFill>
+                  <a:srgbClr val="1F3A3D"/>
+                </a:solidFill>
+              </a:defRPr>
+            </a:pPr>
+            <a:r>
+              <a:t>2b · Paren ≥ 2 jaar als meetlat</a:t>
+            </a:r>
+          </a:p>
+          <a:p>
+            <a:pPr>
+              <a:spcAft>
+                <a:spcPts val="400"/>
+              </a:spcAft>
+              <a:defRPr sz="1200" b="0">
+                <a:solidFill>
+                  <a:srgbClr val="1F3A3D"/>
+                </a:solidFill>
+              </a:defRPr>
+            </a:pPr>
+            <a:r>
+              <a:t>• Hoogtemodel-opnames liggen 3–5 jaar uit elkaar; SAM 1 jaar → dezelfde meetruis ÷ 1 jaar = ruis</a:t>
+            </a:r>
+          </a:p>
+          <a:p>
+            <a:pPr>
+              <a:spcAft>
+                <a:spcPts val="400"/>
+              </a:spcAft>
+              <a:defRPr sz="1200" b="0">
+                <a:solidFill>
+                  <a:srgbClr val="1F3A3D"/>
+                </a:solidFill>
+              </a:defRPr>
+            </a:pPr>
+            <a:r>
+              <a:t>• Zelfde doel (m/jr), alleen paren ≥ 2 jaar, álle paren: 1 vlak met 6 metingen = 10 leervoorbeelden</a:t>
+            </a:r>
+          </a:p>
+          <a:p>
+            <a:pPr>
+              <a:spcAft>
+                <a:spcPts val="400"/>
+              </a:spcAft>
+              <a:defRPr sz="1200" b="0">
+                <a:solidFill>
+                  <a:srgbClr val="1F3A3D"/>
+                </a:solidFill>
+              </a:defRPr>
+            </a:pPr>
+            <a:r>
+              <a:t>• Eerlijk: de naïeve fout zakt mee (2.67 → 1.77); de skill gaat van +20 % naar +23 %. Dit is 'meten wat we kunnen voorspellen', geen 35 % beter model</a:t>
+            </a:r>
+          </a:p>
+          <a:p>
+            <a:pPr>
+              <a:spcAft>
+                <a:spcPts val="400"/>
+              </a:spcAft>
+              <a:defRPr sz="1200" b="0">
+                <a:solidFill>
+                  <a:srgbClr val="1F3A3D"/>
+                </a:solidFill>
+              </a:defRPr>
+            </a:pPr>
+            <a:r>
+              <a:t>• Nog niet overal: 715 van 1 174 testvlakken hebben zo'n paar — groeit met elk SAM-jaar</a:t>
+            </a:r>
+          </a:p>
+          <a:p>
+            <a:pPr>
+              <a:spcAft>
+                <a:spcPts val="400"/>
+              </a:spcAft>
+              <a:defRPr sz="1200" b="0">
+                <a:solidFill>
+                  <a:srgbClr val="1F3A3D"/>
+                </a:solidFill>
+              </a:defRPr>
+            </a:pPr>
+            <a:r>
+              <a:t>• Wat niet werkte: losse jaar-op-jaar stappen als doel, huber-loss, debiet</a:t>
+            </a:r>
+          </a:p>
+        </p:txBody>
+      </p:sp>
+      <p:pic>
+        <p:nvPicPr>
+          <p:cNvPr id="7" name="Picture 6" descr="history.png"/>
+          <p:cNvPicPr>
+            <a:picLocks noChangeAspect="1"/>
+          </p:cNvPicPr>
+          <p:nvPr/>
+        </p:nvPicPr>
+        <p:blipFill>
+          <a:blip r:embed="rId2"/>
+          <a:stretch>
+            <a:fillRect/>
+          </a:stretch>
+        </p:blipFill>
+        <p:spPr>
+          <a:xfrm>
+            <a:off x="548640" y="1463040"/>
+            <a:ext cx="6766560" cy="2952681"/>
+          </a:xfrm>
+          <a:prstGeom prst="rect">
+            <a:avLst/>
+          </a:prstGeom>
+        </p:spPr>
+      </p:pic>
+    </p:spTree>
+  </p:cSld>
+  <p:clrMapOvr>
+    <a:masterClrMapping/>
+  </p:clrMapOvr>
+</p:sld>
+</file>
+
 <file path=ppt/slides/slide11.xml><?xml version="1.0" encoding="utf-8"?>
 <p:sld xmlns:a="http://schemas.openxmlformats.org/drawingml/2006/main" xmlns:r="http://schemas.openxmlformats.org/officeDocument/2006/relationships" xmlns:p="http://schemas.openxmlformats.org/presentationml/2006/main">
   <p:cSld>
@@ -3810,7 +4107,7 @@
               </a:defRPr>
             </a:pPr>
             <a:r>
-              <a:t>As 2 · Meerdere t-punten: als feature én als meetlat</a:t>
+              <a:t>As 3 · Resolutie: van scalar naar oeverlijn</a:t>
             </a:r>
           </a:p>
         </p:txBody>
@@ -3845,7 +4142,7 @@
               </a:defRPr>
             </a:pPr>
             <a:r>
-              <a:t>2a · de hele meetreeks als feature: 2.27 → 2.13   ·   2b · paren ≥ 2 jaar als meetlat: 1.37</a:t>
+              <a:t>Eén afstand per vlak verbergt dat 20 m hard erodeert en 80 m stil ligt</a:t>
             </a:r>
           </a:p>
         </p:txBody>
@@ -3880,157 +4177,14 @@
               </a:defRPr>
             </a:pPr>
             <a:r>
-              <a:t>Oevererosietool · update 26-08-2026 · 10</a:t>
-            </a:r>
-          </a:p>
-        </p:txBody>
-      </p:sp>
-      <p:sp>
-        <p:nvSpPr>
-          <p:cNvPr id="6" name="TextBox 5"/>
-          <p:cNvSpPr txBox="1"/>
-          <p:nvPr/>
-        </p:nvSpPr>
-        <p:spPr>
-          <a:xfrm>
-            <a:off x="7498079" y="1554480"/>
-            <a:ext cx="4480560" cy="4754880"/>
-          </a:xfrm>
-          <a:prstGeom prst="rect">
-            <a:avLst/>
-          </a:prstGeom>
-          <a:noFill/>
-        </p:spPr>
-        <p:txBody>
-          <a:bodyPr wrap="square">
-            <a:spAutoFit/>
-          </a:bodyPr>
-          <a:lstStyle/>
-          <a:p>
-            <a:pPr>
-              <a:spcAft>
-                <a:spcPts val="400"/>
-              </a:spcAft>
-              <a:defRPr sz="1200" b="1">
-                <a:solidFill>
-                  <a:srgbClr val="1F3A3D"/>
-                </a:solidFill>
-              </a:defRPr>
-            </a:pPr>
-            <a:r>
-              <a:t>2a · Features uit de hele meetreeks</a:t>
-            </a:r>
-          </a:p>
-          <a:p>
-            <a:pPr>
-              <a:spcAft>
-                <a:spcPts val="400"/>
-              </a:spcAft>
-              <a:defRPr sz="1200" b="0">
-                <a:solidFill>
-                  <a:srgbClr val="1F3A3D"/>
-                </a:solidFill>
-              </a:defRPr>
-            </a:pPr>
-            <a:r>
-              <a:t>• Trend (Theil–Sen), spreiding om de trend, versnelling, terugkeer naar gemiddelde, recente helling — zelfde doel, zelfde split: 2.27 → 2.13</a:t>
-            </a:r>
-          </a:p>
-          <a:p>
-            <a:pPr>
-              <a:spcAft>
-                <a:spcPts val="400"/>
-              </a:spcAft>
-              <a:defRPr sz="1200" b="1">
-                <a:solidFill>
-                  <a:srgbClr val="1F3A3D"/>
-                </a:solidFill>
-              </a:defRPr>
-            </a:pPr>
-            <a:r>
-              <a:t>2b · Paren ≥ 2 jaar als meetlat</a:t>
-            </a:r>
-          </a:p>
-          <a:p>
-            <a:pPr>
-              <a:spcAft>
-                <a:spcPts val="400"/>
-              </a:spcAft>
-              <a:defRPr sz="1200" b="0">
-                <a:solidFill>
-                  <a:srgbClr val="1F3A3D"/>
-                </a:solidFill>
-              </a:defRPr>
-            </a:pPr>
-            <a:r>
-              <a:t>• Hoogtemodel-opnames liggen 3–5 jaar uit elkaar; SAM 1 jaar → dezelfde meetruis ÷ 1 jaar = ruis</a:t>
-            </a:r>
-          </a:p>
-          <a:p>
-            <a:pPr>
-              <a:spcAft>
-                <a:spcPts val="400"/>
-              </a:spcAft>
-              <a:defRPr sz="1200" b="0">
-                <a:solidFill>
-                  <a:srgbClr val="1F3A3D"/>
-                </a:solidFill>
-              </a:defRPr>
-            </a:pPr>
-            <a:r>
-              <a:t>• Zelfde doel (m/jr), alleen paren ≥ 2 jaar, álle paren: 1 vlak met 6 metingen = 10 leervoorbeelden</a:t>
-            </a:r>
-          </a:p>
-          <a:p>
-            <a:pPr>
-              <a:spcAft>
-                <a:spcPts val="400"/>
-              </a:spcAft>
-              <a:defRPr sz="1200" b="0">
-                <a:solidFill>
-                  <a:srgbClr val="1F3A3D"/>
-                </a:solidFill>
-              </a:defRPr>
-            </a:pPr>
-            <a:r>
-              <a:t>• Eerlijk: de naïeve fout zakt mee (2.67 → 1.77); de skill gaat van +20 % naar +23 %. Dit is 'meten wat we kunnen voorspellen', geen 35 % beter model</a:t>
-            </a:r>
-          </a:p>
-          <a:p>
-            <a:pPr>
-              <a:spcAft>
-                <a:spcPts val="400"/>
-              </a:spcAft>
-              <a:defRPr sz="1200" b="0">
-                <a:solidFill>
-                  <a:srgbClr val="1F3A3D"/>
-                </a:solidFill>
-              </a:defRPr>
-            </a:pPr>
-            <a:r>
-              <a:t>• Nog niet overal: 715 van 1 174 testvlakken hebben zo'n paar — groeit met elk SAM-jaar</a:t>
-            </a:r>
-          </a:p>
-          <a:p>
-            <a:pPr>
-              <a:spcAft>
-                <a:spcPts val="400"/>
-              </a:spcAft>
-              <a:defRPr sz="1200" b="0">
-                <a:solidFill>
-                  <a:srgbClr val="1F3A3D"/>
-                </a:solidFill>
-              </a:defRPr>
-            </a:pPr>
-            <a:r>
-              <a:t>• Wat niet werkte: losse jaar-op-jaar stappen als doel, huber-loss, debiet</a:t>
+              <a:t>Oevererosietool · update 26-08-2026 · 11</a:t>
             </a:r>
           </a:p>
         </p:txBody>
       </p:sp>
       <p:pic>
         <p:nvPicPr>
-          <p:cNvPr id="7" name="Picture 6" descr="history.png"/>
+          <p:cNvPr id="5" name="Picture 4" descr="maas3_r_8930_8940.png"/>
           <p:cNvPicPr>
             <a:picLocks noChangeAspect="1"/>
           </p:cNvPicPr>
@@ -4045,13 +4199,171 @@
         <p:spPr>
           <a:xfrm>
             <a:off x="548640" y="1463040"/>
-            <a:ext cx="6766560" cy="2952681"/>
+            <a:ext cx="6216996" cy="4846320"/>
           </a:xfrm>
           <a:prstGeom prst="rect">
             <a:avLst/>
           </a:prstGeom>
         </p:spPr>
       </p:pic>
+      <p:sp>
+        <p:nvSpPr>
+          <p:cNvPr id="6" name="TextBox 5"/>
+          <p:cNvSpPr txBox="1"/>
+          <p:nvPr/>
+        </p:nvSpPr>
+        <p:spPr>
+          <a:xfrm>
+            <a:off x="6035040" y="1554480"/>
+            <a:ext cx="5943600" cy="4754880"/>
+          </a:xfrm>
+          <a:prstGeom prst="rect">
+            <a:avLst/>
+          </a:prstGeom>
+          <a:noFill/>
+        </p:spPr>
+        <p:txBody>
+          <a:bodyPr wrap="square">
+            <a:spAutoFit/>
+          </a:bodyPr>
+          <a:lstStyle/>
+          <a:p>
+            <a:pPr>
+              <a:spcAft>
+                <a:spcPts val="400"/>
+              </a:spcAft>
+              <a:defRPr sz="1300" b="1">
+                <a:solidFill>
+                  <a:srgbClr val="1F3A3D"/>
+                </a:solidFill>
+              </a:defRPr>
+            </a:pPr>
+            <a:r>
+              <a:t>Wat je ziet</a:t>
+            </a:r>
+          </a:p>
+          <a:p>
+            <a:pPr>
+              <a:spcAft>
+                <a:spcPts val="400"/>
+              </a:spcAft>
+              <a:defRPr sz="1300" b="0">
+                <a:solidFill>
+                  <a:srgbClr val="1F3A3D"/>
+                </a:solidFill>
+              </a:defRPr>
+            </a:pPr>
+            <a:r>
+              <a:t>• groen = gemeten oever per segment (2026) · bruin = voorspeld 2027 per segment</a:t>
+            </a:r>
+          </a:p>
+          <a:p>
+            <a:pPr>
+              <a:spcAft>
+                <a:spcPts val="400"/>
+              </a:spcAft>
+              <a:defRPr sz="1300" b="0">
+                <a:solidFill>
+                  <a:srgbClr val="1F3A3D"/>
+                </a:solidFill>
+              </a:defRPr>
+            </a:pPr>
+            <a:r>
+              <a:t>• gestippeld = de oude voorspelling: één getal voor het hele vlak</a:t>
+            </a:r>
+          </a:p>
+          <a:p>
+            <a:pPr>
+              <a:spcAft>
+                <a:spcPts val="400"/>
+              </a:spcAft>
+              <a:defRPr sz="1300" b="0">
+                <a:solidFill>
+                  <a:srgbClr val="1F3A3D"/>
+                </a:solidFill>
+              </a:defRPr>
+            </a:pPr>
+            <a:r>
+              <a:t>• paars = VVR / signaleringslijn</a:t>
+            </a:r>
+          </a:p>
+          <a:p>
+            <a:pPr>
+              <a:spcAft>
+                <a:spcPts val="400"/>
+              </a:spcAft>
+              <a:defRPr sz="1300" b="1">
+                <a:solidFill>
+                  <a:srgbClr val="1F3A3D"/>
+                </a:solidFill>
+              </a:defRPr>
+            </a:pPr>
+            <a:r>
+              <a:t>Dit vlak</a:t>
+            </a:r>
+          </a:p>
+          <a:p>
+            <a:pPr>
+              <a:spcAft>
+                <a:spcPts val="400"/>
+              </a:spcAft>
+              <a:defRPr sz="1300" b="0">
+                <a:solidFill>
+                  <a:srgbClr val="1F3A3D"/>
+                </a:solidFill>
+              </a:defRPr>
+            </a:pPr>
+            <a:r>
+              <a:t>• Eén getal zegt −9.7 m/jr; de vijf segmenten lopen van −17.1 tot +1.4 (voorbeeld op R = 5; gekozen resolutie R = 10)</a:t>
+            </a:r>
+          </a:p>
+          <a:p>
+            <a:pPr>
+              <a:spcAft>
+                <a:spcPts val="400"/>
+              </a:spcAft>
+              <a:defRPr sz="1300" b="0">
+                <a:solidFill>
+                  <a:srgbClr val="1F3A3D"/>
+                </a:solidFill>
+              </a:defRPr>
+            </a:pPr>
+            <a:r>
+              <a:t>• Het bovenste segment nadert de VVR; de rest niet — het alarm hoort per segment te kijken</a:t>
+            </a:r>
+          </a:p>
+          <a:p>
+            <a:pPr>
+              <a:spcAft>
+                <a:spcPts val="400"/>
+              </a:spcAft>
+              <a:defRPr sz="1300" b="1">
+                <a:solidFill>
+                  <a:srgbClr val="1F3A3D"/>
+                </a:solidFill>
+              </a:defRPr>
+            </a:pPr>
+            <a:r>
+              <a:t>Vandaag</a:t>
+            </a:r>
+          </a:p>
+          <a:p>
+            <a:pPr>
+              <a:spcAft>
+                <a:spcPts val="400"/>
+              </a:spcAft>
+              <a:defRPr sz="1300" b="0">
+                <a:solidFill>
+                  <a:srgbClr val="1F3A3D"/>
+                </a:solidFill>
+              </a:defRPr>
+            </a:pPr>
+            <a:r>
+              <a:t>• VVR-jaar = één drempel per vlak (het verst gelegen punt van de signaleringslijn) tegen één scalar → per definitie laat</a:t>
+            </a:r>
+          </a:p>
+        </p:txBody>
+      </p:sp>
     </p:spTree>
   </p:cSld>
   <p:clrMapOvr>
@@ -4107,7 +4419,7 @@
               </a:defRPr>
             </a:pPr>
             <a:r>
-              <a:t>As 3 · Resolutie: van scalar naar oeverlijn</a:t>
+              <a:t>As 3 · Hoe fijn kan het?</a:t>
             </a:r>
           </a:p>
         </p:txBody>
@@ -4142,7 +4454,7 @@
               </a:defRPr>
             </a:pPr>
             <a:r>
-              <a:t>Eén afstand per vlak verbergt dat 20 m hard erodeert en 80 m stil ligt</a:t>
+              <a:t>Zelfde vlak, R = 1 … 100 · en de fout per segment op de As 2-meetlat (paren ≥ 2 jaar), per R</a:t>
             </a:r>
           </a:p>
         </p:txBody>
@@ -4177,7 +4489,7 @@
               </a:defRPr>
             </a:pPr>
             <a:r>
-              <a:t>Oevererosietool · update 26-08-2026 · 11</a:t>
+              <a:t>Oevererosietool · update 26-08-2026 · 12</a:t>
             </a:r>
           </a:p>
         </p:txBody>
@@ -4198,8 +4510,8 @@
         </p:blipFill>
         <p:spPr>
           <a:xfrm>
-            <a:off x="548640" y="1463040"/>
-            <a:ext cx="6216996" cy="4846320"/>
+            <a:off x="548640" y="1371600"/>
+            <a:ext cx="5760720" cy="3280921"/>
           </a:xfrm>
           <a:prstGeom prst="rect">
             <a:avLst/>
@@ -4208,14 +4520,14 @@
       </p:pic>
       <p:sp>
         <p:nvSpPr>
-          <p:cNvPr id="6" name="TextBox 5"/>
+          <p:cNvPr id="7" name="TextBox 6"/>
           <p:cNvSpPr txBox="1"/>
           <p:nvPr/>
         </p:nvSpPr>
         <p:spPr>
           <a:xfrm>
-            <a:off x="6035040" y="1554480"/>
-            <a:ext cx="5943600" cy="4754880"/>
+            <a:off x="548640" y="4754880"/>
+            <a:ext cx="11430000" cy="1645920"/>
           </a:xfrm>
           <a:prstGeom prst="rect">
             <a:avLst/>
@@ -4232,14 +4544,14 @@
               <a:spcAft>
                 <a:spcPts val="400"/>
               </a:spcAft>
-              <a:defRPr sz="1300" b="1">
+              <a:defRPr sz="1200" b="0">
                 <a:solidFill>
                   <a:srgbClr val="1F3A3D"/>
                 </a:solidFill>
               </a:defRPr>
             </a:pPr>
             <a:r>
-              <a:t>Wat je ziet</a:t>
+              <a:t>• De segment-representatie (bruin) volgt de gemeten oever vanaf R ≈ 5–10; bij R = 50–100 raken segmenten leeg (rood)</a:t>
             </a:r>
           </a:p>
           <a:p>
@@ -4247,14 +4559,14 @@
               <a:spcAft>
                 <a:spcPts val="400"/>
               </a:spcAft>
-              <a:defRPr sz="1300" b="0">
+              <a:defRPr sz="1200" b="0">
                 <a:solidFill>
                   <a:srgbClr val="1F3A3D"/>
                 </a:solidFill>
               </a:defRPr>
             </a:pPr>
             <a:r>
-              <a:t>• groen = gemeten oever per segment (2026) · bruin = voorspeld 2027 per segment</a:t>
+              <a:t>• Fout per segment daalt van 1.37 (R = 1) naar 1.03 (R = 10) en 0.85 (R = 20) — maar de naïeve fout zakt mee: de skill piekt bij R = 10 (+30 %) en bij R = 20 heeft 31 % van de segment-datums geen meting</a:t>
             </a:r>
           </a:p>
           <a:p>
@@ -4262,108 +4574,55 @@
               <a:spcAft>
                 <a:spcPts val="400"/>
               </a:spcAft>
-              <a:defRPr sz="1300" b="0">
+              <a:defRPr sz="1200" b="0">
                 <a:solidFill>
                   <a:srgbClr val="1F3A3D"/>
                 </a:solidFill>
               </a:defRPr>
             </a:pPr>
             <a:r>
-              <a:t>• gestippeld = de oude voorspelling: één getal voor het hele vlak</a:t>
+              <a:t>• Keuze: R = 10 (≈ 10 m). Fijner is alleen een gladdere meetlat, geen beter model — tot de lijnbemonstering (60 punten per lijn) verdicht wordt</a:t>
             </a:r>
           </a:p>
           <a:p>
             <a:pPr>
               <a:spcAft>
-                <a:spcPts val="400"/>
+                <a:spcPts val="300"/>
               </a:spcAft>
-              <a:defRPr sz="1300" b="0">
+              <a:defRPr sz="1200" b="0">
                 <a:solidFill>
                   <a:srgbClr val="1F3A3D"/>
                 </a:solidFill>
               </a:defRPr>
             </a:pPr>
-            <a:r>
-              <a:t>• paars = VVR / signaleringslijn</a:t>
-            </a:r>
-          </a:p>
-          <a:p>
-            <a:pPr>
-              <a:spcAft>
-                <a:spcPts val="400"/>
-              </a:spcAft>
-              <a:defRPr sz="1300" b="1">
-                <a:solidFill>
-                  <a:srgbClr val="1F3A3D"/>
-                </a:solidFill>
-              </a:defRPr>
-            </a:pPr>
-            <a:r>
-              <a:t>Dit vlak</a:t>
-            </a:r>
-          </a:p>
-          <a:p>
-            <a:pPr>
-              <a:spcAft>
-                <a:spcPts val="400"/>
-              </a:spcAft>
-              <a:defRPr sz="1300" b="0">
-                <a:solidFill>
-                  <a:srgbClr val="1F3A3D"/>
-                </a:solidFill>
-              </a:defRPr>
-            </a:pPr>
-            <a:r>
-              <a:t>• Eén getal zegt −9.7 m/jr; de vijf segmenten lopen van −17.1 tot +1.4 (voorbeeld op R = 5; gekozen resolutie R = 10)</a:t>
-            </a:r>
-          </a:p>
-          <a:p>
-            <a:pPr>
-              <a:spcAft>
-                <a:spcPts val="400"/>
-              </a:spcAft>
-              <a:defRPr sz="1300" b="0">
-                <a:solidFill>
-                  <a:srgbClr val="1F3A3D"/>
-                </a:solidFill>
-              </a:defRPr>
-            </a:pPr>
-            <a:r>
-              <a:t>• Het bovenste segment nadert de VVR; de rest niet — het alarm hoort per segment te kijken</a:t>
-            </a:r>
-          </a:p>
-          <a:p>
-            <a:pPr>
-              <a:spcAft>
-                <a:spcPts val="400"/>
-              </a:spcAft>
-              <a:defRPr sz="1300" b="1">
-                <a:solidFill>
-                  <a:srgbClr val="1F3A3D"/>
-                </a:solidFill>
-              </a:defRPr>
-            </a:pPr>
-            <a:r>
-              <a:t>Vandaag</a:t>
-            </a:r>
-          </a:p>
-          <a:p>
-            <a:pPr>
-              <a:spcAft>
-                <a:spcPts val="400"/>
-              </a:spcAft>
-              <a:defRPr sz="1300" b="0">
-                <a:solidFill>
-                  <a:srgbClr val="1F3A3D"/>
-                </a:solidFill>
-              </a:defRPr>
-            </a:pPr>
-            <a:r>
-              <a:t>• VVR-jaar = één drempel per vlak (het verst gelegen punt van de signaleringslijn) tegen één scalar → per definitie laat</a:t>
-            </a:r>
-          </a:p>
-        </p:txBody>
-      </p:sp>
+            <a:endParaRPr/>
+          </a:p>
+        </p:txBody>
+      </p:sp>
+      <p:pic>
+        <p:nvPicPr>
+          <p:cNvPr id="8" name="Picture 7" descr="horizon_sweep.png"/>
+          <p:cNvPicPr>
+            <a:picLocks noChangeAspect="1"/>
+          </p:cNvPicPr>
+          <p:nvPr/>
+        </p:nvPicPr>
+        <p:blipFill>
+          <a:blip r:embed="rId3"/>
+          <a:stretch>
+            <a:fillRect/>
+          </a:stretch>
+        </p:blipFill>
+        <p:spPr>
+          <a:xfrm>
+            <a:off x="6400800" y="1371600"/>
+            <a:ext cx="5577840" cy="2433967"/>
+          </a:xfrm>
+          <a:prstGeom prst="rect">
+            <a:avLst/>
+          </a:prstGeom>
+        </p:spPr>
+      </p:pic>
     </p:spTree>
   </p:cSld>
   <p:clrMapOvr>
@@ -4419,265 +4678,6 @@
               </a:defRPr>
             </a:pPr>
             <a:r>
-              <a:t>As 3 · Hoe fijn kan het?</a:t>
-            </a:r>
-          </a:p>
-        </p:txBody>
-      </p:sp>
-      <p:sp>
-        <p:nvSpPr>
-          <p:cNvPr id="3" name="TextBox 2"/>
-          <p:cNvSpPr txBox="1"/>
-          <p:nvPr/>
-        </p:nvSpPr>
-        <p:spPr>
-          <a:xfrm>
-            <a:off x="548640" y="960120"/>
-            <a:ext cx="10972800" cy="548640"/>
-          </a:xfrm>
-          <a:prstGeom prst="rect">
-            <a:avLst/>
-          </a:prstGeom>
-          <a:noFill/>
-        </p:spPr>
-        <p:txBody>
-          <a:bodyPr wrap="none">
-            <a:spAutoFit/>
-          </a:bodyPr>
-          <a:lstStyle/>
-          <a:p>
-            <a:pPr>
-              <a:defRPr sz="1700">
-                <a:solidFill>
-                  <a:srgbClr val="1F3A3D"/>
-                </a:solidFill>
-              </a:defRPr>
-            </a:pPr>
-            <a:r>
-              <a:t>Zelfde vlak, R = 1 … 100 · en de fout per segment op de As 2-meetlat (paren ≥ 2 jaar), per R</a:t>
-            </a:r>
-          </a:p>
-        </p:txBody>
-      </p:sp>
-      <p:sp>
-        <p:nvSpPr>
-          <p:cNvPr id="4" name="TextBox 3"/>
-          <p:cNvSpPr txBox="1"/>
-          <p:nvPr/>
-        </p:nvSpPr>
-        <p:spPr>
-          <a:xfrm>
-            <a:off x="548640" y="6400800"/>
-            <a:ext cx="10972800" cy="274320"/>
-          </a:xfrm>
-          <a:prstGeom prst="rect">
-            <a:avLst/>
-          </a:prstGeom>
-          <a:noFill/>
-        </p:spPr>
-        <p:txBody>
-          <a:bodyPr wrap="none">
-            <a:spAutoFit/>
-          </a:bodyPr>
-          <a:lstStyle/>
-          <a:p>
-            <a:pPr>
-              <a:defRPr sz="1000">
-                <a:solidFill>
-                  <a:srgbClr val="6B7778"/>
-                </a:solidFill>
-              </a:defRPr>
-            </a:pPr>
-            <a:r>
-              <a:t>Oevererosietool · update 26-08-2026 · 12</a:t>
-            </a:r>
-          </a:p>
-        </p:txBody>
-      </p:sp>
-      <p:pic>
-        <p:nvPicPr>
-          <p:cNvPr id="5" name="Picture 4" descr="maas3_r_8930_8940.png"/>
-          <p:cNvPicPr>
-            <a:picLocks noChangeAspect="1"/>
-          </p:cNvPicPr>
-          <p:nvPr/>
-        </p:nvPicPr>
-        <p:blipFill>
-          <a:blip r:embed="rId2"/>
-          <a:stretch>
-            <a:fillRect/>
-          </a:stretch>
-        </p:blipFill>
-        <p:spPr>
-          <a:xfrm>
-            <a:off x="548640" y="1371600"/>
-            <a:ext cx="5760720" cy="3280921"/>
-          </a:xfrm>
-          <a:prstGeom prst="rect">
-            <a:avLst/>
-          </a:prstGeom>
-        </p:spPr>
-      </p:pic>
-      <p:sp>
-        <p:nvSpPr>
-          <p:cNvPr id="7" name="TextBox 6"/>
-          <p:cNvSpPr txBox="1"/>
-          <p:nvPr/>
-        </p:nvSpPr>
-        <p:spPr>
-          <a:xfrm>
-            <a:off x="548640" y="4754880"/>
-            <a:ext cx="11430000" cy="1645920"/>
-          </a:xfrm>
-          <a:prstGeom prst="rect">
-            <a:avLst/>
-          </a:prstGeom>
-          <a:noFill/>
-        </p:spPr>
-        <p:txBody>
-          <a:bodyPr wrap="square">
-            <a:spAutoFit/>
-          </a:bodyPr>
-          <a:lstStyle/>
-          <a:p>
-            <a:pPr>
-              <a:spcAft>
-                <a:spcPts val="400"/>
-              </a:spcAft>
-              <a:defRPr sz="1200" b="0">
-                <a:solidFill>
-                  <a:srgbClr val="1F3A3D"/>
-                </a:solidFill>
-              </a:defRPr>
-            </a:pPr>
-            <a:r>
-              <a:t>• De segment-representatie (bruin) volgt de gemeten oever vanaf R ≈ 5–10; bij R = 50–100 raken segmenten leeg (rood)</a:t>
-            </a:r>
-          </a:p>
-          <a:p>
-            <a:pPr>
-              <a:spcAft>
-                <a:spcPts val="400"/>
-              </a:spcAft>
-              <a:defRPr sz="1200" b="0">
-                <a:solidFill>
-                  <a:srgbClr val="1F3A3D"/>
-                </a:solidFill>
-              </a:defRPr>
-            </a:pPr>
-            <a:r>
-              <a:t>• Fout per segment daalt van 1.37 (R = 1) naar 1.03 (R = 10) en 0.85 (R = 20) — maar de naïeve fout zakt mee: de skill piekt bij R = 10 (+30 %) en bij R = 20 heeft 31 % van de segment-datums geen meting</a:t>
-            </a:r>
-          </a:p>
-          <a:p>
-            <a:pPr>
-              <a:spcAft>
-                <a:spcPts val="400"/>
-              </a:spcAft>
-              <a:defRPr sz="1200" b="0">
-                <a:solidFill>
-                  <a:srgbClr val="1F3A3D"/>
-                </a:solidFill>
-              </a:defRPr>
-            </a:pPr>
-            <a:r>
-              <a:t>• Keuze: R = 10 (≈ 10 m). Fijner is alleen een gladdere meetlat, geen beter model — tot de lijnbemonstering (60 punten per lijn) verdicht wordt</a:t>
-            </a:r>
-          </a:p>
-          <a:p>
-            <a:pPr>
-              <a:spcAft>
-                <a:spcPts val="300"/>
-              </a:spcAft>
-              <a:defRPr sz="1200" b="0">
-                <a:solidFill>
-                  <a:srgbClr val="1F3A3D"/>
-                </a:solidFill>
-              </a:defRPr>
-            </a:pPr>
-            <a:endParaRPr/>
-          </a:p>
-        </p:txBody>
-      </p:sp>
-      <p:pic>
-        <p:nvPicPr>
-          <p:cNvPr id="8" name="Picture 7" descr="horizon_sweep.png"/>
-          <p:cNvPicPr>
-            <a:picLocks noChangeAspect="1"/>
-          </p:cNvPicPr>
-          <p:nvPr/>
-        </p:nvPicPr>
-        <p:blipFill>
-          <a:blip r:embed="rId3"/>
-          <a:stretch>
-            <a:fillRect/>
-          </a:stretch>
-        </p:blipFill>
-        <p:spPr>
-          <a:xfrm>
-            <a:off x="6400800" y="1371600"/>
-            <a:ext cx="5577840" cy="2433967"/>
-          </a:xfrm>
-          <a:prstGeom prst="rect">
-            <a:avLst/>
-          </a:prstGeom>
-        </p:spPr>
-      </p:pic>
-    </p:spTree>
-  </p:cSld>
-  <p:clrMapOvr>
-    <a:masterClrMapping/>
-  </p:clrMapOvr>
-</p:sld>
-</file>
-
-<file path=ppt/slides/slide14.xml><?xml version="1.0" encoding="utf-8"?>
-<p:sld xmlns:a="http://schemas.openxmlformats.org/drawingml/2006/main" xmlns:r="http://schemas.openxmlformats.org/officeDocument/2006/relationships" xmlns:p="http://schemas.openxmlformats.org/presentationml/2006/main">
-  <p:cSld>
-    <p:spTree>
-      <p:nvGrpSpPr>
-        <p:cNvPr id="1" name=""/>
-        <p:cNvGrpSpPr/>
-        <p:nvPr/>
-      </p:nvGrpSpPr>
-      <p:grpSpPr>
-        <a:xfrm>
-          <a:off x="0" y="0"/>
-          <a:ext cx="0" cy="0"/>
-          <a:chOff x="0" y="0"/>
-          <a:chExt cx="0" cy="0"/>
-        </a:xfrm>
-      </p:grpSpPr>
-      <p:sp>
-        <p:nvSpPr>
-          <p:cNvPr id="2" name="TextBox 1"/>
-          <p:cNvSpPr txBox="1"/>
-          <p:nvPr/>
-        </p:nvSpPr>
-        <p:spPr>
-          <a:xfrm>
-            <a:off x="548640" y="320040"/>
-            <a:ext cx="10972800" cy="731520"/>
-          </a:xfrm>
-          <a:prstGeom prst="rect">
-            <a:avLst/>
-          </a:prstGeom>
-          <a:noFill/>
-        </p:spPr>
-        <p:txBody>
-          <a:bodyPr wrap="none">
-            <a:spAutoFit/>
-          </a:bodyPr>
-          <a:lstStyle/>
-          <a:p>
-            <a:pPr>
-              <a:defRPr sz="3000" b="1">
-                <a:solidFill>
-                  <a:srgbClr val="2BB5A6"/>
-                </a:solidFill>
-              </a:defRPr>
-            </a:pPr>
-            <a:r>
               <a:t>Alles bij elkaar</a:t>
             </a:r>
           </a:p>
@@ -4838,7 +4838,7 @@
 </p:sld>
 </file>
 
-<file path=ppt/slides/slide15.xml><?xml version="1.0" encoding="utf-8"?>
+<file path=ppt/slides/slide14.xml><?xml version="1.0" encoding="utf-8"?>
 <p:sld xmlns:a="http://schemas.openxmlformats.org/drawingml/2006/main" xmlns:r="http://schemas.openxmlformats.org/officeDocument/2006/relationships" xmlns:p="http://schemas.openxmlformats.org/presentationml/2006/main">
   <p:cSld>
     <p:spTree>
@@ -5603,6 +5603,496 @@
 </p:sld>
 </file>
 
+<file path=ppt/slides/slide15.xml><?xml version="1.0" encoding="utf-8"?>
+<p:sld xmlns:a="http://schemas.openxmlformats.org/drawingml/2006/main" xmlns:r="http://schemas.openxmlformats.org/officeDocument/2006/relationships" xmlns:p="http://schemas.openxmlformats.org/presentationml/2006/main">
+  <p:cSld>
+    <p:spTree>
+      <p:nvGrpSpPr>
+        <p:cNvPr id="1" name=""/>
+        <p:cNvGrpSpPr/>
+        <p:nvPr/>
+      </p:nvGrpSpPr>
+      <p:grpSpPr>
+        <a:xfrm>
+          <a:off x="0" y="0"/>
+          <a:ext cx="0" cy="0"/>
+          <a:chOff x="0" y="0"/>
+          <a:chExt cx="0" cy="0"/>
+        </a:xfrm>
+      </p:grpSpPr>
+      <p:sp>
+        <p:nvSpPr>
+          <p:cNvPr id="2" name="TextBox 1"/>
+          <p:cNvSpPr txBox="1"/>
+          <p:nvPr/>
+        </p:nvSpPr>
+        <p:spPr>
+          <a:xfrm>
+            <a:off x="548640" y="320040"/>
+            <a:ext cx="10972800" cy="731520"/>
+          </a:xfrm>
+          <a:prstGeom prst="rect">
+            <a:avLst/>
+          </a:prstGeom>
+          <a:noFill/>
+        </p:spPr>
+        <p:txBody>
+          <a:bodyPr wrap="none">
+            <a:spAutoFit/>
+          </a:bodyPr>
+          <a:lstStyle/>
+          <a:p>
+            <a:pPr>
+              <a:defRPr sz="3000" b="1">
+                <a:solidFill>
+                  <a:srgbClr val="2BB5A6"/>
+                </a:solidFill>
+              </a:defRPr>
+            </a:pPr>
+            <a:r>
+              <a:t>Wat we vragen</a:t>
+            </a:r>
+          </a:p>
+        </p:txBody>
+      </p:sp>
+      <p:sp>
+        <p:nvSpPr>
+          <p:cNvPr id="3" name="TextBox 2"/>
+          <p:cNvSpPr txBox="1"/>
+          <p:nvPr/>
+        </p:nvSpPr>
+        <p:spPr>
+          <a:xfrm>
+            <a:off x="548640" y="960120"/>
+            <a:ext cx="10972800" cy="548640"/>
+          </a:xfrm>
+          <a:prstGeom prst="rect">
+            <a:avLst/>
+          </a:prstGeom>
+          <a:noFill/>
+        </p:spPr>
+        <p:txBody>
+          <a:bodyPr wrap="none">
+            <a:spAutoFit/>
+          </a:bodyPr>
+          <a:lstStyle/>
+          <a:p>
+            <a:pPr>
+              <a:defRPr sz="1700">
+                <a:solidFill>
+                  <a:srgbClr val="1F3A3D"/>
+                </a:solidFill>
+              </a:defRPr>
+            </a:pPr>
+            <a:r>
+              <a:t>Labelen is trial-and-error — geen eenmalige levering</a:t>
+            </a:r>
+          </a:p>
+        </p:txBody>
+      </p:sp>
+      <p:sp>
+        <p:nvSpPr>
+          <p:cNvPr id="4" name="TextBox 3"/>
+          <p:cNvSpPr txBox="1"/>
+          <p:nvPr/>
+        </p:nvSpPr>
+        <p:spPr>
+          <a:xfrm>
+            <a:off x="548640" y="6400800"/>
+            <a:ext cx="10972800" cy="274320"/>
+          </a:xfrm>
+          <a:prstGeom prst="rect">
+            <a:avLst/>
+          </a:prstGeom>
+          <a:noFill/>
+        </p:spPr>
+        <p:txBody>
+          <a:bodyPr wrap="none">
+            <a:spAutoFit/>
+          </a:bodyPr>
+          <a:lstStyle/>
+          <a:p>
+            <a:pPr>
+              <a:defRPr sz="1000">
+                <a:solidFill>
+                  <a:srgbClr val="6B7778"/>
+                </a:solidFill>
+              </a:defRPr>
+            </a:pPr>
+            <a:r>
+              <a:t>Oevererosietool · update 26-08-2026 · 15</a:t>
+            </a:r>
+          </a:p>
+        </p:txBody>
+      </p:sp>
+      <p:sp>
+        <p:nvSpPr>
+          <p:cNvPr id="5" name="Rectangle 4"/>
+          <p:cNvSpPr/>
+          <p:nvPr/>
+        </p:nvSpPr>
+        <p:spPr>
+          <a:xfrm>
+            <a:off x="548640" y="1645920"/>
+            <a:ext cx="3566160" cy="548640"/>
+          </a:xfrm>
+          <a:prstGeom prst="rect">
+            <a:avLst/>
+          </a:prstGeom>
+          <a:solidFill>
+            <a:srgbClr val="2BB5A6"/>
+          </a:solidFill>
+          <a:ln>
+            <a:noFill/>
+          </a:ln>
+        </p:spPr>
+        <p:style>
+          <a:lnRef idx="1">
+            <a:schemeClr val="accent1"/>
+          </a:lnRef>
+          <a:fillRef idx="3">
+            <a:schemeClr val="accent1"/>
+          </a:fillRef>
+          <a:effectRef idx="2">
+            <a:schemeClr val="accent1"/>
+          </a:effectRef>
+          <a:fontRef idx="minor">
+            <a:schemeClr val="lt1"/>
+          </a:fontRef>
+        </p:style>
+        <p:txBody>
+          <a:bodyPr rtlCol="0" anchor="ctr"/>
+          <a:lstStyle/>
+          <a:p>
+            <a:pPr algn="ctr">
+              <a:defRPr sz="1800" b="1">
+                <a:solidFill>
+                  <a:srgbClr val="FFFFFF"/>
+                </a:solidFill>
+              </a:defRPr>
+            </a:pPr>
+            <a:r>
+              <a:t>Hoogtemodel-engineers</a:t>
+            </a:r>
+          </a:p>
+        </p:txBody>
+      </p:sp>
+      <p:sp>
+        <p:nvSpPr>
+          <p:cNvPr id="6" name="TextBox 5"/>
+          <p:cNvSpPr txBox="1"/>
+          <p:nvPr/>
+        </p:nvSpPr>
+        <p:spPr>
+          <a:xfrm>
+            <a:off x="548640" y="2377440"/>
+            <a:ext cx="3566160" cy="3474720"/>
+          </a:xfrm>
+          <a:prstGeom prst="rect">
+            <a:avLst/>
+          </a:prstGeom>
+          <a:noFill/>
+        </p:spPr>
+        <p:txBody>
+          <a:bodyPr wrap="square">
+            <a:spAutoFit/>
+          </a:bodyPr>
+          <a:lstStyle/>
+          <a:p>
+            <a:pPr>
+              <a:spcAft>
+                <a:spcPts val="600"/>
+              </a:spcAft>
+              <a:defRPr sz="1500" b="0">
+                <a:solidFill>
+                  <a:srgbClr val="1F3A3D"/>
+                </a:solidFill>
+              </a:defRPr>
+            </a:pPr>
+            <a:r>
+              <a:t>• De vijfdeling (scope_coverage) meeleveren</a:t>
+            </a:r>
+          </a:p>
+          <a:p>
+            <a:pPr>
+              <a:spcAft>
+                <a:spcPts val="600"/>
+              </a:spcAft>
+              <a:defRPr sz="1500" b="0">
+                <a:solidFill>
+                  <a:srgbClr val="1F3A3D"/>
+                </a:solidFill>
+              </a:defRPr>
+            </a:pPr>
+            <a:r>
+              <a:t>• Per lijn een vlag: 'dit is een constructie / verkeerde oever'</a:t>
+            </a:r>
+          </a:p>
+          <a:p>
+            <a:pPr>
+              <a:spcAft>
+                <a:spcPts val="600"/>
+              </a:spcAft>
+              <a:defRPr sz="1500" b="0">
+                <a:solidFill>
+                  <a:srgbClr val="1F3A3D"/>
+                </a:solidFill>
+              </a:defRPr>
+            </a:pPr>
+            <a:r>
+              <a:t>• Bekende randgevallen: meeroeverig, hoogwater</a:t>
+            </a:r>
+          </a:p>
+        </p:txBody>
+      </p:sp>
+      <p:sp>
+        <p:nvSpPr>
+          <p:cNvPr id="7" name="Rectangle 6"/>
+          <p:cNvSpPr/>
+          <p:nvPr/>
+        </p:nvSpPr>
+        <p:spPr>
+          <a:xfrm>
+            <a:off x="4389120" y="1645920"/>
+            <a:ext cx="3566160" cy="548640"/>
+          </a:xfrm>
+          <a:prstGeom prst="rect">
+            <a:avLst/>
+          </a:prstGeom>
+          <a:solidFill>
+            <a:srgbClr val="2BB5A6"/>
+          </a:solidFill>
+          <a:ln>
+            <a:noFill/>
+          </a:ln>
+        </p:spPr>
+        <p:style>
+          <a:lnRef idx="1">
+            <a:schemeClr val="accent1"/>
+          </a:lnRef>
+          <a:fillRef idx="3">
+            <a:schemeClr val="accent1"/>
+          </a:fillRef>
+          <a:effectRef idx="2">
+            <a:schemeClr val="accent1"/>
+          </a:effectRef>
+          <a:fontRef idx="minor">
+            <a:schemeClr val="lt1"/>
+          </a:fontRef>
+        </p:style>
+        <p:txBody>
+          <a:bodyPr rtlCol="0" anchor="ctr"/>
+          <a:lstStyle/>
+          <a:p>
+            <a:pPr algn="ctr">
+              <a:defRPr sz="1800" b="1">
+                <a:solidFill>
+                  <a:srgbClr val="FFFFFF"/>
+                </a:solidFill>
+              </a:defRPr>
+            </a:pPr>
+            <a:r>
+              <a:t>SAM-engineers</a:t>
+            </a:r>
+          </a:p>
+        </p:txBody>
+      </p:sp>
+      <p:sp>
+        <p:nvSpPr>
+          <p:cNvPr id="8" name="TextBox 7"/>
+          <p:cNvSpPr txBox="1"/>
+          <p:nvPr/>
+        </p:nvSpPr>
+        <p:spPr>
+          <a:xfrm>
+            <a:off x="4389120" y="2377440"/>
+            <a:ext cx="3566160" cy="3474720"/>
+          </a:xfrm>
+          <a:prstGeom prst="rect">
+            <a:avLst/>
+          </a:prstGeom>
+          <a:noFill/>
+        </p:spPr>
+        <p:txBody>
+          <a:bodyPr wrap="square">
+            <a:spAutoFit/>
+          </a:bodyPr>
+          <a:lstStyle/>
+          <a:p>
+            <a:pPr>
+              <a:spcAft>
+                <a:spcPts val="600"/>
+              </a:spcAft>
+              <a:defRPr sz="1500" b="0">
+                <a:solidFill>
+                  <a:srgbClr val="1F3A3D"/>
+                </a:solidFill>
+              </a:defRPr>
+            </a:pPr>
+            <a:r>
+              <a:t>• Kwaliteitsvlag per meting</a:t>
+            </a:r>
+          </a:p>
+          <a:p>
+            <a:pPr>
+              <a:spcAft>
+                <a:spcPts val="600"/>
+              </a:spcAft>
+              <a:defRPr sz="1500" b="0">
+                <a:solidFill>
+                  <a:srgbClr val="1F3A3D"/>
+                </a:solidFill>
+              </a:defRPr>
+            </a:pPr>
+            <a:r>
+              <a:t>• Vooral: méér jaren — elk jaar maakt het model vanzelf beter</a:t>
+            </a:r>
+          </a:p>
+          <a:p>
+            <a:pPr>
+              <a:spcAft>
+                <a:spcPts val="600"/>
+              </a:spcAft>
+              <a:defRPr sz="1500" b="0">
+                <a:solidFill>
+                  <a:srgbClr val="1F3A3D"/>
+                </a:solidFill>
+              </a:defRPr>
+            </a:pPr>
+            <a:r>
+              <a:t>• Waar mogelijk: één lijn per meetmoment</a:t>
+            </a:r>
+          </a:p>
+        </p:txBody>
+      </p:sp>
+      <p:sp>
+        <p:nvSpPr>
+          <p:cNvPr id="9" name="Rectangle 8"/>
+          <p:cNvSpPr/>
+          <p:nvPr/>
+        </p:nvSpPr>
+        <p:spPr>
+          <a:xfrm>
+            <a:off x="8229600" y="1645920"/>
+            <a:ext cx="3566160" cy="548640"/>
+          </a:xfrm>
+          <a:prstGeom prst="rect">
+            <a:avLst/>
+          </a:prstGeom>
+          <a:solidFill>
+            <a:srgbClr val="E07A3F"/>
+          </a:solidFill>
+          <a:ln>
+            <a:noFill/>
+          </a:ln>
+        </p:spPr>
+        <p:style>
+          <a:lnRef idx="1">
+            <a:schemeClr val="accent1"/>
+          </a:lnRef>
+          <a:fillRef idx="3">
+            <a:schemeClr val="accent1"/>
+          </a:fillRef>
+          <a:effectRef idx="2">
+            <a:schemeClr val="accent1"/>
+          </a:effectRef>
+          <a:fontRef idx="minor">
+            <a:schemeClr val="lt1"/>
+          </a:fontRef>
+        </p:style>
+        <p:txBody>
+          <a:bodyPr rtlCol="0" anchor="ctr"/>
+          <a:lstStyle/>
+          <a:p>
+            <a:pPr algn="ctr">
+              <a:defRPr sz="1800" b="1">
+                <a:solidFill>
+                  <a:srgbClr val="FFFFFF"/>
+                </a:solidFill>
+              </a:defRPr>
+            </a:pPr>
+            <a:r>
+              <a:t>Samen</a:t>
+            </a:r>
+          </a:p>
+        </p:txBody>
+      </p:sp>
+      <p:sp>
+        <p:nvSpPr>
+          <p:cNvPr id="10" name="TextBox 9"/>
+          <p:cNvSpPr txBox="1"/>
+          <p:nvPr/>
+        </p:nvSpPr>
+        <p:spPr>
+          <a:xfrm>
+            <a:off x="8229600" y="2377440"/>
+            <a:ext cx="3566160" cy="3474720"/>
+          </a:xfrm>
+          <a:prstGeom prst="rect">
+            <a:avLst/>
+          </a:prstGeom>
+          <a:noFill/>
+        </p:spPr>
+        <p:txBody>
+          <a:bodyPr wrap="square">
+            <a:spAutoFit/>
+          </a:bodyPr>
+          <a:lstStyle/>
+          <a:p>
+            <a:pPr>
+              <a:spcAft>
+                <a:spcPts val="600"/>
+              </a:spcAft>
+              <a:defRPr sz="1500" b="0">
+                <a:solidFill>
+                  <a:srgbClr val="1F3A3D"/>
+                </a:solidFill>
+              </a:defRPr>
+            </a:pPr>
+            <a:r>
+              <a:t>• Labelronde in QGIS: wij leveren de gesorteerde lijst twijfelgevallen, jullie het oordeel</a:t>
+            </a:r>
+          </a:p>
+          <a:p>
+            <a:pPr>
+              <a:spcAft>
+                <a:spcPts val="600"/>
+              </a:spcAft>
+              <a:defRPr sz="1500" b="0">
+                <a:solidFill>
+                  <a:srgbClr val="1F3A3D"/>
+                </a:solidFill>
+              </a:defRPr>
+            </a:pPr>
+            <a:r>
+              <a:t>• Eerste ronde: ~200 vlakken, twee uur</a:t>
+            </a:r>
+          </a:p>
+          <a:p>
+            <a:pPr>
+              <a:spcAft>
+                <a:spcPts val="600"/>
+              </a:spcAft>
+              <a:defRPr sz="1500" b="0">
+                <a:solidFill>
+                  <a:srgbClr val="1F3A3D"/>
+                </a:solidFill>
+              </a:defRPr>
+            </a:pPr>
+            <a:r>
+              <a:t>• Daarna meten we opnieuw</a:t>
+            </a:r>
+          </a:p>
+        </p:txBody>
+      </p:sp>
+    </p:spTree>
+  </p:cSld>
+  <p:clrMapOvr>
+    <a:masterClrMapping/>
+  </p:clrMapOvr>
+</p:sld>
+</file>
+
 <file path=ppt/slides/slide16.xml><?xml version="1.0" encoding="utf-8"?>
 <p:sld xmlns:a="http://schemas.openxmlformats.org/drawingml/2006/main" xmlns:r="http://schemas.openxmlformats.org/officeDocument/2006/relationships" xmlns:p="http://schemas.openxmlformats.org/presentationml/2006/main">
   <p:cSld>
@@ -5650,496 +6140,6 @@
               </a:defRPr>
             </a:pPr>
             <a:r>
-              <a:t>Wat we vragen</a:t>
-            </a:r>
-          </a:p>
-        </p:txBody>
-      </p:sp>
-      <p:sp>
-        <p:nvSpPr>
-          <p:cNvPr id="3" name="TextBox 2"/>
-          <p:cNvSpPr txBox="1"/>
-          <p:nvPr/>
-        </p:nvSpPr>
-        <p:spPr>
-          <a:xfrm>
-            <a:off x="548640" y="960120"/>
-            <a:ext cx="10972800" cy="548640"/>
-          </a:xfrm>
-          <a:prstGeom prst="rect">
-            <a:avLst/>
-          </a:prstGeom>
-          <a:noFill/>
-        </p:spPr>
-        <p:txBody>
-          <a:bodyPr wrap="none">
-            <a:spAutoFit/>
-          </a:bodyPr>
-          <a:lstStyle/>
-          <a:p>
-            <a:pPr>
-              <a:defRPr sz="1700">
-                <a:solidFill>
-                  <a:srgbClr val="1F3A3D"/>
-                </a:solidFill>
-              </a:defRPr>
-            </a:pPr>
-            <a:r>
-              <a:t>Labelen is trial-and-error — geen eenmalige levering</a:t>
-            </a:r>
-          </a:p>
-        </p:txBody>
-      </p:sp>
-      <p:sp>
-        <p:nvSpPr>
-          <p:cNvPr id="4" name="TextBox 3"/>
-          <p:cNvSpPr txBox="1"/>
-          <p:nvPr/>
-        </p:nvSpPr>
-        <p:spPr>
-          <a:xfrm>
-            <a:off x="548640" y="6400800"/>
-            <a:ext cx="10972800" cy="274320"/>
-          </a:xfrm>
-          <a:prstGeom prst="rect">
-            <a:avLst/>
-          </a:prstGeom>
-          <a:noFill/>
-        </p:spPr>
-        <p:txBody>
-          <a:bodyPr wrap="none">
-            <a:spAutoFit/>
-          </a:bodyPr>
-          <a:lstStyle/>
-          <a:p>
-            <a:pPr>
-              <a:defRPr sz="1000">
-                <a:solidFill>
-                  <a:srgbClr val="6B7778"/>
-                </a:solidFill>
-              </a:defRPr>
-            </a:pPr>
-            <a:r>
-              <a:t>Oevererosietool · update 26-08-2026 · 15</a:t>
-            </a:r>
-          </a:p>
-        </p:txBody>
-      </p:sp>
-      <p:sp>
-        <p:nvSpPr>
-          <p:cNvPr id="5" name="Rectangle 4"/>
-          <p:cNvSpPr/>
-          <p:nvPr/>
-        </p:nvSpPr>
-        <p:spPr>
-          <a:xfrm>
-            <a:off x="548640" y="1645920"/>
-            <a:ext cx="3566160" cy="548640"/>
-          </a:xfrm>
-          <a:prstGeom prst="rect">
-            <a:avLst/>
-          </a:prstGeom>
-          <a:solidFill>
-            <a:srgbClr val="2BB5A6"/>
-          </a:solidFill>
-          <a:ln>
-            <a:noFill/>
-          </a:ln>
-        </p:spPr>
-        <p:style>
-          <a:lnRef idx="1">
-            <a:schemeClr val="accent1"/>
-          </a:lnRef>
-          <a:fillRef idx="3">
-            <a:schemeClr val="accent1"/>
-          </a:fillRef>
-          <a:effectRef idx="2">
-            <a:schemeClr val="accent1"/>
-          </a:effectRef>
-          <a:fontRef idx="minor">
-            <a:schemeClr val="lt1"/>
-          </a:fontRef>
-        </p:style>
-        <p:txBody>
-          <a:bodyPr rtlCol="0" anchor="ctr"/>
-          <a:lstStyle/>
-          <a:p>
-            <a:pPr algn="ctr">
-              <a:defRPr sz="1800" b="1">
-                <a:solidFill>
-                  <a:srgbClr val="FFFFFF"/>
-                </a:solidFill>
-              </a:defRPr>
-            </a:pPr>
-            <a:r>
-              <a:t>Hoogtemodel-engineers</a:t>
-            </a:r>
-          </a:p>
-        </p:txBody>
-      </p:sp>
-      <p:sp>
-        <p:nvSpPr>
-          <p:cNvPr id="6" name="TextBox 5"/>
-          <p:cNvSpPr txBox="1"/>
-          <p:nvPr/>
-        </p:nvSpPr>
-        <p:spPr>
-          <a:xfrm>
-            <a:off x="548640" y="2377440"/>
-            <a:ext cx="3566160" cy="3474720"/>
-          </a:xfrm>
-          <a:prstGeom prst="rect">
-            <a:avLst/>
-          </a:prstGeom>
-          <a:noFill/>
-        </p:spPr>
-        <p:txBody>
-          <a:bodyPr wrap="square">
-            <a:spAutoFit/>
-          </a:bodyPr>
-          <a:lstStyle/>
-          <a:p>
-            <a:pPr>
-              <a:spcAft>
-                <a:spcPts val="600"/>
-              </a:spcAft>
-              <a:defRPr sz="1500" b="0">
-                <a:solidFill>
-                  <a:srgbClr val="1F3A3D"/>
-                </a:solidFill>
-              </a:defRPr>
-            </a:pPr>
-            <a:r>
-              <a:t>• De vijfdeling (scope_coverage) meeleveren</a:t>
-            </a:r>
-          </a:p>
-          <a:p>
-            <a:pPr>
-              <a:spcAft>
-                <a:spcPts val="600"/>
-              </a:spcAft>
-              <a:defRPr sz="1500" b="0">
-                <a:solidFill>
-                  <a:srgbClr val="1F3A3D"/>
-                </a:solidFill>
-              </a:defRPr>
-            </a:pPr>
-            <a:r>
-              <a:t>• Per lijn een vlag: 'dit is een constructie / verkeerde oever'</a:t>
-            </a:r>
-          </a:p>
-          <a:p>
-            <a:pPr>
-              <a:spcAft>
-                <a:spcPts val="600"/>
-              </a:spcAft>
-              <a:defRPr sz="1500" b="0">
-                <a:solidFill>
-                  <a:srgbClr val="1F3A3D"/>
-                </a:solidFill>
-              </a:defRPr>
-            </a:pPr>
-            <a:r>
-              <a:t>• Bekende randgevallen: meeroeverig, hoogwater</a:t>
-            </a:r>
-          </a:p>
-        </p:txBody>
-      </p:sp>
-      <p:sp>
-        <p:nvSpPr>
-          <p:cNvPr id="7" name="Rectangle 6"/>
-          <p:cNvSpPr/>
-          <p:nvPr/>
-        </p:nvSpPr>
-        <p:spPr>
-          <a:xfrm>
-            <a:off x="4389120" y="1645920"/>
-            <a:ext cx="3566160" cy="548640"/>
-          </a:xfrm>
-          <a:prstGeom prst="rect">
-            <a:avLst/>
-          </a:prstGeom>
-          <a:solidFill>
-            <a:srgbClr val="2BB5A6"/>
-          </a:solidFill>
-          <a:ln>
-            <a:noFill/>
-          </a:ln>
-        </p:spPr>
-        <p:style>
-          <a:lnRef idx="1">
-            <a:schemeClr val="accent1"/>
-          </a:lnRef>
-          <a:fillRef idx="3">
-            <a:schemeClr val="accent1"/>
-          </a:fillRef>
-          <a:effectRef idx="2">
-            <a:schemeClr val="accent1"/>
-          </a:effectRef>
-          <a:fontRef idx="minor">
-            <a:schemeClr val="lt1"/>
-          </a:fontRef>
-        </p:style>
-        <p:txBody>
-          <a:bodyPr rtlCol="0" anchor="ctr"/>
-          <a:lstStyle/>
-          <a:p>
-            <a:pPr algn="ctr">
-              <a:defRPr sz="1800" b="1">
-                <a:solidFill>
-                  <a:srgbClr val="FFFFFF"/>
-                </a:solidFill>
-              </a:defRPr>
-            </a:pPr>
-            <a:r>
-              <a:t>SAM-engineers</a:t>
-            </a:r>
-          </a:p>
-        </p:txBody>
-      </p:sp>
-      <p:sp>
-        <p:nvSpPr>
-          <p:cNvPr id="8" name="TextBox 7"/>
-          <p:cNvSpPr txBox="1"/>
-          <p:nvPr/>
-        </p:nvSpPr>
-        <p:spPr>
-          <a:xfrm>
-            <a:off x="4389120" y="2377440"/>
-            <a:ext cx="3566160" cy="3474720"/>
-          </a:xfrm>
-          <a:prstGeom prst="rect">
-            <a:avLst/>
-          </a:prstGeom>
-          <a:noFill/>
-        </p:spPr>
-        <p:txBody>
-          <a:bodyPr wrap="square">
-            <a:spAutoFit/>
-          </a:bodyPr>
-          <a:lstStyle/>
-          <a:p>
-            <a:pPr>
-              <a:spcAft>
-                <a:spcPts val="600"/>
-              </a:spcAft>
-              <a:defRPr sz="1500" b="0">
-                <a:solidFill>
-                  <a:srgbClr val="1F3A3D"/>
-                </a:solidFill>
-              </a:defRPr>
-            </a:pPr>
-            <a:r>
-              <a:t>• Kwaliteitsvlag per meting</a:t>
-            </a:r>
-          </a:p>
-          <a:p>
-            <a:pPr>
-              <a:spcAft>
-                <a:spcPts val="600"/>
-              </a:spcAft>
-              <a:defRPr sz="1500" b="0">
-                <a:solidFill>
-                  <a:srgbClr val="1F3A3D"/>
-                </a:solidFill>
-              </a:defRPr>
-            </a:pPr>
-            <a:r>
-              <a:t>• Vooral: méér jaren — elk jaar maakt het model vanzelf beter</a:t>
-            </a:r>
-          </a:p>
-          <a:p>
-            <a:pPr>
-              <a:spcAft>
-                <a:spcPts val="600"/>
-              </a:spcAft>
-              <a:defRPr sz="1500" b="0">
-                <a:solidFill>
-                  <a:srgbClr val="1F3A3D"/>
-                </a:solidFill>
-              </a:defRPr>
-            </a:pPr>
-            <a:r>
-              <a:t>• Waar mogelijk: één lijn per meetmoment</a:t>
-            </a:r>
-          </a:p>
-        </p:txBody>
-      </p:sp>
-      <p:sp>
-        <p:nvSpPr>
-          <p:cNvPr id="9" name="Rectangle 8"/>
-          <p:cNvSpPr/>
-          <p:nvPr/>
-        </p:nvSpPr>
-        <p:spPr>
-          <a:xfrm>
-            <a:off x="8229600" y="1645920"/>
-            <a:ext cx="3566160" cy="548640"/>
-          </a:xfrm>
-          <a:prstGeom prst="rect">
-            <a:avLst/>
-          </a:prstGeom>
-          <a:solidFill>
-            <a:srgbClr val="E07A3F"/>
-          </a:solidFill>
-          <a:ln>
-            <a:noFill/>
-          </a:ln>
-        </p:spPr>
-        <p:style>
-          <a:lnRef idx="1">
-            <a:schemeClr val="accent1"/>
-          </a:lnRef>
-          <a:fillRef idx="3">
-            <a:schemeClr val="accent1"/>
-          </a:fillRef>
-          <a:effectRef idx="2">
-            <a:schemeClr val="accent1"/>
-          </a:effectRef>
-          <a:fontRef idx="minor">
-            <a:schemeClr val="lt1"/>
-          </a:fontRef>
-        </p:style>
-        <p:txBody>
-          <a:bodyPr rtlCol="0" anchor="ctr"/>
-          <a:lstStyle/>
-          <a:p>
-            <a:pPr algn="ctr">
-              <a:defRPr sz="1800" b="1">
-                <a:solidFill>
-                  <a:srgbClr val="FFFFFF"/>
-                </a:solidFill>
-              </a:defRPr>
-            </a:pPr>
-            <a:r>
-              <a:t>Samen</a:t>
-            </a:r>
-          </a:p>
-        </p:txBody>
-      </p:sp>
-      <p:sp>
-        <p:nvSpPr>
-          <p:cNvPr id="10" name="TextBox 9"/>
-          <p:cNvSpPr txBox="1"/>
-          <p:nvPr/>
-        </p:nvSpPr>
-        <p:spPr>
-          <a:xfrm>
-            <a:off x="8229600" y="2377440"/>
-            <a:ext cx="3566160" cy="3474720"/>
-          </a:xfrm>
-          <a:prstGeom prst="rect">
-            <a:avLst/>
-          </a:prstGeom>
-          <a:noFill/>
-        </p:spPr>
-        <p:txBody>
-          <a:bodyPr wrap="square">
-            <a:spAutoFit/>
-          </a:bodyPr>
-          <a:lstStyle/>
-          <a:p>
-            <a:pPr>
-              <a:spcAft>
-                <a:spcPts val="600"/>
-              </a:spcAft>
-              <a:defRPr sz="1500" b="0">
-                <a:solidFill>
-                  <a:srgbClr val="1F3A3D"/>
-                </a:solidFill>
-              </a:defRPr>
-            </a:pPr>
-            <a:r>
-              <a:t>• Labelronde in QGIS: wij leveren de gesorteerde lijst twijfelgevallen, jullie het oordeel</a:t>
-            </a:r>
-          </a:p>
-          <a:p>
-            <a:pPr>
-              <a:spcAft>
-                <a:spcPts val="600"/>
-              </a:spcAft>
-              <a:defRPr sz="1500" b="0">
-                <a:solidFill>
-                  <a:srgbClr val="1F3A3D"/>
-                </a:solidFill>
-              </a:defRPr>
-            </a:pPr>
-            <a:r>
-              <a:t>• Eerste ronde: ~200 vlakken, twee uur</a:t>
-            </a:r>
-          </a:p>
-          <a:p>
-            <a:pPr>
-              <a:spcAft>
-                <a:spcPts val="600"/>
-              </a:spcAft>
-              <a:defRPr sz="1500" b="0">
-                <a:solidFill>
-                  <a:srgbClr val="1F3A3D"/>
-                </a:solidFill>
-              </a:defRPr>
-            </a:pPr>
-            <a:r>
-              <a:t>• Daarna meten we opnieuw</a:t>
-            </a:r>
-          </a:p>
-        </p:txBody>
-      </p:sp>
-    </p:spTree>
-  </p:cSld>
-  <p:clrMapOvr>
-    <a:masterClrMapping/>
-  </p:clrMapOvr>
-</p:sld>
-</file>
-
-<file path=ppt/slides/slide17.xml><?xml version="1.0" encoding="utf-8"?>
-<p:sld xmlns:a="http://schemas.openxmlformats.org/drawingml/2006/main" xmlns:r="http://schemas.openxmlformats.org/officeDocument/2006/relationships" xmlns:p="http://schemas.openxmlformats.org/presentationml/2006/main">
-  <p:cSld>
-    <p:spTree>
-      <p:nvGrpSpPr>
-        <p:cNvPr id="1" name=""/>
-        <p:cNvGrpSpPr/>
-        <p:nvPr/>
-      </p:nvGrpSpPr>
-      <p:grpSpPr>
-        <a:xfrm>
-          <a:off x="0" y="0"/>
-          <a:ext cx="0" cy="0"/>
-          <a:chOff x="0" y="0"/>
-          <a:chExt cx="0" cy="0"/>
-        </a:xfrm>
-      </p:grpSpPr>
-      <p:sp>
-        <p:nvSpPr>
-          <p:cNvPr id="2" name="TextBox 1"/>
-          <p:cNvSpPr txBox="1"/>
-          <p:nvPr/>
-        </p:nvSpPr>
-        <p:spPr>
-          <a:xfrm>
-            <a:off x="548640" y="320040"/>
-            <a:ext cx="10972800" cy="731520"/>
-          </a:xfrm>
-          <a:prstGeom prst="rect">
-            <a:avLst/>
-          </a:prstGeom>
-          <a:noFill/>
-        </p:spPr>
-        <p:txBody>
-          <a:bodyPr wrap="none">
-            <a:spAutoFit/>
-          </a:bodyPr>
-          <a:lstStyle/>
-          <a:p>
-            <a:pPr>
-              <a:defRPr sz="3000" b="1">
-                <a:solidFill>
-                  <a:srgbClr val="2BB5A6"/>
-                </a:solidFill>
-              </a:defRPr>
-            </a:pPr>
-            <a:r>
               <a:t>Wat dit oplevert voor asset management</a:t>
             </a:r>
           </a:p>
@@ -6345,7 +6345,7 @@
 </p:sld>
 </file>
 
-<file path=ppt/slides/slide18.xml><?xml version="1.0" encoding="utf-8"?>
+<file path=ppt/slides/slide17.xml><?xml version="1.0" encoding="utf-8"?>
 <p:sld xmlns:a="http://schemas.openxmlformats.org/drawingml/2006/main" xmlns:r="http://schemas.openxmlformats.org/officeDocument/2006/relationships" xmlns:p="http://schemas.openxmlformats.org/presentationml/2006/main">
   <p:cSld>
     <p:spTree>
@@ -10293,65 +10293,65 @@
           </a:p>
         </p:txBody>
       </p:sp>
+      <p:sp>
+        <p:nvSpPr>
+          <p:cNvPr id="8" name="TextBox 7"/>
+          <p:cNvSpPr txBox="1"/>
+          <p:nvPr/>
+        </p:nvSpPr>
+        <p:spPr>
+          <a:xfrm>
+            <a:off x="365760" y="5669280"/>
+            <a:ext cx="8412480" cy="731520"/>
+          </a:xfrm>
+          <a:prstGeom prst="rect">
+            <a:avLst/>
+          </a:prstGeom>
+          <a:noFill/>
+        </p:spPr>
+        <p:txBody>
+          <a:bodyPr wrap="square">
+            <a:spAutoFit/>
+          </a:bodyPr>
+          <a:lstStyle/>
+          <a:p>
+            <a:pPr>
+              <a:defRPr sz="1000" i="1">
+                <a:solidFill>
+                  <a:srgbClr val="6B7778"/>
+                </a:solidFill>
+              </a:defRPr>
+            </a:pPr>
+            <a:r>
+              <a:t>Leeswijzer: 4.12 was de score van het 19 aug-model op zijn eigen willekeurige splitsing; op de bevroren testset van 1 174 vlakken scoort datzelfde model 3.99. Alle stappen in As 1–3 zijn op deze vaste set gemeten.</a:t>
+            </a:r>
+          </a:p>
+        </p:txBody>
+      </p:sp>
       <p:pic>
         <p:nvPicPr>
-          <p:cNvPr id="7" name="Picture 6" descr="rule_ablation.png"/>
+          <p:cNvPr id="9" name="Picture 8" descr="rule_ablation.png"/>
           <p:cNvPicPr>
             <a:picLocks noChangeAspect="1"/>
           </p:cNvPicPr>
           <p:nvPr/>
         </p:nvPicPr>
         <p:blipFill>
-          <a:blip r:embed="rId3"/>
+          <a:blip r:embed="rId4"/>
           <a:stretch>
             <a:fillRect/>
           </a:stretch>
         </p:blipFill>
         <p:spPr>
           <a:xfrm>
-            <a:off x="365760" y="1463040"/>
-            <a:ext cx="8412480" cy="3364992"/>
+            <a:off x="365760" y="1417320"/>
+            <a:ext cx="7381568" cy="4160520"/>
           </a:xfrm>
           <a:prstGeom prst="rect">
             <a:avLst/>
           </a:prstGeom>
         </p:spPr>
       </p:pic>
-      <p:sp>
-        <p:nvSpPr>
-          <p:cNvPr id="8" name="TextBox 7"/>
-          <p:cNvSpPr txBox="1"/>
-          <p:nvPr/>
-        </p:nvSpPr>
-        <p:spPr>
-          <a:xfrm>
-            <a:off x="365760" y="5577840"/>
-            <a:ext cx="8412480" cy="731520"/>
-          </a:xfrm>
-          <a:prstGeom prst="rect">
-            <a:avLst/>
-          </a:prstGeom>
-          <a:noFill/>
-        </p:spPr>
-        <p:txBody>
-          <a:bodyPr wrap="square">
-            <a:spAutoFit/>
-          </a:bodyPr>
-          <a:lstStyle/>
-          <a:p>
-            <a:pPr>
-              <a:defRPr sz="1000" i="1">
-                <a:solidFill>
-                  <a:srgbClr val="6B7778"/>
-                </a:solidFill>
-              </a:defRPr>
-            </a:pPr>
-            <a:r>
-              <a:t>Leeswijzer: 4.12 was de score van het 19 aug-model op zijn eigen willekeurige splitsing; op de bevroren testset van 1 174 vlakken scoort datzelfde model 3.99. Alle stappen in As 1–3 zijn op deze vaste set gemeten.</a:t>
-            </a:r>
-          </a:p>
-        </p:txBody>
-      </p:sp>
     </p:spTree>
   </p:cSld>
   <p:clrMapOvr>

</xml_diff>

<commit_message>
feat(pipeline)+docs: segment_R default 20; deck slides 12-14 on R=20
</commit_message>
<xml_diff>
--- a/docs/presentations/20260826_update_v2.pptx
+++ b/docs/presentations/20260826_update_v2.pptx
@@ -4314,7 +4314,7 @@
               </a:defRPr>
             </a:pPr>
             <a:r>
-              <a:t>• Eén getal zegt −9.7 m/jr; de vijf segmenten lopen van −17.1 tot +1.4 (voorbeeld op R = 5; gekozen resolutie R = 10)</a:t>
+              <a:t>• Eén getal zegt −9.7 m/jr; de vijf segmenten lopen van −17.1 tot +1.4 (voorbeeld op R = 5; gekozen resolutie R = 20)</a:t>
             </a:r>
           </a:p>
           <a:p>
@@ -4566,7 +4566,7 @@
               </a:defRPr>
             </a:pPr>
             <a:r>
-              <a:t>• Fout per segment daalt van 1.37 (R = 1) naar 1.03 (R = 10) en 0.85 (R = 20) — maar de naïeve fout zakt mee: de skill piekt bij R = 10 (+30 %) en bij R = 20 heeft 31 % van de segment-datums geen meting</a:t>
+              <a:t>• Fout per segment daalt van 1.37 (R = 1) naar 0.85 (R = 20); skill t.o.v. naïef stijgt van +23 % naar +29–30 % — hoe fijner, hoe beter</a:t>
             </a:r>
           </a:p>
           <a:p>
@@ -4581,7 +4581,7 @@
               </a:defRPr>
             </a:pPr>
             <a:r>
-              <a:t>• Keuze: R = 10 (≈ 10 m). Fijner is alleen een gladdere meetlat, geen beter model — tot de lijnbemonstering (60 punten per lijn) verdicht wordt</a:t>
+              <a:t>• Keuze: R = 20 (≈ 5 m). Prijs: 31 % van de segment-datums heeft nog geen meting — dat lossen we op in de lijnbemonstering (60 → meer punten per lijn), niet in het model</a:t>
             </a:r>
           </a:p>
           <a:p>
@@ -4608,7 +4608,7 @@
           <p:nvPr/>
         </p:nvPicPr>
         <p:blipFill>
-          <a:blip r:embed="rId3"/>
+          <a:blip r:embed="rId4"/>
           <a:stretch>
             <a:fillRect/>
           </a:stretch>
@@ -4786,7 +4786,7 @@
               </a:defRPr>
             </a:pPr>
             <a:r>
-              <a:t>• Opschonen: −1.72 m/jr (−43 %) · structurenlaag: ±0 (juistheid/dekking) · historie-features: −0.14 · paren ≥ 2 jaar: andere meetlat, skill +20 → +23 % · segmenten R = 10: skill +30 %, positiefout 1.05 m</a:t>
+              <a:t>• Opschonen: −1.72 m/jr (−43 %) · structurenlaag: ±0 (juistheid/dekking) · historie-features: −0.14 · paren ≥ 2 jaar: andere meetlat, skill +20 → +23 % · segmenten R = 20: skill +29 %, positiefout 0.85 m</a:t>
             </a:r>
           </a:p>
           <a:p>
@@ -4815,7 +4815,7 @@
           <p:nvPr/>
         </p:nvPicPr>
         <p:blipFill>
-          <a:blip r:embed="rId3"/>
+          <a:blip r:embed="rId4"/>
           <a:stretch>
             <a:fillRect/>
           </a:stretch>
@@ -5545,7 +5545,7 @@
               </a:defRPr>
             </a:pPr>
             <a:r>
-              <a:t>• Slide 14 = het experiment op de vaste testset (met test-set early stopping); dit = de volledige pipeline op een nieuwe splitsing zónder de testset in de training — strenger, en daarom hoger: 2.13 → 2.47 en 1.07 → 1.23 (R = 5; R = 10 volgt in de volgende run)</a:t>
+              <a:t>• Slide 13 = het experiment op de vaste testset (met test-set early stopping); dit = de volledige pipeline op een nieuwe splitsing zónder de testset in de training — strenger, en daarom hoger: 2.13 → 2.47 en 1.07 → 1.23 (R = 5; R = 20 volgt in de volgende run)</a:t>
             </a:r>
           </a:p>
           <a:p>
@@ -6272,7 +6272,7 @@
               </a:defRPr>
             </a:pPr>
             <a:r>
-              <a:t>• Per segment (≈ 10–20 m) een verwachte positie ≥ 2 jaar vooruit — mediane positiefout ≈ 1 m</a:t>
+              <a:t>• Per segment (≈ 5 m) een verwachte positie ≥ 2 jaar vooruit — mediane positiefout ≈ 0.85 m</a:t>
             </a:r>
           </a:p>
           <a:p>
@@ -6510,7 +6510,7 @@
               </a:defRPr>
             </a:pPr>
             <a:r>
-              <a:t>• Tien segmenten per vlak (≈ 10 m); gemeten én voorspelde oever als lijn; positiefout ≈ 1 m op ≥ 2 jaar</a:t>
+              <a:t>• Twintig segmenten per vlak (≈ 5 m); gemeten én voorspelde oever als lijn; positiefout ≈ 0.85 m op ≥ 2 jaar</a:t>
             </a:r>
           </a:p>
           <a:p>

</xml_diff>

<commit_message>
docs(presentation): comparison table with to-do column; closing slide = feedback + to-dos; asset-management slide removed
</commit_message>
<xml_diff>
--- a/docs/presentations/20260826_update_v2.pptx
+++ b/docs/presentations/20260826_update_v2.pptx
@@ -23,8 +23,6 @@
     <p:sldId id="265" r:id="rId15"/>
     <p:sldId id="266" r:id="rId16"/>
     <p:sldId id="267" r:id="rId17"/>
-    <p:sldId id="268" r:id="rId18"/>
-    <p:sldId id="269" r:id="rId19"/>
   </p:sldIdLst>
   <p:sldSz cx="12192000" cy="6858000"/>
   <p:notesSz cx="6858000" cy="9144000"/>
@@ -4885,14 +4883,49 @@
               </a:defRPr>
             </a:pPr>
             <a:r>
-              <a:t>Eindrun — eerlijk gemeten, nieuwe splitsing</a:t>
-            </a:r>
-          </a:p>
-        </p:txBody>
-      </p:sp>
-      <p:sp>
-        <p:nvSpPr>
-          <p:cNvPr id="3" name="TextBox 2"/>
+              <a:t>Waar we nu staan — alle condities naast elkaar</a:t>
+            </a:r>
+          </a:p>
+        </p:txBody>
+      </p:sp>
+      <p:sp>
+        <p:nvSpPr>
+          <p:cNvPr id="4" name="TextBox 3"/>
+          <p:cNvSpPr txBox="1"/>
+          <p:nvPr/>
+        </p:nvSpPr>
+        <p:spPr>
+          <a:xfrm>
+            <a:off x="548640" y="6400800"/>
+            <a:ext cx="10972800" cy="274320"/>
+          </a:xfrm>
+          <a:prstGeom prst="rect">
+            <a:avLst/>
+          </a:prstGeom>
+          <a:noFill/>
+        </p:spPr>
+        <p:txBody>
+          <a:bodyPr wrap="none">
+            <a:spAutoFit/>
+          </a:bodyPr>
+          <a:lstStyle/>
+          <a:p>
+            <a:pPr>
+              <a:defRPr sz="1000">
+                <a:solidFill>
+                  <a:srgbClr val="6B7778"/>
+                </a:solidFill>
+              </a:defRPr>
+            </a:pPr>
+            <a:r>
+              <a:t>Oevererosietool · update 26-08-2026 · 14</a:t>
+            </a:r>
+          </a:p>
+        </p:txBody>
+      </p:sp>
+      <p:sp>
+        <p:nvSpPr>
+          <p:cNvPr id="5" name="TextBox 4"/>
           <p:cNvSpPr txBox="1"/>
           <p:nvPr/>
         </p:nvSpPr>
@@ -4907,70 +4940,35 @@
           <a:noFill/>
         </p:spPr>
         <p:txBody>
-          <a:bodyPr wrap="none">
+          <a:bodyPr wrap="square">
             <a:spAutoFit/>
           </a:bodyPr>
           <a:lstStyle/>
           <a:p>
             <a:pPr>
-              <a:defRPr sz="1700">
+              <a:defRPr sz="1700" b="0" i="0">
                 <a:solidFill>
                   <a:srgbClr val="1F3A3D"/>
                 </a:solidFill>
               </a:defRPr>
             </a:pPr>
             <a:r>
-              <a:t>Volledige pipeline op een nieuwe 80/20-splitsing, testset buiten de training · alleen binnen een rij vergelijken</a:t>
-            </a:r>
-          </a:p>
-        </p:txBody>
-      </p:sp>
-      <p:sp>
-        <p:nvSpPr>
-          <p:cNvPr id="4" name="TextBox 3"/>
-          <p:cNvSpPr txBox="1"/>
-          <p:nvPr/>
-        </p:nvSpPr>
-        <p:spPr>
-          <a:xfrm>
-            <a:off x="548640" y="6400800"/>
-            <a:ext cx="10972800" cy="274320"/>
-          </a:xfrm>
-          <a:prstGeom prst="rect">
-            <a:avLst/>
-          </a:prstGeom>
-          <a:noFill/>
-        </p:spPr>
-        <p:txBody>
-          <a:bodyPr wrap="none">
-            <a:spAutoFit/>
-          </a:bodyPr>
-          <a:lstStyle/>
-          <a:p>
-            <a:pPr>
-              <a:defRPr sz="1000">
-                <a:solidFill>
-                  <a:srgbClr val="6B7778"/>
-                </a:solidFill>
-              </a:defRPr>
-            </a:pPr>
-            <a:r>
-              <a:t>Oevererosietool · update 26-08-2026 · 14</a:t>
+              <a:t>Zelfde opzet als slide 3 · de laatste kolom is de te-doen-stap: alles opnieuw op een willekeurige splitsing, testset buiten de training</a:t>
             </a:r>
           </a:p>
         </p:txBody>
       </p:sp>
       <p:graphicFrame>
         <p:nvGraphicFramePr>
-          <p:cNvPr id="5" name="Table 4"/>
+          <p:cNvPr id="6" name="Table 5"/>
           <p:cNvGraphicFramePr>
             <a:graphicFrameLocks noGrp="1"/>
           </p:cNvGraphicFramePr>
           <p:nvPr/>
         </p:nvGraphicFramePr>
         <p:xfrm>
-          <a:off x="548640" y="1645920"/>
-          <a:ext cx="11064240" cy="2042160"/>
+          <a:off x="548640" y="1600200"/>
+          <a:ext cx="11064240" cy="3456432"/>
         </p:xfrm>
         <a:graphic>
           <a:graphicData uri="http://schemas.openxmlformats.org/drawingml/2006/table">
@@ -4979,50 +4977,52 @@
                 <a:tableStyleId>{5C22544A-7EE6-4342-B048-85BDC9FD1C3A}</a:tableStyleId>
               </a:tblPr>
               <a:tblGrid>
-                <a:gridCol w="4846320">
-                  <a:extLst>
-                    <a:ext uri="{9D8B030D-6E8A-4147-A177-3AD203B41FA5}">
-                      <a16:colId xmlns:a16="http://schemas.microsoft.com/office/drawing/2014/main" val="20000"/>
-                    </a:ext>
-                  </a:extLst>
-                </a:gridCol>
-                <a:gridCol w="1463040">
-                  <a:extLst>
-                    <a:ext uri="{9D8B030D-6E8A-4147-A177-3AD203B41FA5}">
-                      <a16:colId xmlns:a16="http://schemas.microsoft.com/office/drawing/2014/main" val="20001"/>
-                    </a:ext>
-                  </a:extLst>
-                </a:gridCol>
-                <a:gridCol w="2194560">
-                  <a:extLst>
-                    <a:ext uri="{9D8B030D-6E8A-4147-A177-3AD203B41FA5}">
-                      <a16:colId xmlns:a16="http://schemas.microsoft.com/office/drawing/2014/main" val="20002"/>
-                    </a:ext>
-                  </a:extLst>
-                </a:gridCol>
-                <a:gridCol w="2560320">
-                  <a:extLst>
-                    <a:ext uri="{9D8B030D-6E8A-4147-A177-3AD203B41FA5}">
-                      <a16:colId xmlns:a16="http://schemas.microsoft.com/office/drawing/2014/main" val="20003"/>
-                    </a:ext>
-                  </a:extLst>
-                </a:gridCol>
+                <a:gridCol w="3657600"/>
+                <a:gridCol w="1554480"/>
+                <a:gridCol w="1737360"/>
+                <a:gridCol w="2286000"/>
+                <a:gridCol w="1828800"/>
               </a:tblGrid>
-              <a:tr h="365760">
+              <a:tr h="384048">
                 <a:tc>
                   <a:txBody>
                     <a:bodyPr/>
                     <a:lstStyle/>
                     <a:p>
                       <a:pPr>
-                        <a:defRPr sz="1400" b="1">
+                        <a:defRPr sz="1200" b="1">
+                          <a:solidFill>
+                            <a:srgbClr val="1F3A3D"/>
+                          </a:solidFill>
+                        </a:defRPr>
+                      </a:pPr>
+                    </a:p>
+                  </a:txBody>
+                  <a:tcPr>
+                    <a:solidFill>
+                      <a:srgbClr val="E6F5F3"/>
+                    </a:solidFill>
+                  </a:tcPr>
+                </a:tc>
+                <a:tc>
+                  <a:txBody>
+                    <a:bodyPr/>
+                    <a:lstStyle/>
+                    <a:p>
+                      <a:pPr algn="ctr">
+                        <a:defRPr sz="1200" b="1">
                           <a:solidFill>
                             <a:srgbClr val="1F3A3D"/>
                           </a:solidFill>
                         </a:defRPr>
                       </a:pPr>
                       <a:r>
-                        <a:t>meetlat</a:t>
+                        <a:t>maart 2026</a:t>
+                      </a:r>
+                    </a:p>
+                    <a:p>
+                      <a:r>
+                        <a:t>alleen hoogtemodel</a:t>
                       </a:r>
                     </a:p>
                   </a:txBody>
@@ -5038,14 +5038,19 @@
                     <a:lstStyle/>
                     <a:p>
                       <a:pPr algn="ctr">
-                        <a:defRPr sz="1400" b="1">
+                        <a:defRPr sz="1200" b="1">
                           <a:solidFill>
                             <a:srgbClr val="1F3A3D"/>
                           </a:solidFill>
                         </a:defRPr>
                       </a:pPr>
                       <a:r>
-                        <a:t>naïef</a:t>
+                        <a:t>19 augustus</a:t>
+                      </a:r>
+                    </a:p>
+                    <a:p>
+                      <a:r>
+                        <a:t>hybride, eigen split</a:t>
                       </a:r>
                     </a:p>
                   </a:txBody>
@@ -5061,14 +5066,19 @@
                     <a:lstStyle/>
                     <a:p>
                       <a:pPr algn="ctr">
-                        <a:defRPr sz="1400" b="1">
+                        <a:defRPr sz="1200" b="1">
                           <a:solidFill>
                             <a:srgbClr val="1F3A3D"/>
                           </a:solidFill>
                         </a:defRPr>
                       </a:pPr>
                       <a:r>
-                        <a:t>LightGBM</a:t>
+                        <a:t>nu</a:t>
+                      </a:r>
+                    </a:p>
+                    <a:p>
+                      <a:r>
+                        <a:t>vaste testset · R = 20 · paren ≥ 2 jr</a:t>
                       </a:r>
                     </a:p>
                   </a:txBody>
@@ -5084,19 +5094,19 @@
                     <a:lstStyle/>
                     <a:p>
                       <a:pPr algn="ctr">
-                        <a:defRPr sz="1400" b="1">
+                        <a:defRPr sz="1200" b="1">
                           <a:solidFill>
                             <a:srgbClr val="1F3A3D"/>
                           </a:solidFill>
                         </a:defRPr>
                       </a:pPr>
                       <a:r>
-                        <a:t>risicogevallen &gt; 2 m/jr</a:t>
+                        <a:t>te doen</a:t>
                       </a:r>
                     </a:p>
                     <a:p>
                       <a:r>
-                        <a:t>LGB / naïef</a:t>
+                        <a:t>willekeurige split, eerlijk</a:t>
                       </a:r>
                     </a:p>
                   </a:txBody>
@@ -5106,27 +5116,22 @@
                     </a:solidFill>
                   </a:tcPr>
                 </a:tc>
-                <a:extLst>
-                  <a:ext uri="{0D108BD9-81ED-4DB2-BD59-A6C34878D82A}">
-                    <a16:rowId xmlns:a16="http://schemas.microsoft.com/office/drawing/2014/main" val="10000"/>
-                  </a:ext>
-                </a:extLst>
               </a:tr>
-              <a:tr h="365760">
+              <a:tr h="384048">
                 <a:tc>
                   <a:txBody>
                     <a:bodyPr/>
                     <a:lstStyle/>
                     <a:p>
                       <a:pPr>
-                        <a:defRPr sz="1400" b="1">
+                        <a:defRPr sz="1200" b="1">
                           <a:solidFill>
                             <a:srgbClr val="1F3A3D"/>
                           </a:solidFill>
                         </a:defRPr>
                       </a:pPr>
                       <a:r>
-                        <a:t>maart · hoogtemodel · 3–4 jr · per vlak</a:t>
+                        <a:t>Baseline (naïef gemiddelde) — fout test (m/jr)</a:t>
                       </a:r>
                     </a:p>
                   </a:txBody>
@@ -5142,7 +5147,7 @@
                     <a:lstStyle/>
                     <a:p>
                       <a:pPr algn="ctr">
-                        <a:defRPr sz="1400" b="0">
+                        <a:defRPr sz="1200" b="0">
                           <a:solidFill>
                             <a:srgbClr val="1F3A3D"/>
                           </a:solidFill>
@@ -5165,83 +5170,7 @@
                     <a:lstStyle/>
                     <a:p>
                       <a:pPr algn="ctr">
-                        <a:defRPr sz="1400" b="0">
-                          <a:solidFill>
-                            <a:srgbClr val="1F3A3D"/>
-                          </a:solidFill>
-                        </a:defRPr>
-                      </a:pPr>
-                      <a:r>
-                        <a:t>0.94  (−20 %)</a:t>
-                      </a:r>
-                    </a:p>
-                  </a:txBody>
-                  <a:tcPr>
-                    <a:solidFill>
-                      <a:srgbClr val="FFFFFF"/>
-                    </a:solidFill>
-                  </a:tcPr>
-                </a:tc>
-                <a:tc>
-                  <a:txBody>
-                    <a:bodyPr/>
-                    <a:lstStyle/>
-                    <a:p>
-                      <a:pPr algn="ctr">
-                        <a:defRPr sz="1400" b="0">
-                          <a:solidFill>
-                            <a:srgbClr val="1F3A3D"/>
-                          </a:solidFill>
-                        </a:defRPr>
-                      </a:pPr>
-                      <a:r>
-                        <a:t>4.6 / 5.5</a:t>
-                      </a:r>
-                    </a:p>
-                  </a:txBody>
-                  <a:tcPr>
-                    <a:solidFill>
-                      <a:srgbClr val="FFFFFF"/>
-                    </a:solidFill>
-                  </a:tcPr>
-                </a:tc>
-                <a:extLst>
-                  <a:ext uri="{0D108BD9-81ED-4DB2-BD59-A6C34878D82A}">
-                    <a16:rowId xmlns:a16="http://schemas.microsoft.com/office/drawing/2014/main" val="10001"/>
-                  </a:ext>
-                </a:extLst>
-              </a:tr>
-              <a:tr h="365760">
-                <a:tc>
-                  <a:txBody>
-                    <a:bodyPr/>
-                    <a:lstStyle/>
-                    <a:p>
-                      <a:pPr>
-                        <a:defRPr sz="1400" b="1">
-                          <a:solidFill>
-                            <a:srgbClr val="1F3A3D"/>
-                          </a:solidFill>
-                        </a:defRPr>
-                      </a:pPr>
-                      <a:r>
-                        <a:t>19 aug · hybride · 1 jr · per vlak</a:t>
-                      </a:r>
-                    </a:p>
-                  </a:txBody>
-                  <a:tcPr>
-                    <a:solidFill>
-                      <a:srgbClr val="FFFFFF"/>
-                    </a:solidFill>
-                  </a:tcPr>
-                </a:tc>
-                <a:tc>
-                  <a:txBody>
-                    <a:bodyPr/>
-                    <a:lstStyle/>
-                    <a:p>
-                      <a:pPr algn="ctr">
-                        <a:defRPr sz="1400" b="0">
+                        <a:defRPr sz="1200" b="0">
                           <a:solidFill>
                             <a:srgbClr val="1F3A3D"/>
                           </a:solidFill>
@@ -5264,14 +5193,62 @@
                     <a:lstStyle/>
                     <a:p>
                       <a:pPr algn="ctr">
-                        <a:defRPr sz="1400" b="0">
+                        <a:defRPr sz="1200" b="1">
                           <a:solidFill>
                             <a:srgbClr val="1F3A3D"/>
                           </a:solidFill>
                         </a:defRPr>
                       </a:pPr>
                       <a:r>
-                        <a:t>4.12  (+14 %)</a:t>
+                        <a:t>1.20</a:t>
+                      </a:r>
+                    </a:p>
+                  </a:txBody>
+                  <a:tcPr>
+                    <a:solidFill>
+                      <a:srgbClr val="FFF1E6"/>
+                    </a:solidFill>
+                  </a:tcPr>
+                </a:tc>
+                <a:tc>
+                  <a:txBody>
+                    <a:bodyPr/>
+                    <a:lstStyle/>
+                    <a:p>
+                      <a:pPr algn="ctr">
+                        <a:defRPr sz="1200" b="0">
+                          <a:solidFill>
+                            <a:srgbClr val="1F3A3D"/>
+                          </a:solidFill>
+                        </a:defRPr>
+                      </a:pPr>
+                      <a:r>
+                        <a:t>…</a:t>
+                      </a:r>
+                    </a:p>
+                  </a:txBody>
+                  <a:tcPr>
+                    <a:solidFill>
+                      <a:srgbClr val="FFFFFF"/>
+                    </a:solidFill>
+                  </a:tcPr>
+                </a:tc>
+              </a:tr>
+              <a:tr h="384048">
+                <a:tc>
+                  <a:txBody>
+                    <a:bodyPr/>
+                    <a:lstStyle/>
+                    <a:p>
+                      <a:pPr>
+                        <a:defRPr sz="1200" b="1">
+                          <a:solidFill>
+                            <a:srgbClr val="1F3A3D"/>
+                          </a:solidFill>
+                        </a:defRPr>
+                      </a:pPr>
+                      <a:r>
+                        <a:t>LightGBM — fout test (m/jr)</a:t>
                       </a:r>
                     </a:p>
                   </a:txBody>
@@ -5287,44 +5264,14 @@
                     <a:lstStyle/>
                     <a:p>
                       <a:pPr algn="ctr">
-                        <a:defRPr sz="1400" b="0">
+                        <a:defRPr sz="1200" b="0">
                           <a:solidFill>
                             <a:srgbClr val="1F3A3D"/>
                           </a:solidFill>
                         </a:defRPr>
                       </a:pPr>
                       <a:r>
-                        <a:t>≈ 8.3</a:t>
-                      </a:r>
-                    </a:p>
-                  </a:txBody>
-                  <a:tcPr>
-                    <a:solidFill>
-                      <a:srgbClr val="FFFFFF"/>
-                    </a:solidFill>
-                  </a:tcPr>
-                </a:tc>
-                <a:extLst>
-                  <a:ext uri="{0D108BD9-81ED-4DB2-BD59-A6C34878D82A}">
-                    <a16:rowId xmlns:a16="http://schemas.microsoft.com/office/drawing/2014/main" val="10002"/>
-                  </a:ext>
-                </a:extLst>
-              </a:tr>
-              <a:tr h="365760">
-                <a:tc>
-                  <a:txBody>
-                    <a:bodyPr/>
-                    <a:lstStyle/>
-                    <a:p>
-                      <a:pPr>
-                        <a:defRPr sz="1400" b="1">
-                          <a:solidFill>
-                            <a:srgbClr val="1F3A3D"/>
-                          </a:solidFill>
-                        </a:defRPr>
-                      </a:pPr>
-                      <a:r>
-                        <a:t>nu · zelfde 1-jr meetlat · eindrun, eerlijk</a:t>
+                        <a:t>0.94</a:t>
                       </a:r>
                     </a:p>
                   </a:txBody>
@@ -5340,14 +5287,14 @@
                     <a:lstStyle/>
                     <a:p>
                       <a:pPr algn="ctr">
-                        <a:defRPr sz="1400" b="0">
+                        <a:defRPr sz="1200" b="0">
                           <a:solidFill>
                             <a:srgbClr val="1F3A3D"/>
                           </a:solidFill>
                         </a:defRPr>
                       </a:pPr>
                       <a:r>
-                        <a:t>2.86</a:t>
+                        <a:t>4.12</a:t>
                       </a:r>
                     </a:p>
                   </a:txBody>
@@ -5363,14 +5310,62 @@
                     <a:lstStyle/>
                     <a:p>
                       <a:pPr algn="ctr">
-                        <a:defRPr sz="1400" b="0">
+                        <a:defRPr sz="1200" b="1">
                           <a:solidFill>
                             <a:srgbClr val="1F3A3D"/>
                           </a:solidFill>
                         </a:defRPr>
                       </a:pPr>
                       <a:r>
-                        <a:t>2.47  (+13 %)</a:t>
+                        <a:t>0.85</a:t>
+                      </a:r>
+                    </a:p>
+                  </a:txBody>
+                  <a:tcPr>
+                    <a:solidFill>
+                      <a:srgbClr val="FFF1E6"/>
+                    </a:solidFill>
+                  </a:tcPr>
+                </a:tc>
+                <a:tc>
+                  <a:txBody>
+                    <a:bodyPr/>
+                    <a:lstStyle/>
+                    <a:p>
+                      <a:pPr algn="ctr">
+                        <a:defRPr sz="1200" b="0">
+                          <a:solidFill>
+                            <a:srgbClr val="1F3A3D"/>
+                          </a:solidFill>
+                        </a:defRPr>
+                      </a:pPr>
+                      <a:r>
+                        <a:t>…</a:t>
+                      </a:r>
+                    </a:p>
+                  </a:txBody>
+                  <a:tcPr>
+                    <a:solidFill>
+                      <a:srgbClr val="FFFFFF"/>
+                    </a:solidFill>
+                  </a:tcPr>
+                </a:tc>
+              </a:tr>
+              <a:tr h="384048">
+                <a:tc>
+                  <a:txBody>
+                    <a:bodyPr/>
+                    <a:lstStyle/>
+                    <a:p>
+                      <a:pPr>
+                        <a:defRPr sz="1200" b="1">
+                          <a:solidFill>
+                            <a:srgbClr val="1F3A3D"/>
+                          </a:solidFill>
+                        </a:defRPr>
+                      </a:pPr>
+                      <a:r>
+                        <a:t>LightGBM t.o.v. baseline (skill)</a:t>
                       </a:r>
                     </a:p>
                   </a:txBody>
@@ -5386,44 +5381,14 @@
                     <a:lstStyle/>
                     <a:p>
                       <a:pPr algn="ctr">
-                        <a:defRPr sz="1400" b="0">
+                        <a:defRPr sz="1200" b="0">
                           <a:solidFill>
                             <a:srgbClr val="1F3A3D"/>
                           </a:solidFill>
                         </a:defRPr>
                       </a:pPr>
                       <a:r>
-                        <a:t>5.0 / 6.3</a:t>
-                      </a:r>
-                    </a:p>
-                  </a:txBody>
-                  <a:tcPr>
-                    <a:solidFill>
-                      <a:srgbClr val="FFFFFF"/>
-                    </a:solidFill>
-                  </a:tcPr>
-                </a:tc>
-                <a:extLst>
-                  <a:ext uri="{0D108BD9-81ED-4DB2-BD59-A6C34878D82A}">
-                    <a16:rowId xmlns:a16="http://schemas.microsoft.com/office/drawing/2014/main" val="10003"/>
-                  </a:ext>
-                </a:extLst>
-              </a:tr>
-              <a:tr h="365760">
-                <a:tc>
-                  <a:txBody>
-                    <a:bodyPr/>
-                    <a:lstStyle/>
-                    <a:p>
-                      <a:pPr>
-                        <a:defRPr sz="1400" b="1">
-                          <a:solidFill>
-                            <a:srgbClr val="1F3A3D"/>
-                          </a:solidFill>
-                        </a:defRPr>
-                      </a:pPr>
-                      <a:r>
-                        <a:t>nu · segment R = 5 · paren ≥ 2 jr · eindrun, eerlijk</a:t>
+                        <a:t>−20 %</a:t>
                       </a:r>
                     </a:p>
                   </a:txBody>
@@ -5439,14 +5404,14 @@
                     <a:lstStyle/>
                     <a:p>
                       <a:pPr algn="ctr">
-                        <a:defRPr sz="1400" b="0">
+                        <a:defRPr sz="1200" b="0">
                           <a:solidFill>
                             <a:srgbClr val="1F3A3D"/>
                           </a:solidFill>
                         </a:defRPr>
                       </a:pPr>
                       <a:r>
-                        <a:t>1.79</a:t>
+                        <a:t>+14 %</a:t>
                       </a:r>
                     </a:p>
                   </a:txBody>
@@ -5462,14 +5427,62 @@
                     <a:lstStyle/>
                     <a:p>
                       <a:pPr algn="ctr">
-                        <a:defRPr sz="1400" b="0">
+                        <a:defRPr sz="1200" b="1">
                           <a:solidFill>
                             <a:srgbClr val="1F3A3D"/>
                           </a:solidFill>
                         </a:defRPr>
                       </a:pPr>
                       <a:r>
-                        <a:t>1.23  (+31 %)</a:t>
+                        <a:t>+29 %</a:t>
+                      </a:r>
+                    </a:p>
+                  </a:txBody>
+                  <a:tcPr>
+                    <a:solidFill>
+                      <a:srgbClr val="FFF1E6"/>
+                    </a:solidFill>
+                  </a:tcPr>
+                </a:tc>
+                <a:tc>
+                  <a:txBody>
+                    <a:bodyPr/>
+                    <a:lstStyle/>
+                    <a:p>
+                      <a:pPr algn="ctr">
+                        <a:defRPr sz="1200" b="0">
+                          <a:solidFill>
+                            <a:srgbClr val="1F3A3D"/>
+                          </a:solidFill>
+                        </a:defRPr>
+                      </a:pPr>
+                      <a:r>
+                        <a:t>…</a:t>
+                      </a:r>
+                    </a:p>
+                  </a:txBody>
+                  <a:tcPr>
+                    <a:solidFill>
+                      <a:srgbClr val="FFFFFF"/>
+                    </a:solidFill>
+                  </a:tcPr>
+                </a:tc>
+              </a:tr>
+              <a:tr h="384048">
+                <a:tc>
+                  <a:txBody>
+                    <a:bodyPr/>
+                    <a:lstStyle/>
+                    <a:p>
+                      <a:pPr>
+                        <a:defRPr sz="1200" b="1">
+                          <a:solidFill>
+                            <a:srgbClr val="1F3A3D"/>
+                          </a:solidFill>
+                        </a:defRPr>
+                      </a:pPr>
+                      <a:r>
+                        <a:t>LightGBM — fout risicogevallen &gt; 2 m/jr (m/jr)</a:t>
                       </a:r>
                     </a:p>
                   </a:txBody>
@@ -5485,14 +5498,14 @@
                     <a:lstStyle/>
                     <a:p>
                       <a:pPr algn="ctr">
-                        <a:defRPr sz="1400" b="0">
+                        <a:defRPr sz="1200" b="0">
                           <a:solidFill>
                             <a:srgbClr val="1F3A3D"/>
                           </a:solidFill>
                         </a:defRPr>
                       </a:pPr>
                       <a:r>
-                        <a:t>3.5</a:t>
+                        <a:t>4.61</a:t>
                       </a:r>
                     </a:p>
                   </a:txBody>
@@ -5502,11 +5515,543 @@
                     </a:solidFill>
                   </a:tcPr>
                 </a:tc>
-                <a:extLst>
-                  <a:ext uri="{0D108BD9-81ED-4DB2-BD59-A6C34878D82A}">
-                    <a16:rowId xmlns:a16="http://schemas.microsoft.com/office/drawing/2014/main" val="10004"/>
-                  </a:ext>
-                </a:extLst>
+                <a:tc>
+                  <a:txBody>
+                    <a:bodyPr/>
+                    <a:lstStyle/>
+                    <a:p>
+                      <a:pPr algn="ctr">
+                        <a:defRPr sz="1200" b="0">
+                          <a:solidFill>
+                            <a:srgbClr val="1F3A3D"/>
+                          </a:solidFill>
+                        </a:defRPr>
+                      </a:pPr>
+                      <a:r>
+                        <a:t>9.13</a:t>
+                      </a:r>
+                    </a:p>
+                  </a:txBody>
+                  <a:tcPr>
+                    <a:solidFill>
+                      <a:srgbClr val="FFFFFF"/>
+                    </a:solidFill>
+                  </a:tcPr>
+                </a:tc>
+                <a:tc>
+                  <a:txBody>
+                    <a:bodyPr/>
+                    <a:lstStyle/>
+                    <a:p>
+                      <a:pPr algn="ctr">
+                        <a:defRPr sz="1200" b="1">
+                          <a:solidFill>
+                            <a:srgbClr val="1F3A3D"/>
+                          </a:solidFill>
+                        </a:defRPr>
+                      </a:pPr>
+                      <a:r>
+                        <a:t>2.89</a:t>
+                      </a:r>
+                    </a:p>
+                  </a:txBody>
+                  <a:tcPr>
+                    <a:solidFill>
+                      <a:srgbClr val="FFF1E6"/>
+                    </a:solidFill>
+                  </a:tcPr>
+                </a:tc>
+                <a:tc>
+                  <a:txBody>
+                    <a:bodyPr/>
+                    <a:lstStyle/>
+                    <a:p>
+                      <a:pPr algn="ctr">
+                        <a:defRPr sz="1200" b="0">
+                          <a:solidFill>
+                            <a:srgbClr val="1F3A3D"/>
+                          </a:solidFill>
+                        </a:defRPr>
+                      </a:pPr>
+                      <a:r>
+                        <a:t>…</a:t>
+                      </a:r>
+                    </a:p>
+                  </a:txBody>
+                  <a:tcPr>
+                    <a:solidFill>
+                      <a:srgbClr val="FFFFFF"/>
+                    </a:solidFill>
+                  </a:tcPr>
+                </a:tc>
+              </a:tr>
+              <a:tr h="384048">
+                <a:tc>
+                  <a:txBody>
+                    <a:bodyPr/>
+                    <a:lstStyle/>
+                    <a:p>
+                      <a:pPr>
+                        <a:defRPr sz="1200" b="1">
+                          <a:solidFill>
+                            <a:srgbClr val="1F3A3D"/>
+                          </a:solidFill>
+                        </a:defRPr>
+                      </a:pPr>
+                      <a:r>
+                        <a:t>Eenheid</a:t>
+                      </a:r>
+                    </a:p>
+                  </a:txBody>
+                  <a:tcPr>
+                    <a:solidFill>
+                      <a:srgbClr val="FFFFFF"/>
+                    </a:solidFill>
+                  </a:tcPr>
+                </a:tc>
+                <a:tc>
+                  <a:txBody>
+                    <a:bodyPr/>
+                    <a:lstStyle/>
+                    <a:p>
+                      <a:pPr algn="ctr">
+                        <a:defRPr sz="1200" b="0">
+                          <a:solidFill>
+                            <a:srgbClr val="1F3A3D"/>
+                          </a:solidFill>
+                        </a:defRPr>
+                      </a:pPr>
+                      <a:r>
+                        <a:t>vlak (≈ 100 m)</a:t>
+                      </a:r>
+                    </a:p>
+                  </a:txBody>
+                  <a:tcPr>
+                    <a:solidFill>
+                      <a:srgbClr val="FFFFFF"/>
+                    </a:solidFill>
+                  </a:tcPr>
+                </a:tc>
+                <a:tc>
+                  <a:txBody>
+                    <a:bodyPr/>
+                    <a:lstStyle/>
+                    <a:p>
+                      <a:pPr algn="ctr">
+                        <a:defRPr sz="1200" b="0">
+                          <a:solidFill>
+                            <a:srgbClr val="1F3A3D"/>
+                          </a:solidFill>
+                        </a:defRPr>
+                      </a:pPr>
+                      <a:r>
+                        <a:t>vlak (≈ 100 m)</a:t>
+                      </a:r>
+                    </a:p>
+                  </a:txBody>
+                  <a:tcPr>
+                    <a:solidFill>
+                      <a:srgbClr val="FFFFFF"/>
+                    </a:solidFill>
+                  </a:tcPr>
+                </a:tc>
+                <a:tc>
+                  <a:txBody>
+                    <a:bodyPr/>
+                    <a:lstStyle/>
+                    <a:p>
+                      <a:pPr algn="ctr">
+                        <a:defRPr sz="1200" b="1">
+                          <a:solidFill>
+                            <a:srgbClr val="1F3A3D"/>
+                          </a:solidFill>
+                        </a:defRPr>
+                      </a:pPr>
+                      <a:r>
+                        <a:t>segment (≈ 5 m)</a:t>
+                      </a:r>
+                    </a:p>
+                  </a:txBody>
+                  <a:tcPr>
+                    <a:solidFill>
+                      <a:srgbClr val="FFF1E6"/>
+                    </a:solidFill>
+                  </a:tcPr>
+                </a:tc>
+                <a:tc>
+                  <a:txBody>
+                    <a:bodyPr/>
+                    <a:lstStyle/>
+                    <a:p>
+                      <a:pPr algn="ctr">
+                        <a:defRPr sz="1200" b="0">
+                          <a:solidFill>
+                            <a:srgbClr val="1F3A3D"/>
+                          </a:solidFill>
+                        </a:defRPr>
+                      </a:pPr>
+                      <a:r>
+                        <a:t>segment (≈ 5 m)</a:t>
+                      </a:r>
+                    </a:p>
+                  </a:txBody>
+                  <a:tcPr>
+                    <a:solidFill>
+                      <a:srgbClr val="FFFFFF"/>
+                    </a:solidFill>
+                  </a:tcPr>
+                </a:tc>
+              </a:tr>
+              <a:tr h="384048">
+                <a:tc>
+                  <a:txBody>
+                    <a:bodyPr/>
+                    <a:lstStyle/>
+                    <a:p>
+                      <a:pPr>
+                        <a:defRPr sz="1200" b="1">
+                          <a:solidFill>
+                            <a:srgbClr val="1F3A3D"/>
+                          </a:solidFill>
+                        </a:defRPr>
+                      </a:pPr>
+                      <a:r>
+                        <a:t>Tijd tussen t-punten</a:t>
+                      </a:r>
+                    </a:p>
+                  </a:txBody>
+                  <a:tcPr>
+                    <a:solidFill>
+                      <a:srgbClr val="FFFFFF"/>
+                    </a:solidFill>
+                  </a:tcPr>
+                </a:tc>
+                <a:tc>
+                  <a:txBody>
+                    <a:bodyPr/>
+                    <a:lstStyle/>
+                    <a:p>
+                      <a:pPr algn="ctr">
+                        <a:defRPr sz="1200" b="0">
+                          <a:solidFill>
+                            <a:srgbClr val="1F3A3D"/>
+                          </a:solidFill>
+                        </a:defRPr>
+                      </a:pPr>
+                      <a:r>
+                        <a:t>3–4 jaar</a:t>
+                      </a:r>
+                    </a:p>
+                  </a:txBody>
+                  <a:tcPr>
+                    <a:solidFill>
+                      <a:srgbClr val="FFFFFF"/>
+                    </a:solidFill>
+                  </a:tcPr>
+                </a:tc>
+                <a:tc>
+                  <a:txBody>
+                    <a:bodyPr/>
+                    <a:lstStyle/>
+                    <a:p>
+                      <a:pPr algn="ctr">
+                        <a:defRPr sz="1200" b="0">
+                          <a:solidFill>
+                            <a:srgbClr val="1F3A3D"/>
+                          </a:solidFill>
+                        </a:defRPr>
+                      </a:pPr>
+                      <a:r>
+                        <a:t>1 jaar</a:t>
+                      </a:r>
+                    </a:p>
+                  </a:txBody>
+                  <a:tcPr>
+                    <a:solidFill>
+                      <a:srgbClr val="FFFFFF"/>
+                    </a:solidFill>
+                  </a:tcPr>
+                </a:tc>
+                <a:tc>
+                  <a:txBody>
+                    <a:bodyPr/>
+                    <a:lstStyle/>
+                    <a:p>
+                      <a:pPr algn="ctr">
+                        <a:defRPr sz="1200" b="1">
+                          <a:solidFill>
+                            <a:srgbClr val="1F3A3D"/>
+                          </a:solidFill>
+                        </a:defRPr>
+                      </a:pPr>
+                      <a:r>
+                        <a:t>≥ 2 jaar (alle paren)</a:t>
+                      </a:r>
+                    </a:p>
+                  </a:txBody>
+                  <a:tcPr>
+                    <a:solidFill>
+                      <a:srgbClr val="FFF1E6"/>
+                    </a:solidFill>
+                  </a:tcPr>
+                </a:tc>
+                <a:tc>
+                  <a:txBody>
+                    <a:bodyPr/>
+                    <a:lstStyle/>
+                    <a:p>
+                      <a:pPr algn="ctr">
+                        <a:defRPr sz="1200" b="0">
+                          <a:solidFill>
+                            <a:srgbClr val="1F3A3D"/>
+                          </a:solidFill>
+                        </a:defRPr>
+                      </a:pPr>
+                      <a:r>
+                        <a:t>≥ 2 jaar (alle paren)</a:t>
+                      </a:r>
+                    </a:p>
+                  </a:txBody>
+                  <a:tcPr>
+                    <a:solidFill>
+                      <a:srgbClr val="FFFFFF"/>
+                    </a:solidFill>
+                  </a:tcPr>
+                </a:tc>
+              </a:tr>
+              <a:tr h="384048">
+                <a:tc>
+                  <a:txBody>
+                    <a:bodyPr/>
+                    <a:lstStyle/>
+                    <a:p>
+                      <a:pPr>
+                        <a:defRPr sz="1200" b="1">
+                          <a:solidFill>
+                            <a:srgbClr val="1F3A3D"/>
+                          </a:solidFill>
+                        </a:defRPr>
+                      </a:pPr>
+                      <a:r>
+                        <a:t>Testset</a:t>
+                      </a:r>
+                    </a:p>
+                  </a:txBody>
+                  <a:tcPr>
+                    <a:solidFill>
+                      <a:srgbClr val="FFFFFF"/>
+                    </a:solidFill>
+                  </a:tcPr>
+                </a:tc>
+                <a:tc>
+                  <a:txBody>
+                    <a:bodyPr/>
+                    <a:lstStyle/>
+                    <a:p>
+                      <a:pPr algn="ctr">
+                        <a:defRPr sz="1200" b="0">
+                          <a:solidFill>
+                            <a:srgbClr val="1F3A3D"/>
+                          </a:solidFill>
+                        </a:defRPr>
+                      </a:pPr>
+                      <a:r>
+                        <a:t>willekeurig 20 %</a:t>
+                      </a:r>
+                    </a:p>
+                  </a:txBody>
+                  <a:tcPr>
+                    <a:solidFill>
+                      <a:srgbClr val="FFFFFF"/>
+                    </a:solidFill>
+                  </a:tcPr>
+                </a:tc>
+                <a:tc>
+                  <a:txBody>
+                    <a:bodyPr/>
+                    <a:lstStyle/>
+                    <a:p>
+                      <a:pPr algn="ctr">
+                        <a:defRPr sz="1200" b="0">
+                          <a:solidFill>
+                            <a:srgbClr val="1F3A3D"/>
+                          </a:solidFill>
+                        </a:defRPr>
+                      </a:pPr>
+                      <a:r>
+                        <a:t>willekeurig 20 %</a:t>
+                      </a:r>
+                    </a:p>
+                  </a:txBody>
+                  <a:tcPr>
+                    <a:solidFill>
+                      <a:srgbClr val="FFFFFF"/>
+                    </a:solidFill>
+                  </a:tcPr>
+                </a:tc>
+                <a:tc>
+                  <a:txBody>
+                    <a:bodyPr/>
+                    <a:lstStyle/>
+                    <a:p>
+                      <a:pPr algn="ctr">
+                        <a:defRPr sz="1200" b="1">
+                          <a:solidFill>
+                            <a:srgbClr val="1F3A3D"/>
+                          </a:solidFill>
+                        </a:defRPr>
+                      </a:pPr>
+                      <a:r>
+                        <a:t>vast · 715 vlakken · 8 578 segmenten</a:t>
+                      </a:r>
+                    </a:p>
+                  </a:txBody>
+                  <a:tcPr>
+                    <a:solidFill>
+                      <a:srgbClr val="FFF1E6"/>
+                    </a:solidFill>
+                  </a:tcPr>
+                </a:tc>
+                <a:tc>
+                  <a:txBody>
+                    <a:bodyPr/>
+                    <a:lstStyle/>
+                    <a:p>
+                      <a:pPr algn="ctr">
+                        <a:defRPr sz="1200" b="0">
+                          <a:solidFill>
+                            <a:srgbClr val="1F3A3D"/>
+                          </a:solidFill>
+                        </a:defRPr>
+                      </a:pPr>
+                      <a:r>
+                        <a:t>willekeurig 20 %</a:t>
+                      </a:r>
+                    </a:p>
+                  </a:txBody>
+                  <a:tcPr>
+                    <a:solidFill>
+                      <a:srgbClr val="FFFFFF"/>
+                    </a:solidFill>
+                  </a:tcPr>
+                </a:tc>
+              </a:tr>
+              <a:tr h="384048">
+                <a:tc>
+                  <a:txBody>
+                    <a:bodyPr/>
+                    <a:lstStyle/>
+                    <a:p>
+                      <a:pPr>
+                        <a:defRPr sz="1200" b="1">
+                          <a:solidFill>
+                            <a:srgbClr val="1F3A3D"/>
+                          </a:solidFill>
+                        </a:defRPr>
+                      </a:pPr>
+                      <a:r>
+                        <a:t>Validatie</a:t>
+                      </a:r>
+                    </a:p>
+                  </a:txBody>
+                  <a:tcPr>
+                    <a:solidFill>
+                      <a:srgbClr val="FFFFFF"/>
+                    </a:solidFill>
+                  </a:tcPr>
+                </a:tc>
+                <a:tc>
+                  <a:txBody>
+                    <a:bodyPr/>
+                    <a:lstStyle/>
+                    <a:p>
+                      <a:pPr algn="ctr">
+                        <a:defRPr sz="1200" b="0">
+                          <a:solidFill>
+                            <a:srgbClr val="1F3A3D"/>
+                          </a:solidFill>
+                        </a:defRPr>
+                      </a:pPr>
+                      <a:r>
+                        <a:t>test-set early stopping</a:t>
+                      </a:r>
+                    </a:p>
+                  </a:txBody>
+                  <a:tcPr>
+                    <a:solidFill>
+                      <a:srgbClr val="FFFFFF"/>
+                    </a:solidFill>
+                  </a:tcPr>
+                </a:tc>
+                <a:tc>
+                  <a:txBody>
+                    <a:bodyPr/>
+                    <a:lstStyle/>
+                    <a:p>
+                      <a:pPr algn="ctr">
+                        <a:defRPr sz="1200" b="0">
+                          <a:solidFill>
+                            <a:srgbClr val="1F3A3D"/>
+                          </a:solidFill>
+                        </a:defRPr>
+                      </a:pPr>
+                      <a:r>
+                        <a:t>test-set early stopping</a:t>
+                      </a:r>
+                    </a:p>
+                  </a:txBody>
+                  <a:tcPr>
+                    <a:solidFill>
+                      <a:srgbClr val="FFFFFF"/>
+                    </a:solidFill>
+                  </a:tcPr>
+                </a:tc>
+                <a:tc>
+                  <a:txBody>
+                    <a:bodyPr/>
+                    <a:lstStyle/>
+                    <a:p>
+                      <a:pPr algn="ctr">
+                        <a:defRPr sz="1200" b="1">
+                          <a:solidFill>
+                            <a:srgbClr val="1F3A3D"/>
+                          </a:solidFill>
+                        </a:defRPr>
+                      </a:pPr>
+                      <a:r>
+                        <a:t>test-set early stopping</a:t>
+                      </a:r>
+                    </a:p>
+                  </a:txBody>
+                  <a:tcPr>
+                    <a:solidFill>
+                      <a:srgbClr val="FFF1E6"/>
+                    </a:solidFill>
+                  </a:tcPr>
+                </a:tc>
+                <a:tc>
+                  <a:txBody>
+                    <a:bodyPr/>
+                    <a:lstStyle/>
+                    <a:p>
+                      <a:pPr algn="ctr">
+                        <a:defRPr sz="1200" b="0">
+                          <a:solidFill>
+                            <a:srgbClr val="1F3A3D"/>
+                          </a:solidFill>
+                        </a:defRPr>
+                      </a:pPr>
+                      <a:r>
+                        <a:t>testset buiten de training</a:t>
+                      </a:r>
+                    </a:p>
+                  </a:txBody>
+                  <a:tcPr>
+                    <a:solidFill>
+                      <a:srgbClr val="FFFFFF"/>
+                    </a:solidFill>
+                  </a:tcPr>
+                </a:tc>
               </a:tr>
             </a:tbl>
           </a:graphicData>
@@ -5514,14 +6059,14 @@
       </p:graphicFrame>
       <p:sp>
         <p:nvSpPr>
-          <p:cNvPr id="6" name="TextBox 5"/>
+          <p:cNvPr id="7" name="TextBox 6"/>
           <p:cNvSpPr txBox="1"/>
           <p:nvPr/>
         </p:nvSpPr>
         <p:spPr>
           <a:xfrm>
-            <a:off x="548640" y="4023360"/>
-            <a:ext cx="10972800" cy="2286000"/>
+            <a:off x="548640" y="5257800"/>
+            <a:ext cx="11064240" cy="1005840"/>
           </a:xfrm>
           <a:prstGeom prst="rect">
             <a:avLst/>
@@ -5535,62 +6080,14 @@
           <a:lstStyle/>
           <a:p>
             <a:pPr>
-              <a:spcAft>
-                <a:spcPts val="400"/>
-              </a:spcAft>
-              <a:defRPr sz="1300" b="0">
-                <a:solidFill>
-                  <a:srgbClr val="1F3A3D"/>
+              <a:defRPr sz="1100" b="0" i="1">
+                <a:solidFill>
+                  <a:srgbClr val="6B7778"/>
                 </a:solidFill>
               </a:defRPr>
             </a:pPr>
             <a:r>
-              <a:t>• Slide 13 = het experiment op de vaste testset (met test-set early stopping); dit = de volledige pipeline op een nieuwe splitsing zónder de testset in de training — strenger, en daarom hoger: 2.13 → 2.47 en 1.07 → 1.23 (R = 5; R = 20 volgt in de volgende run)</a:t>
-            </a:r>
-          </a:p>
-          <a:p>
-            <a:pPr>
-              <a:spcAft>
-                <a:spcPts val="400"/>
-              </a:spcAft>
-              <a:defRPr sz="1300" b="0">
-                <a:solidFill>
-                  <a:srgbClr val="1F3A3D"/>
-                </a:solidFill>
-              </a:defRPr>
-            </a:pPr>
-            <a:r>
-              <a:t>• Vlakken met voorspelling 8 006 → 10 721</a:t>
-            </a:r>
-          </a:p>
-          <a:p>
-            <a:pPr>
-              <a:spcAft>
-                <a:spcPts val="400"/>
-              </a:spcAft>
-              <a:defRPr sz="1300" b="0">
-                <a:solidFill>
-                  <a:srgbClr val="1F3A3D"/>
-                </a:solidFill>
-              </a:defRPr>
-            </a:pPr>
-            <a:r>
-              <a:t>• 1.23 is m/jr op de ≥ 2-jaar-meetlat — lees het als '31 % beter dan niets doen', niet als '2× beter dan 2.47'</a:t>
-            </a:r>
-          </a:p>
-          <a:p>
-            <a:pPr>
-              <a:spcAft>
-                <a:spcPts val="400"/>
-              </a:spcAft>
-              <a:defRPr sz="1300" b="0">
-                <a:solidFill>
-                  <a:srgbClr val="1F3A3D"/>
-                </a:solidFill>
-              </a:defRPr>
-            </a:pPr>
-            <a:r>
-              <a:t>• Toezegging 10× (op 4.12): nu 1.7× op die exacte meetlat, met strengere validatie</a:t>
+              <a:t>Let op: de 'nu'-kolom is het experiment (vaste testset, 715 vlakken met een ≥ 2-jaar-paar, R = 20); pas na de eerlijke run op een willekeurige splitsing zijn de kolommen echt vergelijkbaar. De vorige eerlijke run (R = 5, 1 jr) gaf 2.47 / 5.0 per vlak en 1.23 / 3.5 per segment.</a:t>
             </a:r>
           </a:p>
         </p:txBody>
@@ -5622,7 +6119,42 @@
       </p:grpSpPr>
       <p:sp>
         <p:nvSpPr>
-          <p:cNvPr id="2" name="TextBox 1"/>
+          <p:cNvPr id="4" name="TextBox 3"/>
+          <p:cNvSpPr txBox="1"/>
+          <p:nvPr/>
+        </p:nvSpPr>
+        <p:spPr>
+          <a:xfrm>
+            <a:off x="548640" y="6400800"/>
+            <a:ext cx="10972800" cy="274320"/>
+          </a:xfrm>
+          <a:prstGeom prst="rect">
+            <a:avLst/>
+          </a:prstGeom>
+          <a:noFill/>
+        </p:spPr>
+        <p:txBody>
+          <a:bodyPr wrap="none">
+            <a:spAutoFit/>
+          </a:bodyPr>
+          <a:lstStyle/>
+          <a:p>
+            <a:pPr>
+              <a:defRPr sz="1000">
+                <a:solidFill>
+                  <a:srgbClr val="6B7778"/>
+                </a:solidFill>
+              </a:defRPr>
+            </a:pPr>
+            <a:r>
+              <a:t>Oevererosietool · update 26-08-2026 · 15</a:t>
+            </a:r>
+          </a:p>
+        </p:txBody>
+      </p:sp>
+      <p:sp>
+        <p:nvSpPr>
+          <p:cNvPr id="5" name="TextBox 4"/>
           <p:cNvSpPr txBox="1"/>
           <p:nvPr/>
         </p:nvSpPr>
@@ -5637,27 +6169,27 @@
           <a:noFill/>
         </p:spPr>
         <p:txBody>
-          <a:bodyPr wrap="none">
+          <a:bodyPr wrap="square">
             <a:spAutoFit/>
           </a:bodyPr>
           <a:lstStyle/>
           <a:p>
             <a:pPr>
-              <a:defRPr sz="3000" b="1">
+              <a:defRPr sz="3000" b="1" i="0">
                 <a:solidFill>
                   <a:srgbClr val="2BB5A6"/>
                 </a:solidFill>
               </a:defRPr>
             </a:pPr>
             <a:r>
-              <a:t>Wat we vragen</a:t>
-            </a:r>
-          </a:p>
-        </p:txBody>
-      </p:sp>
-      <p:sp>
-        <p:nvSpPr>
-          <p:cNvPr id="3" name="TextBox 2"/>
+              <a:t>Samenvattend — en waar we jullie input op willen</a:t>
+            </a:r>
+          </a:p>
+        </p:txBody>
+      </p:sp>
+      <p:sp>
+        <p:nvSpPr>
+          <p:cNvPr id="6" name="TextBox 5"/>
           <p:cNvSpPr txBox="1"/>
           <p:nvPr/>
         </p:nvSpPr>
@@ -5672,62 +6204,27 @@
           <a:noFill/>
         </p:spPr>
         <p:txBody>
-          <a:bodyPr wrap="none">
+          <a:bodyPr wrap="square">
             <a:spAutoFit/>
           </a:bodyPr>
           <a:lstStyle/>
           <a:p>
             <a:pPr>
-              <a:defRPr sz="1700">
+              <a:defRPr sz="1700" b="0" i="0">
                 <a:solidFill>
                   <a:srgbClr val="1F3A3D"/>
                 </a:solidFill>
               </a:defRPr>
             </a:pPr>
             <a:r>
-              <a:t>Labelen is trial-and-error — geen eenmalige levering</a:t>
-            </a:r>
-          </a:p>
-        </p:txBody>
-      </p:sp>
-      <p:sp>
-        <p:nvSpPr>
-          <p:cNvPr id="4" name="TextBox 3"/>
-          <p:cNvSpPr txBox="1"/>
-          <p:nvPr/>
-        </p:nvSpPr>
-        <p:spPr>
-          <a:xfrm>
-            <a:off x="548640" y="6400800"/>
-            <a:ext cx="10972800" cy="274320"/>
-          </a:xfrm>
-          <a:prstGeom prst="rect">
-            <a:avLst/>
-          </a:prstGeom>
-          <a:noFill/>
-        </p:spPr>
-        <p:txBody>
-          <a:bodyPr wrap="none">
-            <a:spAutoFit/>
-          </a:bodyPr>
-          <a:lstStyle/>
-          <a:p>
-            <a:pPr>
-              <a:defRPr sz="1000">
-                <a:solidFill>
-                  <a:srgbClr val="6B7778"/>
-                </a:solidFill>
-              </a:defRPr>
-            </a:pPr>
-            <a:r>
-              <a:t>Oevererosietool · update 26-08-2026 · 15</a:t>
-            </a:r>
-          </a:p>
-        </p:txBody>
-      </p:sp>
-      <p:sp>
-        <p:nvSpPr>
-          <p:cNvPr id="5" name="Rectangle 4"/>
+              <a:t>Opschonen leverde het meest · van lijn naar oever · de regels raken op: wat overblijft vraagt kennis van de data</a:t>
+            </a:r>
+          </a:p>
+        </p:txBody>
+      </p:sp>
+      <p:sp>
+        <p:nvSpPr>
+          <p:cNvPr id="7" name="Rectangle 6"/>
           <p:cNvSpPr/>
           <p:nvPr/>
         </p:nvSpPr>
@@ -5740,7 +6237,7 @@
             <a:avLst/>
           </a:prstGeom>
           <a:solidFill>
-            <a:srgbClr val="2BB5A6"/>
+            <a:srgbClr val="E07A3F"/>
           </a:solidFill>
           <a:ln>
             <a:noFill/>
@@ -5772,21 +6269,21 @@
               </a:defRPr>
             </a:pPr>
             <a:r>
-              <a:t>Hoogtemodel-engineers</a:t>
-            </a:r>
-          </a:p>
-        </p:txBody>
-      </p:sp>
-      <p:sp>
-        <p:nvSpPr>
-          <p:cNvPr id="6" name="TextBox 5"/>
+              <a:t>Feedback gevraagd</a:t>
+            </a:r>
+          </a:p>
+        </p:txBody>
+      </p:sp>
+      <p:sp>
+        <p:nvSpPr>
+          <p:cNvPr id="8" name="TextBox 7"/>
           <p:cNvSpPr txBox="1"/>
           <p:nvPr/>
         </p:nvSpPr>
         <p:spPr>
           <a:xfrm>
             <a:off x="548640" y="2377440"/>
-            <a:ext cx="3566160" cy="3474720"/>
+            <a:ext cx="3566160" cy="3840480"/>
           </a:xfrm>
           <a:prstGeom prst="rect">
             <a:avLst/>
@@ -5803,14 +6300,14 @@
               <a:spcAft>
                 <a:spcPts val="600"/>
               </a:spcAft>
-              <a:defRPr sz="1500" b="0">
+              <a:defRPr sz="1300">
                 <a:solidFill>
                   <a:srgbClr val="1F3A3D"/>
                 </a:solidFill>
               </a:defRPr>
             </a:pPr>
             <a:r>
-              <a:t>• De vijfdeling (scope_coverage) meeleveren</a:t>
+              <a:t>• Welke bewerking heeft de SAM-data nog nodig? Kronkelende lijnen, doolhoven en uitschieters in de tijd zijn puur SAM-verschijnselen</a:t>
             </a:r>
           </a:p>
           <a:p>
@@ -5818,14 +6315,14 @@
               <a:spcAft>
                 <a:spcPts val="600"/>
               </a:spcAft>
-              <a:defRPr sz="1500" b="0">
+              <a:defRPr sz="1300">
                 <a:solidFill>
                   <a:srgbClr val="1F3A3D"/>
                 </a:solidFill>
               </a:defRPr>
             </a:pPr>
             <a:r>
-              <a:t>• Per lijn een vlag: 'dit is een constructie / verkeerde oever'</a:t>
+              <a:t>• Welke parameters bepalen de output van het hybride model? We willen daaraan draaien: ook ná filteren is het pure hoogtemodel nauwkeuriger — SAM segmenteert en mikt niet op een rechte lijn</a:t>
             </a:r>
           </a:p>
           <a:p>
@@ -5833,21 +6330,21 @@
               <a:spcAft>
                 <a:spcPts val="600"/>
               </a:spcAft>
-              <a:defRPr sz="1500" b="0">
+              <a:defRPr sz="1300">
                 <a:solidFill>
                   <a:srgbClr val="1F3A3D"/>
                 </a:solidFill>
               </a:defRPr>
             </a:pPr>
             <a:r>
-              <a:t>• Bekende randgevallen: meeroeverig, hoogwater</a:t>
-            </a:r>
-          </a:p>
-        </p:txBody>
-      </p:sp>
-      <p:sp>
-        <p:nvSpPr>
-          <p:cNvPr id="7" name="Rectangle 6"/>
+              <a:t>• Wat missen we in de vijf patronen?</a:t>
+            </a:r>
+          </a:p>
+        </p:txBody>
+      </p:sp>
+      <p:sp>
+        <p:nvSpPr>
+          <p:cNvPr id="9" name="Rectangle 8"/>
           <p:cNvSpPr/>
           <p:nvPr/>
         </p:nvSpPr>
@@ -5892,21 +6389,21 @@
               </a:defRPr>
             </a:pPr>
             <a:r>
-              <a:t>SAM-engineers</a:t>
-            </a:r>
-          </a:p>
-        </p:txBody>
-      </p:sp>
-      <p:sp>
-        <p:nvSpPr>
-          <p:cNvPr id="8" name="TextBox 7"/>
+              <a:t>Wat wij gaan doen</a:t>
+            </a:r>
+          </a:p>
+        </p:txBody>
+      </p:sp>
+      <p:sp>
+        <p:nvSpPr>
+          <p:cNvPr id="10" name="TextBox 9"/>
           <p:cNvSpPr txBox="1"/>
           <p:nvPr/>
         </p:nvSpPr>
         <p:spPr>
           <a:xfrm>
             <a:off x="4389120" y="2377440"/>
-            <a:ext cx="3566160" cy="3474720"/>
+            <a:ext cx="3566160" cy="3840480"/>
           </a:xfrm>
           <a:prstGeom prst="rect">
             <a:avLst/>
@@ -5923,14 +6420,14 @@
               <a:spcAft>
                 <a:spcPts val="600"/>
               </a:spcAft>
-              <a:defRPr sz="1500" b="0">
+              <a:defRPr sz="1300">
                 <a:solidFill>
                   <a:srgbClr val="1F3A3D"/>
                 </a:solidFill>
               </a:defRPr>
             </a:pPr>
             <a:r>
-              <a:t>• Kwaliteitsvlag per meting</a:t>
+              <a:t>• Eindrun op een willekeurige splitsing, testset buiten de training, R = 20 — dan is de tabel compleet</a:t>
             </a:r>
           </a:p>
           <a:p>
@@ -5938,14 +6435,14 @@
               <a:spcAft>
                 <a:spcPts val="600"/>
               </a:spcAft>
-              <a:defRPr sz="1500" b="0">
+              <a:defRPr sz="1300">
                 <a:solidFill>
                   <a:srgbClr val="1F3A3D"/>
                 </a:solidFill>
               </a:defRPr>
             </a:pPr>
             <a:r>
-              <a:t>• Vooral: méér jaren — elk jaar maakt het model vanzelf beter</a:t>
+              <a:t>• De staart onderzoeken: de vlakken met de grootste bijdrage aan de fout én de minst voorspelbare — wat hebben ze gemeen?</a:t>
             </a:r>
           </a:p>
           <a:p>
@@ -5953,21 +6450,21 @@
               <a:spcAft>
                 <a:spcPts val="600"/>
               </a:spcAft>
-              <a:defRPr sz="1500" b="0">
+              <a:defRPr sz="1300">
                 <a:solidFill>
                   <a:srgbClr val="1F3A3D"/>
                 </a:solidFill>
               </a:defRPr>
             </a:pPr>
             <a:r>
-              <a:t>• Waar mogelijk: één lijn per meetmoment</a:t>
-            </a:r>
-          </a:p>
-        </p:txBody>
-      </p:sp>
-      <p:sp>
-        <p:nvSpPr>
-          <p:cNvPr id="9" name="Rectangle 8"/>
+              <a:t>• Lijnbemonstering verdichten zodat segmenten zonder meting verdwijnen</a:t>
+            </a:r>
+          </a:p>
+        </p:txBody>
+      </p:sp>
+      <p:sp>
+        <p:nvSpPr>
+          <p:cNvPr id="11" name="Rectangle 10"/>
           <p:cNvSpPr/>
           <p:nvPr/>
         </p:nvSpPr>
@@ -5980,7 +6477,7 @@
             <a:avLst/>
           </a:prstGeom>
           <a:solidFill>
-            <a:srgbClr val="E07A3F"/>
+            <a:srgbClr val="1F3A3D"/>
           </a:solidFill>
           <a:ln>
             <a:noFill/>
@@ -6012,21 +6509,21 @@
               </a:defRPr>
             </a:pPr>
             <a:r>
-              <a:t>Samen</a:t>
-            </a:r>
-          </a:p>
-        </p:txBody>
-      </p:sp>
-      <p:sp>
-        <p:nvSpPr>
-          <p:cNvPr id="10" name="TextBox 9"/>
+              <a:t>Wat er staat</a:t>
+            </a:r>
+          </a:p>
+        </p:txBody>
+      </p:sp>
+      <p:sp>
+        <p:nvSpPr>
+          <p:cNvPr id="12" name="TextBox 11"/>
           <p:cNvSpPr txBox="1"/>
           <p:nvPr/>
         </p:nvSpPr>
         <p:spPr>
           <a:xfrm>
             <a:off x="8229600" y="2377440"/>
-            <a:ext cx="3566160" cy="3474720"/>
+            <a:ext cx="3566160" cy="3840480"/>
           </a:xfrm>
           <a:prstGeom prst="rect">
             <a:avLst/>
@@ -6043,14 +6540,14 @@
               <a:spcAft>
                 <a:spcPts val="600"/>
               </a:spcAft>
-              <a:defRPr sz="1500" b="0">
+              <a:defRPr sz="1300">
                 <a:solidFill>
                   <a:srgbClr val="1F3A3D"/>
                 </a:solidFill>
               </a:defRPr>
             </a:pPr>
             <a:r>
-              <a:t>• Labelronde in QGIS: wij leveren de gesorteerde lijst twijfelgevallen, jullie het oordeel</a:t>
+              <a:t>• Model klaar, alle stappen op één vaste testset: 3.99 → 2.27 (opschonen) → 2.13 (historie) → 1.37 (paren ≥ 2 jr) → 0.85 (R = 20)</a:t>
             </a:r>
           </a:p>
           <a:p>
@@ -6058,14 +6555,14 @@
               <a:spcAft>
                 <a:spcPts val="600"/>
               </a:spcAft>
-              <a:defRPr sz="1500" b="0">
+              <a:defRPr sz="1300">
                 <a:solidFill>
                   <a:srgbClr val="1F3A3D"/>
                 </a:solidFill>
               </a:defRPr>
             </a:pPr>
             <a:r>
-              <a:t>• Eerste ronde: ~200 vlakken, twee uur</a:t>
+              <a:t>• Kribben + kunstwerken landelijk als laag; structurenmasker = juistheid, geen foutwinst</a:t>
             </a:r>
           </a:p>
           <a:p>
@@ -6073,504 +6570,14 @@
               <a:spcAft>
                 <a:spcPts val="600"/>
               </a:spcAft>
-              <a:defRPr sz="1500" b="0">
+              <a:defRPr sz="1300">
                 <a:solidFill>
                   <a:srgbClr val="1F3A3D"/>
                 </a:solidFill>
               </a:defRPr>
             </a:pPr>
             <a:r>
-              <a:t>• Daarna meten we opnieuw</a:t>
-            </a:r>
-          </a:p>
-        </p:txBody>
-      </p:sp>
-    </p:spTree>
-  </p:cSld>
-  <p:clrMapOvr>
-    <a:masterClrMapping/>
-  </p:clrMapOvr>
-</p:sld>
-</file>
-
-<file path=ppt/slides/slide16.xml><?xml version="1.0" encoding="utf-8"?>
-<p:sld xmlns:a="http://schemas.openxmlformats.org/drawingml/2006/main" xmlns:r="http://schemas.openxmlformats.org/officeDocument/2006/relationships" xmlns:p="http://schemas.openxmlformats.org/presentationml/2006/main">
-  <p:cSld>
-    <p:spTree>
-      <p:nvGrpSpPr>
-        <p:cNvPr id="1" name=""/>
-        <p:cNvGrpSpPr/>
-        <p:nvPr/>
-      </p:nvGrpSpPr>
-      <p:grpSpPr>
-        <a:xfrm>
-          <a:off x="0" y="0"/>
-          <a:ext cx="0" cy="0"/>
-          <a:chOff x="0" y="0"/>
-          <a:chExt cx="0" cy="0"/>
-        </a:xfrm>
-      </p:grpSpPr>
-      <p:sp>
-        <p:nvSpPr>
-          <p:cNvPr id="2" name="TextBox 1"/>
-          <p:cNvSpPr txBox="1"/>
-          <p:nvPr/>
-        </p:nvSpPr>
-        <p:spPr>
-          <a:xfrm>
-            <a:off x="548640" y="320040"/>
-            <a:ext cx="10972800" cy="731520"/>
-          </a:xfrm>
-          <a:prstGeom prst="rect">
-            <a:avLst/>
-          </a:prstGeom>
-          <a:noFill/>
-        </p:spPr>
-        <p:txBody>
-          <a:bodyPr wrap="none">
-            <a:spAutoFit/>
-          </a:bodyPr>
-          <a:lstStyle/>
-          <a:p>
-            <a:pPr>
-              <a:defRPr sz="3000" b="1">
-                <a:solidFill>
-                  <a:srgbClr val="2BB5A6"/>
-                </a:solidFill>
-              </a:defRPr>
-            </a:pPr>
-            <a:r>
-              <a:t>Wat dit oplevert voor asset management</a:t>
-            </a:r>
-          </a:p>
-        </p:txBody>
-      </p:sp>
-      <p:sp>
-        <p:nvSpPr>
-          <p:cNvPr id="3" name="TextBox 2"/>
-          <p:cNvSpPr txBox="1"/>
-          <p:nvPr/>
-        </p:nvSpPr>
-        <p:spPr>
-          <a:xfrm>
-            <a:off x="548640" y="960120"/>
-            <a:ext cx="10972800" cy="548640"/>
-          </a:xfrm>
-          <a:prstGeom prst="rect">
-            <a:avLst/>
-          </a:prstGeom>
-          <a:noFill/>
-        </p:spPr>
-        <p:txBody>
-          <a:bodyPr wrap="none">
-            <a:spAutoFit/>
-          </a:bodyPr>
-          <a:lstStyle/>
-          <a:p>
-            <a:pPr>
-              <a:defRPr sz="1700">
-                <a:solidFill>
-                  <a:srgbClr val="1F3A3D"/>
-                </a:solidFill>
-              </a:defRPr>
-            </a:pPr>
-            <a:r>
-              <a:t>Van 'dit vlak gemiddeld' naar 'deze 20 meter'</a:t>
-            </a:r>
-          </a:p>
-        </p:txBody>
-      </p:sp>
-      <p:sp>
-        <p:nvSpPr>
-          <p:cNvPr id="4" name="TextBox 3"/>
-          <p:cNvSpPr txBox="1"/>
-          <p:nvPr/>
-        </p:nvSpPr>
-        <p:spPr>
-          <a:xfrm>
-            <a:off x="548640" y="6400800"/>
-            <a:ext cx="10972800" cy="274320"/>
-          </a:xfrm>
-          <a:prstGeom prst="rect">
-            <a:avLst/>
-          </a:prstGeom>
-          <a:noFill/>
-        </p:spPr>
-        <p:txBody>
-          <a:bodyPr wrap="none">
-            <a:spAutoFit/>
-          </a:bodyPr>
-          <a:lstStyle/>
-          <a:p>
-            <a:pPr>
-              <a:defRPr sz="1000">
-                <a:solidFill>
-                  <a:srgbClr val="6B7778"/>
-                </a:solidFill>
-              </a:defRPr>
-            </a:pPr>
-            <a:r>
-              <a:t>Oevererosietool · update 26-08-2026 · 16</a:t>
-            </a:r>
-          </a:p>
-        </p:txBody>
-      </p:sp>
-      <p:pic>
-        <p:nvPicPr>
-          <p:cNvPr id="5" name="Picture 4" descr="r5_rijn_1220.png"/>
-          <p:cNvPicPr>
-            <a:picLocks noChangeAspect="1"/>
-          </p:cNvPicPr>
-          <p:nvPr/>
-        </p:nvPicPr>
-        <p:blipFill>
-          <a:blip r:embed="rId2"/>
-          <a:stretch>
-            <a:fillRect/>
-          </a:stretch>
-        </p:blipFill>
-        <p:spPr>
-          <a:xfrm>
-            <a:off x="548640" y="1554480"/>
-            <a:ext cx="3388524" cy="4480560"/>
-          </a:xfrm>
-          <a:prstGeom prst="rect">
-            <a:avLst/>
-          </a:prstGeom>
-        </p:spPr>
-      </p:pic>
-      <p:sp>
-        <p:nvSpPr>
-          <p:cNvPr id="6" name="TextBox 5"/>
-          <p:cNvSpPr txBox="1"/>
-          <p:nvPr/>
-        </p:nvSpPr>
-        <p:spPr>
-          <a:xfrm>
-            <a:off x="5120640" y="1737360"/>
-            <a:ext cx="6858000" cy="4114800"/>
-          </a:xfrm>
-          <a:prstGeom prst="rect">
-            <a:avLst/>
-          </a:prstGeom>
-          <a:noFill/>
-        </p:spPr>
-        <p:txBody>
-          <a:bodyPr wrap="square">
-            <a:spAutoFit/>
-          </a:bodyPr>
-          <a:lstStyle/>
-          <a:p>
-            <a:pPr>
-              <a:spcAft>
-                <a:spcPts val="600"/>
-              </a:spcAft>
-              <a:defRPr sz="1500" b="0">
-                <a:solidFill>
-                  <a:srgbClr val="1F3A3D"/>
-                </a:solidFill>
-              </a:defRPr>
-            </a:pPr>
-            <a:r>
-              <a:t>• Per segment (≈ 5 m) een verwachte positie ≥ 2 jaar vooruit — mediane positiefout ≈ 0.85 m</a:t>
-            </a:r>
-          </a:p>
-          <a:p>
-            <a:pPr>
-              <a:spcAft>
-                <a:spcPts val="600"/>
-              </a:spcAft>
-              <a:defRPr sz="1500" b="0">
-                <a:solidFill>
-                  <a:srgbClr val="1F3A3D"/>
-                </a:solidFill>
-              </a:defRPr>
-            </a:pPr>
-            <a:r>
-              <a:t>• Een vlak kleurt rood zodra énig segment de signaleringslijn nadert — met het segment erbij</a:t>
-            </a:r>
-          </a:p>
-          <a:p>
-            <a:pPr>
-              <a:spcAft>
-                <a:spcPts val="600"/>
-              </a:spcAft>
-              <a:defRPr sz="1500" b="0">
-                <a:solidFill>
-                  <a:srgbClr val="1F3A3D"/>
-                </a:solidFill>
-              </a:defRPr>
-            </a:pPr>
-            <a:r>
-              <a:t>• Kribvakken en meerdelige vlakken worden daarmee vanzelf goed behandeld</a:t>
-            </a:r>
-          </a:p>
-          <a:p>
-            <a:pPr>
-              <a:spcAft>
-                <a:spcPts val="600"/>
-              </a:spcAft>
-              <a:defRPr sz="1500" b="0">
-                <a:solidFill>
-                  <a:srgbClr val="1F3A3D"/>
-                </a:solidFill>
-              </a:defRPr>
-            </a:pPr>
-            <a:r>
-              <a:t>• Bestaande stoplicht-kaart en tijdslider blijven; dit komt er als laag bij</a:t>
-            </a:r>
-          </a:p>
-          <a:p>
-            <a:pPr>
-              <a:spcAft>
-                <a:spcPts val="600"/>
-              </a:spcAft>
-              <a:defRPr sz="1500" b="1">
-                <a:solidFill>
-                  <a:srgbClr val="1F3A3D"/>
-                </a:solidFill>
-              </a:defRPr>
-            </a:pPr>
-            <a:r>
-              <a:t>Status: segmentvoorspellingen staan klaar; koppeling aan het VVR-alarm is de volgende stap</a:t>
-            </a:r>
-          </a:p>
-        </p:txBody>
-      </p:sp>
-    </p:spTree>
-  </p:cSld>
-  <p:clrMapOvr>
-    <a:masterClrMapping/>
-  </p:clrMapOvr>
-</p:sld>
-</file>
-
-<file path=ppt/slides/slide17.xml><?xml version="1.0" encoding="utf-8"?>
-<p:sld xmlns:a="http://schemas.openxmlformats.org/drawingml/2006/main" xmlns:r="http://schemas.openxmlformats.org/officeDocument/2006/relationships" xmlns:p="http://schemas.openxmlformats.org/presentationml/2006/main">
-  <p:cSld>
-    <p:spTree>
-      <p:nvGrpSpPr>
-        <p:cNvPr id="1" name=""/>
-        <p:cNvGrpSpPr/>
-        <p:nvPr/>
-      </p:nvGrpSpPr>
-      <p:grpSpPr>
-        <a:xfrm>
-          <a:off x="0" y="0"/>
-          <a:ext cx="0" cy="0"/>
-          <a:chOff x="0" y="0"/>
-          <a:chExt cx="0" cy="0"/>
-        </a:xfrm>
-      </p:grpSpPr>
-      <p:sp>
-        <p:nvSpPr>
-          <p:cNvPr id="2" name="TextBox 1"/>
-          <p:cNvSpPr txBox="1"/>
-          <p:nvPr/>
-        </p:nvSpPr>
-        <p:spPr>
-          <a:xfrm>
-            <a:off x="548640" y="320040"/>
-            <a:ext cx="10972800" cy="731520"/>
-          </a:xfrm>
-          <a:prstGeom prst="rect">
-            <a:avLst/>
-          </a:prstGeom>
-          <a:noFill/>
-        </p:spPr>
-        <p:txBody>
-          <a:bodyPr wrap="none">
-            <a:spAutoFit/>
-          </a:bodyPr>
-          <a:lstStyle/>
-          <a:p>
-            <a:pPr>
-              <a:defRPr sz="3000" b="1">
-                <a:solidFill>
-                  <a:srgbClr val="2BB5A6"/>
-                </a:solidFill>
-              </a:defRPr>
-            </a:pPr>
-            <a:r>
-              <a:t>Samenvattend</a:t>
-            </a:r>
-          </a:p>
-        </p:txBody>
-      </p:sp>
-      <p:sp>
-        <p:nvSpPr>
-          <p:cNvPr id="3" name="TextBox 2"/>
-          <p:cNvSpPr txBox="1"/>
-          <p:nvPr/>
-        </p:nvSpPr>
-        <p:spPr>
-          <a:xfrm>
-            <a:off x="548640" y="6400800"/>
-            <a:ext cx="10972800" cy="274320"/>
-          </a:xfrm>
-          <a:prstGeom prst="rect">
-            <a:avLst/>
-          </a:prstGeom>
-          <a:noFill/>
-        </p:spPr>
-        <p:txBody>
-          <a:bodyPr wrap="none">
-            <a:spAutoFit/>
-          </a:bodyPr>
-          <a:lstStyle/>
-          <a:p>
-            <a:pPr>
-              <a:defRPr sz="1000">
-                <a:solidFill>
-                  <a:srgbClr val="6B7778"/>
-                </a:solidFill>
-              </a:defRPr>
-            </a:pPr>
-            <a:r>
-              <a:t>Oevererosietool · update 26-08-2026 · 17</a:t>
-            </a:r>
-          </a:p>
-        </p:txBody>
-      </p:sp>
-      <p:sp>
-        <p:nvSpPr>
-          <p:cNvPr id="4" name="TextBox 3"/>
-          <p:cNvSpPr txBox="1"/>
-          <p:nvPr/>
-        </p:nvSpPr>
-        <p:spPr>
-          <a:xfrm>
-            <a:off x="548640" y="1463040"/>
-            <a:ext cx="10972800" cy="4754880"/>
-          </a:xfrm>
-          <a:prstGeom prst="rect">
-            <a:avLst/>
-          </a:prstGeom>
-          <a:noFill/>
-        </p:spPr>
-        <p:txBody>
-          <a:bodyPr wrap="square">
-            <a:spAutoFit/>
-          </a:bodyPr>
-          <a:lstStyle/>
-          <a:p>
-            <a:pPr>
-              <a:spcAft>
-                <a:spcPts val="800"/>
-              </a:spcAft>
-              <a:defRPr sz="1800" b="1">
-                <a:solidFill>
-                  <a:srgbClr val="1F3A3D"/>
-                </a:solidFill>
-              </a:defRPr>
-            </a:pPr>
-            <a:r>
-              <a:t>Model: klaar en eerlijk gevalideerd</a:t>
-            </a:r>
-          </a:p>
-          <a:p>
-            <a:pPr>
-              <a:spcAft>
-                <a:spcPts val="800"/>
-              </a:spcAft>
-              <a:defRPr sz="1800" b="0">
-                <a:solidFill>
-                  <a:srgbClr val="1F3A3D"/>
-                </a:solidFill>
-              </a:defRPr>
-            </a:pPr>
-            <a:r>
-              <a:t>• Hybride bron, opschoonregels, historie-features, testset buiten de training</a:t>
-            </a:r>
-          </a:p>
-          <a:p>
-            <a:pPr>
-              <a:spcAft>
-                <a:spcPts val="800"/>
-              </a:spcAft>
-              <a:defRPr sz="1800" b="1">
-                <a:solidFill>
-                  <a:srgbClr val="1F3A3D"/>
-                </a:solidFill>
-              </a:defRPr>
-            </a:pPr>
-            <a:r>
-              <a:t>Van lijn naar oever</a:t>
-            </a:r>
-          </a:p>
-          <a:p>
-            <a:pPr>
-              <a:spcAft>
-                <a:spcPts val="800"/>
-              </a:spcAft>
-              <a:defRPr sz="1800" b="0">
-                <a:solidFill>
-                  <a:srgbClr val="1F3A3D"/>
-                </a:solidFill>
-              </a:defRPr>
-            </a:pPr>
-            <a:r>
-              <a:t>• Twintig segmenten per vlak (≈ 5 m); gemeten én voorspelde oever als lijn; positiefout ≈ 0.85 m op ≥ 2 jaar</a:t>
-            </a:r>
-          </a:p>
-          <a:p>
-            <a:pPr>
-              <a:spcAft>
-                <a:spcPts val="800"/>
-              </a:spcAft>
-              <a:defRPr sz="1800" b="1">
-                <a:solidFill>
-                  <a:srgbClr val="1F3A3D"/>
-                </a:solidFill>
-              </a:defRPr>
-            </a:pPr>
-            <a:r>
-              <a:t>Bottleneck: gelabelde input, niet het algoritme</a:t>
-            </a:r>
-          </a:p>
-          <a:p>
-            <a:pPr>
-              <a:spcAft>
-                <a:spcPts val="800"/>
-              </a:spcAft>
-              <a:defRPr sz="1800" b="0">
-                <a:solidFill>
-                  <a:srgbClr val="1F3A3D"/>
-                </a:solidFill>
-              </a:defRPr>
-            </a:pPr>
-            <a:r>
-              <a:t>• Opschonen leverde 12× zoveel als modelleren; de regels raken op — wat overblijft vraagt een oordeel</a:t>
-            </a:r>
-          </a:p>
-          <a:p>
-            <a:pPr>
-              <a:spcAft>
-                <a:spcPts val="800"/>
-              </a:spcAft>
-              <a:defRPr sz="1800" b="1">
-                <a:solidFill>
-                  <a:srgbClr val="1F3A3D"/>
-                </a:solidFill>
-              </a:defRPr>
-            </a:pPr>
-            <a:r>
-              <a:t>Volgende stap</a:t>
-            </a:r>
-          </a:p>
-          <a:p>
-            <a:pPr>
-              <a:spcAft>
-                <a:spcPts val="800"/>
-              </a:spcAft>
-              <a:defRPr sz="1800" b="0">
-                <a:solidFill>
-                  <a:srgbClr val="1F3A3D"/>
-                </a:solidFill>
-              </a:defRPr>
-            </a:pPr>
-            <a:r>
-              <a:t>• Labelronde met SAM- en hoogtemodel-engineers · VVR-alarm op segmentniveau · daarna opnieuw meten</a:t>
+              <a:t>• Alles reproduceerbaar: ledger met 80+ varianten, rapport per run</a:t>
             </a:r>
           </a:p>
         </p:txBody>

</xml_diff>

<commit_message>
chore: QGIS project in repo, updated 26 Aug deck
qgis/august-input.qgz reads layers relative to ../data/; drop a stray
PowerPoint lock file.

Co-Authored-By: Claude Opus 5.5 <noreply@anthropic.com>
</commit_message>
<xml_diff>
--- a/docs/presentations/20260826_update_v2.pptx
+++ b/docs/presentations/20260826_update_v2.pptx
@@ -5,7 +5,7 @@
     <p:sldMasterId id="2147483648" r:id="rId1"/>
   </p:sldMasterIdLst>
   <p:notesMasterIdLst>
-    <p:notesMasterId r:id="rId20"/>
+    <p:notesMasterId r:id="rId17"/>
   </p:notesMasterIdLst>
   <p:sldIdLst>
     <p:sldId id="256" r:id="rId2"/>
@@ -17,12 +17,12 @@
     <p:sldId id="261" r:id="rId8"/>
     <p:sldId id="272" r:id="rId9"/>
     <p:sldId id="273" r:id="rId10"/>
-    <p:sldId id="262" r:id="rId12"/>
-    <p:sldId id="263" r:id="rId13"/>
-    <p:sldId id="264" r:id="rId14"/>
-    <p:sldId id="265" r:id="rId15"/>
-    <p:sldId id="266" r:id="rId16"/>
-    <p:sldId id="267" r:id="rId17"/>
+    <p:sldId id="262" r:id="rId11"/>
+    <p:sldId id="263" r:id="rId12"/>
+    <p:sldId id="264" r:id="rId13"/>
+    <p:sldId id="265" r:id="rId14"/>
+    <p:sldId id="266" r:id="rId15"/>
+    <p:sldId id="267" r:id="rId16"/>
   </p:sldIdLst>
   <p:sldSz cx="12192000" cy="6858000"/>
   <p:notesSz cx="6858000" cy="9144000"/>
@@ -222,7 +222,7 @@
           <a:p>
             <a:fld id="{215FDD8D-4CBC-4347-B89D-F063BFE20A1D}" type="datetimeFigureOut">
               <a:rPr lang="en-US" smtClean="0"/>
-              <a:t>8/26/26</a:t>
+              <a:t>9/2/26</a:t>
             </a:fld>
             <a:endParaRPr lang="en-US"/>
           </a:p>
@@ -534,7 +534,176 @@
           <a:lstStyle/>
           <a:p>
             <a:r>
-              <a:t>De val: het maartcijfer zag er goed uit omdat de meetlat mild was (3–4 jaar) én omdat één getal per vlak veel verbergt. paars = VVR, zwart = hartlijn, groen = gemeten oever per jaar.</a:t>
+              <a:rPr dirty="0"/>
+              <a:t>De </a:t>
+            </a:r>
+            <a:r>
+              <a:rPr dirty="0" err="1"/>
+              <a:t>val</a:t>
+            </a:r>
+            <a:r>
+              <a:rPr dirty="0"/>
+              <a:t>: het </a:t>
+            </a:r>
+            <a:r>
+              <a:rPr dirty="0" err="1"/>
+              <a:t>maartcijfer</a:t>
+            </a:r>
+            <a:r>
+              <a:rPr dirty="0"/>
+              <a:t> zag er </a:t>
+            </a:r>
+            <a:r>
+              <a:rPr dirty="0" err="1"/>
+              <a:t>goed</a:t>
+            </a:r>
+            <a:r>
+              <a:rPr dirty="0"/>
+              <a:t> </a:t>
+            </a:r>
+            <a:r>
+              <a:rPr dirty="0" err="1"/>
+              <a:t>uit</a:t>
+            </a:r>
+            <a:r>
+              <a:rPr dirty="0"/>
+              <a:t> </a:t>
+            </a:r>
+            <a:r>
+              <a:rPr dirty="0" err="1"/>
+              <a:t>omdat</a:t>
+            </a:r>
+            <a:r>
+              <a:rPr dirty="0"/>
+              <a:t> de </a:t>
+            </a:r>
+            <a:r>
+              <a:rPr dirty="0" err="1"/>
+              <a:t>meetlat</a:t>
+            </a:r>
+            <a:r>
+              <a:rPr dirty="0"/>
+              <a:t> mild was (3–4 </a:t>
+            </a:r>
+            <a:r>
+              <a:rPr dirty="0" err="1"/>
+              <a:t>jaar</a:t>
+            </a:r>
+            <a:r>
+              <a:rPr dirty="0"/>
+              <a:t>) </a:t>
+            </a:r>
+            <a:r>
+              <a:rPr dirty="0" err="1"/>
+              <a:t>én</a:t>
+            </a:r>
+            <a:r>
+              <a:rPr dirty="0"/>
+              <a:t> </a:t>
+            </a:r>
+            <a:r>
+              <a:rPr dirty="0" err="1"/>
+              <a:t>omdat</a:t>
+            </a:r>
+            <a:r>
+              <a:rPr dirty="0"/>
+              <a:t> </a:t>
+            </a:r>
+            <a:r>
+              <a:rPr dirty="0" err="1"/>
+              <a:t>één</a:t>
+            </a:r>
+            <a:r>
+              <a:rPr dirty="0"/>
+              <a:t> </a:t>
+            </a:r>
+            <a:r>
+              <a:rPr dirty="0" err="1"/>
+              <a:t>getal</a:t>
+            </a:r>
+            <a:r>
+              <a:rPr dirty="0"/>
+              <a:t> per </a:t>
+            </a:r>
+            <a:r>
+              <a:rPr dirty="0" err="1"/>
+              <a:t>vlak</a:t>
+            </a:r>
+            <a:r>
+              <a:rPr dirty="0"/>
+              <a:t> </a:t>
+            </a:r>
+            <a:r>
+              <a:rPr dirty="0" err="1"/>
+              <a:t>veel</a:t>
+            </a:r>
+            <a:r>
+              <a:rPr dirty="0"/>
+              <a:t> </a:t>
+            </a:r>
+            <a:r>
+              <a:rPr dirty="0" err="1"/>
+              <a:t>verbergt</a:t>
+            </a:r>
+            <a:r>
+              <a:rPr dirty="0"/>
+              <a:t>. </a:t>
+            </a:r>
+            <a:r>
+              <a:rPr dirty="0" err="1"/>
+              <a:t>paars</a:t>
+            </a:r>
+            <a:r>
+              <a:rPr dirty="0"/>
+              <a:t> = VVR, </a:t>
+            </a:r>
+            <a:r>
+              <a:rPr dirty="0" err="1"/>
+              <a:t>zwart</a:t>
+            </a:r>
+            <a:r>
+              <a:rPr dirty="0"/>
+              <a:t> = </a:t>
+            </a:r>
+            <a:r>
+              <a:rPr dirty="0" err="1"/>
+              <a:t>hartlijn</a:t>
+            </a:r>
+            <a:r>
+              <a:rPr dirty="0"/>
+              <a:t>, </a:t>
+            </a:r>
+            <a:r>
+              <a:rPr dirty="0" err="1"/>
+              <a:t>groen</a:t>
+            </a:r>
+            <a:r>
+              <a:rPr dirty="0"/>
+              <a:t> = </a:t>
+            </a:r>
+            <a:r>
+              <a:rPr dirty="0" err="1"/>
+              <a:t>gemeten</a:t>
+            </a:r>
+            <a:r>
+              <a:rPr dirty="0"/>
+              <a:t> </a:t>
+            </a:r>
+            <a:r>
+              <a:rPr dirty="0" err="1"/>
+              <a:t>oever</a:t>
+            </a:r>
+            <a:r>
+              <a:rPr dirty="0"/>
+              <a:t> per </a:t>
+            </a:r>
+            <a:r>
+              <a:rPr dirty="0" err="1"/>
+              <a:t>jaar</a:t>
+            </a:r>
+            <a:r>
+              <a:rPr dirty="0"/>
+              <a:t>.</a:t>
             </a:r>
           </a:p>
         </p:txBody>
@@ -583,6 +752,90 @@
             <a:spLocks noGrp="1" noRot="1" noChangeAspect="1"/>
           </p:cNvSpPr>
           <p:nvPr>
+            <p:ph type="sldImg"/>
+          </p:nvPr>
+        </p:nvSpPr>
+        <p:spPr/>
+      </p:sp>
+      <p:sp>
+        <p:nvSpPr>
+          <p:cNvPr id="3" name="Notes Placeholder 2"/>
+          <p:cNvSpPr>
+            <a:spLocks noGrp="1"/>
+          </p:cNvSpPr>
+          <p:nvPr>
+            <p:ph type="body" idx="1"/>
+          </p:nvPr>
+        </p:nvSpPr>
+        <p:spPr/>
+        <p:txBody>
+          <a:bodyPr/>
+          <a:lstStyle/>
+          <a:p>
+            <a:endParaRPr lang="en-US" dirty="0"/>
+          </a:p>
+        </p:txBody>
+      </p:sp>
+      <p:sp>
+        <p:nvSpPr>
+          <p:cNvPr id="4" name="Slide Number Placeholder 3"/>
+          <p:cNvSpPr>
+            <a:spLocks noGrp="1"/>
+          </p:cNvSpPr>
+          <p:nvPr>
+            <p:ph type="sldNum" sz="quarter" idx="5"/>
+          </p:nvPr>
+        </p:nvSpPr>
+        <p:spPr/>
+        <p:txBody>
+          <a:bodyPr/>
+          <a:lstStyle/>
+          <a:p>
+            <a:fld id="{3CABB5FF-E68F-F848-8B49-42D48E9715A7}" type="slidenum">
+              <a:rPr lang="en-US" smtClean="0"/>
+              <a:t>12</a:t>
+            </a:fld>
+            <a:endParaRPr lang="en-US"/>
+          </a:p>
+        </p:txBody>
+      </p:sp>
+    </p:spTree>
+    <p:extLst>
+      <p:ext uri="{BB962C8B-B14F-4D97-AF65-F5344CB8AC3E}">
+        <p14:creationId xmlns:p14="http://schemas.microsoft.com/office/powerpoint/2010/main" val="247649612"/>
+      </p:ext>
+    </p:extLst>
+  </p:cSld>
+  <p:clrMapOvr>
+    <a:masterClrMapping/>
+  </p:clrMapOvr>
+</p:notes>
+</file>
+
+<file path=ppt/notesSlides/notesSlide3.xml><?xml version="1.0" encoding="utf-8"?>
+<p:notes xmlns:a="http://schemas.openxmlformats.org/drawingml/2006/main" xmlns:r="http://schemas.openxmlformats.org/officeDocument/2006/relationships" xmlns:p="http://schemas.openxmlformats.org/presentationml/2006/main">
+  <p:cSld>
+    <p:spTree>
+      <p:nvGrpSpPr>
+        <p:cNvPr id="1" name=""/>
+        <p:cNvGrpSpPr/>
+        <p:nvPr/>
+      </p:nvGrpSpPr>
+      <p:grpSpPr>
+        <a:xfrm>
+          <a:off x="0" y="0"/>
+          <a:ext cx="0" cy="0"/>
+          <a:chOff x="0" y="0"/>
+          <a:chExt cx="0" cy="0"/>
+        </a:xfrm>
+      </p:grpSpPr>
+      <p:sp>
+        <p:nvSpPr>
+          <p:cNvPr id="2" name="Slide Image Placeholder 1"/>
+          <p:cNvSpPr>
+            <a:spLocks noGrp="1" noRot="1" noChangeAspect="1"/>
+          </p:cNvSpPr>
+          <p:nvPr>
             <p:ph type="sldImg" idx="2"/>
           </p:nvPr>
         </p:nvSpPr>
@@ -604,7 +857,32 @@
           <a:lstStyle/>
           <a:p>
             <a:r>
-              <a:t>Dit is de hele presentatie in één plaatje.</a:t>
+              <a:rPr dirty="0"/>
+              <a:t>Dit is de hele </a:t>
+            </a:r>
+            <a:r>
+              <a:rPr dirty="0" err="1"/>
+              <a:t>presentatie</a:t>
+            </a:r>
+            <a:r>
+              <a:rPr dirty="0"/>
+              <a:t> in </a:t>
+            </a:r>
+            <a:r>
+              <a:rPr dirty="0" err="1"/>
+              <a:t>één</a:t>
+            </a:r>
+            <a:r>
+              <a:rPr dirty="0"/>
+              <a:t> </a:t>
+            </a:r>
+            <a:r>
+              <a:rPr dirty="0" err="1"/>
+              <a:t>plaatje</a:t>
+            </a:r>
+            <a:r>
+              <a:rPr dirty="0"/>
+              <a:t>.</a:t>
             </a:r>
           </a:p>
         </p:txBody>
@@ -622,6 +900,90 @@
         <p:spPr/>
       </p:sp>
     </p:spTree>
+  </p:cSld>
+  <p:clrMapOvr>
+    <a:masterClrMapping/>
+  </p:clrMapOvr>
+</p:notes>
+</file>
+
+<file path=ppt/notesSlides/notesSlide4.xml><?xml version="1.0" encoding="utf-8"?>
+<p:notes xmlns:a="http://schemas.openxmlformats.org/drawingml/2006/main" xmlns:r="http://schemas.openxmlformats.org/officeDocument/2006/relationships" xmlns:p="http://schemas.openxmlformats.org/presentationml/2006/main">
+  <p:cSld>
+    <p:spTree>
+      <p:nvGrpSpPr>
+        <p:cNvPr id="1" name=""/>
+        <p:cNvGrpSpPr/>
+        <p:nvPr/>
+      </p:nvGrpSpPr>
+      <p:grpSpPr>
+        <a:xfrm>
+          <a:off x="0" y="0"/>
+          <a:ext cx="0" cy="0"/>
+          <a:chOff x="0" y="0"/>
+          <a:chExt cx="0" cy="0"/>
+        </a:xfrm>
+      </p:grpSpPr>
+      <p:sp>
+        <p:nvSpPr>
+          <p:cNvPr id="2" name="Slide Image Placeholder 1"/>
+          <p:cNvSpPr>
+            <a:spLocks noGrp="1" noRot="1" noChangeAspect="1"/>
+          </p:cNvSpPr>
+          <p:nvPr>
+            <p:ph type="sldImg"/>
+          </p:nvPr>
+        </p:nvSpPr>
+        <p:spPr/>
+      </p:sp>
+      <p:sp>
+        <p:nvSpPr>
+          <p:cNvPr id="3" name="Notes Placeholder 2"/>
+          <p:cNvSpPr>
+            <a:spLocks noGrp="1"/>
+          </p:cNvSpPr>
+          <p:nvPr>
+            <p:ph type="body" idx="1"/>
+          </p:nvPr>
+        </p:nvSpPr>
+        <p:spPr/>
+        <p:txBody>
+          <a:bodyPr/>
+          <a:lstStyle/>
+          <a:p>
+            <a:endParaRPr lang="en-US" dirty="0"/>
+          </a:p>
+        </p:txBody>
+      </p:sp>
+      <p:sp>
+        <p:nvSpPr>
+          <p:cNvPr id="4" name="Slide Number Placeholder 3"/>
+          <p:cNvSpPr>
+            <a:spLocks noGrp="1"/>
+          </p:cNvSpPr>
+          <p:nvPr>
+            <p:ph type="sldNum" sz="quarter" idx="5"/>
+          </p:nvPr>
+        </p:nvSpPr>
+        <p:spPr/>
+        <p:txBody>
+          <a:bodyPr/>
+          <a:lstStyle/>
+          <a:p>
+            <a:fld id="{3CABB5FF-E68F-F848-8B49-42D48E9715A7}" type="slidenum">
+              <a:rPr lang="en-US" smtClean="0"/>
+              <a:t>15</a:t>
+            </a:fld>
+            <a:endParaRPr lang="en-US"/>
+          </a:p>
+        </p:txBody>
+      </p:sp>
+    </p:spTree>
+    <p:extLst>
+      <p:ext uri="{BB962C8B-B14F-4D97-AF65-F5344CB8AC3E}">
+        <p14:creationId xmlns:p14="http://schemas.microsoft.com/office/powerpoint/2010/main" val="2652892716"/>
+      </p:ext>
+    </p:extLst>
   </p:cSld>
   <p:clrMapOvr>
     <a:masterClrMapping/>
@@ -808,7 +1170,7 @@
           <a:p>
             <a:fld id="{5BCAD085-E8A6-8845-BD4E-CB4CCA059FC4}" type="datetimeFigureOut">
               <a:rPr lang="en-US" smtClean="0"/>
-              <a:t>8/26/26</a:t>
+              <a:t>9/2/26</a:t>
             </a:fld>
             <a:endParaRPr lang="en-US"/>
           </a:p>
@@ -976,7 +1338,7 @@
           <a:p>
             <a:fld id="{5BCAD085-E8A6-8845-BD4E-CB4CCA059FC4}" type="datetimeFigureOut">
               <a:rPr lang="en-US" smtClean="0"/>
-              <a:t>8/26/26</a:t>
+              <a:t>9/2/26</a:t>
             </a:fld>
             <a:endParaRPr lang="en-US"/>
           </a:p>
@@ -1154,7 +1516,7 @@
           <a:p>
             <a:fld id="{5BCAD085-E8A6-8845-BD4E-CB4CCA059FC4}" type="datetimeFigureOut">
               <a:rPr lang="en-US" smtClean="0"/>
-              <a:t>8/26/26</a:t>
+              <a:t>9/2/26</a:t>
             </a:fld>
             <a:endParaRPr lang="en-US"/>
           </a:p>
@@ -1322,7 +1684,7 @@
           <a:p>
             <a:fld id="{5BCAD085-E8A6-8845-BD4E-CB4CCA059FC4}" type="datetimeFigureOut">
               <a:rPr lang="en-US" smtClean="0"/>
-              <a:t>8/26/26</a:t>
+              <a:t>9/2/26</a:t>
             </a:fld>
             <a:endParaRPr lang="en-US"/>
           </a:p>
@@ -1567,7 +1929,7 @@
           <a:p>
             <a:fld id="{5BCAD085-E8A6-8845-BD4E-CB4CCA059FC4}" type="datetimeFigureOut">
               <a:rPr lang="en-US" smtClean="0"/>
-              <a:t>8/26/26</a:t>
+              <a:t>9/2/26</a:t>
             </a:fld>
             <a:endParaRPr lang="en-US"/>
           </a:p>
@@ -1852,7 +2214,7 @@
           <a:p>
             <a:fld id="{5BCAD085-E8A6-8845-BD4E-CB4CCA059FC4}" type="datetimeFigureOut">
               <a:rPr lang="en-US" smtClean="0"/>
-              <a:t>8/26/26</a:t>
+              <a:t>9/2/26</a:t>
             </a:fld>
             <a:endParaRPr lang="en-US"/>
           </a:p>
@@ -2271,7 +2633,7 @@
           <a:p>
             <a:fld id="{5BCAD085-E8A6-8845-BD4E-CB4CCA059FC4}" type="datetimeFigureOut">
               <a:rPr lang="en-US" smtClean="0"/>
-              <a:t>8/26/26</a:t>
+              <a:t>9/2/26</a:t>
             </a:fld>
             <a:endParaRPr lang="en-US"/>
           </a:p>
@@ -2388,7 +2750,7 @@
           <a:p>
             <a:fld id="{5BCAD085-E8A6-8845-BD4E-CB4CCA059FC4}" type="datetimeFigureOut">
               <a:rPr lang="en-US" smtClean="0"/>
-              <a:t>8/26/26</a:t>
+              <a:t>9/2/26</a:t>
             </a:fld>
             <a:endParaRPr lang="en-US"/>
           </a:p>
@@ -2483,7 +2845,7 @@
           <a:p>
             <a:fld id="{5BCAD085-E8A6-8845-BD4E-CB4CCA059FC4}" type="datetimeFigureOut">
               <a:rPr lang="en-US" smtClean="0"/>
-              <a:t>8/26/26</a:t>
+              <a:t>9/2/26</a:t>
             </a:fld>
             <a:endParaRPr lang="en-US"/>
           </a:p>
@@ -2758,7 +3120,7 @@
           <a:p>
             <a:fld id="{5BCAD085-E8A6-8845-BD4E-CB4CCA059FC4}" type="datetimeFigureOut">
               <a:rPr lang="en-US" smtClean="0"/>
-              <a:t>8/26/26</a:t>
+              <a:t>9/2/26</a:t>
             </a:fld>
             <a:endParaRPr lang="en-US"/>
           </a:p>
@@ -3010,7 +3372,7 @@
           <a:p>
             <a:fld id="{5BCAD085-E8A6-8845-BD4E-CB4CCA059FC4}" type="datetimeFigureOut">
               <a:rPr lang="en-US" smtClean="0"/>
-              <a:t>8/26/26</a:t>
+              <a:t>9/2/26</a:t>
             </a:fld>
             <a:endParaRPr lang="en-US"/>
           </a:p>
@@ -3221,7 +3583,7 @@
           <a:p>
             <a:fld id="{5BCAD085-E8A6-8845-BD4E-CB4CCA059FC4}" type="datetimeFigureOut">
               <a:rPr lang="en-US" smtClean="0"/>
-              <a:t>8/26/26</a:t>
+              <a:t>9/2/26</a:t>
             </a:fld>
             <a:endParaRPr lang="en-US"/>
           </a:p>
@@ -4501,7 +4863,7 @@
           <p:nvPr/>
         </p:nvPicPr>
         <p:blipFill>
-          <a:blip r:embed="rId2"/>
+          <a:blip r:embed="rId3"/>
           <a:stretch>
             <a:fillRect/>
           </a:stretch>
@@ -4606,7 +4968,7 @@
           <p:nvPr/>
         </p:nvPicPr>
         <p:blipFill>
-          <a:blip r:embed="rId5"/>
+          <a:blip r:embed="rId4"/>
           <a:stretch>
             <a:fillRect/>
           </a:stretch>
@@ -4813,7 +5175,7 @@
           <p:nvPr/>
         </p:nvPicPr>
         <p:blipFill>
-          <a:blip r:embed="rId4"/>
+          <a:blip r:embed="rId3"/>
           <a:stretch>
             <a:fillRect/>
           </a:stretch>
@@ -4964,11 +5326,17 @@
           <p:cNvGraphicFramePr>
             <a:graphicFrameLocks noGrp="1"/>
           </p:cNvGraphicFramePr>
-          <p:nvPr/>
+          <p:nvPr>
+            <p:extLst>
+              <p:ext uri="{D42A27DB-BD31-4B8C-83A1-F6EECF244321}">
+                <p14:modId xmlns:p14="http://schemas.microsoft.com/office/powerpoint/2010/main" val="2653217059"/>
+              </p:ext>
+            </p:extLst>
+          </p:nvPr>
         </p:nvGraphicFramePr>
         <p:xfrm>
           <a:off x="548640" y="1600200"/>
-          <a:ext cx="11064240" cy="3456432"/>
+          <a:ext cx="11064240" cy="3968496"/>
         </p:xfrm>
         <a:graphic>
           <a:graphicData uri="http://schemas.openxmlformats.org/drawingml/2006/table">
@@ -4977,11 +5345,41 @@
                 <a:tableStyleId>{5C22544A-7EE6-4342-B048-85BDC9FD1C3A}</a:tableStyleId>
               </a:tblPr>
               <a:tblGrid>
-                <a:gridCol w="3657600"/>
-                <a:gridCol w="1554480"/>
-                <a:gridCol w="1737360"/>
-                <a:gridCol w="2286000"/>
-                <a:gridCol w="1828800"/>
+                <a:gridCol w="3657600">
+                  <a:extLst>
+                    <a:ext uri="{9D8B030D-6E8A-4147-A177-3AD203B41FA5}">
+                      <a16:colId xmlns:a16="http://schemas.microsoft.com/office/drawing/2014/main" val="20000"/>
+                    </a:ext>
+                  </a:extLst>
+                </a:gridCol>
+                <a:gridCol w="1554480">
+                  <a:extLst>
+                    <a:ext uri="{9D8B030D-6E8A-4147-A177-3AD203B41FA5}">
+                      <a16:colId xmlns:a16="http://schemas.microsoft.com/office/drawing/2014/main" val="20001"/>
+                    </a:ext>
+                  </a:extLst>
+                </a:gridCol>
+                <a:gridCol w="1737360">
+                  <a:extLst>
+                    <a:ext uri="{9D8B030D-6E8A-4147-A177-3AD203B41FA5}">
+                      <a16:colId xmlns:a16="http://schemas.microsoft.com/office/drawing/2014/main" val="20002"/>
+                    </a:ext>
+                  </a:extLst>
+                </a:gridCol>
+                <a:gridCol w="2286000">
+                  <a:extLst>
+                    <a:ext uri="{9D8B030D-6E8A-4147-A177-3AD203B41FA5}">
+                      <a16:colId xmlns:a16="http://schemas.microsoft.com/office/drawing/2014/main" val="20003"/>
+                    </a:ext>
+                  </a:extLst>
+                </a:gridCol>
+                <a:gridCol w="1828800">
+                  <a:extLst>
+                    <a:ext uri="{9D8B030D-6E8A-4147-A177-3AD203B41FA5}">
+                      <a16:colId xmlns:a16="http://schemas.microsoft.com/office/drawing/2014/main" val="20004"/>
+                    </a:ext>
+                  </a:extLst>
+                </a:gridCol>
               </a:tblGrid>
               <a:tr h="384048">
                 <a:tc>
@@ -4996,6 +5394,11 @@
                           </a:solidFill>
                         </a:defRPr>
                       </a:pPr>
+                      <a:endParaRPr dirty="0">
+                        <a:solidFill>
+                          <a:schemeClr val="tx1"/>
+                        </a:solidFill>
+                      </a:endParaRPr>
                     </a:p>
                   </a:txBody>
                   <a:tcPr>
@@ -5017,12 +5420,110 @@
                         </a:defRPr>
                       </a:pPr>
                       <a:r>
-                        <a:t>maart 2026</a:t>
+                        <a:rPr dirty="0" err="1">
+                          <a:solidFill>
+                            <a:schemeClr val="tx1"/>
+                          </a:solidFill>
+                        </a:rPr>
+                        <a:t>maart</a:t>
+                      </a:r>
+                      <a:r>
+                        <a:rPr dirty="0">
+                          <a:solidFill>
+                            <a:schemeClr val="tx1"/>
+                          </a:solidFill>
+                        </a:rPr>
+                        <a:t> 2026</a:t>
                       </a:r>
                     </a:p>
                     <a:p>
                       <a:r>
-                        <a:t>alleen hoogtemodel</a:t>
+                        <a:rPr dirty="0" err="1">
+                          <a:solidFill>
+                            <a:schemeClr val="tx1"/>
+                          </a:solidFill>
+                        </a:rPr>
+                        <a:t>alleen</a:t>
+                      </a:r>
+                      <a:r>
+                        <a:rPr dirty="0">
+                          <a:solidFill>
+                            <a:schemeClr val="tx1"/>
+                          </a:solidFill>
+                        </a:rPr>
+                        <a:t> </a:t>
+                      </a:r>
+                      <a:r>
+                        <a:rPr dirty="0" err="1">
+                          <a:solidFill>
+                            <a:schemeClr val="tx1"/>
+                          </a:solidFill>
+                        </a:rPr>
+                        <a:t>hoogtemodel</a:t>
+                      </a:r>
+                      <a:endParaRPr dirty="0">
+                        <a:solidFill>
+                          <a:schemeClr val="tx1"/>
+                        </a:solidFill>
+                      </a:endParaRPr>
+                    </a:p>
+                  </a:txBody>
+                  <a:tcPr>
+                    <a:solidFill>
+                      <a:srgbClr val="E6F5F3"/>
+                    </a:solidFill>
+                  </a:tcPr>
+                </a:tc>
+                <a:tc>
+                  <a:txBody>
+                    <a:bodyPr/>
+                    <a:lstStyle/>
+                    <a:p>
+                      <a:pPr algn="ctr">
+                        <a:defRPr sz="1200" b="1">
+                          <a:solidFill>
+                            <a:srgbClr val="1F3A3D"/>
+                          </a:solidFill>
+                        </a:defRPr>
+                      </a:pPr>
+                      <a:r>
+                        <a:rPr dirty="0">
+                          <a:solidFill>
+                            <a:schemeClr val="tx1"/>
+                          </a:solidFill>
+                        </a:rPr>
+                        <a:t>19 </a:t>
+                      </a:r>
+                      <a:r>
+                        <a:rPr dirty="0" err="1">
+                          <a:solidFill>
+                            <a:schemeClr val="tx1"/>
+                          </a:solidFill>
+                        </a:rPr>
+                        <a:t>augustus</a:t>
+                      </a:r>
+                      <a:endParaRPr dirty="0">
+                        <a:solidFill>
+                          <a:schemeClr val="tx1"/>
+                        </a:solidFill>
+                      </a:endParaRPr>
+                    </a:p>
+                    <a:p>
+                      <a:r>
+                        <a:rPr dirty="0" err="1">
+                          <a:solidFill>
+                            <a:schemeClr val="tx1"/>
+                          </a:solidFill>
+                        </a:rPr>
+                        <a:t>hybride</a:t>
+                      </a:r>
+                      <a:r>
+                        <a:rPr dirty="0">
+                          <a:solidFill>
+                            <a:schemeClr val="tx1"/>
+                          </a:solidFill>
+                        </a:rPr>
+                        <a:t>, eigen split</a:t>
                       </a:r>
                     </a:p>
                   </a:txBody>
@@ -5045,13 +5546,76 @@
                         </a:defRPr>
                       </a:pPr>
                       <a:r>
-                        <a:t>19 augustus</a:t>
+                        <a:rPr dirty="0">
+                          <a:solidFill>
+                            <a:schemeClr val="tx1"/>
+                          </a:solidFill>
+                        </a:rPr>
+                        <a:t>nu</a:t>
                       </a:r>
                     </a:p>
                     <a:p>
                       <a:r>
-                        <a:t>hybride, eigen split</a:t>
+                        <a:rPr dirty="0" err="1">
+                          <a:solidFill>
+                            <a:schemeClr val="tx1"/>
+                          </a:solidFill>
+                        </a:rPr>
+                        <a:t>vaste</a:t>
                       </a:r>
+                      <a:r>
+                        <a:rPr dirty="0">
+                          <a:solidFill>
+                            <a:schemeClr val="tx1"/>
+                          </a:solidFill>
+                        </a:rPr>
+                        <a:t> </a:t>
+                      </a:r>
+                      <a:r>
+                        <a:rPr dirty="0" err="1">
+                          <a:solidFill>
+                            <a:schemeClr val="tx1"/>
+                          </a:solidFill>
+                        </a:rPr>
+                        <a:t>testset</a:t>
+                      </a:r>
+                      <a:r>
+                        <a:rPr dirty="0">
+                          <a:solidFill>
+                            <a:schemeClr val="tx1"/>
+                          </a:solidFill>
+                        </a:rPr>
+                        <a:t> · R = 20 · </a:t>
+                      </a:r>
+                      <a:r>
+                        <a:rPr dirty="0" err="1">
+                          <a:solidFill>
+                            <a:schemeClr val="tx1"/>
+                          </a:solidFill>
+                        </a:rPr>
+                        <a:t>paren</a:t>
+                      </a:r>
+                      <a:r>
+                        <a:rPr dirty="0">
+                          <a:solidFill>
+                            <a:schemeClr val="tx1"/>
+                          </a:solidFill>
+                        </a:rPr>
+                        <a:t> ≥ 2 </a:t>
+                      </a:r>
+                      <a:r>
+                        <a:rPr dirty="0" err="1">
+                          <a:solidFill>
+                            <a:schemeClr val="tx1"/>
+                          </a:solidFill>
+                        </a:rPr>
+                        <a:t>jr</a:t>
+                      </a:r>
+                      <a:endParaRPr dirty="0">
+                        <a:solidFill>
+                          <a:schemeClr val="tx1"/>
+                        </a:solidFill>
+                      </a:endParaRPr>
                     </a:p>
                   </a:txBody>
                   <a:tcPr>
@@ -5073,13 +5637,65 @@
                         </a:defRPr>
                       </a:pPr>
                       <a:r>
-                        <a:t>nu</a:t>
+                        <a:rPr dirty="0" err="1">
+                          <a:solidFill>
+                            <a:schemeClr val="tx1"/>
+                          </a:solidFill>
+                        </a:rPr>
+                        <a:t>te</a:t>
                       </a:r>
+                      <a:r>
+                        <a:rPr dirty="0">
+                          <a:solidFill>
+                            <a:schemeClr val="tx1"/>
+                          </a:solidFill>
+                        </a:rPr>
+                        <a:t> </a:t>
+                      </a:r>
+                      <a:r>
+                        <a:rPr dirty="0" err="1">
+                          <a:solidFill>
+                            <a:schemeClr val="tx1"/>
+                          </a:solidFill>
+                        </a:rPr>
+                        <a:t>doen</a:t>
+                      </a:r>
+                      <a:endParaRPr dirty="0">
+                        <a:solidFill>
+                          <a:schemeClr val="tx1"/>
+                        </a:solidFill>
+                      </a:endParaRPr>
                     </a:p>
                     <a:p>
                       <a:r>
-                        <a:t>vaste testset · R = 20 · paren ≥ 2 jr</a:t>
+                        <a:rPr dirty="0" err="1">
+                          <a:solidFill>
+                            <a:schemeClr val="tx1"/>
+                          </a:solidFill>
+                        </a:rPr>
+                        <a:t>willekeurige</a:t>
                       </a:r>
+                      <a:r>
+                        <a:rPr dirty="0">
+                          <a:solidFill>
+                            <a:schemeClr val="tx1"/>
+                          </a:solidFill>
+                        </a:rPr>
+                        <a:t> split, </a:t>
+                      </a:r>
+                      <a:r>
+                        <a:rPr dirty="0" err="1">
+                          <a:solidFill>
+                            <a:schemeClr val="tx1"/>
+                          </a:solidFill>
+                        </a:rPr>
+                        <a:t>eerlijk</a:t>
+                      </a:r>
+                      <a:endParaRPr dirty="0">
+                        <a:solidFill>
+                          <a:schemeClr val="tx1"/>
+                        </a:solidFill>
+                      </a:endParaRPr>
                     </a:p>
                   </a:txBody>
                   <a:tcPr>
@@ -5088,34 +5704,11 @@
                     </a:solidFill>
                   </a:tcPr>
                 </a:tc>
-                <a:tc>
-                  <a:txBody>
-                    <a:bodyPr/>
-                    <a:lstStyle/>
-                    <a:p>
-                      <a:pPr algn="ctr">
-                        <a:defRPr sz="1200" b="1">
-                          <a:solidFill>
-                            <a:srgbClr val="1F3A3D"/>
-                          </a:solidFill>
-                        </a:defRPr>
-                      </a:pPr>
-                      <a:r>
-                        <a:t>te doen</a:t>
-                      </a:r>
-                    </a:p>
-                    <a:p>
-                      <a:r>
-                        <a:t>willekeurige split, eerlijk</a:t>
-                      </a:r>
-                    </a:p>
-                  </a:txBody>
-                  <a:tcPr>
-                    <a:solidFill>
-                      <a:srgbClr val="E6F5F3"/>
-                    </a:solidFill>
-                  </a:tcPr>
-                </a:tc>
+                <a:extLst>
+                  <a:ext uri="{0D108BD9-81ED-4DB2-BD59-A6C34878D82A}">
+                    <a16:rowId xmlns:a16="http://schemas.microsoft.com/office/drawing/2014/main" val="10000"/>
+                  </a:ext>
+                </a:extLst>
               </a:tr>
               <a:tr h="384048">
                 <a:tc>
@@ -5233,6 +5826,11 @@
                     </a:solidFill>
                   </a:tcPr>
                 </a:tc>
+                <a:extLst>
+                  <a:ext uri="{0D108BD9-81ED-4DB2-BD59-A6C34878D82A}">
+                    <a16:rowId xmlns:a16="http://schemas.microsoft.com/office/drawing/2014/main" val="10001"/>
+                  </a:ext>
+                </a:extLst>
               </a:tr>
               <a:tr h="384048">
                 <a:tc>
@@ -5350,6 +5948,11 @@
                     </a:solidFill>
                   </a:tcPr>
                 </a:tc>
+                <a:extLst>
+                  <a:ext uri="{0D108BD9-81ED-4DB2-BD59-A6C34878D82A}">
+                    <a16:rowId xmlns:a16="http://schemas.microsoft.com/office/drawing/2014/main" val="10002"/>
+                  </a:ext>
+                </a:extLst>
               </a:tr>
               <a:tr h="384048">
                 <a:tc>
@@ -5467,6 +6070,11 @@
                     </a:solidFill>
                   </a:tcPr>
                 </a:tc>
+                <a:extLst>
+                  <a:ext uri="{0D108BD9-81ED-4DB2-BD59-A6C34878D82A}">
+                    <a16:rowId xmlns:a16="http://schemas.microsoft.com/office/drawing/2014/main" val="10003"/>
+                  </a:ext>
+                </a:extLst>
               </a:tr>
               <a:tr h="384048">
                 <a:tc>
@@ -5584,6 +6192,11 @@
                     </a:solidFill>
                   </a:tcPr>
                 </a:tc>
+                <a:extLst>
+                  <a:ext uri="{0D108BD9-81ED-4DB2-BD59-A6C34878D82A}">
+                    <a16:rowId xmlns:a16="http://schemas.microsoft.com/office/drawing/2014/main" val="10004"/>
+                  </a:ext>
+                </a:extLst>
               </a:tr>
               <a:tr h="384048">
                 <a:tc>
@@ -5668,6 +6281,7 @@
                         </a:defRPr>
                       </a:pPr>
                       <a:r>
+                        <a:rPr dirty="0"/>
                         <a:t>segment (≈ 5 m)</a:t>
                       </a:r>
                     </a:p>
@@ -5691,6 +6305,7 @@
                         </a:defRPr>
                       </a:pPr>
                       <a:r>
+                        <a:rPr dirty="0"/>
                         <a:t>segment (≈ 5 m)</a:t>
                       </a:r>
                     </a:p>
@@ -5701,6 +6316,11 @@
                     </a:solidFill>
                   </a:tcPr>
                 </a:tc>
+                <a:extLst>
+                  <a:ext uri="{0D108BD9-81ED-4DB2-BD59-A6C34878D82A}">
+                    <a16:rowId xmlns:a16="http://schemas.microsoft.com/office/drawing/2014/main" val="10005"/>
+                  </a:ext>
+                </a:extLst>
               </a:tr>
               <a:tr h="384048">
                 <a:tc>
@@ -5785,7 +6405,24 @@
                         </a:defRPr>
                       </a:pPr>
                       <a:r>
-                        <a:t>≥ 2 jaar (alle paren)</a:t>
+                        <a:rPr dirty="0"/>
+                        <a:t>≥ 2 </a:t>
+                      </a:r>
+                      <a:r>
+                        <a:rPr dirty="0" err="1"/>
+                        <a:t>jaar</a:t>
+                      </a:r>
+                      <a:r>
+                        <a:rPr dirty="0"/>
+                        <a:t> (alle </a:t>
+                      </a:r>
+                      <a:r>
+                        <a:rPr dirty="0" err="1"/>
+                        <a:t>paren</a:t>
+                      </a:r>
+                      <a:r>
+                        <a:rPr dirty="0"/>
+                        <a:t>)</a:t>
                       </a:r>
                     </a:p>
                   </a:txBody>
@@ -5818,6 +6455,11 @@
                     </a:solidFill>
                   </a:tcPr>
                 </a:tc>
+                <a:extLst>
+                  <a:ext uri="{0D108BD9-81ED-4DB2-BD59-A6C34878D82A}">
+                    <a16:rowId xmlns:a16="http://schemas.microsoft.com/office/drawing/2014/main" val="10006"/>
+                  </a:ext>
+                </a:extLst>
               </a:tr>
               <a:tr h="384048">
                 <a:tc>
@@ -5902,8 +6544,22 @@
                         </a:defRPr>
                       </a:pPr>
                       <a:r>
-                        <a:t>vast · 715 vlakken · 8 578 segmenten</a:t>
+                        <a:rPr dirty="0"/>
+                        <a:t>vast · 715 </a:t>
                       </a:r>
+                      <a:r>
+                        <a:rPr dirty="0" err="1"/>
+                        <a:t>vlakken</a:t>
+                      </a:r>
+                      <a:r>
+                        <a:rPr dirty="0"/>
+                        <a:t> · 8 578 </a:t>
+                      </a:r>
+                      <a:r>
+                        <a:rPr dirty="0" err="1"/>
+                        <a:t>segmenten</a:t>
+                      </a:r>
+                      <a:endParaRPr dirty="0"/>
                     </a:p>
                   </a:txBody>
                   <a:tcPr>
@@ -5925,7 +6581,12 @@
                         </a:defRPr>
                       </a:pPr>
                       <a:r>
-                        <a:t>willekeurig 20 %</a:t>
+                        <a:rPr dirty="0" err="1"/>
+                        <a:t>willekeurig</a:t>
+                      </a:r>
+                      <a:r>
+                        <a:rPr dirty="0"/>
+                        <a:t> 20 %</a:t>
                       </a:r>
                     </a:p>
                   </a:txBody>
@@ -5935,6 +6596,11 @@
                     </a:solidFill>
                   </a:tcPr>
                 </a:tc>
+                <a:extLst>
+                  <a:ext uri="{0D108BD9-81ED-4DB2-BD59-A6C34878D82A}">
+                    <a16:rowId xmlns:a16="http://schemas.microsoft.com/office/drawing/2014/main" val="10007"/>
+                  </a:ext>
+                </a:extLst>
               </a:tr>
               <a:tr h="384048">
                 <a:tc>
@@ -6019,6 +6685,7 @@
                         </a:defRPr>
                       </a:pPr>
                       <a:r>
+                        <a:rPr dirty="0"/>
                         <a:t>test-set early stopping</a:t>
                       </a:r>
                     </a:p>
@@ -6042,7 +6709,28 @@
                         </a:defRPr>
                       </a:pPr>
                       <a:r>
-                        <a:t>testset buiten de training</a:t>
+                        <a:rPr lang="en-US" dirty="0"/>
+                        <a:t>t</a:t>
+                      </a:r>
+                      <a:r>
+                        <a:rPr dirty="0"/>
+                        <a:t>est</a:t>
+                      </a:r>
+                      <a:r>
+                        <a:rPr lang="en-US" dirty="0"/>
+                        <a:t> </a:t>
+                      </a:r>
+                      <a:r>
+                        <a:rPr dirty="0"/>
+                        <a:t>set </a:t>
+                      </a:r>
+                      <a:r>
+                        <a:rPr dirty="0" err="1"/>
+                        <a:t>buiten</a:t>
+                      </a:r>
+                      <a:r>
+                        <a:rPr dirty="0"/>
+                        <a:t> de training</a:t>
                       </a:r>
                     </a:p>
                   </a:txBody>
@@ -6052,46 +6740,16 @@
                     </a:solidFill>
                   </a:tcPr>
                 </a:tc>
+                <a:extLst>
+                  <a:ext uri="{0D108BD9-81ED-4DB2-BD59-A6C34878D82A}">
+                    <a16:rowId xmlns:a16="http://schemas.microsoft.com/office/drawing/2014/main" val="10008"/>
+                  </a:ext>
+                </a:extLst>
               </a:tr>
             </a:tbl>
           </a:graphicData>
         </a:graphic>
       </p:graphicFrame>
-      <p:sp>
-        <p:nvSpPr>
-          <p:cNvPr id="7" name="TextBox 6"/>
-          <p:cNvSpPr txBox="1"/>
-          <p:nvPr/>
-        </p:nvSpPr>
-        <p:spPr>
-          <a:xfrm>
-            <a:off x="548640" y="5257800"/>
-            <a:ext cx="11064240" cy="1005840"/>
-          </a:xfrm>
-          <a:prstGeom prst="rect">
-            <a:avLst/>
-          </a:prstGeom>
-          <a:noFill/>
-        </p:spPr>
-        <p:txBody>
-          <a:bodyPr wrap="square">
-            <a:spAutoFit/>
-          </a:bodyPr>
-          <a:lstStyle/>
-          <a:p>
-            <a:pPr>
-              <a:defRPr sz="1100" b="0" i="1">
-                <a:solidFill>
-                  <a:srgbClr val="6B7778"/>
-                </a:solidFill>
-              </a:defRPr>
-            </a:pPr>
-            <a:r>
-              <a:t>Let op: de 'nu'-kolom is het experiment (vaste testset, 715 vlakken met een ≥ 2-jaar-paar, R = 20); pas na de eerlijke run op een willekeurige splitsing zijn de kolommen echt vergelijkbaar. De vorige eerlijke run (R = 5, 1 jr) gaf 2.47 / 5.0 per vlak en 1.23 / 3.5 per segment.</a:t>
-            </a:r>
-          </a:p>
-        </p:txBody>
-      </p:sp>
     </p:spTree>
   </p:cSld>
   <p:clrMapOvr>
@@ -6125,7 +6783,7 @@
         </p:nvSpPr>
         <p:spPr>
           <a:xfrm>
-            <a:off x="548640" y="6400800"/>
+            <a:off x="548640" y="7032172"/>
             <a:ext cx="10972800" cy="274320"/>
           </a:xfrm>
           <a:prstGeom prst="rect">
@@ -6196,7 +6854,7 @@
         <p:spPr>
           <a:xfrm>
             <a:off x="548640" y="960120"/>
-            <a:ext cx="10972800" cy="548640"/>
+            <a:ext cx="10972800" cy="877163"/>
           </a:xfrm>
           <a:prstGeom prst="rect">
             <a:avLst/>
@@ -6209,7 +6867,9 @@
           </a:bodyPr>
           <a:lstStyle/>
           <a:p>
-            <a:pPr>
+            <a:pPr marL="285750" indent="-285750">
+              <a:buFont typeface="Arial" panose="020B0604020202020204" pitchFamily="34" charset="0"/>
+              <a:buChar char="•"/>
               <a:defRPr sz="1700" b="0" i="0">
                 <a:solidFill>
                   <a:srgbClr val="1F3A3D"/>
@@ -6217,8 +6877,141 @@
               </a:defRPr>
             </a:pPr>
             <a:r>
-              <a:t>Opschonen leverde het meest · van lijn naar oever · de regels raken op: wat overblijft vraagt kennis van de data</a:t>
-            </a:r>
+              <a:rPr dirty="0" err="1"/>
+              <a:t>Opschonen</a:t>
+            </a:r>
+            <a:r>
+              <a:rPr dirty="0"/>
+              <a:t> </a:t>
+            </a:r>
+            <a:r>
+              <a:rPr dirty="0" err="1"/>
+              <a:t>leverde</a:t>
+            </a:r>
+            <a:r>
+              <a:rPr dirty="0"/>
+              <a:t> </a:t>
+            </a:r>
+            <a:r>
+              <a:rPr lang="en-US" dirty="0"/>
+              <a:t>de </a:t>
+            </a:r>
+            <a:r>
+              <a:rPr dirty="0" err="1"/>
+              <a:t>meest</a:t>
+            </a:r>
+            <a:r>
+              <a:rPr lang="en-US" dirty="0" err="1"/>
+              <a:t>e</a:t>
+            </a:r>
+            <a:r>
+              <a:rPr lang="en-US" dirty="0"/>
+              <a:t> </a:t>
+            </a:r>
+            <a:r>
+              <a:rPr lang="en-US" dirty="0" err="1"/>
+              <a:t>winst</a:t>
+            </a:r>
+            <a:endParaRPr lang="en-US" dirty="0"/>
+          </a:p>
+          <a:p>
+            <a:pPr marL="285750" indent="-285750">
+              <a:buFont typeface="Arial" panose="020B0604020202020204" pitchFamily="34" charset="0"/>
+              <a:buChar char="•"/>
+              <a:defRPr sz="1700" b="0" i="0">
+                <a:solidFill>
+                  <a:srgbClr val="1F3A3D"/>
+                </a:solidFill>
+              </a:defRPr>
+            </a:pPr>
+            <a:r>
+              <a:rPr lang="en-US" dirty="0"/>
+              <a:t>V</a:t>
+            </a:r>
+            <a:r>
+              <a:rPr dirty="0"/>
+              <a:t>an </a:t>
+            </a:r>
+            <a:r>
+              <a:rPr dirty="0" err="1"/>
+              <a:t>lijn</a:t>
+            </a:r>
+            <a:r>
+              <a:rPr dirty="0"/>
+              <a:t> </a:t>
+            </a:r>
+            <a:r>
+              <a:rPr dirty="0" err="1"/>
+              <a:t>naar</a:t>
+            </a:r>
+            <a:r>
+              <a:rPr dirty="0"/>
+              <a:t> </a:t>
+            </a:r>
+            <a:r>
+              <a:rPr dirty="0" err="1"/>
+              <a:t>oever</a:t>
+            </a:r>
+            <a:r>
+              <a:rPr lang="en-US" dirty="0"/>
+              <a:t> </a:t>
+            </a:r>
+            <a:r>
+              <a:rPr lang="en-US" dirty="0" err="1"/>
+              <a:t>gegaan</a:t>
+            </a:r>
+            <a:r>
+              <a:rPr lang="en-US" dirty="0"/>
+              <a:t> (</a:t>
+            </a:r>
+            <a:r>
+              <a:rPr lang="en-US" dirty="0" err="1"/>
+              <a:t>resolutie</a:t>
+            </a:r>
+            <a:r>
+              <a:rPr lang="en-US" dirty="0"/>
+              <a:t>)</a:t>
+            </a:r>
+          </a:p>
+          <a:p>
+            <a:pPr marL="285750" indent="-285750">
+              <a:buFont typeface="Arial" panose="020B0604020202020204" pitchFamily="34" charset="0"/>
+              <a:buChar char="•"/>
+              <a:defRPr sz="1700" b="0" i="0">
+                <a:solidFill>
+                  <a:srgbClr val="1F3A3D"/>
+                </a:solidFill>
+              </a:defRPr>
+            </a:pPr>
+            <a:r>
+              <a:rPr lang="en-US" dirty="0"/>
+              <a:t>Hoe </a:t>
+            </a:r>
+            <a:r>
+              <a:rPr lang="en-US" dirty="0" err="1"/>
+              <a:t>schonen</a:t>
+            </a:r>
+            <a:r>
+              <a:rPr lang="en-US" dirty="0"/>
+              <a:t> we de data </a:t>
+            </a:r>
+            <a:r>
+              <a:rPr lang="en-US" dirty="0" err="1"/>
+              <a:t>nog</a:t>
+            </a:r>
+            <a:r>
+              <a:rPr lang="en-US" dirty="0"/>
+              <a:t> </a:t>
+            </a:r>
+            <a:r>
+              <a:rPr lang="en-US" dirty="0" err="1"/>
+              <a:t>verder</a:t>
+            </a:r>
+            <a:r>
+              <a:rPr lang="en-US" dirty="0"/>
+              <a:t> op?</a:t>
+            </a:r>
+            <a:endParaRPr dirty="0"/>
           </a:p>
         </p:txBody>
       </p:sp>
@@ -6230,7 +7023,7 @@
         </p:nvSpPr>
         <p:spPr>
           <a:xfrm>
-            <a:off x="548640" y="1645920"/>
+            <a:off x="548640" y="2277292"/>
             <a:ext cx="3566160" cy="548640"/>
           </a:xfrm>
           <a:prstGeom prst="rect">
@@ -6269,8 +7062,14 @@
               </a:defRPr>
             </a:pPr>
             <a:r>
-              <a:t>Feedback gevraagd</a:t>
-            </a:r>
+              <a:rPr dirty="0"/>
+              <a:t>Feedback </a:t>
+            </a:r>
+            <a:r>
+              <a:rPr lang="en-US" dirty="0" err="1"/>
+              <a:t>nodig</a:t>
+            </a:r>
+            <a:endParaRPr dirty="0"/>
           </a:p>
         </p:txBody>
       </p:sp>
@@ -6282,8 +7081,8 @@
         </p:nvSpPr>
         <p:spPr>
           <a:xfrm>
-            <a:off x="548640" y="2377440"/>
-            <a:ext cx="3566160" cy="3840480"/>
+            <a:off x="548640" y="3008812"/>
+            <a:ext cx="3566160" cy="2046714"/>
           </a:xfrm>
           <a:prstGeom prst="rect">
             <a:avLst/>
@@ -6307,8 +7106,146 @@
               </a:defRPr>
             </a:pPr>
             <a:r>
-              <a:t>• Welke bewerking heeft de SAM-data nog nodig? Kronkelende lijnen, doolhoven en uitschieters in de tijd zijn puur SAM-verschijnselen</a:t>
-            </a:r>
+              <a:rPr dirty="0"/>
+              <a:t>• Welke </a:t>
+            </a:r>
+            <a:r>
+              <a:rPr dirty="0" err="1"/>
+              <a:t>bewerking</a:t>
+            </a:r>
+            <a:r>
+              <a:rPr dirty="0"/>
+              <a:t> </a:t>
+            </a:r>
+            <a:r>
+              <a:rPr dirty="0" err="1"/>
+              <a:t>heeft</a:t>
+            </a:r>
+            <a:r>
+              <a:rPr dirty="0"/>
+              <a:t> de SAM-data </a:t>
+            </a:r>
+            <a:r>
+              <a:rPr dirty="0" err="1"/>
+              <a:t>nog</a:t>
+            </a:r>
+            <a:r>
+              <a:rPr dirty="0"/>
+              <a:t> </a:t>
+            </a:r>
+            <a:r>
+              <a:rPr dirty="0" err="1"/>
+              <a:t>nodig</a:t>
+            </a:r>
+            <a:r>
+              <a:rPr dirty="0"/>
+              <a:t>?</a:t>
+            </a:r>
+            <a:r>
+              <a:rPr lang="en-US" dirty="0"/>
+              <a:t>  Wat </a:t>
+            </a:r>
+            <a:r>
+              <a:rPr lang="en-US" dirty="0" err="1"/>
+              <a:t>missen</a:t>
+            </a:r>
+            <a:r>
+              <a:rPr lang="en-US" dirty="0"/>
+              <a:t> we in de </a:t>
+            </a:r>
+            <a:r>
+              <a:rPr lang="en-US" dirty="0" err="1"/>
+              <a:t>meegenomen</a:t>
+            </a:r>
+            <a:r>
+              <a:rPr lang="en-US" dirty="0"/>
+              <a:t> </a:t>
+            </a:r>
+            <a:r>
+              <a:rPr lang="en-US" dirty="0" err="1"/>
+              <a:t>patronen</a:t>
+            </a:r>
+            <a:r>
+              <a:rPr lang="en-US" dirty="0"/>
+              <a:t>?</a:t>
+            </a:r>
+          </a:p>
+          <a:p>
+            <a:pPr lvl="1">
+              <a:spcAft>
+                <a:spcPts val="600"/>
+              </a:spcAft>
+              <a:defRPr sz="1300">
+                <a:solidFill>
+                  <a:srgbClr val="1F3A3D"/>
+                </a:solidFill>
+              </a:defRPr>
+            </a:pPr>
+            <a:r>
+              <a:rPr lang="en-US" dirty="0"/>
+              <a:t>• Kan </a:t>
+            </a:r>
+            <a:r>
+              <a:rPr lang="en-US" dirty="0" err="1"/>
+              <a:t>lijst</a:t>
+            </a:r>
+            <a:r>
+              <a:rPr lang="en-US" dirty="0"/>
+              <a:t>/</a:t>
+            </a:r>
+            <a:r>
+              <a:rPr lang="en-US" dirty="0" err="1"/>
+              <a:t>geopackage</a:t>
+            </a:r>
+            <a:r>
+              <a:rPr lang="en-US" dirty="0"/>
+              <a:t> </a:t>
+            </a:r>
+            <a:r>
+              <a:rPr lang="en-US" dirty="0" err="1"/>
+              <a:t>delen</a:t>
+            </a:r>
+            <a:r>
+              <a:rPr lang="en-US" dirty="0"/>
+              <a:t> met </a:t>
+            </a:r>
+            <a:r>
+              <a:rPr lang="en-US" dirty="0" err="1"/>
+              <a:t>voor</a:t>
+            </a:r>
+            <a:r>
+              <a:rPr lang="en-US" dirty="0"/>
+              <a:t>- </a:t>
+            </a:r>
+            <a:r>
+              <a:rPr lang="en-US" dirty="0" err="1"/>
+              <a:t>en</a:t>
+            </a:r>
+            <a:r>
+              <a:rPr lang="en-US" dirty="0"/>
+              <a:t> </a:t>
+            </a:r>
+            <a:r>
+              <a:rPr lang="en-US" dirty="0" err="1"/>
+              <a:t>na</a:t>
+            </a:r>
+            <a:r>
+              <a:rPr lang="en-US" dirty="0"/>
+              <a:t>- </a:t>
+            </a:r>
+            <a:r>
+              <a:rPr lang="en-US" dirty="0" err="1"/>
+              <a:t>opschoning</a:t>
+            </a:r>
+            <a:r>
+              <a:rPr lang="en-US" dirty="0"/>
+              <a:t> </a:t>
+            </a:r>
+            <a:r>
+              <a:rPr lang="en-US" dirty="0" err="1"/>
+              <a:t>effecten</a:t>
+            </a:r>
+            <a:endParaRPr lang="en-US" dirty="0"/>
           </a:p>
           <a:p>
             <a:pPr>
@@ -6322,22 +7259,107 @@
               </a:defRPr>
             </a:pPr>
             <a:r>
-              <a:t>• Welke parameters bepalen de output van het hybride model? We willen daaraan draaien: ook ná filteren is het pure hoogtemodel nauwkeuriger — SAM segmenteert en mikt niet op een rechte lijn</a:t>
-            </a:r>
-          </a:p>
-          <a:p>
-            <a:pPr>
-              <a:spcAft>
-                <a:spcPts val="600"/>
-              </a:spcAft>
-              <a:defRPr sz="1300">
-                <a:solidFill>
-                  <a:srgbClr val="1F3A3D"/>
-                </a:solidFill>
-              </a:defRPr>
-            </a:pPr>
-            <a:r>
-              <a:t>• Wat missen we in de vijf patronen?</a:t>
+              <a:rPr lang="en-US" dirty="0"/>
+              <a:t>• Is het </a:t>
+            </a:r>
+            <a:r>
+              <a:rPr lang="en-US" dirty="0" err="1"/>
+              <a:t>wellicht</a:t>
+            </a:r>
+            <a:r>
+              <a:rPr lang="en-US" dirty="0"/>
+              <a:t> </a:t>
+            </a:r>
+            <a:r>
+              <a:rPr lang="en-US" dirty="0" err="1"/>
+              <a:t>handig</a:t>
+            </a:r>
+            <a:r>
+              <a:rPr lang="en-US" dirty="0"/>
+              <a:t> om </a:t>
+            </a:r>
+            <a:r>
+              <a:rPr lang="en-US" dirty="0" err="1"/>
+              <a:t>hoogtemodel</a:t>
+            </a:r>
+            <a:r>
+              <a:rPr lang="en-US" dirty="0"/>
+              <a:t> data op </a:t>
+            </a:r>
+            <a:r>
+              <a:rPr lang="en-US" dirty="0" err="1"/>
+              <a:t>te</a:t>
+            </a:r>
+            <a:r>
+              <a:rPr lang="en-US" dirty="0"/>
+              <a:t> </a:t>
+            </a:r>
+            <a:r>
+              <a:rPr lang="en-US" dirty="0" err="1"/>
+              <a:t>schonen</a:t>
+            </a:r>
+            <a:br>
+              <a:rPr lang="en-US" dirty="0"/>
+            </a:br>
+            <a:r>
+              <a:rPr lang="en-US" dirty="0"/>
+              <a:t>• Welke parameters </a:t>
+            </a:r>
+            <a:r>
+              <a:rPr lang="en-US" dirty="0" err="1"/>
+              <a:t>bepalen</a:t>
+            </a:r>
+            <a:r>
+              <a:rPr lang="en-US" dirty="0"/>
+              <a:t> de output van het </a:t>
+            </a:r>
+            <a:r>
+              <a:rPr lang="en-US" dirty="0" err="1"/>
+              <a:t>hybride</a:t>
+            </a:r>
+            <a:r>
+              <a:rPr lang="en-US" dirty="0"/>
+              <a:t> model? </a:t>
+            </a:r>
+            <a:r>
+              <a:rPr lang="en-US" dirty="0" err="1"/>
+              <a:t>Mogelijk</a:t>
+            </a:r>
+            <a:r>
+              <a:rPr lang="en-US" dirty="0"/>
+              <a:t> om diverse output </a:t>
+            </a:r>
+            <a:r>
+              <a:rPr lang="en-US" dirty="0" err="1"/>
+              <a:t>variaties</a:t>
+            </a:r>
+            <a:r>
+              <a:rPr lang="en-US" dirty="0"/>
+              <a:t> </a:t>
+            </a:r>
+            <a:r>
+              <a:rPr lang="en-US" dirty="0" err="1"/>
+              <a:t>te</a:t>
+            </a:r>
+            <a:r>
+              <a:rPr lang="en-US" dirty="0"/>
+              <a:t> </a:t>
+            </a:r>
+            <a:r>
+              <a:rPr lang="en-US" dirty="0" err="1"/>
+              <a:t>testen</a:t>
+            </a:r>
+            <a:r>
+              <a:rPr lang="en-US" dirty="0"/>
+              <a:t> in het </a:t>
+            </a:r>
+            <a:r>
+              <a:rPr lang="en-US" dirty="0" err="1"/>
+              <a:t>voorspellende</a:t>
+            </a:r>
+            <a:r>
+              <a:rPr lang="en-US" dirty="0"/>
+              <a:t> model</a:t>
             </a:r>
           </a:p>
         </p:txBody>
@@ -6350,7 +7372,7 @@
         </p:nvSpPr>
         <p:spPr>
           <a:xfrm>
-            <a:off x="4389120" y="1645920"/>
+            <a:off x="4389120" y="2277292"/>
             <a:ext cx="3566160" cy="548640"/>
           </a:xfrm>
           <a:prstGeom prst="rect">
@@ -6389,8 +7411,22 @@
               </a:defRPr>
             </a:pPr>
             <a:r>
-              <a:t>Wat wij gaan doen</a:t>
-            </a:r>
+              <a:rPr lang="en-US" dirty="0"/>
+              <a:t>To do van </a:t>
+            </a:r>
+            <a:r>
+              <a:rPr lang="en-US" dirty="0" err="1"/>
+              <a:t>mijn</a:t>
+            </a:r>
+            <a:r>
+              <a:rPr lang="en-US" dirty="0"/>
+              <a:t> </a:t>
+            </a:r>
+            <a:r>
+              <a:rPr lang="en-US" dirty="0" err="1"/>
+              <a:t>kant</a:t>
+            </a:r>
+            <a:endParaRPr dirty="0"/>
           </a:p>
         </p:txBody>
       </p:sp>
@@ -6402,8 +7438,8 @@
         </p:nvSpPr>
         <p:spPr>
           <a:xfrm>
-            <a:off x="4389120" y="2377440"/>
-            <a:ext cx="3566160" cy="3840480"/>
+            <a:off x="4389120" y="3008812"/>
+            <a:ext cx="3566160" cy="2400657"/>
           </a:xfrm>
           <a:prstGeom prst="rect">
             <a:avLst/>
@@ -6427,8 +7463,58 @@
               </a:defRPr>
             </a:pPr>
             <a:r>
-              <a:t>• Eindrun op een willekeurige splitsing, testset buiten de training, R = 20 — dan is de tabel compleet</a:t>
-            </a:r>
+              <a:rPr dirty="0"/>
+              <a:t>• </a:t>
+            </a:r>
+            <a:r>
+              <a:rPr dirty="0" err="1"/>
+              <a:t>Eindrun</a:t>
+            </a:r>
+            <a:r>
+              <a:rPr dirty="0"/>
+              <a:t> op </a:t>
+            </a:r>
+            <a:r>
+              <a:rPr dirty="0" err="1"/>
+              <a:t>een</a:t>
+            </a:r>
+            <a:r>
+              <a:rPr dirty="0"/>
+              <a:t> </a:t>
+            </a:r>
+            <a:r>
+              <a:rPr dirty="0" err="1"/>
+              <a:t>willekeurige</a:t>
+            </a:r>
+            <a:r>
+              <a:rPr dirty="0"/>
+              <a:t> </a:t>
+            </a:r>
+            <a:r>
+              <a:rPr dirty="0" err="1"/>
+              <a:t>splitsing</a:t>
+            </a:r>
+            <a:r>
+              <a:rPr dirty="0"/>
+              <a:t>, </a:t>
+            </a:r>
+            <a:r>
+              <a:rPr dirty="0" err="1"/>
+              <a:t>testset</a:t>
+            </a:r>
+            <a:r>
+              <a:rPr dirty="0"/>
+              <a:t> </a:t>
+            </a:r>
+            <a:r>
+              <a:rPr dirty="0" err="1"/>
+              <a:t>buiten</a:t>
+            </a:r>
+            <a:r>
+              <a:rPr dirty="0"/>
+              <a:t> de training, R = 20</a:t>
+            </a:r>
+            <a:endParaRPr lang="en-US" dirty="0"/>
           </a:p>
           <a:p>
             <a:pPr>
@@ -6442,8 +7528,54 @@
               </a:defRPr>
             </a:pPr>
             <a:r>
-              <a:t>• De staart onderzoeken: de vlakken met de grootste bijdrage aan de fout én de minst voorspelbare — wat hebben ze gemeen?</a:t>
-            </a:r>
+              <a:rPr lang="en-US" dirty="0"/>
+              <a:t>• </a:t>
+            </a:r>
+            <a:r>
+              <a:rPr lang="en-US" dirty="0" err="1"/>
+              <a:t>Methodologie</a:t>
+            </a:r>
+            <a:r>
+              <a:rPr lang="en-US" dirty="0"/>
+              <a:t> SAM/</a:t>
+            </a:r>
+            <a:r>
+              <a:rPr lang="en-US" dirty="0" err="1"/>
+              <a:t>hoogtemodel</a:t>
+            </a:r>
+            <a:r>
+              <a:rPr lang="en-US" dirty="0"/>
+              <a:t> </a:t>
+            </a:r>
+            <a:r>
+              <a:rPr lang="en-US" dirty="0" err="1"/>
+              <a:t>en</a:t>
+            </a:r>
+            <a:r>
+              <a:rPr lang="en-US" dirty="0"/>
+              <a:t> </a:t>
+            </a:r>
+            <a:r>
+              <a:rPr lang="en-US" dirty="0" err="1"/>
+              <a:t>hybride</a:t>
+            </a:r>
+            <a:r>
+              <a:rPr lang="en-US" dirty="0"/>
+              <a:t> </a:t>
+            </a:r>
+            <a:r>
+              <a:rPr lang="en-US" dirty="0" err="1"/>
+              <a:t>beslissingsmodel</a:t>
+            </a:r>
+            <a:r>
+              <a:rPr lang="en-US" dirty="0"/>
+              <a:t> </a:t>
+            </a:r>
+            <a:r>
+              <a:rPr lang="en-US" dirty="0" err="1"/>
+              <a:t>snappen</a:t>
+            </a:r>
+            <a:endParaRPr lang="en-US" dirty="0"/>
           </a:p>
           <a:p>
             <a:pPr>
@@ -6457,8 +7589,254 @@
               </a:defRPr>
             </a:pPr>
             <a:r>
-              <a:t>• Lijnbemonstering verdichten zodat segmenten zonder meting verdwijnen</a:t>
-            </a:r>
+              <a:rPr dirty="0"/>
+              <a:t>• </a:t>
+            </a:r>
+            <a:r>
+              <a:rPr lang="en-US" dirty="0" err="1"/>
+              <a:t>Vlakken</a:t>
+            </a:r>
+            <a:r>
+              <a:rPr lang="en-US" dirty="0"/>
+              <a:t> </a:t>
+            </a:r>
+            <a:r>
+              <a:rPr lang="en-US" dirty="0" err="1"/>
+              <a:t>onderzoeken</a:t>
+            </a:r>
+            <a:r>
+              <a:rPr lang="en-US" dirty="0"/>
+              <a:t> </a:t>
+            </a:r>
+            <a:r>
+              <a:rPr dirty="0"/>
+              <a:t>met de </a:t>
+            </a:r>
+            <a:r>
+              <a:rPr dirty="0" err="1"/>
+              <a:t>grootste</a:t>
+            </a:r>
+            <a:r>
+              <a:rPr dirty="0"/>
+              <a:t> </a:t>
+            </a:r>
+            <a:r>
+              <a:rPr dirty="0" err="1"/>
+              <a:t>bijdrage</a:t>
+            </a:r>
+            <a:r>
+              <a:rPr dirty="0"/>
+              <a:t> </a:t>
+            </a:r>
+            <a:r>
+              <a:rPr dirty="0" err="1"/>
+              <a:t>aan</a:t>
+            </a:r>
+            <a:r>
+              <a:rPr dirty="0"/>
+              <a:t> de </a:t>
+            </a:r>
+            <a:r>
+              <a:rPr dirty="0" err="1"/>
+              <a:t>fout</a:t>
+            </a:r>
+            <a:r>
+              <a:rPr dirty="0"/>
+              <a:t> </a:t>
+            </a:r>
+            <a:r>
+              <a:rPr dirty="0" err="1"/>
+              <a:t>én</a:t>
+            </a:r>
+            <a:r>
+              <a:rPr dirty="0"/>
+              <a:t> </a:t>
+            </a:r>
+            <a:r>
+              <a:rPr lang="en-US" dirty="0" err="1"/>
+              <a:t>dus</a:t>
+            </a:r>
+            <a:r>
+              <a:rPr lang="en-US" dirty="0"/>
+              <a:t> </a:t>
+            </a:r>
+            <a:r>
+              <a:rPr dirty="0"/>
+              <a:t>de </a:t>
+            </a:r>
+            <a:r>
+              <a:rPr dirty="0" err="1"/>
+              <a:t>minst</a:t>
+            </a:r>
+            <a:r>
+              <a:rPr dirty="0"/>
+              <a:t> </a:t>
+            </a:r>
+            <a:r>
+              <a:rPr dirty="0" err="1"/>
+              <a:t>voorspelbare</a:t>
+            </a:r>
+            <a:endParaRPr lang="en-US" dirty="0"/>
+          </a:p>
+          <a:p>
+            <a:pPr marL="742950" lvl="1" indent="-285750">
+              <a:spcAft>
+                <a:spcPts val="600"/>
+              </a:spcAft>
+              <a:buFont typeface="Arial" panose="020B0604020202020204" pitchFamily="34" charset="0"/>
+              <a:buChar char="•"/>
+              <a:defRPr sz="1300">
+                <a:solidFill>
+                  <a:srgbClr val="1F3A3D"/>
+                </a:solidFill>
+              </a:defRPr>
+            </a:pPr>
+            <a:r>
+              <a:rPr lang="en-US" dirty="0"/>
+              <a:t>Zal </a:t>
+            </a:r>
+            <a:r>
+              <a:rPr lang="en-US" dirty="0" err="1"/>
+              <a:t>hier</a:t>
+            </a:r>
+            <a:r>
+              <a:rPr lang="en-US" dirty="0"/>
+              <a:t> </a:t>
+            </a:r>
+            <a:r>
+              <a:rPr lang="en-US" dirty="0" err="1"/>
+              <a:t>een</a:t>
+            </a:r>
+            <a:r>
+              <a:rPr lang="en-US" dirty="0"/>
+              <a:t> </a:t>
+            </a:r>
+            <a:r>
+              <a:rPr lang="en-US" dirty="0" err="1"/>
+              <a:t>lijstje</a:t>
+            </a:r>
+            <a:r>
+              <a:rPr lang="en-US" dirty="0"/>
+              <a:t> van </a:t>
+            </a:r>
+            <a:r>
+              <a:rPr lang="en-US" dirty="0" err="1"/>
+              <a:t>maken</a:t>
+            </a:r>
+            <a:r>
+              <a:rPr lang="en-US" dirty="0"/>
+              <a:t> wat </a:t>
+            </a:r>
+            <a:r>
+              <a:rPr lang="en-US" dirty="0" err="1"/>
+              <a:t>ik</a:t>
+            </a:r>
+            <a:r>
+              <a:rPr lang="en-US" dirty="0"/>
+              <a:t> </a:t>
+            </a:r>
+            <a:r>
+              <a:rPr lang="en-US" dirty="0" err="1"/>
+              <a:t>kan</a:t>
+            </a:r>
+            <a:r>
+              <a:rPr lang="en-US" dirty="0"/>
+              <a:t> </a:t>
+            </a:r>
+            <a:r>
+              <a:rPr lang="en-US" dirty="0" err="1"/>
+              <a:t>delen</a:t>
+            </a:r>
+            <a:endParaRPr dirty="0"/>
+          </a:p>
+          <a:p>
+            <a:pPr>
+              <a:spcAft>
+                <a:spcPts val="600"/>
+              </a:spcAft>
+              <a:defRPr sz="1300">
+                <a:solidFill>
+                  <a:srgbClr val="1F3A3D"/>
+                </a:solidFill>
+              </a:defRPr>
+            </a:pPr>
+            <a:r>
+              <a:rPr dirty="0"/>
+              <a:t>• </a:t>
+            </a:r>
+            <a:r>
+              <a:rPr lang="en-US" dirty="0" err="1"/>
+              <a:t>Lijnformatie</a:t>
+            </a:r>
+            <a:r>
+              <a:rPr lang="en-US" dirty="0"/>
+              <a:t> </a:t>
+            </a:r>
+            <a:r>
+              <a:rPr lang="en-US" dirty="0" err="1"/>
+              <a:t>bij</a:t>
+            </a:r>
+            <a:r>
+              <a:rPr lang="en-US" dirty="0"/>
+              <a:t> </a:t>
+            </a:r>
+            <a:r>
+              <a:rPr lang="en-US" dirty="0" err="1"/>
+              <a:t>hogere</a:t>
+            </a:r>
+            <a:r>
+              <a:rPr lang="en-US" dirty="0"/>
+              <a:t> </a:t>
+            </a:r>
+            <a:r>
+              <a:rPr lang="en-US" dirty="0" err="1"/>
+              <a:t>resolutie</a:t>
+            </a:r>
+            <a:r>
+              <a:rPr dirty="0"/>
+              <a:t> </a:t>
+            </a:r>
+            <a:r>
+              <a:rPr dirty="0" err="1"/>
+              <a:t>ver</a:t>
+            </a:r>
+            <a:r>
+              <a:rPr lang="en-US" dirty="0" err="1"/>
+              <a:t>beteren</a:t>
+            </a:r>
+            <a:r>
+              <a:rPr dirty="0"/>
+              <a:t> </a:t>
+            </a:r>
+            <a:r>
+              <a:rPr dirty="0" err="1"/>
+              <a:t>zodat</a:t>
+            </a:r>
+            <a:r>
+              <a:rPr dirty="0"/>
+              <a:t> </a:t>
+            </a:r>
+            <a:r>
+              <a:rPr dirty="0" err="1"/>
+              <a:t>segmenten</a:t>
+            </a:r>
+            <a:r>
+              <a:rPr dirty="0"/>
+              <a:t> </a:t>
+            </a:r>
+            <a:r>
+              <a:rPr dirty="0" err="1"/>
+              <a:t>zonder</a:t>
+            </a:r>
+            <a:r>
+              <a:rPr dirty="0"/>
+              <a:t> meting </a:t>
+            </a:r>
+            <a:r>
+              <a:rPr dirty="0" err="1"/>
+              <a:t>verdwijnen</a:t>
+            </a:r>
+            <a:endParaRPr dirty="0"/>
           </a:p>
         </p:txBody>
       </p:sp>
@@ -6470,7 +7848,7 @@
         </p:nvSpPr>
         <p:spPr>
           <a:xfrm>
-            <a:off x="8229600" y="1645920"/>
+            <a:off x="8229600" y="2277292"/>
             <a:ext cx="3566160" cy="548640"/>
           </a:xfrm>
           <a:prstGeom prst="rect">
@@ -6509,8 +7887,10 @@
               </a:defRPr>
             </a:pPr>
             <a:r>
-              <a:t>Wat er staat</a:t>
-            </a:r>
+              <a:rPr lang="en-US" dirty="0"/>
+              <a:t>Done</a:t>
+            </a:r>
+            <a:endParaRPr dirty="0"/>
           </a:p>
         </p:txBody>
       </p:sp>
@@ -6522,8 +7902,8 @@
         </p:nvSpPr>
         <p:spPr>
           <a:xfrm>
-            <a:off x="8229600" y="2377440"/>
-            <a:ext cx="3566160" cy="3840480"/>
+            <a:off x="8229600" y="3008812"/>
+            <a:ext cx="3566160" cy="1169551"/>
           </a:xfrm>
           <a:prstGeom prst="rect">
             <a:avLst/>
@@ -6547,7 +7927,80 @@
               </a:defRPr>
             </a:pPr>
             <a:r>
-              <a:t>• Model klaar, alle stappen op één vaste testset: 3.99 → 2.27 (opschonen) → 2.13 (historie) → 1.37 (paren ≥ 2 jr) → 0.85 (R = 20)</a:t>
+              <a:rPr dirty="0"/>
+              <a:t>• Model </a:t>
+            </a:r>
+            <a:r>
+              <a:rPr dirty="0" err="1"/>
+              <a:t>klaar</a:t>
+            </a:r>
+            <a:r>
+              <a:rPr dirty="0"/>
+              <a:t>, alle </a:t>
+            </a:r>
+            <a:r>
+              <a:rPr dirty="0" err="1"/>
+              <a:t>stappen</a:t>
+            </a:r>
+            <a:r>
+              <a:rPr dirty="0"/>
+              <a:t> op </a:t>
+            </a:r>
+            <a:r>
+              <a:rPr dirty="0" err="1"/>
+              <a:t>één</a:t>
+            </a:r>
+            <a:r>
+              <a:rPr dirty="0"/>
+              <a:t> </a:t>
+            </a:r>
+            <a:r>
+              <a:rPr dirty="0" err="1"/>
+              <a:t>vaste</a:t>
+            </a:r>
+            <a:r>
+              <a:rPr dirty="0"/>
+              <a:t> </a:t>
+            </a:r>
+            <a:r>
+              <a:rPr dirty="0" err="1"/>
+              <a:t>testset</a:t>
+            </a:r>
+            <a:r>
+              <a:rPr dirty="0"/>
+              <a:t>: 3.99 → 2.27 (</a:t>
+            </a:r>
+            <a:r>
+              <a:rPr dirty="0" err="1"/>
+              <a:t>opschonen</a:t>
+            </a:r>
+            <a:r>
+              <a:rPr dirty="0"/>
+              <a:t>) → 2.13 (</a:t>
+            </a:r>
+            <a:r>
+              <a:rPr dirty="0" err="1"/>
+              <a:t>historie</a:t>
+            </a:r>
+            <a:r>
+              <a:rPr dirty="0"/>
+              <a:t>) → 1.37 (</a:t>
+            </a:r>
+            <a:r>
+              <a:rPr dirty="0" err="1"/>
+              <a:t>paren</a:t>
+            </a:r>
+            <a:r>
+              <a:rPr dirty="0"/>
+              <a:t> ≥ 2 </a:t>
+            </a:r>
+            <a:r>
+              <a:rPr dirty="0" err="1"/>
+              <a:t>jr</a:t>
+            </a:r>
+            <a:r>
+              <a:rPr dirty="0"/>
+              <a:t>) → 0.85 (R = 20)</a:t>
             </a:r>
           </a:p>
           <a:p>
@@ -6562,23 +8015,78 @@
               </a:defRPr>
             </a:pPr>
             <a:r>
-              <a:t>• Kribben + kunstwerken landelijk als laag; structurenmasker = juistheid, geen foutwinst</a:t>
-            </a:r>
-          </a:p>
-          <a:p>
-            <a:pPr>
-              <a:spcAft>
-                <a:spcPts val="600"/>
-              </a:spcAft>
-              <a:defRPr sz="1300">
-                <a:solidFill>
-                  <a:srgbClr val="1F3A3D"/>
-                </a:solidFill>
-              </a:defRPr>
-            </a:pPr>
-            <a:r>
-              <a:t>• Alles reproduceerbaar: ledger met 80+ varianten, rapport per run</a:t>
-            </a:r>
+              <a:rPr dirty="0"/>
+              <a:t>• </a:t>
+            </a:r>
+            <a:r>
+              <a:rPr dirty="0" err="1"/>
+              <a:t>Kribben</a:t>
+            </a:r>
+            <a:r>
+              <a:rPr dirty="0"/>
+              <a:t> + </a:t>
+            </a:r>
+            <a:r>
+              <a:rPr dirty="0" err="1"/>
+              <a:t>kunstwerken</a:t>
+            </a:r>
+            <a:r>
+              <a:rPr dirty="0"/>
+              <a:t> </a:t>
+            </a:r>
+            <a:r>
+              <a:rPr dirty="0" err="1"/>
+              <a:t>landelijk</a:t>
+            </a:r>
+            <a:r>
+              <a:rPr dirty="0"/>
+              <a:t> </a:t>
+            </a:r>
+            <a:r>
+              <a:rPr dirty="0" err="1"/>
+              <a:t>als</a:t>
+            </a:r>
+            <a:r>
+              <a:rPr dirty="0"/>
+              <a:t> </a:t>
+            </a:r>
+            <a:r>
+              <a:rPr dirty="0" err="1"/>
+              <a:t>laag</a:t>
+            </a:r>
+            <a:r>
+              <a:rPr dirty="0"/>
+              <a:t>; </a:t>
+            </a:r>
+            <a:r>
+              <a:rPr dirty="0" err="1"/>
+              <a:t>structurenmasker</a:t>
+            </a:r>
+            <a:r>
+              <a:rPr dirty="0"/>
+              <a:t> = </a:t>
+            </a:r>
+            <a:r>
+              <a:rPr dirty="0" err="1"/>
+              <a:t>juistheid</a:t>
+            </a:r>
+            <a:r>
+              <a:rPr dirty="0"/>
+              <a:t>, </a:t>
+            </a:r>
+            <a:r>
+              <a:rPr dirty="0" err="1"/>
+              <a:t>geen</a:t>
+            </a:r>
+            <a:r>
+              <a:rPr dirty="0"/>
+              <a:t> </a:t>
+            </a:r>
+            <a:r>
+              <a:rPr dirty="0" err="1"/>
+              <a:t>foutwinst</a:t>
+            </a:r>
+            <a:endParaRPr dirty="0"/>
           </a:p>
         </p:txBody>
       </p:sp>
@@ -9961,7 +11469,7 @@
         </p:blipFill>
         <p:spPr>
           <a:xfrm>
-            <a:off x="365760" y="1554480"/>
+            <a:off x="401619" y="1508760"/>
             <a:ext cx="7863840" cy="3431494"/>
           </a:xfrm>
           <a:prstGeom prst="rect">
@@ -10344,7 +11852,7 @@
           <p:nvPr/>
         </p:nvPicPr>
         <p:blipFill>
-          <a:blip r:embed="rId4"/>
+          <a:blip r:embed="rId2"/>
           <a:stretch>
             <a:fillRect/>
           </a:stretch>

</xml_diff>